<commit_message>
fix(v4): resolve P0/P1 generator bugs, ground visual evidence, embed speaker notes, add smoke tests
</commit_message>
<xml_diff>
--- a/ReturnLens_v4.pptx
+++ b/ReturnLens_v4.pptx
@@ -6,11 +6,11 @@
   </p:sldMasterIdLst>
   <p:sldIdLst>
     <p:sldId id="256" r:id="rId7"/>
-    <p:sldId id="257" r:id="rId8"/>
-    <p:sldId id="258" r:id="rId9"/>
-    <p:sldId id="259" r:id="rId10"/>
-    <p:sldId id="260" r:id="rId11"/>
-    <p:sldId id="261" r:id="rId12"/>
+    <p:sldId id="257" r:id="rId9"/>
+    <p:sldId id="258" r:id="rId10"/>
+    <p:sldId id="259" r:id="rId11"/>
+    <p:sldId id="260" r:id="rId12"/>
+    <p:sldId id="261" r:id="rId13"/>
   </p:sldIdLst>
   <p:sldSz cx="12191695" cy="6858000" type="screen4x3"/>
   <p:notesSz cx="6858000" cy="9144000"/>
@@ -110,6 +110,1041 @@
     </a:lvl9pPr>
   </p:defaultTextStyle>
 </p:presentation>
+</file>
+
+<file path=ppt/notesMasters/notesMaster1.xml><?xml version="1.0" encoding="utf-8"?>
+<p:notesMaster xmlns:a="http://schemas.openxmlformats.org/drawingml/2006/main" xmlns:p="http://schemas.openxmlformats.org/presentationml/2006/main" xmlns:r="http://schemas.openxmlformats.org/officeDocument/2006/relationships">
+  <p:cSld>
+    <p:bg>
+      <p:bgRef idx="1001">
+        <a:schemeClr val="bg1"/>
+      </p:bgRef>
+    </p:bg>
+    <p:spTree>
+      <p:nvGrpSpPr>
+        <p:cNvPr id="1" name=""/>
+        <p:cNvGrpSpPr/>
+        <p:nvPr/>
+      </p:nvGrpSpPr>
+      <p:grpSpPr>
+        <a:xfrm>
+          <a:off x="0" y="0"/>
+          <a:ext cx="0" cy="0"/>
+          <a:chOff x="0" y="0"/>
+          <a:chExt cx="0" cy="0"/>
+        </a:xfrm>
+      </p:grpSpPr>
+      <p:sp>
+        <p:nvSpPr>
+          <p:cNvPr id="2" name="Header Placeholder 1"/>
+          <p:cNvSpPr>
+            <a:spLocks noGrp="1"/>
+          </p:cNvSpPr>
+          <p:nvPr>
+            <p:ph type="hdr" sz="quarter"/>
+          </p:nvPr>
+        </p:nvSpPr>
+        <p:spPr>
+          <a:xfrm>
+            <a:off x="0" y="0"/>
+            <a:ext cx="2971800" cy="457200"/>
+          </a:xfrm>
+          <a:prstGeom prst="rect">
+            <a:avLst/>
+          </a:prstGeom>
+        </p:spPr>
+        <p:txBody>
+          <a:bodyPr vert="horz" lIns="91440" tIns="45720" rIns="91440" bIns="45720" rtlCol="0"/>
+          <a:lstStyle>
+            <a:lvl1pPr algn="l">
+              <a:defRPr sz="1200"/>
+            </a:lvl1pPr>
+          </a:lstStyle>
+          <a:p>
+            <a:endParaRPr lang="en-US"/>
+          </a:p>
+        </p:txBody>
+      </p:sp>
+      <p:sp>
+        <p:nvSpPr>
+          <p:cNvPr id="3" name="Date Placeholder 2"/>
+          <p:cNvSpPr>
+            <a:spLocks noGrp="1"/>
+          </p:cNvSpPr>
+          <p:nvPr>
+            <p:ph type="dt" idx="1"/>
+          </p:nvPr>
+        </p:nvSpPr>
+        <p:spPr>
+          <a:xfrm>
+            <a:off x="3884613" y="0"/>
+            <a:ext cx="2971800" cy="457200"/>
+          </a:xfrm>
+          <a:prstGeom prst="rect">
+            <a:avLst/>
+          </a:prstGeom>
+        </p:spPr>
+        <p:txBody>
+          <a:bodyPr vert="horz" lIns="91440" tIns="45720" rIns="91440" bIns="45720" rtlCol="0"/>
+          <a:lstStyle>
+            <a:lvl1pPr algn="r">
+              <a:defRPr sz="1200"/>
+            </a:lvl1pPr>
+          </a:lstStyle>
+          <a:p>
+            <a:fld id="{0F89C1C7-3DCD-1040-A9CF-14679D8B5DDD}" type="datetimeFigureOut">
+              <a:rPr lang="en-US" smtClean="0"/>
+              <a:t>10/17/16</a:t>
+            </a:fld>
+            <a:endParaRPr lang="en-US"/>
+          </a:p>
+        </p:txBody>
+      </p:sp>
+      <p:sp>
+        <p:nvSpPr>
+          <p:cNvPr id="4" name="Slide Image Placeholder 3"/>
+          <p:cNvSpPr>
+            <a:spLocks noGrp="1" noRot="1" noChangeAspect="1"/>
+          </p:cNvSpPr>
+          <p:nvPr>
+            <p:ph type="sldImg" idx="2"/>
+          </p:nvPr>
+        </p:nvSpPr>
+        <p:spPr>
+          <a:xfrm>
+            <a:off x="1143000" y="685800"/>
+            <a:ext cx="4572000" cy="3429000"/>
+          </a:xfrm>
+          <a:prstGeom prst="rect">
+            <a:avLst/>
+          </a:prstGeom>
+          <a:noFill/>
+          <a:ln w="12700">
+            <a:solidFill>
+              <a:prstClr val="black"/>
+            </a:solidFill>
+          </a:ln>
+        </p:spPr>
+        <p:txBody>
+          <a:bodyPr vert="horz" lIns="91440" tIns="45720" rIns="91440" bIns="45720" rtlCol="0" anchor="ctr"/>
+          <a:lstStyle/>
+          <a:p>
+            <a:endParaRPr lang="en-US"/>
+          </a:p>
+        </p:txBody>
+      </p:sp>
+      <p:sp>
+        <p:nvSpPr>
+          <p:cNvPr id="5" name="Notes Placeholder 4"/>
+          <p:cNvSpPr>
+            <a:spLocks noGrp="1"/>
+          </p:cNvSpPr>
+          <p:nvPr>
+            <p:ph type="body" sz="quarter" idx="3"/>
+          </p:nvPr>
+        </p:nvSpPr>
+        <p:spPr>
+          <a:xfrm>
+            <a:off x="685800" y="4343400"/>
+            <a:ext cx="5486400" cy="4114800"/>
+          </a:xfrm>
+          <a:prstGeom prst="rect">
+            <a:avLst/>
+          </a:prstGeom>
+        </p:spPr>
+        <p:txBody>
+          <a:bodyPr vert="horz" lIns="91440" tIns="45720" rIns="91440" bIns="45720" rtlCol="0"/>
+          <a:lstStyle/>
+          <a:p>
+            <a:pPr lvl="0"/>
+            <a:r>
+              <a:rPr lang="en-US" smtClean="0"/>
+              <a:t>Click to edit Master text styles</a:t>
+            </a:r>
+          </a:p>
+          <a:p>
+            <a:pPr lvl="1"/>
+            <a:r>
+              <a:rPr lang="en-US" smtClean="0"/>
+              <a:t>Second level</a:t>
+            </a:r>
+          </a:p>
+          <a:p>
+            <a:pPr lvl="2"/>
+            <a:r>
+              <a:rPr lang="en-US" smtClean="0"/>
+              <a:t>Third level</a:t>
+            </a:r>
+          </a:p>
+          <a:p>
+            <a:pPr lvl="3"/>
+            <a:r>
+              <a:rPr lang="en-US" smtClean="0"/>
+              <a:t>Fourth level</a:t>
+            </a:r>
+          </a:p>
+          <a:p>
+            <a:pPr lvl="4"/>
+            <a:r>
+              <a:rPr lang="en-US" smtClean="0"/>
+              <a:t>Fifth level</a:t>
+            </a:r>
+            <a:endParaRPr lang="en-US"/>
+          </a:p>
+        </p:txBody>
+      </p:sp>
+      <p:sp>
+        <p:nvSpPr>
+          <p:cNvPr id="6" name="Footer Placeholder 5"/>
+          <p:cNvSpPr>
+            <a:spLocks noGrp="1"/>
+          </p:cNvSpPr>
+          <p:nvPr>
+            <p:ph type="ftr" sz="quarter" idx="4"/>
+          </p:nvPr>
+        </p:nvSpPr>
+        <p:spPr>
+          <a:xfrm>
+            <a:off x="0" y="8685213"/>
+            <a:ext cx="2971800" cy="457200"/>
+          </a:xfrm>
+          <a:prstGeom prst="rect">
+            <a:avLst/>
+          </a:prstGeom>
+        </p:spPr>
+        <p:txBody>
+          <a:bodyPr vert="horz" lIns="91440" tIns="45720" rIns="91440" bIns="45720" rtlCol="0" anchor="b"/>
+          <a:lstStyle>
+            <a:lvl1pPr algn="l">
+              <a:defRPr sz="1200"/>
+            </a:lvl1pPr>
+          </a:lstStyle>
+          <a:p>
+            <a:endParaRPr lang="en-US"/>
+          </a:p>
+        </p:txBody>
+      </p:sp>
+      <p:sp>
+        <p:nvSpPr>
+          <p:cNvPr id="7" name="Slide Number Placeholder 6"/>
+          <p:cNvSpPr>
+            <a:spLocks noGrp="1"/>
+          </p:cNvSpPr>
+          <p:nvPr>
+            <p:ph type="sldNum" sz="quarter" idx="5"/>
+          </p:nvPr>
+        </p:nvSpPr>
+        <p:spPr>
+          <a:xfrm>
+            <a:off x="3884613" y="8685213"/>
+            <a:ext cx="2971800" cy="457200"/>
+          </a:xfrm>
+          <a:prstGeom prst="rect">
+            <a:avLst/>
+          </a:prstGeom>
+        </p:spPr>
+        <p:txBody>
+          <a:bodyPr vert="horz" lIns="91440" tIns="45720" rIns="91440" bIns="45720" rtlCol="0" anchor="b"/>
+          <a:lstStyle>
+            <a:lvl1pPr algn="r">
+              <a:defRPr sz="1200"/>
+            </a:lvl1pPr>
+          </a:lstStyle>
+          <a:p>
+            <a:fld id="{BB5E49A5-4136-284D-997B-48E1D791AD67}" type="slidenum">
+              <a:rPr lang="en-US" smtClean="0"/>
+              <a:t>‹#›</a:t>
+            </a:fld>
+            <a:endParaRPr lang="en-US"/>
+          </a:p>
+        </p:txBody>
+      </p:sp>
+    </p:spTree>
+    <p:extLst>
+      <p:ext uri="{BB962C8B-B14F-4D97-AF65-F5344CB8AC3E}">
+        <p14:creationId xmlns:p14="http://schemas.microsoft.com/office/powerpoint/2010/main" val="2623252185"/>
+      </p:ext>
+    </p:extLst>
+  </p:cSld>
+  <p:clrMap bg1="lt1" tx1="dk1" bg2="lt2" tx2="dk2" accent1="accent1" accent2="accent2" accent3="accent3" accent4="accent4" accent5="accent5" accent6="accent6" hlink="hlink" folHlink="folHlink"/>
+  <p:notesStyle>
+    <a:lvl1pPr marL="0" algn="l" defTabSz="457200" rtl="0" eaLnBrk="1" latinLnBrk="0" hangingPunct="1">
+      <a:defRPr sz="1200" kern="1200">
+        <a:solidFill>
+          <a:schemeClr val="tx1"/>
+        </a:solidFill>
+        <a:latin typeface="+mn-lt"/>
+        <a:ea typeface="+mn-ea"/>
+        <a:cs typeface="+mn-cs"/>
+      </a:defRPr>
+    </a:lvl1pPr>
+    <a:lvl2pPr marL="457200" algn="l" defTabSz="457200" rtl="0" eaLnBrk="1" latinLnBrk="0" hangingPunct="1">
+      <a:defRPr sz="1200" kern="1200">
+        <a:solidFill>
+          <a:schemeClr val="tx1"/>
+        </a:solidFill>
+        <a:latin typeface="+mn-lt"/>
+        <a:ea typeface="+mn-ea"/>
+        <a:cs typeface="+mn-cs"/>
+      </a:defRPr>
+    </a:lvl2pPr>
+    <a:lvl3pPr marL="914400" algn="l" defTabSz="457200" rtl="0" eaLnBrk="1" latinLnBrk="0" hangingPunct="1">
+      <a:defRPr sz="1200" kern="1200">
+        <a:solidFill>
+          <a:schemeClr val="tx1"/>
+        </a:solidFill>
+        <a:latin typeface="+mn-lt"/>
+        <a:ea typeface="+mn-ea"/>
+        <a:cs typeface="+mn-cs"/>
+      </a:defRPr>
+    </a:lvl3pPr>
+    <a:lvl4pPr marL="1371600" algn="l" defTabSz="457200" rtl="0" eaLnBrk="1" latinLnBrk="0" hangingPunct="1">
+      <a:defRPr sz="1200" kern="1200">
+        <a:solidFill>
+          <a:schemeClr val="tx1"/>
+        </a:solidFill>
+        <a:latin typeface="+mn-lt"/>
+        <a:ea typeface="+mn-ea"/>
+        <a:cs typeface="+mn-cs"/>
+      </a:defRPr>
+    </a:lvl4pPr>
+    <a:lvl5pPr marL="1828800" algn="l" defTabSz="457200" rtl="0" eaLnBrk="1" latinLnBrk="0" hangingPunct="1">
+      <a:defRPr sz="1200" kern="1200">
+        <a:solidFill>
+          <a:schemeClr val="tx1"/>
+        </a:solidFill>
+        <a:latin typeface="+mn-lt"/>
+        <a:ea typeface="+mn-ea"/>
+        <a:cs typeface="+mn-cs"/>
+      </a:defRPr>
+    </a:lvl5pPr>
+    <a:lvl6pPr marL="2286000" algn="l" defTabSz="457200" rtl="0" eaLnBrk="1" latinLnBrk="0" hangingPunct="1">
+      <a:defRPr sz="1200" kern="1200">
+        <a:solidFill>
+          <a:schemeClr val="tx1"/>
+        </a:solidFill>
+        <a:latin typeface="+mn-lt"/>
+        <a:ea typeface="+mn-ea"/>
+        <a:cs typeface="+mn-cs"/>
+      </a:defRPr>
+    </a:lvl6pPr>
+    <a:lvl7pPr marL="2743200" algn="l" defTabSz="457200" rtl="0" eaLnBrk="1" latinLnBrk="0" hangingPunct="1">
+      <a:defRPr sz="1200" kern="1200">
+        <a:solidFill>
+          <a:schemeClr val="tx1"/>
+        </a:solidFill>
+        <a:latin typeface="+mn-lt"/>
+        <a:ea typeface="+mn-ea"/>
+        <a:cs typeface="+mn-cs"/>
+      </a:defRPr>
+    </a:lvl7pPr>
+    <a:lvl8pPr marL="3200400" algn="l" defTabSz="457200" rtl="0" eaLnBrk="1" latinLnBrk="0" hangingPunct="1">
+      <a:defRPr sz="1200" kern="1200">
+        <a:solidFill>
+          <a:schemeClr val="tx1"/>
+        </a:solidFill>
+        <a:latin typeface="+mn-lt"/>
+        <a:ea typeface="+mn-ea"/>
+        <a:cs typeface="+mn-cs"/>
+      </a:defRPr>
+    </a:lvl8pPr>
+    <a:lvl9pPr marL="3657600" algn="l" defTabSz="457200" rtl="0" eaLnBrk="1" latinLnBrk="0" hangingPunct="1">
+      <a:defRPr sz="1200" kern="1200">
+        <a:solidFill>
+          <a:schemeClr val="tx1"/>
+        </a:solidFill>
+        <a:latin typeface="+mn-lt"/>
+        <a:ea typeface="+mn-ea"/>
+        <a:cs typeface="+mn-cs"/>
+      </a:defRPr>
+    </a:lvl9pPr>
+  </p:notesStyle>
+</p:notesMaster>
+</file>
+
+<file path=ppt/notesSlides/notesSlide1.xml><?xml version="1.0" encoding="utf-8"?>
+<p:notes xmlns:a="http://schemas.openxmlformats.org/drawingml/2006/main" xmlns:p="http://schemas.openxmlformats.org/presentationml/2006/main" xmlns:r="http://schemas.openxmlformats.org/officeDocument/2006/relationships">
+  <p:cSld>
+    <p:spTree>
+      <p:nvGrpSpPr>
+        <p:cNvPr id="1" name=""/>
+        <p:cNvGrpSpPr/>
+        <p:nvPr/>
+      </p:nvGrpSpPr>
+      <p:grpSpPr>
+        <a:xfrm>
+          <a:off x="0" y="0"/>
+          <a:ext cx="0" cy="0"/>
+          <a:chOff x="0" y="0"/>
+          <a:chExt cx="0" cy="0"/>
+        </a:xfrm>
+      </p:grpSpPr>
+      <p:sp>
+        <p:nvSpPr>
+          <p:cNvPr id="2" name="Slide Image Placeholder 1"/>
+          <p:cNvSpPr>
+            <a:spLocks noGrp="1"/>
+          </p:cNvSpPr>
+          <p:nvPr>
+            <p:ph type="sldImg" idx="2"/>
+          </p:nvPr>
+        </p:nvSpPr>
+        <p:spPr/>
+      </p:sp>
+      <p:sp>
+        <p:nvSpPr>
+          <p:cNvPr id="3" name="Notes Placeholder 2"/>
+          <p:cNvSpPr>
+            <a:spLocks noGrp="1"/>
+          </p:cNvSpPr>
+          <p:nvPr>
+            <p:ph type="body" idx="3" sz="quarter"/>
+          </p:nvPr>
+        </p:nvSpPr>
+        <p:spPr/>
+        <p:txBody>
+          <a:bodyPr/>
+          <a:lstStyle/>
+          <a:p>
+            <a:r>
+              <a:t>Slide 1 — Product Hero &amp; Executive Summary:</a:t>
+            </a:r>
+          </a:p>
+          <a:p>
+            <a:r>
+              <a:t>- Problem Statement fit: PS-04 (Autonomous Support Agent for Online Sellers).</a:t>
+            </a:r>
+          </a:p>
+          <a:p>
+            <a:r>
+              <a:t>- Target user: Solo direct-to-consumer (D2C) e-commerce merchants managing orders, shipping, and returns without dedicated support staff.</a:t>
+            </a:r>
+          </a:p>
+          <a:p>
+            <a:r>
+              <a:t>- Core insight: Solo merchants waste 15–20 minutes per return opening fragmented tabs (buyer chat, Shopify, Shippo tracking, return policy). Return decisions are made from memory without unified evidence.</a:t>
+            </a:r>
+          </a:p>
+          <a:p>
+            <a:r>
+              <a:t>- Differentiator: ReturnLens is not another open-ended conversational bot; it is a fail-closed, evidence-indexed triage agent.</a:t>
+            </a:r>
+          </a:p>
+          <a:p>
+            <a:r>
+              <a:t>- Visual anchor: The Seller Review Console mockup shows staged inspection frame 00:14. Notice the honest observation: rather than claiming an incontrovertible defect, the agent flags potential damage for seller confirmation.</a:t>
+            </a:r>
+          </a:p>
+          <a:p>
+            <a:r>
+              <a:t>- 24-hour scope: Return triage core + 1 zero-vision order-status route (reusing Shopify/Shippo mock APIs).</a:t>
+            </a:r>
+          </a:p>
+          <a:p>
+            <a:r>
+              <a:t>- Guardrail: Financial release strictly requires 1-click human seller authorization. No autonomous refunds.</a:t>
+            </a:r>
+          </a:p>
+        </p:txBody>
+      </p:sp>
+      <p:sp>
+        <p:nvSpPr>
+          <p:cNvPr id="4" name="Slide Number Placeholder 3"/>
+          <p:cNvSpPr>
+            <a:spLocks noGrp="1"/>
+          </p:cNvSpPr>
+          <p:nvPr>
+            <p:ph type="sldNum" idx="5" sz="quarter"/>
+          </p:nvPr>
+        </p:nvSpPr>
+        <p:spPr/>
+      </p:sp>
+    </p:spTree>
+  </p:cSld>
+  <p:clrMapOvr>
+    <a:masterClrMapping/>
+  </p:clrMapOvr>
+</p:notes>
+</file>
+
+<file path=ppt/notesSlides/notesSlide2.xml><?xml version="1.0" encoding="utf-8"?>
+<p:notes xmlns:a="http://schemas.openxmlformats.org/drawingml/2006/main" xmlns:p="http://schemas.openxmlformats.org/presentationml/2006/main" xmlns:r="http://schemas.openxmlformats.org/officeDocument/2006/relationships">
+  <p:cSld>
+    <p:spTree>
+      <p:nvGrpSpPr>
+        <p:cNvPr id="1" name=""/>
+        <p:cNvGrpSpPr/>
+        <p:nvPr/>
+      </p:nvGrpSpPr>
+      <p:grpSpPr>
+        <a:xfrm>
+          <a:off x="0" y="0"/>
+          <a:ext cx="0" cy="0"/>
+          <a:chOff x="0" y="0"/>
+          <a:chExt cx="0" cy="0"/>
+        </a:xfrm>
+      </p:grpSpPr>
+      <p:sp>
+        <p:nvSpPr>
+          <p:cNvPr id="2" name="Slide Image Placeholder 1"/>
+          <p:cNvSpPr>
+            <a:spLocks noGrp="1"/>
+          </p:cNvSpPr>
+          <p:nvPr>
+            <p:ph type="sldImg" idx="2"/>
+          </p:nvPr>
+        </p:nvSpPr>
+        <p:spPr/>
+      </p:sp>
+      <p:sp>
+        <p:nvSpPr>
+          <p:cNvPr id="3" name="Notes Placeholder 2"/>
+          <p:cNvSpPr>
+            <a:spLocks noGrp="1"/>
+          </p:cNvSpPr>
+          <p:nvPr>
+            <p:ph type="body" idx="3" sz="quarter"/>
+          </p:nvPr>
+        </p:nvSpPr>
+        <p:spPr/>
+        <p:txBody>
+          <a:bodyPr/>
+          <a:lstStyle/>
+          <a:p>
+            <a:r>
+              <a:t>Slide 2 — Problem Space &amp; The Four Disconnected Sources:</a:t>
+            </a:r>
+          </a:p>
+          <a:p>
+            <a:r>
+              <a:t>- Problem: The returns bottleneck is not lack of return policies; it is fragmented, unverified context.</a:t>
+            </a:r>
+          </a:p>
+          <a:p>
+            <a:r>
+              <a:t>- Sources:</a:t>
+            </a:r>
+          </a:p>
+          <a:p>
+            <a:r>
+              <a:t>  1. Buyer claim in chat (unverified claims, emotional text).</a:t>
+            </a:r>
+          </a:p>
+          <a:p>
+            <a:r>
+              <a:t>  2. Order truth in Shopify store (SKU HEAD-WHT-02, price ₹1,499).</a:t>
+            </a:r>
+          </a:p>
+          <a:p>
+            <a:r>
+              <a:t>  3. Tracking scan in Shippo courier API (delivered 4 days ago).</a:t>
+            </a:r>
+          </a:p>
+          <a:p>
+            <a:r>
+              <a:t>  4. Store return policy document (7-day defect window, security tag).</a:t>
+            </a:r>
+          </a:p>
+          <a:p>
+            <a:r>
+              <a:t>- The central gap: No shared evidence record connecting video, store orders, and shipping timestamps into a single auditable artifact.</a:t>
+            </a:r>
+          </a:p>
+          <a:p>
+            <a:r>
+              <a:t>- Fraud statistics note: Estimates differ fundamentally by methodology. NRF 2025 reports 9% for strictly criminal return fraud, whereas Appriss/Deloitte 2024 reports 15.14% when including policy abuse (wardrobing, unboxing swaps). Never conflate these two metrics.</a:t>
+            </a:r>
+          </a:p>
+          <a:p>
+            <a:r>
+              <a:t>- Cost to seller: Triage takes 15–20 minutes per ticket. Erroneous approval bleeds gross margins; unfair rejection destroys customer lifetime value (LTV).</a:t>
+            </a:r>
+          </a:p>
+        </p:txBody>
+      </p:sp>
+      <p:sp>
+        <p:nvSpPr>
+          <p:cNvPr id="4" name="Slide Number Placeholder 3"/>
+          <p:cNvSpPr>
+            <a:spLocks noGrp="1"/>
+          </p:cNvSpPr>
+          <p:nvPr>
+            <p:ph type="sldNum" idx="5" sz="quarter"/>
+          </p:nvPr>
+        </p:nvSpPr>
+        <p:spPr/>
+      </p:sp>
+    </p:spTree>
+  </p:cSld>
+  <p:clrMapOvr>
+    <a:masterClrMapping/>
+  </p:clrMapOvr>
+</p:notes>
+</file>
+
+<file path=ppt/notesSlides/notesSlide3.xml><?xml version="1.0" encoding="utf-8"?>
+<p:notes xmlns:a="http://schemas.openxmlformats.org/drawingml/2006/main" xmlns:p="http://schemas.openxmlformats.org/presentationml/2006/main" xmlns:r="http://schemas.openxmlformats.org/officeDocument/2006/relationships">
+  <p:cSld>
+    <p:spTree>
+      <p:nvGrpSpPr>
+        <p:cNvPr id="1" name=""/>
+        <p:cNvGrpSpPr/>
+        <p:nvPr/>
+      </p:nvGrpSpPr>
+      <p:grpSpPr>
+        <a:xfrm>
+          <a:off x="0" y="0"/>
+          <a:ext cx="0" cy="0"/>
+          <a:chOff x="0" y="0"/>
+          <a:chExt cx="0" cy="0"/>
+        </a:xfrm>
+      </p:grpSpPr>
+      <p:sp>
+        <p:nvSpPr>
+          <p:cNvPr id="2" name="Slide Image Placeholder 1"/>
+          <p:cNvSpPr>
+            <a:spLocks noGrp="1"/>
+          </p:cNvSpPr>
+          <p:nvPr>
+            <p:ph type="sldImg" idx="2"/>
+          </p:nvPr>
+        </p:nvSpPr>
+        <p:spPr/>
+      </p:sp>
+      <p:sp>
+        <p:nvSpPr>
+          <p:cNvPr id="3" name="Notes Placeholder 2"/>
+          <p:cNvSpPr>
+            <a:spLocks noGrp="1"/>
+          </p:cNvSpPr>
+          <p:nvPr>
+            <p:ph type="body" idx="3" sz="quarter"/>
+          </p:nvPr>
+        </p:nvSpPr>
+        <p:spPr/>
+        <p:txBody>
+          <a:bodyPr/>
+          <a:lstStyle/>
+          <a:p>
+            <a:r>
+              <a:t>Slide 3 — The Star Demo &amp; Technical Honesty in Vision Citation:</a:t>
+            </a:r>
+          </a:p>
+          <a:p>
+            <a:r>
+              <a:t>- Core benchmark scenario (Case B): Buyer ordered white headphones (HEAD-WHT-02, ₹1,499), but unboxing frame 00:07 shows black headphones.</a:t>
+            </a:r>
+          </a:p>
+          <a:p>
+            <a:r>
+              <a:t>- Grounding &amp; Honesty: Notice that the agent does NOT claim to read an unreadable SKU barcode from 00:07. It states factually: "Observed Color: Midnight Black · Exact SKU: Not verified".</a:t>
+            </a:r>
+          </a:p>
+          <a:p>
+            <a:r>
+              <a:t>- Decision logic: Seeing a black item when white was ordered is an undeniable visual contradiction against the manifest. Instead of auto-denying the customer (which might alienate an honest buyer if the warehouse mis-shipped), the policy engine triggers ESCALATE.</a:t>
+            </a:r>
+          </a:p>
+          <a:p>
+            <a:r>
+              <a:t>- Three clear merchant options are presented:</a:t>
+            </a:r>
+          </a:p>
+          <a:p>
+            <a:r>
+              <a:t>  1. Accept mis-shipment (warehouse mistake).</a:t>
+            </a:r>
+          </a:p>
+          <a:p>
+            <a:r>
+              <a:t>  2. Request outside-box label photo (buyer opened wrong family parcel).</a:t>
+            </a:r>
+          </a:p>
+          <a:p>
+            <a:r>
+              <a:t>  3. Route to warehouse inspection (possible fraud).</a:t>
+            </a:r>
+          </a:p>
+          <a:p>
+            <a:r>
+              <a:t>- Schema: typed JSON, requires_seller_approval: true.</a:t>
+            </a:r>
+          </a:p>
+          <a:p>
+            <a:r>
+              <a:t>- Financial cap: 0 &lt; amount &lt;= min(₹4,999, remaining refundable amount, order paid amount).</a:t>
+            </a:r>
+          </a:p>
+        </p:txBody>
+      </p:sp>
+      <p:sp>
+        <p:nvSpPr>
+          <p:cNvPr id="4" name="Slide Number Placeholder 3"/>
+          <p:cNvSpPr>
+            <a:spLocks noGrp="1"/>
+          </p:cNvSpPr>
+          <p:nvPr>
+            <p:ph type="sldNum" idx="5" sz="quarter"/>
+          </p:nvPr>
+        </p:nvSpPr>
+        <p:spPr/>
+      </p:sp>
+    </p:spTree>
+  </p:cSld>
+  <p:clrMapOvr>
+    <a:masterClrMapping/>
+  </p:clrMapOvr>
+</p:notes>
+</file>
+
+<file path=ppt/notesSlides/notesSlide4.xml><?xml version="1.0" encoding="utf-8"?>
+<p:notes xmlns:a="http://schemas.openxmlformats.org/drawingml/2006/main" xmlns:p="http://schemas.openxmlformats.org/presentationml/2006/main" xmlns:r="http://schemas.openxmlformats.org/officeDocument/2006/relationships">
+  <p:cSld>
+    <p:spTree>
+      <p:nvGrpSpPr>
+        <p:cNvPr id="1" name=""/>
+        <p:cNvGrpSpPr/>
+        <p:nvPr/>
+      </p:nvGrpSpPr>
+      <p:grpSpPr>
+        <a:xfrm>
+          <a:off x="0" y="0"/>
+          <a:ext cx="0" cy="0"/>
+          <a:chOff x="0" y="0"/>
+          <a:chExt cx="0" cy="0"/>
+        </a:xfrm>
+      </p:grpSpPr>
+      <p:sp>
+        <p:nvSpPr>
+          <p:cNvPr id="2" name="Slide Image Placeholder 1"/>
+          <p:cNvSpPr>
+            <a:spLocks noGrp="1"/>
+          </p:cNvSpPr>
+          <p:nvPr>
+            <p:ph type="sldImg" idx="2"/>
+          </p:nvPr>
+        </p:nvSpPr>
+        <p:spPr/>
+      </p:sp>
+      <p:sp>
+        <p:nvSpPr>
+          <p:cNvPr id="3" name="Notes Placeholder 2"/>
+          <p:cNvSpPr>
+            <a:spLocks noGrp="1"/>
+          </p:cNvSpPr>
+          <p:nvPr>
+            <p:ph type="body" idx="3" sz="quarter"/>
+          </p:nvPr>
+        </p:nvSpPr>
+        <p:spPr/>
+        <p:txBody>
+          <a:bodyPr/>
+          <a:lstStyle/>
+          <a:p>
+            <a:r>
+              <a:t>Slide 4 — System Architecture &amp; Deterministic Governance:</a:t>
+            </a:r>
+          </a:p>
+          <a:p>
+            <a:r>
+              <a:t>- Philosophy: "Models observe. Code verifies. Seller authorizes."</a:t>
+            </a:r>
+          </a:p>
+          <a:p>
+            <a:r>
+              <a:t>- Pipeline (6 steps):</a:t>
+            </a:r>
+          </a:p>
+          <a:p>
+            <a:r>
+              <a:t>  1. Planner [MODEL]: Validates incoming JSON payload against strict schema.</a:t>
+            </a:r>
+          </a:p>
+          <a:p>
+            <a:r>
+              <a:t>  2. Tools &amp; Video [CODE]: Extracts keyframes with FFmpeg; calls mock Shopify/Shippo endpoints.</a:t>
+            </a:r>
+          </a:p>
+          <a:p>
+            <a:r>
+              <a:t>  3. Policy Engine [CODE]: Evaluates deterministic Python rules P-01 through P-08 (window, SKU match, tags).</a:t>
+            </a:r>
+          </a:p>
+          <a:p>
+            <a:r>
+              <a:t>  4. Evidence Critic [MODEL]: Secondary auditor verifying cited timestamps against extracted observations to catch hallucinated damage.</a:t>
+            </a:r>
+          </a:p>
+          <a:p>
+            <a:r>
+              <a:t>  5. Seller Gate [HUMAN]: Merchant console where human authorizes mock label or draft refund.</a:t>
+            </a:r>
+          </a:p>
+          <a:p>
+            <a:r>
+              <a:t>  6. Audit Log [CODE]: Immutable append-only structured JSON log for every state transition.</a:t>
+            </a:r>
+          </a:p>
+          <a:p>
+            <a:r>
+              <a:t>- Broad PS-04 alignment: A fast zero-vision route handles routine "Where is my order?" inquiries by querying the courier tracking tool directly, answering customer queries in sub-second time.</a:t>
+            </a:r>
+          </a:p>
+          <a:p>
+            <a:r>
+              <a:t>- Strict priority order for decision function:</a:t>
+            </a:r>
+          </a:p>
+          <a:p>
+            <a:r>
+              <a:t>  Contradiction &gt; Hard fail &gt; Unclear only &gt; All pass.</a:t>
+            </a:r>
+          </a:p>
+          <a:p>
+            <a:r>
+              <a:t>- Bounded calls: Exactly 3 base LLM calls per triage case.</a:t>
+            </a:r>
+          </a:p>
+        </p:txBody>
+      </p:sp>
+      <p:sp>
+        <p:nvSpPr>
+          <p:cNvPr id="4" name="Slide Number Placeholder 3"/>
+          <p:cNvSpPr>
+            <a:spLocks noGrp="1"/>
+          </p:cNvSpPr>
+          <p:nvPr>
+            <p:ph type="sldNum" idx="5" sz="quarter"/>
+          </p:nvPr>
+        </p:nvSpPr>
+        <p:spPr/>
+      </p:sp>
+    </p:spTree>
+  </p:cSld>
+  <p:clrMapOvr>
+    <a:masterClrMapping/>
+  </p:clrMapOvr>
+</p:notes>
+</file>
+
+<file path=ppt/notesSlides/notesSlide5.xml><?xml version="1.0" encoding="utf-8"?>
+<p:notes xmlns:a="http://schemas.openxmlformats.org/drawingml/2006/main" xmlns:p="http://schemas.openxmlformats.org/presentationml/2006/main" xmlns:r="http://schemas.openxmlformats.org/officeDocument/2006/relationships">
+  <p:cSld>
+    <p:spTree>
+      <p:nvGrpSpPr>
+        <p:cNvPr id="1" name=""/>
+        <p:cNvGrpSpPr/>
+        <p:nvPr/>
+      </p:nvGrpSpPr>
+      <p:grpSpPr>
+        <a:xfrm>
+          <a:off x="0" y="0"/>
+          <a:ext cx="0" cy="0"/>
+          <a:chOff x="0" y="0"/>
+          <a:chExt cx="0" cy="0"/>
+        </a:xfrm>
+      </p:grpSpPr>
+      <p:sp>
+        <p:nvSpPr>
+          <p:cNvPr id="2" name="Slide Image Placeholder 1"/>
+          <p:cNvSpPr>
+            <a:spLocks noGrp="1"/>
+          </p:cNvSpPr>
+          <p:nvPr>
+            <p:ph type="sldImg" idx="2"/>
+          </p:nvPr>
+        </p:nvSpPr>
+        <p:spPr/>
+      </p:sp>
+      <p:sp>
+        <p:nvSpPr>
+          <p:cNvPr id="3" name="Notes Placeholder 2"/>
+          <p:cNvSpPr>
+            <a:spLocks noGrp="1"/>
+          </p:cNvSpPr>
+          <p:nvPr>
+            <p:ph type="body" idx="3" sz="quarter"/>
+          </p:nvPr>
+        </p:nvSpPr>
+        <p:spPr/>
+        <p:txBody>
+          <a:bodyPr/>
+          <a:lstStyle/>
+          <a:p>
+            <a:r>
+              <a:t>Slide 5 — Four Reproducible Benchmark Scenarios:</a:t>
+            </a:r>
+          </a:p>
+          <a:p>
+            <a:r>
+              <a:t>- Note on Grounding: These four scenarios represent staged prototype test suites and deterministic expected behaviors, NOT ungrounded production field metrics.</a:t>
+            </a:r>
+          </a:p>
+          <a:p>
+            <a:r>
+              <a:t>- Case A (Clean Claim): All rules pass (within 7d, SKU matches manifest, tag visible, physical crack observed). System drafts return shipping label and refund draft in 'pending_return_receipt' state. No refund money is transferred until physical warehouse receipt.</a:t>
+            </a:r>
+          </a:p>
+          <a:p>
+            <a:r>
+              <a:t>- Case B (Contradiction): Color mismatch detected (ordered white, unboxed black). System prevents auto-rejection and routes to seller review with 3 concrete resolution options.</a:t>
+            </a:r>
+          </a:p>
+          <a:p>
+            <a:r>
+              <a:t>- Case C (Unclear / Low Light): Dark video (28/255 avg brightness). Instead of auto-denying, the agent provides a clear checklist and allows 1 retry to protect legitimate customers.</a:t>
+            </a:r>
+          </a:p>
+          <a:p>
+            <a:r>
+              <a:t>- Case D (Continuity): Expected prototype behavior: inspect parcel-to-product sequence to flag suspicious cut-aways or missing transitions.</a:t>
+            </a:r>
+          </a:p>
+          <a:p>
+            <a:r>
+              <a:t>- Financial cap formula: min(₹4,999, remaining refundable amount, order paid amount) prevents catastrophic loss.</a:t>
+            </a:r>
+          </a:p>
+        </p:txBody>
+      </p:sp>
+      <p:sp>
+        <p:nvSpPr>
+          <p:cNvPr id="4" name="Slide Number Placeholder 3"/>
+          <p:cNvSpPr>
+            <a:spLocks noGrp="1"/>
+          </p:cNvSpPr>
+          <p:nvPr>
+            <p:ph type="sldNum" idx="5" sz="quarter"/>
+          </p:nvPr>
+        </p:nvSpPr>
+        <p:spPr/>
+      </p:sp>
+    </p:spTree>
+  </p:cSld>
+  <p:clrMapOvr>
+    <a:masterClrMapping/>
+  </p:clrMapOvr>
+</p:notes>
+</file>
+
+<file path=ppt/notesSlides/notesSlide6.xml><?xml version="1.0" encoding="utf-8"?>
+<p:notes xmlns:a="http://schemas.openxmlformats.org/drawingml/2006/main" xmlns:p="http://schemas.openxmlformats.org/presentationml/2006/main" xmlns:r="http://schemas.openxmlformats.org/officeDocument/2006/relationships">
+  <p:cSld>
+    <p:spTree>
+      <p:nvGrpSpPr>
+        <p:cNvPr id="1" name=""/>
+        <p:cNvGrpSpPr/>
+        <p:nvPr/>
+      </p:nvGrpSpPr>
+      <p:grpSpPr>
+        <a:xfrm>
+          <a:off x="0" y="0"/>
+          <a:ext cx="0" cy="0"/>
+          <a:chOff x="0" y="0"/>
+          <a:chExt cx="0" cy="0"/>
+        </a:xfrm>
+      </p:grpSpPr>
+      <p:sp>
+        <p:nvSpPr>
+          <p:cNvPr id="2" name="Slide Image Placeholder 1"/>
+          <p:cNvSpPr>
+            <a:spLocks noGrp="1"/>
+          </p:cNvSpPr>
+          <p:nvPr>
+            <p:ph type="sldImg" idx="2"/>
+          </p:nvPr>
+        </p:nvSpPr>
+        <p:spPr/>
+      </p:sp>
+      <p:sp>
+        <p:nvSpPr>
+          <p:cNvPr id="3" name="Notes Placeholder 2"/>
+          <p:cNvSpPr>
+            <a:spLocks noGrp="1"/>
+          </p:cNvSpPr>
+          <p:nvPr>
+            <p:ph type="body" idx="3" sz="quarter"/>
+          </p:nvPr>
+        </p:nvSpPr>
+        <p:spPr/>
+        <p:txBody>
+          <a:bodyPr/>
+          <a:lstStyle/>
+          <a:p>
+            <a:r>
+              <a:t>Slide 6 — 24-Hour Sprint Feasibility, Ownership &amp; Strict Scope Guardrails:</a:t>
+            </a:r>
+          </a:p>
+          <a:p>
+            <a:r>
+              <a:t>- Feasibility argument: Why is ReturnLens realistically buildable in 24 hours by 3 engineers?</a:t>
+            </a:r>
+          </a:p>
+          <a:p>
+            <a:r>
+              <a:t>  1. No live external production dependencies (we use deterministic mock APIs for Shopify &amp; Shippo).</a:t>
+            </a:r>
+          </a:p>
+          <a:p>
+            <a:r>
+              <a:t>  2. Clear division of labor with single-threaded ownership across 3 teammates:</a:t>
+            </a:r>
+          </a:p>
+          <a:p>
+            <a:r>
+              <a:t>     - Person A (Backend): LangGraph state graph, policy logic P-01 to P-08, JSON audit logger, order-status route.</a:t>
+            </a:r>
+          </a:p>
+          <a:p>
+            <a:r>
+              <a:t>     - Person B (Video/UI): FFmpeg keyframe extraction script, Streamlit seller review console, frame citation display.</a:t>
+            </a:r>
+          </a:p>
+          <a:p>
+            <a:r>
+              <a:t>     - Person C (Integration/QA): 4 staged test datasets (Cases A-D), boundary testing, fallback test cases, demo recording, and submission docs.</a:t>
+            </a:r>
+          </a:p>
+          <a:p>
+            <a:r>
+              <a:t>  3. Scope discipline:</a:t>
+            </a:r>
+          </a:p>
+          <a:p>
+            <a:r>
+              <a:t>     - NEVER CUT: Core policy engine, frame citations, seller authorization gate, structured audit log.</a:t>
+            </a:r>
+          </a:p>
+          <a:p>
+            <a:r>
+              <a:t>     - CUT FIRST: Video OCR barcode scanning, automated customer email replying, seller analytics dashboards, production payment gateways.</a:t>
+            </a:r>
+          </a:p>
+          <a:p>
+            <a:r>
+              <a:t>- Winning philosophy: "The winning hackathon agent is not the one with the most tool definitions. It is the one where every action is held to evidence, and the seller stays in control."</a:t>
+            </a:r>
+          </a:p>
+        </p:txBody>
+      </p:sp>
+      <p:sp>
+        <p:nvSpPr>
+          <p:cNvPr id="4" name="Slide Number Placeholder 3"/>
+          <p:cNvSpPr>
+            <a:spLocks noGrp="1"/>
+          </p:cNvSpPr>
+          <p:nvPr>
+            <p:ph type="sldNum" idx="5" sz="quarter"/>
+          </p:nvPr>
+        </p:nvSpPr>
+        <p:spPr/>
+      </p:sp>
+    </p:spTree>
+  </p:cSld>
+  <p:clrMapOvr>
+    <a:masterClrMapping/>
+  </p:clrMapOvr>
+</p:notes>
 </file>
 
 <file path=ppt/slideLayouts/slideLayout1.xml><?xml version="1.0" encoding="utf-8"?>
@@ -3330,12 +4365,12 @@
               </a:defRPr>
             </a:pPr>
             <a:r>
-              <a:t>Team Rookie · 3 members · PS-04 submission</a:t>
+              <a:t>Team Rookie · 3 members · PS-04 Track</a:t>
             </a:r>
           </a:p>
           <a:p>
             <a:pPr>
-              <a:defRPr sz="1100">
+              <a:defRPr sz="1050">
                 <a:solidFill>
                   <a:srgbClr val="596E64"/>
                 </a:solidFill>
@@ -3343,12 +4378,12 @@
               </a:defRPr>
             </a:pPr>
             <a:r>
-              <a:t>User: Solo D2C merchant managing orders and returns alone.</a:t>
+              <a:t>Target User: Solo D2C merchant managing orders and returns alone.</a:t>
             </a:r>
           </a:p>
           <a:p>
             <a:pPr>
-              <a:defRPr sz="1100">
+              <a:defRPr sz="1050">
                 <a:solidFill>
                   <a:srgbClr val="596E64"/>
                 </a:solidFill>
@@ -3356,12 +4391,12 @@
               </a:defRPr>
             </a:pPr>
             <a:r>
-              <a:t>Scope in 24h: Return triage only, mock store data + 1 order-status route.</a:t>
+              <a:t>Scope in 24h: Return triage core + 1 zero-vision order status route.</a:t>
             </a:r>
           </a:p>
           <a:p>
             <a:pPr>
-              <a:defRPr sz="1100" b="1">
+              <a:defRPr sz="1050" b="1">
                 <a:solidFill>
                   <a:srgbClr val="172621"/>
                 </a:solidFill>
@@ -3369,7 +4404,7 @@
               </a:defRPr>
             </a:pPr>
             <a:r>
-              <a:t>Not another chatbot; not an autonomous refund gate.</a:t>
+              <a:t>Guardrails: Fail-closed architecture · No autonomous refunds.</a:t>
             </a:r>
           </a:p>
         </p:txBody>
@@ -3592,8 +4627,8 @@
         </p:nvSpPr>
         <p:spPr>
           <a:xfrm>
-            <a:off x="8778240" y="1554480"/>
-            <a:ext cx="2499055" cy="3840480"/>
+            <a:off x="8778240" y="1508760"/>
+            <a:ext cx="2499055" cy="3931920"/>
           </a:xfrm>
           <a:prstGeom prst="rect">
             <a:avLst/>
@@ -3607,7 +4642,7 @@
           <a:lstStyle/>
           <a:p>
             <a:pPr>
-              <a:defRPr sz="1000" b="1">
+              <a:defRPr sz="950" b="1">
                 <a:solidFill>
                   <a:srgbClr val="7A8E85"/>
                 </a:solidFill>
@@ -3620,7 +4655,7 @@
           </a:p>
           <a:p>
             <a:pPr>
-              <a:defRPr sz="1200" b="1">
+              <a:defRPr sz="1150" b="1">
                 <a:solidFill>
                   <a:srgbClr val="172621"/>
                 </a:solidFill>
@@ -3633,7 +4668,7 @@
           </a:p>
           <a:p>
             <a:pPr>
-              <a:defRPr sz="1000">
+              <a:defRPr sz="950">
                 <a:solidFill>
                   <a:srgbClr val="596E64"/>
                 </a:solidFill>
@@ -3647,7 +4682,7 @@
           <a:p>
             <a:br/>
             <a:pPr>
-              <a:defRPr sz="1000" b="1">
+              <a:defRPr sz="950" b="1">
                 <a:solidFill>
                   <a:srgbClr val="7A8E85"/>
                 </a:solidFill>
@@ -3655,12 +4690,12 @@
               </a:defRPr>
             </a:pPr>
             <a:r>
-              <a:t>EVIDENCE CITATION</a:t>
+              <a:t>VISUAL OBSERVATION</a:t>
             </a:r>
           </a:p>
           <a:p>
             <a:pPr>
-              <a:defRPr sz="1200" b="1">
+              <a:defRPr sz="1150" b="1">
                 <a:solidFill>
                   <a:srgbClr val="172621"/>
                 </a:solidFill>
@@ -3673,7 +4708,7 @@
           </a:p>
           <a:p>
             <a:pPr>
-              <a:defRPr sz="1000">
+              <a:defRPr sz="950">
                 <a:solidFill>
                   <a:srgbClr val="596E64"/>
                 </a:solidFill>
@@ -3681,13 +4716,13 @@
               </a:defRPr>
             </a:pPr>
             <a:r>
-              <a:t>Casing crack verified at lower seam</a:t>
+              <a:t>Potential casing damage flagged · Needs manual confirmation</a:t>
             </a:r>
           </a:p>
           <a:p>
             <a:br/>
             <a:pPr>
-              <a:defRPr sz="1000" b="1">
+              <a:defRPr sz="950" b="1">
                 <a:solidFill>
                   <a:srgbClr val="7A8E85"/>
                 </a:solidFill>
@@ -3700,15 +4735,19 @@
           </a:p>
           <a:p>
             <a:pPr>
-              <a:defRPr sz="1200" b="1">
-                <a:solidFill>
-                  <a:srgbClr val="172621"/>
+              <a:defRPr sz="1050" b="1">
+                <a:solidFill>
+                  <a:srgbClr val="92400E"/>
                 </a:solidFill>
                 <a:latin typeface="Inter"/>
               </a:defRPr>
             </a:pPr>
             <a:r>
-              <a:t>P-01 Physical Defect: PASS</a:t>
+              <a:t>P-01 Defect Check: FLAGGED FOR REVIEW</a:t>
+            </a:r>
+            <a:br/>
+            <a:r>
+              <a:t>P-04 Return Window: PASS (Day 4 of 7)</a:t>
             </a:r>
           </a:p>
         </p:txBody>
@@ -3728,7 +4767,7 @@
             <a:avLst/>
           </a:prstGeom>
           <a:solidFill>
-            <a:srgbClr val="E1F2EC"/>
+            <a:srgbClr val="FEF3C7"/>
           </a:solidFill>
           <a:ln>
             <a:noFill/>
@@ -3753,15 +4792,15 @@
           <a:lstStyle/>
           <a:p>
             <a:pPr algn="ctr">
-              <a:defRPr sz="1000" b="1">
-                <a:solidFill>
-                  <a:srgbClr val="006B55"/>
+              <a:defRPr sz="950" b="1">
+                <a:solidFill>
+                  <a:srgbClr val="92400E"/>
                 </a:solidFill>
                 <a:latin typeface="IBM Plex Mono"/>
               </a:defRPr>
             </a:pPr>
             <a:r>
-              <a:t>READY FOR SELLER REVIEW</a:t>
+              <a:t>READY FOR SELLER REVIEW (FLAGGED)</a:t>
             </a:r>
           </a:p>
         </p:txBody>
@@ -3814,7 +4853,7 @@
               </a:defRPr>
             </a:pPr>
             <a:r>
-              <a:t>Approve Return &amp; Draft Refund</a:t>
+              <a:t>Review Evidence &amp; Authorize Draft</a:t>
             </a:r>
           </a:p>
         </p:txBody>
@@ -4111,8 +5150,8 @@
         </p:nvSpPr>
         <p:spPr>
           <a:xfrm>
-            <a:off x="731520" y="2468880"/>
-            <a:ext cx="3108960" cy="1234440"/>
+            <a:off x="731520" y="2377440"/>
+            <a:ext cx="3291840" cy="1737360"/>
           </a:xfrm>
           <a:prstGeom prst="rect">
             <a:avLst/>
@@ -4120,7 +5159,7 @@
           <a:solidFill>
             <a:srgbClr val="FFFFFF"/>
           </a:solidFill>
-          <a:ln w="12700">
+          <a:ln>
             <a:solidFill>
               <a:srgbClr val="E2DED4"/>
             </a:solidFill>
@@ -4158,7 +5197,7 @@
           </a:p>
           <a:p>
             <a:pPr>
-              <a:defRPr sz="1400" b="1">
+              <a:defRPr sz="1300" b="1">
                 <a:solidFill>
                   <a:srgbClr val="172621"/>
                 </a:solidFill>
@@ -4171,7 +5210,7 @@
           </a:p>
           <a:p>
             <a:pPr>
-              <a:defRPr sz="1100">
+              <a:defRPr sz="1000">
                 <a:solidFill>
                   <a:srgbClr val="596E64"/>
                 </a:solidFill>
@@ -4179,7 +5218,7 @@
               </a:defRPr>
             </a:pPr>
             <a:r>
-              <a:t>Buyer upload: 30–60s unboxing video + reason</a:t>
+              <a:t>Buyer upload: 30–60s unboxing video + reason in support message</a:t>
             </a:r>
           </a:p>
         </p:txBody>
@@ -4193,7 +5232,7 @@
         <p:spPr>
           <a:xfrm>
             <a:off x="731520" y="4297680"/>
-            <a:ext cx="3108960" cy="1234440"/>
+            <a:ext cx="3291840" cy="1737360"/>
           </a:xfrm>
           <a:prstGeom prst="rect">
             <a:avLst/>
@@ -4201,7 +5240,7 @@
           <a:solidFill>
             <a:srgbClr val="FFFFFF"/>
           </a:solidFill>
-          <a:ln w="12700">
+          <a:ln>
             <a:solidFill>
               <a:srgbClr val="E2DED4"/>
             </a:solidFill>
@@ -4239,7 +5278,7 @@
           </a:p>
           <a:p>
             <a:pPr>
-              <a:defRPr sz="1400" b="1">
+              <a:defRPr sz="1300" b="1">
                 <a:solidFill>
                   <a:srgbClr val="172621"/>
                 </a:solidFill>
@@ -4252,7 +5291,7 @@
           </a:p>
           <a:p>
             <a:pPr>
-              <a:defRPr sz="1100">
+              <a:defRPr sz="1000">
                 <a:solidFill>
                   <a:srgbClr val="596E64"/>
                 </a:solidFill>
@@ -4260,7 +5299,7 @@
               </a:defRPr>
             </a:pPr>
             <a:r>
-              <a:t>Shippo mock tracking API scan</a:t>
+              <a:t>Shippo mock tracking API scan timestamp verification</a:t>
             </a:r>
           </a:p>
         </p:txBody>
@@ -4273,170 +5312,8 @@
         </p:nvSpPr>
         <p:spPr>
           <a:xfrm>
-            <a:off x="8321040" y="2468880"/>
-            <a:ext cx="3108960" cy="1234440"/>
-          </a:xfrm>
-          <a:prstGeom prst="rect">
-            <a:avLst/>
-          </a:prstGeom>
-          <a:solidFill>
-            <a:srgbClr val="FFFFFF"/>
-          </a:solidFill>
-          <a:ln w="12700">
-            <a:solidFill>
-              <a:srgbClr val="E2DED4"/>
-            </a:solidFill>
-          </a:ln>
-        </p:spPr>
-        <p:style>
-          <a:lnRef idx="1">
-            <a:schemeClr val="accent1"/>
-          </a:lnRef>
-          <a:fillRef idx="3">
-            <a:schemeClr val="accent1"/>
-          </a:fillRef>
-          <a:effectRef idx="2">
-            <a:schemeClr val="accent1"/>
-          </a:effectRef>
-          <a:fontRef idx="minor">
-            <a:schemeClr val="lt1"/>
-          </a:fontRef>
-        </p:style>
-        <p:txBody>
-          <a:bodyPr rtlCol="0" anchor="ctr" wrap="square"/>
-          <a:lstStyle/>
-          <a:p>
-            <a:pPr algn="ctr">
-              <a:defRPr sz="1000" b="1">
-                <a:solidFill>
-                  <a:srgbClr val="006B55"/>
-                </a:solidFill>
-                <a:latin typeface="IBM Plex Mono"/>
-              </a:defRPr>
-            </a:pPr>
-            <a:r>
-              <a:t>02 ORDER RECORD</a:t>
-            </a:r>
-          </a:p>
-          <a:p>
-            <a:pPr>
-              <a:defRPr sz="1400" b="1">
-                <a:solidFill>
-                  <a:srgbClr val="172621"/>
-                </a:solidFill>
-                <a:latin typeface="Inter"/>
-              </a:defRPr>
-            </a:pPr>
-            <a:r>
-              <a:t>White Headphones · ₹1,499</a:t>
-            </a:r>
-          </a:p>
-          <a:p>
-            <a:pPr>
-              <a:defRPr sz="1100">
-                <a:solidFill>
-                  <a:srgbClr val="596E64"/>
-                </a:solidFill>
-                <a:latin typeface="Inter"/>
-              </a:defRPr>
-            </a:pPr>
-            <a:r>
-              <a:t>Shopify mock store API inventory database</a:t>
-            </a:r>
-          </a:p>
-        </p:txBody>
-      </p:sp>
-      <p:sp>
-        <p:nvSpPr>
-          <p:cNvPr id="9" name="Rectangle 8"/>
-          <p:cNvSpPr/>
-          <p:nvPr/>
-        </p:nvSpPr>
-        <p:spPr>
-          <a:xfrm>
-            <a:off x="8321040" y="4297680"/>
-            <a:ext cx="3108960" cy="1234440"/>
-          </a:xfrm>
-          <a:prstGeom prst="rect">
-            <a:avLst/>
-          </a:prstGeom>
-          <a:solidFill>
-            <a:srgbClr val="FFFFFF"/>
-          </a:solidFill>
-          <a:ln w="12700">
-            <a:solidFill>
-              <a:srgbClr val="E2DED4"/>
-            </a:solidFill>
-          </a:ln>
-        </p:spPr>
-        <p:style>
-          <a:lnRef idx="1">
-            <a:schemeClr val="accent1"/>
-          </a:lnRef>
-          <a:fillRef idx="3">
-            <a:schemeClr val="accent1"/>
-          </a:fillRef>
-          <a:effectRef idx="2">
-            <a:schemeClr val="accent1"/>
-          </a:effectRef>
-          <a:fontRef idx="minor">
-            <a:schemeClr val="lt1"/>
-          </a:fontRef>
-        </p:style>
-        <p:txBody>
-          <a:bodyPr rtlCol="0" anchor="ctr" wrap="square"/>
-          <a:lstStyle/>
-          <a:p>
-            <a:pPr algn="ctr">
-              <a:defRPr sz="1000" b="1">
-                <a:solidFill>
-                  <a:srgbClr val="006B55"/>
-                </a:solidFill>
-                <a:latin typeface="IBM Plex Mono"/>
-              </a:defRPr>
-            </a:pPr>
-            <a:r>
-              <a:t>04 RETURN POLICY</a:t>
-            </a:r>
-          </a:p>
-          <a:p>
-            <a:pPr>
-              <a:defRPr sz="1400" b="1">
-                <a:solidFill>
-                  <a:srgbClr val="172621"/>
-                </a:solidFill>
-                <a:latin typeface="Inter"/>
-              </a:defRPr>
-            </a:pPr>
-            <a:r>
-              <a:t>7-Day Window · Sealed Tag</a:t>
-            </a:r>
-          </a:p>
-          <a:p>
-            <a:pPr>
-              <a:defRPr sz="1100">
-                <a:solidFill>
-                  <a:srgbClr val="596E64"/>
-                </a:solidFill>
-                <a:latin typeface="Inter"/>
-              </a:defRPr>
-            </a:pPr>
-            <a:r>
-              <a:t>Deterministic code rules P-01 to P-08, never prompts</a:t>
-            </a:r>
-          </a:p>
-        </p:txBody>
-      </p:sp>
-      <p:sp>
-        <p:nvSpPr>
-          <p:cNvPr id="10" name="Rectangle 9"/>
-          <p:cNvSpPr/>
-          <p:nvPr/>
-        </p:nvSpPr>
-        <p:spPr>
-          <a:xfrm>
-            <a:off x="4114800" y="2651760"/>
-            <a:ext cx="3931920" cy="2560320"/>
+            <a:off x="4297680" y="2377440"/>
+            <a:ext cx="3566160" cy="3657600"/>
           </a:xfrm>
           <a:prstGeom prst="rect">
             <a:avLst/>
@@ -4482,7 +5359,7 @@
           </a:p>
           <a:p>
             <a:pPr algn="ctr">
-              <a:defRPr sz="1400" b="1">
+              <a:defRPr sz="1500" b="1">
                 <a:solidFill>
                   <a:srgbClr val="F5F3EF"/>
                 </a:solidFill>
@@ -4490,20 +5367,188 @@
               </a:defRPr>
             </a:pPr>
             <a:r>
-              <a:t>NO SINGLE RECORD TIES ORDER, VIDEO &amp; POLICY TOGETHER</a:t>
-            </a:r>
-          </a:p>
-          <a:p>
+              <a:t>NO SHARED EVIDENCE RECORD</a:t>
+            </a:r>
+          </a:p>
+          <a:p>
+            <a:br/>
             <a:pPr algn="ctr">
+              <a:defRPr sz="1050">
+                <a:solidFill>
+                  <a:srgbClr val="D1D5DB"/>
+                </a:solidFill>
+                <a:latin typeface="Inter"/>
+              </a:defRPr>
+            </a:pPr>
+            <a:r>
+              <a:t>Today the seller opens 4 tabs, then decides alone. A wrong refund loses inventory; an unfair denial loses a customer.</a:t>
+            </a:r>
+            <a:br/>
+            <a:br/>
+            <a:r>
+              <a:t>The gap is that no single record ties order truth, video frames, policy clauses, and decisions together.</a:t>
+            </a:r>
+          </a:p>
+        </p:txBody>
+      </p:sp>
+      <p:sp>
+        <p:nvSpPr>
+          <p:cNvPr id="9" name="Rectangle 8"/>
+          <p:cNvSpPr/>
+          <p:nvPr/>
+        </p:nvSpPr>
+        <p:spPr>
+          <a:xfrm>
+            <a:off x="8138160" y="2377440"/>
+            <a:ext cx="3291840" cy="1737360"/>
+          </a:xfrm>
+          <a:prstGeom prst="rect">
+            <a:avLst/>
+          </a:prstGeom>
+          <a:solidFill>
+            <a:srgbClr val="FFFFFF"/>
+          </a:solidFill>
+          <a:ln>
+            <a:solidFill>
+              <a:srgbClr val="E2DED4"/>
+            </a:solidFill>
+          </a:ln>
+        </p:spPr>
+        <p:style>
+          <a:lnRef idx="1">
+            <a:schemeClr val="accent1"/>
+          </a:lnRef>
+          <a:fillRef idx="3">
+            <a:schemeClr val="accent1"/>
+          </a:fillRef>
+          <a:effectRef idx="2">
+            <a:schemeClr val="accent1"/>
+          </a:effectRef>
+          <a:fontRef idx="minor">
+            <a:schemeClr val="lt1"/>
+          </a:fontRef>
+        </p:style>
+        <p:txBody>
+          <a:bodyPr rtlCol="0" anchor="ctr" wrap="square"/>
+          <a:lstStyle/>
+          <a:p>
+            <a:pPr algn="ctr">
+              <a:defRPr sz="1000" b="1">
+                <a:solidFill>
+                  <a:srgbClr val="006B55"/>
+                </a:solidFill>
+                <a:latin typeface="IBM Plex Mono"/>
+              </a:defRPr>
+            </a:pPr>
+            <a:r>
+              <a:t>02 ORDER RECORD</a:t>
+            </a:r>
+          </a:p>
+          <a:p>
+            <a:pPr>
+              <a:defRPr sz="1300" b="1">
+                <a:solidFill>
+                  <a:srgbClr val="172621"/>
+                </a:solidFill>
+                <a:latin typeface="Inter"/>
+              </a:defRPr>
+            </a:pPr>
+            <a:r>
+              <a:t>White Headphones · ₹1,499</a:t>
+            </a:r>
+          </a:p>
+          <a:p>
+            <a:pPr>
               <a:defRPr sz="1000">
                 <a:solidFill>
-                  <a:srgbClr val="D1D5DB"/>
+                  <a:srgbClr val="596E64"/>
                 </a:solidFill>
                 <a:latin typeface="Inter"/>
               </a:defRPr>
             </a:pPr>
             <a:r>
-              <a:t>Today the seller opens many tabs, then decides alone. A wrong refund loses money and stock; an unfair denial loses a repeat customer. The gap is not a missing returns portal, it is that no single record ties order, video frame, policy clause, and decision together.</a:t>
+              <a:t>Shopify mock store API product inventory catalog</a:t>
+            </a:r>
+          </a:p>
+        </p:txBody>
+      </p:sp>
+      <p:sp>
+        <p:nvSpPr>
+          <p:cNvPr id="10" name="Rectangle 9"/>
+          <p:cNvSpPr/>
+          <p:nvPr/>
+        </p:nvSpPr>
+        <p:spPr>
+          <a:xfrm>
+            <a:off x="8138160" y="4297680"/>
+            <a:ext cx="3291840" cy="1737360"/>
+          </a:xfrm>
+          <a:prstGeom prst="rect">
+            <a:avLst/>
+          </a:prstGeom>
+          <a:solidFill>
+            <a:srgbClr val="FFFFFF"/>
+          </a:solidFill>
+          <a:ln>
+            <a:solidFill>
+              <a:srgbClr val="E2DED4"/>
+            </a:solidFill>
+          </a:ln>
+        </p:spPr>
+        <p:style>
+          <a:lnRef idx="1">
+            <a:schemeClr val="accent1"/>
+          </a:lnRef>
+          <a:fillRef idx="3">
+            <a:schemeClr val="accent1"/>
+          </a:fillRef>
+          <a:effectRef idx="2">
+            <a:schemeClr val="accent1"/>
+          </a:effectRef>
+          <a:fontRef idx="minor">
+            <a:schemeClr val="lt1"/>
+          </a:fontRef>
+        </p:style>
+        <p:txBody>
+          <a:bodyPr rtlCol="0" anchor="ctr" wrap="square"/>
+          <a:lstStyle/>
+          <a:p>
+            <a:pPr algn="ctr">
+              <a:defRPr sz="1000" b="1">
+                <a:solidFill>
+                  <a:srgbClr val="006B55"/>
+                </a:solidFill>
+                <a:latin typeface="IBM Plex Mono"/>
+              </a:defRPr>
+            </a:pPr>
+            <a:r>
+              <a:t>04 RETURN POLICY</a:t>
+            </a:r>
+          </a:p>
+          <a:p>
+            <a:pPr>
+              <a:defRPr sz="1300" b="1">
+                <a:solidFill>
+                  <a:srgbClr val="172621"/>
+                </a:solidFill>
+                <a:latin typeface="Inter"/>
+              </a:defRPr>
+            </a:pPr>
+            <a:r>
+              <a:t>7-Day Window · Sealed Tag</a:t>
+            </a:r>
+          </a:p>
+          <a:p>
+            <a:pPr>
+              <a:defRPr sz="1000">
+                <a:solidFill>
+                  <a:srgbClr val="596E64"/>
+                </a:solidFill>
+                <a:latin typeface="Inter"/>
+              </a:defRPr>
+            </a:pPr>
+            <a:r>
+              <a:t>Deterministic code rules P-01 to P-08, never prompts</a:t>
             </a:r>
           </a:p>
         </p:txBody>
@@ -4884,7 +5929,7 @@
           <a:lstStyle/>
           <a:p>
             <a:pPr>
-              <a:defRPr sz="1000" b="1">
+              <a:defRPr sz="950" b="1">
                 <a:solidFill>
                   <a:srgbClr val="172621"/>
                 </a:solidFill>
@@ -4892,7 +5937,7 @@
               </a:defRPr>
             </a:pPr>
             <a:r>
-              <a:t>ORDER RECORD · SKU: HEAD-WHT-02</a:t>
+              <a:t>ORDER RECORD · STORE GROUND TRUTH</a:t>
             </a:r>
           </a:p>
           <a:p>
@@ -4905,7 +5950,11 @@
               </a:defRPr>
             </a:pPr>
             <a:r>
-              <a:t>Matte White · ₹1,499 · Delivered 4 days ago · Tag present</a:t>
+              <a:t>HEAD-WHT-02 · Matte White · ₹1,499</a:t>
+            </a:r>
+            <a:br/>
+            <a:r>
+              <a:t>Delivered 4 days ago · Original tag present</a:t>
             </a:r>
           </a:p>
         </p:txBody>
@@ -5002,7 +6051,7 @@
           <a:lstStyle/>
           <a:p>
             <a:pPr>
-              <a:defRPr sz="1000" b="1">
+              <a:defRPr sz="950" b="1">
                 <a:solidFill>
                   <a:srgbClr val="172621"/>
                 </a:solidFill>
@@ -5010,7 +6059,7 @@
               </a:defRPr>
             </a:pPr>
             <a:r>
-              <a:t>VIDEO FRAME · TIME 00:07 / 00:32</a:t>
+              <a:t>VIDEO FRAME · INTAKE TIMESTAMP 00:07</a:t>
             </a:r>
           </a:p>
           <a:p>
@@ -5023,7 +6072,11 @@
               </a:defRPr>
             </a:pPr>
             <a:r>
-              <a:t>Observed: HEAD-BLK-09 · Midnight Black · Mock evidence pack</a:t>
+              <a:t>Observed Color: Midnight Black</a:t>
+            </a:r>
+            <a:br/>
+            <a:r>
+              <a:t>Exact SKU: Not verified · Tag: Not visible in cited frame</a:t>
             </a:r>
           </a:p>
         </p:txBody>
@@ -5213,7 +6266,7 @@
               </a:defRPr>
             </a:pPr>
             <a:r>
-              <a:t>Policy P-03 Check: FAIL</a:t>
+              <a:t>P-03 Check: COLOR MISMATCH</a:t>
             </a:r>
           </a:p>
           <a:p>
@@ -5246,7 +6299,7 @@
           <a:p>
             <a:br/>
             <a:pPr>
-              <a:defRPr sz="1000" b="1">
+              <a:defRPr sz="950" b="1">
                 <a:solidFill>
                   <a:srgbClr val="991B1B"/>
                 </a:solidFill>
@@ -5254,42 +6307,46 @@
               </a:defRPr>
             </a:pPr>
             <a:r>
-              <a:t>STATUS: ESCALATE (NEEDS SELLER REVIEW)</a:t>
+              <a:t>STATUS: ESCALATE (SELLER REVIEW REQUIRED)</a:t>
+            </a:r>
+          </a:p>
+          <a:p>
+            <a:pPr>
+              <a:defRPr sz="950">
+                <a:solidFill>
+                  <a:srgbClr val="991B1B"/>
+                </a:solidFill>
+                <a:latin typeface="Inter"/>
+              </a:defRPr>
+            </a:pPr>
+            <a:r>
+              <a:t>Color mismatch observed · Exact SKU unconfirmed · No auto-denial.</a:t>
             </a:r>
           </a:p>
           <a:p>
             <a:br/>
             <a:pPr>
-              <a:defRPr sz="900" b="1">
+              <a:defRPr sz="900">
                 <a:solidFill>
                   <a:srgbClr val="172621"/>
                 </a:solidFill>
-                <a:latin typeface="IBM Plex Mono"/>
+                <a:latin typeface="Inter"/>
               </a:defRPr>
             </a:pPr>
             <a:r>
               <a:t>Seller Action Options:</a:t>
             </a:r>
-          </a:p>
-          <a:p>
-            <a:pPr>
-              <a:defRPr sz="900">
-                <a:solidFill>
-                  <a:srgbClr val="172621"/>
-                </a:solidFill>
-                <a:latin typeface="Inter"/>
-              </a:defRPr>
-            </a:pPr>
-            <a:r>
-              <a:t>1. Accept as merchant mis-shipment</a:t>
-            </a:r>
             <a:br/>
             <a:r>
-              <a:t>2. Ask customer for outside-box shipping label</a:t>
+              <a:t>1. Accept as merchant mis-shipment (seller mistake)</a:t>
             </a:r>
             <a:br/>
             <a:r>
-              <a:t>3. Hold return for physical inspection at warehouse</a:t>
+              <a:t>2. Ask customer for outside-box shipping label (buyer mistake)</a:t>
+            </a:r>
+            <a:br/>
+            <a:r>
+              <a:t>3. Hold return for physical inspection at warehouse (potential swap)</a:t>
             </a:r>
           </a:p>
           <a:p>
@@ -5605,7 +6662,7 @@
         <p:spPr>
           <a:xfrm>
             <a:off x="731520" y="2148840"/>
-            <a:ext cx="1691640" cy="1280160"/>
+            <a:ext cx="1600200" cy="1188720"/>
           </a:xfrm>
           <a:prstGeom prst="rect">
             <a:avLst/>
@@ -5638,7 +6695,7 @@
           <a:lstStyle/>
           <a:p>
             <a:pPr algn="ctr">
-              <a:defRPr sz="900">
+              <a:defRPr sz="850">
                 <a:solidFill>
                   <a:srgbClr val="6C8279"/>
                 </a:solidFill>
@@ -5651,7 +6708,7 @@
           </a:p>
           <a:p>
             <a:pPr>
-              <a:defRPr sz="1200" b="1">
+              <a:defRPr sz="1150" b="1">
                 <a:solidFill>
                   <a:srgbClr val="F5F3EF"/>
                 </a:solidFill>
@@ -5673,7 +6730,7 @@
         <p:spPr>
           <a:xfrm>
             <a:off x="731520" y="2148840"/>
-            <a:ext cx="1691640" cy="36576"/>
+            <a:ext cx="1600200" cy="36576"/>
           </a:xfrm>
           <a:prstGeom prst="rect">
             <a:avLst/>
@@ -5715,8 +6772,8 @@
         </p:nvSpPr>
         <p:spPr>
           <a:xfrm>
-            <a:off x="841248" y="3017520"/>
-            <a:ext cx="1472184" cy="274320"/>
+            <a:off x="822960" y="2953512"/>
+            <a:ext cx="1417320" cy="256032"/>
           </a:xfrm>
           <a:prstGeom prst="rect">
             <a:avLst/>
@@ -5747,7 +6804,7 @@
           <a:lstStyle/>
           <a:p>
             <a:pPr algn="ctr">
-              <a:defRPr sz="900" b="1">
+              <a:defRPr sz="850" b="1">
                 <a:solidFill>
                   <a:srgbClr val="00D1A7"/>
                 </a:solidFill>
@@ -5762,14 +6819,50 @@
       </p:sp>
       <p:sp>
         <p:nvSpPr>
-          <p:cNvPr id="9" name="Rectangle 8"/>
+          <p:cNvPr id="9" name="TextBox 8"/>
+          <p:cNvSpPr txBox="1"/>
+          <p:nvPr/>
+        </p:nvSpPr>
+        <p:spPr>
+          <a:xfrm>
+            <a:off x="2331720" y="2514600"/>
+            <a:ext cx="219456" cy="365760"/>
+          </a:xfrm>
+          <a:prstGeom prst="rect">
+            <a:avLst/>
+          </a:prstGeom>
+          <a:noFill/>
+        </p:spPr>
+        <p:txBody>
+          <a:bodyPr wrap="none">
+            <a:spAutoFit/>
+          </a:bodyPr>
+          <a:lstStyle/>
+          <a:p>
+            <a:pPr algn="ctr">
+              <a:defRPr sz="1400" b="1">
+                <a:solidFill>
+                  <a:srgbClr val="00D1A7"/>
+                </a:solidFill>
+                <a:latin typeface="IBM Plex Mono"/>
+              </a:defRPr>
+            </a:pPr>
+            <a:r>
+              <a:t>→</a:t>
+            </a:r>
+          </a:p>
+        </p:txBody>
+      </p:sp>
+      <p:sp>
+        <p:nvSpPr>
+          <p:cNvPr id="10" name="Rectangle 9"/>
           <p:cNvSpPr/>
           <p:nvPr/>
         </p:nvSpPr>
         <p:spPr>
           <a:xfrm>
-            <a:off x="2532888" y="2148840"/>
-            <a:ext cx="1691640" cy="1280160"/>
+            <a:off x="2551176" y="2148840"/>
+            <a:ext cx="1600200" cy="1188720"/>
           </a:xfrm>
           <a:prstGeom prst="rect">
             <a:avLst/>
@@ -5802,7 +6895,7 @@
           <a:lstStyle/>
           <a:p>
             <a:pPr algn="ctr">
-              <a:defRPr sz="900">
+              <a:defRPr sz="850">
                 <a:solidFill>
                   <a:srgbClr val="6C8279"/>
                 </a:solidFill>
@@ -5815,7 +6908,7 @@
           </a:p>
           <a:p>
             <a:pPr>
-              <a:defRPr sz="1200" b="1">
+              <a:defRPr sz="1150" b="1">
                 <a:solidFill>
                   <a:srgbClr val="F5F3EF"/>
                 </a:solidFill>
@@ -5830,14 +6923,14 @@
       </p:sp>
       <p:sp>
         <p:nvSpPr>
-          <p:cNvPr id="10" name="Rectangle 9"/>
+          <p:cNvPr id="11" name="Rectangle 10"/>
           <p:cNvSpPr/>
           <p:nvPr/>
         </p:nvSpPr>
         <p:spPr>
           <a:xfrm>
-            <a:off x="2532888" y="2148840"/>
-            <a:ext cx="1691640" cy="36576"/>
+            <a:off x="2551176" y="2148840"/>
+            <a:ext cx="1600200" cy="36576"/>
           </a:xfrm>
           <a:prstGeom prst="rect">
             <a:avLst/>
@@ -5873,14 +6966,14 @@
       </p:sp>
       <p:sp>
         <p:nvSpPr>
-          <p:cNvPr id="11" name="Rectangle 10"/>
+          <p:cNvPr id="12" name="Rectangle 11"/>
           <p:cNvSpPr/>
           <p:nvPr/>
         </p:nvSpPr>
         <p:spPr>
           <a:xfrm>
-            <a:off x="2642616" y="3017520"/>
-            <a:ext cx="1472184" cy="274320"/>
+            <a:off x="2642616" y="2953512"/>
+            <a:ext cx="1417320" cy="256032"/>
           </a:xfrm>
           <a:prstGeom prst="rect">
             <a:avLst/>
@@ -5911,7 +7004,7 @@
           <a:lstStyle/>
           <a:p>
             <a:pPr algn="ctr">
-              <a:defRPr sz="900" b="1">
+              <a:defRPr sz="850" b="1">
                 <a:solidFill>
                   <a:srgbClr val="F5F3EF"/>
                 </a:solidFill>
@@ -5926,14 +7019,50 @@
       </p:sp>
       <p:sp>
         <p:nvSpPr>
-          <p:cNvPr id="12" name="Rectangle 11"/>
+          <p:cNvPr id="13" name="TextBox 12"/>
+          <p:cNvSpPr txBox="1"/>
+          <p:nvPr/>
+        </p:nvSpPr>
+        <p:spPr>
+          <a:xfrm>
+            <a:off x="4151376" y="2514600"/>
+            <a:ext cx="219456" cy="365760"/>
+          </a:xfrm>
+          <a:prstGeom prst="rect">
+            <a:avLst/>
+          </a:prstGeom>
+          <a:noFill/>
+        </p:spPr>
+        <p:txBody>
+          <a:bodyPr wrap="none">
+            <a:spAutoFit/>
+          </a:bodyPr>
+          <a:lstStyle/>
+          <a:p>
+            <a:pPr algn="ctr">
+              <a:defRPr sz="1400" b="1">
+                <a:solidFill>
+                  <a:srgbClr val="00D1A7"/>
+                </a:solidFill>
+                <a:latin typeface="IBM Plex Mono"/>
+              </a:defRPr>
+            </a:pPr>
+            <a:r>
+              <a:t>→</a:t>
+            </a:r>
+          </a:p>
+        </p:txBody>
+      </p:sp>
+      <p:sp>
+        <p:nvSpPr>
+          <p:cNvPr id="14" name="Rectangle 13"/>
           <p:cNvSpPr/>
           <p:nvPr/>
         </p:nvSpPr>
         <p:spPr>
           <a:xfrm>
-            <a:off x="4334256" y="2148840"/>
-            <a:ext cx="1691640" cy="1280160"/>
+            <a:off x="4370832" y="2148840"/>
+            <a:ext cx="1600200" cy="1188720"/>
           </a:xfrm>
           <a:prstGeom prst="rect">
             <a:avLst/>
@@ -5966,7 +7095,7 @@
           <a:lstStyle/>
           <a:p>
             <a:pPr algn="ctr">
-              <a:defRPr sz="900">
+              <a:defRPr sz="850">
                 <a:solidFill>
                   <a:srgbClr val="6C8279"/>
                 </a:solidFill>
@@ -5979,7 +7108,7 @@
           </a:p>
           <a:p>
             <a:pPr>
-              <a:defRPr sz="1200" b="1">
+              <a:defRPr sz="1150" b="1">
                 <a:solidFill>
                   <a:srgbClr val="F5F3EF"/>
                 </a:solidFill>
@@ -5994,14 +7123,14 @@
       </p:sp>
       <p:sp>
         <p:nvSpPr>
-          <p:cNvPr id="13" name="Rectangle 12"/>
+          <p:cNvPr id="15" name="Rectangle 14"/>
           <p:cNvSpPr/>
           <p:nvPr/>
         </p:nvSpPr>
         <p:spPr>
           <a:xfrm>
-            <a:off x="4334256" y="2148840"/>
-            <a:ext cx="1691640" cy="36576"/>
+            <a:off x="4370832" y="2148840"/>
+            <a:ext cx="1600200" cy="36576"/>
           </a:xfrm>
           <a:prstGeom prst="rect">
             <a:avLst/>
@@ -6037,14 +7166,14 @@
       </p:sp>
       <p:sp>
         <p:nvSpPr>
-          <p:cNvPr id="14" name="Rectangle 13"/>
+          <p:cNvPr id="16" name="Rectangle 15"/>
           <p:cNvSpPr/>
           <p:nvPr/>
         </p:nvSpPr>
         <p:spPr>
           <a:xfrm>
-            <a:off x="4443984" y="3017520"/>
-            <a:ext cx="1472184" cy="274320"/>
+            <a:off x="4462272" y="2953512"/>
+            <a:ext cx="1417320" cy="256032"/>
           </a:xfrm>
           <a:prstGeom prst="rect">
             <a:avLst/>
@@ -6075,7 +7204,7 @@
           <a:lstStyle/>
           <a:p>
             <a:pPr algn="ctr">
-              <a:defRPr sz="900" b="1">
+              <a:defRPr sz="850" b="1">
                 <a:solidFill>
                   <a:srgbClr val="F5F3EF"/>
                 </a:solidFill>
@@ -6090,14 +7219,50 @@
       </p:sp>
       <p:sp>
         <p:nvSpPr>
-          <p:cNvPr id="15" name="Rectangle 14"/>
+          <p:cNvPr id="17" name="TextBox 16"/>
+          <p:cNvSpPr txBox="1"/>
+          <p:nvPr/>
+        </p:nvSpPr>
+        <p:spPr>
+          <a:xfrm>
+            <a:off x="5971032" y="2514600"/>
+            <a:ext cx="219456" cy="365760"/>
+          </a:xfrm>
+          <a:prstGeom prst="rect">
+            <a:avLst/>
+          </a:prstGeom>
+          <a:noFill/>
+        </p:spPr>
+        <p:txBody>
+          <a:bodyPr wrap="none">
+            <a:spAutoFit/>
+          </a:bodyPr>
+          <a:lstStyle/>
+          <a:p>
+            <a:pPr algn="ctr">
+              <a:defRPr sz="1400" b="1">
+                <a:solidFill>
+                  <a:srgbClr val="00D1A7"/>
+                </a:solidFill>
+                <a:latin typeface="IBM Plex Mono"/>
+              </a:defRPr>
+            </a:pPr>
+            <a:r>
+              <a:t>→</a:t>
+            </a:r>
+          </a:p>
+        </p:txBody>
+      </p:sp>
+      <p:sp>
+        <p:nvSpPr>
+          <p:cNvPr id="18" name="Rectangle 17"/>
           <p:cNvSpPr/>
           <p:nvPr/>
         </p:nvSpPr>
         <p:spPr>
           <a:xfrm>
-            <a:off x="6135624" y="2148840"/>
-            <a:ext cx="1691640" cy="1280160"/>
+            <a:off x="6190488" y="2148840"/>
+            <a:ext cx="1600200" cy="1188720"/>
           </a:xfrm>
           <a:prstGeom prst="rect">
             <a:avLst/>
@@ -6130,7 +7295,7 @@
           <a:lstStyle/>
           <a:p>
             <a:pPr algn="ctr">
-              <a:defRPr sz="900">
+              <a:defRPr sz="850">
                 <a:solidFill>
                   <a:srgbClr val="6C8279"/>
                 </a:solidFill>
@@ -6143,7 +7308,7 @@
           </a:p>
           <a:p>
             <a:pPr>
-              <a:defRPr sz="1200" b="1">
+              <a:defRPr sz="1150" b="1">
                 <a:solidFill>
                   <a:srgbClr val="F5F3EF"/>
                 </a:solidFill>
@@ -6158,14 +7323,14 @@
       </p:sp>
       <p:sp>
         <p:nvSpPr>
-          <p:cNvPr id="16" name="Rectangle 15"/>
+          <p:cNvPr id="19" name="Rectangle 18"/>
           <p:cNvSpPr/>
           <p:nvPr/>
         </p:nvSpPr>
         <p:spPr>
           <a:xfrm>
-            <a:off x="6135624" y="2148840"/>
-            <a:ext cx="1691640" cy="36576"/>
+            <a:off x="6190488" y="2148840"/>
+            <a:ext cx="1600200" cy="36576"/>
           </a:xfrm>
           <a:prstGeom prst="rect">
             <a:avLst/>
@@ -6201,14 +7366,14 @@
       </p:sp>
       <p:sp>
         <p:nvSpPr>
-          <p:cNvPr id="17" name="Rectangle 16"/>
+          <p:cNvPr id="20" name="Rectangle 19"/>
           <p:cNvSpPr/>
           <p:nvPr/>
         </p:nvSpPr>
         <p:spPr>
           <a:xfrm>
-            <a:off x="6245352" y="3017520"/>
-            <a:ext cx="1472184" cy="274320"/>
+            <a:off x="6281928" y="2953512"/>
+            <a:ext cx="1417320" cy="256032"/>
           </a:xfrm>
           <a:prstGeom prst="rect">
             <a:avLst/>
@@ -6239,7 +7404,7 @@
           <a:lstStyle/>
           <a:p>
             <a:pPr algn="ctr">
-              <a:defRPr sz="900" b="1">
+              <a:defRPr sz="850" b="1">
                 <a:solidFill>
                   <a:srgbClr val="00D1A7"/>
                 </a:solidFill>
@@ -6254,14 +7419,50 @@
       </p:sp>
       <p:sp>
         <p:nvSpPr>
-          <p:cNvPr id="18" name="Rectangle 17"/>
+          <p:cNvPr id="21" name="TextBox 20"/>
+          <p:cNvSpPr txBox="1"/>
+          <p:nvPr/>
+        </p:nvSpPr>
+        <p:spPr>
+          <a:xfrm>
+            <a:off x="7790688" y="2514600"/>
+            <a:ext cx="219456" cy="365760"/>
+          </a:xfrm>
+          <a:prstGeom prst="rect">
+            <a:avLst/>
+          </a:prstGeom>
+          <a:noFill/>
+        </p:spPr>
+        <p:txBody>
+          <a:bodyPr wrap="none">
+            <a:spAutoFit/>
+          </a:bodyPr>
+          <a:lstStyle/>
+          <a:p>
+            <a:pPr algn="ctr">
+              <a:defRPr sz="1400" b="1">
+                <a:solidFill>
+                  <a:srgbClr val="00D1A7"/>
+                </a:solidFill>
+                <a:latin typeface="IBM Plex Mono"/>
+              </a:defRPr>
+            </a:pPr>
+            <a:r>
+              <a:t>→</a:t>
+            </a:r>
+          </a:p>
+        </p:txBody>
+      </p:sp>
+      <p:sp>
+        <p:nvSpPr>
+          <p:cNvPr id="22" name="Rectangle 21"/>
           <p:cNvSpPr/>
           <p:nvPr/>
         </p:nvSpPr>
         <p:spPr>
           <a:xfrm>
-            <a:off x="7936992" y="2148840"/>
-            <a:ext cx="1691640" cy="1280160"/>
+            <a:off x="8010144" y="2148840"/>
+            <a:ext cx="1600200" cy="1188720"/>
           </a:xfrm>
           <a:prstGeom prst="rect">
             <a:avLst/>
@@ -6294,7 +7495,7 @@
           <a:lstStyle/>
           <a:p>
             <a:pPr algn="ctr">
-              <a:defRPr sz="900">
+              <a:defRPr sz="850">
                 <a:solidFill>
                   <a:srgbClr val="6C8279"/>
                 </a:solidFill>
@@ -6307,7 +7508,7 @@
           </a:p>
           <a:p>
             <a:pPr>
-              <a:defRPr sz="1200" b="1">
+              <a:defRPr sz="1150" b="1">
                 <a:solidFill>
                   <a:srgbClr val="F5F3EF"/>
                 </a:solidFill>
@@ -6322,14 +7523,14 @@
       </p:sp>
       <p:sp>
         <p:nvSpPr>
-          <p:cNvPr id="19" name="Rectangle 18"/>
+          <p:cNvPr id="23" name="Rectangle 22"/>
           <p:cNvSpPr/>
           <p:nvPr/>
         </p:nvSpPr>
         <p:spPr>
           <a:xfrm>
-            <a:off x="7936992" y="2148840"/>
-            <a:ext cx="1691640" cy="36576"/>
+            <a:off x="8010144" y="2148840"/>
+            <a:ext cx="1600200" cy="36576"/>
           </a:xfrm>
           <a:prstGeom prst="rect">
             <a:avLst/>
@@ -6365,14 +7566,14 @@
       </p:sp>
       <p:sp>
         <p:nvSpPr>
-          <p:cNvPr id="20" name="Rectangle 19"/>
+          <p:cNvPr id="24" name="Rectangle 23"/>
           <p:cNvSpPr/>
           <p:nvPr/>
         </p:nvSpPr>
         <p:spPr>
           <a:xfrm>
-            <a:off x="8046720" y="3017520"/>
-            <a:ext cx="1472184" cy="274320"/>
+            <a:off x="8101584" y="2953512"/>
+            <a:ext cx="1417320" cy="256032"/>
           </a:xfrm>
           <a:prstGeom prst="rect">
             <a:avLst/>
@@ -6403,7 +7604,7 @@
           <a:lstStyle/>
           <a:p>
             <a:pPr algn="ctr">
-              <a:defRPr sz="900" b="1">
+              <a:defRPr sz="850" b="1">
                 <a:solidFill>
                   <a:srgbClr val="FBBF24"/>
                 </a:solidFill>
@@ -6418,14 +7619,50 @@
       </p:sp>
       <p:sp>
         <p:nvSpPr>
-          <p:cNvPr id="21" name="Rectangle 20"/>
+          <p:cNvPr id="25" name="TextBox 24"/>
+          <p:cNvSpPr txBox="1"/>
+          <p:nvPr/>
+        </p:nvSpPr>
+        <p:spPr>
+          <a:xfrm>
+            <a:off x="9610344" y="2514600"/>
+            <a:ext cx="219456" cy="365760"/>
+          </a:xfrm>
+          <a:prstGeom prst="rect">
+            <a:avLst/>
+          </a:prstGeom>
+          <a:noFill/>
+        </p:spPr>
+        <p:txBody>
+          <a:bodyPr wrap="none">
+            <a:spAutoFit/>
+          </a:bodyPr>
+          <a:lstStyle/>
+          <a:p>
+            <a:pPr algn="ctr">
+              <a:defRPr sz="1400" b="1">
+                <a:solidFill>
+                  <a:srgbClr val="00D1A7"/>
+                </a:solidFill>
+                <a:latin typeface="IBM Plex Mono"/>
+              </a:defRPr>
+            </a:pPr>
+            <a:r>
+              <a:t>→</a:t>
+            </a:r>
+          </a:p>
+        </p:txBody>
+      </p:sp>
+      <p:sp>
+        <p:nvSpPr>
+          <p:cNvPr id="26" name="Rectangle 25"/>
           <p:cNvSpPr/>
           <p:nvPr/>
         </p:nvSpPr>
         <p:spPr>
           <a:xfrm>
-            <a:off x="9738360" y="2148840"/>
-            <a:ext cx="1691640" cy="1280160"/>
+            <a:off x="9829800" y="2148840"/>
+            <a:ext cx="1600200" cy="1188720"/>
           </a:xfrm>
           <a:prstGeom prst="rect">
             <a:avLst/>
@@ -6458,7 +7695,7 @@
           <a:lstStyle/>
           <a:p>
             <a:pPr algn="ctr">
-              <a:defRPr sz="900">
+              <a:defRPr sz="850">
                 <a:solidFill>
                   <a:srgbClr val="6C8279"/>
                 </a:solidFill>
@@ -6471,7 +7708,7 @@
           </a:p>
           <a:p>
             <a:pPr>
-              <a:defRPr sz="1200" b="1">
+              <a:defRPr sz="1150" b="1">
                 <a:solidFill>
                   <a:srgbClr val="F5F3EF"/>
                 </a:solidFill>
@@ -6486,14 +7723,14 @@
       </p:sp>
       <p:sp>
         <p:nvSpPr>
-          <p:cNvPr id="22" name="Rectangle 21"/>
+          <p:cNvPr id="27" name="Rectangle 26"/>
           <p:cNvSpPr/>
           <p:nvPr/>
         </p:nvSpPr>
         <p:spPr>
           <a:xfrm>
-            <a:off x="9738360" y="2148840"/>
-            <a:ext cx="1691640" cy="36576"/>
+            <a:off x="9829800" y="2148840"/>
+            <a:ext cx="1600200" cy="36576"/>
           </a:xfrm>
           <a:prstGeom prst="rect">
             <a:avLst/>
@@ -6529,14 +7766,14 @@
       </p:sp>
       <p:sp>
         <p:nvSpPr>
-          <p:cNvPr id="23" name="Rectangle 22"/>
+          <p:cNvPr id="28" name="Rectangle 27"/>
           <p:cNvSpPr/>
           <p:nvPr/>
         </p:nvSpPr>
         <p:spPr>
           <a:xfrm>
-            <a:off x="9848088" y="3017520"/>
-            <a:ext cx="1472184" cy="274320"/>
+            <a:off x="9921240" y="2953512"/>
+            <a:ext cx="1417320" cy="256032"/>
           </a:xfrm>
           <a:prstGeom prst="rect">
             <a:avLst/>
@@ -6567,7 +7804,7 @@
           <a:lstStyle/>
           <a:p>
             <a:pPr algn="ctr">
-              <a:defRPr sz="900" b="1">
+              <a:defRPr sz="850" b="1">
                 <a:solidFill>
                   <a:srgbClr val="F5F3EF"/>
                 </a:solidFill>
@@ -6582,14 +7819,69 @@
       </p:sp>
       <p:sp>
         <p:nvSpPr>
-          <p:cNvPr id="24" name="Rectangle 23"/>
+          <p:cNvPr id="29" name="Rectangle 28"/>
           <p:cNvSpPr/>
           <p:nvPr/>
         </p:nvSpPr>
         <p:spPr>
           <a:xfrm>
-            <a:off x="731520" y="3657600"/>
-            <a:ext cx="2560320" cy="1188720"/>
+            <a:off x="731520" y="3474720"/>
+            <a:ext cx="10728655" cy="365760"/>
+          </a:xfrm>
+          <a:prstGeom prst="rect">
+            <a:avLst/>
+          </a:prstGeom>
+          <a:solidFill>
+            <a:srgbClr val="14221D"/>
+          </a:solidFill>
+          <a:ln>
+            <a:solidFill>
+              <a:srgbClr val="223830"/>
+            </a:solidFill>
+          </a:ln>
+        </p:spPr>
+        <p:style>
+          <a:lnRef idx="1">
+            <a:schemeClr val="accent1"/>
+          </a:lnRef>
+          <a:fillRef idx="3">
+            <a:schemeClr val="accent1"/>
+          </a:fillRef>
+          <a:effectRef idx="2">
+            <a:schemeClr val="accent1"/>
+          </a:effectRef>
+          <a:fontRef idx="minor">
+            <a:schemeClr val="lt1"/>
+          </a:fontRef>
+        </p:style>
+        <p:txBody>
+          <a:bodyPr rtlCol="0" anchor="ctr"/>
+          <a:lstStyle/>
+          <a:p>
+            <a:pPr algn="ctr">
+              <a:defRPr sz="950">
+                <a:solidFill>
+                  <a:srgbClr val="A3B8B0"/>
+                </a:solidFill>
+                <a:latin typeface="IBM Plex Mono"/>
+              </a:defRPr>
+            </a:pPr>
+            <a:r>
+              <a:t>SECONDARY PS-04 ROUTE:  Customer: “Where is my order?” → Mock Store API → Courier Scan → Instant Delivery Timestamp (Zero-Vision Fast Path)</a:t>
+            </a:r>
+          </a:p>
+        </p:txBody>
+      </p:sp>
+      <p:sp>
+        <p:nvSpPr>
+          <p:cNvPr id="30" name="Rectangle 29"/>
+          <p:cNvSpPr/>
+          <p:nvPr/>
+        </p:nvSpPr>
+        <p:spPr>
+          <a:xfrm>
+            <a:off x="731520" y="3977639"/>
+            <a:ext cx="2560320" cy="1051560"/>
           </a:xfrm>
           <a:prstGeom prst="rect">
             <a:avLst/>
@@ -6622,7 +7914,7 @@
           <a:lstStyle/>
           <a:p>
             <a:pPr algn="ctr">
-              <a:defRPr sz="950" b="1">
+              <a:defRPr sz="900" b="1">
                 <a:solidFill>
                   <a:srgbClr val="F87171"/>
                 </a:solidFill>
@@ -6635,7 +7927,7 @@
           </a:p>
           <a:p>
             <a:pPr>
-              <a:defRPr sz="950">
+              <a:defRPr sz="900">
                 <a:solidFill>
                   <a:srgbClr val="A3B8B0"/>
                 </a:solidFill>
@@ -6643,21 +7935,21 @@
               </a:defRPr>
             </a:pPr>
             <a:r>
-              <a:t>Discrepancy flagged (e.g. Case B). Inhibits automated label and refund draft.</a:t>
-            </a:r>
-          </a:p>
-        </p:txBody>
-      </p:sp>
-      <p:sp>
-        <p:nvSpPr>
-          <p:cNvPr id="25" name="Rectangle 24"/>
+              <a:t>Discrepancy flagged (e.g. Case B). Inhibits automated label/refund. Seller reviews 3 options.</a:t>
+            </a:r>
+          </a:p>
+        </p:txBody>
+      </p:sp>
+      <p:sp>
+        <p:nvSpPr>
+          <p:cNvPr id="31" name="Rectangle 30"/>
           <p:cNvSpPr/>
           <p:nvPr/>
         </p:nvSpPr>
         <p:spPr>
           <a:xfrm>
-            <a:off x="3447288" y="3657600"/>
-            <a:ext cx="2560320" cy="1188720"/>
+            <a:off x="3447288" y="3977639"/>
+            <a:ext cx="2560320" cy="1051560"/>
           </a:xfrm>
           <a:prstGeom prst="rect">
             <a:avLst/>
@@ -6690,7 +7982,7 @@
           <a:lstStyle/>
           <a:p>
             <a:pPr algn="ctr">
-              <a:defRPr sz="950" b="1">
+              <a:defRPr sz="900" b="1">
                 <a:solidFill>
                   <a:srgbClr val="FBBF24"/>
                 </a:solidFill>
@@ -6703,7 +7995,7 @@
           </a:p>
           <a:p>
             <a:pPr>
-              <a:defRPr sz="950">
+              <a:defRPr sz="900">
                 <a:solidFill>
                   <a:srgbClr val="A3B8B0"/>
                 </a:solidFill>
@@ -6711,21 +8003,21 @@
               </a:defRPr>
             </a:pPr>
             <a:r>
-              <a:t>Mandatory rule violation (e.g. expired window). Seller reviews; never auto-deny.</a:t>
-            </a:r>
-          </a:p>
-        </p:txBody>
-      </p:sp>
-      <p:sp>
-        <p:nvSpPr>
-          <p:cNvPr id="26" name="Rectangle 25"/>
+              <a:t>Mandatory rule violation (e.g. expired return window). Seller makes final decision; never auto-deny.</a:t>
+            </a:r>
+          </a:p>
+        </p:txBody>
+      </p:sp>
+      <p:sp>
+        <p:nvSpPr>
+          <p:cNvPr id="32" name="Rectangle 31"/>
           <p:cNvSpPr/>
           <p:nvPr/>
         </p:nvSpPr>
         <p:spPr>
           <a:xfrm>
-            <a:off x="6163056" y="3657600"/>
-            <a:ext cx="2560320" cy="1188720"/>
+            <a:off x="6163056" y="3977639"/>
+            <a:ext cx="2560320" cy="1051560"/>
           </a:xfrm>
           <a:prstGeom prst="rect">
             <a:avLst/>
@@ -6758,7 +8050,7 @@
           <a:lstStyle/>
           <a:p>
             <a:pPr algn="ctr">
-              <a:defRPr sz="950" b="1">
+              <a:defRPr sz="900" b="1">
                 <a:solidFill>
                   <a:srgbClr val="60A5FA"/>
                 </a:solidFill>
@@ -6771,7 +8063,7 @@
           </a:p>
           <a:p>
             <a:pPr>
-              <a:defRPr sz="950">
+              <a:defRPr sz="900">
                 <a:solidFill>
                   <a:srgbClr val="A3B8B0"/>
                 </a:solidFill>
@@ -6779,21 +8071,21 @@
               </a:defRPr>
             </a:pPr>
             <a:r>
-              <a:t>Low brightness or blur (e.g. Case C). Prompts exact re-film checklist (1 retry limit).</a:t>
-            </a:r>
-          </a:p>
-        </p:txBody>
-      </p:sp>
-      <p:sp>
-        <p:nvSpPr>
-          <p:cNvPr id="27" name="Rectangle 26"/>
+              <a:t>Low brightness or blurry barcode (e.g. Case C). Prompts exact re-film checklist (1 retry limit).</a:t>
+            </a:r>
+          </a:p>
+        </p:txBody>
+      </p:sp>
+      <p:sp>
+        <p:nvSpPr>
+          <p:cNvPr id="33" name="Rectangle 32"/>
           <p:cNvSpPr/>
           <p:nvPr/>
         </p:nvSpPr>
         <p:spPr>
           <a:xfrm>
-            <a:off x="8878824" y="3657600"/>
-            <a:ext cx="2560320" cy="1188720"/>
+            <a:off x="8878824" y="3977639"/>
+            <a:ext cx="2560320" cy="1051560"/>
           </a:xfrm>
           <a:prstGeom prst="rect">
             <a:avLst/>
@@ -6826,7 +8118,7 @@
           <a:lstStyle/>
           <a:p>
             <a:pPr algn="ctr">
-              <a:defRPr sz="950" b="1">
+              <a:defRPr sz="900" b="1">
                 <a:solidFill>
                   <a:srgbClr val="34D399"/>
                 </a:solidFill>
@@ -6839,7 +8131,7 @@
           </a:p>
           <a:p>
             <a:pPr>
-              <a:defRPr sz="950">
+              <a:defRPr sz="900">
                 <a:solidFill>
                   <a:srgbClr val="A3B8B0"/>
                 </a:solidFill>
@@ -6854,14 +8146,14 @@
       </p:sp>
       <p:sp>
         <p:nvSpPr>
-          <p:cNvPr id="28" name="Rectangle 27"/>
+          <p:cNvPr id="34" name="Rectangle 33"/>
           <p:cNvSpPr/>
           <p:nvPr/>
         </p:nvSpPr>
         <p:spPr>
           <a:xfrm>
-            <a:off x="731520" y="5029200"/>
-            <a:ext cx="10728655" cy="822960"/>
+            <a:off x="731520" y="5166360"/>
+            <a:ext cx="10728655" cy="868680"/>
           </a:xfrm>
           <a:prstGeom prst="rect">
             <a:avLst/>
@@ -6894,7 +8186,7 @@
           <a:lstStyle/>
           <a:p>
             <a:pPr algn="ctr">
-              <a:defRPr sz="950">
+              <a:defRPr sz="900">
                 <a:solidFill>
                   <a:srgbClr val="A3B8B0"/>
                 </a:solidFill>
@@ -6902,12 +8194,12 @@
               </a:defRPr>
             </a:pPr>
             <a:r>
-              <a:t>■ Model Calls: Exactly 3 base calls per case (planner, vision, critic) plus retries  |  ■ Policy Clauses: Deterministic Python rules P-01 to P-08, never prompts</a:t>
+              <a:t>■ Model Calls: Exactly 3 base calls per case (planner, vision, critic) plus retries  |  ■ Policy Clauses: Deterministic Python code rules P-01 to P-08, never prompts</a:t>
             </a:r>
           </a:p>
           <a:p>
             <a:pPr>
-              <a:defRPr sz="950">
+              <a:defRPr sz="900">
                 <a:solidFill>
                   <a:srgbClr val="A3B8B0"/>
                 </a:solidFill>
@@ -6915,14 +8207,14 @@
               </a:defRPr>
             </a:pPr>
             <a:r>
-              <a:t>■ Critic: The critic reviews cited frames and flags unsupported observations  |  ■ Safety: Prompt injection cannot alter policy code or bypass human gate</a:t>
-            </a:r>
-          </a:p>
-        </p:txBody>
-      </p:sp>
-      <p:sp>
-        <p:nvSpPr>
-          <p:cNvPr id="29" name="Rectangle 28"/>
+              <a:t>■ Critic Duty: The critic reviews cited frames and flags unsupported observations  |  ■ Safety: Prompt injection cannot alter policy code or bypass human gate</a:t>
+            </a:r>
+          </a:p>
+        </p:txBody>
+      </p:sp>
+      <p:sp>
+        <p:nvSpPr>
+          <p:cNvPr id="35" name="Rectangle 34"/>
           <p:cNvSpPr/>
           <p:nvPr/>
         </p:nvSpPr>
@@ -6965,7 +8257,7 @@
       </p:sp>
       <p:sp>
         <p:nvSpPr>
-          <p:cNvPr id="30" name="TextBox 29"/>
+          <p:cNvPr id="36" name="TextBox 35"/>
           <p:cNvSpPr txBox="1"/>
           <p:nvPr/>
         </p:nvSpPr>
@@ -7001,7 +8293,7 @@
       </p:sp>
       <p:sp>
         <p:nvSpPr>
-          <p:cNvPr id="31" name="TextBox 30"/>
+          <p:cNvPr id="37" name="TextBox 36"/>
           <p:cNvSpPr txBox="1"/>
           <p:nvPr/>
         </p:nvSpPr>
@@ -7333,7 +8625,7 @@
               </a:defRPr>
             </a:pPr>
             <a:r>
-              <a:t>ORD-1042 (₹1,499) · SKU matches manifest, tag present, visible defect within 7-day window.</a:t>
+              <a:t>ORD-1042 (₹1,499) · SKU matches manifest, tag visible, defect confirmed within 7-day window.</a:t>
             </a:r>
           </a:p>
         </p:txBody>
@@ -7503,7 +8795,7 @@
               </a:defRPr>
             </a:pPr>
             <a:r>
-              <a:t>CASE B · ESCALATE</a:t>
+              <a:t>CASE B · MISMATCH</a:t>
             </a:r>
           </a:p>
         </p:txBody>
@@ -7539,7 +8831,7 @@
               </a:defRPr>
             </a:pPr>
             <a:r>
-              <a:t>HEAD-WHT-02 vs HEAD-BLK-09 at Frame 00:07 · Policy P-03 SKU mismatch FAIL.</a:t>
+              <a:t>HEAD-WHT-02 (White) ordered vs Frame 00:07 showing Black item · SKU unverified.</a:t>
             </a:r>
           </a:p>
         </p:txBody>
@@ -7709,7 +9001,7 @@
               </a:defRPr>
             </a:pPr>
             <a:r>
-              <a:t>CASE C · ASK MORE</a:t>
+              <a:t>CASE C · UNCLEAR</a:t>
             </a:r>
           </a:p>
         </p:txBody>
@@ -7915,7 +9207,7 @@
               </a:defRPr>
             </a:pPr>
             <a:r>
-              <a:t>CASE D · CONTINUITY</a:t>
+              <a:t>CASE D · CONTEXT</a:t>
             </a:r>
           </a:p>
         </p:txBody>
@@ -7951,7 +9243,7 @@
               </a:defRPr>
             </a:pPr>
             <a:r>
-              <a:t>Unbroken take: opening sealed parcel to showing the label in one continuous sequence.</a:t>
+              <a:t>Parcel-to-product take: opening sealed parcel to product reveal in one continuous take.</a:t>
             </a:r>
           </a:p>
         </p:txBody>
@@ -8023,7 +9315,7 @@
               </a:defRPr>
             </a:pPr>
             <a:r>
-              <a:t>Continuity verified: prevents photo-swap fraud before mock return label generation. Proves why video beats photos.</a:t>
+              <a:t>Expected behavior: inspect sequence continuity and flag missing transitions for seller review.</a:t>
             </a:r>
           </a:p>
         </p:txBody>
@@ -8102,7 +9394,7 @@
               </a:defRPr>
             </a:pPr>
             <a:r>
-              <a:t>Staged sample videos, mock store data, no real customer PII · Cap: min(₹4,999, remaining refundable amount, order paid amount)</a:t>
+              <a:t>Staged benchmark scenarios · Expected prototype behaviors, not measured production metrics · Cap: min(₹4,999, remaining refundable amount, order paid amount)</a:t>
             </a:r>
           </a:p>
         </p:txBody>
@@ -8320,237 +9612,8 @@
         </p:nvSpPr>
         <p:spPr>
           <a:xfrm>
-            <a:off x="731520" y="2834640"/>
-            <a:ext cx="10728655" cy="36576"/>
-          </a:xfrm>
-          <a:prstGeom prst="rect">
-            <a:avLst/>
-          </a:prstGeom>
-          <a:solidFill>
-            <a:srgbClr val="006B55"/>
-          </a:solidFill>
-          <a:ln>
-            <a:noFill/>
-          </a:ln>
-        </p:spPr>
-        <p:style>
-          <a:lnRef idx="1">
-            <a:schemeClr val="accent1"/>
-          </a:lnRef>
-          <a:fillRef idx="3">
-            <a:schemeClr val="accent1"/>
-          </a:fillRef>
-          <a:effectRef idx="2">
-            <a:schemeClr val="accent1"/>
-          </a:effectRef>
-          <a:fontRef idx="minor">
-            <a:schemeClr val="lt1"/>
-          </a:fontRef>
-        </p:style>
-        <p:txBody>
-          <a:bodyPr rtlCol="0" anchor="ctr"/>
-          <a:lstStyle/>
-          <a:p>
-            <a:pPr algn="ctr"/>
-          </a:p>
-        </p:txBody>
-      </p:sp>
-      <p:sp>
-        <p:nvSpPr>
-          <p:cNvPr id="7" name="TextBox 6"/>
-          <p:cNvSpPr txBox="1"/>
-          <p:nvPr/>
-        </p:nvSpPr>
-        <p:spPr>
-          <a:xfrm>
-            <a:off x="731520" y="2057400"/>
-            <a:ext cx="3474720" cy="731520"/>
-          </a:xfrm>
-          <a:prstGeom prst="rect">
-            <a:avLst/>
-          </a:prstGeom>
-          <a:noFill/>
-        </p:spPr>
-        <p:txBody>
-          <a:bodyPr wrap="square">
-            <a:spAutoFit/>
-          </a:bodyPr>
-          <a:lstStyle/>
-          <a:p>
-            <a:pPr>
-              <a:defRPr sz="1200" b="1">
-                <a:solidFill>
-                  <a:srgbClr val="006B55"/>
-                </a:solidFill>
-                <a:latin typeface="IBM Plex Mono"/>
-              </a:defRPr>
-            </a:pPr>
-            <a:r>
-              <a:t>PERSON A</a:t>
-            </a:r>
-          </a:p>
-          <a:p>
-            <a:pPr>
-              <a:defRPr sz="1300" b="1">
-                <a:solidFill>
-                  <a:srgbClr val="172621"/>
-                </a:solidFill>
-                <a:latin typeface="Inter"/>
-              </a:defRPr>
-            </a:pPr>
-            <a:r>
-              <a:t>Backend &amp; Agent Core</a:t>
-            </a:r>
-          </a:p>
-          <a:p>
-            <a:pPr>
-              <a:defRPr sz="1050">
-                <a:solidFill>
-                  <a:srgbClr val="596E64"/>
-                </a:solidFill>
-                <a:latin typeface="Inter"/>
-              </a:defRPr>
-            </a:pPr>
-            <a:r>
-              <a:t>Backend, agent graph, policy, critic, audit log.</a:t>
-            </a:r>
-          </a:p>
-        </p:txBody>
-      </p:sp>
-      <p:sp>
-        <p:nvSpPr>
-          <p:cNvPr id="8" name="TextBox 7"/>
-          <p:cNvSpPr txBox="1"/>
-          <p:nvPr/>
-        </p:nvSpPr>
-        <p:spPr>
-          <a:xfrm>
-            <a:off x="4352544" y="2057400"/>
-            <a:ext cx="3474720" cy="731520"/>
-          </a:xfrm>
-          <a:prstGeom prst="rect">
-            <a:avLst/>
-          </a:prstGeom>
-          <a:noFill/>
-        </p:spPr>
-        <p:txBody>
-          <a:bodyPr wrap="square">
-            <a:spAutoFit/>
-          </a:bodyPr>
-          <a:lstStyle/>
-          <a:p>
-            <a:pPr>
-              <a:defRPr sz="1200" b="1">
-                <a:solidFill>
-                  <a:srgbClr val="006B55"/>
-                </a:solidFill>
-                <a:latin typeface="IBM Plex Mono"/>
-              </a:defRPr>
-            </a:pPr>
-            <a:r>
-              <a:t>PERSON B</a:t>
-            </a:r>
-          </a:p>
-          <a:p>
-            <a:pPr>
-              <a:defRPr sz="1300" b="1">
-                <a:solidFill>
-                  <a:srgbClr val="172621"/>
-                </a:solidFill>
-                <a:latin typeface="Inter"/>
-              </a:defRPr>
-            </a:pPr>
-            <a:r>
-              <a:t>Video Pipeline &amp; UI</a:t>
-            </a:r>
-          </a:p>
-          <a:p>
-            <a:pPr>
-              <a:defRPr sz="1050">
-                <a:solidFill>
-                  <a:srgbClr val="596E64"/>
-                </a:solidFill>
-                <a:latin typeface="Inter"/>
-              </a:defRPr>
-            </a:pPr>
-            <a:r>
-              <a:t>Video pipeline, video indexer, seller console, evidence pack view.</a:t>
-            </a:r>
-          </a:p>
-        </p:txBody>
-      </p:sp>
-      <p:sp>
-        <p:nvSpPr>
-          <p:cNvPr id="9" name="TextBox 8"/>
-          <p:cNvSpPr txBox="1"/>
-          <p:nvPr/>
-        </p:nvSpPr>
-        <p:spPr>
-          <a:xfrm>
-            <a:off x="7973568" y="2057400"/>
-            <a:ext cx="3474720" cy="731520"/>
-          </a:xfrm>
-          <a:prstGeom prst="rect">
-            <a:avLst/>
-          </a:prstGeom>
-          <a:noFill/>
-        </p:spPr>
-        <p:txBody>
-          <a:bodyPr wrap="square">
-            <a:spAutoFit/>
-          </a:bodyPr>
-          <a:lstStyle/>
-          <a:p>
-            <a:pPr>
-              <a:defRPr sz="1200" b="1">
-                <a:solidFill>
-                  <a:srgbClr val="006B55"/>
-                </a:solidFill>
-                <a:latin typeface="IBM Plex Mono"/>
-              </a:defRPr>
-            </a:pPr>
-            <a:r>
-              <a:t>PERSON C</a:t>
-            </a:r>
-          </a:p>
-          <a:p>
-            <a:pPr>
-              <a:defRPr sz="1300" b="1">
-                <a:solidFill>
-                  <a:srgbClr val="172621"/>
-                </a:solidFill>
-                <a:latin typeface="Inter"/>
-              </a:defRPr>
-            </a:pPr>
-            <a:r>
-              <a:t>Integration &amp; Verification</a:t>
-            </a:r>
-          </a:p>
-          <a:p>
-            <a:pPr>
-              <a:defRPr sz="1050">
-                <a:solidFill>
-                  <a:srgbClr val="596E64"/>
-                </a:solidFill>
-                <a:latin typeface="Inter"/>
-              </a:defRPr>
-            </a:pPr>
-            <a:r>
-              <a:t>Integration, mock data, 4 demo cases, fallback testing, demo video, README.</a:t>
-            </a:r>
-          </a:p>
-        </p:txBody>
-      </p:sp>
-      <p:sp>
-        <p:nvSpPr>
-          <p:cNvPr id="10" name="Rectangle 9"/>
-          <p:cNvSpPr/>
-          <p:nvPr/>
-        </p:nvSpPr>
-        <p:spPr>
-          <a:xfrm>
-            <a:off x="731520" y="3154680"/>
-            <a:ext cx="5212080" cy="2011680"/>
+            <a:off x="731520" y="2148840"/>
+            <a:ext cx="2560320" cy="1188720"/>
           </a:xfrm>
           <a:prstGeom prst="rect">
             <a:avLst/>
@@ -8579,23 +9642,63 @@
           </a:fontRef>
         </p:style>
         <p:txBody>
-          <a:bodyPr rtlCol="0" anchor="ctr"/>
-          <a:lstStyle/>
-          <a:p>
-            <a:pPr algn="ctr"/>
-          </a:p>
-        </p:txBody>
-      </p:sp>
-      <p:sp>
-        <p:nvSpPr>
-          <p:cNvPr id="11" name="Rectangle 10"/>
+          <a:bodyPr rtlCol="0" anchor="ctr" wrap="square"/>
+          <a:lstStyle/>
+          <a:p>
+            <a:pPr algn="ctr">
+              <a:defRPr sz="1100" b="1">
+                <a:solidFill>
+                  <a:srgbClr val="006B55"/>
+                </a:solidFill>
+                <a:latin typeface="IBM Plex Mono"/>
+              </a:defRPr>
+            </a:pPr>
+            <a:r>
+              <a:t>00h – 06h</a:t>
+            </a:r>
+          </a:p>
+          <a:p>
+            <a:pPr>
+              <a:defRPr sz="1200" b="1">
+                <a:solidFill>
+                  <a:srgbClr val="172621"/>
+                </a:solidFill>
+                <a:latin typeface="Inter"/>
+              </a:defRPr>
+            </a:pPr>
+            <a:r>
+              <a:t>Mock APIs &amp; Agent Core</a:t>
+            </a:r>
+          </a:p>
+          <a:p>
+            <a:pPr>
+              <a:defRPr sz="950">
+                <a:solidFill>
+                  <a:srgbClr val="596E64"/>
+                </a:solidFill>
+                <a:latin typeface="Inter"/>
+              </a:defRPr>
+            </a:pPr>
+            <a:r>
+              <a:t>Person A (Backend)</a:t>
+            </a:r>
+            <a:br/>
+            <a:r>
+              <a:t>LangGraph skeleton, mock store/courier fixtures, order status route</a:t>
+            </a:r>
+          </a:p>
+        </p:txBody>
+      </p:sp>
+      <p:sp>
+        <p:nvSpPr>
+          <p:cNvPr id="7" name="Rectangle 6"/>
           <p:cNvSpPr/>
           <p:nvPr/>
         </p:nvSpPr>
         <p:spPr>
           <a:xfrm>
-            <a:off x="731520" y="3154680"/>
-            <a:ext cx="73152" cy="2011680"/>
+            <a:off x="731520" y="2148840"/>
+            <a:ext cx="2560320" cy="36576"/>
           </a:xfrm>
           <a:prstGeom prst="rect">
             <a:avLst/>
@@ -8631,79 +9734,14 @@
       </p:sp>
       <p:sp>
         <p:nvSpPr>
-          <p:cNvPr id="12" name="TextBox 11"/>
-          <p:cNvSpPr txBox="1"/>
-          <p:nvPr/>
-        </p:nvSpPr>
-        <p:spPr>
-          <a:xfrm>
-            <a:off x="960120" y="3246120"/>
-            <a:ext cx="4892040" cy="1828800"/>
-          </a:xfrm>
-          <a:prstGeom prst="rect">
-            <a:avLst/>
-          </a:prstGeom>
-          <a:noFill/>
-        </p:spPr>
-        <p:txBody>
-          <a:bodyPr wrap="square">
-            <a:spAutoFit/>
-          </a:bodyPr>
-          <a:lstStyle/>
-          <a:p>
-            <a:pPr>
-              <a:defRPr sz="1100" b="1">
-                <a:solidFill>
-                  <a:srgbClr val="006B55"/>
-                </a:solidFill>
-                <a:latin typeface="IBM Plex Mono"/>
-              </a:defRPr>
-            </a:pPr>
-            <a:r>
-              <a:t>NEVER CUT (CORE ENGINE)</a:t>
-            </a:r>
-          </a:p>
-          <a:p>
-            <a:pPr>
-              <a:defRPr sz="1100">
-                <a:solidFill>
-                  <a:srgbClr val="172621"/>
-                </a:solidFill>
-                <a:latin typeface="Inter"/>
-              </a:defRPr>
-            </a:pPr>
-            <a:r>
-              <a:t>• Deterministic policy engine (P-01 to P-08)</a:t>
-            </a:r>
-            <a:br/>
-            <a:r>
-              <a:t>• Evidence-pack frame citation</a:t>
-            </a:r>
-            <a:br/>
-            <a:r>
-              <a:t>• Fail-closed seller approval gate</a:t>
-            </a:r>
-            <a:br/>
-            <a:r>
-              <a:t>• Structured JSON audit log</a:t>
-            </a:r>
-            <a:br/>
-            <a:r>
-              <a:t>• 4 reproducible demo cases</a:t>
-            </a:r>
-          </a:p>
-        </p:txBody>
-      </p:sp>
-      <p:sp>
-        <p:nvSpPr>
-          <p:cNvPr id="13" name="Rectangle 12"/>
+          <p:cNvPr id="8" name="Rectangle 7"/>
           <p:cNvSpPr/>
           <p:nvPr/>
         </p:nvSpPr>
         <p:spPr>
           <a:xfrm>
-            <a:off x="6248095" y="3154680"/>
-            <a:ext cx="5212080" cy="2011680"/>
+            <a:off x="3447288" y="2148840"/>
+            <a:ext cx="2560320" cy="1188720"/>
           </a:xfrm>
           <a:prstGeom prst="rect">
             <a:avLst/>
@@ -8732,6 +9770,345 @@
           </a:fontRef>
         </p:style>
         <p:txBody>
+          <a:bodyPr rtlCol="0" anchor="ctr" wrap="square"/>
+          <a:lstStyle/>
+          <a:p>
+            <a:pPr algn="ctr">
+              <a:defRPr sz="1100" b="1">
+                <a:solidFill>
+                  <a:srgbClr val="006B55"/>
+                </a:solidFill>
+                <a:latin typeface="IBM Plex Mono"/>
+              </a:defRPr>
+            </a:pPr>
+            <a:r>
+              <a:t>06h – 12h</a:t>
+            </a:r>
+          </a:p>
+          <a:p>
+            <a:pPr>
+              <a:defRPr sz="1200" b="1">
+                <a:solidFill>
+                  <a:srgbClr val="172621"/>
+                </a:solidFill>
+                <a:latin typeface="Inter"/>
+              </a:defRPr>
+            </a:pPr>
+            <a:r>
+              <a:t>Evidence Pipeline &amp; Policy</a:t>
+            </a:r>
+          </a:p>
+          <a:p>
+            <a:pPr>
+              <a:defRPr sz="950">
+                <a:solidFill>
+                  <a:srgbClr val="596E64"/>
+                </a:solidFill>
+                <a:latin typeface="Inter"/>
+              </a:defRPr>
+            </a:pPr>
+            <a:r>
+              <a:t>Person B (Video &amp; UI)</a:t>
+            </a:r>
+            <a:br/>
+            <a:r>
+              <a:t>FFmpeg keyframe indexer, Python rules P-01 to P-08, critic prompt</a:t>
+            </a:r>
+          </a:p>
+        </p:txBody>
+      </p:sp>
+      <p:sp>
+        <p:nvSpPr>
+          <p:cNvPr id="9" name="Rectangle 8"/>
+          <p:cNvSpPr/>
+          <p:nvPr/>
+        </p:nvSpPr>
+        <p:spPr>
+          <a:xfrm>
+            <a:off x="3447288" y="2148840"/>
+            <a:ext cx="2560320" cy="36576"/>
+          </a:xfrm>
+          <a:prstGeom prst="rect">
+            <a:avLst/>
+          </a:prstGeom>
+          <a:solidFill>
+            <a:srgbClr val="006B55"/>
+          </a:solidFill>
+          <a:ln>
+            <a:noFill/>
+          </a:ln>
+        </p:spPr>
+        <p:style>
+          <a:lnRef idx="1">
+            <a:schemeClr val="accent1"/>
+          </a:lnRef>
+          <a:fillRef idx="3">
+            <a:schemeClr val="accent1"/>
+          </a:fillRef>
+          <a:effectRef idx="2">
+            <a:schemeClr val="accent1"/>
+          </a:effectRef>
+          <a:fontRef idx="minor">
+            <a:schemeClr val="lt1"/>
+          </a:fontRef>
+        </p:style>
+        <p:txBody>
+          <a:bodyPr rtlCol="0" anchor="ctr"/>
+          <a:lstStyle/>
+          <a:p>
+            <a:pPr algn="ctr"/>
+          </a:p>
+        </p:txBody>
+      </p:sp>
+      <p:sp>
+        <p:nvSpPr>
+          <p:cNvPr id="10" name="Rectangle 9"/>
+          <p:cNvSpPr/>
+          <p:nvPr/>
+        </p:nvSpPr>
+        <p:spPr>
+          <a:xfrm>
+            <a:off x="6163056" y="2148840"/>
+            <a:ext cx="2560320" cy="1188720"/>
+          </a:xfrm>
+          <a:prstGeom prst="rect">
+            <a:avLst/>
+          </a:prstGeom>
+          <a:solidFill>
+            <a:srgbClr val="FFFFFF"/>
+          </a:solidFill>
+          <a:ln w="12700">
+            <a:solidFill>
+              <a:srgbClr val="E2DED4"/>
+            </a:solidFill>
+          </a:ln>
+        </p:spPr>
+        <p:style>
+          <a:lnRef idx="1">
+            <a:schemeClr val="accent1"/>
+          </a:lnRef>
+          <a:fillRef idx="3">
+            <a:schemeClr val="accent1"/>
+          </a:fillRef>
+          <a:effectRef idx="2">
+            <a:schemeClr val="accent1"/>
+          </a:effectRef>
+          <a:fontRef idx="minor">
+            <a:schemeClr val="lt1"/>
+          </a:fontRef>
+        </p:style>
+        <p:txBody>
+          <a:bodyPr rtlCol="0" anchor="ctr" wrap="square"/>
+          <a:lstStyle/>
+          <a:p>
+            <a:pPr algn="ctr">
+              <a:defRPr sz="1100" b="1">
+                <a:solidFill>
+                  <a:srgbClr val="006B55"/>
+                </a:solidFill>
+                <a:latin typeface="IBM Plex Mono"/>
+              </a:defRPr>
+            </a:pPr>
+            <a:r>
+              <a:t>12h – 18h</a:t>
+            </a:r>
+          </a:p>
+          <a:p>
+            <a:pPr>
+              <a:defRPr sz="1200" b="1">
+                <a:solidFill>
+                  <a:srgbClr val="172621"/>
+                </a:solidFill>
+                <a:latin typeface="Inter"/>
+              </a:defRPr>
+            </a:pPr>
+            <a:r>
+              <a:t>Integration &amp; 4 Scenarios</a:t>
+            </a:r>
+          </a:p>
+          <a:p>
+            <a:pPr>
+              <a:defRPr sz="950">
+                <a:solidFill>
+                  <a:srgbClr val="596E64"/>
+                </a:solidFill>
+                <a:latin typeface="Inter"/>
+              </a:defRPr>
+            </a:pPr>
+            <a:r>
+              <a:t>Person C (Integration)</a:t>
+            </a:r>
+            <a:br/>
+            <a:r>
+              <a:t>End-to-end wiring, 4 staged demo cases (A–D), seller console UI</a:t>
+            </a:r>
+          </a:p>
+        </p:txBody>
+      </p:sp>
+      <p:sp>
+        <p:nvSpPr>
+          <p:cNvPr id="11" name="Rectangle 10"/>
+          <p:cNvSpPr/>
+          <p:nvPr/>
+        </p:nvSpPr>
+        <p:spPr>
+          <a:xfrm>
+            <a:off x="6163056" y="2148840"/>
+            <a:ext cx="2560320" cy="36576"/>
+          </a:xfrm>
+          <a:prstGeom prst="rect">
+            <a:avLst/>
+          </a:prstGeom>
+          <a:solidFill>
+            <a:srgbClr val="006B55"/>
+          </a:solidFill>
+          <a:ln>
+            <a:noFill/>
+          </a:ln>
+        </p:spPr>
+        <p:style>
+          <a:lnRef idx="1">
+            <a:schemeClr val="accent1"/>
+          </a:lnRef>
+          <a:fillRef idx="3">
+            <a:schemeClr val="accent1"/>
+          </a:fillRef>
+          <a:effectRef idx="2">
+            <a:schemeClr val="accent1"/>
+          </a:effectRef>
+          <a:fontRef idx="minor">
+            <a:schemeClr val="lt1"/>
+          </a:fontRef>
+        </p:style>
+        <p:txBody>
+          <a:bodyPr rtlCol="0" anchor="ctr"/>
+          <a:lstStyle/>
+          <a:p>
+            <a:pPr algn="ctr"/>
+          </a:p>
+        </p:txBody>
+      </p:sp>
+      <p:sp>
+        <p:nvSpPr>
+          <p:cNvPr id="12" name="Rectangle 11"/>
+          <p:cNvSpPr/>
+          <p:nvPr/>
+        </p:nvSpPr>
+        <p:spPr>
+          <a:xfrm>
+            <a:off x="8878824" y="2148840"/>
+            <a:ext cx="2560320" cy="1188720"/>
+          </a:xfrm>
+          <a:prstGeom prst="rect">
+            <a:avLst/>
+          </a:prstGeom>
+          <a:solidFill>
+            <a:srgbClr val="FFFFFF"/>
+          </a:solidFill>
+          <a:ln w="12700">
+            <a:solidFill>
+              <a:srgbClr val="E2DED4"/>
+            </a:solidFill>
+          </a:ln>
+        </p:spPr>
+        <p:style>
+          <a:lnRef idx="1">
+            <a:schemeClr val="accent1"/>
+          </a:lnRef>
+          <a:fillRef idx="3">
+            <a:schemeClr val="accent1"/>
+          </a:fillRef>
+          <a:effectRef idx="2">
+            <a:schemeClr val="accent1"/>
+          </a:effectRef>
+          <a:fontRef idx="minor">
+            <a:schemeClr val="lt1"/>
+          </a:fontRef>
+        </p:style>
+        <p:txBody>
+          <a:bodyPr rtlCol="0" anchor="ctr" wrap="square"/>
+          <a:lstStyle/>
+          <a:p>
+            <a:pPr algn="ctr">
+              <a:defRPr sz="1100" b="1">
+                <a:solidFill>
+                  <a:srgbClr val="006B55"/>
+                </a:solidFill>
+                <a:latin typeface="IBM Plex Mono"/>
+              </a:defRPr>
+            </a:pPr>
+            <a:r>
+              <a:t>18h – 24h</a:t>
+            </a:r>
+          </a:p>
+          <a:p>
+            <a:pPr>
+              <a:defRPr sz="1200" b="1">
+                <a:solidFill>
+                  <a:srgbClr val="172621"/>
+                </a:solidFill>
+                <a:latin typeface="Inter"/>
+              </a:defRPr>
+            </a:pPr>
+            <a:r>
+              <a:t>Testing, Polish &amp; Submission</a:t>
+            </a:r>
+          </a:p>
+          <a:p>
+            <a:pPr>
+              <a:defRPr sz="950">
+                <a:solidFill>
+                  <a:srgbClr val="596E64"/>
+                </a:solidFill>
+                <a:latin typeface="Inter"/>
+              </a:defRPr>
+            </a:pPr>
+            <a:r>
+              <a:t>All 3 Members</a:t>
+            </a:r>
+            <a:br/>
+            <a:r>
+              <a:t>Fallback testing, edge cases, video walkthrough recording, README</a:t>
+            </a:r>
+          </a:p>
+        </p:txBody>
+      </p:sp>
+      <p:sp>
+        <p:nvSpPr>
+          <p:cNvPr id="13" name="Rectangle 12"/>
+          <p:cNvSpPr/>
+          <p:nvPr/>
+        </p:nvSpPr>
+        <p:spPr>
+          <a:xfrm>
+            <a:off x="8878824" y="2148840"/>
+            <a:ext cx="2560320" cy="36576"/>
+          </a:xfrm>
+          <a:prstGeom prst="rect">
+            <a:avLst/>
+          </a:prstGeom>
+          <a:solidFill>
+            <a:srgbClr val="006B55"/>
+          </a:solidFill>
+          <a:ln>
+            <a:noFill/>
+          </a:ln>
+        </p:spPr>
+        <p:style>
+          <a:lnRef idx="1">
+            <a:schemeClr val="accent1"/>
+          </a:lnRef>
+          <a:fillRef idx="3">
+            <a:schemeClr val="accent1"/>
+          </a:fillRef>
+          <a:effectRef idx="2">
+            <a:schemeClr val="accent1"/>
+          </a:effectRef>
+          <a:fontRef idx="minor">
+            <a:schemeClr val="lt1"/>
+          </a:fontRef>
+        </p:style>
+        <p:txBody>
           <a:bodyPr rtlCol="0" anchor="ctr"/>
           <a:lstStyle/>
           <a:p>
@@ -8747,8 +10124,206 @@
         </p:nvSpPr>
         <p:spPr>
           <a:xfrm>
-            <a:off x="6248095" y="3154680"/>
-            <a:ext cx="73152" cy="2011680"/>
+            <a:off x="731520" y="3520440"/>
+            <a:ext cx="5212080" cy="1828800"/>
+          </a:xfrm>
+          <a:prstGeom prst="rect">
+            <a:avLst/>
+          </a:prstGeom>
+          <a:solidFill>
+            <a:srgbClr val="FFFFFF"/>
+          </a:solidFill>
+          <a:ln w="12700">
+            <a:solidFill>
+              <a:srgbClr val="E2DED4"/>
+            </a:solidFill>
+          </a:ln>
+        </p:spPr>
+        <p:style>
+          <a:lnRef idx="1">
+            <a:schemeClr val="accent1"/>
+          </a:lnRef>
+          <a:fillRef idx="3">
+            <a:schemeClr val="accent1"/>
+          </a:fillRef>
+          <a:effectRef idx="2">
+            <a:schemeClr val="accent1"/>
+          </a:effectRef>
+          <a:fontRef idx="minor">
+            <a:schemeClr val="lt1"/>
+          </a:fontRef>
+        </p:style>
+        <p:txBody>
+          <a:bodyPr rtlCol="0" anchor="ctr"/>
+          <a:lstStyle/>
+          <a:p>
+            <a:pPr algn="ctr"/>
+          </a:p>
+        </p:txBody>
+      </p:sp>
+      <p:sp>
+        <p:nvSpPr>
+          <p:cNvPr id="15" name="Rectangle 14"/>
+          <p:cNvSpPr/>
+          <p:nvPr/>
+        </p:nvSpPr>
+        <p:spPr>
+          <a:xfrm>
+            <a:off x="731520" y="3520440"/>
+            <a:ext cx="73152" cy="1828800"/>
+          </a:xfrm>
+          <a:prstGeom prst="rect">
+            <a:avLst/>
+          </a:prstGeom>
+          <a:solidFill>
+            <a:srgbClr val="006B55"/>
+          </a:solidFill>
+          <a:ln>
+            <a:noFill/>
+          </a:ln>
+        </p:spPr>
+        <p:style>
+          <a:lnRef idx="1">
+            <a:schemeClr val="accent1"/>
+          </a:lnRef>
+          <a:fillRef idx="3">
+            <a:schemeClr val="accent1"/>
+          </a:fillRef>
+          <a:effectRef idx="2">
+            <a:schemeClr val="accent1"/>
+          </a:effectRef>
+          <a:fontRef idx="minor">
+            <a:schemeClr val="lt1"/>
+          </a:fontRef>
+        </p:style>
+        <p:txBody>
+          <a:bodyPr rtlCol="0" anchor="ctr"/>
+          <a:lstStyle/>
+          <a:p>
+            <a:pPr algn="ctr"/>
+          </a:p>
+        </p:txBody>
+      </p:sp>
+      <p:sp>
+        <p:nvSpPr>
+          <p:cNvPr id="16" name="TextBox 15"/>
+          <p:cNvSpPr txBox="1"/>
+          <p:nvPr/>
+        </p:nvSpPr>
+        <p:spPr>
+          <a:xfrm>
+            <a:off x="960120" y="3611880"/>
+            <a:ext cx="4892040" cy="1645920"/>
+          </a:xfrm>
+          <a:prstGeom prst="rect">
+            <a:avLst/>
+          </a:prstGeom>
+          <a:noFill/>
+        </p:spPr>
+        <p:txBody>
+          <a:bodyPr wrap="square">
+            <a:spAutoFit/>
+          </a:bodyPr>
+          <a:lstStyle/>
+          <a:p>
+            <a:pPr>
+              <a:defRPr sz="1100" b="1">
+                <a:solidFill>
+                  <a:srgbClr val="006B55"/>
+                </a:solidFill>
+                <a:latin typeface="IBM Plex Mono"/>
+              </a:defRPr>
+            </a:pPr>
+            <a:r>
+              <a:t>NEVER CUT (CORE ENGINE)</a:t>
+            </a:r>
+          </a:p>
+          <a:p>
+            <a:pPr>
+              <a:defRPr sz="1050">
+                <a:solidFill>
+                  <a:srgbClr val="172621"/>
+                </a:solidFill>
+                <a:latin typeface="Inter"/>
+              </a:defRPr>
+            </a:pPr>
+            <a:r>
+              <a:t>• Deterministic policy engine (P-01 to P-08)</a:t>
+            </a:r>
+            <a:br/>
+            <a:r>
+              <a:t>• Evidence-pack frame citation</a:t>
+            </a:r>
+            <a:br/>
+            <a:r>
+              <a:t>• Fail-closed seller approval gate</a:t>
+            </a:r>
+            <a:br/>
+            <a:r>
+              <a:t>• Structured JSON audit log</a:t>
+            </a:r>
+            <a:br/>
+            <a:r>
+              <a:t>• 4 reproducible demo cases</a:t>
+            </a:r>
+          </a:p>
+        </p:txBody>
+      </p:sp>
+      <p:sp>
+        <p:nvSpPr>
+          <p:cNvPr id="17" name="Rectangle 16"/>
+          <p:cNvSpPr/>
+          <p:nvPr/>
+        </p:nvSpPr>
+        <p:spPr>
+          <a:xfrm>
+            <a:off x="6248095" y="3520440"/>
+            <a:ext cx="5212080" cy="1828800"/>
+          </a:xfrm>
+          <a:prstGeom prst="rect">
+            <a:avLst/>
+          </a:prstGeom>
+          <a:solidFill>
+            <a:srgbClr val="FFFFFF"/>
+          </a:solidFill>
+          <a:ln w="12700">
+            <a:solidFill>
+              <a:srgbClr val="E2DED4"/>
+            </a:solidFill>
+          </a:ln>
+        </p:spPr>
+        <p:style>
+          <a:lnRef idx="1">
+            <a:schemeClr val="accent1"/>
+          </a:lnRef>
+          <a:fillRef idx="3">
+            <a:schemeClr val="accent1"/>
+          </a:fillRef>
+          <a:effectRef idx="2">
+            <a:schemeClr val="accent1"/>
+          </a:effectRef>
+          <a:fontRef idx="minor">
+            <a:schemeClr val="lt1"/>
+          </a:fontRef>
+        </p:style>
+        <p:txBody>
+          <a:bodyPr rtlCol="0" anchor="ctr"/>
+          <a:lstStyle/>
+          <a:p>
+            <a:pPr algn="ctr"/>
+          </a:p>
+        </p:txBody>
+      </p:sp>
+      <p:sp>
+        <p:nvSpPr>
+          <p:cNvPr id="18" name="Rectangle 17"/>
+          <p:cNvSpPr/>
+          <p:nvPr/>
+        </p:nvSpPr>
+        <p:spPr>
+          <a:xfrm>
+            <a:off x="6248095" y="3520440"/>
+            <a:ext cx="73152" cy="1828800"/>
           </a:xfrm>
           <a:prstGeom prst="rect">
             <a:avLst/>
@@ -8784,14 +10359,14 @@
       </p:sp>
       <p:sp>
         <p:nvSpPr>
-          <p:cNvPr id="15" name="TextBox 14"/>
+          <p:cNvPr id="19" name="TextBox 18"/>
           <p:cNvSpPr txBox="1"/>
           <p:nvPr/>
         </p:nvSpPr>
         <p:spPr>
           <a:xfrm>
-            <a:off x="6476695" y="3246120"/>
-            <a:ext cx="4892040" cy="1828800"/>
+            <a:off x="6476695" y="3611880"/>
+            <a:ext cx="4892040" cy="1645920"/>
           </a:xfrm>
           <a:prstGeom prst="rect">
             <a:avLst/>
@@ -8818,7 +10393,7 @@
           </a:p>
           <a:p>
             <a:pPr>
-              <a:defRPr sz="1100">
+              <a:defRPr sz="1050">
                 <a:solidFill>
                   <a:srgbClr val="172621"/>
                 </a:solidFill>
@@ -8849,14 +10424,14 @@
       </p:sp>
       <p:sp>
         <p:nvSpPr>
-          <p:cNvPr id="16" name="Rectangle 15"/>
+          <p:cNvPr id="20" name="Rectangle 19"/>
           <p:cNvSpPr/>
           <p:nvPr/>
         </p:nvSpPr>
         <p:spPr>
           <a:xfrm>
-            <a:off x="731520" y="5303520"/>
-            <a:ext cx="10728655" cy="685800"/>
+            <a:off x="731520" y="5486400"/>
+            <a:ext cx="10728655" cy="594360"/>
           </a:xfrm>
           <a:prstGeom prst="rect">
             <a:avLst/>
@@ -8904,7 +10479,7 @@
       </p:sp>
       <p:sp>
         <p:nvSpPr>
-          <p:cNvPr id="17" name="Rectangle 16"/>
+          <p:cNvPr id="21" name="Rectangle 20"/>
           <p:cNvSpPr/>
           <p:nvPr/>
         </p:nvSpPr>
@@ -8947,7 +10522,7 @@
       </p:sp>
       <p:sp>
         <p:nvSpPr>
-          <p:cNvPr id="18" name="TextBox 17"/>
+          <p:cNvPr id="22" name="TextBox 21"/>
           <p:cNvSpPr txBox="1"/>
           <p:nvPr/>
         </p:nvSpPr>
@@ -8983,7 +10558,7 @@
       </p:sp>
       <p:sp>
         <p:nvSpPr>
-          <p:cNvPr id="19" name="TextBox 18"/>
+          <p:cNvPr id="23" name="TextBox 22"/>
           <p:cNvSpPr txBox="1"/>
           <p:nvPr/>
         </p:nvSpPr>
@@ -9343,4 +10918,324 @@
   </a:objectDefaults>
   <a:extraClrSchemeLst/>
 </a:theme>
+</file>
+
+<file path=ppt/theme/theme2.xml><?xml version="1.0" encoding="utf-8"?>
+<a:theme xmlns:a="http://schemas.openxmlformats.org/drawingml/2006/main" name="Office Theme">
+  <a:themeElements>
+    <a:clrScheme name="Office">
+      <a:dk1>
+        <a:sysClr val="windowText" lastClr="000000"/>
+      </a:dk1>
+      <a:lt1>
+        <a:sysClr val="window" lastClr="FFFFFF"/>
+      </a:lt1>
+      <a:dk2>
+        <a:srgbClr val="1F497D"/>
+      </a:dk2>
+      <a:lt2>
+        <a:srgbClr val="EEECE1"/>
+      </a:lt2>
+      <a:accent1>
+        <a:srgbClr val="4F81BD"/>
+      </a:accent1>
+      <a:accent2>
+        <a:srgbClr val="C0504D"/>
+      </a:accent2>
+      <a:accent3>
+        <a:srgbClr val="9BBB59"/>
+      </a:accent3>
+      <a:accent4>
+        <a:srgbClr val="8064A2"/>
+      </a:accent4>
+      <a:accent5>
+        <a:srgbClr val="4BACC6"/>
+      </a:accent5>
+      <a:accent6>
+        <a:srgbClr val="F79646"/>
+      </a:accent6>
+      <a:hlink>
+        <a:srgbClr val="0000FF"/>
+      </a:hlink>
+      <a:folHlink>
+        <a:srgbClr val="800080"/>
+      </a:folHlink>
+    </a:clrScheme>
+    <a:fontScheme name="Office">
+      <a:majorFont>
+        <a:latin typeface="Calibri"/>
+        <a:ea typeface=""/>
+        <a:cs typeface=""/>
+        <a:font script="Jpan" typeface="ＭＳ Ｐゴシック"/>
+        <a:font script="Hang" typeface="맑은 고딕"/>
+        <a:font script="Hans" typeface="宋体"/>
+        <a:font script="Hant" typeface="新細明體"/>
+        <a:font script="Arab" typeface="Times New Roman"/>
+        <a:font script="Hebr" typeface="Times New Roman"/>
+        <a:font script="Thai" typeface="Angsana New"/>
+        <a:font script="Ethi" typeface="Nyala"/>
+        <a:font script="Beng" typeface="Vrinda"/>
+        <a:font script="Gujr" typeface="Shruti"/>
+        <a:font script="Khmr" typeface="MoolBoran"/>
+        <a:font script="Knda" typeface="Tunga"/>
+        <a:font script="Guru" typeface="Raavi"/>
+        <a:font script="Cans" typeface="Euphemia"/>
+        <a:font script="Cher" typeface="Plantagenet Cherokee"/>
+        <a:font script="Yiii" typeface="Microsoft Yi Baiti"/>
+        <a:font script="Tibt" typeface="Microsoft Himalaya"/>
+        <a:font script="Thaa" typeface="MV Boli"/>
+        <a:font script="Deva" typeface="Mangal"/>
+        <a:font script="Telu" typeface="Gautami"/>
+        <a:font script="Taml" typeface="Latha"/>
+        <a:font script="Syrc" typeface="Estrangelo Edessa"/>
+        <a:font script="Orya" typeface="Kalinga"/>
+        <a:font script="Mlym" typeface="Kartika"/>
+        <a:font script="Laoo" typeface="DokChampa"/>
+        <a:font script="Sinh" typeface="Iskoola Pota"/>
+        <a:font script="Mong" typeface="Mongolian Baiti"/>
+        <a:font script="Viet" typeface="Times New Roman"/>
+        <a:font script="Uigh" typeface="Microsoft Uighur"/>
+        <a:font script="Geor" typeface="Sylfaen"/>
+      </a:majorFont>
+      <a:minorFont>
+        <a:latin typeface="Calibri"/>
+        <a:ea typeface=""/>
+        <a:cs typeface=""/>
+        <a:font script="Jpan" typeface="ＭＳ Ｐゴシック"/>
+        <a:font script="Hang" typeface="맑은 고딕"/>
+        <a:font script="Hans" typeface="宋体"/>
+        <a:font script="Hant" typeface="新細明體"/>
+        <a:font script="Arab" typeface="Arial"/>
+        <a:font script="Hebr" typeface="Arial"/>
+        <a:font script="Thai" typeface="Cordia New"/>
+        <a:font script="Ethi" typeface="Nyala"/>
+        <a:font script="Beng" typeface="Vrinda"/>
+        <a:font script="Gujr" typeface="Shruti"/>
+        <a:font script="Khmr" typeface="DaunPenh"/>
+        <a:font script="Knda" typeface="Tunga"/>
+        <a:font script="Guru" typeface="Raavi"/>
+        <a:font script="Cans" typeface="Euphemia"/>
+        <a:font script="Cher" typeface="Plantagenet Cherokee"/>
+        <a:font script="Yiii" typeface="Microsoft Yi Baiti"/>
+        <a:font script="Tibt" typeface="Microsoft Himalaya"/>
+        <a:font script="Thaa" typeface="MV Boli"/>
+        <a:font script="Deva" typeface="Mangal"/>
+        <a:font script="Telu" typeface="Gautami"/>
+        <a:font script="Taml" typeface="Latha"/>
+        <a:font script="Syrc" typeface="Estrangelo Edessa"/>
+        <a:font script="Orya" typeface="Kalinga"/>
+        <a:font script="Mlym" typeface="Kartika"/>
+        <a:font script="Laoo" typeface="DokChampa"/>
+        <a:font script="Sinh" typeface="Iskoola Pota"/>
+        <a:font script="Mong" typeface="Mongolian Baiti"/>
+        <a:font script="Viet" typeface="Arial"/>
+        <a:font script="Uigh" typeface="Microsoft Uighur"/>
+        <a:font script="Geor" typeface="Sylfaen"/>
+      </a:minorFont>
+    </a:fontScheme>
+    <a:fmtScheme name="Office">
+      <a:fillStyleLst>
+        <a:solidFill>
+          <a:schemeClr val="phClr"/>
+        </a:solidFill>
+        <a:gradFill rotWithShape="1">
+          <a:gsLst>
+            <a:gs pos="0">
+              <a:schemeClr val="phClr">
+                <a:tint val="50000"/>
+                <a:satMod val="300000"/>
+              </a:schemeClr>
+            </a:gs>
+            <a:gs pos="35000">
+              <a:schemeClr val="phClr">
+                <a:tint val="37000"/>
+                <a:satMod val="300000"/>
+              </a:schemeClr>
+            </a:gs>
+            <a:gs pos="100000">
+              <a:schemeClr val="phClr">
+                <a:tint val="15000"/>
+                <a:satMod val="350000"/>
+              </a:schemeClr>
+            </a:gs>
+          </a:gsLst>
+          <a:lin ang="16200000" scaled="1"/>
+        </a:gradFill>
+        <a:gradFill rotWithShape="1">
+          <a:gsLst>
+            <a:gs pos="0">
+              <a:schemeClr val="phClr">
+                <a:tint val="100000"/>
+                <a:shade val="100000"/>
+                <a:satMod val="130000"/>
+              </a:schemeClr>
+            </a:gs>
+            <a:gs pos="100000">
+              <a:schemeClr val="phClr">
+                <a:tint val="50000"/>
+                <a:shade val="100000"/>
+                <a:satMod val="350000"/>
+              </a:schemeClr>
+            </a:gs>
+          </a:gsLst>
+          <a:lin ang="16200000" scaled="0"/>
+        </a:gradFill>
+      </a:fillStyleLst>
+      <a:lnStyleLst>
+        <a:ln w="9525" cap="flat" cmpd="sng" algn="ctr">
+          <a:solidFill>
+            <a:schemeClr val="phClr">
+              <a:shade val="95000"/>
+              <a:satMod val="105000"/>
+            </a:schemeClr>
+          </a:solidFill>
+          <a:prstDash val="solid"/>
+        </a:ln>
+        <a:ln w="25400" cap="flat" cmpd="sng" algn="ctr">
+          <a:solidFill>
+            <a:schemeClr val="phClr"/>
+          </a:solidFill>
+          <a:prstDash val="solid"/>
+        </a:ln>
+        <a:ln w="38100" cap="flat" cmpd="sng" algn="ctr">
+          <a:solidFill>
+            <a:schemeClr val="phClr"/>
+          </a:solidFill>
+          <a:prstDash val="solid"/>
+        </a:ln>
+      </a:lnStyleLst>
+      <a:effectStyleLst>
+        <a:effectStyle>
+          <a:effectLst>
+            <a:outerShdw blurRad="40000" dist="20000" dir="5400000" rotWithShape="0">
+              <a:srgbClr val="000000">
+                <a:alpha val="38000"/>
+              </a:srgbClr>
+            </a:outerShdw>
+          </a:effectLst>
+        </a:effectStyle>
+        <a:effectStyle>
+          <a:effectLst>
+            <a:outerShdw blurRad="40000" dist="23000" dir="5400000" rotWithShape="0">
+              <a:srgbClr val="000000">
+                <a:alpha val="35000"/>
+              </a:srgbClr>
+            </a:outerShdw>
+          </a:effectLst>
+        </a:effectStyle>
+        <a:effectStyle>
+          <a:effectLst>
+            <a:outerShdw blurRad="40000" dist="23000" dir="5400000" rotWithShape="0">
+              <a:srgbClr val="000000">
+                <a:alpha val="35000"/>
+              </a:srgbClr>
+            </a:outerShdw>
+          </a:effectLst>
+          <a:scene3d>
+            <a:camera prst="orthographicFront">
+              <a:rot lat="0" lon="0" rev="0"/>
+            </a:camera>
+            <a:lightRig rig="threePt" dir="t">
+              <a:rot lat="0" lon="0" rev="1200000"/>
+            </a:lightRig>
+          </a:scene3d>
+          <a:sp3d>
+            <a:bevelT w="63500" h="25400"/>
+          </a:sp3d>
+        </a:effectStyle>
+      </a:effectStyleLst>
+      <a:bgFillStyleLst>
+        <a:solidFill>
+          <a:schemeClr val="phClr"/>
+        </a:solidFill>
+        <a:gradFill rotWithShape="1">
+          <a:gsLst>
+            <a:gs pos="0">
+              <a:schemeClr val="phClr">
+                <a:tint val="40000"/>
+                <a:satMod val="350000"/>
+              </a:schemeClr>
+            </a:gs>
+            <a:gs pos="40000">
+              <a:schemeClr val="phClr">
+                <a:tint val="45000"/>
+                <a:shade val="99000"/>
+                <a:satMod val="350000"/>
+              </a:schemeClr>
+            </a:gs>
+            <a:gs pos="100000">
+              <a:schemeClr val="phClr">
+                <a:shade val="20000"/>
+                <a:satMod val="255000"/>
+              </a:schemeClr>
+            </a:gs>
+          </a:gsLst>
+          <a:path path="circle">
+            <a:fillToRect l="50000" t="-80000" r="50000" b="180000"/>
+          </a:path>
+        </a:gradFill>
+        <a:gradFill rotWithShape="1">
+          <a:gsLst>
+            <a:gs pos="0">
+              <a:schemeClr val="phClr">
+                <a:tint val="80000"/>
+                <a:satMod val="300000"/>
+              </a:schemeClr>
+            </a:gs>
+            <a:gs pos="100000">
+              <a:schemeClr val="phClr">
+                <a:shade val="30000"/>
+                <a:satMod val="200000"/>
+              </a:schemeClr>
+            </a:gs>
+          </a:gsLst>
+          <a:path path="circle">
+            <a:fillToRect l="50000" t="50000" r="50000" b="50000"/>
+          </a:path>
+        </a:gradFill>
+      </a:bgFillStyleLst>
+    </a:fmtScheme>
+  </a:themeElements>
+  <a:objectDefaults>
+    <a:spDef>
+      <a:spPr/>
+      <a:bodyPr/>
+      <a:lstStyle/>
+      <a:style>
+        <a:lnRef idx="1">
+          <a:schemeClr val="accent1"/>
+        </a:lnRef>
+        <a:fillRef idx="3">
+          <a:schemeClr val="accent1"/>
+        </a:fillRef>
+        <a:effectRef idx="2">
+          <a:schemeClr val="accent1"/>
+        </a:effectRef>
+        <a:fontRef idx="minor">
+          <a:schemeClr val="lt1"/>
+        </a:fontRef>
+      </a:style>
+    </a:spDef>
+    <a:lnDef>
+      <a:spPr/>
+      <a:bodyPr/>
+      <a:lstStyle/>
+      <a:style>
+        <a:lnRef idx="2">
+          <a:schemeClr val="accent1"/>
+        </a:lnRef>
+        <a:fillRef idx="0">
+          <a:schemeClr val="accent1"/>
+        </a:fillRef>
+        <a:effectRef idx="1">
+          <a:schemeClr val="accent1"/>
+        </a:effectRef>
+        <a:fontRef idx="minor">
+          <a:schemeClr val="tx1"/>
+        </a:fontRef>
+      </a:style>
+    </a:lnDef>
+  </a:objectDefaults>
+  <a:extraClrSchemeLst/>
+</a:theme>
 </file>
</xml_diff>

<commit_message>
feat(v4): judge-level polish, dynamic agentic trace, technical Q&A defense, and deliverable synchronization
</commit_message>
<xml_diff>
--- a/ReturnLens_v4.pptx
+++ b/ReturnLens_v4.pptx
@@ -512,37 +512,37 @@
           </a:p>
           <a:p>
             <a:r>
-              <a:t>- Problem Statement fit: PS-04 (Autonomous Support Agent for Online Sellers).</a:t>
-            </a:r>
-          </a:p>
-          <a:p>
-            <a:r>
-              <a:t>- Target user: Solo direct-to-consumer (D2C) e-commerce merchants managing orders, shipping, and returns without dedicated support staff.</a:t>
-            </a:r>
-          </a:p>
-          <a:p>
-            <a:r>
-              <a:t>- Core insight: Solo merchants waste 15–20 minutes per return opening fragmented tabs (buyer chat, Shopify, Shippo tracking, return policy). Return decisions are made from memory without unified evidence.</a:t>
-            </a:r>
-          </a:p>
-          <a:p>
-            <a:r>
-              <a:t>- Differentiator: ReturnLens is not another open-ended conversational bot; it is a fail-closed, evidence-indexed triage agent.</a:t>
-            </a:r>
-          </a:p>
-          <a:p>
-            <a:r>
-              <a:t>- Visual anchor: The Seller Review Console mockup shows staged inspection frame 00:14. Notice the honest observation: rather than claiming an incontrovertible defect, the agent flags potential damage for seller confirmation.</a:t>
-            </a:r>
-          </a:p>
-          <a:p>
-            <a:r>
-              <a:t>- 24-hour scope: Return triage core + 1 zero-vision order-status route (reusing Shopify/Shippo mock APIs).</a:t>
-            </a:r>
-          </a:p>
-          <a:p>
-            <a:r>
-              <a:t>- Guardrail: Financial release strictly requires 1-click human seller authorization. No autonomous refunds.</a:t>
+              <a:t>- Track &amp; Fit: AgentX Hackathon 2026, Track PS-04 (Autonomous Support Agent for Online Sellers), Team Rookie (3 members).</a:t>
+            </a:r>
+          </a:p>
+          <a:p>
+            <a:r>
+              <a:t>- Target Merchant: Solo direct-to-consumer (D2C) e-commerce sellers managing orders, shipping, and returns without dedicated support staff.</a:t>
+            </a:r>
+          </a:p>
+          <a:p>
+            <a:r>
+              <a:t>- Core Friction: Solo sellers spend 15–20 minutes per return opening fragmented tabs (buyer chat, Shopify, Shippo tracking, store return policy). Return decisions are currently made from memory without unified evidence.</a:t>
+            </a:r>
+          </a:p>
+          <a:p>
+            <a:r>
+              <a:t>- Our Thesis: "Models observe. Code verifies. Seller authorizes."</a:t>
+            </a:r>
+          </a:p>
+          <a:p>
+            <a:r>
+              <a:t>- Technical Honesty: In the console mockup, observe the conservative metadata: "Potential casing damage flagged · Requires manual confirmation" rather than an ungrounded claim of incontrovertible defect.</a:t>
+            </a:r>
+          </a:p>
+          <a:p>
+            <a:r>
+              <a:t>- Fail-Closed Safety: The system never autonomously transfers money. Return labels and refund drafts remain strictly in pending status until the human merchant reviews evidence and clicks authorization.</a:t>
+            </a:r>
+          </a:p>
+          <a:p>
+            <a:r>
+              <a:t>- 24-Hour Hackathon Scope: Focused exclusively on return triage plus one zero-vision order status fast path (reusing store and courier APIs).</a:t>
             </a:r>
           </a:p>
         </p:txBody>
@@ -617,7 +617,7 @@
           </a:p>
           <a:p>
             <a:r>
-              <a:t>- Problem: The returns bottleneck is not lack of return policies; it is fragmented, unverified context.</a:t>
+              <a:t>- Problem: The return decision bottleneck is not an absent return policy; it is fragmented, unverified context.</a:t>
             </a:r>
           </a:p>
           <a:p>
@@ -627,37 +627,37 @@
           </a:p>
           <a:p>
             <a:r>
-              <a:t>  1. Buyer claim in chat (unverified claims, emotional text).</a:t>
-            </a:r>
-          </a:p>
-          <a:p>
-            <a:r>
-              <a:t>  2. Order truth in Shopify store (SKU HEAD-WHT-02, price ₹1,499).</a:t>
-            </a:r>
-          </a:p>
-          <a:p>
-            <a:r>
-              <a:t>  3. Tracking scan in Shippo courier API (delivered 4 days ago).</a:t>
-            </a:r>
-          </a:p>
-          <a:p>
-            <a:r>
-              <a:t>  4. Store return policy document (7-day defect window, security tag).</a:t>
-            </a:r>
-          </a:p>
-          <a:p>
-            <a:r>
-              <a:t>- The central gap: No shared evidence record connecting video, store orders, and shipping timestamps into a single auditable artifact.</a:t>
-            </a:r>
-          </a:p>
-          <a:p>
-            <a:r>
-              <a:t>- Fraud statistics note: Estimates differ fundamentally by methodology. NRF 2025 reports 9% for strictly criminal return fraud, whereas Appriss/Deloitte 2024 reports 15.14% when including policy abuse (wardrobing, unboxing swaps). Never conflate these two metrics.</a:t>
-            </a:r>
-          </a:p>
-          <a:p>
-            <a:r>
-              <a:t>- Cost to seller: Triage takes 15–20 minutes per ticket. Erroneous approval bleeds gross margins; unfair rejection destroys customer lifetime value (LTV).</a:t>
+              <a:t>  1. Customer Claim in chat (unverified claims, emotional text).</a:t>
+            </a:r>
+          </a:p>
+          <a:p>
+            <a:r>
+              <a:t>  2. Order Truth in Shopify store (SKU HEAD-WHT-02, price ₹4,999).</a:t>
+            </a:r>
+          </a:p>
+          <a:p>
+            <a:r>
+              <a:t>  3. Tracking Scan in Shippo courier API (delivered 4 days ago).</a:t>
+            </a:r>
+          </a:p>
+          <a:p>
+            <a:r>
+              <a:t>  4. Store Return Policy document (7-day defect window, security tag required).</a:t>
+            </a:r>
+          </a:p>
+          <a:p>
+            <a:r>
+              <a:t>- Central Gap: "Four systems. No traceable decision." Sellers decide returns from memory today. No single record ties video frames, store orders, and shipping status into an immutable decision trace.</a:t>
+            </a:r>
+          </a:p>
+          <a:p>
+            <a:r>
+              <a:t>- Fraud Metrics Defense: Strict fraud is 9% (NRF 2025, fraud only), while fraud + abuse is 15.14% (Appriss/Deloitte 2024). They represent fundamentally different measurement scopes and must never be merged.</a:t>
+            </a:r>
+          </a:p>
+          <a:p>
+            <a:r>
+              <a:t>- Asymmetric Merchant Risk: Wrong refund loses inventory and gross margin; unfair denial destroys customer lifetime value (LTV).</a:t>
             </a:r>
           </a:p>
         </p:txBody>
@@ -732,47 +732,52 @@
           </a:p>
           <a:p>
             <a:r>
-              <a:t>- Core benchmark scenario (Case B): Buyer ordered white headphones (HEAD-WHT-02, ₹1,499), but unboxing frame 00:07 shows black headphones.</a:t>
-            </a:r>
-          </a:p>
-          <a:p>
-            <a:r>
-              <a:t>- Grounding &amp; Honesty: Notice that the agent does NOT claim to read an unreadable SKU barcode from 00:07. It states factually: "Observed Color: Midnight Black · Exact SKU: Not verified".</a:t>
-            </a:r>
-          </a:p>
-          <a:p>
-            <a:r>
-              <a:t>- Decision logic: Seeing a black item when white was ordered is an undeniable visual contradiction against the manifest. Instead of auto-denying the customer (which might alienate an honest buyer if the warehouse mis-shipped), the policy engine triggers ESCALATE.</a:t>
-            </a:r>
-          </a:p>
-          <a:p>
-            <a:r>
-              <a:t>- Three clear merchant options are presented:</a:t>
-            </a:r>
-          </a:p>
-          <a:p>
-            <a:r>
-              <a:t>  1. Accept mis-shipment (warehouse mistake).</a:t>
-            </a:r>
-          </a:p>
-          <a:p>
-            <a:r>
-              <a:t>  2. Request outside-box label photo (buyer opened wrong family parcel).</a:t>
-            </a:r>
-          </a:p>
-          <a:p>
-            <a:r>
-              <a:t>  3. Route to warehouse inspection (possible fraud).</a:t>
-            </a:r>
-          </a:p>
-          <a:p>
-            <a:r>
-              <a:t>- Schema: typed JSON, requires_seller_approval: true.</a:t>
-            </a:r>
-          </a:p>
-          <a:p>
-            <a:r>
-              <a:t>- Financial cap: 0 &lt; amount &lt;= min(₹4,999, remaining refundable amount, order paid amount).</a:t>
+              <a:t>- Core Benchmark Scenario (Case B): Buyer ordered white headphones (HEAD-WHT-02, ₹4,999), but unboxing frame 00:07 shows black headphones.</a:t>
+            </a:r>
+          </a:p>
+          <a:p>
+            <a:r>
+              <a:t>- Grounding &amp; Honesty: The agent does NOT claim to read an unreadable SKU barcode from frame 00:07. It states factually: "Observed Color: Midnight Black · Exact SKU: Not verified · Tag: Not visible in cited frame".</a:t>
+            </a:r>
+          </a:p>
+          <a:p>
+            <a:r>
+              <a:t>- Decision Logic: Seeing a black item when white was ordered is an undeniable visual contradiction against the manifest. Instead of auto-denying the customer (which might alienate an honest buyer if the warehouse mis-shipped), the policy engine triggers ESCALATE.</a:t>
+            </a:r>
+          </a:p>
+          <a:p>
+            <a:r>
+              <a:t>- Three Merchant Decision Options:</a:t>
+            </a:r>
+          </a:p>
+          <a:p>
+            <a:r>
+              <a:t>  1. Request unboxing video with packaging label / serial number visible.</a:t>
+            </a:r>
+          </a:p>
+          <a:p>
+            <a:r>
+              <a:t>  2. Reject return under Clause 4.2 (Item does not match order record).</a:t>
+            </a:r>
+          </a:p>
+          <a:p>
+            <a:r>
+              <a:t>  3. Override &amp; approve if seller acknowledges known warehouse fulfillment error.</a:t>
+            </a:r>
+          </a:p>
+          <a:p>
+            <a:r>
+              <a:t>- Fail-Closed Financial Gate:</a:t>
+            </a:r>
+          </a:p>
+          <a:p>
+            <a:r>
+              <a:t>  max_refund = min(₹4,999, remaining refundable amount, order paid amount).</a:t>
+            </a:r>
+          </a:p>
+          <a:p>
+            <a:r>
+              <a:t>  No refund money is released without explicit seller click.</a:t>
             </a:r>
           </a:p>
         </p:txBody>
@@ -842,7 +847,7 @@
           <a:lstStyle/>
           <a:p>
             <a:r>
-              <a:t>Slide 4 — System Architecture &amp; Deterministic Governance:</a:t>
+              <a:t>Slide 4 — System Architecture, Agentic Governance &amp; Technical Q&amp;A Defense:</a:t>
             </a:r>
           </a:p>
           <a:p>
@@ -850,59 +855,73 @@
               <a:t>- Philosophy: "Models observe. Code verifies. Seller authorizes."</a:t>
             </a:r>
           </a:p>
-          <a:p>
-            <a:r>
-              <a:t>- Pipeline (6 steps):</a:t>
-            </a:r>
-          </a:p>
-          <a:p>
-            <a:r>
-              <a:t>  1. Planner [MODEL]: Validates incoming JSON payload against strict schema.</a:t>
-            </a:r>
-          </a:p>
-          <a:p>
-            <a:r>
-              <a:t>  2. Tools &amp; Video [CODE]: Extracts keyframes with FFmpeg; calls mock Shopify/Shippo endpoints.</a:t>
-            </a:r>
-          </a:p>
-          <a:p>
-            <a:r>
-              <a:t>  3. Policy Engine [CODE]: Evaluates deterministic Python rules P-01 through P-08 (window, SKU match, tags).</a:t>
-            </a:r>
-          </a:p>
-          <a:p>
-            <a:r>
-              <a:t>  4. Evidence Critic [MODEL]: Secondary auditor verifying cited timestamps against extracted observations to catch hallucinated damage.</a:t>
-            </a:r>
-          </a:p>
-          <a:p>
-            <a:r>
-              <a:t>  5. Seller Gate [HUMAN]: Merchant console where human authorizes mock label or draft refund.</a:t>
-            </a:r>
-          </a:p>
-          <a:p>
-            <a:r>
-              <a:t>  6. Audit Log [CODE]: Immutable append-only structured JSON log for every state transition.</a:t>
-            </a:r>
-          </a:p>
-          <a:p>
-            <a:r>
-              <a:t>- Broad PS-04 alignment: A fast zero-vision route handles routine "Where is my order?" inquiries by querying the courier tracking tool directly, answering customer queries in sub-second time.</a:t>
-            </a:r>
-          </a:p>
-          <a:p>
-            <a:r>
-              <a:t>- Strict priority order for decision function:</a:t>
-            </a:r>
-          </a:p>
-          <a:p>
-            <a:r>
-              <a:t>  Contradiction &gt; Hard fail &gt; Unclear only &gt; All pass.</a:t>
-            </a:r>
-          </a:p>
-          <a:p>
-            <a:r>
-              <a:t>- Bounded calls: Exactly 3 base LLM calls per triage case.</a:t>
+          <a:p/>
+          <a:p>
+            <a:r>
+              <a:t>- DEFENSE QUESTION 1: Why is this an agent rather than a hardcoded workflow?</a:t>
+            </a:r>
+          </a:p>
+          <a:p>
+            <a:r>
+              <a:t>  ReturnLens is an autonomous state machine with dynamic action selection, multi-modal observation, and stateful lifecycle management.</a:t>
+            </a:r>
+          </a:p>
+          <a:p>
+            <a:r>
+              <a:t>  In Case C, when a customer submits a dark/blurry video (average brightness 28), the agent does NOT simply fail or run a static linear chain. It inspects the frames, determines evidence is insufficient under Policy P-05, dynamically decides to invoke ask_for_evidence() with specific re-filming guidance, transitions the ticket to WAITING_FOR_EVIDENCE, pauses execution while retaining state and order context, and resumes the exact triage session when new media arrives.</a:t>
+            </a:r>
+          </a:p>
+          <a:p>
+            <a:r>
+              <a:t>  Conversely, for routine "Where is my order?" requests, the agent selects the zero-vision fast path, querying mock Shopify and Shippo APIs directly without invoking heavy vision models.</a:t>
+            </a:r>
+          </a:p>
+          <a:p/>
+          <a:p>
+            <a:r>
+              <a:t>- DEFENSE QUESTION 2: What happens if vision or critic models hallucinate?</a:t>
+            </a:r>
+          </a:p>
+          <a:p>
+            <a:r>
+              <a:t>  Vision models produce non-binding observation metadata, never authoritative decisions. Hard business rules (return windows from carrier delivery timestamps, SKU comparisons) are executed in deterministic Python code (P-01 to P-08), which cannot be jailbroken by customer prompts.</a:t>
+            </a:r>
+          </a:p>
+          <a:p>
+            <a:r>
+              <a:t>  The critic provides an adversarial sanity check against cited timestamps. If both vision and critic experience correlated hallucinations, the fail-closed human seller gate guarantees that no refund or return label can ever be issued without seller review.</a:t>
+            </a:r>
+          </a:p>
+          <a:p/>
+          <a:p>
+            <a:r>
+              <a:t>- DEFENSE QUESTION 3: How do you prevent duplicate or incorrect refunds?</a:t>
+            </a:r>
+          </a:p>
+          <a:p>
+            <a:r>
+              <a:t>  Refund transactions are enforced at the backend policy layer:</a:t>
+            </a:r>
+          </a:p>
+          <a:p>
+            <a:r>
+              <a:t>  1. Idempotency keys (hash(order_id, return_id, transaction_type)) prevent double-execution.</a:t>
+            </a:r>
+          </a:p>
+          <a:p>
+            <a:r>
+              <a:t>  2. Ledgers track cumulative refunded amounts against total order value: 0 &lt; amount &lt;= min(₹4,999, remaining_refundable_amount, order_paid_amount).</a:t>
+            </a:r>
+          </a:p>
+          <a:p>
+            <a:r>
+              <a:t>  3. LLMs possess zero capability to call payment gateways directly; all actions produce draft state objects awaiting merchant authorization.</a:t>
+            </a:r>
+          </a:p>
+          <a:p/>
+          <a:p>
+            <a:r>
+              <a:t>- Bounded Execution: Exactly 3 base model calls per triage case (Planner, Vision, Critic) plus retries.</a:t>
             </a:r>
           </a:p>
         </p:txBody>
@@ -992,7 +1011,7 @@
           </a:p>
           <a:p>
             <a:r>
-              <a:t>- Case C (Unclear / Low Light): Dark video (28/255 avg brightness). Instead of auto-denying, the agent provides a clear checklist and allows 1 retry to protect legitimate customers.</a:t>
+              <a:t>- Case C (Unclear / Agentic Loop): Dark video (28/255 avg brightness). Instead of auto-denying, the agent provides a clear checklist, transitions to WAITING_FOR_EVIDENCE, and resumes on upload (1 retry limit protects customers from infinite loops).</a:t>
             </a:r>
           </a:p>
           <a:p>
@@ -1002,7 +1021,7 @@
           </a:p>
           <a:p>
             <a:r>
-              <a:t>- Financial cap formula: min(₹4,999, remaining refundable amount, order paid amount) prevents catastrophic loss.</a:t>
+              <a:t>- Financial Cap Formula: min(₹4,999, remaining refundable amount, order paid amount) strictly prevents over-refunding.</a:t>
             </a:r>
           </a:p>
         </p:txBody>
@@ -1077,12 +1096,12 @@
           </a:p>
           <a:p>
             <a:r>
-              <a:t>- Feasibility argument: Why is ReturnLens realistically buildable in 24 hours by 3 engineers?</a:t>
-            </a:r>
-          </a:p>
-          <a:p>
-            <a:r>
-              <a:t>  1. No live external production dependencies (we use deterministic mock APIs for Shopify &amp; Shippo).</a:t>
+              <a:t>- Feasibility Argument: Why is ReturnLens realistically buildable in 24 hours by 3 engineers?</a:t>
+            </a:r>
+          </a:p>
+          <a:p>
+            <a:r>
+              <a:t>  1. No live external production dependencies: deterministic mock APIs for Shopify &amp; Shippo eliminate external latency and flakiness.</a:t>
             </a:r>
           </a:p>
           <a:p>
@@ -1092,37 +1111,37 @@
           </a:p>
           <a:p>
             <a:r>
-              <a:t>     - Person A (Backend): LangGraph state graph, policy logic P-01 to P-08, JSON audit logger, order-status route.</a:t>
-            </a:r>
-          </a:p>
-          <a:p>
-            <a:r>
-              <a:t>     - Person B (Video/UI): FFmpeg keyframe extraction script, Streamlit seller review console, frame citation display.</a:t>
-            </a:r>
-          </a:p>
-          <a:p>
-            <a:r>
-              <a:t>     - Person C (Integration/QA): 4 staged test datasets (Cases A-D), boundary testing, fallback test cases, demo recording, and submission docs.</a:t>
-            </a:r>
-          </a:p>
-          <a:p>
-            <a:r>
-              <a:t>  3. Scope discipline:</a:t>
-            </a:r>
-          </a:p>
-          <a:p>
-            <a:r>
-              <a:t>     - NEVER CUT: Core policy engine, frame citations, seller authorization gate, structured audit log.</a:t>
-            </a:r>
-          </a:p>
-          <a:p>
-            <a:r>
-              <a:t>     - CUT FIRST: Video OCR barcode scanning, automated customer email replying, seller analytics dashboards, production payment gateways.</a:t>
-            </a:r>
-          </a:p>
-          <a:p>
-            <a:r>
-              <a:t>- Winning philosophy: "The winning hackathon agent is not the one with the most tool definitions. It is the one where every action is held to evidence, and the seller stays in control."</a:t>
+              <a:t>     - Person A (Backend): LangGraph state graph, mock store/courier fixtures, order-status route, state serialization.</a:t>
+            </a:r>
+          </a:p>
+          <a:p>
+            <a:r>
+              <a:t>     - Person B (Video &amp; UI): FFmpeg keyframe extraction, deterministic rules P-01 to P-08, critic prompt, seller console.</a:t>
+            </a:r>
+          </a:p>
+          <a:p>
+            <a:r>
+              <a:t>     - Person C (Integration &amp; Validation): Clarification/resume loop, 4 staged demo cases (A-D), authorization boundary tests, demo video recording, README.</a:t>
+            </a:r>
+          </a:p>
+          <a:p>
+            <a:r>
+              <a:t>  3. Strict Scope Discipline:</a:t>
+            </a:r>
+          </a:p>
+          <a:p>
+            <a:r>
+              <a:t>     - NEVER CUT: Core policy engine, frame citations, seller authorization gate, structured audit log, clarification/resume loop, 4 demo cases.</a:t>
+            </a:r>
+          </a:p>
+          <a:p>
+            <a:r>
+              <a:t>     - CUT FIRST IF BEHIND: Real carrier webhooks, multi-product order parsing, video OCR barcode scanning, production payment gateways, seller analytics dashboards.</a:t>
+            </a:r>
+          </a:p>
+          <a:p>
+            <a:r>
+              <a:t>- Winning Philosophy: "The winning hackathon agent is not the one with the most tool definitions. It is the one where every action is held to evidence, and the seller stays in control."</a:t>
             </a:r>
           </a:p>
         </p:txBody>
@@ -4180,7 +4199,7 @@
         <p:spPr>
           <a:xfrm>
             <a:off x="731520" y="548640"/>
-            <a:ext cx="5486400" cy="365760"/>
+            <a:ext cx="5669280" cy="365760"/>
           </a:xfrm>
           <a:prstGeom prst="rect">
             <a:avLst/>
@@ -4202,7 +4221,7 @@
               </a:defRPr>
             </a:pPr>
             <a:r>
-              <a:t>AGENTX HACKATHON 2026 · TRACK PS-04</a:t>
+              <a:t>RETURNLENS · PRODUCT LAUNCH</a:t>
             </a:r>
           </a:p>
         </p:txBody>
@@ -4215,8 +4234,8 @@
         </p:nvSpPr>
         <p:spPr>
           <a:xfrm>
-            <a:off x="731520" y="1005840"/>
-            <a:ext cx="4114800" cy="822960"/>
+            <a:off x="731520" y="960120"/>
+            <a:ext cx="5669280" cy="1005840"/>
           </a:xfrm>
           <a:prstGeom prst="rect">
             <a:avLst/>
@@ -4230,7 +4249,7 @@
           <a:lstStyle/>
           <a:p>
             <a:pPr>
-              <a:defRPr sz="5600" b="1">
+              <a:defRPr sz="5400" b="1">
                 <a:solidFill>
                   <a:srgbClr val="172621"/>
                 </a:solidFill>
@@ -4251,8 +4270,8 @@
         </p:nvSpPr>
         <p:spPr>
           <a:xfrm>
-            <a:off x="731520" y="1920240"/>
-            <a:ext cx="4114800" cy="731520"/>
+            <a:off x="731520" y="2011680"/>
+            <a:ext cx="5669280" cy="731520"/>
           </a:xfrm>
           <a:prstGeom prst="rect">
             <a:avLst/>
@@ -4266,15 +4285,15 @@
           <a:lstStyle/>
           <a:p>
             <a:pPr>
-              <a:defRPr sz="1800" b="1">
-                <a:solidFill>
-                  <a:srgbClr val="006B55"/>
+              <a:defRPr sz="2600" b="1">
+                <a:solidFill>
+                  <a:srgbClr val="172621"/>
                 </a:solidFill>
                 <a:latin typeface="Inter"/>
               </a:defRPr>
             </a:pPr>
             <a:r>
-              <a:t>“Review returns with cited video evidence.”</a:t>
+              <a:t>Every return decision, backed by evidence.</a:t>
             </a:r>
           </a:p>
         </p:txBody>
@@ -4287,8 +4306,8 @@
         </p:nvSpPr>
         <p:spPr>
           <a:xfrm>
-            <a:off x="731520" y="2651760"/>
-            <a:ext cx="4114800" cy="822960"/>
+            <a:off x="731520" y="2834640"/>
+            <a:ext cx="5669280" cy="1097280"/>
           </a:xfrm>
           <a:prstGeom prst="rect">
             <a:avLst/>
@@ -4302,7 +4321,7 @@
           <a:lstStyle/>
           <a:p>
             <a:pPr>
-              <a:defRPr sz="1400">
+              <a:defRPr sz="1200">
                 <a:solidFill>
                   <a:srgbClr val="596E64"/>
                 </a:solidFill>
@@ -4310,7 +4329,12 @@
               </a:defRPr>
             </a:pPr>
             <a:r>
-              <a:t>An evidence-backed return triage agent for small direct-to-consumer sellers.</a:t>
+              <a:t>Solo online sellers lose 15–20 minutes per return deciding from memory across disconnected tabs.</a:t>
+            </a:r>
+            <a:br/>
+            <a:br/>
+            <a:r>
+              <a:t>ReturnLens indexes unboxing video keyframes, matches store orders, applies deterministic policy rules, and presents a 1-click decision console to the merchant.</a:t>
             </a:r>
           </a:p>
         </p:txBody>
@@ -4323,8 +4347,8 @@
         </p:nvSpPr>
         <p:spPr>
           <a:xfrm>
-            <a:off x="731520" y="3931920"/>
-            <a:ext cx="4114800" cy="2011680"/>
+            <a:off x="731520" y="4114800"/>
+            <a:ext cx="5669280" cy="594360"/>
           </a:xfrm>
           <a:prstGeom prst="rect">
             <a:avLst/>
@@ -4353,58 +4377,32 @@
           </a:fontRef>
         </p:style>
         <p:txBody>
-          <a:bodyPr rtlCol="0" anchor="ctr" wrap="square"/>
+          <a:bodyPr rtlCol="0" anchor="ctr"/>
           <a:lstStyle/>
           <a:p>
             <a:pPr algn="ctr">
-              <a:defRPr sz="1100" b="1">
+              <a:defRPr sz="950" b="1">
+                <a:solidFill>
+                  <a:srgbClr val="006B55"/>
+                </a:solidFill>
+                <a:latin typeface="IBM Plex Mono"/>
+              </a:defRPr>
+            </a:pPr>
+            <a:r>
+              <a:t>AgentX Hackathon 2026 · PS-04 Track · Team Rookie (3 Members)</a:t>
+            </a:r>
+          </a:p>
+          <a:p>
+            <a:pPr>
+              <a:defRPr sz="1000">
                 <a:solidFill>
                   <a:srgbClr val="172621"/>
                 </a:solidFill>
-                <a:latin typeface="IBM Plex Mono"/>
-              </a:defRPr>
-            </a:pPr>
-            <a:r>
-              <a:t>Team Rookie · 3 members · PS-04 Track</a:t>
-            </a:r>
-          </a:p>
-          <a:p>
-            <a:pPr>
-              <a:defRPr sz="1050">
-                <a:solidFill>
-                  <a:srgbClr val="596E64"/>
-                </a:solidFill>
                 <a:latin typeface="Inter"/>
               </a:defRPr>
             </a:pPr>
             <a:r>
-              <a:t>Target User: Solo D2C merchant managing orders and returns alone.</a:t>
-            </a:r>
-          </a:p>
-          <a:p>
-            <a:pPr>
-              <a:defRPr sz="1050">
-                <a:solidFill>
-                  <a:srgbClr val="596E64"/>
-                </a:solidFill>
-                <a:latin typeface="Inter"/>
-              </a:defRPr>
-            </a:pPr>
-            <a:r>
-              <a:t>Scope in 24h: Return triage core + 1 zero-vision order status route.</a:t>
-            </a:r>
-          </a:p>
-          <a:p>
-            <a:pPr>
-              <a:defRPr sz="1050" b="1">
-                <a:solidFill>
-                  <a:srgbClr val="172621"/>
-                </a:solidFill>
-                <a:latin typeface="Inter"/>
-              </a:defRPr>
-            </a:pPr>
-            <a:r>
-              <a:t>Guardrails: Fail-closed architecture · No autonomous refunds.</a:t>
+              <a:t>Thesis: Models observe. Code verifies. Seller authorizes.</a:t>
             </a:r>
           </a:p>
         </p:txBody>
@@ -4417,51 +4415,8 @@
         </p:nvSpPr>
         <p:spPr>
           <a:xfrm>
-            <a:off x="731520" y="3931920"/>
-            <a:ext cx="73152" cy="2011680"/>
-          </a:xfrm>
-          <a:prstGeom prst="rect">
-            <a:avLst/>
-          </a:prstGeom>
-          <a:solidFill>
-            <a:srgbClr val="006B55"/>
-          </a:solidFill>
-          <a:ln>
-            <a:noFill/>
-          </a:ln>
-        </p:spPr>
-        <p:style>
-          <a:lnRef idx="1">
-            <a:schemeClr val="accent1"/>
-          </a:lnRef>
-          <a:fillRef idx="3">
-            <a:schemeClr val="accent1"/>
-          </a:fillRef>
-          <a:effectRef idx="2">
-            <a:schemeClr val="accent1"/>
-          </a:effectRef>
-          <a:fontRef idx="minor">
-            <a:schemeClr val="lt1"/>
-          </a:fontRef>
-        </p:style>
-        <p:txBody>
-          <a:bodyPr rtlCol="0" anchor="ctr"/>
-          <a:lstStyle/>
-          <a:p>
-            <a:pPr algn="ctr"/>
-          </a:p>
-        </p:txBody>
-      </p:sp>
-      <p:sp>
-        <p:nvSpPr>
-          <p:cNvPr id="9" name="Rectangle 8"/>
-          <p:cNvSpPr/>
-          <p:nvPr/>
-        </p:nvSpPr>
-        <p:spPr>
-          <a:xfrm>
-            <a:off x="5120640" y="1005840"/>
-            <a:ext cx="6339535" cy="4937760"/>
+            <a:off x="731520" y="4846320"/>
+            <a:ext cx="1737360" cy="1143000"/>
           </a:xfrm>
           <a:prstGeom prst="rect">
             <a:avLst/>
@@ -4493,97 +4448,43 @@
           <a:bodyPr rtlCol="0" anchor="ctr"/>
           <a:lstStyle/>
           <a:p>
-            <a:pPr algn="ctr"/>
-          </a:p>
-        </p:txBody>
-      </p:sp>
-      <p:sp>
-        <p:nvSpPr>
-          <p:cNvPr id="10" name="Rectangle 9"/>
+            <a:pPr algn="ctr">
+              <a:defRPr sz="2200" b="1">
+                <a:solidFill>
+                  <a:srgbClr val="D95D39"/>
+                </a:solidFill>
+                <a:latin typeface="Inter"/>
+              </a:defRPr>
+            </a:pPr>
+            <a:r>
+              <a:t>15–20m</a:t>
+            </a:r>
+          </a:p>
+          <a:p>
+            <a:pPr>
+              <a:defRPr sz="900">
+                <a:solidFill>
+                  <a:srgbClr val="596E64"/>
+                </a:solidFill>
+                <a:latin typeface="Inter"/>
+              </a:defRPr>
+            </a:pPr>
+            <a:r>
+              <a:t>Current manual triage time per return ticket</a:t>
+            </a:r>
+          </a:p>
+        </p:txBody>
+      </p:sp>
+      <p:sp>
+        <p:nvSpPr>
+          <p:cNvPr id="9" name="Rectangle 8"/>
           <p:cNvSpPr/>
           <p:nvPr/>
         </p:nvSpPr>
         <p:spPr>
           <a:xfrm>
-            <a:off x="5120640" y="1005840"/>
-            <a:ext cx="6339535" cy="411480"/>
-          </a:xfrm>
-          <a:prstGeom prst="rect">
-            <a:avLst/>
-          </a:prstGeom>
-          <a:solidFill>
-            <a:srgbClr val="172621"/>
-          </a:solidFill>
-          <a:ln>
-            <a:noFill/>
-          </a:ln>
-        </p:spPr>
-        <p:style>
-          <a:lnRef idx="1">
-            <a:schemeClr val="accent1"/>
-          </a:lnRef>
-          <a:fillRef idx="3">
-            <a:schemeClr val="accent1"/>
-          </a:fillRef>
-          <a:effectRef idx="2">
-            <a:schemeClr val="accent1"/>
-          </a:effectRef>
-          <a:fontRef idx="minor">
-            <a:schemeClr val="lt1"/>
-          </a:fontRef>
-        </p:style>
-        <p:txBody>
-          <a:bodyPr rtlCol="0" anchor="ctr"/>
-          <a:lstStyle/>
-          <a:p>
-            <a:pPr algn="ctr">
-              <a:defRPr sz="1000" b="1">
-                <a:solidFill>
-                  <a:srgbClr val="F5F3EF"/>
-                </a:solidFill>
-                <a:latin typeface="IBM Plex Mono"/>
-              </a:defRPr>
-            </a:pPr>
-            <a:r>
-              <a:t>RETURNLENS SELLER CONSOLE · CASE #RET-4082          ORDER #ORD-9021</a:t>
-            </a:r>
-          </a:p>
-        </p:txBody>
-      </p:sp>
-      <p:pic>
-        <p:nvPicPr>
-          <p:cNvPr id="11" name="Picture 10" descr="hero_video_frame.jpg"/>
-          <p:cNvPicPr>
-            <a:picLocks noChangeAspect="1"/>
-          </p:cNvPicPr>
-          <p:nvPr/>
-        </p:nvPicPr>
-        <p:blipFill>
-          <a:blip r:embed="rId2"/>
-          <a:stretch>
-            <a:fillRect/>
-          </a:stretch>
-        </p:blipFill>
-        <p:spPr>
-          <a:xfrm>
-            <a:off x="5120640" y="1417320"/>
-            <a:ext cx="3474720" cy="4526280"/>
-          </a:xfrm>
-          <a:prstGeom prst="rect">
-            <a:avLst/>
-          </a:prstGeom>
-        </p:spPr>
-      </p:pic>
-      <p:sp>
-        <p:nvSpPr>
-          <p:cNvPr id="12" name="Rectangle 11"/>
-          <p:cNvSpPr/>
-          <p:nvPr/>
-        </p:nvSpPr>
-        <p:spPr>
-          <a:xfrm>
-            <a:off x="8595360" y="1417320"/>
-            <a:ext cx="2864815" cy="4526280"/>
+            <a:off x="2697480" y="4846320"/>
+            <a:ext cx="1737360" cy="1143000"/>
           </a:xfrm>
           <a:prstGeom prst="rect">
             <a:avLst/>
@@ -4615,7 +4516,196 @@
           <a:bodyPr rtlCol="0" anchor="ctr"/>
           <a:lstStyle/>
           <a:p>
+            <a:pPr algn="ctr">
+              <a:defRPr sz="2200" b="1">
+                <a:solidFill>
+                  <a:srgbClr val="006B55"/>
+                </a:solidFill>
+                <a:latin typeface="Inter"/>
+              </a:defRPr>
+            </a:pPr>
+            <a:r>
+              <a:t>1-Click</a:t>
+            </a:r>
+          </a:p>
+          <a:p>
+            <a:pPr>
+              <a:defRPr sz="900">
+                <a:solidFill>
+                  <a:srgbClr val="596E64"/>
+                </a:solidFill>
+                <a:latin typeface="Inter"/>
+              </a:defRPr>
+            </a:pPr>
+            <a:r>
+              <a:t>Merchant decision with cited keyframe evidence</a:t>
+            </a:r>
+          </a:p>
+        </p:txBody>
+      </p:sp>
+      <p:sp>
+        <p:nvSpPr>
+          <p:cNvPr id="10" name="Rectangle 9"/>
+          <p:cNvSpPr/>
+          <p:nvPr/>
+        </p:nvSpPr>
+        <p:spPr>
+          <a:xfrm>
+            <a:off x="4663440" y="4846320"/>
+            <a:ext cx="1737360" cy="1143000"/>
+          </a:xfrm>
+          <a:prstGeom prst="rect">
+            <a:avLst/>
+          </a:prstGeom>
+          <a:solidFill>
+            <a:srgbClr val="FFFFFF"/>
+          </a:solidFill>
+          <a:ln w="12700">
+            <a:solidFill>
+              <a:srgbClr val="E2DED4"/>
+            </a:solidFill>
+          </a:ln>
+        </p:spPr>
+        <p:style>
+          <a:lnRef idx="1">
+            <a:schemeClr val="accent1"/>
+          </a:lnRef>
+          <a:fillRef idx="3">
+            <a:schemeClr val="accent1"/>
+          </a:fillRef>
+          <a:effectRef idx="2">
+            <a:schemeClr val="accent1"/>
+          </a:effectRef>
+          <a:fontRef idx="minor">
+            <a:schemeClr val="lt1"/>
+          </a:fontRef>
+        </p:style>
+        <p:txBody>
+          <a:bodyPr rtlCol="0" anchor="ctr"/>
+          <a:lstStyle/>
+          <a:p>
+            <a:pPr algn="ctr">
+              <a:defRPr sz="2200" b="1">
+                <a:solidFill>
+                  <a:srgbClr val="172621"/>
+                </a:solidFill>
+                <a:latin typeface="Inter"/>
+              </a:defRPr>
+            </a:pPr>
+            <a:r>
+              <a:t>24h</a:t>
+            </a:r>
+          </a:p>
+          <a:p>
+            <a:pPr>
+              <a:defRPr sz="900">
+                <a:solidFill>
+                  <a:srgbClr val="596E64"/>
+                </a:solidFill>
+                <a:latin typeface="Inter"/>
+              </a:defRPr>
+            </a:pPr>
+            <a:r>
+              <a:t>Prototype feasibility for 3-member team</a:t>
+            </a:r>
+          </a:p>
+        </p:txBody>
+      </p:sp>
+      <p:sp>
+        <p:nvSpPr>
+          <p:cNvPr id="11" name="Rectangle 10"/>
+          <p:cNvSpPr/>
+          <p:nvPr/>
+        </p:nvSpPr>
+        <p:spPr>
+          <a:xfrm>
+            <a:off x="6766560" y="777240"/>
+            <a:ext cx="4693615" cy="5212080"/>
+          </a:xfrm>
+          <a:prstGeom prst="rect">
+            <a:avLst/>
+          </a:prstGeom>
+          <a:solidFill>
+            <a:srgbClr val="FFFFFF"/>
+          </a:solidFill>
+          <a:ln w="12700">
+            <a:solidFill>
+              <a:srgbClr val="E2DED4"/>
+            </a:solidFill>
+          </a:ln>
+        </p:spPr>
+        <p:style>
+          <a:lnRef idx="1">
+            <a:schemeClr val="accent1"/>
+          </a:lnRef>
+          <a:fillRef idx="3">
+            <a:schemeClr val="accent1"/>
+          </a:fillRef>
+          <a:effectRef idx="2">
+            <a:schemeClr val="accent1"/>
+          </a:effectRef>
+          <a:fontRef idx="minor">
+            <a:schemeClr val="lt1"/>
+          </a:fontRef>
+        </p:style>
+        <p:txBody>
+          <a:bodyPr rtlCol="0" anchor="ctr"/>
+          <a:lstStyle/>
+          <a:p>
             <a:pPr algn="ctr"/>
+          </a:p>
+        </p:txBody>
+      </p:sp>
+      <p:sp>
+        <p:nvSpPr>
+          <p:cNvPr id="12" name="Rectangle 11"/>
+          <p:cNvSpPr/>
+          <p:nvPr/>
+        </p:nvSpPr>
+        <p:spPr>
+          <a:xfrm>
+            <a:off x="6766560" y="777240"/>
+            <a:ext cx="4693615" cy="502920"/>
+          </a:xfrm>
+          <a:prstGeom prst="rect">
+            <a:avLst/>
+          </a:prstGeom>
+          <a:solidFill>
+            <a:srgbClr val="1F302A"/>
+          </a:solidFill>
+          <a:ln>
+            <a:noFill/>
+          </a:ln>
+        </p:spPr>
+        <p:style>
+          <a:lnRef idx="1">
+            <a:schemeClr val="accent1"/>
+          </a:lnRef>
+          <a:fillRef idx="3">
+            <a:schemeClr val="accent1"/>
+          </a:fillRef>
+          <a:effectRef idx="2">
+            <a:schemeClr val="accent1"/>
+          </a:effectRef>
+          <a:fontRef idx="minor">
+            <a:schemeClr val="lt1"/>
+          </a:fontRef>
+        </p:style>
+        <p:txBody>
+          <a:bodyPr rtlCol="0" anchor="ctr"/>
+          <a:lstStyle/>
+          <a:p>
+            <a:pPr algn="ctr">
+              <a:defRPr sz="950" b="1">
+                <a:solidFill>
+                  <a:srgbClr val="00D1A7"/>
+                </a:solidFill>
+                <a:latin typeface="IBM Plex Mono"/>
+              </a:defRPr>
+            </a:pPr>
+            <a:r>
+              <a:t>RETURNLENS SELLER CONSOLE  ·  CASE #RT-1042</a:t>
+            </a:r>
           </a:p>
         </p:txBody>
       </p:sp>
@@ -4627,8 +4717,8 @@
         </p:nvSpPr>
         <p:spPr>
           <a:xfrm>
-            <a:off x="8778240" y="1508760"/>
-            <a:ext cx="2499055" cy="3931920"/>
+            <a:off x="9098280" y="1417320"/>
+            <a:ext cx="2179015" cy="3931920"/>
           </a:xfrm>
           <a:prstGeom prst="rect">
             <a:avLst/>
@@ -4642,7 +4732,7 @@
           <a:lstStyle/>
           <a:p>
             <a:pPr>
-              <a:defRPr sz="950" b="1">
+              <a:defRPr sz="900" b="1">
                 <a:solidFill>
                   <a:srgbClr val="7A8E85"/>
                 </a:solidFill>
@@ -4650,12 +4740,12 @@
               </a:defRPr>
             </a:pPr>
             <a:r>
-              <a:t>ORDER TRUTH</a:t>
+              <a:t>ORDER INFORMATION</a:t>
             </a:r>
           </a:p>
           <a:p>
             <a:pPr>
-              <a:defRPr sz="1150" b="1">
+              <a:defRPr sz="1050" b="1">
                 <a:solidFill>
                   <a:srgbClr val="172621"/>
                 </a:solidFill>
@@ -4663,7 +4753,42 @@
               </a:defRPr>
             </a:pPr>
             <a:r>
-              <a:t>HEAD-WHT-02 · White Headphones</a:t>
+              <a:t>Order #ORD-8821</a:t>
+            </a:r>
+            <a:br/>
+            <a:r>
+              <a:t>SKU: HEAD-WHT-02 (White)</a:t>
+            </a:r>
+            <a:br/>
+            <a:r>
+              <a:t>Price: ₹4,999 · Delivered 4d ago</a:t>
+            </a:r>
+          </a:p>
+          <a:p>
+            <a:br/>
+            <a:pPr>
+              <a:defRPr sz="900" b="1">
+                <a:solidFill>
+                  <a:srgbClr val="7A8E85"/>
+                </a:solidFill>
+                <a:latin typeface="IBM Plex Mono"/>
+              </a:defRPr>
+            </a:pPr>
+            <a:r>
+              <a:t>VIDEO EVIDENCE CITATION</a:t>
+            </a:r>
+          </a:p>
+          <a:p>
+            <a:pPr>
+              <a:defRPr sz="1100" b="1">
+                <a:solidFill>
+                  <a:srgbClr val="172621"/>
+                </a:solidFill>
+                <a:latin typeface="Inter"/>
+              </a:defRPr>
+            </a:pPr>
+            <a:r>
+              <a:t>Inspection Frame 00:14</a:t>
             </a:r>
           </a:p>
           <a:p>
@@ -4676,13 +4801,13 @@
               </a:defRPr>
             </a:pPr>
             <a:r>
-              <a:t>₹1,499 · Delivered Day 4 (Within 7d window)</a:t>
+              <a:t>Potential casing damage flagged · Requires manual confirmation</a:t>
             </a:r>
           </a:p>
           <a:p>
             <a:br/>
             <a:pPr>
-              <a:defRPr sz="950" b="1">
+              <a:defRPr sz="900" b="1">
                 <a:solidFill>
                   <a:srgbClr val="7A8E85"/>
                 </a:solidFill>
@@ -4690,52 +4815,12 @@
               </a:defRPr>
             </a:pPr>
             <a:r>
-              <a:t>VISUAL OBSERVATION</a:t>
+              <a:t>POLICY VERIFICATION</a:t>
             </a:r>
           </a:p>
           <a:p>
             <a:pPr>
-              <a:defRPr sz="1150" b="1">
-                <a:solidFill>
-                  <a:srgbClr val="172621"/>
-                </a:solidFill>
-                <a:latin typeface="Inter"/>
-              </a:defRPr>
-            </a:pPr>
-            <a:r>
-              <a:t>Inspection Frame 00:14</a:t>
-            </a:r>
-          </a:p>
-          <a:p>
-            <a:pPr>
-              <a:defRPr sz="950">
-                <a:solidFill>
-                  <a:srgbClr val="596E64"/>
-                </a:solidFill>
-                <a:latin typeface="Inter"/>
-              </a:defRPr>
-            </a:pPr>
-            <a:r>
-              <a:t>Potential casing damage flagged · Needs manual confirmation</a:t>
-            </a:r>
-          </a:p>
-          <a:p>
-            <a:br/>
-            <a:pPr>
-              <a:defRPr sz="950" b="1">
-                <a:solidFill>
-                  <a:srgbClr val="7A8E85"/>
-                </a:solidFill>
-                <a:latin typeface="IBM Plex Mono"/>
-              </a:defRPr>
-            </a:pPr>
-            <a:r>
-              <a:t>POLICY VERIFICATION</a:t>
-            </a:r>
-          </a:p>
-          <a:p>
-            <a:pPr>
-              <a:defRPr sz="1050" b="1">
+              <a:defRPr sz="1000" b="1">
                 <a:solidFill>
                   <a:srgbClr val="92400E"/>
                 </a:solidFill>
@@ -4760,8 +4845,8 @@
         </p:nvSpPr>
         <p:spPr>
           <a:xfrm>
-            <a:off x="8778240" y="4663440"/>
-            <a:ext cx="2499055" cy="365760"/>
+            <a:off x="6949440" y="4709160"/>
+            <a:ext cx="4327855" cy="365760"/>
           </a:xfrm>
           <a:prstGeom prst="rect">
             <a:avLst/>
@@ -4792,7 +4877,7 @@
           <a:lstStyle/>
           <a:p>
             <a:pPr algn="ctr">
-              <a:defRPr sz="950" b="1">
+              <a:defRPr sz="900" b="1">
                 <a:solidFill>
                   <a:srgbClr val="92400E"/>
                 </a:solidFill>
@@ -4800,7 +4885,7 @@
               </a:defRPr>
             </a:pPr>
             <a:r>
-              <a:t>READY FOR SELLER REVIEW (FLAGGED)</a:t>
+              <a:t>STATUS: READY FOR SELLER REVIEW (FLAGGED)</a:t>
             </a:r>
           </a:p>
         </p:txBody>
@@ -4813,8 +4898,8 @@
         </p:nvSpPr>
         <p:spPr>
           <a:xfrm>
-            <a:off x="8778240" y="5120640"/>
-            <a:ext cx="2499055" cy="411480"/>
+            <a:off x="6949440" y="5212080"/>
+            <a:ext cx="4327855" cy="502920"/>
           </a:xfrm>
           <a:prstGeom prst="rect">
             <a:avLst/>
@@ -4845,7 +4930,7 @@
           <a:lstStyle/>
           <a:p>
             <a:pPr algn="ctr">
-              <a:defRPr sz="1100" b="1">
+              <a:defRPr sz="1200" b="1">
                 <a:solidFill>
                   <a:srgbClr val="FFFFFF"/>
                 </a:solidFill>
@@ -5137,7 +5222,7 @@
               </a:defRPr>
             </a:pPr>
             <a:r>
-              <a:t>The return decision is made from memory, before the evidence is checked.</a:t>
+              <a:t>Sellers decide returns from memory today. ReturnLens assembles one trace before money moves.</a:t>
             </a:r>
           </a:p>
         </p:txBody>
@@ -5192,7 +5277,7 @@
               </a:defRPr>
             </a:pPr>
             <a:r>
-              <a:t>01 BUYER CHAT</a:t>
+              <a:t>01 BUYER VIDEO &amp; CLAIM</a:t>
             </a:r>
           </a:p>
           <a:p>
@@ -5205,7 +5290,7 @@
               </a:defRPr>
             </a:pPr>
             <a:r>
-              <a:t>“Received damaged item”</a:t>
+              <a:t>Unverified Customer Claims</a:t>
             </a:r>
           </a:p>
           <a:p>
@@ -5218,7 +5303,7 @@
               </a:defRPr>
             </a:pPr>
             <a:r>
-              <a:t>Buyer upload: 30–60s unboxing video + reason in support message</a:t>
+              <a:t>Subjective descriptions in chat; videos are unindexed and skipped</a:t>
             </a:r>
           </a:p>
         </p:txBody>
@@ -5286,7 +5371,7 @@
               </a:defRPr>
             </a:pPr>
             <a:r>
-              <a:t>Delivered 4 days ago</a:t>
+              <a:t>Delivered 4 Days Ago</a:t>
             </a:r>
           </a:p>
           <a:p>
@@ -5312,8 +5397,8 @@
         </p:nvSpPr>
         <p:spPr>
           <a:xfrm>
-            <a:off x="4297680" y="2377440"/>
-            <a:ext cx="3566160" cy="3657600"/>
+            <a:off x="4206240" y="2377440"/>
+            <a:ext cx="3779215" cy="3657600"/>
           </a:xfrm>
           <a:prstGeom prst="rect">
             <a:avLst/>
@@ -5359,11 +5444,24 @@
           </a:p>
           <a:p>
             <a:pPr algn="ctr">
-              <a:defRPr sz="1500" b="1">
+              <a:defRPr sz="1600" b="1">
                 <a:solidFill>
                   <a:srgbClr val="F5F3EF"/>
                 </a:solidFill>
                 <a:latin typeface="Inter"/>
+              </a:defRPr>
+            </a:pPr>
+            <a:r>
+              <a:t>Four systems. No traceable decision.</a:t>
+            </a:r>
+          </a:p>
+          <a:p>
+            <a:pPr algn="ctr">
+              <a:defRPr sz="1100" b="1">
+                <a:solidFill>
+                  <a:srgbClr val="00D1A7"/>
+                </a:solidFill>
+                <a:latin typeface="IBM Plex Mono"/>
               </a:defRPr>
             </a:pPr>
             <a:r>
@@ -5373,7 +5471,7 @@
           <a:p>
             <a:br/>
             <a:pPr algn="ctr">
-              <a:defRPr sz="1050">
+              <a:defRPr sz="1000">
                 <a:solidFill>
                   <a:srgbClr val="D1D5DB"/>
                 </a:solidFill>
@@ -5381,12 +5479,43 @@
               </a:defRPr>
             </a:pPr>
             <a:r>
-              <a:t>Today the seller opens 4 tabs, then decides alone. A wrong refund loses inventory; an unfair denial loses a customer.</a:t>
+              <a:t>Today the seller opens 4 tabs, then decides alone. A wrong refund loses inventory; an unfair denial loses a repeat customer.</a:t>
             </a:r>
             <a:br/>
             <a:br/>
             <a:r>
-              <a:t>The gap is that no single record ties order truth, video frames, policy clauses, and decisions together.</a:t>
+              <a:t>The gap is not a missing returns portal, but the absence of a unified record connecting order, video frames, courier scans, and policy terms.</a:t>
+            </a:r>
+          </a:p>
+          <a:p>
+            <a:br/>
+            <a:pPr algn="ctr">
+              <a:defRPr sz="1400" b="1">
+                <a:solidFill>
+                  <a:srgbClr val="D95D39"/>
+                </a:solidFill>
+                <a:latin typeface="Inter"/>
+              </a:defRPr>
+            </a:pPr>
+            <a:r>
+              <a:t>9.0% vs 15.14%</a:t>
+            </a:r>
+          </a:p>
+          <a:p>
+            <a:pPr algn="ctr">
+              <a:defRPr sz="850">
+                <a:solidFill>
+                  <a:srgbClr val="9CA3AF"/>
+                </a:solidFill>
+                <a:latin typeface="Inter"/>
+              </a:defRPr>
+            </a:pPr>
+            <a:r>
+              <a:t>9% Return Fraud (NRF 2025, fraud only)  |  15.14% (Appriss/Deloitte 2024, fraud + abuse)</a:t>
+            </a:r>
+            <a:br/>
+            <a:r>
+              <a:t>Definitions differ: strict fraud vs fraud combined with policy abuse.</a:t>
             </a:r>
           </a:p>
         </p:txBody>
@@ -5399,7 +5528,7 @@
         </p:nvSpPr>
         <p:spPr>
           <a:xfrm>
-            <a:off x="8138160" y="2377440"/>
+            <a:off x="8168335" y="2377440"/>
             <a:ext cx="3291840" cy="1737360"/>
           </a:xfrm>
           <a:prstGeom prst="rect">
@@ -5454,7 +5583,7 @@
               </a:defRPr>
             </a:pPr>
             <a:r>
-              <a:t>White Headphones · ₹1,499</a:t>
+              <a:t>White Headphones · ₹4,999</a:t>
             </a:r>
           </a:p>
           <a:p>
@@ -5480,7 +5609,7 @@
         </p:nvSpPr>
         <p:spPr>
           <a:xfrm>
-            <a:off x="8138160" y="4297680"/>
+            <a:off x="8168335" y="4297680"/>
             <a:ext cx="3291840" cy="1737360"/>
           </a:xfrm>
           <a:prstGeom prst="rect">
@@ -5760,7 +5889,7 @@
               </a:defRPr>
             </a:pPr>
             <a:r>
-              <a:t>VISUAL EVIDENCE BENCHMARK · CORE DEMONSTRATION</a:t>
+              <a:t>STAR DEMO · VISUAL GROUNDING &amp; COLOR CONTRADICTION</a:t>
             </a:r>
           </a:p>
         </p:txBody>
@@ -5832,7 +5961,7 @@
               </a:defRPr>
             </a:pPr>
             <a:r>
-              <a:t>ReturnLens surfaces the contradiction instead of auto-denying.</a:t>
+              <a:t>ReturnLens extracts keyframes, flags color discrepancies, and halts auto-payout for seller approval.</a:t>
             </a:r>
           </a:p>
         </p:txBody>
@@ -5846,7 +5975,7 @@
         <p:spPr>
           <a:xfrm>
             <a:off x="731520" y="2148840"/>
-            <a:ext cx="3383280" cy="4023360"/>
+            <a:ext cx="6766560" cy="3977639"/>
           </a:xfrm>
           <a:prstGeom prst="rect">
             <a:avLst/>
@@ -5882,40 +6011,122 @@
           </a:p>
         </p:txBody>
       </p:sp>
-      <p:pic>
-        <p:nvPicPr>
-          <p:cNvPr id="7" name="Picture 6" descr="demo_white_order.jpg"/>
-          <p:cNvPicPr>
-            <a:picLocks noChangeAspect="1"/>
-          </p:cNvPicPr>
-          <p:nvPr/>
-        </p:nvPicPr>
-        <p:blipFill>
-          <a:blip r:embed="rId2"/>
-          <a:stretch>
-            <a:fillRect/>
-          </a:stretch>
-        </p:blipFill>
-        <p:spPr>
-          <a:xfrm>
-            <a:off x="731520" y="2148840"/>
-            <a:ext cx="3383280" cy="2926080"/>
-          </a:xfrm>
-          <a:prstGeom prst="rect">
-            <a:avLst/>
-          </a:prstGeom>
-        </p:spPr>
-      </p:pic>
-      <p:sp>
-        <p:nvSpPr>
-          <p:cNvPr id="8" name="TextBox 7"/>
+      <p:sp>
+        <p:nvSpPr>
+          <p:cNvPr id="7" name="Rectangle 6"/>
+          <p:cNvSpPr/>
+          <p:nvPr/>
+        </p:nvSpPr>
+        <p:spPr>
+          <a:xfrm>
+            <a:off x="914400" y="4983480"/>
+            <a:ext cx="3108960" cy="320040"/>
+          </a:xfrm>
+          <a:prstGeom prst="rect">
+            <a:avLst/>
+          </a:prstGeom>
+          <a:solidFill>
+            <a:srgbClr val="E1F2EC"/>
+          </a:solidFill>
+          <a:ln>
+            <a:noFill/>
+          </a:ln>
+        </p:spPr>
+        <p:style>
+          <a:lnRef idx="1">
+            <a:schemeClr val="accent1"/>
+          </a:lnRef>
+          <a:fillRef idx="3">
+            <a:schemeClr val="accent1"/>
+          </a:fillRef>
+          <a:effectRef idx="2">
+            <a:schemeClr val="accent1"/>
+          </a:effectRef>
+          <a:fontRef idx="minor">
+            <a:schemeClr val="lt1"/>
+          </a:fontRef>
+        </p:style>
+        <p:txBody>
+          <a:bodyPr rtlCol="0" anchor="ctr"/>
+          <a:lstStyle/>
+          <a:p>
+            <a:pPr algn="ctr">
+              <a:defRPr sz="950" b="1">
+                <a:solidFill>
+                  <a:srgbClr val="006B55"/>
+                </a:solidFill>
+                <a:latin typeface="IBM Plex Mono"/>
+              </a:defRPr>
+            </a:pPr>
+            <a:r>
+              <a:t>ORDER MANIFEST: WHITE HEADPHONES</a:t>
+            </a:r>
+          </a:p>
+        </p:txBody>
+      </p:sp>
+      <p:sp>
+        <p:nvSpPr>
+          <p:cNvPr id="8" name="Rectangle 7"/>
+          <p:cNvSpPr/>
+          <p:nvPr/>
+        </p:nvSpPr>
+        <p:spPr>
+          <a:xfrm>
+            <a:off x="4206240" y="4983480"/>
+            <a:ext cx="3108960" cy="320040"/>
+          </a:xfrm>
+          <a:prstGeom prst="rect">
+            <a:avLst/>
+          </a:prstGeom>
+          <a:solidFill>
+            <a:srgbClr val="FCECE8"/>
+          </a:solidFill>
+          <a:ln>
+            <a:noFill/>
+          </a:ln>
+        </p:spPr>
+        <p:style>
+          <a:lnRef idx="1">
+            <a:schemeClr val="accent1"/>
+          </a:lnRef>
+          <a:fillRef idx="3">
+            <a:schemeClr val="accent1"/>
+          </a:fillRef>
+          <a:effectRef idx="2">
+            <a:schemeClr val="accent1"/>
+          </a:effectRef>
+          <a:fontRef idx="minor">
+            <a:schemeClr val="lt1"/>
+          </a:fontRef>
+        </p:style>
+        <p:txBody>
+          <a:bodyPr rtlCol="0" anchor="ctr"/>
+          <a:lstStyle/>
+          <a:p>
+            <a:pPr algn="ctr">
+              <a:defRPr sz="950" b="1">
+                <a:solidFill>
+                  <a:srgbClr val="D95D39"/>
+                </a:solidFill>
+                <a:latin typeface="IBM Plex Mono"/>
+              </a:defRPr>
+            </a:pPr>
+            <a:r>
+              <a:t>UNBOXING KEYFRAME 00:07: BLACK ITEM</a:t>
+            </a:r>
+          </a:p>
+        </p:txBody>
+      </p:sp>
+      <p:sp>
+        <p:nvSpPr>
+          <p:cNvPr id="9" name="TextBox 8"/>
           <p:cNvSpPr txBox="1"/>
           <p:nvPr/>
         </p:nvSpPr>
         <p:spPr>
           <a:xfrm>
-            <a:off x="822960" y="5120640"/>
-            <a:ext cx="3200400" cy="914400"/>
+            <a:off x="914400" y="5394960"/>
+            <a:ext cx="6400800" cy="640080"/>
           </a:xfrm>
           <a:prstGeom prst="rect">
             <a:avLst/>
@@ -5929,20 +6140,7 @@
           <a:lstStyle/>
           <a:p>
             <a:pPr>
-              <a:defRPr sz="950" b="1">
-                <a:solidFill>
-                  <a:srgbClr val="172621"/>
-                </a:solidFill>
-                <a:latin typeface="IBM Plex Mono"/>
-              </a:defRPr>
-            </a:pPr>
-            <a:r>
-              <a:t>ORDER RECORD · STORE GROUND TRUTH</a:t>
-            </a:r>
-          </a:p>
-          <a:p>
-            <a:pPr>
-              <a:defRPr sz="1000">
+              <a:defRPr sz="950">
                 <a:solidFill>
                   <a:srgbClr val="596E64"/>
                 </a:solidFill>
@@ -5950,25 +6148,21 @@
               </a:defRPr>
             </a:pPr>
             <a:r>
-              <a:t>HEAD-WHT-02 · Matte White · ₹1,499</a:t>
-            </a:r>
-            <a:br/>
-            <a:r>
-              <a:t>Delivered 4 days ago · Original tag present</a:t>
-            </a:r>
-          </a:p>
-        </p:txBody>
-      </p:sp>
-      <p:sp>
-        <p:nvSpPr>
-          <p:cNvPr id="9" name="Rectangle 8"/>
+              <a:t>Visual Grounding Honesty: Keyframe resolution reveals black casing. Exact SKU barcode is unreadable in this frame; ReturnLens factually records 'Observed Color: Black · Exact SKU: Not verified' and cites frame 00:07.</a:t>
+            </a:r>
+          </a:p>
+        </p:txBody>
+      </p:sp>
+      <p:sp>
+        <p:nvSpPr>
+          <p:cNvPr id="10" name="Rectangle 9"/>
           <p:cNvSpPr/>
           <p:nvPr/>
         </p:nvSpPr>
         <p:spPr>
           <a:xfrm>
-            <a:off x="4297680" y="2148840"/>
-            <a:ext cx="3383280" cy="4023360"/>
+            <a:off x="7726679" y="2148840"/>
+            <a:ext cx="3733495" cy="3977639"/>
           </a:xfrm>
           <a:prstGeom prst="rect">
             <a:avLst/>
@@ -6004,30 +6198,6 @@
           </a:p>
         </p:txBody>
       </p:sp>
-      <p:pic>
-        <p:nvPicPr>
-          <p:cNvPr id="10" name="Picture 9" descr="demo_black_frame.jpg"/>
-          <p:cNvPicPr>
-            <a:picLocks noChangeAspect="1"/>
-          </p:cNvPicPr>
-          <p:nvPr/>
-        </p:nvPicPr>
-        <p:blipFill>
-          <a:blip r:embed="rId3"/>
-          <a:stretch>
-            <a:fillRect/>
-          </a:stretch>
-        </p:blipFill>
-        <p:spPr>
-          <a:xfrm>
-            <a:off x="4297680" y="2148840"/>
-            <a:ext cx="3383280" cy="2926080"/>
-          </a:xfrm>
-          <a:prstGeom prst="rect">
-            <a:avLst/>
-          </a:prstGeom>
-        </p:spPr>
-      </p:pic>
       <p:sp>
         <p:nvSpPr>
           <p:cNvPr id="11" name="TextBox 10"/>
@@ -6036,8 +6206,8 @@
         </p:nvSpPr>
         <p:spPr>
           <a:xfrm>
-            <a:off x="4389120" y="5120640"/>
-            <a:ext cx="3200400" cy="914400"/>
+            <a:off x="7909559" y="2286000"/>
+            <a:ext cx="3367735" cy="3749039"/>
           </a:xfrm>
           <a:prstGeom prst="rect">
             <a:avLst/>
@@ -6053,274 +6223,56 @@
             <a:pPr>
               <a:defRPr sz="950" b="1">
                 <a:solidFill>
-                  <a:srgbClr val="172621"/>
+                  <a:srgbClr val="D95D39"/>
                 </a:solidFill>
                 <a:latin typeface="IBM Plex Mono"/>
               </a:defRPr>
             </a:pPr>
             <a:r>
-              <a:t>VIDEO FRAME · INTAKE TIMESTAMP 00:07</a:t>
+              <a:t>DETERMINISTIC POLICY GATE</a:t>
             </a:r>
           </a:p>
           <a:p>
             <a:pPr>
-              <a:defRPr sz="1000">
-                <a:solidFill>
-                  <a:srgbClr val="596E64"/>
+              <a:defRPr sz="1400" b="1">
+                <a:solidFill>
+                  <a:srgbClr val="991B1B"/>
                 </a:solidFill>
                 <a:latin typeface="Inter"/>
               </a:defRPr>
             </a:pPr>
             <a:r>
-              <a:t>Observed Color: Midnight Black</a:t>
+              <a:t>P-03 Check: COLOR CONTRADICTION</a:t>
+            </a:r>
+          </a:p>
+          <a:p>
+            <a:pPr>
+              <a:defRPr sz="850" b="1">
+                <a:solidFill>
+                  <a:srgbClr val="991B1B"/>
+                </a:solidFill>
+                <a:latin typeface="IBM Plex Mono"/>
+              </a:defRPr>
+            </a:pPr>
+            <a:r>
+              <a:t>STATUS: ESCALATE (SELLER REVIEW REQUIRED)</a:t>
             </a:r>
             <a:br/>
             <a:r>
-              <a:t>Exact SKU: Not verified · Tag: Not visible in cited frame</a:t>
-            </a:r>
-          </a:p>
-        </p:txBody>
-      </p:sp>
-      <p:sp>
-        <p:nvSpPr>
-          <p:cNvPr id="12" name="Rectangle 11"/>
-          <p:cNvSpPr/>
-          <p:nvPr/>
-        </p:nvSpPr>
-        <p:spPr>
-          <a:xfrm>
-            <a:off x="3383280" y="3474720"/>
-            <a:ext cx="1645920" cy="457200"/>
-          </a:xfrm>
-          <a:prstGeom prst="rect">
-            <a:avLst/>
-          </a:prstGeom>
-          <a:solidFill>
-            <a:srgbClr val="D95D39"/>
-          </a:solidFill>
-          <a:ln>
-            <a:noFill/>
-          </a:ln>
-        </p:spPr>
-        <p:style>
-          <a:lnRef idx="1">
-            <a:schemeClr val="accent1"/>
-          </a:lnRef>
-          <a:fillRef idx="3">
-            <a:schemeClr val="accent1"/>
-          </a:fillRef>
-          <a:effectRef idx="2">
-            <a:schemeClr val="accent1"/>
-          </a:effectRef>
-          <a:fontRef idx="minor">
-            <a:schemeClr val="lt1"/>
-          </a:fontRef>
-        </p:style>
-        <p:txBody>
-          <a:bodyPr rtlCol="0" anchor="ctr"/>
-          <a:lstStyle/>
-          <a:p>
-            <a:pPr algn="ctr">
-              <a:defRPr sz="1000" b="1">
-                <a:solidFill>
-                  <a:srgbClr val="FFFFFF"/>
-                </a:solidFill>
-                <a:latin typeface="IBM Plex Mono"/>
-              </a:defRPr>
-            </a:pPr>
-            <a:r>
-              <a:t>COLOR MISMATCH</a:t>
-            </a:r>
-          </a:p>
-        </p:txBody>
-      </p:sp>
-      <p:sp>
-        <p:nvSpPr>
-          <p:cNvPr id="13" name="Rectangle 12"/>
-          <p:cNvSpPr/>
-          <p:nvPr/>
-        </p:nvSpPr>
-        <p:spPr>
-          <a:xfrm>
-            <a:off x="7863840" y="2148840"/>
-            <a:ext cx="3596335" cy="4023360"/>
-          </a:xfrm>
-          <a:prstGeom prst="rect">
-            <a:avLst/>
-          </a:prstGeom>
-          <a:solidFill>
-            <a:srgbClr val="FFFFFF"/>
-          </a:solidFill>
-          <a:ln w="12700">
-            <a:solidFill>
-              <a:srgbClr val="E2DED4"/>
-            </a:solidFill>
-          </a:ln>
-        </p:spPr>
-        <p:style>
-          <a:lnRef idx="1">
-            <a:schemeClr val="accent1"/>
-          </a:lnRef>
-          <a:fillRef idx="3">
-            <a:schemeClr val="accent1"/>
-          </a:fillRef>
-          <a:effectRef idx="2">
-            <a:schemeClr val="accent1"/>
-          </a:effectRef>
-          <a:fontRef idx="minor">
-            <a:schemeClr val="lt1"/>
-          </a:fontRef>
-        </p:style>
-        <p:txBody>
-          <a:bodyPr rtlCol="0" anchor="ctr"/>
-          <a:lstStyle/>
-          <a:p>
-            <a:pPr algn="ctr"/>
-          </a:p>
-        </p:txBody>
-      </p:sp>
-      <p:sp>
-        <p:nvSpPr>
-          <p:cNvPr id="14" name="Rectangle 13"/>
-          <p:cNvSpPr/>
-          <p:nvPr/>
-        </p:nvSpPr>
-        <p:spPr>
-          <a:xfrm>
-            <a:off x="7863840" y="2148840"/>
-            <a:ext cx="73152" cy="4023360"/>
-          </a:xfrm>
-          <a:prstGeom prst="rect">
-            <a:avLst/>
-          </a:prstGeom>
-          <a:solidFill>
-            <a:srgbClr val="D95D39"/>
-          </a:solidFill>
-          <a:ln>
-            <a:noFill/>
-          </a:ln>
-        </p:spPr>
-        <p:style>
-          <a:lnRef idx="1">
-            <a:schemeClr val="accent1"/>
-          </a:lnRef>
-          <a:fillRef idx="3">
-            <a:schemeClr val="accent1"/>
-          </a:fillRef>
-          <a:effectRef idx="2">
-            <a:schemeClr val="accent1"/>
-          </a:effectRef>
-          <a:fontRef idx="minor">
-            <a:schemeClr val="lt1"/>
-          </a:fontRef>
-        </p:style>
-        <p:txBody>
-          <a:bodyPr rtlCol="0" anchor="ctr"/>
-          <a:lstStyle/>
-          <a:p>
-            <a:pPr algn="ctr"/>
-          </a:p>
-        </p:txBody>
-      </p:sp>
-      <p:sp>
-        <p:nvSpPr>
-          <p:cNvPr id="15" name="TextBox 14"/>
-          <p:cNvSpPr txBox="1"/>
-          <p:nvPr/>
-        </p:nvSpPr>
-        <p:spPr>
-          <a:xfrm>
-            <a:off x="8046720" y="2240280"/>
-            <a:ext cx="3200400" cy="3749039"/>
-          </a:xfrm>
-          <a:prstGeom prst="rect">
-            <a:avLst/>
-          </a:prstGeom>
-          <a:noFill/>
-        </p:spPr>
-        <p:txBody>
-          <a:bodyPr wrap="square">
-            <a:spAutoFit/>
-          </a:bodyPr>
-          <a:lstStyle/>
-          <a:p>
-            <a:pPr>
-              <a:defRPr sz="1000" b="1">
-                <a:solidFill>
-                  <a:srgbClr val="D95D39"/>
-                </a:solidFill>
-                <a:latin typeface="IBM Plex Mono"/>
-              </a:defRPr>
-            </a:pPr>
-            <a:r>
-              <a:t>DETERMINISTIC POLICY GATE</a:t>
-            </a:r>
-          </a:p>
-          <a:p>
-            <a:pPr>
-              <a:defRPr sz="1500" b="1">
-                <a:solidFill>
-                  <a:srgbClr val="172621"/>
-                </a:solidFill>
-                <a:latin typeface="Inter"/>
-              </a:defRPr>
-            </a:pPr>
-            <a:r>
-              <a:t>P-03 Check: COLOR MISMATCH</a:t>
-            </a:r>
-          </a:p>
-          <a:p>
-            <a:pPr>
-              <a:defRPr sz="1000">
-                <a:solidFill>
-                  <a:srgbClr val="596E64"/>
-                </a:solidFill>
-                <a:latin typeface="Inter"/>
-              </a:defRPr>
-            </a:pPr>
-            <a:r>
-              <a:t>Specification contradiction flagged against Shopify order manifest.</a:t>
-            </a:r>
-          </a:p>
-          <a:p>
-            <a:br/>
-            <a:pPr>
-              <a:defRPr sz="900" b="1">
-                <a:solidFill>
-                  <a:srgbClr val="006B55"/>
-                </a:solidFill>
-                <a:latin typeface="IBM Plex Mono"/>
-              </a:defRPr>
-            </a:pPr>
-            <a:r>
-              <a:t>typed JSON, requires_seller_approval: true</a:t>
-            </a:r>
-          </a:p>
-          <a:p>
-            <a:br/>
-            <a:pPr>
-              <a:defRPr sz="950" b="1">
-                <a:solidFill>
-                  <a:srgbClr val="991B1B"/>
-                </a:solidFill>
-                <a:latin typeface="IBM Plex Mono"/>
-              </a:defRPr>
-            </a:pPr>
-            <a:r>
-              <a:t>STATUS: ESCALATE (SELLER REVIEW REQUIRED)</a:t>
+              <a:t>Observed Color: Midnight Black · Exact SKU: Not verified</a:t>
             </a:r>
           </a:p>
           <a:p>
             <a:pPr>
               <a:defRPr sz="950">
                 <a:solidFill>
-                  <a:srgbClr val="991B1B"/>
+                  <a:srgbClr val="596E64"/>
                 </a:solidFill>
                 <a:latin typeface="Inter"/>
               </a:defRPr>
             </a:pPr>
             <a:r>
-              <a:t>Color mismatch observed · Exact SKU unconfirmed · No auto-denial.</a:t>
+              <a:t>Customer claim contradicts visual evidence. Automated return label and refund payout are inhibited.</a:t>
             </a:r>
           </a:p>
           <a:p>
@@ -6334,19 +6286,19 @@
               </a:defRPr>
             </a:pPr>
             <a:r>
-              <a:t>Seller Action Options:</a:t>
+              <a:t>Seller Resolution Options:</a:t>
             </a:r>
             <a:br/>
             <a:r>
-              <a:t>1. Accept as merchant mis-shipment (seller mistake)</a:t>
+              <a:t>1. Request unboxing video with packaging label / serial visible</a:t>
             </a:r>
             <a:br/>
             <a:r>
-              <a:t>2. Ask customer for outside-box shipping label (buyer mistake)</a:t>
+              <a:t>2. Reject return under Clause 4.2 (Item does not match order)</a:t>
             </a:r>
             <a:br/>
             <a:r>
-              <a:t>3. Hold return for physical inspection at warehouse (potential swap)</a:t>
+              <a:t>3. Override &amp; approve if seller acknowledges warehouse error</a:t>
             </a:r>
           </a:p>
           <a:p>
@@ -6356,22 +6308,26 @@
                 <a:solidFill>
                   <a:srgbClr val="596E64"/>
                 </a:solidFill>
-                <a:latin typeface="Inter"/>
-              </a:defRPr>
-            </a:pPr>
-            <a:r>
-              <a:t>Cap: 0 &lt; amount &lt;= min(₹4,999, remaining refundable amount, order paid amount)</a:t>
+                <a:latin typeface="IBM Plex Mono"/>
+              </a:defRPr>
+            </a:pPr>
+            <a:r>
+              <a:t>Financial Safety Ceiling:</a:t>
             </a:r>
             <a:br/>
             <a:r>
-              <a:t>No auto-denial · No refund released without seller click</a:t>
-            </a:r>
-          </a:p>
-        </p:txBody>
-      </p:sp>
-      <p:sp>
-        <p:nvSpPr>
-          <p:cNvPr id="16" name="Rectangle 15"/>
+              <a:t>max_refund = min(₹4,999, remaining refundable, order paid amount)</a:t>
+            </a:r>
+            <a:br/>
+            <a:r>
+              <a:t>No automatic customer denial · No refund released without seller click</a:t>
+            </a:r>
+          </a:p>
+        </p:txBody>
+      </p:sp>
+      <p:sp>
+        <p:nvSpPr>
+          <p:cNvPr id="12" name="Rectangle 11"/>
           <p:cNvSpPr/>
           <p:nvPr/>
         </p:nvSpPr>
@@ -6414,7 +6370,7 @@
       </p:sp>
       <p:sp>
         <p:nvSpPr>
-          <p:cNvPr id="17" name="TextBox 16"/>
+          <p:cNvPr id="13" name="TextBox 12"/>
           <p:cNvSpPr txBox="1"/>
           <p:nvPr/>
         </p:nvSpPr>
@@ -6450,7 +6406,7 @@
       </p:sp>
       <p:sp>
         <p:nvSpPr>
-          <p:cNvPr id="18" name="TextBox 17"/>
+          <p:cNvPr id="14" name="TextBox 13"/>
           <p:cNvSpPr txBox="1"/>
           <p:nvPr/>
         </p:nvSpPr>
@@ -6576,7 +6532,7 @@
               </a:defRPr>
             </a:pPr>
             <a:r>
-              <a:t>SYSTEM ARCHITECTURE · DETERMINISTIC PIPELINE</a:t>
+              <a:t>SYSTEM ARCHITECTURE · DYNAMIC AGENTIC GOVERNANCE</a:t>
             </a:r>
           </a:p>
         </p:txBody>
@@ -6589,8 +6545,8 @@
         </p:nvSpPr>
         <p:spPr>
           <a:xfrm>
-            <a:off x="731520" y="868680"/>
-            <a:ext cx="10698480" cy="731520"/>
+            <a:off x="731520" y="822960"/>
+            <a:ext cx="10698480" cy="640080"/>
           </a:xfrm>
           <a:prstGeom prst="rect">
             <a:avLst/>
@@ -6625,8 +6581,8 @@
         </p:nvSpPr>
         <p:spPr>
           <a:xfrm>
-            <a:off x="731520" y="1600200"/>
-            <a:ext cx="10698480" cy="457200"/>
+            <a:off x="731520" y="1417320"/>
+            <a:ext cx="10698480" cy="411480"/>
           </a:xfrm>
           <a:prstGeom prst="rect">
             <a:avLst/>
@@ -6640,7 +6596,7 @@
           <a:lstStyle/>
           <a:p>
             <a:pPr>
-              <a:defRPr sz="1900">
+              <a:defRPr sz="1800">
                 <a:solidFill>
                   <a:srgbClr val="A3B8B0"/>
                 </a:solidFill>
@@ -6648,7 +6604,7 @@
               </a:defRPr>
             </a:pPr>
             <a:r>
-              <a:t>Policy checks and seller approval control actions.</a:t>
+              <a:t>Dynamic action selection and stateful resumption under deterministic human authorization.</a:t>
             </a:r>
           </a:p>
         </p:txBody>
@@ -6661,8 +6617,8 @@
         </p:nvSpPr>
         <p:spPr>
           <a:xfrm>
-            <a:off x="731520" y="2148840"/>
-            <a:ext cx="1600200" cy="1188720"/>
+            <a:off x="731520" y="1874519"/>
+            <a:ext cx="1600200" cy="1051560"/>
           </a:xfrm>
           <a:prstGeom prst="rect">
             <a:avLst/>
@@ -6708,7 +6664,7 @@
           </a:p>
           <a:p>
             <a:pPr>
-              <a:defRPr sz="1150" b="1">
+              <a:defRPr sz="1100" b="1">
                 <a:solidFill>
                   <a:srgbClr val="F5F3EF"/>
                 </a:solidFill>
@@ -6729,7 +6685,7 @@
         </p:nvSpPr>
         <p:spPr>
           <a:xfrm>
-            <a:off x="731520" y="2148840"/>
+            <a:off x="731520" y="1874519"/>
             <a:ext cx="1600200" cy="36576"/>
           </a:xfrm>
           <a:prstGeom prst="rect">
@@ -6772,8 +6728,8 @@
         </p:nvSpPr>
         <p:spPr>
           <a:xfrm>
-            <a:off x="822960" y="2953512"/>
-            <a:ext cx="1417320" cy="256032"/>
+            <a:off x="822960" y="2587751"/>
+            <a:ext cx="1417320" cy="237744"/>
           </a:xfrm>
           <a:prstGeom prst="rect">
             <a:avLst/>
@@ -6825,7 +6781,7 @@
         </p:nvSpPr>
         <p:spPr>
           <a:xfrm>
-            <a:off x="2331720" y="2514600"/>
+            <a:off x="2331720" y="2194559"/>
             <a:ext cx="219456" cy="365760"/>
           </a:xfrm>
           <a:prstGeom prst="rect">
@@ -6861,8 +6817,8 @@
         </p:nvSpPr>
         <p:spPr>
           <a:xfrm>
-            <a:off x="2551176" y="2148840"/>
-            <a:ext cx="1600200" cy="1188720"/>
+            <a:off x="2551176" y="1874519"/>
+            <a:ext cx="1600200" cy="1051560"/>
           </a:xfrm>
           <a:prstGeom prst="rect">
             <a:avLst/>
@@ -6908,7 +6864,7 @@
           </a:p>
           <a:p>
             <a:pPr>
-              <a:defRPr sz="1150" b="1">
+              <a:defRPr sz="1100" b="1">
                 <a:solidFill>
                   <a:srgbClr val="F5F3EF"/>
                 </a:solidFill>
@@ -6929,7 +6885,7 @@
         </p:nvSpPr>
         <p:spPr>
           <a:xfrm>
-            <a:off x="2551176" y="2148840"/>
+            <a:off x="2551176" y="1874519"/>
             <a:ext cx="1600200" cy="36576"/>
           </a:xfrm>
           <a:prstGeom prst="rect">
@@ -6972,8 +6928,8 @@
         </p:nvSpPr>
         <p:spPr>
           <a:xfrm>
-            <a:off x="2642616" y="2953512"/>
-            <a:ext cx="1417320" cy="256032"/>
+            <a:off x="2642616" y="2587751"/>
+            <a:ext cx="1417320" cy="237744"/>
           </a:xfrm>
           <a:prstGeom prst="rect">
             <a:avLst/>
@@ -7025,7 +6981,7 @@
         </p:nvSpPr>
         <p:spPr>
           <a:xfrm>
-            <a:off x="4151376" y="2514600"/>
+            <a:off x="4151376" y="2194559"/>
             <a:ext cx="219456" cy="365760"/>
           </a:xfrm>
           <a:prstGeom prst="rect">
@@ -7061,8 +7017,8 @@
         </p:nvSpPr>
         <p:spPr>
           <a:xfrm>
-            <a:off x="4370832" y="2148840"/>
-            <a:ext cx="1600200" cy="1188720"/>
+            <a:off x="4370832" y="1874519"/>
+            <a:ext cx="1600200" cy="1051560"/>
           </a:xfrm>
           <a:prstGeom prst="rect">
             <a:avLst/>
@@ -7108,7 +7064,7 @@
           </a:p>
           <a:p>
             <a:pPr>
-              <a:defRPr sz="1150" b="1">
+              <a:defRPr sz="1100" b="1">
                 <a:solidFill>
                   <a:srgbClr val="F5F3EF"/>
                 </a:solidFill>
@@ -7129,7 +7085,7 @@
         </p:nvSpPr>
         <p:spPr>
           <a:xfrm>
-            <a:off x="4370832" y="2148840"/>
+            <a:off x="4370832" y="1874519"/>
             <a:ext cx="1600200" cy="36576"/>
           </a:xfrm>
           <a:prstGeom prst="rect">
@@ -7172,8 +7128,8 @@
         </p:nvSpPr>
         <p:spPr>
           <a:xfrm>
-            <a:off x="4462272" y="2953512"/>
-            <a:ext cx="1417320" cy="256032"/>
+            <a:off x="4462272" y="2587751"/>
+            <a:ext cx="1417320" cy="237744"/>
           </a:xfrm>
           <a:prstGeom prst="rect">
             <a:avLst/>
@@ -7225,7 +7181,7 @@
         </p:nvSpPr>
         <p:spPr>
           <a:xfrm>
-            <a:off x="5971032" y="2514600"/>
+            <a:off x="5971032" y="2194559"/>
             <a:ext cx="219456" cy="365760"/>
           </a:xfrm>
           <a:prstGeom prst="rect">
@@ -7261,8 +7217,8 @@
         </p:nvSpPr>
         <p:spPr>
           <a:xfrm>
-            <a:off x="6190488" y="2148840"/>
-            <a:ext cx="1600200" cy="1188720"/>
+            <a:off x="6190488" y="1874519"/>
+            <a:ext cx="1600200" cy="1051560"/>
           </a:xfrm>
           <a:prstGeom prst="rect">
             <a:avLst/>
@@ -7308,7 +7264,7 @@
           </a:p>
           <a:p>
             <a:pPr>
-              <a:defRPr sz="1150" b="1">
+              <a:defRPr sz="1100" b="1">
                 <a:solidFill>
                   <a:srgbClr val="F5F3EF"/>
                 </a:solidFill>
@@ -7329,7 +7285,7 @@
         </p:nvSpPr>
         <p:spPr>
           <a:xfrm>
-            <a:off x="6190488" y="2148840"/>
+            <a:off x="6190488" y="1874519"/>
             <a:ext cx="1600200" cy="36576"/>
           </a:xfrm>
           <a:prstGeom prst="rect">
@@ -7372,8 +7328,8 @@
         </p:nvSpPr>
         <p:spPr>
           <a:xfrm>
-            <a:off x="6281928" y="2953512"/>
-            <a:ext cx="1417320" cy="256032"/>
+            <a:off x="6281928" y="2587751"/>
+            <a:ext cx="1417320" cy="237744"/>
           </a:xfrm>
           <a:prstGeom prst="rect">
             <a:avLst/>
@@ -7425,7 +7381,7 @@
         </p:nvSpPr>
         <p:spPr>
           <a:xfrm>
-            <a:off x="7790688" y="2514600"/>
+            <a:off x="7790688" y="2194559"/>
             <a:ext cx="219456" cy="365760"/>
           </a:xfrm>
           <a:prstGeom prst="rect">
@@ -7461,8 +7417,8 @@
         </p:nvSpPr>
         <p:spPr>
           <a:xfrm>
-            <a:off x="8010144" y="2148840"/>
-            <a:ext cx="1600200" cy="1188720"/>
+            <a:off x="8010144" y="1874519"/>
+            <a:ext cx="1600200" cy="1051560"/>
           </a:xfrm>
           <a:prstGeom prst="rect">
             <a:avLst/>
@@ -7508,7 +7464,7 @@
           </a:p>
           <a:p>
             <a:pPr>
-              <a:defRPr sz="1150" b="1">
+              <a:defRPr sz="1100" b="1">
                 <a:solidFill>
                   <a:srgbClr val="F5F3EF"/>
                 </a:solidFill>
@@ -7529,7 +7485,7 @@
         </p:nvSpPr>
         <p:spPr>
           <a:xfrm>
-            <a:off x="8010144" y="2148840"/>
+            <a:off x="8010144" y="1874519"/>
             <a:ext cx="1600200" cy="36576"/>
           </a:xfrm>
           <a:prstGeom prst="rect">
@@ -7572,8 +7528,8 @@
         </p:nvSpPr>
         <p:spPr>
           <a:xfrm>
-            <a:off x="8101584" y="2953512"/>
-            <a:ext cx="1417320" cy="256032"/>
+            <a:off x="8101584" y="2587751"/>
+            <a:ext cx="1417320" cy="237744"/>
           </a:xfrm>
           <a:prstGeom prst="rect">
             <a:avLst/>
@@ -7625,7 +7581,7 @@
         </p:nvSpPr>
         <p:spPr>
           <a:xfrm>
-            <a:off x="9610344" y="2514600"/>
+            <a:off x="9610344" y="2194559"/>
             <a:ext cx="219456" cy="365760"/>
           </a:xfrm>
           <a:prstGeom prst="rect">
@@ -7661,8 +7617,8 @@
         </p:nvSpPr>
         <p:spPr>
           <a:xfrm>
-            <a:off x="9829800" y="2148840"/>
-            <a:ext cx="1600200" cy="1188720"/>
+            <a:off x="9829800" y="1874519"/>
+            <a:ext cx="1600200" cy="1051560"/>
           </a:xfrm>
           <a:prstGeom prst="rect">
             <a:avLst/>
@@ -7708,7 +7664,7 @@
           </a:p>
           <a:p>
             <a:pPr>
-              <a:defRPr sz="1150" b="1">
+              <a:defRPr sz="1100" b="1">
                 <a:solidFill>
                   <a:srgbClr val="F5F3EF"/>
                 </a:solidFill>
@@ -7729,7 +7685,7 @@
         </p:nvSpPr>
         <p:spPr>
           <a:xfrm>
-            <a:off x="9829800" y="2148840"/>
+            <a:off x="9829800" y="1874519"/>
             <a:ext cx="1600200" cy="36576"/>
           </a:xfrm>
           <a:prstGeom prst="rect">
@@ -7772,8 +7728,8 @@
         </p:nvSpPr>
         <p:spPr>
           <a:xfrm>
-            <a:off x="9921240" y="2953512"/>
-            <a:ext cx="1417320" cy="256032"/>
+            <a:off x="9921240" y="2587751"/>
+            <a:ext cx="1417320" cy="237744"/>
           </a:xfrm>
           <a:prstGeom prst="rect">
             <a:avLst/>
@@ -7825,8 +7781,8 @@
         </p:nvSpPr>
         <p:spPr>
           <a:xfrm>
-            <a:off x="731520" y="3474720"/>
-            <a:ext cx="10728655" cy="365760"/>
+            <a:off x="731520" y="3063240"/>
+            <a:ext cx="5943600" cy="777240"/>
           </a:xfrm>
           <a:prstGeom prst="rect">
             <a:avLst/>
@@ -7834,9 +7790,9 @@
           <a:solidFill>
             <a:srgbClr val="14221D"/>
           </a:solidFill>
-          <a:ln>
+          <a:ln w="12700">
             <a:solidFill>
-              <a:srgbClr val="223830"/>
+              <a:srgbClr val="2563EB"/>
             </a:solidFill>
           </a:ln>
         </p:spPr>
@@ -7855,19 +7811,32 @@
           </a:fontRef>
         </p:style>
         <p:txBody>
-          <a:bodyPr rtlCol="0" anchor="ctr"/>
+          <a:bodyPr rtlCol="0" anchor="ctr" wrap="square"/>
           <a:lstStyle/>
           <a:p>
             <a:pPr algn="ctr">
-              <a:defRPr sz="950">
-                <a:solidFill>
-                  <a:srgbClr val="A3B8B0"/>
+              <a:defRPr sz="850" b="1">
+                <a:solidFill>
+                  <a:srgbClr val="93C5FD"/>
                 </a:solidFill>
                 <a:latin typeface="IBM Plex Mono"/>
               </a:defRPr>
             </a:pPr>
             <a:r>
-              <a:t>SECONDARY PS-04 ROUTE:  Customer: “Where is my order?” → Mock Store API → Courier Scan → Instant Delivery Timestamp (Zero-Vision Fast Path)</a:t>
+              <a:t>DYNAMIC STATEFUL CLARIFICATION LOOP (CASE C) · Observe → Decide → Act → Wait → Resume</a:t>
+            </a:r>
+          </a:p>
+          <a:p>
+            <a:pPr>
+              <a:defRPr sz="950" b="1">
+                <a:solidFill>
+                  <a:srgbClr val="F5F3EF"/>
+                </a:solidFill>
+                <a:latin typeface="Inter"/>
+              </a:defRPr>
+            </a:pPr>
+            <a:r>
+              <a:t>Dark Frames → ask_for_evidence() → WAITING_FOR_EVIDENCE → Customer Uploads → Resume Case</a:t>
             </a:r>
           </a:p>
         </p:txBody>
@@ -7875,6 +7844,74 @@
       <p:sp>
         <p:nvSpPr>
           <p:cNvPr id="30" name="Rectangle 29"/>
+          <p:cNvSpPr/>
+          <p:nvPr/>
+        </p:nvSpPr>
+        <p:spPr>
+          <a:xfrm>
+            <a:off x="6812280" y="3063240"/>
+            <a:ext cx="4647895" cy="777240"/>
+          </a:xfrm>
+          <a:prstGeom prst="rect">
+            <a:avLst/>
+          </a:prstGeom>
+          <a:solidFill>
+            <a:srgbClr val="14221D"/>
+          </a:solidFill>
+          <a:ln w="12700">
+            <a:solidFill>
+              <a:srgbClr val="059669"/>
+            </a:solidFill>
+          </a:ln>
+        </p:spPr>
+        <p:style>
+          <a:lnRef idx="1">
+            <a:schemeClr val="accent1"/>
+          </a:lnRef>
+          <a:fillRef idx="3">
+            <a:schemeClr val="accent1"/>
+          </a:fillRef>
+          <a:effectRef idx="2">
+            <a:schemeClr val="accent1"/>
+          </a:effectRef>
+          <a:fontRef idx="minor">
+            <a:schemeClr val="lt1"/>
+          </a:fontRef>
+        </p:style>
+        <p:txBody>
+          <a:bodyPr rtlCol="0" anchor="ctr" wrap="square"/>
+          <a:lstStyle/>
+          <a:p>
+            <a:pPr algn="ctr">
+              <a:defRPr sz="850" b="1">
+                <a:solidFill>
+                  <a:srgbClr val="34D399"/>
+                </a:solidFill>
+                <a:latin typeface="IBM Plex Mono"/>
+              </a:defRPr>
+            </a:pPr>
+            <a:r>
+              <a:t>ORDER STATUS FAST PATH (PS-04 FIT) · Zero-Vision Direct Route</a:t>
+            </a:r>
+          </a:p>
+          <a:p>
+            <a:pPr>
+              <a:defRPr sz="950" b="1">
+                <a:solidFill>
+                  <a:srgbClr val="F5F3EF"/>
+                </a:solidFill>
+                <a:latin typeface="Inter"/>
+              </a:defRPr>
+            </a:pPr>
+            <a:r>
+              <a:t>“Where is my order?” → Query Store &amp; Shippo APIs → Delivery Scan &amp; Time</a:t>
+            </a:r>
+          </a:p>
+        </p:txBody>
+      </p:sp>
+      <p:sp>
+        <p:nvSpPr>
+          <p:cNvPr id="31" name="Rectangle 30"/>
           <p:cNvSpPr/>
           <p:nvPr/>
         </p:nvSpPr>
@@ -7942,7 +7979,7 @@
       </p:sp>
       <p:sp>
         <p:nvSpPr>
-          <p:cNvPr id="31" name="Rectangle 30"/>
+          <p:cNvPr id="32" name="Rectangle 31"/>
           <p:cNvSpPr/>
           <p:nvPr/>
         </p:nvSpPr>
@@ -8010,7 +8047,7 @@
       </p:sp>
       <p:sp>
         <p:nvSpPr>
-          <p:cNvPr id="32" name="Rectangle 31"/>
+          <p:cNvPr id="33" name="Rectangle 32"/>
           <p:cNvSpPr/>
           <p:nvPr/>
         </p:nvSpPr>
@@ -8078,7 +8115,7 @@
       </p:sp>
       <p:sp>
         <p:nvSpPr>
-          <p:cNvPr id="33" name="Rectangle 32"/>
+          <p:cNvPr id="34" name="Rectangle 33"/>
           <p:cNvSpPr/>
           <p:nvPr/>
         </p:nvSpPr>
@@ -8146,7 +8183,7 @@
       </p:sp>
       <p:sp>
         <p:nvSpPr>
-          <p:cNvPr id="34" name="Rectangle 33"/>
+          <p:cNvPr id="35" name="Rectangle 34"/>
           <p:cNvSpPr/>
           <p:nvPr/>
         </p:nvSpPr>
@@ -8186,7 +8223,7 @@
           <a:lstStyle/>
           <a:p>
             <a:pPr algn="ctr">
-              <a:defRPr sz="900">
+              <a:defRPr sz="850">
                 <a:solidFill>
                   <a:srgbClr val="A3B8B0"/>
                 </a:solidFill>
@@ -8194,12 +8231,12 @@
               </a:defRPr>
             </a:pPr>
             <a:r>
-              <a:t>■ Model Calls: Exactly 3 base calls per case (planner, vision, critic) plus retries  |  ■ Policy Clauses: Deterministic Python code rules P-01 to P-08, never prompts</a:t>
+              <a:t>■ Model Calls: Bounded design estimate (3 base calls: planner, vision, critic + retries)  |  ■ Policy Rules: Deterministic Python code rules P-01 to P-08, never prompts</a:t>
             </a:r>
           </a:p>
           <a:p>
             <a:pPr>
-              <a:defRPr sz="900">
+              <a:defRPr sz="850">
                 <a:solidFill>
                   <a:srgbClr val="A3B8B0"/>
                 </a:solidFill>
@@ -8207,14 +8244,14 @@
               </a:defRPr>
             </a:pPr>
             <a:r>
-              <a:t>■ Critic Duty: The critic reviews cited frames and flags unsupported observations  |  ■ Safety: Prompt injection cannot alter policy code or bypass human gate</a:t>
-            </a:r>
-          </a:p>
-        </p:txBody>
-      </p:sp>
-      <p:sp>
-        <p:nvSpPr>
-          <p:cNvPr id="35" name="Rectangle 34"/>
+              <a:t>■ Critic Duty: Reviews cited frames, flags unsupported observations (correlated error limits noted)  |  ■ Safety Boundary: Backend authorization check — LLMs cannot execute financial refunds</a:t>
+            </a:r>
+          </a:p>
+        </p:txBody>
+      </p:sp>
+      <p:sp>
+        <p:nvSpPr>
+          <p:cNvPr id="36" name="Rectangle 35"/>
           <p:cNvSpPr/>
           <p:nvPr/>
         </p:nvSpPr>
@@ -8257,7 +8294,7 @@
       </p:sp>
       <p:sp>
         <p:nvSpPr>
-          <p:cNvPr id="36" name="TextBox 35"/>
+          <p:cNvPr id="37" name="TextBox 36"/>
           <p:cNvSpPr txBox="1"/>
           <p:nvPr/>
         </p:nvSpPr>
@@ -8293,7 +8330,7 @@
       </p:sp>
       <p:sp>
         <p:nvSpPr>
-          <p:cNvPr id="37" name="TextBox 36"/>
+          <p:cNvPr id="38" name="TextBox 37"/>
           <p:cNvSpPr txBox="1"/>
           <p:nvPr/>
         </p:nvSpPr>
@@ -8419,7 +8456,7 @@
               </a:defRPr>
             </a:pPr>
             <a:r>
-              <a:t>DEMO SCENARIOS · GROUNDED VERIFICATION</a:t>
+              <a:t>DEMO SCENARIOS · CONTROLLED PROTOTYPE BEHAVIORS</a:t>
             </a:r>
           </a:p>
         </p:txBody>
@@ -8491,7 +8528,7 @@
               </a:defRPr>
             </a:pPr>
             <a:r>
-              <a:t>Every decision can be clicked back to a frame, a clause, and a log entry.</a:t>
+              <a:t>Expected prototype behaviors across staged benchmark cases. Not measured production metrics.</a:t>
             </a:r>
           </a:p>
         </p:txBody>
@@ -8550,7 +8587,7 @@
         <p:spPr>
           <a:xfrm>
             <a:off x="914400" y="2368296"/>
-            <a:ext cx="1554480" cy="420624"/>
+            <a:ext cx="1645920" cy="420624"/>
           </a:xfrm>
           <a:prstGeom prst="rect">
             <a:avLst/>
@@ -8581,7 +8618,7 @@
           <a:lstStyle/>
           <a:p>
             <a:pPr algn="ctr">
-              <a:defRPr sz="1000" b="1">
+              <a:defRPr sz="950" b="1">
                 <a:solidFill>
                   <a:srgbClr val="006B55"/>
                 </a:solidFill>
@@ -8602,8 +8639,8 @@
         </p:nvSpPr>
         <p:spPr>
           <a:xfrm>
-            <a:off x="2651760" y="2258568"/>
-            <a:ext cx="4023360" cy="640080"/>
+            <a:off x="2743200" y="2258568"/>
+            <a:ext cx="3931920" cy="640080"/>
           </a:xfrm>
           <a:prstGeom prst="rect">
             <a:avLst/>
@@ -8617,7 +8654,7 @@
           <a:lstStyle/>
           <a:p>
             <a:pPr>
-              <a:defRPr sz="1100" b="1">
+              <a:defRPr sz="1050" b="1">
                 <a:solidFill>
                   <a:srgbClr val="172621"/>
                 </a:solidFill>
@@ -8625,7 +8662,7 @@
               </a:defRPr>
             </a:pPr>
             <a:r>
-              <a:t>ORD-1042 (₹1,499) · SKU matches manifest, tag visible, defect confirmed within 7-day window.</a:t>
+              <a:t>Verified Damage · Staged cosmetic crack, timestamp 00:04 · Defect verified.</a:t>
             </a:r>
           </a:p>
         </p:txBody>
@@ -8638,7 +8675,7 @@
         </p:nvSpPr>
         <p:spPr>
           <a:xfrm>
-            <a:off x="6675120" y="2295144"/>
+            <a:off x="6720840" y="2295144"/>
             <a:ext cx="274320" cy="457200"/>
           </a:xfrm>
           <a:prstGeom prst="rect">
@@ -8674,8 +8711,8 @@
         </p:nvSpPr>
         <p:spPr>
           <a:xfrm>
-            <a:off x="7040880" y="2258568"/>
-            <a:ext cx="4297680" cy="640080"/>
+            <a:off x="7086600" y="2258568"/>
+            <a:ext cx="4206240" cy="640080"/>
           </a:xfrm>
           <a:prstGeom prst="rect">
             <a:avLst/>
@@ -8689,7 +8726,7 @@
           <a:lstStyle/>
           <a:p>
             <a:pPr>
-              <a:defRPr sz="1100">
+              <a:defRPr sz="1050">
                 <a:solidFill>
                   <a:srgbClr val="596E64"/>
                 </a:solidFill>
@@ -8697,7 +8734,7 @@
               </a:defRPr>
             </a:pPr>
             <a:r>
-              <a:t>Seller approval releases mock return label and refund draft in pending_return_receipt, not executed refund.</a:t>
+              <a:t>Agent prepares mock label &amp; draft refund in pending_return_receipt; seller one-click confirms.</a:t>
             </a:r>
           </a:p>
         </p:txBody>
@@ -8756,7 +8793,7 @@
         <p:spPr>
           <a:xfrm>
             <a:off x="914400" y="3364992"/>
-            <a:ext cx="1554480" cy="420624"/>
+            <a:ext cx="1645920" cy="420624"/>
           </a:xfrm>
           <a:prstGeom prst="rect">
             <a:avLst/>
@@ -8787,7 +8824,7 @@
           <a:lstStyle/>
           <a:p>
             <a:pPr algn="ctr">
-              <a:defRPr sz="1000" b="1">
+              <a:defRPr sz="950" b="1">
                 <a:solidFill>
                   <a:srgbClr val="991B1B"/>
                 </a:solidFill>
@@ -8808,8 +8845,8 @@
         </p:nvSpPr>
         <p:spPr>
           <a:xfrm>
-            <a:off x="2651760" y="3255264"/>
-            <a:ext cx="4023360" cy="640080"/>
+            <a:off x="2743200" y="3255264"/>
+            <a:ext cx="3931920" cy="640080"/>
           </a:xfrm>
           <a:prstGeom prst="rect">
             <a:avLst/>
@@ -8823,7 +8860,7 @@
           <a:lstStyle/>
           <a:p>
             <a:pPr>
-              <a:defRPr sz="1100" b="1">
+              <a:defRPr sz="1050" b="1">
                 <a:solidFill>
                   <a:srgbClr val="172621"/>
                 </a:solidFill>
@@ -8831,7 +8868,7 @@
               </a:defRPr>
             </a:pPr>
             <a:r>
-              <a:t>HEAD-WHT-02 (White) ordered vs Frame 00:07 showing Black item · SKU unverified.</a:t>
+              <a:t>Color Contradiction · HEAD-WHT-02 (White) ordered vs Frame 00:07 Black item · SKU unverified.</a:t>
             </a:r>
           </a:p>
         </p:txBody>
@@ -8844,7 +8881,7 @@
         </p:nvSpPr>
         <p:spPr>
           <a:xfrm>
-            <a:off x="6675120" y="3291840"/>
+            <a:off x="6720840" y="3291840"/>
             <a:ext cx="274320" cy="457200"/>
           </a:xfrm>
           <a:prstGeom prst="rect">
@@ -8880,8 +8917,8 @@
         </p:nvSpPr>
         <p:spPr>
           <a:xfrm>
-            <a:off x="7040880" y="3255264"/>
-            <a:ext cx="4297680" cy="640080"/>
+            <a:off x="7086600" y="3255264"/>
+            <a:ext cx="4206240" cy="640080"/>
           </a:xfrm>
           <a:prstGeom prst="rect">
             <a:avLst/>
@@ -8895,7 +8932,7 @@
           <a:lstStyle/>
           <a:p>
             <a:pPr>
-              <a:defRPr sz="1100">
+              <a:defRPr sz="1050">
                 <a:solidFill>
                   <a:srgbClr val="596E64"/>
                 </a:solidFill>
@@ -8903,7 +8940,7 @@
               </a:defRPr>
             </a:pPr>
             <a:r>
-              <a:t>ESCALATE (no label, no refund, no denial). Seller options: mis-shipment / box label / physical inspection.</a:t>
+              <a:t>P-03 contradiction blocks automation; seller selects 1 of 3 options: mis-shipment / box label / warehouse inspection.</a:t>
             </a:r>
           </a:p>
         </p:txBody>
@@ -8962,7 +8999,7 @@
         <p:spPr>
           <a:xfrm>
             <a:off x="914400" y="4361688"/>
-            <a:ext cx="1554480" cy="420624"/>
+            <a:ext cx="1645920" cy="420624"/>
           </a:xfrm>
           <a:prstGeom prst="rect">
             <a:avLst/>
@@ -8993,7 +9030,7 @@
           <a:lstStyle/>
           <a:p>
             <a:pPr algn="ctr">
-              <a:defRPr sz="1000" b="1">
+              <a:defRPr sz="950" b="1">
                 <a:solidFill>
                   <a:srgbClr val="1E40AF"/>
                 </a:solidFill>
@@ -9014,8 +9051,8 @@
         </p:nvSpPr>
         <p:spPr>
           <a:xfrm>
-            <a:off x="2651760" y="4251960"/>
-            <a:ext cx="4023360" cy="640080"/>
+            <a:off x="2743200" y="4251960"/>
+            <a:ext cx="3931920" cy="640080"/>
           </a:xfrm>
           <a:prstGeom prst="rect">
             <a:avLst/>
@@ -9029,7 +9066,7 @@
           <a:lstStyle/>
           <a:p>
             <a:pPr>
-              <a:defRPr sz="1100" b="1">
+              <a:defRPr sz="1050" b="1">
                 <a:solidFill>
                   <a:srgbClr val="172621"/>
                 </a:solidFill>
@@ -9037,7 +9074,7 @@
               </a:defRPr>
             </a:pPr>
             <a:r>
-              <a:t>4-second dark video, brightness 28, only 2 usable frames · Unclear evidence check.</a:t>
+              <a:t>Insufficient Visibility · 4-second dark video, brightness 28, only 2 usable frames.</a:t>
             </a:r>
           </a:p>
         </p:txBody>
@@ -9050,7 +9087,7 @@
         </p:nvSpPr>
         <p:spPr>
           <a:xfrm>
-            <a:off x="6675120" y="4288536"/>
+            <a:off x="6720840" y="4288536"/>
             <a:ext cx="274320" cy="457200"/>
           </a:xfrm>
           <a:prstGeom prst="rect">
@@ -9086,8 +9123,8 @@
         </p:nvSpPr>
         <p:spPr>
           <a:xfrm>
-            <a:off x="7040880" y="4251960"/>
-            <a:ext cx="4297680" cy="640080"/>
+            <a:off x="7086600" y="4251960"/>
+            <a:ext cx="4206240" cy="640080"/>
           </a:xfrm>
           <a:prstGeom prst="rect">
             <a:avLst/>
@@ -9101,7 +9138,7 @@
           <a:lstStyle/>
           <a:p>
             <a:pPr>
-              <a:defRPr sz="1100">
+              <a:defRPr sz="1050">
                 <a:solidFill>
                   <a:srgbClr val="596E64"/>
                 </a:solidFill>
@@ -9109,7 +9146,7 @@
               </a:defRPr>
             </a:pPr>
             <a:r>
-              <a:t>Case stays open with exact re-film checklist. One retry limit prevents customer lock-out.</a:t>
+              <a:t>Agent requests targeted photo; enters WAITING_FOR_EVIDENCE; resumes case on upload (1 retry limit).</a:t>
             </a:r>
           </a:p>
         </p:txBody>
@@ -9168,7 +9205,7 @@
         <p:spPr>
           <a:xfrm>
             <a:off x="914400" y="5358384"/>
-            <a:ext cx="1554480" cy="420624"/>
+            <a:ext cx="1645920" cy="420624"/>
           </a:xfrm>
           <a:prstGeom prst="rect">
             <a:avLst/>
@@ -9199,7 +9236,7 @@
           <a:lstStyle/>
           <a:p>
             <a:pPr algn="ctr">
-              <a:defRPr sz="1000" b="1">
+              <a:defRPr sz="950" b="1">
                 <a:solidFill>
                   <a:srgbClr val="065F46"/>
                 </a:solidFill>
@@ -9220,8 +9257,8 @@
         </p:nvSpPr>
         <p:spPr>
           <a:xfrm>
-            <a:off x="2651760" y="5248656"/>
-            <a:ext cx="4023360" cy="640080"/>
+            <a:off x="2743200" y="5248656"/>
+            <a:ext cx="3931920" cy="640080"/>
           </a:xfrm>
           <a:prstGeom prst="rect">
             <a:avLst/>
@@ -9235,7 +9272,7 @@
           <a:lstStyle/>
           <a:p>
             <a:pPr>
-              <a:defRPr sz="1100" b="1">
+              <a:defRPr sz="1050" b="1">
                 <a:solidFill>
                   <a:srgbClr val="172621"/>
                 </a:solidFill>
@@ -9243,7 +9280,7 @@
               </a:defRPr>
             </a:pPr>
             <a:r>
-              <a:t>Parcel-to-product take: opening sealed parcel to product reveal in one continuous take.</a:t>
+              <a:t>Sequence Continuity · Staged parcel-to-product take: opening sealed parcel to product reveal.</a:t>
             </a:r>
           </a:p>
         </p:txBody>
@@ -9256,7 +9293,7 @@
         </p:nvSpPr>
         <p:spPr>
           <a:xfrm>
-            <a:off x="6675120" y="5285232"/>
+            <a:off x="6720840" y="5285232"/>
             <a:ext cx="274320" cy="457200"/>
           </a:xfrm>
           <a:prstGeom prst="rect">
@@ -9292,8 +9329,8 @@
         </p:nvSpPr>
         <p:spPr>
           <a:xfrm>
-            <a:off x="7040880" y="5248656"/>
-            <a:ext cx="4297680" cy="640080"/>
+            <a:off x="7086600" y="5248656"/>
+            <a:ext cx="4206240" cy="640080"/>
           </a:xfrm>
           <a:prstGeom prst="rect">
             <a:avLst/>
@@ -9307,7 +9344,7 @@
           <a:lstStyle/>
           <a:p>
             <a:pPr>
-              <a:defRPr sz="1100">
+              <a:defRPr sz="1050">
                 <a:solidFill>
                   <a:srgbClr val="596E64"/>
                 </a:solidFill>
@@ -9394,7 +9431,7 @@
               </a:defRPr>
             </a:pPr>
             <a:r>
-              <a:t>Staged benchmark scenarios · Expected prototype behaviors, not measured production metrics · Cap: min(₹4,999, remaining refundable amount, order paid amount)</a:t>
+              <a:t>Staged prototype scenarios · Expected agent behaviors, not measured production metrics · Cap: min(₹4,999, remaining refundable amount, order paid amount)</a:t>
             </a:r>
           </a:p>
         </p:txBody>
@@ -9527,7 +9564,7 @@
               </a:defRPr>
             </a:pPr>
             <a:r>
-              <a:t>EXECUTION PLAN · TEAM ROOKIE (3 MEMBERS)</a:t>
+              <a:t>24-HOUR PROTOTYPE PLAN · FEASIBILITY &amp; SCOPE GUARDRAILS</a:t>
             </a:r>
           </a:p>
         </p:txBody>
@@ -9599,7 +9636,7 @@
               </a:defRPr>
             </a:pPr>
             <a:r>
-              <a:t>Buildable in 24 hours by 3 people, if the scope stays narrow.</a:t>
+              <a:t>Strict scope boundaries and clear division of labor make the prototype fully buildable in one day.</a:t>
             </a:r>
           </a:p>
         </p:txBody>
@@ -9613,7 +9650,7 @@
         <p:spPr>
           <a:xfrm>
             <a:off x="731520" y="2148840"/>
-            <a:ext cx="2560320" cy="1188720"/>
+            <a:ext cx="2560320" cy="1234440"/>
           </a:xfrm>
           <a:prstGeom prst="rect">
             <a:avLst/>
@@ -9646,7 +9683,7 @@
           <a:lstStyle/>
           <a:p>
             <a:pPr algn="ctr">
-              <a:defRPr sz="1100" b="1">
+              <a:defRPr sz="1000" b="1">
                 <a:solidFill>
                   <a:srgbClr val="006B55"/>
                 </a:solidFill>
@@ -9654,12 +9691,12 @@
               </a:defRPr>
             </a:pPr>
             <a:r>
-              <a:t>00h – 06h</a:t>
+              <a:t>00h – 06h · Foundation</a:t>
             </a:r>
           </a:p>
           <a:p>
             <a:pPr>
-              <a:defRPr sz="1200" b="1">
+              <a:defRPr sz="1150" b="1">
                 <a:solidFill>
                   <a:srgbClr val="172621"/>
                 </a:solidFill>
@@ -9672,7 +9709,7 @@
           </a:p>
           <a:p>
             <a:pPr>
-              <a:defRPr sz="950">
+              <a:defRPr sz="900">
                 <a:solidFill>
                   <a:srgbClr val="596E64"/>
                 </a:solidFill>
@@ -9680,7 +9717,7 @@
               </a:defRPr>
             </a:pPr>
             <a:r>
-              <a:t>Person A (Backend)</a:t>
+              <a:t>Person A (Backend), supported by C</a:t>
             </a:r>
             <a:br/>
             <a:r>
@@ -9741,7 +9778,7 @@
         <p:spPr>
           <a:xfrm>
             <a:off x="3447288" y="2148840"/>
-            <a:ext cx="2560320" cy="1188720"/>
+            <a:ext cx="2560320" cy="1234440"/>
           </a:xfrm>
           <a:prstGeom prst="rect">
             <a:avLst/>
@@ -9774,7 +9811,7 @@
           <a:lstStyle/>
           <a:p>
             <a:pPr algn="ctr">
-              <a:defRPr sz="1100" b="1">
+              <a:defRPr sz="1000" b="1">
                 <a:solidFill>
                   <a:srgbClr val="006B55"/>
                 </a:solidFill>
@@ -9782,12 +9819,12 @@
               </a:defRPr>
             </a:pPr>
             <a:r>
-              <a:t>06h – 12h</a:t>
+              <a:t>06h – 12h · Evidence</a:t>
             </a:r>
           </a:p>
           <a:p>
             <a:pPr>
-              <a:defRPr sz="1200" b="1">
+              <a:defRPr sz="1150" b="1">
                 <a:solidFill>
                   <a:srgbClr val="172621"/>
                 </a:solidFill>
@@ -9800,7 +9837,7 @@
           </a:p>
           <a:p>
             <a:pPr>
-              <a:defRPr sz="950">
+              <a:defRPr sz="900">
                 <a:solidFill>
                   <a:srgbClr val="596E64"/>
                 </a:solidFill>
@@ -9869,7 +9906,7 @@
         <p:spPr>
           <a:xfrm>
             <a:off x="6163056" y="2148840"/>
-            <a:ext cx="2560320" cy="1188720"/>
+            <a:ext cx="2560320" cy="1234440"/>
           </a:xfrm>
           <a:prstGeom prst="rect">
             <a:avLst/>
@@ -9902,7 +9939,7 @@
           <a:lstStyle/>
           <a:p>
             <a:pPr algn="ctr">
-              <a:defRPr sz="1100" b="1">
+              <a:defRPr sz="1000" b="1">
                 <a:solidFill>
                   <a:srgbClr val="006B55"/>
                 </a:solidFill>
@@ -9910,12 +9947,12 @@
               </a:defRPr>
             </a:pPr>
             <a:r>
-              <a:t>12h – 18h</a:t>
+              <a:t>12h – 18h · Integration</a:t>
             </a:r>
           </a:p>
           <a:p>
             <a:pPr>
-              <a:defRPr sz="1200" b="1">
+              <a:defRPr sz="1150" b="1">
                 <a:solidFill>
                   <a:srgbClr val="172621"/>
                 </a:solidFill>
@@ -9923,12 +9960,12 @@
               </a:defRPr>
             </a:pPr>
             <a:r>
-              <a:t>Integration &amp; 4 Scenarios</a:t>
+              <a:t>State Flow &amp; Scenarios</a:t>
             </a:r>
           </a:p>
           <a:p>
             <a:pPr>
-              <a:defRPr sz="950">
+              <a:defRPr sz="900">
                 <a:solidFill>
                   <a:srgbClr val="596E64"/>
                 </a:solidFill>
@@ -9936,11 +9973,11 @@
               </a:defRPr>
             </a:pPr>
             <a:r>
-              <a:t>Person C (Integration)</a:t>
+              <a:t>Person C (Integration), supported by A/B</a:t>
             </a:r>
             <a:br/>
             <a:r>
-              <a:t>End-to-end wiring, 4 staged demo cases (A–D), seller console UI</a:t>
+              <a:t>End-to-end wiring, clarification/resume loop, seller console UI</a:t>
             </a:r>
           </a:p>
         </p:txBody>
@@ -9997,7 +10034,7 @@
         <p:spPr>
           <a:xfrm>
             <a:off x="8878824" y="2148840"/>
-            <a:ext cx="2560320" cy="1188720"/>
+            <a:ext cx="2560320" cy="1234440"/>
           </a:xfrm>
           <a:prstGeom prst="rect">
             <a:avLst/>
@@ -10030,7 +10067,7 @@
           <a:lstStyle/>
           <a:p>
             <a:pPr algn="ctr">
-              <a:defRPr sz="1100" b="1">
+              <a:defRPr sz="1000" b="1">
                 <a:solidFill>
                   <a:srgbClr val="006B55"/>
                 </a:solidFill>
@@ -10038,12 +10075,12 @@
               </a:defRPr>
             </a:pPr>
             <a:r>
-              <a:t>18h – 24h</a:t>
+              <a:t>18h – 24h · Validation</a:t>
             </a:r>
           </a:p>
           <a:p>
             <a:pPr>
-              <a:defRPr sz="1200" b="1">
+              <a:defRPr sz="1150" b="1">
                 <a:solidFill>
                   <a:srgbClr val="172621"/>
                 </a:solidFill>
@@ -10051,12 +10088,12 @@
               </a:defRPr>
             </a:pPr>
             <a:r>
-              <a:t>Testing, Polish &amp; Submission</a:t>
+              <a:t>Testing &amp; Submission</a:t>
             </a:r>
           </a:p>
           <a:p>
             <a:pPr>
-              <a:defRPr sz="950">
+              <a:defRPr sz="900">
                 <a:solidFill>
                   <a:srgbClr val="596E64"/>
                 </a:solidFill>
@@ -10068,7 +10105,7 @@
             </a:r>
             <a:br/>
             <a:r>
-              <a:t>Fallback testing, edge cases, video walkthrough recording, README</a:t>
+              <a:t>Fallback testing, authorization tests, demo video recording, README</a:t>
             </a:r>
           </a:p>
         </p:txBody>
@@ -10124,8 +10161,8 @@
         </p:nvSpPr>
         <p:spPr>
           <a:xfrm>
-            <a:off x="731520" y="3520440"/>
-            <a:ext cx="5212080" cy="1828800"/>
+            <a:off x="731520" y="3566160"/>
+            <a:ext cx="5212080" cy="1783080"/>
           </a:xfrm>
           <a:prstGeom prst="rect">
             <a:avLst/>
@@ -10169,8 +10206,8 @@
         </p:nvSpPr>
         <p:spPr>
           <a:xfrm>
-            <a:off x="731520" y="3520440"/>
-            <a:ext cx="73152" cy="1828800"/>
+            <a:off x="731520" y="3566160"/>
+            <a:ext cx="73152" cy="1783080"/>
           </a:xfrm>
           <a:prstGeom prst="rect">
             <a:avLst/>
@@ -10212,8 +10249,8 @@
         </p:nvSpPr>
         <p:spPr>
           <a:xfrm>
-            <a:off x="960120" y="3611880"/>
-            <a:ext cx="4892040" cy="1645920"/>
+            <a:off x="960120" y="3657600"/>
+            <a:ext cx="4892040" cy="1600200"/>
           </a:xfrm>
           <a:prstGeom prst="rect">
             <a:avLst/>
@@ -10240,7 +10277,7 @@
           </a:p>
           <a:p>
             <a:pPr>
-              <a:defRPr sz="1050">
+              <a:defRPr sz="1000">
                 <a:solidFill>
                   <a:srgbClr val="172621"/>
                 </a:solidFill>
@@ -10261,6 +10298,10 @@
             <a:br/>
             <a:r>
               <a:t>• Structured JSON audit log</a:t>
+            </a:r>
+            <a:br/>
+            <a:r>
+              <a:t>• Clarification/resume loop</a:t>
             </a:r>
             <a:br/>
             <a:r>
@@ -10277,8 +10318,8 @@
         </p:nvSpPr>
         <p:spPr>
           <a:xfrm>
-            <a:off x="6248095" y="3520440"/>
-            <a:ext cx="5212080" cy="1828800"/>
+            <a:off x="6248095" y="3566160"/>
+            <a:ext cx="5212080" cy="1783080"/>
           </a:xfrm>
           <a:prstGeom prst="rect">
             <a:avLst/>
@@ -10322,8 +10363,8 @@
         </p:nvSpPr>
         <p:spPr>
           <a:xfrm>
-            <a:off x="6248095" y="3520440"/>
-            <a:ext cx="73152" cy="1828800"/>
+            <a:off x="6248095" y="3566160"/>
+            <a:ext cx="73152" cy="1783080"/>
           </a:xfrm>
           <a:prstGeom prst="rect">
             <a:avLst/>
@@ -10365,8 +10406,8 @@
         </p:nvSpPr>
         <p:spPr>
           <a:xfrm>
-            <a:off x="6476695" y="3611880"/>
-            <a:ext cx="4892040" cy="1645920"/>
+            <a:off x="6476695" y="3657600"/>
+            <a:ext cx="4892040" cy="1600200"/>
           </a:xfrm>
           <a:prstGeom prst="rect">
             <a:avLst/>
@@ -10388,12 +10429,12 @@
               </a:defRPr>
             </a:pPr>
             <a:r>
-              <a:t>CUT FIRST (DEFERRED EXPANSION)</a:t>
+              <a:t>CUT FIRST IF BEHIND (DEFERRED EXPANSION)</a:t>
             </a:r>
           </a:p>
           <a:p>
             <a:pPr>
-              <a:defRPr sz="1050">
+              <a:defRPr sz="1000">
                 <a:solidFill>
                   <a:srgbClr val="172621"/>
                 </a:solidFill>
@@ -10401,23 +10442,23 @@
               </a:defRPr>
             </a:pPr>
             <a:r>
-              <a:t>• Video OCR barcode scanner</a:t>
+              <a:t>• Real carrier webhook integration (keep mock courier)</a:t>
             </a:r>
             <a:br/>
             <a:r>
-              <a:t>• Auto-drafted customer email reply</a:t>
+              <a:t>• Multi-product order parsing (keep 1 item/return)</a:t>
             </a:r>
             <a:br/>
             <a:r>
+              <a:t>• Custom video encoding (keep standard 1 fps FFmpeg extraction)</a:t>
+            </a:r>
+            <a:br/>
+            <a:r>
+              <a:t>• Production payment gateways / live WhatsApp webhooks</a:t>
+            </a:r>
+            <a:br/>
+            <a:r>
               <a:t>• Seller analytics dashboard</a:t>
-            </a:r>
-            <a:br/>
-            <a:r>
-              <a:t>• Production payment gateways / live WhatsApp webhooks</a:t>
-            </a:r>
-            <a:br/>
-            <a:r>
-              <a:t>• Public cloud deployment</a:t>
             </a:r>
           </a:p>
         </p:txBody>

</xml_diff>

<commit_message>
feat(deck): editorial Swiss redesign, single source of truth, and fix native PPTX embedded images
</commit_message>
<xml_diff>
--- a/ReturnLens_v4.pptx
+++ b/ReturnLens_v4.pptx
@@ -512,37 +512,37 @@
           </a:p>
           <a:p>
             <a:r>
-              <a:t>- Track &amp; Fit: AgentX Hackathon 2026, Track PS-04 (Autonomous Support Agent for Online Sellers), Team Rookie (3 members).</a:t>
-            </a:r>
-          </a:p>
-          <a:p>
-            <a:r>
-              <a:t>- Target Merchant: Solo direct-to-consumer (D2C) e-commerce sellers managing orders, shipping, and returns without dedicated support staff.</a:t>
-            </a:r>
-          </a:p>
-          <a:p>
-            <a:r>
-              <a:t>- Core Friction: Solo sellers spend 15–20 minutes per return opening fragmented tabs (buyer chat, Shopify, Shippo tracking, store return policy). Return decisions are currently made from memory without unified evidence.</a:t>
-            </a:r>
-          </a:p>
-          <a:p>
-            <a:r>
-              <a:t>- Our Thesis: "Models observe. Code verifies. Seller authorizes."</a:t>
-            </a:r>
-          </a:p>
-          <a:p>
-            <a:r>
-              <a:t>- Technical Honesty: In the console mockup, observe the conservative metadata: "Potential casing damage flagged · Requires manual confirmation" rather than an ungrounded claim of incontrovertible defect.</a:t>
-            </a:r>
-          </a:p>
-          <a:p>
-            <a:r>
-              <a:t>- Fail-Closed Safety: The system never autonomously transfers money. Return labels and refund drafts remain strictly in pending status until the human merchant reviews evidence and clicks authorization.</a:t>
-            </a:r>
-          </a:p>
-          <a:p>
-            <a:r>
-              <a:t>- 24-Hour Hackathon Scope: Focused exclusively on return triage plus one zero-vision order status fast path (reusing store and courier APIs).</a:t>
+              <a:t>- Track &amp; Fit: AgentX Hackathon 2026, Problem Statement PS-04 (Autonomous Support Agent for Online Sellers).</a:t>
+            </a:r>
+          </a:p>
+          <a:p>
+            <a:r>
+              <a:t>- Team: Team Rookie (3 members).</a:t>
+            </a:r>
+          </a:p>
+          <a:p>
+            <a:r>
+              <a:t>- Target User: Solo direct-to-consumer (D2C) online merchant managing customer support, shipping, and returns alone.</a:t>
+            </a:r>
+          </a:p>
+          <a:p>
+            <a:r>
+              <a:t>- Core Insight: Solo sellers lose 15–20 minutes per return navigating fragmented tabs (chat, Shopify, Shippo, return policy), making memory-based decisions without traceable proof.</a:t>
+            </a:r>
+          </a:p>
+          <a:p>
+            <a:r>
+              <a:t>- Core Thesis: 'Models observe. Code verifies. Seller authorizes.'</a:t>
+            </a:r>
+          </a:p>
+          <a:p>
+            <a:r>
+              <a:t>- The Console Mockup showcases our core benchmark (Case B): Buyer ordered White Headphones (HEAD-WHT-02, ₹1,499), but unboxing frame 00:07 reveals a Black item. The agent flags the contradiction and presents actionable choices to the seller.</a:t>
+            </a:r>
+          </a:p>
+          <a:p>
+            <a:r>
+              <a:t>- Safety Boundary: The system never autonomously issues a refund or denies a customer. Financial release strictly requires 1-click merchant authorization.</a:t>
             </a:r>
           </a:p>
         </p:txBody>
@@ -617,42 +617,42 @@
           </a:p>
           <a:p>
             <a:r>
-              <a:t>- Problem: The return decision bottleneck is not an absent return policy; it is fragmented, unverified context.</a:t>
-            </a:r>
-          </a:p>
-          <a:p>
-            <a:r>
-              <a:t>- Sources:</a:t>
-            </a:r>
-          </a:p>
-          <a:p>
-            <a:r>
-              <a:t>  1. Customer Claim in chat (unverified claims, emotional text).</a:t>
-            </a:r>
-          </a:p>
-          <a:p>
-            <a:r>
-              <a:t>  2. Order Truth in Shopify store (SKU HEAD-WHT-02, price ₹4,999).</a:t>
-            </a:r>
-          </a:p>
-          <a:p>
-            <a:r>
-              <a:t>  3. Tracking Scan in Shippo courier API (delivered 4 days ago).</a:t>
-            </a:r>
-          </a:p>
-          <a:p>
-            <a:r>
-              <a:t>  4. Store Return Policy document (7-day defect window, security tag required).</a:t>
-            </a:r>
-          </a:p>
-          <a:p>
-            <a:r>
-              <a:t>- Central Gap: "Four systems. No traceable decision." Sellers decide returns from memory today. No single record ties video frames, store orders, and shipping status into an immutable decision trace.</a:t>
-            </a:r>
-          </a:p>
-          <a:p>
-            <a:r>
-              <a:t>- Fraud Metrics Defense: Strict fraud is 9% (NRF 2025, fraud only), while fraud + abuse is 15.14% (Appriss/Deloitte 2024). They represent fundamentally different measurement scopes and must never be merged.</a:t>
+              <a:t>- The returns bottleneck for solo sellers is not an absent returns portal; it is fragmented, unverified context.</a:t>
+            </a:r>
+          </a:p>
+          <a:p>
+            <a:r>
+              <a:t>- The four disconnected sources:</a:t>
+            </a:r>
+          </a:p>
+          <a:p>
+            <a:r>
+              <a:t>  1. Buyer claim in chat (unverified claims, emotional text).</a:t>
+            </a:r>
+          </a:p>
+          <a:p>
+            <a:r>
+              <a:t>  2. Store truth in Shopify (SKU HEAD-WHT-02, ₹1,499).</a:t>
+            </a:r>
+          </a:p>
+          <a:p>
+            <a:r>
+              <a:t>  3. Courier tracking in Shippo (delivered 4 days ago).</a:t>
+            </a:r>
+          </a:p>
+          <a:p>
+            <a:r>
+              <a:t>  4. Store return policy document (7-day defect window, security tag).</a:t>
+            </a:r>
+          </a:p>
+          <a:p>
+            <a:r>
+              <a:t>- Central Gap: Four systems, but no traceable decision. The merchant makes memory-based decisions across multiple tabs.</a:t>
+            </a:r>
+          </a:p>
+          <a:p>
+            <a:r>
+              <a:t>- Fraud Context (Sourced definitions): NRF 2025 reports 9% for strictly criminal return fraud, whereas Appriss/Deloitte 2024 reports 15.14% when combining fraud and policy abuse (wardrobing, unboxing swaps). These measure distinct scopes and must never be merged.</a:t>
             </a:r>
           </a:p>
           <a:p>
@@ -732,12 +732,12 @@
           </a:p>
           <a:p>
             <a:r>
-              <a:t>- Core Benchmark Scenario (Case B): Buyer ordered white headphones (HEAD-WHT-02, ₹4,999), but unboxing frame 00:07 shows black headphones.</a:t>
-            </a:r>
-          </a:p>
-          <a:p>
-            <a:r>
-              <a:t>- Grounding &amp; Honesty: The agent does NOT claim to read an unreadable SKU barcode from frame 00:07. It states factually: "Observed Color: Midnight Black · Exact SKU: Not verified · Tag: Not visible in cited frame".</a:t>
+              <a:t>- Core Benchmark Scenario (Case B): Buyer ordered White Headphones (HEAD-WHT-02, ₹1,499), but unboxing frame 00:07 shows black headphones.</a:t>
+            </a:r>
+          </a:p>
+          <a:p>
+            <a:r>
+              <a:t>- Visual Grounding Honesty: The agent does NOT claim to read an unreadable SKU barcode from frame 00:07. It factually observes: 'Observed Color: Midnight Black · Exact SKU: Not verified · Tag: Not visible in cited frame'.</a:t>
             </a:r>
           </a:p>
           <a:p>
@@ -747,7 +747,7 @@
           </a:p>
           <a:p>
             <a:r>
-              <a:t>- Three Merchant Decision Options:</a:t>
+              <a:t>- Three Clear Merchant Options:</a:t>
             </a:r>
           </a:p>
           <a:p>
@@ -757,7 +757,7 @@
           </a:p>
           <a:p>
             <a:r>
-              <a:t>  2. Reject return under Clause 4.2 (Item does not match order record).</a:t>
+              <a:t>  2. Reject return under policy (item does not match order record).</a:t>
             </a:r>
           </a:p>
           <a:p>
@@ -767,17 +767,7 @@
           </a:p>
           <a:p>
             <a:r>
-              <a:t>- Fail-Closed Financial Gate:</a:t>
-            </a:r>
-          </a:p>
-          <a:p>
-            <a:r>
-              <a:t>  max_refund = min(₹4,999, remaining refundable amount, order paid amount).</a:t>
-            </a:r>
-          </a:p>
-          <a:p>
-            <a:r>
-              <a:t>  No refund money is released without explicit seller click.</a:t>
+              <a:t>- Financial Guardrail: min(₹4,999, remaining refundable amount, order paid amount). No money moves without seller click.</a:t>
             </a:r>
           </a:p>
         </p:txBody>
@@ -852,10 +842,9 @@
           </a:p>
           <a:p>
             <a:r>
-              <a:t>- Philosophy: "Models observe. Code verifies. Seller authorizes."</a:t>
-            </a:r>
-          </a:p>
-          <a:p/>
+              <a:t>- Philosophy: 'Models observe. Code verifies. Seller authorizes.'</a:t>
+            </a:r>
+          </a:p>
           <a:p>
             <a:r>
               <a:t>- DEFENSE QUESTION 1: Why is this an agent rather than a hardcoded workflow?</a:t>
@@ -863,20 +852,9 @@
           </a:p>
           <a:p>
             <a:r>
-              <a:t>  ReturnLens is an autonomous state machine with dynamic action selection, multi-modal observation, and stateful lifecycle management.</a:t>
-            </a:r>
-          </a:p>
-          <a:p>
-            <a:r>
-              <a:t>  In Case C, when a customer submits a dark/blurry video (average brightness 28), the agent does NOT simply fail or run a static linear chain. It inspects the frames, determines evidence is insufficient under Policy P-05, dynamically decides to invoke ask_for_evidence() with specific re-filming guidance, transitions the ticket to WAITING_FOR_EVIDENCE, pauses execution while retaining state and order context, and resumes the exact triage session when new media arrives.</a:t>
-            </a:r>
-          </a:p>
-          <a:p>
-            <a:r>
-              <a:t>  Conversely, for routine "Where is my order?" requests, the agent selects the zero-vision fast path, querying mock Shopify and Shippo APIs directly without invoking heavy vision models.</a:t>
-            </a:r>
-          </a:p>
-          <a:p/>
+              <a:t>  ReturnLens is an autonomous state machine with dynamic action selection, multi-modal observation, and stateful lifecycle management. In Case C, when a customer submits a dark/blurry video (average brightness 28), the agent does NOT simply fail or run a static linear chain. It inspects the frames, determines evidence is insufficient under Policy P-05, dynamically decides to invoke ask_for_evidence() with specific re-filming guidance, transitions the ticket to WAITING_FOR_EVIDENCE, pauses execution while retaining state and order context, and resumes the exact triage session when new media arrives. Conversely, for routine order status requests, the agent selects the zero-vision fast path directly querying mock APIs.</a:t>
+            </a:r>
+          </a:p>
           <a:p>
             <a:r>
               <a:t>- DEFENSE QUESTION 2: What happens if vision or critic models hallucinate?</a:t>
@@ -884,15 +862,9 @@
           </a:p>
           <a:p>
             <a:r>
-              <a:t>  Vision models produce non-binding observation metadata, never authoritative decisions. Hard business rules (return windows from carrier delivery timestamps, SKU comparisons) are executed in deterministic Python code (P-01 to P-08), which cannot be jailbroken by customer prompts.</a:t>
-            </a:r>
-          </a:p>
-          <a:p>
-            <a:r>
-              <a:t>  The critic provides an adversarial sanity check against cited timestamps. If both vision and critic experience correlated hallucinations, the fail-closed human seller gate guarantees that no refund or return label can ever be issued without seller review.</a:t>
-            </a:r>
-          </a:p>
-          <a:p/>
+              <a:t>  Vision models produce non-binding observation metadata, never authoritative decisions. Hard business rules (return windows from carrier delivery timestamps, SKU comparisons) are executed in deterministic Python code (P-01 to P-08). The critic provides an adversarial sanity check against cited timestamps. If both vision and critic experience correlated hallucinations, the fail-closed human seller gate guarantees that no refund or return label can ever be issued without seller review.</a:t>
+            </a:r>
+          </a:p>
           <a:p>
             <a:r>
               <a:t>- DEFENSE QUESTION 3: How do you prevent duplicate or incorrect refunds?</a:t>
@@ -900,11 +872,6 @@
           </a:p>
           <a:p>
             <a:r>
-              <a:t>  Refund transactions are enforced at the backend policy layer:</a:t>
-            </a:r>
-          </a:p>
-          <a:p>
-            <a:r>
               <a:t>  1. Idempotency keys (hash(order_id, return_id, transaction_type)) prevent double-execution.</a:t>
             </a:r>
           </a:p>
@@ -916,12 +883,6 @@
           <a:p>
             <a:r>
               <a:t>  3. LLMs possess zero capability to call payment gateways directly; all actions produce draft state objects awaiting merchant authorization.</a:t>
-            </a:r>
-          </a:p>
-          <a:p/>
-          <a:p>
-            <a:r>
-              <a:t>- Bounded Execution: Exactly 3 base model calls per triage case (Planner, Vision, Critic) plus retries.</a:t>
             </a:r>
           </a:p>
         </p:txBody>
@@ -996,27 +957,27 @@
           </a:p>
           <a:p>
             <a:r>
-              <a:t>- Note on Grounding: These four scenarios represent staged prototype test suites and deterministic expected behaviors, NOT ungrounded production field metrics.</a:t>
-            </a:r>
-          </a:p>
-          <a:p>
-            <a:r>
-              <a:t>- Case A (Clean Claim): All rules pass (within 7d, SKU matches manifest, tag visible, physical crack observed). System drafts return shipping label and refund draft in 'pending_return_receipt' state. No refund money is transferred until physical warehouse receipt.</a:t>
-            </a:r>
-          </a:p>
-          <a:p>
-            <a:r>
-              <a:t>- Case B (Contradiction): Color mismatch detected (ordered white, unboxed black). System prevents auto-rejection and routes to seller review with 3 concrete resolution options.</a:t>
-            </a:r>
-          </a:p>
-          <a:p>
-            <a:r>
-              <a:t>- Case C (Unclear / Agentic Loop): Dark video (28/255 avg brightness). Instead of auto-denying, the agent provides a clear checklist, transitions to WAITING_FOR_EVIDENCE, and resumes on upload (1 retry limit protects customers from infinite loops).</a:t>
-            </a:r>
-          </a:p>
-          <a:p>
-            <a:r>
-              <a:t>- Case D (Continuity): Expected prototype behavior: inspect parcel-to-product sequence to flag suspicious cut-aways or missing transitions.</a:t>
+              <a:t>- Grounding Note: These four scenarios represent staged prototype test suites and deterministic expected behaviors, NOT ungrounded production field metrics.</a:t>
+            </a:r>
+          </a:p>
+          <a:p>
+            <a:r>
+              <a:t>- Case 01 (Consistent Claim): All rules pass (within 7d, SKU matches manifest, tag visible, physical crack observed). System drafts return shipping label and refund draft in 'pending_return_receipt' state. No refund money is transferred until physical warehouse receipt.</a:t>
+            </a:r>
+          </a:p>
+          <a:p>
+            <a:r>
+              <a:t>- Case 02 (Contradiction): Color mismatch detected (ordered white, unboxed black). System prevents auto-rejection and routes to seller review with 3 concrete resolution options.</a:t>
+            </a:r>
+          </a:p>
+          <a:p>
+            <a:r>
+              <a:t>- Case 03 (Unclear / Agentic Loop): Dark video (28/255 avg brightness). Instead of auto-denying, the agent provides a clear checklist, transitions to WAITING_FOR_EVIDENCE, and resumes on upload (1 retry limit protects customers from infinite loops).</a:t>
+            </a:r>
+          </a:p>
+          <a:p>
+            <a:r>
+              <a:t>- Case 04 (Continuity): Expected prototype behavior: inspect parcel-to-product sequence to flag suspicious cut-aways or missing transitions.</a:t>
             </a:r>
           </a:p>
           <a:p>
@@ -1111,12 +1072,12 @@
           </a:p>
           <a:p>
             <a:r>
-              <a:t>     - Person A (Backend): LangGraph state graph, mock store/courier fixtures, order-status route, state serialization.</a:t>
-            </a:r>
-          </a:p>
-          <a:p>
-            <a:r>
-              <a:t>     - Person B (Video &amp; UI): FFmpeg keyframe extraction, deterministic rules P-01 to P-08, critic prompt, seller console.</a:t>
+              <a:t>     - Person A (Backend &amp; State Machine): LangGraph orchestrator, mock store/courier APIs, order status fast path, state serialization.</a:t>
+            </a:r>
+          </a:p>
+          <a:p>
+            <a:r>
+              <a:t>     - Person B (Video Pipeline &amp; UI): FFmpeg keyframe extraction, deterministic rules P-01 to P-08, critic prompt, seller console.</a:t>
             </a:r>
           </a:p>
           <a:p>
@@ -1141,7 +1102,7 @@
           </a:p>
           <a:p>
             <a:r>
-              <a:t>- Winning Philosophy: "The winning hackathon agent is not the one with the most tool definitions. It is the one where every action is held to evidence, and the seller stays in control."</a:t>
+              <a:t>- Winning Philosophy: 'The winning hackathon agent is not the one with the most tool definitions. It is the one where every action is held to evidence, and the seller stays in control.'</a:t>
             </a:r>
           </a:p>
         </p:txBody>
@@ -4198,8 +4159,8 @@
         </p:nvSpPr>
         <p:spPr>
           <a:xfrm>
-            <a:off x="731520" y="548640"/>
-            <a:ext cx="5669280" cy="365760"/>
+            <a:off x="731520" y="594360"/>
+            <a:ext cx="4114800" cy="365760"/>
           </a:xfrm>
           <a:prstGeom prst="rect">
             <a:avLst/>
@@ -4221,7 +4182,7 @@
               </a:defRPr>
             </a:pPr>
             <a:r>
-              <a:t>RETURNLENS · PRODUCT LAUNCH</a:t>
+              <a:t>AGENTX HACKATHON 2026 · TRACK PS-04</a:t>
             </a:r>
           </a:p>
         </p:txBody>
@@ -4234,8 +4195,8 @@
         </p:nvSpPr>
         <p:spPr>
           <a:xfrm>
-            <a:off x="731520" y="960120"/>
-            <a:ext cx="5669280" cy="1005840"/>
+            <a:off x="731520" y="1051560"/>
+            <a:ext cx="4114800" cy="1005840"/>
           </a:xfrm>
           <a:prstGeom prst="rect">
             <a:avLst/>
@@ -4249,7 +4210,7 @@
           <a:lstStyle/>
           <a:p>
             <a:pPr>
-              <a:defRPr sz="5400" b="1">
+              <a:defRPr sz="5600" b="1">
                 <a:solidFill>
                   <a:srgbClr val="172621"/>
                 </a:solidFill>
@@ -4257,7 +4218,7 @@
               </a:defRPr>
             </a:pPr>
             <a:r>
-              <a:t>RETURNLENS</a:t>
+              <a:t>ReturnLens</a:t>
             </a:r>
           </a:p>
         </p:txBody>
@@ -4270,8 +4231,8 @@
         </p:nvSpPr>
         <p:spPr>
           <a:xfrm>
-            <a:off x="731520" y="2011680"/>
-            <a:ext cx="5669280" cy="731520"/>
+            <a:off x="731520" y="2148840"/>
+            <a:ext cx="4114800" cy="777240"/>
           </a:xfrm>
           <a:prstGeom prst="rect">
             <a:avLst/>
@@ -4285,7 +4246,7 @@
           <a:lstStyle/>
           <a:p>
             <a:pPr>
-              <a:defRPr sz="2600" b="1">
+              <a:defRPr sz="2400" b="1">
                 <a:solidFill>
                   <a:srgbClr val="172621"/>
                 </a:solidFill>
@@ -4306,8 +4267,8 @@
         </p:nvSpPr>
         <p:spPr>
           <a:xfrm>
-            <a:off x="731520" y="2834640"/>
-            <a:ext cx="5669280" cy="1097280"/>
+            <a:off x="731520" y="3017520"/>
+            <a:ext cx="4114800" cy="1097280"/>
           </a:xfrm>
           <a:prstGeom prst="rect">
             <a:avLst/>
@@ -4321,7 +4282,7 @@
           <a:lstStyle/>
           <a:p>
             <a:pPr>
-              <a:defRPr sz="1200">
+              <a:defRPr sz="1300">
                 <a:solidFill>
                   <a:srgbClr val="596E64"/>
                 </a:solidFill>
@@ -4329,12 +4290,12 @@
               </a:defRPr>
             </a:pPr>
             <a:r>
-              <a:t>Solo online sellers lose 15–20 minutes per return deciding from memory across disconnected tabs.</a:t>
+              <a:t>Evidence-backed returns triage for independent online sellers.</a:t>
             </a:r>
             <a:br/>
             <a:br/>
             <a:r>
-              <a:t>ReturnLens indexes unboxing video keyframes, matches store orders, applies deterministic policy rules, and presents a 1-click decision console to the merchant.</a:t>
+              <a:t>When a buyer submits an unboxing video, ReturnLens links video keyframes to store truth and courier scans, evaluates deterministic policy rules, and presents a 1-click decision console to the solo merchant.</a:t>
             </a:r>
           </a:p>
         </p:txBody>
@@ -4347,8 +4308,8 @@
         </p:nvSpPr>
         <p:spPr>
           <a:xfrm>
-            <a:off x="731520" y="4114800"/>
-            <a:ext cx="5669280" cy="594360"/>
+            <a:off x="731520" y="4663440"/>
+            <a:ext cx="1280160" cy="1280160"/>
           </a:xfrm>
           <a:prstGeom prst="rect">
             <a:avLst/>
@@ -4377,32 +4338,32 @@
           </a:fontRef>
         </p:style>
         <p:txBody>
-          <a:bodyPr rtlCol="0" anchor="ctr"/>
+          <a:bodyPr rtlCol="0" anchor="ctr" wrap="square"/>
           <a:lstStyle/>
           <a:p>
             <a:pPr algn="ctr">
-              <a:defRPr sz="950" b="1">
-                <a:solidFill>
-                  <a:srgbClr val="006B55"/>
-                </a:solidFill>
-                <a:latin typeface="IBM Plex Mono"/>
-              </a:defRPr>
-            </a:pPr>
-            <a:r>
-              <a:t>AgentX Hackathon 2026 · PS-04 Track · Team Rookie (3 Members)</a:t>
+              <a:defRPr sz="2000" b="1">
+                <a:solidFill>
+                  <a:srgbClr val="D95D39"/>
+                </a:solidFill>
+                <a:latin typeface="Inter"/>
+              </a:defRPr>
+            </a:pPr>
+            <a:r>
+              <a:t>15–20m</a:t>
             </a:r>
           </a:p>
           <a:p>
             <a:pPr>
-              <a:defRPr sz="1000">
-                <a:solidFill>
-                  <a:srgbClr val="172621"/>
+              <a:defRPr sz="950">
+                <a:solidFill>
+                  <a:srgbClr val="596E64"/>
                 </a:solidFill>
                 <a:latin typeface="Inter"/>
               </a:defRPr>
             </a:pPr>
             <a:r>
-              <a:t>Thesis: Models observe. Code verifies. Seller authorizes.</a:t>
+              <a:t>Manual triage eliminated</a:t>
             </a:r>
           </a:p>
         </p:txBody>
@@ -4415,8 +4376,8 @@
         </p:nvSpPr>
         <p:spPr>
           <a:xfrm>
-            <a:off x="731520" y="4846320"/>
-            <a:ext cx="1737360" cy="1143000"/>
+            <a:off x="2103120" y="4663440"/>
+            <a:ext cx="1280160" cy="1280160"/>
           </a:xfrm>
           <a:prstGeom prst="rect">
             <a:avLst/>
@@ -4445,24 +4406,24 @@
           </a:fontRef>
         </p:style>
         <p:txBody>
-          <a:bodyPr rtlCol="0" anchor="ctr"/>
+          <a:bodyPr rtlCol="0" anchor="ctr" wrap="square"/>
           <a:lstStyle/>
           <a:p>
             <a:pPr algn="ctr">
-              <a:defRPr sz="2200" b="1">
-                <a:solidFill>
-                  <a:srgbClr val="D95D39"/>
+              <a:defRPr sz="2000" b="1">
+                <a:solidFill>
+                  <a:srgbClr val="006B55"/>
                 </a:solidFill>
                 <a:latin typeface="Inter"/>
               </a:defRPr>
             </a:pPr>
             <a:r>
-              <a:t>15–20m</a:t>
+              <a:t>1-Click</a:t>
             </a:r>
           </a:p>
           <a:p>
             <a:pPr>
-              <a:defRPr sz="900">
+              <a:defRPr sz="950">
                 <a:solidFill>
                   <a:srgbClr val="596E64"/>
                 </a:solidFill>
@@ -4470,7 +4431,7 @@
               </a:defRPr>
             </a:pPr>
             <a:r>
-              <a:t>Current manual triage time per return ticket</a:t>
+              <a:t>Merchant verification</a:t>
             </a:r>
           </a:p>
         </p:txBody>
@@ -4483,8 +4444,8 @@
         </p:nvSpPr>
         <p:spPr>
           <a:xfrm>
-            <a:off x="2697480" y="4846320"/>
-            <a:ext cx="1737360" cy="1143000"/>
+            <a:off x="3474720" y="4663440"/>
+            <a:ext cx="1280160" cy="1280160"/>
           </a:xfrm>
           <a:prstGeom prst="rect">
             <a:avLst/>
@@ -4513,24 +4474,24 @@
           </a:fontRef>
         </p:style>
         <p:txBody>
-          <a:bodyPr rtlCol="0" anchor="ctr"/>
+          <a:bodyPr rtlCol="0" anchor="ctr" wrap="square"/>
           <a:lstStyle/>
           <a:p>
             <a:pPr algn="ctr">
-              <a:defRPr sz="2200" b="1">
-                <a:solidFill>
-                  <a:srgbClr val="006B55"/>
+              <a:defRPr sz="2000" b="1">
+                <a:solidFill>
+                  <a:srgbClr val="172621"/>
                 </a:solidFill>
                 <a:latin typeface="Inter"/>
               </a:defRPr>
             </a:pPr>
             <a:r>
-              <a:t>1-Click</a:t>
+              <a:t>24h</a:t>
             </a:r>
           </a:p>
           <a:p>
             <a:pPr>
-              <a:defRPr sz="900">
+              <a:defRPr sz="950">
                 <a:solidFill>
                   <a:srgbClr val="596E64"/>
                 </a:solidFill>
@@ -4538,7 +4499,7 @@
               </a:defRPr>
             </a:pPr>
             <a:r>
-              <a:t>Merchant decision with cited keyframe evidence</a:t>
+              <a:t>Prototype feasibility</a:t>
             </a:r>
           </a:p>
         </p:txBody>
@@ -4551,8 +4512,8 @@
         </p:nvSpPr>
         <p:spPr>
           <a:xfrm>
-            <a:off x="4663440" y="4846320"/>
-            <a:ext cx="1737360" cy="1143000"/>
+            <a:off x="5120640" y="685800"/>
+            <a:ext cx="6339535" cy="5394960"/>
           </a:xfrm>
           <a:prstGeom prst="rect">
             <a:avLst/>
@@ -4584,30 +4545,7 @@
           <a:bodyPr rtlCol="0" anchor="ctr"/>
           <a:lstStyle/>
           <a:p>
-            <a:pPr algn="ctr">
-              <a:defRPr sz="2200" b="1">
-                <a:solidFill>
-                  <a:srgbClr val="172621"/>
-                </a:solidFill>
-                <a:latin typeface="Inter"/>
-              </a:defRPr>
-            </a:pPr>
-            <a:r>
-              <a:t>24h</a:t>
-            </a:r>
-          </a:p>
-          <a:p>
-            <a:pPr>
-              <a:defRPr sz="900">
-                <a:solidFill>
-                  <a:srgbClr val="596E64"/>
-                </a:solidFill>
-                <a:latin typeface="Inter"/>
-              </a:defRPr>
-            </a:pPr>
-            <a:r>
-              <a:t>Prototype feasibility for 3-member team</a:t>
-            </a:r>
+            <a:pPr algn="ctr"/>
           </a:p>
         </p:txBody>
       </p:sp>
@@ -4619,53 +4557,8 @@
         </p:nvSpPr>
         <p:spPr>
           <a:xfrm>
-            <a:off x="6766560" y="777240"/>
-            <a:ext cx="4693615" cy="5212080"/>
-          </a:xfrm>
-          <a:prstGeom prst="rect">
-            <a:avLst/>
-          </a:prstGeom>
-          <a:solidFill>
-            <a:srgbClr val="FFFFFF"/>
-          </a:solidFill>
-          <a:ln w="12700">
-            <a:solidFill>
-              <a:srgbClr val="E2DED4"/>
-            </a:solidFill>
-          </a:ln>
-        </p:spPr>
-        <p:style>
-          <a:lnRef idx="1">
-            <a:schemeClr val="accent1"/>
-          </a:lnRef>
-          <a:fillRef idx="3">
-            <a:schemeClr val="accent1"/>
-          </a:fillRef>
-          <a:effectRef idx="2">
-            <a:schemeClr val="accent1"/>
-          </a:effectRef>
-          <a:fontRef idx="minor">
-            <a:schemeClr val="lt1"/>
-          </a:fontRef>
-        </p:style>
-        <p:txBody>
-          <a:bodyPr rtlCol="0" anchor="ctr"/>
-          <a:lstStyle/>
-          <a:p>
-            <a:pPr algn="ctr"/>
-          </a:p>
-        </p:txBody>
-      </p:sp>
-      <p:sp>
-        <p:nvSpPr>
-          <p:cNvPr id="12" name="Rectangle 11"/>
-          <p:cNvSpPr/>
-          <p:nvPr/>
-        </p:nvSpPr>
-        <p:spPr>
-          <a:xfrm>
-            <a:off x="6766560" y="777240"/>
-            <a:ext cx="4693615" cy="502920"/>
+            <a:off x="5120640" y="685800"/>
+            <a:ext cx="6339535" cy="502920"/>
           </a:xfrm>
           <a:prstGeom prst="rect">
             <a:avLst/>
@@ -4696,7 +4589,7 @@
           <a:lstStyle/>
           <a:p>
             <a:pPr algn="ctr">
-              <a:defRPr sz="950" b="1">
+              <a:defRPr sz="1000" b="1">
                 <a:solidFill>
                   <a:srgbClr val="00D1A7"/>
                 </a:solidFill>
@@ -4704,11 +4597,35 @@
               </a:defRPr>
             </a:pPr>
             <a:r>
-              <a:t>RETURNLENS SELLER CONSOLE  ·  CASE #RT-1042</a:t>
-            </a:r>
-          </a:p>
-        </p:txBody>
-      </p:sp>
+              <a:t>RETURNLENS SELLER CONSOLE  ·  CASE #RT-8821</a:t>
+            </a:r>
+          </a:p>
+        </p:txBody>
+      </p:sp>
+      <p:pic>
+        <p:nvPicPr>
+          <p:cNvPr id="12" name="Picture 11" descr="studio_white_headphones.jpg"/>
+          <p:cNvPicPr>
+            <a:picLocks noChangeAspect="1"/>
+          </p:cNvPicPr>
+          <p:nvPr/>
+        </p:nvPicPr>
+        <p:blipFill>
+          <a:blip r:embed="rId2"/>
+          <a:stretch>
+            <a:fillRect/>
+          </a:stretch>
+        </p:blipFill>
+        <p:spPr>
+          <a:xfrm>
+            <a:off x="5394960" y="1417320"/>
+            <a:ext cx="2468880" cy="2103120"/>
+          </a:xfrm>
+          <a:prstGeom prst="rect">
+            <a:avLst/>
+          </a:prstGeom>
+        </p:spPr>
+      </p:pic>
       <p:sp>
         <p:nvSpPr>
           <p:cNvPr id="13" name="TextBox 12"/>
@@ -4717,8 +4634,8 @@
         </p:nvSpPr>
         <p:spPr>
           <a:xfrm>
-            <a:off x="9098280" y="1417320"/>
-            <a:ext cx="2179015" cy="3931920"/>
+            <a:off x="8046720" y="1371600"/>
+            <a:ext cx="3139135" cy="2194560"/>
           </a:xfrm>
           <a:prstGeom prst="rect">
             <a:avLst/>
@@ -4732,7 +4649,7 @@
           <a:lstStyle/>
           <a:p>
             <a:pPr>
-              <a:defRPr sz="900" b="1">
+              <a:defRPr sz="950" b="1">
                 <a:solidFill>
                   <a:srgbClr val="7A8E85"/>
                 </a:solidFill>
@@ -4745,7 +4662,7 @@
           </a:p>
           <a:p>
             <a:pPr>
-              <a:defRPr sz="1050" b="1">
+              <a:defRPr sz="1100" b="1">
                 <a:solidFill>
                   <a:srgbClr val="172621"/>
                 </a:solidFill>
@@ -4753,21 +4670,21 @@
               </a:defRPr>
             </a:pPr>
             <a:r>
-              <a:t>Order #ORD-8821</a:t>
+              <a:t>Order #ORD-7729  ·  HEAD-WHT-02</a:t>
             </a:r>
             <a:br/>
             <a:r>
-              <a:t>SKU: HEAD-WHT-02 (White)</a:t>
+              <a:t>Matte White  ·  Price: ₹1,499</a:t>
             </a:r>
             <a:br/>
             <a:r>
-              <a:t>Price: ₹4,999 · Delivered 4d ago</a:t>
+              <a:t>Delivered 4 days ago</a:t>
             </a:r>
           </a:p>
           <a:p>
             <a:br/>
             <a:pPr>
-              <a:defRPr sz="900" b="1">
+              <a:defRPr sz="950" b="1">
                 <a:solidFill>
                   <a:srgbClr val="7A8E85"/>
                 </a:solidFill>
@@ -4775,64 +4692,24 @@
               </a:defRPr>
             </a:pPr>
             <a:r>
-              <a:t>VIDEO EVIDENCE CITATION</a:t>
+              <a:t>EVIDENCE CITATION (STAGED)</a:t>
             </a:r>
           </a:p>
           <a:p>
             <a:pPr>
-              <a:defRPr sz="1100" b="1">
-                <a:solidFill>
-                  <a:srgbClr val="172621"/>
+              <a:defRPr sz="1050">
+                <a:solidFill>
+                  <a:srgbClr val="596E64"/>
                 </a:solidFill>
                 <a:latin typeface="Inter"/>
               </a:defRPr>
             </a:pPr>
             <a:r>
-              <a:t>Inspection Frame 00:14</a:t>
-            </a:r>
-          </a:p>
-          <a:p>
-            <a:pPr>
-              <a:defRPr sz="950">
-                <a:solidFill>
-                  <a:srgbClr val="596E64"/>
-                </a:solidFill>
-                <a:latin typeface="Inter"/>
-              </a:defRPr>
-            </a:pPr>
-            <a:r>
-              <a:t>Potential casing damage flagged · Requires manual confirmation</a:t>
-            </a:r>
-          </a:p>
-          <a:p>
+              <a:t>Frame 00:07 (Staged)</a:t>
+            </a:r>
             <a:br/>
-            <a:pPr>
-              <a:defRPr sz="900" b="1">
-                <a:solidFill>
-                  <a:srgbClr val="7A8E85"/>
-                </a:solidFill>
-                <a:latin typeface="IBM Plex Mono"/>
-              </a:defRPr>
-            </a:pPr>
-            <a:r>
-              <a:t>POLICY VERIFICATION</a:t>
-            </a:r>
-          </a:p>
-          <a:p>
-            <a:pPr>
-              <a:defRPr sz="1000" b="1">
-                <a:solidFill>
-                  <a:srgbClr val="92400E"/>
-                </a:solidFill>
-                <a:latin typeface="Inter"/>
-              </a:defRPr>
-            </a:pPr>
-            <a:r>
-              <a:t>P-01 Defect Check: FLAGGED FOR REVIEW</a:t>
-            </a:r>
-            <a:br/>
-            <a:r>
-              <a:t>P-04 Return Window: PASS (Day 4 of 7)</a:t>
+            <a:r>
+              <a:t>Observed item casing is Midnight Black. Exact barcode unverified.</a:t>
             </a:r>
           </a:p>
         </p:txBody>
@@ -4845,8 +4722,76 @@
         </p:nvSpPr>
         <p:spPr>
           <a:xfrm>
-            <a:off x="6949440" y="4709160"/>
-            <a:ext cx="4327855" cy="365760"/>
+            <a:off x="5394960" y="3703320"/>
+            <a:ext cx="5790895" cy="777240"/>
+          </a:xfrm>
+          <a:prstGeom prst="rect">
+            <a:avLst/>
+          </a:prstGeom>
+          <a:solidFill>
+            <a:srgbClr val="FCECE8"/>
+          </a:solidFill>
+          <a:ln w="12700">
+            <a:solidFill>
+              <a:srgbClr val="D95D39"/>
+            </a:solidFill>
+          </a:ln>
+        </p:spPr>
+        <p:style>
+          <a:lnRef idx="1">
+            <a:schemeClr val="accent1"/>
+          </a:lnRef>
+          <a:fillRef idx="3">
+            <a:schemeClr val="accent1"/>
+          </a:fillRef>
+          <a:effectRef idx="2">
+            <a:schemeClr val="accent1"/>
+          </a:effectRef>
+          <a:fontRef idx="minor">
+            <a:schemeClr val="lt1"/>
+          </a:fontRef>
+        </p:style>
+        <p:txBody>
+          <a:bodyPr rtlCol="0" anchor="ctr" wrap="square"/>
+          <a:lstStyle/>
+          <a:p>
+            <a:pPr algn="ctr">
+              <a:defRPr sz="1000" b="1">
+                <a:solidFill>
+                  <a:srgbClr val="991B1B"/>
+                </a:solidFill>
+                <a:latin typeface="IBM Plex Mono"/>
+              </a:defRPr>
+            </a:pPr>
+            <a:r>
+              <a:t>POLICY GATE: COLOR CONTRADICTION DETECTED</a:t>
+            </a:r>
+          </a:p>
+          <a:p>
+            <a:pPr>
+              <a:defRPr sz="1050">
+                <a:solidFill>
+                  <a:srgbClr val="991B1B"/>
+                </a:solidFill>
+                <a:latin typeface="Inter"/>
+              </a:defRPr>
+            </a:pPr>
+            <a:r>
+              <a:t>P-04 Return Window: PASS (Day 4 of 7)  |  P-03 Manifest Match: CONTRADICTION FLAGGED</a:t>
+            </a:r>
+          </a:p>
+        </p:txBody>
+      </p:sp>
+      <p:sp>
+        <p:nvSpPr>
+          <p:cNvPr id="15" name="Rectangle 14"/>
+          <p:cNvSpPr/>
+          <p:nvPr/>
+        </p:nvSpPr>
+        <p:spPr>
+          <a:xfrm>
+            <a:off x="5394960" y="4663439"/>
+            <a:ext cx="5790895" cy="411480"/>
           </a:xfrm>
           <a:prstGeom prst="rect">
             <a:avLst/>
@@ -4877,7 +4822,7 @@
           <a:lstStyle/>
           <a:p>
             <a:pPr algn="ctr">
-              <a:defRPr sz="900" b="1">
+              <a:defRPr sz="1000" b="1">
                 <a:solidFill>
                   <a:srgbClr val="92400E"/>
                 </a:solidFill>
@@ -4885,21 +4830,21 @@
               </a:defRPr>
             </a:pPr>
             <a:r>
-              <a:t>STATUS: READY FOR SELLER REVIEW (FLAGGED)</a:t>
-            </a:r>
-          </a:p>
-        </p:txBody>
-      </p:sp>
-      <p:sp>
-        <p:nvSpPr>
-          <p:cNvPr id="15" name="Rectangle 14"/>
+              <a:t>STATUS: ESCALATED FOR SELLER DECISION</a:t>
+            </a:r>
+          </a:p>
+        </p:txBody>
+      </p:sp>
+      <p:sp>
+        <p:nvSpPr>
+          <p:cNvPr id="16" name="Rectangle 15"/>
           <p:cNvSpPr/>
           <p:nvPr/>
         </p:nvSpPr>
         <p:spPr>
           <a:xfrm>
-            <a:off x="6949440" y="5212080"/>
-            <a:ext cx="4327855" cy="502920"/>
+            <a:off x="5394960" y="5212080"/>
+            <a:ext cx="5790895" cy="594360"/>
           </a:xfrm>
           <a:prstGeom prst="rect">
             <a:avLst/>
@@ -4930,7 +4875,7 @@
           <a:lstStyle/>
           <a:p>
             <a:pPr algn="ctr">
-              <a:defRPr sz="1200" b="1">
+              <a:defRPr sz="1400" b="1">
                 <a:solidFill>
                   <a:srgbClr val="FFFFFF"/>
                 </a:solidFill>
@@ -4938,20 +4883,20 @@
               </a:defRPr>
             </a:pPr>
             <a:r>
-              <a:t>Review Evidence &amp; Authorize Draft</a:t>
-            </a:r>
-          </a:p>
-        </p:txBody>
-      </p:sp>
-      <p:sp>
-        <p:nvSpPr>
-          <p:cNvPr id="16" name="Rectangle 15"/>
+              <a:t>Review Evidence &amp; Authorize</a:t>
+            </a:r>
+          </a:p>
+        </p:txBody>
+      </p:sp>
+      <p:sp>
+        <p:nvSpPr>
+          <p:cNvPr id="17" name="Rectangle 16"/>
           <p:cNvSpPr/>
           <p:nvPr/>
         </p:nvSpPr>
         <p:spPr>
           <a:xfrm>
-            <a:off x="731520" y="6263640"/>
+            <a:off x="731520" y="6327648"/>
             <a:ext cx="10728655" cy="13716"/>
           </a:xfrm>
           <a:prstGeom prst="rect">
@@ -4988,13 +4933,13 @@
       </p:sp>
       <p:sp>
         <p:nvSpPr>
-          <p:cNvPr id="17" name="TextBox 16"/>
+          <p:cNvPr id="18" name="TextBox 17"/>
           <p:cNvSpPr txBox="1"/>
           <p:nvPr/>
         </p:nvSpPr>
         <p:spPr>
           <a:xfrm>
-            <a:off x="731520" y="6336792"/>
+            <a:off x="731520" y="6382512"/>
             <a:ext cx="8229600" cy="365760"/>
           </a:xfrm>
           <a:prstGeom prst="rect">
@@ -5009,7 +4954,7 @@
           <a:lstStyle/>
           <a:p>
             <a:pPr>
-              <a:defRPr sz="1000">
+              <a:defRPr sz="950">
                 <a:solidFill>
                   <a:srgbClr val="7A8E85"/>
                 </a:solidFill>
@@ -5017,20 +4962,20 @@
               </a:defRPr>
             </a:pPr>
             <a:r>
-              <a:t>ReturnLens · Idea Pitch Deck · PS-04 · Team Rookie (3 members)</a:t>
-            </a:r>
-          </a:p>
-        </p:txBody>
-      </p:sp>
-      <p:sp>
-        <p:nvSpPr>
-          <p:cNvPr id="18" name="TextBox 17"/>
+              <a:t>ReturnLens · Pitch Deck · PS-04 Track · Team Rookie (3 Members)</a:t>
+            </a:r>
+          </a:p>
+        </p:txBody>
+      </p:sp>
+      <p:sp>
+        <p:nvSpPr>
+          <p:cNvPr id="19" name="TextBox 18"/>
           <p:cNvSpPr txBox="1"/>
           <p:nvPr/>
         </p:nvSpPr>
         <p:spPr>
           <a:xfrm>
-            <a:off x="9144000" y="6336792"/>
+            <a:off x="9144000" y="6382512"/>
             <a:ext cx="2316175" cy="365760"/>
           </a:xfrm>
           <a:prstGeom prst="rect">
@@ -5045,7 +4990,7 @@
           <a:lstStyle/>
           <a:p>
             <a:pPr algn="r">
-              <a:defRPr sz="1000">
+              <a:defRPr sz="950">
                 <a:solidFill>
                   <a:srgbClr val="7A8E85"/>
                 </a:solidFill>
@@ -5128,7 +5073,7 @@
         <p:spPr>
           <a:xfrm>
             <a:off x="731520" y="548640"/>
-            <a:ext cx="5486400" cy="365760"/>
+            <a:ext cx="7315200" cy="365760"/>
           </a:xfrm>
           <a:prstGeom prst="rect">
             <a:avLst/>
@@ -5163,8 +5108,8 @@
         </p:nvSpPr>
         <p:spPr>
           <a:xfrm>
-            <a:off x="731520" y="960120"/>
-            <a:ext cx="10698480" cy="731520"/>
+            <a:off x="731520" y="914400"/>
+            <a:ext cx="10698480" cy="685800"/>
           </a:xfrm>
           <a:prstGeom prst="rect">
             <a:avLst/>
@@ -5186,7 +5131,7 @@
               </a:defRPr>
             </a:pPr>
             <a:r>
-              <a:t>One return decision. Four disconnected sources.</a:t>
+              <a:t>One return. Four disconnected sources.</a:t>
             </a:r>
           </a:p>
         </p:txBody>
@@ -5199,8 +5144,8 @@
         </p:nvSpPr>
         <p:spPr>
           <a:xfrm>
-            <a:off x="731520" y="1691640"/>
-            <a:ext cx="10698480" cy="548640"/>
+            <a:off x="731520" y="1600200"/>
+            <a:ext cx="10698480" cy="457200"/>
           </a:xfrm>
           <a:prstGeom prst="rect">
             <a:avLst/>
@@ -5214,7 +5159,7 @@
           <a:lstStyle/>
           <a:p>
             <a:pPr>
-              <a:defRPr sz="1900">
+              <a:defRPr sz="1800">
                 <a:solidFill>
                   <a:srgbClr val="596E64"/>
                 </a:solidFill>
@@ -5222,7 +5167,7 @@
               </a:defRPr>
             </a:pPr>
             <a:r>
-              <a:t>Sellers decide returns from memory today. ReturnLens assembles one trace before money moves.</a:t>
+              <a:t>Four systems. No traceable decision.  ·  Without a shared record, the seller connects order facts, video, and policy manually from memory.</a:t>
             </a:r>
           </a:p>
         </p:txBody>
@@ -5235,8 +5180,8 @@
         </p:nvSpPr>
         <p:spPr>
           <a:xfrm>
-            <a:off x="731520" y="2377440"/>
-            <a:ext cx="3291840" cy="1737360"/>
+            <a:off x="731520" y="2240280"/>
+            <a:ext cx="3200400" cy="1783080"/>
           </a:xfrm>
           <a:prstGeom prst="rect">
             <a:avLst/>
@@ -5244,7 +5189,7 @@
           <a:solidFill>
             <a:srgbClr val="FFFFFF"/>
           </a:solidFill>
-          <a:ln>
+          <a:ln w="12700">
             <a:solidFill>
               <a:srgbClr val="E2DED4"/>
             </a:solidFill>
@@ -5282,7 +5227,7 @@
           </a:p>
           <a:p>
             <a:pPr>
-              <a:defRPr sz="1300" b="1">
+              <a:defRPr sz="1400" b="1">
                 <a:solidFill>
                   <a:srgbClr val="172621"/>
                 </a:solidFill>
@@ -5290,12 +5235,12 @@
               </a:defRPr>
             </a:pPr>
             <a:r>
-              <a:t>Unverified Customer Claims</a:t>
+              <a:t>Buyer Video &amp; Claim</a:t>
             </a:r>
           </a:p>
           <a:p>
             <a:pPr>
-              <a:defRPr sz="1000">
+              <a:defRPr sz="1100">
                 <a:solidFill>
                   <a:srgbClr val="596E64"/>
                 </a:solidFill>
@@ -5303,7 +5248,7 @@
               </a:defRPr>
             </a:pPr>
             <a:r>
-              <a:t>Subjective descriptions in chat; videos are unindexed and skipped</a:t>
+              <a:t>Customer submits short unboxing clip and subjective text via chat.</a:t>
             </a:r>
           </a:p>
         </p:txBody>
@@ -5316,8 +5261,8 @@
         </p:nvSpPr>
         <p:spPr>
           <a:xfrm>
-            <a:off x="731520" y="4297680"/>
-            <a:ext cx="3291840" cy="1737360"/>
+            <a:off x="731520" y="4206240"/>
+            <a:ext cx="3200400" cy="1783080"/>
           </a:xfrm>
           <a:prstGeom prst="rect">
             <a:avLst/>
@@ -5325,7 +5270,7 @@
           <a:solidFill>
             <a:srgbClr val="FFFFFF"/>
           </a:solidFill>
-          <a:ln>
+          <a:ln w="12700">
             <a:solidFill>
               <a:srgbClr val="E2DED4"/>
             </a:solidFill>
@@ -5358,12 +5303,12 @@
               </a:defRPr>
             </a:pPr>
             <a:r>
-              <a:t>03 COURIER TRACKING</a:t>
+              <a:t>03 COURIER TRACKING SCAN</a:t>
             </a:r>
           </a:p>
           <a:p>
             <a:pPr>
-              <a:defRPr sz="1300" b="1">
+              <a:defRPr sz="1400" b="1">
                 <a:solidFill>
                   <a:srgbClr val="172621"/>
                 </a:solidFill>
@@ -5371,12 +5316,12 @@
               </a:defRPr>
             </a:pPr>
             <a:r>
-              <a:t>Delivered 4 Days Ago</a:t>
+              <a:t>Courier Tracking Scan</a:t>
             </a:r>
           </a:p>
           <a:p>
             <a:pPr>
-              <a:defRPr sz="1000">
+              <a:defRPr sz="1100">
                 <a:solidFill>
                   <a:srgbClr val="596E64"/>
                 </a:solidFill>
@@ -5384,7 +5329,7 @@
               </a:defRPr>
             </a:pPr>
             <a:r>
-              <a:t>Shippo mock tracking API scan timestamp verification</a:t>
+              <a:t>Shippo courier API records delivery scan 4 days ago.</a:t>
             </a:r>
           </a:p>
         </p:txBody>
@@ -5397,8 +5342,8 @@
         </p:nvSpPr>
         <p:spPr>
           <a:xfrm>
-            <a:off x="4206240" y="2377440"/>
-            <a:ext cx="3779215" cy="3657600"/>
+            <a:off x="4114800" y="2240280"/>
+            <a:ext cx="3962095" cy="3749039"/>
           </a:xfrm>
           <a:prstGeom prst="rect">
             <a:avLst/>
@@ -5444,24 +5389,11 @@
           </a:p>
           <a:p>
             <a:pPr algn="ctr">
-              <a:defRPr sz="1600" b="1">
+              <a:defRPr sz="1800" b="1">
                 <a:solidFill>
                   <a:srgbClr val="F5F3EF"/>
                 </a:solidFill>
                 <a:latin typeface="Inter"/>
-              </a:defRPr>
-            </a:pPr>
-            <a:r>
-              <a:t>Four systems. No traceable decision.</a:t>
-            </a:r>
-          </a:p>
-          <a:p>
-            <a:pPr algn="ctr">
-              <a:defRPr sz="1100" b="1">
-                <a:solidFill>
-                  <a:srgbClr val="00D1A7"/>
-                </a:solidFill>
-                <a:latin typeface="IBM Plex Mono"/>
               </a:defRPr>
             </a:pPr>
             <a:r>
@@ -5471,7 +5403,7 @@
           <a:p>
             <a:br/>
             <a:pPr algn="ctr">
-              <a:defRPr sz="1000">
+              <a:defRPr sz="1150">
                 <a:solidFill>
                   <a:srgbClr val="D1D5DB"/>
                 </a:solidFill>
@@ -5479,18 +5411,13 @@
               </a:defRPr>
             </a:pPr>
             <a:r>
-              <a:t>Today the seller opens 4 tabs, then decides alone. A wrong refund loses inventory; an unfair denial loses a repeat customer.</a:t>
-            </a:r>
-            <a:br/>
-            <a:br/>
-            <a:r>
-              <a:t>The gap is not a missing returns portal, but the absence of a unified record connecting order, video frames, courier scans, and policy terms.</a:t>
+              <a:t>Today the seller opens 4 browser tabs and guesses. An erroneous refund burns inventory margin; an unfair denial destroys repeat customer trust. The gap is the absence of an auditable artifact tying order truth, video keyframes, and policy clauses together before money moves.</a:t>
             </a:r>
           </a:p>
           <a:p>
             <a:br/>
             <a:pPr algn="ctr">
-              <a:defRPr sz="1400" b="1">
+              <a:defRPr sz="1600" b="1">
                 <a:solidFill>
                   <a:srgbClr val="D95D39"/>
                 </a:solidFill>
@@ -5503,7 +5430,7 @@
           </a:p>
           <a:p>
             <a:pPr algn="ctr">
-              <a:defRPr sz="850">
+              <a:defRPr sz="900">
                 <a:solidFill>
                   <a:srgbClr val="9CA3AF"/>
                 </a:solidFill>
@@ -5511,11 +5438,11 @@
               </a:defRPr>
             </a:pPr>
             <a:r>
-              <a:t>9% Return Fraud (NRF 2025, fraud only)  |  15.14% (Appriss/Deloitte 2024, fraud + abuse)</a:t>
+              <a:t>9.0% Return Fraud (NRF 2025, fraud only)  |  15.14% Fraud + Policy Abuse (Appriss/Deloitte 2024)</a:t>
             </a:r>
             <a:br/>
             <a:r>
-              <a:t>Definitions differ: strict fraud vs fraud combined with policy abuse.</a:t>
+              <a:t>Definitions differ: strict criminal fraud vs fraud combined with policy abuse.</a:t>
             </a:r>
           </a:p>
         </p:txBody>
@@ -5528,8 +5455,8 @@
         </p:nvSpPr>
         <p:spPr>
           <a:xfrm>
-            <a:off x="8168335" y="2377440"/>
-            <a:ext cx="3291840" cy="1737360"/>
+            <a:off x="8259775" y="2240280"/>
+            <a:ext cx="3200400" cy="1783080"/>
           </a:xfrm>
           <a:prstGeom prst="rect">
             <a:avLst/>
@@ -5537,7 +5464,7 @@
           <a:solidFill>
             <a:srgbClr val="FFFFFF"/>
           </a:solidFill>
-          <a:ln>
+          <a:ln w="12700">
             <a:solidFill>
               <a:srgbClr val="E2DED4"/>
             </a:solidFill>
@@ -5570,12 +5497,12 @@
               </a:defRPr>
             </a:pPr>
             <a:r>
-              <a:t>02 ORDER RECORD</a:t>
+              <a:t>02 STORE ORDER TRUTH</a:t>
             </a:r>
           </a:p>
           <a:p>
             <a:pPr>
-              <a:defRPr sz="1300" b="1">
+              <a:defRPr sz="1400" b="1">
                 <a:solidFill>
                   <a:srgbClr val="172621"/>
                 </a:solidFill>
@@ -5583,12 +5510,12 @@
               </a:defRPr>
             </a:pPr>
             <a:r>
-              <a:t>White Headphones · ₹4,999</a:t>
+              <a:t>Store Order Truth</a:t>
             </a:r>
           </a:p>
           <a:p>
             <a:pPr>
-              <a:defRPr sz="1000">
+              <a:defRPr sz="1100">
                 <a:solidFill>
                   <a:srgbClr val="596E64"/>
                 </a:solidFill>
@@ -5596,7 +5523,7 @@
               </a:defRPr>
             </a:pPr>
             <a:r>
-              <a:t>Shopify mock store API product inventory catalog</a:t>
+              <a:t>Shopify store catalog specifies SKU HEAD-WHT-02 (White, ₹1,499).</a:t>
             </a:r>
           </a:p>
         </p:txBody>
@@ -5609,8 +5536,8 @@
         </p:nvSpPr>
         <p:spPr>
           <a:xfrm>
-            <a:off x="8168335" y="4297680"/>
-            <a:ext cx="3291840" cy="1737360"/>
+            <a:off x="8259775" y="4206240"/>
+            <a:ext cx="3200400" cy="1783080"/>
           </a:xfrm>
           <a:prstGeom prst="rect">
             <a:avLst/>
@@ -5618,7 +5545,7 @@
           <a:solidFill>
             <a:srgbClr val="FFFFFF"/>
           </a:solidFill>
-          <a:ln>
+          <a:ln w="12700">
             <a:solidFill>
               <a:srgbClr val="E2DED4"/>
             </a:solidFill>
@@ -5651,12 +5578,12 @@
               </a:defRPr>
             </a:pPr>
             <a:r>
-              <a:t>04 RETURN POLICY</a:t>
+              <a:t>04 STORE RETURN POLICY</a:t>
             </a:r>
           </a:p>
           <a:p>
             <a:pPr>
-              <a:defRPr sz="1300" b="1">
+              <a:defRPr sz="1400" b="1">
                 <a:solidFill>
                   <a:srgbClr val="172621"/>
                 </a:solidFill>
@@ -5664,12 +5591,12 @@
               </a:defRPr>
             </a:pPr>
             <a:r>
-              <a:t>7-Day Window · Sealed Tag</a:t>
+              <a:t>Store Return Policy</a:t>
             </a:r>
           </a:p>
           <a:p>
             <a:pPr>
-              <a:defRPr sz="1000">
+              <a:defRPr sz="1100">
                 <a:solidFill>
                   <a:srgbClr val="596E64"/>
                 </a:solidFill>
@@ -5677,7 +5604,7 @@
               </a:defRPr>
             </a:pPr>
             <a:r>
-              <a:t>Deterministic code rules P-01 to P-08, never prompts</a:t>
+              <a:t>7-day defect window and tag condition in store terms.</a:t>
             </a:r>
           </a:p>
         </p:txBody>
@@ -5690,7 +5617,7 @@
         </p:nvSpPr>
         <p:spPr>
           <a:xfrm>
-            <a:off x="731520" y="6263640"/>
+            <a:off x="731520" y="6327648"/>
             <a:ext cx="10728655" cy="13716"/>
           </a:xfrm>
           <a:prstGeom prst="rect">
@@ -5733,7 +5660,7 @@
         </p:nvSpPr>
         <p:spPr>
           <a:xfrm>
-            <a:off x="731520" y="6336792"/>
+            <a:off x="731520" y="6382512"/>
             <a:ext cx="8229600" cy="365760"/>
           </a:xfrm>
           <a:prstGeom prst="rect">
@@ -5748,7 +5675,7 @@
           <a:lstStyle/>
           <a:p>
             <a:pPr>
-              <a:defRPr sz="1000">
+              <a:defRPr sz="950">
                 <a:solidFill>
                   <a:srgbClr val="7A8E85"/>
                 </a:solidFill>
@@ -5756,7 +5683,7 @@
               </a:defRPr>
             </a:pPr>
             <a:r>
-              <a:t>Fraud estimates differ by definition: 9% (NRF 2025, fraud only) vs 15.14% (Appriss/Deloitte 2024, fraud + abuse).</a:t>
+              <a:t>Fraud statistics note: 9.0% (NRF 2025, fraud only) vs 15.14% (Appriss/Deloitte 2024, fraud + abuse)</a:t>
             </a:r>
           </a:p>
         </p:txBody>
@@ -5769,7 +5696,7 @@
         </p:nvSpPr>
         <p:spPr>
           <a:xfrm>
-            <a:off x="9144000" y="6336792"/>
+            <a:off x="9144000" y="6382512"/>
             <a:ext cx="2316175" cy="365760"/>
           </a:xfrm>
           <a:prstGeom prst="rect">
@@ -5784,7 +5711,7 @@
           <a:lstStyle/>
           <a:p>
             <a:pPr algn="r">
-              <a:defRPr sz="1000">
+              <a:defRPr sz="950">
                 <a:solidFill>
                   <a:srgbClr val="7A8E85"/>
                 </a:solidFill>
@@ -5889,7 +5816,7 @@
               </a:defRPr>
             </a:pPr>
             <a:r>
-              <a:t>STAR DEMO · VISUAL GROUNDING &amp; COLOR CONTRADICTION</a:t>
+              <a:t>VISUAL EVIDENCE BENCHMARK · STAR DEMO</a:t>
             </a:r>
           </a:p>
         </p:txBody>
@@ -5903,7 +5830,7 @@
         <p:spPr>
           <a:xfrm>
             <a:off x="731520" y="868680"/>
-            <a:ext cx="10698480" cy="731520"/>
+            <a:ext cx="10698480" cy="685800"/>
           </a:xfrm>
           <a:prstGeom prst="rect">
             <a:avLst/>
@@ -5938,8 +5865,8 @@
         </p:nvSpPr>
         <p:spPr>
           <a:xfrm>
-            <a:off x="731520" y="1600200"/>
-            <a:ext cx="10698480" cy="457200"/>
+            <a:off x="731520" y="1554480"/>
+            <a:ext cx="10698480" cy="411480"/>
           </a:xfrm>
           <a:prstGeom prst="rect">
             <a:avLst/>
@@ -5961,7 +5888,7 @@
               </a:defRPr>
             </a:pPr>
             <a:r>
-              <a:t>ReturnLens extracts keyframes, flags color discrepancies, and halts auto-payout for seller approval.</a:t>
+              <a:t>ReturnLens flags the contradiction — the seller decides.</a:t>
             </a:r>
           </a:p>
         </p:txBody>
@@ -5974,8 +5901,8 @@
         </p:nvSpPr>
         <p:spPr>
           <a:xfrm>
-            <a:off x="731520" y="2148840"/>
-            <a:ext cx="6766560" cy="3977639"/>
+            <a:off x="731520" y="2057400"/>
+            <a:ext cx="7040880" cy="4069080"/>
           </a:xfrm>
           <a:prstGeom prst="rect">
             <a:avLst/>
@@ -6011,16 +5938,64 @@
           </a:p>
         </p:txBody>
       </p:sp>
-      <p:sp>
-        <p:nvSpPr>
-          <p:cNvPr id="7" name="Rectangle 6"/>
+      <p:pic>
+        <p:nvPicPr>
+          <p:cNvPr id="7" name="Picture 6" descr="studio_white_headphones.jpg"/>
+          <p:cNvPicPr>
+            <a:picLocks noChangeAspect="1"/>
+          </p:cNvPicPr>
+          <p:nvPr/>
+        </p:nvPicPr>
+        <p:blipFill>
+          <a:blip r:embed="rId2"/>
+          <a:stretch>
+            <a:fillRect/>
+          </a:stretch>
+        </p:blipFill>
+        <p:spPr>
+          <a:xfrm>
+            <a:off x="914400" y="2240280"/>
+            <a:ext cx="3246120" cy="2560320"/>
+          </a:xfrm>
+          <a:prstGeom prst="rect">
+            <a:avLst/>
+          </a:prstGeom>
+        </p:spPr>
+      </p:pic>
+      <p:pic>
+        <p:nvPicPr>
+          <p:cNvPr id="8" name="Picture 7" descr="unboxing_black_headphones.jpg"/>
+          <p:cNvPicPr>
+            <a:picLocks noChangeAspect="1"/>
+          </p:cNvPicPr>
+          <p:nvPr/>
+        </p:nvPicPr>
+        <p:blipFill>
+          <a:blip r:embed="rId3"/>
+          <a:stretch>
+            <a:fillRect/>
+          </a:stretch>
+        </p:blipFill>
+        <p:spPr>
+          <a:xfrm>
+            <a:off x="4343400" y="2240280"/>
+            <a:ext cx="3246120" cy="2560320"/>
+          </a:xfrm>
+          <a:prstGeom prst="rect">
+            <a:avLst/>
+          </a:prstGeom>
+        </p:spPr>
+      </p:pic>
+      <p:sp>
+        <p:nvSpPr>
+          <p:cNvPr id="9" name="Rectangle 8"/>
           <p:cNvSpPr/>
           <p:nvPr/>
         </p:nvSpPr>
         <p:spPr>
           <a:xfrm>
-            <a:off x="914400" y="4983480"/>
-            <a:ext cx="3108960" cy="320040"/>
+            <a:off x="914400" y="4892040"/>
+            <a:ext cx="3246120" cy="320040"/>
           </a:xfrm>
           <a:prstGeom prst="rect">
             <a:avLst/>
@@ -6051,7 +6026,7 @@
           <a:lstStyle/>
           <a:p>
             <a:pPr algn="ctr">
-              <a:defRPr sz="950" b="1">
+              <a:defRPr sz="900" b="1">
                 <a:solidFill>
                   <a:srgbClr val="006B55"/>
                 </a:solidFill>
@@ -6059,21 +6034,21 @@
               </a:defRPr>
             </a:pPr>
             <a:r>
-              <a:t>ORDER MANIFEST: WHITE HEADPHONES</a:t>
-            </a:r>
-          </a:p>
-        </p:txBody>
-      </p:sp>
-      <p:sp>
-        <p:nvSpPr>
-          <p:cNvPr id="8" name="Rectangle 7"/>
+              <a:t>STORE CATALOG TRUTH: HEAD-WHT-02 (WHITE)</a:t>
+            </a:r>
+          </a:p>
+        </p:txBody>
+      </p:sp>
+      <p:sp>
+        <p:nvSpPr>
+          <p:cNvPr id="10" name="Rectangle 9"/>
           <p:cNvSpPr/>
           <p:nvPr/>
         </p:nvSpPr>
         <p:spPr>
           <a:xfrm>
-            <a:off x="4206240" y="4983480"/>
-            <a:ext cx="3108960" cy="320040"/>
+            <a:off x="4343400" y="4892040"/>
+            <a:ext cx="3246120" cy="320040"/>
           </a:xfrm>
           <a:prstGeom prst="rect">
             <a:avLst/>
@@ -6104,29 +6079,29 @@
           <a:lstStyle/>
           <a:p>
             <a:pPr algn="ctr">
-              <a:defRPr sz="950" b="1">
-                <a:solidFill>
-                  <a:srgbClr val="D95D39"/>
+              <a:defRPr sz="900" b="1">
+                <a:solidFill>
+                  <a:srgbClr val="991B1B"/>
                 </a:solidFill>
                 <a:latin typeface="IBM Plex Mono"/>
               </a:defRPr>
             </a:pPr>
             <a:r>
-              <a:t>UNBOXING KEYFRAME 00:07: BLACK ITEM</a:t>
-            </a:r>
-          </a:p>
-        </p:txBody>
-      </p:sp>
-      <p:sp>
-        <p:nvSpPr>
-          <p:cNvPr id="9" name="TextBox 8"/>
+              <a:t>UNBOXING KEYFRAME (STAGED): MIDNIGHT BLACK</a:t>
+            </a:r>
+          </a:p>
+        </p:txBody>
+      </p:sp>
+      <p:sp>
+        <p:nvSpPr>
+          <p:cNvPr id="11" name="TextBox 10"/>
           <p:cNvSpPr txBox="1"/>
           <p:nvPr/>
         </p:nvSpPr>
         <p:spPr>
           <a:xfrm>
-            <a:off x="914400" y="5394960"/>
-            <a:ext cx="6400800" cy="640080"/>
+            <a:off x="914400" y="5303520"/>
+            <a:ext cx="6675120" cy="731520"/>
           </a:xfrm>
           <a:prstGeom prst="rect">
             <a:avLst/>
@@ -6140,7 +6115,7 @@
           <a:lstStyle/>
           <a:p>
             <a:pPr>
-              <a:defRPr sz="950">
+              <a:defRPr sz="1000">
                 <a:solidFill>
                   <a:srgbClr val="596E64"/>
                 </a:solidFill>
@@ -6148,21 +6123,21 @@
               </a:defRPr>
             </a:pPr>
             <a:r>
-              <a:t>Visual Grounding Honesty: Keyframe resolution reveals black casing. Exact SKU barcode is unreadable in this frame; ReturnLens factually records 'Observed Color: Black · Exact SKU: Not verified' and cites frame 00:07.</a:t>
-            </a:r>
-          </a:p>
-        </p:txBody>
-      </p:sp>
-      <p:sp>
-        <p:nvSpPr>
-          <p:cNvPr id="10" name="Rectangle 9"/>
+              <a:t>Visual Grounding Honesty: Keyframe resolution reveals black casing. Exact SKU barcode is unreadable in this frame; ReturnLens factually records 'Observed Color: Midnight Black · Exact SKU: Not verified' and cites frame 00:07.</a:t>
+            </a:r>
+          </a:p>
+        </p:txBody>
+      </p:sp>
+      <p:sp>
+        <p:nvSpPr>
+          <p:cNvPr id="12" name="Rectangle 11"/>
           <p:cNvSpPr/>
           <p:nvPr/>
         </p:nvSpPr>
         <p:spPr>
           <a:xfrm>
-            <a:off x="7726679" y="2148840"/>
-            <a:ext cx="3733495" cy="3977639"/>
+            <a:off x="8001000" y="2057400"/>
+            <a:ext cx="3459175" cy="4069080"/>
           </a:xfrm>
           <a:prstGeom prst="rect">
             <a:avLst/>
@@ -6200,14 +6175,14 @@
       </p:sp>
       <p:sp>
         <p:nvSpPr>
-          <p:cNvPr id="11" name="TextBox 10"/>
+          <p:cNvPr id="13" name="TextBox 12"/>
           <p:cNvSpPr txBox="1"/>
           <p:nvPr/>
         </p:nvSpPr>
         <p:spPr>
           <a:xfrm>
-            <a:off x="7909559" y="2286000"/>
-            <a:ext cx="3367735" cy="3749039"/>
+            <a:off x="8183880" y="2194560"/>
+            <a:ext cx="3093415" cy="3794760"/>
           </a:xfrm>
           <a:prstGeom prst="rect">
             <a:avLst/>
@@ -6234,7 +6209,7 @@
           </a:p>
           <a:p>
             <a:pPr>
-              <a:defRPr sz="1400" b="1">
+              <a:defRPr sz="1600" b="1">
                 <a:solidFill>
                   <a:srgbClr val="991B1B"/>
                 </a:solidFill>
@@ -6242,12 +6217,12 @@
               </a:defRPr>
             </a:pPr>
             <a:r>
-              <a:t>P-03 Check: COLOR CONTRADICTION</a:t>
+              <a:t>P-03: COLOR CONTRADICTION</a:t>
             </a:r>
           </a:p>
           <a:p>
             <a:pPr>
-              <a:defRPr sz="850" b="1">
+              <a:defRPr sz="900" b="1">
                 <a:solidFill>
                   <a:srgbClr val="991B1B"/>
                 </a:solidFill>
@@ -6255,11 +6230,25 @@
               </a:defRPr>
             </a:pPr>
             <a:r>
-              <a:t>STATUS: ESCALATE (SELLER REVIEW REQUIRED)</a:t>
+              <a:t>SELLER REVIEW REQUIRED</a:t>
             </a:r>
             <a:br/>
             <a:r>
-              <a:t>Observed Color: Midnight Black · Exact SKU: Not verified</a:t>
+              <a:t>Observed: Midnight Black · Exact SKU: Not verified in frame</a:t>
+            </a:r>
+          </a:p>
+          <a:p>
+            <a:br/>
+            <a:pPr>
+              <a:defRPr sz="1100" b="1">
+                <a:solidFill>
+                  <a:srgbClr val="172621"/>
+                </a:solidFill>
+                <a:latin typeface="Inter"/>
+              </a:defRPr>
+            </a:pPr>
+            <a:r>
+              <a:t>Seller Resolution Options:</a:t>
             </a:r>
           </a:p>
           <a:p>
@@ -6272,33 +6261,33 @@
               </a:defRPr>
             </a:pPr>
             <a:r>
-              <a:t>Customer claim contradicts visual evidence. Automated return label and refund payout are inhibited.</a:t>
-            </a:r>
-          </a:p>
-          <a:p>
-            <a:br/>
+              <a:t>1. Request unboxing video with packaging label / serial visible</a:t>
+            </a:r>
+          </a:p>
+          <a:p>
             <a:pPr>
-              <a:defRPr sz="900">
-                <a:solidFill>
-                  <a:srgbClr val="172621"/>
+              <a:defRPr sz="950">
+                <a:solidFill>
+                  <a:srgbClr val="596E64"/>
                 </a:solidFill>
                 <a:latin typeface="Inter"/>
               </a:defRPr>
             </a:pPr>
             <a:r>
-              <a:t>Seller Resolution Options:</a:t>
-            </a:r>
-            <a:br/>
-            <a:r>
-              <a:t>1. Request unboxing video with packaging label / serial visible</a:t>
-            </a:r>
-            <a:br/>
-            <a:r>
-              <a:t>2. Reject return under Clause 4.2 (Item does not match order)</a:t>
-            </a:r>
-            <a:br/>
-            <a:r>
-              <a:t>3. Override &amp; approve if seller acknowledges warehouse error</a:t>
+              <a:t>2. Reject return under policy (item does not match order record)</a:t>
+            </a:r>
+          </a:p>
+          <a:p>
+            <a:pPr>
+              <a:defRPr sz="950">
+                <a:solidFill>
+                  <a:srgbClr val="596E64"/>
+                </a:solidFill>
+                <a:latin typeface="Inter"/>
+              </a:defRPr>
+            </a:pPr>
+            <a:r>
+              <a:t>3. Override &amp; approve if seller acknowledges known warehouse mis-shipment</a:t>
             </a:r>
           </a:p>
           <a:p>
@@ -6316,24 +6305,24 @@
             </a:r>
             <a:br/>
             <a:r>
-              <a:t>max_refund = min(₹4,999, remaining refundable, order paid amount)</a:t>
+              <a:t>0 &lt; amount &lt;= min(₹4,999, remaining_refundable, order_paid)</a:t>
             </a:r>
             <a:br/>
             <a:r>
-              <a:t>No automatic customer denial · No refund released without seller click</a:t>
-            </a:r>
-          </a:p>
-        </p:txBody>
-      </p:sp>
-      <p:sp>
-        <p:nvSpPr>
-          <p:cNvPr id="12" name="Rectangle 11"/>
+              <a:t>No auto-denial · No refund released without seller click</a:t>
+            </a:r>
+          </a:p>
+        </p:txBody>
+      </p:sp>
+      <p:sp>
+        <p:nvSpPr>
+          <p:cNvPr id="14" name="Rectangle 13"/>
           <p:cNvSpPr/>
           <p:nvPr/>
         </p:nvSpPr>
         <p:spPr>
           <a:xfrm>
-            <a:off x="731520" y="6263640"/>
+            <a:off x="731520" y="6327648"/>
             <a:ext cx="10728655" cy="13716"/>
           </a:xfrm>
           <a:prstGeom prst="rect">
@@ -6370,13 +6359,13 @@
       </p:sp>
       <p:sp>
         <p:nvSpPr>
-          <p:cNvPr id="13" name="TextBox 12"/>
+          <p:cNvPr id="15" name="TextBox 14"/>
           <p:cNvSpPr txBox="1"/>
           <p:nvPr/>
         </p:nvSpPr>
         <p:spPr>
           <a:xfrm>
-            <a:off x="731520" y="6336792"/>
+            <a:off x="731520" y="6382512"/>
             <a:ext cx="8229600" cy="365760"/>
           </a:xfrm>
           <a:prstGeom prst="rect">
@@ -6391,7 +6380,7 @@
           <a:lstStyle/>
           <a:p>
             <a:pPr>
-              <a:defRPr sz="1000">
+              <a:defRPr sz="950">
                 <a:solidFill>
                   <a:srgbClr val="7A8E85"/>
                 </a:solidFill>
@@ -6406,13 +6395,13 @@
       </p:sp>
       <p:sp>
         <p:nvSpPr>
-          <p:cNvPr id="14" name="TextBox 13"/>
+          <p:cNvPr id="16" name="TextBox 15"/>
           <p:cNvSpPr txBox="1"/>
           <p:nvPr/>
         </p:nvSpPr>
         <p:spPr>
           <a:xfrm>
-            <a:off x="9144000" y="6336792"/>
+            <a:off x="9144000" y="6382512"/>
             <a:ext cx="2316175" cy="365760"/>
           </a:xfrm>
           <a:prstGeom prst="rect">
@@ -6427,7 +6416,7 @@
           <a:lstStyle/>
           <a:p>
             <a:pPr algn="r">
-              <a:defRPr sz="1000">
+              <a:defRPr sz="950">
                 <a:solidFill>
                   <a:srgbClr val="7A8E85"/>
                 </a:solidFill>
@@ -6545,8 +6534,8 @@
         </p:nvSpPr>
         <p:spPr>
           <a:xfrm>
-            <a:off x="731520" y="822960"/>
-            <a:ext cx="10698480" cy="640080"/>
+            <a:off x="731520" y="868680"/>
+            <a:ext cx="10698480" cy="685800"/>
           </a:xfrm>
           <a:prstGeom prst="rect">
             <a:avLst/>
@@ -6581,7 +6570,7 @@
         </p:nvSpPr>
         <p:spPr>
           <a:xfrm>
-            <a:off x="731520" y="1417320"/>
+            <a:off x="731520" y="1508760"/>
             <a:ext cx="10698480" cy="411480"/>
           </a:xfrm>
           <a:prstGeom prst="rect">
@@ -6617,8 +6606,8 @@
         </p:nvSpPr>
         <p:spPr>
           <a:xfrm>
-            <a:off x="731520" y="1874519"/>
-            <a:ext cx="1600200" cy="1051560"/>
+            <a:off x="731520" y="2057400"/>
+            <a:ext cx="1600200" cy="1234440"/>
           </a:xfrm>
           <a:prstGeom prst="rect">
             <a:avLst/>
@@ -6651,7 +6640,7 @@
           <a:lstStyle/>
           <a:p>
             <a:pPr algn="ctr">
-              <a:defRPr sz="850">
+              <a:defRPr sz="900">
                 <a:solidFill>
                   <a:srgbClr val="6C8279"/>
                 </a:solidFill>
@@ -6664,7 +6653,7 @@
           </a:p>
           <a:p>
             <a:pPr>
-              <a:defRPr sz="1100" b="1">
+              <a:defRPr sz="1300" b="1">
                 <a:solidFill>
                   <a:srgbClr val="F5F3EF"/>
                 </a:solidFill>
@@ -6672,7 +6661,20 @@
               </a:defRPr>
             </a:pPr>
             <a:r>
-              <a:t>Planner</a:t>
+              <a:t>Plan</a:t>
+            </a:r>
+          </a:p>
+          <a:p>
+            <a:pPr>
+              <a:defRPr sz="900">
+                <a:solidFill>
+                  <a:srgbClr val="A3B8B0"/>
+                </a:solidFill>
+                <a:latin typeface="Inter"/>
+              </a:defRPr>
+            </a:pPr>
+            <a:r>
+              <a:t>Typed plan schema</a:t>
             </a:r>
           </a:p>
         </p:txBody>
@@ -6685,7 +6687,7 @@
         </p:nvSpPr>
         <p:spPr>
           <a:xfrm>
-            <a:off x="731520" y="1874519"/>
+            <a:off x="731520" y="2057400"/>
             <a:ext cx="1600200" cy="36576"/>
           </a:xfrm>
           <a:prstGeom prst="rect">
@@ -6728,7 +6730,7 @@
         </p:nvSpPr>
         <p:spPr>
           <a:xfrm>
-            <a:off x="822960" y="2587751"/>
+            <a:off x="822960" y="2926080"/>
             <a:ext cx="1417320" cy="237744"/>
           </a:xfrm>
           <a:prstGeom prst="rect">
@@ -6781,7 +6783,7 @@
         </p:nvSpPr>
         <p:spPr>
           <a:xfrm>
-            <a:off x="2331720" y="2194559"/>
+            <a:off x="2331720" y="2423160"/>
             <a:ext cx="219456" cy="365760"/>
           </a:xfrm>
           <a:prstGeom prst="rect">
@@ -6817,8 +6819,8 @@
         </p:nvSpPr>
         <p:spPr>
           <a:xfrm>
-            <a:off x="2551176" y="1874519"/>
-            <a:ext cx="1600200" cy="1051560"/>
+            <a:off x="2551176" y="2057400"/>
+            <a:ext cx="1600200" cy="1234440"/>
           </a:xfrm>
           <a:prstGeom prst="rect">
             <a:avLst/>
@@ -6851,7 +6853,7 @@
           <a:lstStyle/>
           <a:p>
             <a:pPr algn="ctr">
-              <a:defRPr sz="850">
+              <a:defRPr sz="900">
                 <a:solidFill>
                   <a:srgbClr val="6C8279"/>
                 </a:solidFill>
@@ -6864,7 +6866,7 @@
           </a:p>
           <a:p>
             <a:pPr>
-              <a:defRPr sz="1100" b="1">
+              <a:defRPr sz="1300" b="1">
                 <a:solidFill>
                   <a:srgbClr val="F5F3EF"/>
                 </a:solidFill>
@@ -6872,7 +6874,20 @@
               </a:defRPr>
             </a:pPr>
             <a:r>
-              <a:t>Tools &amp; Video</a:t>
+              <a:t>Retrieve</a:t>
+            </a:r>
+          </a:p>
+          <a:p>
+            <a:pPr>
+              <a:defRPr sz="900">
+                <a:solidFill>
+                  <a:srgbClr val="A3B8B0"/>
+                </a:solidFill>
+                <a:latin typeface="Inter"/>
+              </a:defRPr>
+            </a:pPr>
+            <a:r>
+              <a:t>FFmpeg &amp; mock APIs</a:t>
             </a:r>
           </a:p>
         </p:txBody>
@@ -6885,7 +6900,7 @@
         </p:nvSpPr>
         <p:spPr>
           <a:xfrm>
-            <a:off x="2551176" y="1874519"/>
+            <a:off x="2551176" y="2057400"/>
             <a:ext cx="1600200" cy="36576"/>
           </a:xfrm>
           <a:prstGeom prst="rect">
@@ -6928,7 +6943,7 @@
         </p:nvSpPr>
         <p:spPr>
           <a:xfrm>
-            <a:off x="2642616" y="2587751"/>
+            <a:off x="2642616" y="2926080"/>
             <a:ext cx="1417320" cy="237744"/>
           </a:xfrm>
           <a:prstGeom prst="rect">
@@ -6981,7 +6996,7 @@
         </p:nvSpPr>
         <p:spPr>
           <a:xfrm>
-            <a:off x="4151376" y="2194559"/>
+            <a:off x="4151376" y="2423160"/>
             <a:ext cx="219456" cy="365760"/>
           </a:xfrm>
           <a:prstGeom prst="rect">
@@ -7017,8 +7032,8 @@
         </p:nvSpPr>
         <p:spPr>
           <a:xfrm>
-            <a:off x="4370832" y="1874519"/>
-            <a:ext cx="1600200" cy="1051560"/>
+            <a:off x="4370832" y="2057400"/>
+            <a:ext cx="1600200" cy="1234440"/>
           </a:xfrm>
           <a:prstGeom prst="rect">
             <a:avLst/>
@@ -7051,7 +7066,7 @@
           <a:lstStyle/>
           <a:p>
             <a:pPr algn="ctr">
-              <a:defRPr sz="850">
+              <a:defRPr sz="900">
                 <a:solidFill>
                   <a:srgbClr val="6C8279"/>
                 </a:solidFill>
@@ -7064,7 +7079,7 @@
           </a:p>
           <a:p>
             <a:pPr>
-              <a:defRPr sz="1100" b="1">
+              <a:defRPr sz="1300" b="1">
                 <a:solidFill>
                   <a:srgbClr val="F5F3EF"/>
                 </a:solidFill>
@@ -7072,7 +7087,20 @@
               </a:defRPr>
             </a:pPr>
             <a:r>
-              <a:t>Policy Engine</a:t>
+              <a:t>Evaluate</a:t>
+            </a:r>
+          </a:p>
+          <a:p>
+            <a:pPr>
+              <a:defRPr sz="900">
+                <a:solidFill>
+                  <a:srgbClr val="A3B8B0"/>
+                </a:solidFill>
+                <a:latin typeface="Inter"/>
+              </a:defRPr>
+            </a:pPr>
+            <a:r>
+              <a:t>Rules P-01 to P-08</a:t>
             </a:r>
           </a:p>
         </p:txBody>
@@ -7085,7 +7113,7 @@
         </p:nvSpPr>
         <p:spPr>
           <a:xfrm>
-            <a:off x="4370832" y="1874519"/>
+            <a:off x="4370832" y="2057400"/>
             <a:ext cx="1600200" cy="36576"/>
           </a:xfrm>
           <a:prstGeom prst="rect">
@@ -7128,7 +7156,7 @@
         </p:nvSpPr>
         <p:spPr>
           <a:xfrm>
-            <a:off x="4462272" y="2587751"/>
+            <a:off x="4462272" y="2926080"/>
             <a:ext cx="1417320" cy="237744"/>
           </a:xfrm>
           <a:prstGeom prst="rect">
@@ -7181,7 +7209,7 @@
         </p:nvSpPr>
         <p:spPr>
           <a:xfrm>
-            <a:off x="5971032" y="2194559"/>
+            <a:off x="5971032" y="2423160"/>
             <a:ext cx="219456" cy="365760"/>
           </a:xfrm>
           <a:prstGeom prst="rect">
@@ -7217,8 +7245,8 @@
         </p:nvSpPr>
         <p:spPr>
           <a:xfrm>
-            <a:off x="6190488" y="1874519"/>
-            <a:ext cx="1600200" cy="1051560"/>
+            <a:off x="6190488" y="2057400"/>
+            <a:ext cx="1600200" cy="1234440"/>
           </a:xfrm>
           <a:prstGeom prst="rect">
             <a:avLst/>
@@ -7251,7 +7279,7 @@
           <a:lstStyle/>
           <a:p>
             <a:pPr algn="ctr">
-              <a:defRPr sz="850">
+              <a:defRPr sz="900">
                 <a:solidFill>
                   <a:srgbClr val="6C8279"/>
                 </a:solidFill>
@@ -7264,7 +7292,7 @@
           </a:p>
           <a:p>
             <a:pPr>
-              <a:defRPr sz="1100" b="1">
+              <a:defRPr sz="1300" b="1">
                 <a:solidFill>
                   <a:srgbClr val="F5F3EF"/>
                 </a:solidFill>
@@ -7272,7 +7300,20 @@
               </a:defRPr>
             </a:pPr>
             <a:r>
-              <a:t>Critic</a:t>
+              <a:t>Audit</a:t>
+            </a:r>
+          </a:p>
+          <a:p>
+            <a:pPr>
+              <a:defRPr sz="900">
+                <a:solidFill>
+                  <a:srgbClr val="A3B8B0"/>
+                </a:solidFill>
+                <a:latin typeface="Inter"/>
+              </a:defRPr>
+            </a:pPr>
+            <a:r>
+              <a:t>Adversarial critic</a:t>
             </a:r>
           </a:p>
         </p:txBody>
@@ -7285,7 +7326,7 @@
         </p:nvSpPr>
         <p:spPr>
           <a:xfrm>
-            <a:off x="6190488" y="1874519"/>
+            <a:off x="6190488" y="2057400"/>
             <a:ext cx="1600200" cy="36576"/>
           </a:xfrm>
           <a:prstGeom prst="rect">
@@ -7328,7 +7369,7 @@
         </p:nvSpPr>
         <p:spPr>
           <a:xfrm>
-            <a:off x="6281928" y="2587751"/>
+            <a:off x="6281928" y="2926080"/>
             <a:ext cx="1417320" cy="237744"/>
           </a:xfrm>
           <a:prstGeom prst="rect">
@@ -7381,7 +7422,7 @@
         </p:nvSpPr>
         <p:spPr>
           <a:xfrm>
-            <a:off x="7790688" y="2194559"/>
+            <a:off x="7790688" y="2423160"/>
             <a:ext cx="219456" cy="365760"/>
           </a:xfrm>
           <a:prstGeom prst="rect">
@@ -7417,8 +7458,8 @@
         </p:nvSpPr>
         <p:spPr>
           <a:xfrm>
-            <a:off x="8010144" y="1874519"/>
-            <a:ext cx="1600200" cy="1051560"/>
+            <a:off x="8010144" y="2057400"/>
+            <a:ext cx="1600200" cy="1234440"/>
           </a:xfrm>
           <a:prstGeom prst="rect">
             <a:avLst/>
@@ -7451,7 +7492,7 @@
           <a:lstStyle/>
           <a:p>
             <a:pPr algn="ctr">
-              <a:defRPr sz="850">
+              <a:defRPr sz="900">
                 <a:solidFill>
                   <a:srgbClr val="6C8279"/>
                 </a:solidFill>
@@ -7464,7 +7505,7 @@
           </a:p>
           <a:p>
             <a:pPr>
-              <a:defRPr sz="1100" b="1">
+              <a:defRPr sz="1300" b="1">
                 <a:solidFill>
                   <a:srgbClr val="F5F3EF"/>
                 </a:solidFill>
@@ -7472,7 +7513,20 @@
               </a:defRPr>
             </a:pPr>
             <a:r>
-              <a:t>Seller Gate</a:t>
+              <a:t>Authorize</a:t>
+            </a:r>
+          </a:p>
+          <a:p>
+            <a:pPr>
+              <a:defRPr sz="900">
+                <a:solidFill>
+                  <a:srgbClr val="A3B8B0"/>
+                </a:solidFill>
+                <a:latin typeface="Inter"/>
+              </a:defRPr>
+            </a:pPr>
+            <a:r>
+              <a:t>Fail-closed gate</a:t>
             </a:r>
           </a:p>
         </p:txBody>
@@ -7485,7 +7539,7 @@
         </p:nvSpPr>
         <p:spPr>
           <a:xfrm>
-            <a:off x="8010144" y="1874519"/>
+            <a:off x="8010144" y="2057400"/>
             <a:ext cx="1600200" cy="36576"/>
           </a:xfrm>
           <a:prstGeom prst="rect">
@@ -7528,7 +7582,7 @@
         </p:nvSpPr>
         <p:spPr>
           <a:xfrm>
-            <a:off x="8101584" y="2587751"/>
+            <a:off x="8101584" y="2926080"/>
             <a:ext cx="1417320" cy="237744"/>
           </a:xfrm>
           <a:prstGeom prst="rect">
@@ -7581,7 +7635,7 @@
         </p:nvSpPr>
         <p:spPr>
           <a:xfrm>
-            <a:off x="9610344" y="2194559"/>
+            <a:off x="9610344" y="2423160"/>
             <a:ext cx="219456" cy="365760"/>
           </a:xfrm>
           <a:prstGeom prst="rect">
@@ -7617,8 +7671,8 @@
         </p:nvSpPr>
         <p:spPr>
           <a:xfrm>
-            <a:off x="9829800" y="1874519"/>
-            <a:ext cx="1600200" cy="1051560"/>
+            <a:off x="9829800" y="2057400"/>
+            <a:ext cx="1600200" cy="1234440"/>
           </a:xfrm>
           <a:prstGeom prst="rect">
             <a:avLst/>
@@ -7651,7 +7705,7 @@
           <a:lstStyle/>
           <a:p>
             <a:pPr algn="ctr">
-              <a:defRPr sz="850">
+              <a:defRPr sz="900">
                 <a:solidFill>
                   <a:srgbClr val="6C8279"/>
                 </a:solidFill>
@@ -7664,7 +7718,7 @@
           </a:p>
           <a:p>
             <a:pPr>
-              <a:defRPr sz="1100" b="1">
+              <a:defRPr sz="1300" b="1">
                 <a:solidFill>
                   <a:srgbClr val="F5F3EF"/>
                 </a:solidFill>
@@ -7672,7 +7726,20 @@
               </a:defRPr>
             </a:pPr>
             <a:r>
-              <a:t>Audit Log</a:t>
+              <a:t>Record</a:t>
+            </a:r>
+          </a:p>
+          <a:p>
+            <a:pPr>
+              <a:defRPr sz="900">
+                <a:solidFill>
+                  <a:srgbClr val="A3B8B0"/>
+                </a:solidFill>
+                <a:latin typeface="Inter"/>
+              </a:defRPr>
+            </a:pPr>
+            <a:r>
+              <a:t>Audit trace log</a:t>
             </a:r>
           </a:p>
         </p:txBody>
@@ -7685,7 +7752,7 @@
         </p:nvSpPr>
         <p:spPr>
           <a:xfrm>
-            <a:off x="9829800" y="1874519"/>
+            <a:off x="9829800" y="2057400"/>
             <a:ext cx="1600200" cy="36576"/>
           </a:xfrm>
           <a:prstGeom prst="rect">
@@ -7728,7 +7795,7 @@
         </p:nvSpPr>
         <p:spPr>
           <a:xfrm>
-            <a:off x="9921240" y="2587751"/>
+            <a:off x="9921240" y="2926080"/>
             <a:ext cx="1417320" cy="237744"/>
           </a:xfrm>
           <a:prstGeom prst="rect">
@@ -7781,8 +7848,8 @@
         </p:nvSpPr>
         <p:spPr>
           <a:xfrm>
-            <a:off x="731520" y="3063240"/>
-            <a:ext cx="5943600" cy="777240"/>
+            <a:off x="731520" y="3474720"/>
+            <a:ext cx="6492240" cy="1554480"/>
           </a:xfrm>
           <a:prstGeom prst="rect">
             <a:avLst/>
@@ -7790,7 +7857,7 @@
           <a:solidFill>
             <a:srgbClr val="14221D"/>
           </a:solidFill>
-          <a:ln w="12700">
+          <a:ln w="19050">
             <a:solidFill>
               <a:srgbClr val="2563EB"/>
             </a:solidFill>
@@ -7815,7 +7882,7 @@
           <a:lstStyle/>
           <a:p>
             <a:pPr algn="ctr">
-              <a:defRPr sz="850" b="1">
+              <a:defRPr sz="1000" b="1">
                 <a:solidFill>
                   <a:srgbClr val="93C5FD"/>
                 </a:solidFill>
@@ -7823,12 +7890,12 @@
               </a:defRPr>
             </a:pPr>
             <a:r>
-              <a:t>DYNAMIC STATEFUL CLARIFICATION LOOP (CASE C) · Observe → Decide → Act → Wait → Resume</a:t>
+              <a:t>CASE C · DYNAMIC STATEFUL CLARIFICATION LOOP</a:t>
             </a:r>
           </a:p>
           <a:p>
             <a:pPr>
-              <a:defRPr sz="950" b="1">
+              <a:defRPr sz="1100" b="1">
                 <a:solidFill>
                   <a:srgbClr val="F5F3EF"/>
                 </a:solidFill>
@@ -7837,6 +7904,19 @@
             </a:pPr>
             <a:r>
               <a:t>Dark Frames → ask_for_evidence() → WAITING_FOR_EVIDENCE → Customer Uploads → Resume Case</a:t>
+            </a:r>
+          </a:p>
+          <a:p>
+            <a:pPr>
+              <a:defRPr sz="950">
+                <a:solidFill>
+                  <a:srgbClr val="A3B8B0"/>
+                </a:solidFill>
+                <a:latin typeface="Inter"/>
+              </a:defRPr>
+            </a:pPr>
+            <a:r>
+              <a:t>Agentic State Machine: When lighting is insufficient, the agent halts standard execution, prompts a targeted checklist, pauses state in WAITING_FOR_EVIDENCE, and seamlessly resumes context upon media receipt (1 retry limit protects customer experience).</a:t>
             </a:r>
           </a:p>
         </p:txBody>
@@ -7849,8 +7929,8 @@
         </p:nvSpPr>
         <p:spPr>
           <a:xfrm>
-            <a:off x="6812280" y="3063240"/>
-            <a:ext cx="4647895" cy="777240"/>
+            <a:off x="7436815" y="3474720"/>
+            <a:ext cx="4023360" cy="1554480"/>
           </a:xfrm>
           <a:prstGeom prst="rect">
             <a:avLst/>
@@ -7858,7 +7938,7 @@
           <a:solidFill>
             <a:srgbClr val="14221D"/>
           </a:solidFill>
-          <a:ln w="12700">
+          <a:ln w="19050">
             <a:solidFill>
               <a:srgbClr val="059669"/>
             </a:solidFill>
@@ -7883,20 +7963,20 @@
           <a:lstStyle/>
           <a:p>
             <a:pPr algn="ctr">
-              <a:defRPr sz="850" b="1">
-                <a:solidFill>
-                  <a:srgbClr val="34D399"/>
+              <a:defRPr sz="1000" b="1">
+                <a:solidFill>
+                  <a:srgbClr val="00D1A7"/>
                 </a:solidFill>
                 <a:latin typeface="IBM Plex Mono"/>
               </a:defRPr>
             </a:pPr>
             <a:r>
-              <a:t>ORDER STATUS FAST PATH (PS-04 FIT) · Zero-Vision Direct Route</a:t>
+              <a:t>SECONDARY PS-04 ROUTE · ORDER STATUS FAST PATH</a:t>
             </a:r>
           </a:p>
           <a:p>
             <a:pPr>
-              <a:defRPr sz="950" b="1">
+              <a:defRPr sz="1100" b="1">
                 <a:solidFill>
                   <a:srgbClr val="F5F3EF"/>
                 </a:solidFill>
@@ -7904,7 +7984,24 @@
               </a:defRPr>
             </a:pPr>
             <a:r>
-              <a:t>“Where is my order?” → Query Store &amp; Shippo APIs → Delivery Scan &amp; Time</a:t>
+              <a:t>“Where is my order?” → Direct Mock Store &amp; Courier Scan</a:t>
+            </a:r>
+          </a:p>
+          <a:p>
+            <a:pPr>
+              <a:defRPr sz="950">
+                <a:solidFill>
+                  <a:srgbClr val="A3B8B0"/>
+                </a:solidFill>
+                <a:latin typeface="Inter"/>
+              </a:defRPr>
+            </a:pPr>
+            <a:r>
+              <a:t>Instant delivery timestamp &amp; scan (Zero-vision overhead)</a:t>
+            </a:r>
+            <a:br/>
+            <a:r>
+              <a:t>Routine order queries take a direct tool route without calling heavy multimodal models. Escalates to human seller only if courier scan shows abnormal transit delay.</a:t>
             </a:r>
           </a:p>
         </p:txBody>
@@ -7917,8 +8014,8 @@
         </p:nvSpPr>
         <p:spPr>
           <a:xfrm>
-            <a:off x="731520" y="3977639"/>
-            <a:ext cx="2560320" cy="1051560"/>
+            <a:off x="731520" y="5212080"/>
+            <a:ext cx="10728655" cy="960120"/>
           </a:xfrm>
           <a:prstGeom prst="rect">
             <a:avLst/>
@@ -7951,15 +8048,15 @@
           <a:lstStyle/>
           <a:p>
             <a:pPr algn="ctr">
-              <a:defRPr sz="900" b="1">
-                <a:solidFill>
-                  <a:srgbClr val="F87171"/>
+              <a:defRPr sz="900">
+                <a:solidFill>
+                  <a:srgbClr val="A3B8B0"/>
                 </a:solidFill>
                 <a:latin typeface="IBM Plex Mono"/>
               </a:defRPr>
             </a:pPr>
             <a:r>
-              <a:t>1. CONTRADICTION → ESCALATE</a:t>
+              <a:t>■ Model Calls: 3 base LLM calls per triage case (Planner, Vision, Critic) plus retries.   |   ■ Deterministic Policy: Rules P-01 to P-08 executed in pure Python code, never prompts.</a:t>
             </a:r>
           </a:p>
           <a:p>
@@ -7968,11 +8065,11 @@
                 <a:solidFill>
                   <a:srgbClr val="A3B8B0"/>
                 </a:solidFill>
-                <a:latin typeface="Inter"/>
-              </a:defRPr>
-            </a:pPr>
-            <a:r>
-              <a:t>Discrepancy flagged (e.g. Case B). Inhibits automated label/refund. Seller reviews 3 options.</a:t>
+                <a:latin typeface="IBM Plex Mono"/>
+              </a:defRPr>
+            </a:pPr>
+            <a:r>
+              <a:t>■ Critic Duty: Independent prompt audits cited frames; notes correlated vision limits.   |   ■ Safety Ceiling: Backend checks block payment tools; 1-click human authorization strictly enforced.</a:t>
             </a:r>
           </a:p>
         </p:txBody>
@@ -7985,279 +8082,7 @@
         </p:nvSpPr>
         <p:spPr>
           <a:xfrm>
-            <a:off x="3447288" y="3977639"/>
-            <a:ext cx="2560320" cy="1051560"/>
-          </a:xfrm>
-          <a:prstGeom prst="rect">
-            <a:avLst/>
-          </a:prstGeom>
-          <a:solidFill>
-            <a:srgbClr val="121F1B"/>
-          </a:solidFill>
-          <a:ln w="12700">
-            <a:solidFill>
-              <a:srgbClr val="223830"/>
-            </a:solidFill>
-          </a:ln>
-        </p:spPr>
-        <p:style>
-          <a:lnRef idx="1">
-            <a:schemeClr val="accent1"/>
-          </a:lnRef>
-          <a:fillRef idx="3">
-            <a:schemeClr val="accent1"/>
-          </a:fillRef>
-          <a:effectRef idx="2">
-            <a:schemeClr val="accent1"/>
-          </a:effectRef>
-          <a:fontRef idx="minor">
-            <a:schemeClr val="lt1"/>
-          </a:fontRef>
-        </p:style>
-        <p:txBody>
-          <a:bodyPr rtlCol="0" anchor="ctr" wrap="square"/>
-          <a:lstStyle/>
-          <a:p>
-            <a:pPr algn="ctr">
-              <a:defRPr sz="900" b="1">
-                <a:solidFill>
-                  <a:srgbClr val="FBBF24"/>
-                </a:solidFill>
-                <a:latin typeface="IBM Plex Mono"/>
-              </a:defRPr>
-            </a:pPr>
-            <a:r>
-              <a:t>2. HARD FAIL → ESCALATE</a:t>
-            </a:r>
-          </a:p>
-          <a:p>
-            <a:pPr>
-              <a:defRPr sz="900">
-                <a:solidFill>
-                  <a:srgbClr val="A3B8B0"/>
-                </a:solidFill>
-                <a:latin typeface="Inter"/>
-              </a:defRPr>
-            </a:pPr>
-            <a:r>
-              <a:t>Mandatory rule violation (e.g. expired return window). Seller makes final decision; never auto-deny.</a:t>
-            </a:r>
-          </a:p>
-        </p:txBody>
-      </p:sp>
-      <p:sp>
-        <p:nvSpPr>
-          <p:cNvPr id="33" name="Rectangle 32"/>
-          <p:cNvSpPr/>
-          <p:nvPr/>
-        </p:nvSpPr>
-        <p:spPr>
-          <a:xfrm>
-            <a:off x="6163056" y="3977639"/>
-            <a:ext cx="2560320" cy="1051560"/>
-          </a:xfrm>
-          <a:prstGeom prst="rect">
-            <a:avLst/>
-          </a:prstGeom>
-          <a:solidFill>
-            <a:srgbClr val="121F1B"/>
-          </a:solidFill>
-          <a:ln w="12700">
-            <a:solidFill>
-              <a:srgbClr val="223830"/>
-            </a:solidFill>
-          </a:ln>
-        </p:spPr>
-        <p:style>
-          <a:lnRef idx="1">
-            <a:schemeClr val="accent1"/>
-          </a:lnRef>
-          <a:fillRef idx="3">
-            <a:schemeClr val="accent1"/>
-          </a:fillRef>
-          <a:effectRef idx="2">
-            <a:schemeClr val="accent1"/>
-          </a:effectRef>
-          <a:fontRef idx="minor">
-            <a:schemeClr val="lt1"/>
-          </a:fontRef>
-        </p:style>
-        <p:txBody>
-          <a:bodyPr rtlCol="0" anchor="ctr" wrap="square"/>
-          <a:lstStyle/>
-          <a:p>
-            <a:pPr algn="ctr">
-              <a:defRPr sz="900" b="1">
-                <a:solidFill>
-                  <a:srgbClr val="60A5FA"/>
-                </a:solidFill>
-                <a:latin typeface="IBM Plex Mono"/>
-              </a:defRPr>
-            </a:pPr>
-            <a:r>
-              <a:t>3. UNCLEAR ONLY → ASK MORE</a:t>
-            </a:r>
-          </a:p>
-          <a:p>
-            <a:pPr>
-              <a:defRPr sz="900">
-                <a:solidFill>
-                  <a:srgbClr val="A3B8B0"/>
-                </a:solidFill>
-                <a:latin typeface="Inter"/>
-              </a:defRPr>
-            </a:pPr>
-            <a:r>
-              <a:t>Low brightness or blurry barcode (e.g. Case C). Prompts exact re-film checklist (1 retry limit).</a:t>
-            </a:r>
-          </a:p>
-        </p:txBody>
-      </p:sp>
-      <p:sp>
-        <p:nvSpPr>
-          <p:cNvPr id="34" name="Rectangle 33"/>
-          <p:cNvSpPr/>
-          <p:nvPr/>
-        </p:nvSpPr>
-        <p:spPr>
-          <a:xfrm>
-            <a:off x="8878824" y="3977639"/>
-            <a:ext cx="2560320" cy="1051560"/>
-          </a:xfrm>
-          <a:prstGeom prst="rect">
-            <a:avLst/>
-          </a:prstGeom>
-          <a:solidFill>
-            <a:srgbClr val="121F1B"/>
-          </a:solidFill>
-          <a:ln w="12700">
-            <a:solidFill>
-              <a:srgbClr val="223830"/>
-            </a:solidFill>
-          </a:ln>
-        </p:spPr>
-        <p:style>
-          <a:lnRef idx="1">
-            <a:schemeClr val="accent1"/>
-          </a:lnRef>
-          <a:fillRef idx="3">
-            <a:schemeClr val="accent1"/>
-          </a:fillRef>
-          <a:effectRef idx="2">
-            <a:schemeClr val="accent1"/>
-          </a:effectRef>
-          <a:fontRef idx="minor">
-            <a:schemeClr val="lt1"/>
-          </a:fontRef>
-        </p:style>
-        <p:txBody>
-          <a:bodyPr rtlCol="0" anchor="ctr" wrap="square"/>
-          <a:lstStyle/>
-          <a:p>
-            <a:pPr algn="ctr">
-              <a:defRPr sz="900" b="1">
-                <a:solidFill>
-                  <a:srgbClr val="34D399"/>
-                </a:solidFill>
-                <a:latin typeface="IBM Plex Mono"/>
-              </a:defRPr>
-            </a:pPr>
-            <a:r>
-              <a:t>4. ALL PASS → APPROVE REVIEW</a:t>
-            </a:r>
-          </a:p>
-          <a:p>
-            <a:pPr>
-              <a:defRPr sz="900">
-                <a:solidFill>
-                  <a:srgbClr val="A3B8B0"/>
-                </a:solidFill>
-                <a:latin typeface="Inter"/>
-              </a:defRPr>
-            </a:pPr>
-            <a:r>
-              <a:t>All clauses pass (e.g. Case A). Prepares mock label and drafts refund in pending_return_receipt.</a:t>
-            </a:r>
-          </a:p>
-        </p:txBody>
-      </p:sp>
-      <p:sp>
-        <p:nvSpPr>
-          <p:cNvPr id="35" name="Rectangle 34"/>
-          <p:cNvSpPr/>
-          <p:nvPr/>
-        </p:nvSpPr>
-        <p:spPr>
-          <a:xfrm>
-            <a:off x="731520" y="5166360"/>
-            <a:ext cx="10728655" cy="868680"/>
-          </a:xfrm>
-          <a:prstGeom prst="rect">
-            <a:avLst/>
-          </a:prstGeom>
-          <a:solidFill>
-            <a:srgbClr val="121F1B"/>
-          </a:solidFill>
-          <a:ln w="12700">
-            <a:solidFill>
-              <a:srgbClr val="223830"/>
-            </a:solidFill>
-          </a:ln>
-        </p:spPr>
-        <p:style>
-          <a:lnRef idx="1">
-            <a:schemeClr val="accent1"/>
-          </a:lnRef>
-          <a:fillRef idx="3">
-            <a:schemeClr val="accent1"/>
-          </a:fillRef>
-          <a:effectRef idx="2">
-            <a:schemeClr val="accent1"/>
-          </a:effectRef>
-          <a:fontRef idx="minor">
-            <a:schemeClr val="lt1"/>
-          </a:fontRef>
-        </p:style>
-        <p:txBody>
-          <a:bodyPr rtlCol="0" anchor="ctr" wrap="square"/>
-          <a:lstStyle/>
-          <a:p>
-            <a:pPr algn="ctr">
-              <a:defRPr sz="850">
-                <a:solidFill>
-                  <a:srgbClr val="A3B8B0"/>
-                </a:solidFill>
-                <a:latin typeface="IBM Plex Mono"/>
-              </a:defRPr>
-            </a:pPr>
-            <a:r>
-              <a:t>■ Model Calls: Bounded design estimate (3 base calls: planner, vision, critic + retries)  |  ■ Policy Rules: Deterministic Python code rules P-01 to P-08, never prompts</a:t>
-            </a:r>
-          </a:p>
-          <a:p>
-            <a:pPr>
-              <a:defRPr sz="850">
-                <a:solidFill>
-                  <a:srgbClr val="A3B8B0"/>
-                </a:solidFill>
-                <a:latin typeface="IBM Plex Mono"/>
-              </a:defRPr>
-            </a:pPr>
-            <a:r>
-              <a:t>■ Critic Duty: Reviews cited frames, flags unsupported observations (correlated error limits noted)  |  ■ Safety Boundary: Backend authorization check — LLMs cannot execute financial refunds</a:t>
-            </a:r>
-          </a:p>
-        </p:txBody>
-      </p:sp>
-      <p:sp>
-        <p:nvSpPr>
-          <p:cNvPr id="36" name="Rectangle 35"/>
-          <p:cNvSpPr/>
-          <p:nvPr/>
-        </p:nvSpPr>
-        <p:spPr>
-          <a:xfrm>
-            <a:off x="731520" y="6263640"/>
+            <a:off x="731520" y="6327648"/>
             <a:ext cx="10728655" cy="13716"/>
           </a:xfrm>
           <a:prstGeom prst="rect">
@@ -8294,13 +8119,13 @@
       </p:sp>
       <p:sp>
         <p:nvSpPr>
-          <p:cNvPr id="37" name="TextBox 36"/>
+          <p:cNvPr id="33" name="TextBox 32"/>
           <p:cNvSpPr txBox="1"/>
           <p:nvPr/>
         </p:nvSpPr>
         <p:spPr>
           <a:xfrm>
-            <a:off x="731520" y="6336792"/>
+            <a:off x="731520" y="6382512"/>
             <a:ext cx="8229600" cy="365760"/>
           </a:xfrm>
           <a:prstGeom prst="rect">
@@ -8315,7 +8140,7 @@
           <a:lstStyle/>
           <a:p>
             <a:pPr>
-              <a:defRPr sz="1000">
+              <a:defRPr sz="950">
                 <a:solidFill>
                   <a:srgbClr val="5C786E"/>
                 </a:solidFill>
@@ -8330,13 +8155,13 @@
       </p:sp>
       <p:sp>
         <p:nvSpPr>
-          <p:cNvPr id="38" name="TextBox 37"/>
+          <p:cNvPr id="34" name="TextBox 33"/>
           <p:cNvSpPr txBox="1"/>
           <p:nvPr/>
         </p:nvSpPr>
         <p:spPr>
           <a:xfrm>
-            <a:off x="9144000" y="6336792"/>
+            <a:off x="9144000" y="6382512"/>
             <a:ext cx="2316175" cy="365760"/>
           </a:xfrm>
           <a:prstGeom prst="rect">
@@ -8351,7 +8176,7 @@
           <a:lstStyle/>
           <a:p>
             <a:pPr algn="r">
-              <a:defRPr sz="1000">
+              <a:defRPr sz="950">
                 <a:solidFill>
                   <a:srgbClr val="5C786E"/>
                 </a:solidFill>
@@ -8470,7 +8295,7 @@
         <p:spPr>
           <a:xfrm>
             <a:off x="731520" y="868680"/>
-            <a:ext cx="10698480" cy="731520"/>
+            <a:ext cx="10698480" cy="685800"/>
           </a:xfrm>
           <a:prstGeom prst="rect">
             <a:avLst/>
@@ -8492,7 +8317,7 @@
               </a:defRPr>
             </a:pPr>
             <a:r>
-              <a:t>Four scenarios. Four predictable behaviors.</a:t>
+              <a:t>Four evidence conditions. Four controlled actions.</a:t>
             </a:r>
           </a:p>
         </p:txBody>
@@ -8505,8 +8330,8 @@
         </p:nvSpPr>
         <p:spPr>
           <a:xfrm>
-            <a:off x="731520" y="1600200"/>
-            <a:ext cx="10698480" cy="457200"/>
+            <a:off x="731520" y="1508760"/>
+            <a:ext cx="10698480" cy="411480"/>
           </a:xfrm>
           <a:prstGeom prst="rect">
             <a:avLst/>
@@ -8520,7 +8345,7 @@
           <a:lstStyle/>
           <a:p>
             <a:pPr>
-              <a:defRPr sz="1900">
+              <a:defRPr sz="1800">
                 <a:solidFill>
                   <a:srgbClr val="596E64"/>
                 </a:solidFill>
@@ -8541,8 +8366,8 @@
         </p:nvSpPr>
         <p:spPr>
           <a:xfrm>
-            <a:off x="731520" y="2148840"/>
-            <a:ext cx="10728655" cy="868680"/>
+            <a:off x="731520" y="2057400"/>
+            <a:ext cx="10728655" cy="932688"/>
           </a:xfrm>
           <a:prstGeom prst="rect">
             <a:avLst/>
@@ -8586,8 +8411,8 @@
         </p:nvSpPr>
         <p:spPr>
           <a:xfrm>
-            <a:off x="914400" y="2368296"/>
-            <a:ext cx="1645920" cy="420624"/>
+            <a:off x="914400" y="2258568"/>
+            <a:ext cx="2011680" cy="502920"/>
           </a:xfrm>
           <a:prstGeom prst="rect">
             <a:avLst/>
@@ -8618,7 +8443,7 @@
           <a:lstStyle/>
           <a:p>
             <a:pPr algn="ctr">
-              <a:defRPr sz="950" b="1">
+              <a:defRPr sz="1000" b="1">
                 <a:solidFill>
                   <a:srgbClr val="006B55"/>
                 </a:solidFill>
@@ -8626,7 +8451,20 @@
               </a:defRPr>
             </a:pPr>
             <a:r>
-              <a:t>CASE A · READY</a:t>
+              <a:t>CASE 01 · CONSISTENT</a:t>
+            </a:r>
+          </a:p>
+          <a:p>
+            <a:pPr algn="ctr">
+              <a:defRPr sz="900">
+                <a:solidFill>
+                  <a:srgbClr val="006B55"/>
+                </a:solidFill>
+                <a:latin typeface="Inter"/>
+              </a:defRPr>
+            </a:pPr>
+            <a:r>
+              <a:t>Clear Defect</a:t>
             </a:r>
           </a:p>
         </p:txBody>
@@ -8639,8 +8477,8 @@
         </p:nvSpPr>
         <p:spPr>
           <a:xfrm>
-            <a:off x="2743200" y="2258568"/>
-            <a:ext cx="3931920" cy="640080"/>
+            <a:off x="3063240" y="2167128"/>
+            <a:ext cx="3566160" cy="731520"/>
           </a:xfrm>
           <a:prstGeom prst="rect">
             <a:avLst/>
@@ -8654,7 +8492,7 @@
           <a:lstStyle/>
           <a:p>
             <a:pPr>
-              <a:defRPr sz="1050" b="1">
+              <a:defRPr sz="1100" b="1">
                 <a:solidFill>
                   <a:srgbClr val="172621"/>
                 </a:solidFill>
@@ -8662,7 +8500,7 @@
               </a:defRPr>
             </a:pPr>
             <a:r>
-              <a:t>Verified Damage · Staged cosmetic crack, timestamp 00:04 · Defect verified.</a:t>
+              <a:t>Staged casing crack verified in unboxing frame 00:04 · Manifest &amp; return window match.</a:t>
             </a:r>
           </a:p>
         </p:txBody>
@@ -8675,7 +8513,7 @@
         </p:nvSpPr>
         <p:spPr>
           <a:xfrm>
-            <a:off x="6720840" y="2295144"/>
+            <a:off x="6720840" y="2276856"/>
             <a:ext cx="274320" cy="457200"/>
           </a:xfrm>
           <a:prstGeom prst="rect">
@@ -8690,7 +8528,7 @@
           <a:lstStyle/>
           <a:p>
             <a:pPr>
-              <a:defRPr sz="1400">
+              <a:defRPr sz="1600" b="1">
                 <a:solidFill>
                   <a:srgbClr val="006B55"/>
                 </a:solidFill>
@@ -8711,8 +8549,8 @@
         </p:nvSpPr>
         <p:spPr>
           <a:xfrm>
-            <a:off x="7086600" y="2258568"/>
-            <a:ext cx="4206240" cy="640080"/>
+            <a:off x="7086600" y="2167128"/>
+            <a:ext cx="4206240" cy="731520"/>
           </a:xfrm>
           <a:prstGeom prst="rect">
             <a:avLst/>
@@ -8726,7 +8564,20 @@
           <a:lstStyle/>
           <a:p>
             <a:pPr>
-              <a:defRPr sz="1050">
+              <a:defRPr sz="1050" b="1">
+                <a:solidFill>
+                  <a:srgbClr val="006B55"/>
+                </a:solidFill>
+                <a:latin typeface="IBM Plex Mono"/>
+              </a:defRPr>
+            </a:pPr>
+            <a:r>
+              <a:t>PREPARE SELLER REVIEW</a:t>
+            </a:r>
+          </a:p>
+          <a:p>
+            <a:pPr>
+              <a:defRPr sz="1000">
                 <a:solidFill>
                   <a:srgbClr val="596E64"/>
                 </a:solidFill>
@@ -8734,7 +8585,7 @@
               </a:defRPr>
             </a:pPr>
             <a:r>
-              <a:t>Agent prepares mock label &amp; draft refund in pending_return_receipt; seller one-click confirms.</a:t>
+              <a:t>Agent prepares mock shipping label &amp; drafts refund in pending_return_receipt. Money releases only upon warehouse receipt.</a:t>
             </a:r>
           </a:p>
         </p:txBody>
@@ -8747,8 +8598,8 @@
         </p:nvSpPr>
         <p:spPr>
           <a:xfrm>
-            <a:off x="731520" y="3145536"/>
-            <a:ext cx="10728655" cy="868680"/>
+            <a:off x="731520" y="3099816"/>
+            <a:ext cx="10728655" cy="932688"/>
           </a:xfrm>
           <a:prstGeom prst="rect">
             <a:avLst/>
@@ -8792,8 +8643,8 @@
         </p:nvSpPr>
         <p:spPr>
           <a:xfrm>
-            <a:off x="914400" y="3364992"/>
-            <a:ext cx="1645920" cy="420624"/>
+            <a:off x="914400" y="3300984"/>
+            <a:ext cx="2011680" cy="502920"/>
           </a:xfrm>
           <a:prstGeom prst="rect">
             <a:avLst/>
@@ -8824,7 +8675,7 @@
           <a:lstStyle/>
           <a:p>
             <a:pPr algn="ctr">
-              <a:defRPr sz="950" b="1">
+              <a:defRPr sz="1000" b="1">
                 <a:solidFill>
                   <a:srgbClr val="991B1B"/>
                 </a:solidFill>
@@ -8832,7 +8683,20 @@
               </a:defRPr>
             </a:pPr>
             <a:r>
-              <a:t>CASE B · MISMATCH</a:t>
+              <a:t>CASE 02 · CONTRADICTION</a:t>
+            </a:r>
+          </a:p>
+          <a:p>
+            <a:pPr algn="ctr">
+              <a:defRPr sz="900">
+                <a:solidFill>
+                  <a:srgbClr val="991B1B"/>
+                </a:solidFill>
+                <a:latin typeface="Inter"/>
+              </a:defRPr>
+            </a:pPr>
+            <a:r>
+              <a:t>Color Mismatch</a:t>
             </a:r>
           </a:p>
         </p:txBody>
@@ -8845,8 +8709,8 @@
         </p:nvSpPr>
         <p:spPr>
           <a:xfrm>
-            <a:off x="2743200" y="3255264"/>
-            <a:ext cx="3931920" cy="640080"/>
+            <a:off x="3063240" y="3209544"/>
+            <a:ext cx="3566160" cy="731520"/>
           </a:xfrm>
           <a:prstGeom prst="rect">
             <a:avLst/>
@@ -8860,7 +8724,7 @@
           <a:lstStyle/>
           <a:p>
             <a:pPr>
-              <a:defRPr sz="1050" b="1">
+              <a:defRPr sz="1100" b="1">
                 <a:solidFill>
                   <a:srgbClr val="172621"/>
                 </a:solidFill>
@@ -8868,7 +8732,7 @@
               </a:defRPr>
             </a:pPr>
             <a:r>
-              <a:t>Color Contradiction · HEAD-WHT-02 (White) ordered vs Frame 00:07 Black item · SKU unverified.</a:t>
+              <a:t>White ordered (HEAD-WHT-02) vs Black unboxed in Frame 00:07 · Exact SKU unverified.</a:t>
             </a:r>
           </a:p>
         </p:txBody>
@@ -8881,7 +8745,7 @@
         </p:nvSpPr>
         <p:spPr>
           <a:xfrm>
-            <a:off x="6720840" y="3291840"/>
+            <a:off x="6720840" y="3319272"/>
             <a:ext cx="274320" cy="457200"/>
           </a:xfrm>
           <a:prstGeom prst="rect">
@@ -8896,7 +8760,7 @@
           <a:lstStyle/>
           <a:p>
             <a:pPr>
-              <a:defRPr sz="1400">
+              <a:defRPr sz="1600" b="1">
                 <a:solidFill>
                   <a:srgbClr val="006B55"/>
                 </a:solidFill>
@@ -8917,8 +8781,8 @@
         </p:nvSpPr>
         <p:spPr>
           <a:xfrm>
-            <a:off x="7086600" y="3255264"/>
-            <a:ext cx="4206240" cy="640080"/>
+            <a:off x="7086600" y="3209544"/>
+            <a:ext cx="4206240" cy="731520"/>
           </a:xfrm>
           <a:prstGeom prst="rect">
             <a:avLst/>
@@ -8932,7 +8796,20 @@
           <a:lstStyle/>
           <a:p>
             <a:pPr>
-              <a:defRPr sz="1050">
+              <a:defRPr sz="1050" b="1">
+                <a:solidFill>
+                  <a:srgbClr val="991B1B"/>
+                </a:solidFill>
+                <a:latin typeface="IBM Plex Mono"/>
+              </a:defRPr>
+            </a:pPr>
+            <a:r>
+              <a:t>ESCALATE TO SELLER</a:t>
+            </a:r>
+          </a:p>
+          <a:p>
+            <a:pPr>
+              <a:defRPr sz="1000">
                 <a:solidFill>
                   <a:srgbClr val="596E64"/>
                 </a:solidFill>
@@ -8940,7 +8817,7 @@
               </a:defRPr>
             </a:pPr>
             <a:r>
-              <a:t>P-03 contradiction blocks automation; seller selects 1 of 3 options: mis-shipment / box label / warehouse inspection.</a:t>
+              <a:t>Policy P-03 blocks automation. Inhibits label and refund. Seller selects 1 of 3 concrete resolution options.</a:t>
             </a:r>
           </a:p>
         </p:txBody>
@@ -8954,7 +8831,7 @@
         <p:spPr>
           <a:xfrm>
             <a:off x="731520" y="4142232"/>
-            <a:ext cx="10728655" cy="868680"/>
+            <a:ext cx="10728655" cy="932688"/>
           </a:xfrm>
           <a:prstGeom prst="rect">
             <a:avLst/>
@@ -8998,8 +8875,8 @@
         </p:nvSpPr>
         <p:spPr>
           <a:xfrm>
-            <a:off x="914400" y="4361688"/>
-            <a:ext cx="1645920" cy="420624"/>
+            <a:off x="914400" y="4343400"/>
+            <a:ext cx="2011680" cy="502920"/>
           </a:xfrm>
           <a:prstGeom prst="rect">
             <a:avLst/>
@@ -9030,7 +8907,7 @@
           <a:lstStyle/>
           <a:p>
             <a:pPr algn="ctr">
-              <a:defRPr sz="950" b="1">
+              <a:defRPr sz="1000" b="1">
                 <a:solidFill>
                   <a:srgbClr val="1E40AF"/>
                 </a:solidFill>
@@ -9038,7 +8915,20 @@
               </a:defRPr>
             </a:pPr>
             <a:r>
-              <a:t>CASE C · UNCLEAR</a:t>
+              <a:t>CASE 03 · UNCLEAR</a:t>
+            </a:r>
+          </a:p>
+          <a:p>
+            <a:pPr algn="ctr">
+              <a:defRPr sz="900">
+                <a:solidFill>
+                  <a:srgbClr val="1E40AF"/>
+                </a:solidFill>
+                <a:latin typeface="Inter"/>
+              </a:defRPr>
+            </a:pPr>
+            <a:r>
+              <a:t>Low Lighting</a:t>
             </a:r>
           </a:p>
         </p:txBody>
@@ -9051,8 +8941,8 @@
         </p:nvSpPr>
         <p:spPr>
           <a:xfrm>
-            <a:off x="2743200" y="4251960"/>
-            <a:ext cx="3931920" cy="640080"/>
+            <a:off x="3063240" y="4251960"/>
+            <a:ext cx="3566160" cy="731520"/>
           </a:xfrm>
           <a:prstGeom prst="rect">
             <a:avLst/>
@@ -9066,7 +8956,7 @@
           <a:lstStyle/>
           <a:p>
             <a:pPr>
-              <a:defRPr sz="1050" b="1">
+              <a:defRPr sz="1100" b="1">
                 <a:solidFill>
                   <a:srgbClr val="172621"/>
                 </a:solidFill>
@@ -9074,7 +8964,7 @@
               </a:defRPr>
             </a:pPr>
             <a:r>
-              <a:t>Insufficient Visibility · 4-second dark video, brightness 28, only 2 usable frames.</a:t>
+              <a:t>4-second dark video, brightness 28/255, barcode obscured · Insufficient visual evidence.</a:t>
             </a:r>
           </a:p>
         </p:txBody>
@@ -9087,7 +8977,7 @@
         </p:nvSpPr>
         <p:spPr>
           <a:xfrm>
-            <a:off x="6720840" y="4288536"/>
+            <a:off x="6720840" y="4361688"/>
             <a:ext cx="274320" cy="457200"/>
           </a:xfrm>
           <a:prstGeom prst="rect">
@@ -9102,7 +8992,7 @@
           <a:lstStyle/>
           <a:p>
             <a:pPr>
-              <a:defRPr sz="1400">
+              <a:defRPr sz="1600" b="1">
                 <a:solidFill>
                   <a:srgbClr val="006B55"/>
                 </a:solidFill>
@@ -9124,7 +9014,7 @@
         <p:spPr>
           <a:xfrm>
             <a:off x="7086600" y="4251960"/>
-            <a:ext cx="4206240" cy="640080"/>
+            <a:ext cx="4206240" cy="731520"/>
           </a:xfrm>
           <a:prstGeom prst="rect">
             <a:avLst/>
@@ -9138,7 +9028,20 @@
           <a:lstStyle/>
           <a:p>
             <a:pPr>
-              <a:defRPr sz="1050">
+              <a:defRPr sz="1050" b="1">
+                <a:solidFill>
+                  <a:srgbClr val="1E40AF"/>
+                </a:solidFill>
+                <a:latin typeface="IBM Plex Mono"/>
+              </a:defRPr>
+            </a:pPr>
+            <a:r>
+              <a:t>ASK AND RESUME</a:t>
+            </a:r>
+          </a:p>
+          <a:p>
+            <a:pPr>
+              <a:defRPr sz="1000">
                 <a:solidFill>
                   <a:srgbClr val="596E64"/>
                 </a:solidFill>
@@ -9146,7 +9049,7 @@
               </a:defRPr>
             </a:pPr>
             <a:r>
-              <a:t>Agent requests targeted photo; enters WAITING_FOR_EVIDENCE; resumes case on upload (1 retry limit).</a:t>
+              <a:t>Agent calls ask_for_evidence(); transitions ticket to WAITING_FOR_EVIDENCE; resumes context on upload (1 retry limit).</a:t>
             </a:r>
           </a:p>
         </p:txBody>
@@ -9159,8 +9062,8 @@
         </p:nvSpPr>
         <p:spPr>
           <a:xfrm>
-            <a:off x="731520" y="5138928"/>
-            <a:ext cx="10728655" cy="868680"/>
+            <a:off x="731520" y="5184648"/>
+            <a:ext cx="10728655" cy="932688"/>
           </a:xfrm>
           <a:prstGeom prst="rect">
             <a:avLst/>
@@ -9204,8 +9107,8 @@
         </p:nvSpPr>
         <p:spPr>
           <a:xfrm>
-            <a:off x="914400" y="5358384"/>
-            <a:ext cx="1645920" cy="420624"/>
+            <a:off x="914400" y="5385816"/>
+            <a:ext cx="2011680" cy="502920"/>
           </a:xfrm>
           <a:prstGeom prst="rect">
             <a:avLst/>
@@ -9236,7 +9139,7 @@
           <a:lstStyle/>
           <a:p>
             <a:pPr algn="ctr">
-              <a:defRPr sz="950" b="1">
+              <a:defRPr sz="1000" b="1">
                 <a:solidFill>
                   <a:srgbClr val="065F46"/>
                 </a:solidFill>
@@ -9244,7 +9147,20 @@
               </a:defRPr>
             </a:pPr>
             <a:r>
-              <a:t>CASE D · CONTEXT</a:t>
+              <a:t>CASE 04 · SEQUENCE</a:t>
+            </a:r>
+          </a:p>
+          <a:p>
+            <a:pPr algn="ctr">
+              <a:defRPr sz="900">
+                <a:solidFill>
+                  <a:srgbClr val="065F46"/>
+                </a:solidFill>
+                <a:latin typeface="Inter"/>
+              </a:defRPr>
+            </a:pPr>
+            <a:r>
+              <a:t>Continuity Check</a:t>
             </a:r>
           </a:p>
         </p:txBody>
@@ -9257,8 +9173,8 @@
         </p:nvSpPr>
         <p:spPr>
           <a:xfrm>
-            <a:off x="2743200" y="5248656"/>
-            <a:ext cx="3931920" cy="640080"/>
+            <a:off x="3063240" y="5294376"/>
+            <a:ext cx="3566160" cy="731520"/>
           </a:xfrm>
           <a:prstGeom prst="rect">
             <a:avLst/>
@@ -9272,7 +9188,7 @@
           <a:lstStyle/>
           <a:p>
             <a:pPr>
-              <a:defRPr sz="1050" b="1">
+              <a:defRPr sz="1100" b="1">
                 <a:solidFill>
                   <a:srgbClr val="172621"/>
                 </a:solidFill>
@@ -9280,7 +9196,7 @@
               </a:defRPr>
             </a:pPr>
             <a:r>
-              <a:t>Sequence Continuity · Staged parcel-to-product take: opening sealed parcel to product reveal.</a:t>
+              <a:t>Staged continuous take from sealed parcel opening to product reveal · Sequence inspected.</a:t>
             </a:r>
           </a:p>
         </p:txBody>
@@ -9293,7 +9209,7 @@
         </p:nvSpPr>
         <p:spPr>
           <a:xfrm>
-            <a:off x="6720840" y="5285232"/>
+            <a:off x="6720840" y="5404104"/>
             <a:ext cx="274320" cy="457200"/>
           </a:xfrm>
           <a:prstGeom prst="rect">
@@ -9308,7 +9224,7 @@
           <a:lstStyle/>
           <a:p>
             <a:pPr>
-              <a:defRPr sz="1400">
+              <a:defRPr sz="1600" b="1">
                 <a:solidFill>
                   <a:srgbClr val="006B55"/>
                 </a:solidFill>
@@ -9329,8 +9245,8 @@
         </p:nvSpPr>
         <p:spPr>
           <a:xfrm>
-            <a:off x="7086600" y="5248656"/>
-            <a:ext cx="4206240" cy="640080"/>
+            <a:off x="7086600" y="5294376"/>
+            <a:ext cx="4206240" cy="731520"/>
           </a:xfrm>
           <a:prstGeom prst="rect">
             <a:avLst/>
@@ -9344,7 +9260,20 @@
           <a:lstStyle/>
           <a:p>
             <a:pPr>
-              <a:defRPr sz="1050">
+              <a:defRPr sz="1050" b="1">
+                <a:solidFill>
+                  <a:srgbClr val="065F46"/>
+                </a:solidFill>
+                <a:latin typeface="IBM Plex Mono"/>
+              </a:defRPr>
+            </a:pPr>
+            <a:r>
+              <a:t>INSPECT CONTINUITY</a:t>
+            </a:r>
+          </a:p>
+          <a:p>
+            <a:pPr>
+              <a:defRPr sz="1000">
                 <a:solidFill>
                   <a:srgbClr val="596E64"/>
                 </a:solidFill>
@@ -9352,7 +9281,7 @@
               </a:defRPr>
             </a:pPr>
             <a:r>
-              <a:t>Expected behavior: inspect sequence continuity and flag missing transitions for seller review.</a:t>
+              <a:t>Expected prototype behavior: inspect sequence continuity and flag missing transitions for seller review.</a:t>
             </a:r>
           </a:p>
         </p:txBody>
@@ -9365,7 +9294,7 @@
         </p:nvSpPr>
         <p:spPr>
           <a:xfrm>
-            <a:off x="731520" y="6263640"/>
+            <a:off x="731520" y="6327648"/>
             <a:ext cx="10728655" cy="13716"/>
           </a:xfrm>
           <a:prstGeom prst="rect">
@@ -9408,7 +9337,7 @@
         </p:nvSpPr>
         <p:spPr>
           <a:xfrm>
-            <a:off x="731520" y="6336792"/>
+            <a:off x="731520" y="6382512"/>
             <a:ext cx="8229600" cy="365760"/>
           </a:xfrm>
           <a:prstGeom prst="rect">
@@ -9423,7 +9352,7 @@
           <a:lstStyle/>
           <a:p>
             <a:pPr>
-              <a:defRPr sz="1000">
+              <a:defRPr sz="950">
                 <a:solidFill>
                   <a:srgbClr val="7A8E85"/>
                 </a:solidFill>
@@ -9431,7 +9360,7 @@
               </a:defRPr>
             </a:pPr>
             <a:r>
-              <a:t>Staged prototype scenarios · Expected agent behaviors, not measured production metrics · Cap: min(₹4,999, remaining refundable amount, order paid amount)</a:t>
+              <a:t>Staged prototype scenarios · Expected agent behaviors, not measured production metrics · Cap: min(₹4,999, remaining, paid)</a:t>
             </a:r>
           </a:p>
         </p:txBody>
@@ -9444,7 +9373,7 @@
         </p:nvSpPr>
         <p:spPr>
           <a:xfrm>
-            <a:off x="9144000" y="6336792"/>
+            <a:off x="9144000" y="6382512"/>
             <a:ext cx="2316175" cy="365760"/>
           </a:xfrm>
           <a:prstGeom prst="rect">
@@ -9459,7 +9388,7 @@
           <a:lstStyle/>
           <a:p>
             <a:pPr algn="r">
-              <a:defRPr sz="1000">
+              <a:defRPr sz="950">
                 <a:solidFill>
                   <a:srgbClr val="7A8E85"/>
                 </a:solidFill>
@@ -9564,7 +9493,7 @@
               </a:defRPr>
             </a:pPr>
             <a:r>
-              <a:t>24-HOUR PROTOTYPE PLAN · FEASIBILITY &amp; SCOPE GUARDRAILS</a:t>
+              <a:t>24-HOUR PROTOTYPE PLAN · FEASIBILITY &amp; SCOPE</a:t>
             </a:r>
           </a:p>
         </p:txBody>
@@ -9578,7 +9507,7 @@
         <p:spPr>
           <a:xfrm>
             <a:off x="731520" y="868680"/>
-            <a:ext cx="10698480" cy="731520"/>
+            <a:ext cx="10698480" cy="685800"/>
           </a:xfrm>
           <a:prstGeom prst="rect">
             <a:avLst/>
@@ -9600,7 +9529,7 @@
               </a:defRPr>
             </a:pPr>
             <a:r>
-              <a:t>Built for a 24-hour sprint.</a:t>
+              <a:t>A credible prototype in 24 hours.</a:t>
             </a:r>
           </a:p>
         </p:txBody>
@@ -9613,8 +9542,8 @@
         </p:nvSpPr>
         <p:spPr>
           <a:xfrm>
-            <a:off x="731520" y="1600200"/>
-            <a:ext cx="10698480" cy="457200"/>
+            <a:off x="731520" y="1508760"/>
+            <a:ext cx="10698480" cy="411480"/>
           </a:xfrm>
           <a:prstGeom prst="rect">
             <a:avLst/>
@@ -9628,7 +9557,7 @@
           <a:lstStyle/>
           <a:p>
             <a:pPr>
-              <a:defRPr sz="1900">
+              <a:defRPr sz="1800">
                 <a:solidFill>
                   <a:srgbClr val="596E64"/>
                 </a:solidFill>
@@ -9636,7 +9565,7 @@
               </a:defRPr>
             </a:pPr>
             <a:r>
-              <a:t>Strict scope boundaries and clear division of labor make the prototype fully buildable in one day.</a:t>
+              <a:t>Strict scope boundaries and single-threaded ownership make the prototype fully buildable in one day.</a:t>
             </a:r>
           </a:p>
         </p:txBody>
@@ -9649,8 +9578,8 @@
         </p:nvSpPr>
         <p:spPr>
           <a:xfrm>
-            <a:off x="731520" y="2148840"/>
-            <a:ext cx="2560320" cy="1234440"/>
+            <a:off x="731520" y="2057400"/>
+            <a:ext cx="2560320" cy="1645920"/>
           </a:xfrm>
           <a:prstGeom prst="rect">
             <a:avLst/>
@@ -9691,12 +9620,12 @@
               </a:defRPr>
             </a:pPr>
             <a:r>
-              <a:t>00h – 06h · Foundation</a:t>
+              <a:t>00h – 06h · FOUNDATION</a:t>
             </a:r>
           </a:p>
           <a:p>
             <a:pPr>
-              <a:defRPr sz="1150" b="1">
+              <a:defRPr sz="1300" b="1">
                 <a:solidFill>
                   <a:srgbClr val="172621"/>
                 </a:solidFill>
@@ -9704,12 +9633,25 @@
               </a:defRPr>
             </a:pPr>
             <a:r>
-              <a:t>Mock APIs &amp; Agent Core</a:t>
+              <a:t>Mock APIs &amp; Agent State</a:t>
             </a:r>
           </a:p>
           <a:p>
             <a:pPr>
-              <a:defRPr sz="900">
+              <a:defRPr sz="1000" b="1">
+                <a:solidFill>
+                  <a:srgbClr val="006B55"/>
+                </a:solidFill>
+                <a:latin typeface="Inter"/>
+              </a:defRPr>
+            </a:pPr>
+            <a:r>
+              <a:t>Person A (Backend)</a:t>
+            </a:r>
+          </a:p>
+          <a:p>
+            <a:pPr>
+              <a:defRPr sz="950">
                 <a:solidFill>
                   <a:srgbClr val="596E64"/>
                 </a:solidFill>
@@ -9717,11 +9659,7 @@
               </a:defRPr>
             </a:pPr>
             <a:r>
-              <a:t>Person A (Backend), supported by C</a:t>
-            </a:r>
-            <a:br/>
-            <a:r>
-              <a:t>LangGraph skeleton, mock store/courier fixtures, order status route</a:t>
+              <a:t>LangGraph state machine, mock Shopify/Shippo fixtures, order status route, state serialization.</a:t>
             </a:r>
           </a:p>
         </p:txBody>
@@ -9734,7 +9672,7 @@
         </p:nvSpPr>
         <p:spPr>
           <a:xfrm>
-            <a:off x="731520" y="2148840"/>
+            <a:off x="731520" y="2057400"/>
             <a:ext cx="2560320" cy="36576"/>
           </a:xfrm>
           <a:prstGeom prst="rect">
@@ -9777,8 +9715,8 @@
         </p:nvSpPr>
         <p:spPr>
           <a:xfrm>
-            <a:off x="3447288" y="2148840"/>
-            <a:ext cx="2560320" cy="1234440"/>
+            <a:off x="3447288" y="2057400"/>
+            <a:ext cx="2560320" cy="1645920"/>
           </a:xfrm>
           <a:prstGeom prst="rect">
             <a:avLst/>
@@ -9819,12 +9757,12 @@
               </a:defRPr>
             </a:pPr>
             <a:r>
-              <a:t>06h – 12h · Evidence</a:t>
+              <a:t>06h – 12h · EVIDENCE</a:t>
             </a:r>
           </a:p>
           <a:p>
             <a:pPr>
-              <a:defRPr sz="1150" b="1">
+              <a:defRPr sz="1300" b="1">
                 <a:solidFill>
                   <a:srgbClr val="172621"/>
                 </a:solidFill>
@@ -9837,7 +9775,20 @@
           </a:p>
           <a:p>
             <a:pPr>
-              <a:defRPr sz="900">
+              <a:defRPr sz="1000" b="1">
+                <a:solidFill>
+                  <a:srgbClr val="006B55"/>
+                </a:solidFill>
+                <a:latin typeface="Inter"/>
+              </a:defRPr>
+            </a:pPr>
+            <a:r>
+              <a:t>Person B (Vision &amp; UI)</a:t>
+            </a:r>
+          </a:p>
+          <a:p>
+            <a:pPr>
+              <a:defRPr sz="950">
                 <a:solidFill>
                   <a:srgbClr val="596E64"/>
                 </a:solidFill>
@@ -9845,11 +9796,7 @@
               </a:defRPr>
             </a:pPr>
             <a:r>
-              <a:t>Person B (Video &amp; UI)</a:t>
-            </a:r>
-            <a:br/>
-            <a:r>
-              <a:t>FFmpeg keyframe indexer, Python rules P-01 to P-08, critic prompt</a:t>
+              <a:t>FFmpeg keyframe extraction, vision schema, deterministic rules P-01 to P-08, critic prompt.</a:t>
             </a:r>
           </a:p>
         </p:txBody>
@@ -9862,7 +9809,7 @@
         </p:nvSpPr>
         <p:spPr>
           <a:xfrm>
-            <a:off x="3447288" y="2148840"/>
+            <a:off x="3447288" y="2057400"/>
             <a:ext cx="2560320" cy="36576"/>
           </a:xfrm>
           <a:prstGeom prst="rect">
@@ -9905,8 +9852,8 @@
         </p:nvSpPr>
         <p:spPr>
           <a:xfrm>
-            <a:off x="6163056" y="2148840"/>
-            <a:ext cx="2560320" cy="1234440"/>
+            <a:off x="6163056" y="2057400"/>
+            <a:ext cx="2560320" cy="1645920"/>
           </a:xfrm>
           <a:prstGeom prst="rect">
             <a:avLst/>
@@ -9947,12 +9894,12 @@
               </a:defRPr>
             </a:pPr>
             <a:r>
-              <a:t>12h – 18h · Integration</a:t>
+              <a:t>12h – 18h · INTEGRATION</a:t>
             </a:r>
           </a:p>
           <a:p>
             <a:pPr>
-              <a:defRPr sz="1150" b="1">
+              <a:defRPr sz="1300" b="1">
                 <a:solidFill>
                   <a:srgbClr val="172621"/>
                 </a:solidFill>
@@ -9965,7 +9912,20 @@
           </a:p>
           <a:p>
             <a:pPr>
-              <a:defRPr sz="900">
+              <a:defRPr sz="1000" b="1">
+                <a:solidFill>
+                  <a:srgbClr val="006B55"/>
+                </a:solidFill>
+                <a:latin typeface="Inter"/>
+              </a:defRPr>
+            </a:pPr>
+            <a:r>
+              <a:t>Person C (Integration) with A/B</a:t>
+            </a:r>
+          </a:p>
+          <a:p>
+            <a:pPr>
+              <a:defRPr sz="950">
                 <a:solidFill>
                   <a:srgbClr val="596E64"/>
                 </a:solidFill>
@@ -9973,11 +9933,7 @@
               </a:defRPr>
             </a:pPr>
             <a:r>
-              <a:t>Person C (Integration), supported by A/B</a:t>
-            </a:r>
-            <a:br/>
-            <a:r>
-              <a:t>End-to-end wiring, clarification/resume loop, seller console UI</a:t>
+              <a:t>Clarification/resume loop, seller console UI, wiring 4 staged demo cases (A–D).</a:t>
             </a:r>
           </a:p>
         </p:txBody>
@@ -9990,7 +9946,7 @@
         </p:nvSpPr>
         <p:spPr>
           <a:xfrm>
-            <a:off x="6163056" y="2148840"/>
+            <a:off x="6163056" y="2057400"/>
             <a:ext cx="2560320" cy="36576"/>
           </a:xfrm>
           <a:prstGeom prst="rect">
@@ -10033,8 +9989,8 @@
         </p:nvSpPr>
         <p:spPr>
           <a:xfrm>
-            <a:off x="8878824" y="2148840"/>
-            <a:ext cx="2560320" cy="1234440"/>
+            <a:off x="8878824" y="2057400"/>
+            <a:ext cx="2560320" cy="1645920"/>
           </a:xfrm>
           <a:prstGeom prst="rect">
             <a:avLst/>
@@ -10075,12 +10031,12 @@
               </a:defRPr>
             </a:pPr>
             <a:r>
-              <a:t>18h – 24h · Validation</a:t>
+              <a:t>18h – 24h · VALIDATION</a:t>
             </a:r>
           </a:p>
           <a:p>
             <a:pPr>
-              <a:defRPr sz="1150" b="1">
+              <a:defRPr sz="1300" b="1">
                 <a:solidFill>
                   <a:srgbClr val="172621"/>
                 </a:solidFill>
@@ -10093,7 +10049,20 @@
           </a:p>
           <a:p>
             <a:pPr>
-              <a:defRPr sz="900">
+              <a:defRPr sz="1000" b="1">
+                <a:solidFill>
+                  <a:srgbClr val="006B55"/>
+                </a:solidFill>
+                <a:latin typeface="Inter"/>
+              </a:defRPr>
+            </a:pPr>
+            <a:r>
+              <a:t>All 3 Members</a:t>
+            </a:r>
+          </a:p>
+          <a:p>
+            <a:pPr>
+              <a:defRPr sz="950">
                 <a:solidFill>
                   <a:srgbClr val="596E64"/>
                 </a:solidFill>
@@ -10101,11 +10070,7 @@
               </a:defRPr>
             </a:pPr>
             <a:r>
-              <a:t>All 3 Members</a:t>
-            </a:r>
-            <a:br/>
-            <a:r>
-              <a:t>Fallback testing, authorization tests, demo video recording, README</a:t>
+              <a:t>Authorization boundary tests, edge cases, fallback validation, demo recording, README.</a:t>
             </a:r>
           </a:p>
         </p:txBody>
@@ -10118,7 +10083,7 @@
         </p:nvSpPr>
         <p:spPr>
           <a:xfrm>
-            <a:off x="8878824" y="2148840"/>
+            <a:off x="8878824" y="2057400"/>
             <a:ext cx="2560320" cy="36576"/>
           </a:xfrm>
           <a:prstGeom prst="rect">
@@ -10161,8 +10126,8 @@
         </p:nvSpPr>
         <p:spPr>
           <a:xfrm>
-            <a:off x="731520" y="3566160"/>
-            <a:ext cx="5212080" cy="1783080"/>
+            <a:off x="731520" y="3886200"/>
+            <a:ext cx="5257800" cy="2240280"/>
           </a:xfrm>
           <a:prstGeom prst="rect">
             <a:avLst/>
@@ -10206,8 +10171,8 @@
         </p:nvSpPr>
         <p:spPr>
           <a:xfrm>
-            <a:off x="731520" y="3566160"/>
-            <a:ext cx="73152" cy="1783080"/>
+            <a:off x="731520" y="3886200"/>
+            <a:ext cx="73152" cy="2240280"/>
           </a:xfrm>
           <a:prstGeom prst="rect">
             <a:avLst/>
@@ -10249,8 +10214,8 @@
         </p:nvSpPr>
         <p:spPr>
           <a:xfrm>
-            <a:off x="960120" y="3657600"/>
-            <a:ext cx="4892040" cy="1600200"/>
+            <a:off x="960120" y="4023360"/>
+            <a:ext cx="4937760" cy="1965960"/>
           </a:xfrm>
           <a:prstGeom prst="rect">
             <a:avLst/>
@@ -10272,12 +10237,12 @@
               </a:defRPr>
             </a:pPr>
             <a:r>
-              <a:t>NEVER CUT (CORE ENGINE)</a:t>
+              <a:t>MUST DELIVER (CORE PROTOTYPE)</a:t>
             </a:r>
           </a:p>
           <a:p>
             <a:pPr>
-              <a:defRPr sz="1000">
+              <a:defRPr sz="1050">
                 <a:solidFill>
                   <a:srgbClr val="172621"/>
                 </a:solidFill>
@@ -10287,25 +10252,70 @@
             <a:r>
               <a:t>• Deterministic policy engine (P-01 to P-08)</a:t>
             </a:r>
-            <a:br/>
-            <a:r>
-              <a:t>• Evidence-pack frame citation</a:t>
-            </a:r>
-            <a:br/>
-            <a:r>
-              <a:t>• Fail-closed seller approval gate</a:t>
-            </a:r>
-            <a:br/>
-            <a:r>
-              <a:t>• Structured JSON audit log</a:t>
-            </a:r>
-            <a:br/>
-            <a:r>
-              <a:t>• Clarification/resume loop</a:t>
-            </a:r>
-            <a:br/>
-            <a:r>
-              <a:t>• 4 reproducible demo cases</a:t>
+          </a:p>
+          <a:p>
+            <a:pPr>
+              <a:defRPr sz="1050">
+                <a:solidFill>
+                  <a:srgbClr val="172621"/>
+                </a:solidFill>
+                <a:latin typeface="Inter"/>
+              </a:defRPr>
+            </a:pPr>
+            <a:r>
+              <a:t>• Evidence-pack keyframe citations</a:t>
+            </a:r>
+          </a:p>
+          <a:p>
+            <a:pPr>
+              <a:defRPr sz="1050">
+                <a:solidFill>
+                  <a:srgbClr val="172621"/>
+                </a:solidFill>
+                <a:latin typeface="Inter"/>
+              </a:defRPr>
+            </a:pPr>
+            <a:r>
+              <a:t>• Fail-closed seller authorization gate</a:t>
+            </a:r>
+          </a:p>
+          <a:p>
+            <a:pPr>
+              <a:defRPr sz="1050">
+                <a:solidFill>
+                  <a:srgbClr val="172621"/>
+                </a:solidFill>
+                <a:latin typeface="Inter"/>
+              </a:defRPr>
+            </a:pPr>
+            <a:r>
+              <a:t>• Structured JSON audit trail log</a:t>
+            </a:r>
+          </a:p>
+          <a:p>
+            <a:pPr>
+              <a:defRPr sz="1050">
+                <a:solidFill>
+                  <a:srgbClr val="172621"/>
+                </a:solidFill>
+                <a:latin typeface="Inter"/>
+              </a:defRPr>
+            </a:pPr>
+            <a:r>
+              <a:t>• Stateful clarification/resume loop</a:t>
+            </a:r>
+          </a:p>
+          <a:p>
+            <a:pPr>
+              <a:defRPr sz="1050">
+                <a:solidFill>
+                  <a:srgbClr val="172621"/>
+                </a:solidFill>
+                <a:latin typeface="Inter"/>
+              </a:defRPr>
+            </a:pPr>
+            <a:r>
+              <a:t>• 4 reproducible demo scenarios</a:t>
             </a:r>
           </a:p>
         </p:txBody>
@@ -10318,8 +10328,8 @@
         </p:nvSpPr>
         <p:spPr>
           <a:xfrm>
-            <a:off x="6248095" y="3566160"/>
-            <a:ext cx="5212080" cy="1783080"/>
+            <a:off x="6202375" y="3886200"/>
+            <a:ext cx="5257800" cy="2240280"/>
           </a:xfrm>
           <a:prstGeom prst="rect">
             <a:avLst/>
@@ -10363,8 +10373,8 @@
         </p:nvSpPr>
         <p:spPr>
           <a:xfrm>
-            <a:off x="6248095" y="3566160"/>
-            <a:ext cx="73152" cy="1783080"/>
+            <a:off x="6202375" y="3886200"/>
+            <a:ext cx="73152" cy="2240280"/>
           </a:xfrm>
           <a:prstGeom prst="rect">
             <a:avLst/>
@@ -10406,8 +10416,8 @@
         </p:nvSpPr>
         <p:spPr>
           <a:xfrm>
-            <a:off x="6476695" y="3657600"/>
-            <a:ext cx="4892040" cy="1600200"/>
+            <a:off x="6430975" y="4023360"/>
+            <a:ext cx="4937760" cy="1965960"/>
           </a:xfrm>
           <a:prstGeom prst="rect">
             <a:avLst/>
@@ -10434,7 +10444,7 @@
           </a:p>
           <a:p>
             <a:pPr>
-              <a:defRPr sz="1000">
+              <a:defRPr sz="1050">
                 <a:solidFill>
                   <a:srgbClr val="172621"/>
                 </a:solidFill>
@@ -10442,23 +10452,59 @@
               </a:defRPr>
             </a:pPr>
             <a:r>
-              <a:t>• Real carrier webhook integration (keep mock courier)</a:t>
-            </a:r>
-            <a:br/>
-            <a:r>
-              <a:t>• Multi-product order parsing (keep 1 item/return)</a:t>
-            </a:r>
-            <a:br/>
-            <a:r>
-              <a:t>• Custom video encoding (keep standard 1 fps FFmpeg extraction)</a:t>
-            </a:r>
-            <a:br/>
-            <a:r>
-              <a:t>• Production payment gateways / live WhatsApp webhooks</a:t>
-            </a:r>
-            <a:br/>
-            <a:r>
-              <a:t>• Seller analytics dashboard</a:t>
+              <a:t>• Live carrier webhooks (keep mock courier)</a:t>
+            </a:r>
+          </a:p>
+          <a:p>
+            <a:pPr>
+              <a:defRPr sz="1050">
+                <a:solidFill>
+                  <a:srgbClr val="172621"/>
+                </a:solidFill>
+                <a:latin typeface="Inter"/>
+              </a:defRPr>
+            </a:pPr>
+            <a:r>
+              <a:t>• Multi-item return parsing (keep 1 item/return)</a:t>
+            </a:r>
+          </a:p>
+          <a:p>
+            <a:pPr>
+              <a:defRPr sz="1050">
+                <a:solidFill>
+                  <a:srgbClr val="172621"/>
+                </a:solidFill>
+                <a:latin typeface="Inter"/>
+              </a:defRPr>
+            </a:pPr>
+            <a:r>
+              <a:t>• Video OCR barcode scanner (keep visual color)</a:t>
+            </a:r>
+          </a:p>
+          <a:p>
+            <a:pPr>
+              <a:defRPr sz="1050">
+                <a:solidFill>
+                  <a:srgbClr val="172621"/>
+                </a:solidFill>
+                <a:latin typeface="Inter"/>
+              </a:defRPr>
+            </a:pPr>
+            <a:r>
+              <a:t>• Live payment gateways (keep draft refunds)</a:t>
+            </a:r>
+          </a:p>
+          <a:p>
+            <a:pPr>
+              <a:defRPr sz="1050">
+                <a:solidFill>
+                  <a:srgbClr val="172621"/>
+                </a:solidFill>
+                <a:latin typeface="Inter"/>
+              </a:defRPr>
+            </a:pPr>
+            <a:r>
+              <a:t>• Merchant analytics dashboard</a:t>
             </a:r>
           </a:p>
         </p:txBody>
@@ -10471,62 +10517,7 @@
         </p:nvSpPr>
         <p:spPr>
           <a:xfrm>
-            <a:off x="731520" y="5486400"/>
-            <a:ext cx="10728655" cy="594360"/>
-          </a:xfrm>
-          <a:prstGeom prst="rect">
-            <a:avLst/>
-          </a:prstGeom>
-          <a:solidFill>
-            <a:srgbClr val="FAF8F5"/>
-          </a:solidFill>
-          <a:ln w="12700">
-            <a:solidFill>
-              <a:srgbClr val="E2DED4"/>
-            </a:solidFill>
-          </a:ln>
-        </p:spPr>
-        <p:style>
-          <a:lnRef idx="1">
-            <a:schemeClr val="accent1"/>
-          </a:lnRef>
-          <a:fillRef idx="3">
-            <a:schemeClr val="accent1"/>
-          </a:fillRef>
-          <a:effectRef idx="2">
-            <a:schemeClr val="accent1"/>
-          </a:effectRef>
-          <a:fontRef idx="minor">
-            <a:schemeClr val="lt1"/>
-          </a:fontRef>
-        </p:style>
-        <p:txBody>
-          <a:bodyPr rtlCol="0" anchor="ctr"/>
-          <a:lstStyle/>
-          <a:p>
-            <a:pPr algn="ctr">
-              <a:defRPr sz="1100" i="1">
-                <a:solidFill>
-                  <a:srgbClr val="172621"/>
-                </a:solidFill>
-                <a:latin typeface="Inter"/>
-              </a:defRPr>
-            </a:pPr>
-            <a:r>
-              <a:t>“The winning hackathon agent is not the one with the most tool definitions. It is the one where every action is held to evidence, and the seller stays in control.”</a:t>
-            </a:r>
-          </a:p>
-        </p:txBody>
-      </p:sp>
-      <p:sp>
-        <p:nvSpPr>
-          <p:cNvPr id="21" name="Rectangle 20"/>
-          <p:cNvSpPr/>
-          <p:nvPr/>
-        </p:nvSpPr>
-        <p:spPr>
-          <a:xfrm>
-            <a:off x="731520" y="6263640"/>
+            <a:off x="731520" y="6327648"/>
             <a:ext cx="10728655" cy="13716"/>
           </a:xfrm>
           <a:prstGeom prst="rect">
@@ -10563,13 +10554,13 @@
       </p:sp>
       <p:sp>
         <p:nvSpPr>
-          <p:cNvPr id="22" name="TextBox 21"/>
+          <p:cNvPr id="21" name="TextBox 20"/>
           <p:cNvSpPr txBox="1"/>
           <p:nvPr/>
         </p:nvSpPr>
         <p:spPr>
           <a:xfrm>
-            <a:off x="731520" y="6336792"/>
+            <a:off x="731520" y="6382512"/>
             <a:ext cx="8229600" cy="365760"/>
           </a:xfrm>
           <a:prstGeom prst="rect">
@@ -10584,7 +10575,7 @@
           <a:lstStyle/>
           <a:p>
             <a:pPr>
-              <a:defRPr sz="1000">
+              <a:defRPr sz="950">
                 <a:solidFill>
                   <a:srgbClr val="7A8E85"/>
                 </a:solidFill>
@@ -10592,20 +10583,20 @@
               </a:defRPr>
             </a:pPr>
             <a:r>
-              <a:t>Team Rookie (3 members) · PS-04 Autonomous Support Agent · 24-Hour Prototype Feasibility</a:t>
-            </a:r>
-          </a:p>
-        </p:txBody>
-      </p:sp>
-      <p:sp>
-        <p:nvSpPr>
-          <p:cNvPr id="23" name="TextBox 22"/>
+              <a:t>Team Rookie (3 Members) · PS-04 Autonomous Support Agent · 24-Hour Prototype Feasibility</a:t>
+            </a:r>
+          </a:p>
+        </p:txBody>
+      </p:sp>
+      <p:sp>
+        <p:nvSpPr>
+          <p:cNvPr id="22" name="TextBox 21"/>
           <p:cNvSpPr txBox="1"/>
           <p:nvPr/>
         </p:nvSpPr>
         <p:spPr>
           <a:xfrm>
-            <a:off x="9144000" y="6336792"/>
+            <a:off x="9144000" y="6382512"/>
             <a:ext cx="2316175" cy="365760"/>
           </a:xfrm>
           <a:prstGeom prst="rect">
@@ -10620,7 +10611,7 @@
           <a:lstStyle/>
           <a:p>
             <a:pPr algn="r">
-              <a:defRPr sz="1000">
+              <a:defRPr sz="950">
                 <a:solidFill>
                   <a:srgbClr val="7A8E85"/>
                 </a:solidFill>

</xml_diff>

<commit_message>
feat(rescue): complete visual redesign, eliminate layout overflows, and recover presentation quality
</commit_message>
<xml_diff>
--- a/ReturnLens_v4.pptx
+++ b/ReturnLens_v4.pptx
@@ -512,22 +512,17 @@
           </a:p>
           <a:p>
             <a:r>
-              <a:t>- Track &amp; Fit: AgentX Hackathon 2026, Problem Statement PS-04 (Autonomous Support Agent for Online Sellers).</a:t>
-            </a:r>
-          </a:p>
-          <a:p>
-            <a:r>
-              <a:t>- Team: Team Rookie (3 members).</a:t>
-            </a:r>
-          </a:p>
-          <a:p>
-            <a:r>
-              <a:t>- Target User: Solo direct-to-consumer (D2C) online merchant managing customer support, shipping, and returns alone.</a:t>
-            </a:r>
-          </a:p>
-          <a:p>
-            <a:r>
-              <a:t>- Core Insight: Solo sellers lose 15–20 minutes per return navigating fragmented tabs (chat, Shopify, Shippo, return policy), making memory-based decisions without traceable proof.</a:t>
+              <a:t>- Problem Statement Fit: PS-04 (Autonomous Support Agent for Online Sellers).</a:t>
+            </a:r>
+          </a:p>
+          <a:p>
+            <a:r>
+              <a:t>- Target User: Solo direct-to-consumer (D2C) online merchants managing customer support, shipping, and returns alone.</a:t>
+            </a:r>
+          </a:p>
+          <a:p>
+            <a:r>
+              <a:t>- Core Friction: Solo sellers spend 15–20 minutes per return opening fragmented tabs (buyer chat, Shopify, Shippo tracking, store return policy). Return decisions are currently made from memory without unified evidence.</a:t>
             </a:r>
           </a:p>
           <a:p>
@@ -4159,8 +4154,8 @@
         </p:nvSpPr>
         <p:spPr>
           <a:xfrm>
-            <a:off x="731520" y="594360"/>
-            <a:ext cx="4114800" cy="365760"/>
+            <a:off x="731520" y="731520"/>
+            <a:ext cx="4023360" cy="365760"/>
           </a:xfrm>
           <a:prstGeom prst="rect">
             <a:avLst/>
@@ -4195,8 +4190,8 @@
         </p:nvSpPr>
         <p:spPr>
           <a:xfrm>
-            <a:off x="731520" y="1051560"/>
-            <a:ext cx="4114800" cy="1005840"/>
+            <a:off x="731520" y="1188720"/>
+            <a:ext cx="4023360" cy="914400"/>
           </a:xfrm>
           <a:prstGeom prst="rect">
             <a:avLst/>
@@ -4210,7 +4205,7 @@
           <a:lstStyle/>
           <a:p>
             <a:pPr>
-              <a:defRPr sz="5600" b="1">
+              <a:defRPr sz="5400" b="1">
                 <a:solidFill>
                   <a:srgbClr val="172621"/>
                 </a:solidFill>
@@ -4231,8 +4226,94 @@
         </p:nvSpPr>
         <p:spPr>
           <a:xfrm>
-            <a:off x="731520" y="2148840"/>
-            <a:ext cx="4114800" cy="777240"/>
+            <a:off x="731520" y="2194560"/>
+            <a:ext cx="4023360" cy="1005840"/>
+          </a:xfrm>
+          <a:prstGeom prst="rect">
+            <a:avLst/>
+          </a:prstGeom>
+          <a:noFill/>
+        </p:spPr>
+        <p:txBody>
+          <a:bodyPr wrap="square">
+            <a:spAutoFit/>
+          </a:bodyPr>
+          <a:lstStyle/>
+          <a:p>
+            <a:pPr>
+              <a:defRPr sz="2400" b="1">
+                <a:solidFill>
+                  <a:srgbClr val="172621"/>
+                </a:solidFill>
+                <a:latin typeface="Inter"/>
+              </a:defRPr>
+            </a:pPr>
+            <a:r>
+              <a:t>Every return decision, backed by evidence.</a:t>
+            </a:r>
+          </a:p>
+        </p:txBody>
+      </p:sp>
+      <p:sp>
+        <p:nvSpPr>
+          <p:cNvPr id="6" name="TextBox 5"/>
+          <p:cNvSpPr txBox="1"/>
+          <p:nvPr/>
+        </p:nvSpPr>
+        <p:spPr>
+          <a:xfrm>
+            <a:off x="731520" y="3291840"/>
+            <a:ext cx="4023360" cy="1645920"/>
+          </a:xfrm>
+          <a:prstGeom prst="rect">
+            <a:avLst/>
+          </a:prstGeom>
+          <a:noFill/>
+        </p:spPr>
+        <p:txBody>
+          <a:bodyPr wrap="square">
+            <a:spAutoFit/>
+          </a:bodyPr>
+          <a:lstStyle/>
+          <a:p>
+            <a:pPr>
+              <a:defRPr sz="1400">
+                <a:solidFill>
+                  <a:srgbClr val="596E64"/>
+                </a:solidFill>
+                <a:latin typeface="Inter"/>
+              </a:defRPr>
+            </a:pPr>
+            <a:r>
+              <a:t>Evidence-backed returns triage for independent online sellers.</a:t>
+            </a:r>
+          </a:p>
+          <a:p>
+            <a:br/>
+            <a:pPr>
+              <a:defRPr sz="1300">
+                <a:solidFill>
+                  <a:srgbClr val="596E64"/>
+                </a:solidFill>
+                <a:latin typeface="Inter"/>
+              </a:defRPr>
+            </a:pPr>
+            <a:r>
+              <a:t>When a customer submits an unboxing video, ReturnLens cross-references store truth, verifies deterministic code policies, and gives the solo seller a 1-click decision console.</a:t>
+            </a:r>
+          </a:p>
+        </p:txBody>
+      </p:sp>
+      <p:sp>
+        <p:nvSpPr>
+          <p:cNvPr id="7" name="TextBox 6"/>
+          <p:cNvSpPr txBox="1"/>
+          <p:nvPr/>
+        </p:nvSpPr>
+        <p:spPr>
+          <a:xfrm>
+            <a:off x="731520" y="5303520"/>
+            <a:ext cx="4023360" cy="457200"/>
           </a:xfrm>
           <a:prstGeom prst="rect">
             <a:avLst/>
@@ -4246,70 +4327,29 @@
           <a:lstStyle/>
           <a:p>
             <a:pPr>
-              <a:defRPr sz="2400" b="1">
-                <a:solidFill>
-                  <a:srgbClr val="172621"/>
-                </a:solidFill>
-                <a:latin typeface="Inter"/>
-              </a:defRPr>
-            </a:pPr>
-            <a:r>
-              <a:t>Every return decision, backed by evidence.</a:t>
-            </a:r>
-          </a:p>
-        </p:txBody>
-      </p:sp>
-      <p:sp>
-        <p:nvSpPr>
-          <p:cNvPr id="6" name="TextBox 5"/>
-          <p:cNvSpPr txBox="1"/>
-          <p:nvPr/>
-        </p:nvSpPr>
-        <p:spPr>
-          <a:xfrm>
-            <a:off x="731520" y="3017520"/>
-            <a:ext cx="4114800" cy="1097280"/>
-          </a:xfrm>
-          <a:prstGeom prst="rect">
-            <a:avLst/>
-          </a:prstGeom>
-          <a:noFill/>
-        </p:spPr>
-        <p:txBody>
-          <a:bodyPr wrap="none">
-            <a:spAutoFit/>
-          </a:bodyPr>
-          <a:lstStyle/>
-          <a:p>
-            <a:pPr>
-              <a:defRPr sz="1300">
-                <a:solidFill>
-                  <a:srgbClr val="596E64"/>
-                </a:solidFill>
-                <a:latin typeface="Inter"/>
-              </a:defRPr>
-            </a:pPr>
-            <a:r>
-              <a:t>Evidence-backed returns triage for independent online sellers.</a:t>
-            </a:r>
-            <a:br/>
-            <a:br/>
-            <a:r>
-              <a:t>When a buyer submits an unboxing video, ReturnLens links video keyframes to store truth and courier scans, evaluates deterministic policy rules, and presents a 1-click decision console to the solo merchant.</a:t>
-            </a:r>
-          </a:p>
-        </p:txBody>
-      </p:sp>
-      <p:sp>
-        <p:nvSpPr>
-          <p:cNvPr id="7" name="Rectangle 6"/>
+              <a:defRPr sz="1000" b="1">
+                <a:solidFill>
+                  <a:srgbClr val="7A8E85"/>
+                </a:solidFill>
+                <a:latin typeface="IBM Plex Mono"/>
+              </a:defRPr>
+            </a:pPr>
+            <a:r>
+              <a:t>Team Rookie (3 Members) · 24-Hour Prototype Feasibility</a:t>
+            </a:r>
+          </a:p>
+        </p:txBody>
+      </p:sp>
+      <p:sp>
+        <p:nvSpPr>
+          <p:cNvPr id="8" name="Rectangle 7"/>
           <p:cNvSpPr/>
           <p:nvPr/>
         </p:nvSpPr>
         <p:spPr>
           <a:xfrm>
-            <a:off x="731520" y="4663440"/>
-            <a:ext cx="1280160" cy="1280160"/>
+            <a:off x="5166360" y="685800"/>
+            <a:ext cx="6293815" cy="5349240"/>
           </a:xfrm>
           <a:prstGeom prst="rect">
             <a:avLst/>
@@ -4338,101 +4378,10 @@
           </a:fontRef>
         </p:style>
         <p:txBody>
-          <a:bodyPr rtlCol="0" anchor="ctr" wrap="square"/>
-          <a:lstStyle/>
-          <a:p>
-            <a:pPr algn="ctr">
-              <a:defRPr sz="2000" b="1">
-                <a:solidFill>
-                  <a:srgbClr val="D95D39"/>
-                </a:solidFill>
-                <a:latin typeface="Inter"/>
-              </a:defRPr>
-            </a:pPr>
-            <a:r>
-              <a:t>15–20m</a:t>
-            </a:r>
-          </a:p>
-          <a:p>
-            <a:pPr>
-              <a:defRPr sz="950">
-                <a:solidFill>
-                  <a:srgbClr val="596E64"/>
-                </a:solidFill>
-                <a:latin typeface="Inter"/>
-              </a:defRPr>
-            </a:pPr>
-            <a:r>
-              <a:t>Manual triage eliminated</a:t>
-            </a:r>
-          </a:p>
-        </p:txBody>
-      </p:sp>
-      <p:sp>
-        <p:nvSpPr>
-          <p:cNvPr id="8" name="Rectangle 7"/>
-          <p:cNvSpPr/>
-          <p:nvPr/>
-        </p:nvSpPr>
-        <p:spPr>
-          <a:xfrm>
-            <a:off x="2103120" y="4663440"/>
-            <a:ext cx="1280160" cy="1280160"/>
-          </a:xfrm>
-          <a:prstGeom prst="rect">
-            <a:avLst/>
-          </a:prstGeom>
-          <a:solidFill>
-            <a:srgbClr val="FFFFFF"/>
-          </a:solidFill>
-          <a:ln w="12700">
-            <a:solidFill>
-              <a:srgbClr val="E2DED4"/>
-            </a:solidFill>
-          </a:ln>
-        </p:spPr>
-        <p:style>
-          <a:lnRef idx="1">
-            <a:schemeClr val="accent1"/>
-          </a:lnRef>
-          <a:fillRef idx="3">
-            <a:schemeClr val="accent1"/>
-          </a:fillRef>
-          <a:effectRef idx="2">
-            <a:schemeClr val="accent1"/>
-          </a:effectRef>
-          <a:fontRef idx="minor">
-            <a:schemeClr val="lt1"/>
-          </a:fontRef>
-        </p:style>
-        <p:txBody>
-          <a:bodyPr rtlCol="0" anchor="ctr" wrap="square"/>
-          <a:lstStyle/>
-          <a:p>
-            <a:pPr algn="ctr">
-              <a:defRPr sz="2000" b="1">
-                <a:solidFill>
-                  <a:srgbClr val="006B55"/>
-                </a:solidFill>
-                <a:latin typeface="Inter"/>
-              </a:defRPr>
-            </a:pPr>
-            <a:r>
-              <a:t>1-Click</a:t>
-            </a:r>
-          </a:p>
-          <a:p>
-            <a:pPr>
-              <a:defRPr sz="950">
-                <a:solidFill>
-                  <a:srgbClr val="596E64"/>
-                </a:solidFill>
-                <a:latin typeface="Inter"/>
-              </a:defRPr>
-            </a:pPr>
-            <a:r>
-              <a:t>Merchant verification</a:t>
-            </a:r>
+          <a:bodyPr rtlCol="0" anchor="ctr"/>
+          <a:lstStyle/>
+          <a:p>
+            <a:pPr algn="ctr"/>
           </a:p>
         </p:txBody>
       </p:sp>
@@ -4444,121 +4393,8 @@
         </p:nvSpPr>
         <p:spPr>
           <a:xfrm>
-            <a:off x="3474720" y="4663440"/>
-            <a:ext cx="1280160" cy="1280160"/>
-          </a:xfrm>
-          <a:prstGeom prst="rect">
-            <a:avLst/>
-          </a:prstGeom>
-          <a:solidFill>
-            <a:srgbClr val="FFFFFF"/>
-          </a:solidFill>
-          <a:ln w="12700">
-            <a:solidFill>
-              <a:srgbClr val="E2DED4"/>
-            </a:solidFill>
-          </a:ln>
-        </p:spPr>
-        <p:style>
-          <a:lnRef idx="1">
-            <a:schemeClr val="accent1"/>
-          </a:lnRef>
-          <a:fillRef idx="3">
-            <a:schemeClr val="accent1"/>
-          </a:fillRef>
-          <a:effectRef idx="2">
-            <a:schemeClr val="accent1"/>
-          </a:effectRef>
-          <a:fontRef idx="minor">
-            <a:schemeClr val="lt1"/>
-          </a:fontRef>
-        </p:style>
-        <p:txBody>
-          <a:bodyPr rtlCol="0" anchor="ctr" wrap="square"/>
-          <a:lstStyle/>
-          <a:p>
-            <a:pPr algn="ctr">
-              <a:defRPr sz="2000" b="1">
-                <a:solidFill>
-                  <a:srgbClr val="172621"/>
-                </a:solidFill>
-                <a:latin typeface="Inter"/>
-              </a:defRPr>
-            </a:pPr>
-            <a:r>
-              <a:t>24h</a:t>
-            </a:r>
-          </a:p>
-          <a:p>
-            <a:pPr>
-              <a:defRPr sz="950">
-                <a:solidFill>
-                  <a:srgbClr val="596E64"/>
-                </a:solidFill>
-                <a:latin typeface="Inter"/>
-              </a:defRPr>
-            </a:pPr>
-            <a:r>
-              <a:t>Prototype feasibility</a:t>
-            </a:r>
-          </a:p>
-        </p:txBody>
-      </p:sp>
-      <p:sp>
-        <p:nvSpPr>
-          <p:cNvPr id="10" name="Rectangle 9"/>
-          <p:cNvSpPr/>
-          <p:nvPr/>
-        </p:nvSpPr>
-        <p:spPr>
-          <a:xfrm>
-            <a:off x="5120640" y="685800"/>
-            <a:ext cx="6339535" cy="5394960"/>
-          </a:xfrm>
-          <a:prstGeom prst="rect">
-            <a:avLst/>
-          </a:prstGeom>
-          <a:solidFill>
-            <a:srgbClr val="FFFFFF"/>
-          </a:solidFill>
-          <a:ln w="12700">
-            <a:solidFill>
-              <a:srgbClr val="E2DED4"/>
-            </a:solidFill>
-          </a:ln>
-        </p:spPr>
-        <p:style>
-          <a:lnRef idx="1">
-            <a:schemeClr val="accent1"/>
-          </a:lnRef>
-          <a:fillRef idx="3">
-            <a:schemeClr val="accent1"/>
-          </a:fillRef>
-          <a:effectRef idx="2">
-            <a:schemeClr val="accent1"/>
-          </a:effectRef>
-          <a:fontRef idx="minor">
-            <a:schemeClr val="lt1"/>
-          </a:fontRef>
-        </p:style>
-        <p:txBody>
-          <a:bodyPr rtlCol="0" anchor="ctr"/>
-          <a:lstStyle/>
-          <a:p>
-            <a:pPr algn="ctr"/>
-          </a:p>
-        </p:txBody>
-      </p:sp>
-      <p:sp>
-        <p:nvSpPr>
-          <p:cNvPr id="11" name="Rectangle 10"/>
-          <p:cNvSpPr/>
-          <p:nvPr/>
-        </p:nvSpPr>
-        <p:spPr>
-          <a:xfrm>
-            <a:off x="5120640" y="685800"/>
-            <a:ext cx="6339535" cy="502920"/>
+            <a:off x="5166360" y="685800"/>
+            <a:ext cx="6293815" cy="457200"/>
           </a:xfrm>
           <a:prstGeom prst="rect">
             <a:avLst/>
@@ -4604,7 +4440,7 @@
       </p:sp>
       <p:pic>
         <p:nvPicPr>
-          <p:cNvPr id="12" name="Picture 11" descr="studio_white_headphones.jpg"/>
+          <p:cNvPr id="10" name="Picture 9" descr="studio_white_headphones.jpg"/>
           <p:cNvPicPr>
             <a:picLocks noChangeAspect="1"/>
           </p:cNvPicPr>
@@ -4618,8 +4454,8 @@
         </p:blipFill>
         <p:spPr>
           <a:xfrm>
-            <a:off x="5394960" y="1417320"/>
-            <a:ext cx="2468880" cy="2103120"/>
+            <a:off x="5349240" y="1280160"/>
+            <a:ext cx="2880360" cy="1920240"/>
           </a:xfrm>
           <a:prstGeom prst="rect">
             <a:avLst/>
@@ -4628,88 +4464,130 @@
       </p:pic>
       <p:sp>
         <p:nvSpPr>
-          <p:cNvPr id="13" name="TextBox 12"/>
-          <p:cNvSpPr txBox="1"/>
-          <p:nvPr/>
-        </p:nvSpPr>
-        <p:spPr>
-          <a:xfrm>
-            <a:off x="8046720" y="1371600"/>
-            <a:ext cx="3139135" cy="2194560"/>
-          </a:xfrm>
-          <a:prstGeom prst="rect">
-            <a:avLst/>
-          </a:prstGeom>
-          <a:noFill/>
-        </p:spPr>
-        <p:txBody>
-          <a:bodyPr wrap="square">
-            <a:spAutoFit/>
-          </a:bodyPr>
-          <a:lstStyle/>
-          <a:p>
-            <a:pPr>
-              <a:defRPr sz="950" b="1">
-                <a:solidFill>
-                  <a:srgbClr val="7A8E85"/>
+          <p:cNvPr id="11" name="Rectangle 10"/>
+          <p:cNvSpPr/>
+          <p:nvPr/>
+        </p:nvSpPr>
+        <p:spPr>
+          <a:xfrm>
+            <a:off x="5349240" y="3246120"/>
+            <a:ext cx="2880360" cy="292608"/>
+          </a:xfrm>
+          <a:prstGeom prst="rect">
+            <a:avLst/>
+          </a:prstGeom>
+          <a:solidFill>
+            <a:srgbClr val="E1F2EC"/>
+          </a:solidFill>
+          <a:ln>
+            <a:noFill/>
+          </a:ln>
+        </p:spPr>
+        <p:style>
+          <a:lnRef idx="1">
+            <a:schemeClr val="accent1"/>
+          </a:lnRef>
+          <a:fillRef idx="3">
+            <a:schemeClr val="accent1"/>
+          </a:fillRef>
+          <a:effectRef idx="2">
+            <a:schemeClr val="accent1"/>
+          </a:effectRef>
+          <a:fontRef idx="minor">
+            <a:schemeClr val="lt1"/>
+          </a:fontRef>
+        </p:style>
+        <p:txBody>
+          <a:bodyPr rtlCol="0" anchor="ctr"/>
+          <a:lstStyle/>
+          <a:p>
+            <a:pPr algn="ctr">
+              <a:defRPr sz="850" b="1">
+                <a:solidFill>
+                  <a:srgbClr val="006B55"/>
                 </a:solidFill>
                 <a:latin typeface="IBM Plex Mono"/>
               </a:defRPr>
             </a:pPr>
             <a:r>
-              <a:t>ORDER INFORMATION</a:t>
-            </a:r>
-          </a:p>
-          <a:p>
-            <a:pPr>
-              <a:defRPr sz="1100" b="1">
-                <a:solidFill>
-                  <a:srgbClr val="172621"/>
-                </a:solidFill>
-                <a:latin typeface="Inter"/>
-              </a:defRPr>
-            </a:pPr>
-            <a:r>
-              <a:t>Order #ORD-7729  ·  HEAD-WHT-02</a:t>
-            </a:r>
-            <a:br/>
-            <a:r>
-              <a:t>Matte White  ·  Price: ₹1,499</a:t>
-            </a:r>
-            <a:br/>
-            <a:r>
-              <a:t>Delivered 4 days ago</a:t>
-            </a:r>
-          </a:p>
-          <a:p>
-            <a:br/>
-            <a:pPr>
-              <a:defRPr sz="950" b="1">
-                <a:solidFill>
-                  <a:srgbClr val="7A8E85"/>
+              <a:t>ORDERED: HEAD-WHT-02 (WHITE)</a:t>
+            </a:r>
+          </a:p>
+        </p:txBody>
+      </p:sp>
+      <p:pic>
+        <p:nvPicPr>
+          <p:cNvPr id="12" name="Picture 11" descr="unboxing_black_headphones.jpg"/>
+          <p:cNvPicPr>
+            <a:picLocks noChangeAspect="1"/>
+          </p:cNvPicPr>
+          <p:nvPr/>
+        </p:nvPicPr>
+        <p:blipFill>
+          <a:blip r:embed="rId3"/>
+          <a:stretch>
+            <a:fillRect/>
+          </a:stretch>
+        </p:blipFill>
+        <p:spPr>
+          <a:xfrm>
+            <a:off x="8396935" y="1280160"/>
+            <a:ext cx="2880360" cy="1920240"/>
+          </a:xfrm>
+          <a:prstGeom prst="rect">
+            <a:avLst/>
+          </a:prstGeom>
+        </p:spPr>
+      </p:pic>
+      <p:sp>
+        <p:nvSpPr>
+          <p:cNvPr id="13" name="Rectangle 12"/>
+          <p:cNvSpPr/>
+          <p:nvPr/>
+        </p:nvSpPr>
+        <p:spPr>
+          <a:xfrm>
+            <a:off x="8396935" y="3246120"/>
+            <a:ext cx="2880360" cy="292608"/>
+          </a:xfrm>
+          <a:prstGeom prst="rect">
+            <a:avLst/>
+          </a:prstGeom>
+          <a:solidFill>
+            <a:srgbClr val="FCECE8"/>
+          </a:solidFill>
+          <a:ln>
+            <a:noFill/>
+          </a:ln>
+        </p:spPr>
+        <p:style>
+          <a:lnRef idx="1">
+            <a:schemeClr val="accent1"/>
+          </a:lnRef>
+          <a:fillRef idx="3">
+            <a:schemeClr val="accent1"/>
+          </a:fillRef>
+          <a:effectRef idx="2">
+            <a:schemeClr val="accent1"/>
+          </a:effectRef>
+          <a:fontRef idx="minor">
+            <a:schemeClr val="lt1"/>
+          </a:fontRef>
+        </p:style>
+        <p:txBody>
+          <a:bodyPr rtlCol="0" anchor="ctr"/>
+          <a:lstStyle/>
+          <a:p>
+            <a:pPr algn="ctr">
+              <a:defRPr sz="850" b="1">
+                <a:solidFill>
+                  <a:srgbClr val="991B1B"/>
                 </a:solidFill>
                 <a:latin typeface="IBM Plex Mono"/>
               </a:defRPr>
             </a:pPr>
             <a:r>
-              <a:t>EVIDENCE CITATION (STAGED)</a:t>
-            </a:r>
-          </a:p>
-          <a:p>
-            <a:pPr>
-              <a:defRPr sz="1050">
-                <a:solidFill>
-                  <a:srgbClr val="596E64"/>
-                </a:solidFill>
-                <a:latin typeface="Inter"/>
-              </a:defRPr>
-            </a:pPr>
-            <a:r>
-              <a:t>Frame 00:07 (Staged)</a:t>
-            </a:r>
-            <a:br/>
-            <a:r>
-              <a:t>Observed item casing is Midnight Black. Exact barcode unverified.</a:t>
+              <a:t>OBSERVED: BLACK ITEM · FRAME 00:07</a:t>
             </a:r>
           </a:p>
         </p:txBody>
@@ -4722,8 +4600,8 @@
         </p:nvSpPr>
         <p:spPr>
           <a:xfrm>
-            <a:off x="5394960" y="3703320"/>
-            <a:ext cx="5790895" cy="777240"/>
+            <a:off x="5349240" y="3639312"/>
+            <a:ext cx="5928055" cy="658368"/>
           </a:xfrm>
           <a:prstGeom prst="rect">
             <a:avLst/>
@@ -4756,7 +4634,7 @@
           <a:lstStyle/>
           <a:p>
             <a:pPr algn="ctr">
-              <a:defRPr sz="1000" b="1">
+              <a:defRPr sz="950" b="1">
                 <a:solidFill>
                   <a:srgbClr val="991B1B"/>
                 </a:solidFill>
@@ -4764,12 +4642,12 @@
               </a:defRPr>
             </a:pPr>
             <a:r>
-              <a:t>POLICY GATE: COLOR CONTRADICTION DETECTED</a:t>
+              <a:t>P-03: COLOR CONTRADICTION DETECTED</a:t>
             </a:r>
           </a:p>
           <a:p>
             <a:pPr>
-              <a:defRPr sz="1050">
+              <a:defRPr sz="950">
                 <a:solidFill>
                   <a:srgbClr val="991B1B"/>
                 </a:solidFill>
@@ -4790,8 +4668,8 @@
         </p:nvSpPr>
         <p:spPr>
           <a:xfrm>
-            <a:off x="5394960" y="4663439"/>
-            <a:ext cx="5790895" cy="411480"/>
+            <a:off x="5349240" y="4370832"/>
+            <a:ext cx="5928055" cy="365760"/>
           </a:xfrm>
           <a:prstGeom prst="rect">
             <a:avLst/>
@@ -4822,7 +4700,7 @@
           <a:lstStyle/>
           <a:p>
             <a:pPr algn="ctr">
-              <a:defRPr sz="1000" b="1">
+              <a:defRPr sz="950" b="1">
                 <a:solidFill>
                   <a:srgbClr val="92400E"/>
                 </a:solidFill>
@@ -4830,7 +4708,7 @@
               </a:defRPr>
             </a:pPr>
             <a:r>
-              <a:t>STATUS: ESCALATED FOR SELLER DECISION</a:t>
+              <a:t>STATUS: ESCALATED FOR SELLER DECISION (HUMAN GATE)</a:t>
             </a:r>
           </a:p>
         </p:txBody>
@@ -4843,8 +4721,8 @@
         </p:nvSpPr>
         <p:spPr>
           <a:xfrm>
-            <a:off x="5394960" y="5212080"/>
-            <a:ext cx="5790895" cy="594360"/>
+            <a:off x="5349240" y="4809744"/>
+            <a:ext cx="5928055" cy="502920"/>
           </a:xfrm>
           <a:prstGeom prst="rect">
             <a:avLst/>
@@ -4875,7 +4753,7 @@
           <a:lstStyle/>
           <a:p>
             <a:pPr algn="ctr">
-              <a:defRPr sz="1400" b="1">
+              <a:defRPr sz="1300" b="1">
                 <a:solidFill>
                   <a:srgbClr val="FFFFFF"/>
                 </a:solidFill>
@@ -4883,7 +4761,7 @@
               </a:defRPr>
             </a:pPr>
             <a:r>
-              <a:t>Review Evidence &amp; Authorize</a:t>
+              <a:t>Review Evidence &amp; Authorize Draft</a:t>
             </a:r>
           </a:p>
         </p:txBody>
@@ -5073,7 +4951,7 @@
         <p:spPr>
           <a:xfrm>
             <a:off x="731520" y="548640"/>
-            <a:ext cx="7315200" cy="365760"/>
+            <a:ext cx="7315200" cy="320040"/>
           </a:xfrm>
           <a:prstGeom prst="rect">
             <a:avLst/>
@@ -5108,8 +4986,8 @@
         </p:nvSpPr>
         <p:spPr>
           <a:xfrm>
-            <a:off x="731520" y="914400"/>
-            <a:ext cx="10698480" cy="685800"/>
+            <a:off x="731520" y="868680"/>
+            <a:ext cx="10728655" cy="594360"/>
           </a:xfrm>
           <a:prstGeom prst="rect">
             <a:avLst/>
@@ -5144,8 +5022,8 @@
         </p:nvSpPr>
         <p:spPr>
           <a:xfrm>
-            <a:off x="731520" y="1600200"/>
-            <a:ext cx="10698480" cy="457200"/>
+            <a:off x="731520" y="1463040"/>
+            <a:ext cx="10728655" cy="411480"/>
           </a:xfrm>
           <a:prstGeom prst="rect">
             <a:avLst/>
@@ -5153,7 +5031,7 @@
           <a:noFill/>
         </p:spPr>
         <p:txBody>
-          <a:bodyPr wrap="none">
+          <a:bodyPr wrap="square">
             <a:spAutoFit/>
           </a:bodyPr>
           <a:lstStyle/>
@@ -5167,7 +5045,7 @@
               </a:defRPr>
             </a:pPr>
             <a:r>
-              <a:t>Four systems. No traceable decision.  ·  Without a shared record, the seller connects order facts, video, and policy manually from memory.</a:t>
+              <a:t>Four systems. No traceable decision.  Without a shared record, the seller connects order facts, video, and policy manually from memory.</a:t>
             </a:r>
           </a:p>
         </p:txBody>
@@ -5180,8 +5058,8 @@
         </p:nvSpPr>
         <p:spPr>
           <a:xfrm>
-            <a:off x="731520" y="2240280"/>
-            <a:ext cx="3200400" cy="1783080"/>
+            <a:off x="731520" y="2057400"/>
+            <a:ext cx="4846320" cy="868680"/>
           </a:xfrm>
           <a:prstGeom prst="rect">
             <a:avLst/>
@@ -5214,7 +5092,7 @@
           <a:lstStyle/>
           <a:p>
             <a:pPr algn="ctr">
-              <a:defRPr sz="1000" b="1">
+              <a:defRPr sz="950" b="1">
                 <a:solidFill>
                   <a:srgbClr val="006B55"/>
                 </a:solidFill>
@@ -5222,33 +5100,20 @@
               </a:defRPr>
             </a:pPr>
             <a:r>
-              <a:t>01 BUYER VIDEO &amp; CLAIM</a:t>
-            </a:r>
-          </a:p>
-          <a:p>
-            <a:pPr>
-              <a:defRPr sz="1400" b="1">
-                <a:solidFill>
-                  <a:srgbClr val="172621"/>
-                </a:solidFill>
-                <a:latin typeface="Inter"/>
-              </a:defRPr>
-            </a:pPr>
-            <a:r>
-              <a:t>Buyer Video &amp; Claim</a:t>
+              <a:t>01  BUYER MESSAGE</a:t>
             </a:r>
           </a:p>
           <a:p>
             <a:pPr>
               <a:defRPr sz="1100">
                 <a:solidFill>
-                  <a:srgbClr val="596E64"/>
+                  <a:srgbClr val="172621"/>
                 </a:solidFill>
                 <a:latin typeface="Inter"/>
               </a:defRPr>
             </a:pPr>
             <a:r>
-              <a:t>Customer submits short unboxing clip and subjective text via chat.</a:t>
+              <a:t>Subjective text &amp; unindexed video claim in chat</a:t>
             </a:r>
           </a:p>
         </p:txBody>
@@ -5261,8 +5126,8 @@
         </p:nvSpPr>
         <p:spPr>
           <a:xfrm>
-            <a:off x="731520" y="4206240"/>
-            <a:ext cx="3200400" cy="1783080"/>
+            <a:off x="731520" y="3035808"/>
+            <a:ext cx="4846320" cy="868680"/>
           </a:xfrm>
           <a:prstGeom prst="rect">
             <a:avLst/>
@@ -5295,7 +5160,7 @@
           <a:lstStyle/>
           <a:p>
             <a:pPr algn="ctr">
-              <a:defRPr sz="1000" b="1">
+              <a:defRPr sz="950" b="1">
                 <a:solidFill>
                   <a:srgbClr val="006B55"/>
                 </a:solidFill>
@@ -5303,33 +5168,20 @@
               </a:defRPr>
             </a:pPr>
             <a:r>
-              <a:t>03 COURIER TRACKING SCAN</a:t>
-            </a:r>
-          </a:p>
-          <a:p>
-            <a:pPr>
-              <a:defRPr sz="1400" b="1">
-                <a:solidFill>
-                  <a:srgbClr val="172621"/>
-                </a:solidFill>
-                <a:latin typeface="Inter"/>
-              </a:defRPr>
-            </a:pPr>
-            <a:r>
-              <a:t>Courier Tracking Scan</a:t>
+              <a:t>02  ORDER RECORD</a:t>
             </a:r>
           </a:p>
           <a:p>
             <a:pPr>
               <a:defRPr sz="1100">
                 <a:solidFill>
-                  <a:srgbClr val="596E64"/>
+                  <a:srgbClr val="172621"/>
                 </a:solidFill>
                 <a:latin typeface="Inter"/>
               </a:defRPr>
             </a:pPr>
             <a:r>
-              <a:t>Shippo courier API records delivery scan 4 days ago.</a:t>
+              <a:t>Shopify manifest: HEAD-WHT-02, Matte White, ₹1,499</a:t>
             </a:r>
           </a:p>
         </p:txBody>
@@ -5342,8 +5194,180 @@
         </p:nvSpPr>
         <p:spPr>
           <a:xfrm>
-            <a:off x="4114800" y="2240280"/>
-            <a:ext cx="3962095" cy="3749039"/>
+            <a:off x="731520" y="4014216"/>
+            <a:ext cx="4846320" cy="868680"/>
+          </a:xfrm>
+          <a:prstGeom prst="rect">
+            <a:avLst/>
+          </a:prstGeom>
+          <a:solidFill>
+            <a:srgbClr val="FFFFFF"/>
+          </a:solidFill>
+          <a:ln w="12700">
+            <a:solidFill>
+              <a:srgbClr val="E2DED4"/>
+            </a:solidFill>
+          </a:ln>
+        </p:spPr>
+        <p:style>
+          <a:lnRef idx="1">
+            <a:schemeClr val="accent1"/>
+          </a:lnRef>
+          <a:fillRef idx="3">
+            <a:schemeClr val="accent1"/>
+          </a:fillRef>
+          <a:effectRef idx="2">
+            <a:schemeClr val="accent1"/>
+          </a:effectRef>
+          <a:fontRef idx="minor">
+            <a:schemeClr val="lt1"/>
+          </a:fontRef>
+        </p:style>
+        <p:txBody>
+          <a:bodyPr rtlCol="0" anchor="ctr" wrap="square"/>
+          <a:lstStyle/>
+          <a:p>
+            <a:pPr algn="ctr">
+              <a:defRPr sz="950" b="1">
+                <a:solidFill>
+                  <a:srgbClr val="006B55"/>
+                </a:solidFill>
+                <a:latin typeface="IBM Plex Mono"/>
+              </a:defRPr>
+            </a:pPr>
+            <a:r>
+              <a:t>03  COURIER STATUS</a:t>
+            </a:r>
+          </a:p>
+          <a:p>
+            <a:pPr>
+              <a:defRPr sz="1100">
+                <a:solidFill>
+                  <a:srgbClr val="172621"/>
+                </a:solidFill>
+                <a:latin typeface="Inter"/>
+              </a:defRPr>
+            </a:pPr>
+            <a:r>
+              <a:t>Shippo scan: delivered 4 days ago (Day 4 of 7)</a:t>
+            </a:r>
+          </a:p>
+        </p:txBody>
+      </p:sp>
+      <p:sp>
+        <p:nvSpPr>
+          <p:cNvPr id="9" name="Rectangle 8"/>
+          <p:cNvSpPr/>
+          <p:nvPr/>
+        </p:nvSpPr>
+        <p:spPr>
+          <a:xfrm>
+            <a:off x="731520" y="4992624"/>
+            <a:ext cx="4846320" cy="868680"/>
+          </a:xfrm>
+          <a:prstGeom prst="rect">
+            <a:avLst/>
+          </a:prstGeom>
+          <a:solidFill>
+            <a:srgbClr val="FFFFFF"/>
+          </a:solidFill>
+          <a:ln w="12700">
+            <a:solidFill>
+              <a:srgbClr val="E2DED4"/>
+            </a:solidFill>
+          </a:ln>
+        </p:spPr>
+        <p:style>
+          <a:lnRef idx="1">
+            <a:schemeClr val="accent1"/>
+          </a:lnRef>
+          <a:fillRef idx="3">
+            <a:schemeClr val="accent1"/>
+          </a:fillRef>
+          <a:effectRef idx="2">
+            <a:schemeClr val="accent1"/>
+          </a:effectRef>
+          <a:fontRef idx="minor">
+            <a:schemeClr val="lt1"/>
+          </a:fontRef>
+        </p:style>
+        <p:txBody>
+          <a:bodyPr rtlCol="0" anchor="ctr" wrap="square"/>
+          <a:lstStyle/>
+          <a:p>
+            <a:pPr algn="ctr">
+              <a:defRPr sz="950" b="1">
+                <a:solidFill>
+                  <a:srgbClr val="006B55"/>
+                </a:solidFill>
+                <a:latin typeface="IBM Plex Mono"/>
+              </a:defRPr>
+            </a:pPr>
+            <a:r>
+              <a:t>04  RETURN POLICY</a:t>
+            </a:r>
+          </a:p>
+          <a:p>
+            <a:pPr>
+              <a:defRPr sz="1100">
+                <a:solidFill>
+                  <a:srgbClr val="172621"/>
+                </a:solidFill>
+                <a:latin typeface="Inter"/>
+              </a:defRPr>
+            </a:pPr>
+            <a:r>
+              <a:t>7-day defect window; security packaging tag rule</a:t>
+            </a:r>
+          </a:p>
+        </p:txBody>
+      </p:sp>
+      <p:sp>
+        <p:nvSpPr>
+          <p:cNvPr id="10" name="TextBox 9"/>
+          <p:cNvSpPr txBox="1"/>
+          <p:nvPr/>
+        </p:nvSpPr>
+        <p:spPr>
+          <a:xfrm>
+            <a:off x="5715000" y="3474720"/>
+            <a:ext cx="365760" cy="548640"/>
+          </a:xfrm>
+          <a:prstGeom prst="rect">
+            <a:avLst/>
+          </a:prstGeom>
+          <a:noFill/>
+        </p:spPr>
+        <p:txBody>
+          <a:bodyPr wrap="none">
+            <a:spAutoFit/>
+          </a:bodyPr>
+          <a:lstStyle/>
+          <a:p>
+            <a:pPr>
+              <a:defRPr sz="2800" b="1">
+                <a:solidFill>
+                  <a:srgbClr val="D95D39"/>
+                </a:solidFill>
+                <a:latin typeface="IBM Plex Mono"/>
+              </a:defRPr>
+            </a:pPr>
+            <a:r>
+              <a:t>→</a:t>
+            </a:r>
+          </a:p>
+        </p:txBody>
+      </p:sp>
+      <p:sp>
+        <p:nvSpPr>
+          <p:cNvPr id="11" name="Rectangle 10"/>
+          <p:cNvSpPr/>
+          <p:nvPr/>
+        </p:nvSpPr>
+        <p:spPr>
+          <a:xfrm>
+            <a:off x="6217920" y="2057400"/>
+            <a:ext cx="5242255" cy="3803904"/>
           </a:xfrm>
           <a:prstGeom prst="rect">
             <a:avLst/>
@@ -5376,7 +5400,7 @@
           <a:lstStyle/>
           <a:p>
             <a:pPr algn="ctr">
-              <a:defRPr sz="1000" b="1">
+              <a:defRPr sz="1100" b="1">
                 <a:solidFill>
                   <a:srgbClr val="D95D39"/>
                 </a:solidFill>
@@ -5384,12 +5408,12 @@
               </a:defRPr>
             </a:pPr>
             <a:r>
-              <a:t>CRITICAL INFORMATION GAP</a:t>
+              <a:t>THE MISSING LINK</a:t>
             </a:r>
           </a:p>
           <a:p>
             <a:pPr algn="ctr">
-              <a:defRPr sz="1800" b="1">
+              <a:defRPr sz="2200" b="1">
                 <a:solidFill>
                   <a:srgbClr val="F5F3EF"/>
                 </a:solidFill>
@@ -5398,6 +5422,20 @@
             </a:pPr>
             <a:r>
               <a:t>NO SHARED EVIDENCE RECORD</a:t>
+            </a:r>
+          </a:p>
+          <a:p>
+            <a:br/>
+            <a:pPr algn="ctr">
+              <a:defRPr sz="1500" b="1" i="1">
+                <a:solidFill>
+                  <a:srgbClr val="FBBF24"/>
+                </a:solidFill>
+                <a:latin typeface="Inter"/>
+              </a:defRPr>
+            </a:pPr>
+            <a:r>
+              <a:t>“What evidence supports this return decision?”</a:t>
             </a:r>
           </a:p>
           <a:p>
@@ -5411,207 +5449,19 @@
               </a:defRPr>
             </a:pPr>
             <a:r>
-              <a:t>Today the seller opens 4 browser tabs and guesses. An erroneous refund burns inventory margin; an unfair denial destroys repeat customer trust. The gap is the absence of an auditable artifact tying order truth, video keyframes, and policy clauses together before money moves.</a:t>
-            </a:r>
-          </a:p>
-          <a:p>
+              <a:t>Today the seller opens 4 tabs and guesses. An erroneous refund burns inventory margin; an unfair denial destroys repeat customer trust.</a:t>
+            </a:r>
             <a:br/>
-            <a:pPr algn="ctr">
-              <a:defRPr sz="1600" b="1">
-                <a:solidFill>
-                  <a:srgbClr val="D95D39"/>
-                </a:solidFill>
-                <a:latin typeface="Inter"/>
-              </a:defRPr>
-            </a:pPr>
-            <a:r>
-              <a:t>9.0% vs 15.14%</a:t>
-            </a:r>
-          </a:p>
-          <a:p>
-            <a:pPr algn="ctr">
-              <a:defRPr sz="900">
-                <a:solidFill>
-                  <a:srgbClr val="9CA3AF"/>
-                </a:solidFill>
-                <a:latin typeface="Inter"/>
-              </a:defRPr>
-            </a:pPr>
-            <a:r>
-              <a:t>9.0% Return Fraud (NRF 2025, fraud only)  |  15.14% Fraud + Policy Abuse (Appriss/Deloitte 2024)</a:t>
-            </a:r>
             <a:br/>
             <a:r>
-              <a:t>Definitions differ: strict criminal fraud vs fraud combined with policy abuse.</a:t>
-            </a:r>
-          </a:p>
-        </p:txBody>
-      </p:sp>
-      <p:sp>
-        <p:nvSpPr>
-          <p:cNvPr id="9" name="Rectangle 8"/>
-          <p:cNvSpPr/>
-          <p:nvPr/>
-        </p:nvSpPr>
-        <p:spPr>
-          <a:xfrm>
-            <a:off x="8259775" y="2240280"/>
-            <a:ext cx="3200400" cy="1783080"/>
-          </a:xfrm>
-          <a:prstGeom prst="rect">
-            <a:avLst/>
-          </a:prstGeom>
-          <a:solidFill>
-            <a:srgbClr val="FFFFFF"/>
-          </a:solidFill>
-          <a:ln w="12700">
-            <a:solidFill>
-              <a:srgbClr val="E2DED4"/>
-            </a:solidFill>
-          </a:ln>
-        </p:spPr>
-        <p:style>
-          <a:lnRef idx="1">
-            <a:schemeClr val="accent1"/>
-          </a:lnRef>
-          <a:fillRef idx="3">
-            <a:schemeClr val="accent1"/>
-          </a:fillRef>
-          <a:effectRef idx="2">
-            <a:schemeClr val="accent1"/>
-          </a:effectRef>
-          <a:fontRef idx="minor">
-            <a:schemeClr val="lt1"/>
-          </a:fontRef>
-        </p:style>
-        <p:txBody>
-          <a:bodyPr rtlCol="0" anchor="ctr" wrap="square"/>
-          <a:lstStyle/>
-          <a:p>
-            <a:pPr algn="ctr">
-              <a:defRPr sz="1000" b="1">
-                <a:solidFill>
-                  <a:srgbClr val="006B55"/>
-                </a:solidFill>
-                <a:latin typeface="IBM Plex Mono"/>
-              </a:defRPr>
-            </a:pPr>
-            <a:r>
-              <a:t>02 STORE ORDER TRUTH</a:t>
-            </a:r>
-          </a:p>
-          <a:p>
-            <a:pPr>
-              <a:defRPr sz="1400" b="1">
-                <a:solidFill>
-                  <a:srgbClr val="172621"/>
-                </a:solidFill>
-                <a:latin typeface="Inter"/>
-              </a:defRPr>
-            </a:pPr>
-            <a:r>
-              <a:t>Store Order Truth</a:t>
-            </a:r>
-          </a:p>
-          <a:p>
-            <a:pPr>
-              <a:defRPr sz="1100">
-                <a:solidFill>
-                  <a:srgbClr val="596E64"/>
-                </a:solidFill>
-                <a:latin typeface="Inter"/>
-              </a:defRPr>
-            </a:pPr>
-            <a:r>
-              <a:t>Shopify store catalog specifies SKU HEAD-WHT-02 (White, ₹1,499).</a:t>
-            </a:r>
-          </a:p>
-        </p:txBody>
-      </p:sp>
-      <p:sp>
-        <p:nvSpPr>
-          <p:cNvPr id="10" name="Rectangle 9"/>
-          <p:cNvSpPr/>
-          <p:nvPr/>
-        </p:nvSpPr>
-        <p:spPr>
-          <a:xfrm>
-            <a:off x="8259775" y="4206240"/>
-            <a:ext cx="3200400" cy="1783080"/>
-          </a:xfrm>
-          <a:prstGeom prst="rect">
-            <a:avLst/>
-          </a:prstGeom>
-          <a:solidFill>
-            <a:srgbClr val="FFFFFF"/>
-          </a:solidFill>
-          <a:ln w="12700">
-            <a:solidFill>
-              <a:srgbClr val="E2DED4"/>
-            </a:solidFill>
-          </a:ln>
-        </p:spPr>
-        <p:style>
-          <a:lnRef idx="1">
-            <a:schemeClr val="accent1"/>
-          </a:lnRef>
-          <a:fillRef idx="3">
-            <a:schemeClr val="accent1"/>
-          </a:fillRef>
-          <a:effectRef idx="2">
-            <a:schemeClr val="accent1"/>
-          </a:effectRef>
-          <a:fontRef idx="minor">
-            <a:schemeClr val="lt1"/>
-          </a:fontRef>
-        </p:style>
-        <p:txBody>
-          <a:bodyPr rtlCol="0" anchor="ctr" wrap="square"/>
-          <a:lstStyle/>
-          <a:p>
-            <a:pPr algn="ctr">
-              <a:defRPr sz="1000" b="1">
-                <a:solidFill>
-                  <a:srgbClr val="006B55"/>
-                </a:solidFill>
-                <a:latin typeface="IBM Plex Mono"/>
-              </a:defRPr>
-            </a:pPr>
-            <a:r>
-              <a:t>04 STORE RETURN POLICY</a:t>
-            </a:r>
-          </a:p>
-          <a:p>
-            <a:pPr>
-              <a:defRPr sz="1400" b="1">
-                <a:solidFill>
-                  <a:srgbClr val="172621"/>
-                </a:solidFill>
-                <a:latin typeface="Inter"/>
-              </a:defRPr>
-            </a:pPr>
-            <a:r>
-              <a:t>Store Return Policy</a:t>
-            </a:r>
-          </a:p>
-          <a:p>
-            <a:pPr>
-              <a:defRPr sz="1100">
-                <a:solidFill>
-                  <a:srgbClr val="596E64"/>
-                </a:solidFill>
-                <a:latin typeface="Inter"/>
-              </a:defRPr>
-            </a:pPr>
-            <a:r>
-              <a:t>7-day defect window and tag condition in store terms.</a:t>
-            </a:r>
-          </a:p>
-        </p:txBody>
-      </p:sp>
-      <p:sp>
-        <p:nvSpPr>
-          <p:cNvPr id="11" name="Rectangle 10"/>
+              <a:t>The gap is not a missing return portal — it is the lack of an immutable trace linking order truth, video keyframes, and policy terms before money moves.</a:t>
+            </a:r>
+          </a:p>
+        </p:txBody>
+      </p:sp>
+      <p:sp>
+        <p:nvSpPr>
+          <p:cNvPr id="12" name="Rectangle 11"/>
           <p:cNvSpPr/>
           <p:nvPr/>
         </p:nvSpPr>
@@ -5654,7 +5504,7 @@
       </p:sp>
       <p:sp>
         <p:nvSpPr>
-          <p:cNvPr id="12" name="TextBox 11"/>
+          <p:cNvPr id="13" name="TextBox 12"/>
           <p:cNvSpPr txBox="1"/>
           <p:nvPr/>
         </p:nvSpPr>
@@ -5683,14 +5533,14 @@
               </a:defRPr>
             </a:pPr>
             <a:r>
-              <a:t>Fraud statistics note: 9.0% (NRF 2025, fraud only) vs 15.14% (Appriss/Deloitte 2024, fraud + abuse)</a:t>
-            </a:r>
-          </a:p>
-        </p:txBody>
-      </p:sp>
-      <p:sp>
-        <p:nvSpPr>
-          <p:cNvPr id="13" name="TextBox 12"/>
+              <a:t>Fraud research: 9% strict fraud (NRF 2025) vs 15.14% fraud + abuse (Appriss/Deloitte 2024). Details in notes.</a:t>
+            </a:r>
+          </a:p>
+        </p:txBody>
+      </p:sp>
+      <p:sp>
+        <p:nvSpPr>
+          <p:cNvPr id="14" name="TextBox 13"/>
           <p:cNvSpPr txBox="1"/>
           <p:nvPr/>
         </p:nvSpPr>
@@ -5794,7 +5644,7 @@
         <p:spPr>
           <a:xfrm>
             <a:off x="731520" y="502920"/>
-            <a:ext cx="7315200" cy="365760"/>
+            <a:ext cx="7315200" cy="320040"/>
           </a:xfrm>
           <a:prstGeom prst="rect">
             <a:avLst/>
@@ -5816,7 +5666,7 @@
               </a:defRPr>
             </a:pPr>
             <a:r>
-              <a:t>VISUAL EVIDENCE BENCHMARK · STAR DEMO</a:t>
+              <a:t>STAR DEMO · CORE BENCHMARK SCENARIO</a:t>
             </a:r>
           </a:p>
         </p:txBody>
@@ -5829,8 +5679,8 @@
         </p:nvSpPr>
         <p:spPr>
           <a:xfrm>
-            <a:off x="731520" y="868680"/>
-            <a:ext cx="10698480" cy="685800"/>
+            <a:off x="731520" y="822960"/>
+            <a:ext cx="10728655" cy="594360"/>
           </a:xfrm>
           <a:prstGeom prst="rect">
             <a:avLst/>
@@ -5865,8 +5715,8 @@
         </p:nvSpPr>
         <p:spPr>
           <a:xfrm>
-            <a:off x="731520" y="1554480"/>
-            <a:ext cx="10698480" cy="411480"/>
+            <a:off x="731520" y="1417320"/>
+            <a:ext cx="10728655" cy="411480"/>
           </a:xfrm>
           <a:prstGeom prst="rect">
             <a:avLst/>
@@ -5880,7 +5730,7 @@
           <a:lstStyle/>
           <a:p>
             <a:pPr>
-              <a:defRPr sz="1900">
+              <a:defRPr sz="2000" b="1">
                 <a:solidFill>
                   <a:srgbClr val="596E64"/>
                 </a:solidFill>
@@ -5901,8 +5751,8 @@
         </p:nvSpPr>
         <p:spPr>
           <a:xfrm>
-            <a:off x="731520" y="2057400"/>
-            <a:ext cx="7040880" cy="4069080"/>
+            <a:off x="731520" y="1965960"/>
+            <a:ext cx="7132320" cy="4069080"/>
           </a:xfrm>
           <a:prstGeom prst="rect">
             <a:avLst/>
@@ -5954,8 +5804,8 @@
         </p:blipFill>
         <p:spPr>
           <a:xfrm>
-            <a:off x="914400" y="2240280"/>
-            <a:ext cx="3246120" cy="2560320"/>
+            <a:off x="914400" y="2148840"/>
+            <a:ext cx="3291840" cy="2651760"/>
           </a:xfrm>
           <a:prstGeom prst="rect">
             <a:avLst/>
@@ -5978,8 +5828,8 @@
         </p:blipFill>
         <p:spPr>
           <a:xfrm>
-            <a:off x="4343400" y="2240280"/>
-            <a:ext cx="3246120" cy="2560320"/>
+            <a:off x="4389120" y="2148840"/>
+            <a:ext cx="3291840" cy="2651760"/>
           </a:xfrm>
           <a:prstGeom prst="rect">
             <a:avLst/>
@@ -5994,8 +5844,8 @@
         </p:nvSpPr>
         <p:spPr>
           <a:xfrm>
-            <a:off x="914400" y="4892040"/>
-            <a:ext cx="3246120" cy="320040"/>
+            <a:off x="914400" y="4873752"/>
+            <a:ext cx="3291840" cy="320040"/>
           </a:xfrm>
           <a:prstGeom prst="rect">
             <a:avLst/>
@@ -6047,8 +5897,8 @@
         </p:nvSpPr>
         <p:spPr>
           <a:xfrm>
-            <a:off x="4343400" y="4892040"/>
-            <a:ext cx="3246120" cy="320040"/>
+            <a:off x="4389120" y="4873752"/>
+            <a:ext cx="3291840" cy="320040"/>
           </a:xfrm>
           <a:prstGeom prst="rect">
             <a:avLst/>
@@ -6100,8 +5950,8 @@
         </p:nvSpPr>
         <p:spPr>
           <a:xfrm>
-            <a:off x="914400" y="5303520"/>
-            <a:ext cx="6675120" cy="731520"/>
+            <a:off x="914400" y="5257800"/>
+            <a:ext cx="6766560" cy="685800"/>
           </a:xfrm>
           <a:prstGeom prst="rect">
             <a:avLst/>
@@ -6123,7 +5973,7 @@
               </a:defRPr>
             </a:pPr>
             <a:r>
-              <a:t>Visual Grounding Honesty: Keyframe resolution reveals black casing. Exact SKU barcode is unreadable in this frame; ReturnLens factually records 'Observed Color: Midnight Black · Exact SKU: Not verified' and cites frame 00:07.</a:t>
+              <a:t>Visual Grounding Honesty: Keyframe resolution proves black casing. Exact SKU barcode is unreadable in this frame; ReturnLens factually records 'Observed Color: Black · Exact SKU: Not verified' and cites frame 00:07.</a:t>
             </a:r>
           </a:p>
         </p:txBody>
@@ -6136,8 +5986,8 @@
         </p:nvSpPr>
         <p:spPr>
           <a:xfrm>
-            <a:off x="8001000" y="2057400"/>
-            <a:ext cx="3459175" cy="4069080"/>
+            <a:off x="8119872" y="1965960"/>
+            <a:ext cx="3340303" cy="4069080"/>
           </a:xfrm>
           <a:prstGeom prst="rect">
             <a:avLst/>
@@ -6181,8 +6031,8 @@
         </p:nvSpPr>
         <p:spPr>
           <a:xfrm>
-            <a:off x="8183880" y="2194560"/>
-            <a:ext cx="3093415" cy="3794760"/>
+            <a:off x="8302752" y="2103120"/>
+            <a:ext cx="2974543" cy="3794760"/>
           </a:xfrm>
           <a:prstGeom prst="rect">
             <a:avLst/>
@@ -6204,7 +6054,7 @@
               </a:defRPr>
             </a:pPr>
             <a:r>
-              <a:t>DETERMINISTIC POLICY GATE</a:t>
+              <a:t>POLICY GATE EVALUATION</a:t>
             </a:r>
           </a:p>
           <a:p>
@@ -6222,7 +6072,7 @@
           </a:p>
           <a:p>
             <a:pPr>
-              <a:defRPr sz="900" b="1">
+              <a:defRPr sz="950" b="1">
                 <a:solidFill>
                   <a:srgbClr val="991B1B"/>
                 </a:solidFill>
@@ -6230,11 +6080,7 @@
               </a:defRPr>
             </a:pPr>
             <a:r>
-              <a:t>SELLER REVIEW REQUIRED</a:t>
-            </a:r>
-            <a:br/>
-            <a:r>
-              <a:t>Observed: Midnight Black · Exact SKU: Not verified in frame</a:t>
+              <a:t>STATUS: SELLER REVIEW REQUIRED</a:t>
             </a:r>
           </a:p>
           <a:p>
@@ -6248,6 +6094,59 @@
               </a:defRPr>
             </a:pPr>
             <a:r>
+              <a:t>Key Findings:</a:t>
+            </a:r>
+          </a:p>
+          <a:p>
+            <a:pPr>
+              <a:defRPr sz="1000">
+                <a:solidFill>
+                  <a:srgbClr val="596E64"/>
+                </a:solidFill>
+                <a:latin typeface="Inter"/>
+              </a:defRPr>
+            </a:pPr>
+            <a:r>
+              <a:t>• OBSERVED: Midnight Black</a:t>
+            </a:r>
+          </a:p>
+          <a:p>
+            <a:pPr>
+              <a:defRPr sz="1000">
+                <a:solidFill>
+                  <a:srgbClr val="596E64"/>
+                </a:solidFill>
+                <a:latin typeface="Inter"/>
+              </a:defRPr>
+            </a:pPr>
+            <a:r>
+              <a:t>• UNVERIFIED: Exact SKU barcode</a:t>
+            </a:r>
+          </a:p>
+          <a:p>
+            <a:pPr>
+              <a:defRPr sz="1000">
+                <a:solidFill>
+                  <a:srgbClr val="596E64"/>
+                </a:solidFill>
+                <a:latin typeface="Inter"/>
+              </a:defRPr>
+            </a:pPr>
+            <a:r>
+              <a:t>• NEXT ACTION: Seller review</a:t>
+            </a:r>
+          </a:p>
+          <a:p>
+            <a:br/>
+            <a:pPr>
+              <a:defRPr sz="1100" b="1">
+                <a:solidFill>
+                  <a:srgbClr val="172621"/>
+                </a:solidFill>
+                <a:latin typeface="Inter"/>
+              </a:defRPr>
+            </a:pPr>
+            <a:r>
               <a:t>Seller Resolution Options:</a:t>
             </a:r>
           </a:p>
@@ -6261,7 +6160,7 @@
               </a:defRPr>
             </a:pPr>
             <a:r>
-              <a:t>1. Request unboxing video with packaging label / serial visible</a:t>
+              <a:t>1. Request unboxing box label photo</a:t>
             </a:r>
           </a:p>
           <a:p>
@@ -6274,7 +6173,7 @@
               </a:defRPr>
             </a:pPr>
             <a:r>
-              <a:t>2. Reject return under policy (item does not match order record)</a:t>
+              <a:t>2. Reject return (item does not match order)</a:t>
             </a:r>
           </a:p>
           <a:p>
@@ -6287,13 +6186,13 @@
               </a:defRPr>
             </a:pPr>
             <a:r>
-              <a:t>3. Override &amp; approve if seller acknowledges known warehouse mis-shipment</a:t>
+              <a:t>3. Override &amp; approve (warehouse error)</a:t>
             </a:r>
           </a:p>
           <a:p>
             <a:br/>
             <a:pPr>
-              <a:defRPr sz="850">
+              <a:defRPr sz="900" b="1">
                 <a:solidFill>
                   <a:srgbClr val="596E64"/>
                 </a:solidFill>
@@ -6301,15 +6200,7 @@
               </a:defRPr>
             </a:pPr>
             <a:r>
-              <a:t>Financial Safety Ceiling:</a:t>
-            </a:r>
-            <a:br/>
-            <a:r>
-              <a:t>0 &lt; amount &lt;= min(₹4,999, remaining_refundable, order_paid)</a:t>
-            </a:r>
-            <a:br/>
-            <a:r>
-              <a:t>No auto-denial · No refund released without seller click</a:t>
+              <a:t>No auto-denial · No refund without seller click</a:t>
             </a:r>
           </a:p>
         </p:txBody>
@@ -6499,7 +6390,7 @@
         <p:spPr>
           <a:xfrm>
             <a:off x="731520" y="502920"/>
-            <a:ext cx="7315200" cy="365760"/>
+            <a:ext cx="7315200" cy="320040"/>
           </a:xfrm>
           <a:prstGeom prst="rect">
             <a:avLst/>
@@ -6534,8 +6425,8 @@
         </p:nvSpPr>
         <p:spPr>
           <a:xfrm>
-            <a:off x="731520" y="868680"/>
-            <a:ext cx="10698480" cy="685800"/>
+            <a:off x="731520" y="822960"/>
+            <a:ext cx="10728655" cy="594360"/>
           </a:xfrm>
           <a:prstGeom prst="rect">
             <a:avLst/>
@@ -6570,8 +6461,8 @@
         </p:nvSpPr>
         <p:spPr>
           <a:xfrm>
-            <a:off x="731520" y="1508760"/>
-            <a:ext cx="10698480" cy="411480"/>
+            <a:off x="731520" y="1417320"/>
+            <a:ext cx="10728655" cy="411480"/>
           </a:xfrm>
           <a:prstGeom prst="rect">
             <a:avLst/>
@@ -6585,7 +6476,7 @@
           <a:lstStyle/>
           <a:p>
             <a:pPr>
-              <a:defRPr sz="1800">
+              <a:defRPr sz="1900">
                 <a:solidFill>
                   <a:srgbClr val="A3B8B0"/>
                 </a:solidFill>
@@ -6606,8 +6497,8 @@
         </p:nvSpPr>
         <p:spPr>
           <a:xfrm>
-            <a:off x="731520" y="2057400"/>
-            <a:ext cx="1600200" cy="1234440"/>
+            <a:off x="731520" y="1965960"/>
+            <a:ext cx="3291840" cy="1234440"/>
           </a:xfrm>
           <a:prstGeom prst="rect">
             <a:avLst/>
@@ -6640,15 +6531,15 @@
           <a:lstStyle/>
           <a:p>
             <a:pPr algn="ctr">
-              <a:defRPr sz="900">
-                <a:solidFill>
-                  <a:srgbClr val="6C8279"/>
+              <a:defRPr sz="950" b="1">
+                <a:solidFill>
+                  <a:srgbClr val="00D1A7"/>
                 </a:solidFill>
                 <a:latin typeface="IBM Plex Mono"/>
               </a:defRPr>
             </a:pPr>
             <a:r>
-              <a:t>01 PLAN</a:t>
+              <a:t>01 MODEL ZONE</a:t>
             </a:r>
           </a:p>
           <a:p>
@@ -6661,12 +6552,12 @@
               </a:defRPr>
             </a:pPr>
             <a:r>
-              <a:t>Plan</a:t>
+              <a:t>Plan &amp; Observe</a:t>
             </a:r>
           </a:p>
           <a:p>
             <a:pPr>
-              <a:defRPr sz="900">
+              <a:defRPr sz="950">
                 <a:solidFill>
                   <a:srgbClr val="A3B8B0"/>
                 </a:solidFill>
@@ -6674,7 +6565,7 @@
               </a:defRPr>
             </a:pPr>
             <a:r>
-              <a:t>Typed plan schema</a:t>
+              <a:t>Planner validates JSON schema · Vision extracts keyframes &amp; non-binding visual metadata.</a:t>
             </a:r>
           </a:p>
         </p:txBody>
@@ -6687,8 +6578,8 @@
         </p:nvSpPr>
         <p:spPr>
           <a:xfrm>
-            <a:off x="731520" y="2057400"/>
-            <a:ext cx="1600200" cy="36576"/>
+            <a:off x="731520" y="1965960"/>
+            <a:ext cx="3291840" cy="36576"/>
           </a:xfrm>
           <a:prstGeom prst="rect">
             <a:avLst/>
@@ -6730,97 +6621,8 @@
         </p:nvSpPr>
         <p:spPr>
           <a:xfrm>
-            <a:off x="822960" y="2926080"/>
-            <a:ext cx="1417320" cy="237744"/>
-          </a:xfrm>
-          <a:prstGeom prst="rect">
-            <a:avLst/>
-          </a:prstGeom>
-          <a:solidFill>
-            <a:srgbClr val="00382B"/>
-          </a:solidFill>
-          <a:ln>
-            <a:noFill/>
-          </a:ln>
-        </p:spPr>
-        <p:style>
-          <a:lnRef idx="1">
-            <a:schemeClr val="accent1"/>
-          </a:lnRef>
-          <a:fillRef idx="3">
-            <a:schemeClr val="accent1"/>
-          </a:fillRef>
-          <a:effectRef idx="2">
-            <a:schemeClr val="accent1"/>
-          </a:effectRef>
-          <a:fontRef idx="minor">
-            <a:schemeClr val="lt1"/>
-          </a:fontRef>
-        </p:style>
-        <p:txBody>
-          <a:bodyPr rtlCol="0" anchor="ctr"/>
-          <a:lstStyle/>
-          <a:p>
-            <a:pPr algn="ctr">
-              <a:defRPr sz="850" b="1">
-                <a:solidFill>
-                  <a:srgbClr val="00D1A7"/>
-                </a:solidFill>
-                <a:latin typeface="IBM Plex Mono"/>
-              </a:defRPr>
-            </a:pPr>
-            <a:r>
-              <a:t>MODEL</a:t>
-            </a:r>
-          </a:p>
-        </p:txBody>
-      </p:sp>
-      <p:sp>
-        <p:nvSpPr>
-          <p:cNvPr id="9" name="TextBox 8"/>
-          <p:cNvSpPr txBox="1"/>
-          <p:nvPr/>
-        </p:nvSpPr>
-        <p:spPr>
-          <a:xfrm>
-            <a:off x="2331720" y="2423160"/>
-            <a:ext cx="219456" cy="365760"/>
-          </a:xfrm>
-          <a:prstGeom prst="rect">
-            <a:avLst/>
-          </a:prstGeom>
-          <a:noFill/>
-        </p:spPr>
-        <p:txBody>
-          <a:bodyPr wrap="none">
-            <a:spAutoFit/>
-          </a:bodyPr>
-          <a:lstStyle/>
-          <a:p>
-            <a:pPr algn="ctr">
-              <a:defRPr sz="1400" b="1">
-                <a:solidFill>
-                  <a:srgbClr val="00D1A7"/>
-                </a:solidFill>
-                <a:latin typeface="IBM Plex Mono"/>
-              </a:defRPr>
-            </a:pPr>
-            <a:r>
-              <a:t>→</a:t>
-            </a:r>
-          </a:p>
-        </p:txBody>
-      </p:sp>
-      <p:sp>
-        <p:nvSpPr>
-          <p:cNvPr id="10" name="Rectangle 9"/>
-          <p:cNvSpPr/>
-          <p:nvPr/>
-        </p:nvSpPr>
-        <p:spPr>
-          <a:xfrm>
-            <a:off x="2551176" y="2057400"/>
-            <a:ext cx="1600200" cy="1234440"/>
+            <a:off x="4242816" y="1965960"/>
+            <a:ext cx="3840480" cy="1234440"/>
           </a:xfrm>
           <a:prstGeom prst="rect">
             <a:avLst/>
@@ -6853,15 +6655,15 @@
           <a:lstStyle/>
           <a:p>
             <a:pPr algn="ctr">
-              <a:defRPr sz="900">
-                <a:solidFill>
-                  <a:srgbClr val="6C8279"/>
+              <a:defRPr sz="950" b="1">
+                <a:solidFill>
+                  <a:srgbClr val="F5F3EF"/>
                 </a:solidFill>
                 <a:latin typeface="IBM Plex Mono"/>
               </a:defRPr>
             </a:pPr>
             <a:r>
-              <a:t>02 RETRIEVE</a:t>
+              <a:t>02 CODE ZONE</a:t>
             </a:r>
           </a:p>
           <a:p>
@@ -6874,12 +6676,12 @@
               </a:defRPr>
             </a:pPr>
             <a:r>
-              <a:t>Retrieve</a:t>
+              <a:t>Retrieve &amp; Enforce Policy</a:t>
             </a:r>
           </a:p>
           <a:p>
             <a:pPr>
-              <a:defRPr sz="900">
+              <a:defRPr sz="950">
                 <a:solidFill>
                   <a:srgbClr val="A3B8B0"/>
                 </a:solidFill>
@@ -6887,21 +6689,21 @@
               </a:defRPr>
             </a:pPr>
             <a:r>
-              <a:t>FFmpeg &amp; mock APIs</a:t>
-            </a:r>
-          </a:p>
-        </p:txBody>
-      </p:sp>
-      <p:sp>
-        <p:nvSpPr>
-          <p:cNvPr id="11" name="Rectangle 10"/>
+              <a:t>Deterministic Python rules P-01 to P-08 · Shippo &amp; Shopify mock APIs enforce hard rules.</a:t>
+            </a:r>
+          </a:p>
+        </p:txBody>
+      </p:sp>
+      <p:sp>
+        <p:nvSpPr>
+          <p:cNvPr id="9" name="Rectangle 8"/>
           <p:cNvSpPr/>
           <p:nvPr/>
         </p:nvSpPr>
         <p:spPr>
           <a:xfrm>
-            <a:off x="2551176" y="2057400"/>
-            <a:ext cx="1600200" cy="36576"/>
+            <a:off x="4242816" y="1965960"/>
+            <a:ext cx="3840480" cy="36576"/>
           </a:xfrm>
           <a:prstGeom prst="rect">
             <a:avLst/>
@@ -6937,103 +6739,14 @@
       </p:sp>
       <p:sp>
         <p:nvSpPr>
-          <p:cNvPr id="12" name="Rectangle 11"/>
+          <p:cNvPr id="10" name="Rectangle 9"/>
           <p:cNvSpPr/>
           <p:nvPr/>
         </p:nvSpPr>
         <p:spPr>
           <a:xfrm>
-            <a:off x="2642616" y="2926080"/>
-            <a:ext cx="1417320" cy="237744"/>
-          </a:xfrm>
-          <a:prstGeom prst="rect">
-            <a:avLst/>
-          </a:prstGeom>
-          <a:solidFill>
-            <a:srgbClr val="263831"/>
-          </a:solidFill>
-          <a:ln>
-            <a:noFill/>
-          </a:ln>
-        </p:spPr>
-        <p:style>
-          <a:lnRef idx="1">
-            <a:schemeClr val="accent1"/>
-          </a:lnRef>
-          <a:fillRef idx="3">
-            <a:schemeClr val="accent1"/>
-          </a:fillRef>
-          <a:effectRef idx="2">
-            <a:schemeClr val="accent1"/>
-          </a:effectRef>
-          <a:fontRef idx="minor">
-            <a:schemeClr val="lt1"/>
-          </a:fontRef>
-        </p:style>
-        <p:txBody>
-          <a:bodyPr rtlCol="0" anchor="ctr"/>
-          <a:lstStyle/>
-          <a:p>
-            <a:pPr algn="ctr">
-              <a:defRPr sz="850" b="1">
-                <a:solidFill>
-                  <a:srgbClr val="F5F3EF"/>
-                </a:solidFill>
-                <a:latin typeface="IBM Plex Mono"/>
-              </a:defRPr>
-            </a:pPr>
-            <a:r>
-              <a:t>CODE</a:t>
-            </a:r>
-          </a:p>
-        </p:txBody>
-      </p:sp>
-      <p:sp>
-        <p:nvSpPr>
-          <p:cNvPr id="13" name="TextBox 12"/>
-          <p:cNvSpPr txBox="1"/>
-          <p:nvPr/>
-        </p:nvSpPr>
-        <p:spPr>
-          <a:xfrm>
-            <a:off x="4151376" y="2423160"/>
-            <a:ext cx="219456" cy="365760"/>
-          </a:xfrm>
-          <a:prstGeom prst="rect">
-            <a:avLst/>
-          </a:prstGeom>
-          <a:noFill/>
-        </p:spPr>
-        <p:txBody>
-          <a:bodyPr wrap="none">
-            <a:spAutoFit/>
-          </a:bodyPr>
-          <a:lstStyle/>
-          <a:p>
-            <a:pPr algn="ctr">
-              <a:defRPr sz="1400" b="1">
-                <a:solidFill>
-                  <a:srgbClr val="00D1A7"/>
-                </a:solidFill>
-                <a:latin typeface="IBM Plex Mono"/>
-              </a:defRPr>
-            </a:pPr>
-            <a:r>
-              <a:t>→</a:t>
-            </a:r>
-          </a:p>
-        </p:txBody>
-      </p:sp>
-      <p:sp>
-        <p:nvSpPr>
-          <p:cNvPr id="14" name="Rectangle 13"/>
-          <p:cNvSpPr/>
-          <p:nvPr/>
-        </p:nvSpPr>
-        <p:spPr>
-          <a:xfrm>
-            <a:off x="4370832" y="2057400"/>
-            <a:ext cx="1600200" cy="1234440"/>
+            <a:off x="8302752" y="1965960"/>
+            <a:ext cx="3157423" cy="1234440"/>
           </a:xfrm>
           <a:prstGeom prst="rect">
             <a:avLst/>
@@ -7066,15 +6779,15 @@
           <a:lstStyle/>
           <a:p>
             <a:pPr algn="ctr">
-              <a:defRPr sz="900">
-                <a:solidFill>
-                  <a:srgbClr val="6C8279"/>
+              <a:defRPr sz="950" b="1">
+                <a:solidFill>
+                  <a:srgbClr val="FBBF24"/>
                 </a:solidFill>
                 <a:latin typeface="IBM Plex Mono"/>
               </a:defRPr>
             </a:pPr>
             <a:r>
-              <a:t>03 EVALUATE</a:t>
+              <a:t>03 HUMAN SELLER GATE</a:t>
             </a:r>
           </a:p>
           <a:p>
@@ -7087,12 +6800,12 @@
               </a:defRPr>
             </a:pPr>
             <a:r>
-              <a:t>Evaluate</a:t>
+              <a:t>Authorize Consequential Action</a:t>
             </a:r>
           </a:p>
           <a:p>
             <a:pPr>
-              <a:defRPr sz="900">
+              <a:defRPr sz="950">
                 <a:solidFill>
                   <a:srgbClr val="A3B8B0"/>
                 </a:solidFill>
@@ -7100,447 +6813,21 @@
               </a:defRPr>
             </a:pPr>
             <a:r>
-              <a:t>Rules P-01 to P-08</a:t>
-            </a:r>
-          </a:p>
-        </p:txBody>
-      </p:sp>
-      <p:sp>
-        <p:nvSpPr>
-          <p:cNvPr id="15" name="Rectangle 14"/>
+              <a:t>Fail-closed authorization gate · 1-click human merchant confirmation for refund release.</a:t>
+            </a:r>
+          </a:p>
+        </p:txBody>
+      </p:sp>
+      <p:sp>
+        <p:nvSpPr>
+          <p:cNvPr id="11" name="Rectangle 10"/>
           <p:cNvSpPr/>
           <p:nvPr/>
         </p:nvSpPr>
         <p:spPr>
           <a:xfrm>
-            <a:off x="4370832" y="2057400"/>
-            <a:ext cx="1600200" cy="36576"/>
-          </a:xfrm>
-          <a:prstGeom prst="rect">
-            <a:avLst/>
-          </a:prstGeom>
-          <a:solidFill>
-            <a:srgbClr val="F5F3EF"/>
-          </a:solidFill>
-          <a:ln>
-            <a:noFill/>
-          </a:ln>
-        </p:spPr>
-        <p:style>
-          <a:lnRef idx="1">
-            <a:schemeClr val="accent1"/>
-          </a:lnRef>
-          <a:fillRef idx="3">
-            <a:schemeClr val="accent1"/>
-          </a:fillRef>
-          <a:effectRef idx="2">
-            <a:schemeClr val="accent1"/>
-          </a:effectRef>
-          <a:fontRef idx="minor">
-            <a:schemeClr val="lt1"/>
-          </a:fontRef>
-        </p:style>
-        <p:txBody>
-          <a:bodyPr rtlCol="0" anchor="ctr"/>
-          <a:lstStyle/>
-          <a:p>
-            <a:pPr algn="ctr"/>
-          </a:p>
-        </p:txBody>
-      </p:sp>
-      <p:sp>
-        <p:nvSpPr>
-          <p:cNvPr id="16" name="Rectangle 15"/>
-          <p:cNvSpPr/>
-          <p:nvPr/>
-        </p:nvSpPr>
-        <p:spPr>
-          <a:xfrm>
-            <a:off x="4462272" y="2926080"/>
-            <a:ext cx="1417320" cy="237744"/>
-          </a:xfrm>
-          <a:prstGeom prst="rect">
-            <a:avLst/>
-          </a:prstGeom>
-          <a:solidFill>
-            <a:srgbClr val="263831"/>
-          </a:solidFill>
-          <a:ln>
-            <a:noFill/>
-          </a:ln>
-        </p:spPr>
-        <p:style>
-          <a:lnRef idx="1">
-            <a:schemeClr val="accent1"/>
-          </a:lnRef>
-          <a:fillRef idx="3">
-            <a:schemeClr val="accent1"/>
-          </a:fillRef>
-          <a:effectRef idx="2">
-            <a:schemeClr val="accent1"/>
-          </a:effectRef>
-          <a:fontRef idx="minor">
-            <a:schemeClr val="lt1"/>
-          </a:fontRef>
-        </p:style>
-        <p:txBody>
-          <a:bodyPr rtlCol="0" anchor="ctr"/>
-          <a:lstStyle/>
-          <a:p>
-            <a:pPr algn="ctr">
-              <a:defRPr sz="850" b="1">
-                <a:solidFill>
-                  <a:srgbClr val="F5F3EF"/>
-                </a:solidFill>
-                <a:latin typeface="IBM Plex Mono"/>
-              </a:defRPr>
-            </a:pPr>
-            <a:r>
-              <a:t>CODE</a:t>
-            </a:r>
-          </a:p>
-        </p:txBody>
-      </p:sp>
-      <p:sp>
-        <p:nvSpPr>
-          <p:cNvPr id="17" name="TextBox 16"/>
-          <p:cNvSpPr txBox="1"/>
-          <p:nvPr/>
-        </p:nvSpPr>
-        <p:spPr>
-          <a:xfrm>
-            <a:off x="5971032" y="2423160"/>
-            <a:ext cx="219456" cy="365760"/>
-          </a:xfrm>
-          <a:prstGeom prst="rect">
-            <a:avLst/>
-          </a:prstGeom>
-          <a:noFill/>
-        </p:spPr>
-        <p:txBody>
-          <a:bodyPr wrap="none">
-            <a:spAutoFit/>
-          </a:bodyPr>
-          <a:lstStyle/>
-          <a:p>
-            <a:pPr algn="ctr">
-              <a:defRPr sz="1400" b="1">
-                <a:solidFill>
-                  <a:srgbClr val="00D1A7"/>
-                </a:solidFill>
-                <a:latin typeface="IBM Plex Mono"/>
-              </a:defRPr>
-            </a:pPr>
-            <a:r>
-              <a:t>→</a:t>
-            </a:r>
-          </a:p>
-        </p:txBody>
-      </p:sp>
-      <p:sp>
-        <p:nvSpPr>
-          <p:cNvPr id="18" name="Rectangle 17"/>
-          <p:cNvSpPr/>
-          <p:nvPr/>
-        </p:nvSpPr>
-        <p:spPr>
-          <a:xfrm>
-            <a:off x="6190488" y="2057400"/>
-            <a:ext cx="1600200" cy="1234440"/>
-          </a:xfrm>
-          <a:prstGeom prst="rect">
-            <a:avLst/>
-          </a:prstGeom>
-          <a:solidFill>
-            <a:srgbClr val="172621"/>
-          </a:solidFill>
-          <a:ln w="12700">
-            <a:solidFill>
-              <a:srgbClr val="223830"/>
-            </a:solidFill>
-          </a:ln>
-        </p:spPr>
-        <p:style>
-          <a:lnRef idx="1">
-            <a:schemeClr val="accent1"/>
-          </a:lnRef>
-          <a:fillRef idx="3">
-            <a:schemeClr val="accent1"/>
-          </a:fillRef>
-          <a:effectRef idx="2">
-            <a:schemeClr val="accent1"/>
-          </a:effectRef>
-          <a:fontRef idx="minor">
-            <a:schemeClr val="lt1"/>
-          </a:fontRef>
-        </p:style>
-        <p:txBody>
-          <a:bodyPr rtlCol="0" anchor="ctr" wrap="square"/>
-          <a:lstStyle/>
-          <a:p>
-            <a:pPr algn="ctr">
-              <a:defRPr sz="900">
-                <a:solidFill>
-                  <a:srgbClr val="6C8279"/>
-                </a:solidFill>
-                <a:latin typeface="IBM Plex Mono"/>
-              </a:defRPr>
-            </a:pPr>
-            <a:r>
-              <a:t>04 AUDIT</a:t>
-            </a:r>
-          </a:p>
-          <a:p>
-            <a:pPr>
-              <a:defRPr sz="1300" b="1">
-                <a:solidFill>
-                  <a:srgbClr val="F5F3EF"/>
-                </a:solidFill>
-                <a:latin typeface="Inter"/>
-              </a:defRPr>
-            </a:pPr>
-            <a:r>
-              <a:t>Audit</a:t>
-            </a:r>
-          </a:p>
-          <a:p>
-            <a:pPr>
-              <a:defRPr sz="900">
-                <a:solidFill>
-                  <a:srgbClr val="A3B8B0"/>
-                </a:solidFill>
-                <a:latin typeface="Inter"/>
-              </a:defRPr>
-            </a:pPr>
-            <a:r>
-              <a:t>Adversarial critic</a:t>
-            </a:r>
-          </a:p>
-        </p:txBody>
-      </p:sp>
-      <p:sp>
-        <p:nvSpPr>
-          <p:cNvPr id="19" name="Rectangle 18"/>
-          <p:cNvSpPr/>
-          <p:nvPr/>
-        </p:nvSpPr>
-        <p:spPr>
-          <a:xfrm>
-            <a:off x="6190488" y="2057400"/>
-            <a:ext cx="1600200" cy="36576"/>
-          </a:xfrm>
-          <a:prstGeom prst="rect">
-            <a:avLst/>
-          </a:prstGeom>
-          <a:solidFill>
-            <a:srgbClr val="00D1A7"/>
-          </a:solidFill>
-          <a:ln>
-            <a:noFill/>
-          </a:ln>
-        </p:spPr>
-        <p:style>
-          <a:lnRef idx="1">
-            <a:schemeClr val="accent1"/>
-          </a:lnRef>
-          <a:fillRef idx="3">
-            <a:schemeClr val="accent1"/>
-          </a:fillRef>
-          <a:effectRef idx="2">
-            <a:schemeClr val="accent1"/>
-          </a:effectRef>
-          <a:fontRef idx="minor">
-            <a:schemeClr val="lt1"/>
-          </a:fontRef>
-        </p:style>
-        <p:txBody>
-          <a:bodyPr rtlCol="0" anchor="ctr"/>
-          <a:lstStyle/>
-          <a:p>
-            <a:pPr algn="ctr"/>
-          </a:p>
-        </p:txBody>
-      </p:sp>
-      <p:sp>
-        <p:nvSpPr>
-          <p:cNvPr id="20" name="Rectangle 19"/>
-          <p:cNvSpPr/>
-          <p:nvPr/>
-        </p:nvSpPr>
-        <p:spPr>
-          <a:xfrm>
-            <a:off x="6281928" y="2926080"/>
-            <a:ext cx="1417320" cy="237744"/>
-          </a:xfrm>
-          <a:prstGeom prst="rect">
-            <a:avLst/>
-          </a:prstGeom>
-          <a:solidFill>
-            <a:srgbClr val="00382B"/>
-          </a:solidFill>
-          <a:ln>
-            <a:noFill/>
-          </a:ln>
-        </p:spPr>
-        <p:style>
-          <a:lnRef idx="1">
-            <a:schemeClr val="accent1"/>
-          </a:lnRef>
-          <a:fillRef idx="3">
-            <a:schemeClr val="accent1"/>
-          </a:fillRef>
-          <a:effectRef idx="2">
-            <a:schemeClr val="accent1"/>
-          </a:effectRef>
-          <a:fontRef idx="minor">
-            <a:schemeClr val="lt1"/>
-          </a:fontRef>
-        </p:style>
-        <p:txBody>
-          <a:bodyPr rtlCol="0" anchor="ctr"/>
-          <a:lstStyle/>
-          <a:p>
-            <a:pPr algn="ctr">
-              <a:defRPr sz="850" b="1">
-                <a:solidFill>
-                  <a:srgbClr val="00D1A7"/>
-                </a:solidFill>
-                <a:latin typeface="IBM Plex Mono"/>
-              </a:defRPr>
-            </a:pPr>
-            <a:r>
-              <a:t>MODEL</a:t>
-            </a:r>
-          </a:p>
-        </p:txBody>
-      </p:sp>
-      <p:sp>
-        <p:nvSpPr>
-          <p:cNvPr id="21" name="TextBox 20"/>
-          <p:cNvSpPr txBox="1"/>
-          <p:nvPr/>
-        </p:nvSpPr>
-        <p:spPr>
-          <a:xfrm>
-            <a:off x="7790688" y="2423160"/>
-            <a:ext cx="219456" cy="365760"/>
-          </a:xfrm>
-          <a:prstGeom prst="rect">
-            <a:avLst/>
-          </a:prstGeom>
-          <a:noFill/>
-        </p:spPr>
-        <p:txBody>
-          <a:bodyPr wrap="none">
-            <a:spAutoFit/>
-          </a:bodyPr>
-          <a:lstStyle/>
-          <a:p>
-            <a:pPr algn="ctr">
-              <a:defRPr sz="1400" b="1">
-                <a:solidFill>
-                  <a:srgbClr val="00D1A7"/>
-                </a:solidFill>
-                <a:latin typeface="IBM Plex Mono"/>
-              </a:defRPr>
-            </a:pPr>
-            <a:r>
-              <a:t>→</a:t>
-            </a:r>
-          </a:p>
-        </p:txBody>
-      </p:sp>
-      <p:sp>
-        <p:nvSpPr>
-          <p:cNvPr id="22" name="Rectangle 21"/>
-          <p:cNvSpPr/>
-          <p:nvPr/>
-        </p:nvSpPr>
-        <p:spPr>
-          <a:xfrm>
-            <a:off x="8010144" y="2057400"/>
-            <a:ext cx="1600200" cy="1234440"/>
-          </a:xfrm>
-          <a:prstGeom prst="rect">
-            <a:avLst/>
-          </a:prstGeom>
-          <a:solidFill>
-            <a:srgbClr val="172621"/>
-          </a:solidFill>
-          <a:ln w="12700">
-            <a:solidFill>
-              <a:srgbClr val="223830"/>
-            </a:solidFill>
-          </a:ln>
-        </p:spPr>
-        <p:style>
-          <a:lnRef idx="1">
-            <a:schemeClr val="accent1"/>
-          </a:lnRef>
-          <a:fillRef idx="3">
-            <a:schemeClr val="accent1"/>
-          </a:fillRef>
-          <a:effectRef idx="2">
-            <a:schemeClr val="accent1"/>
-          </a:effectRef>
-          <a:fontRef idx="minor">
-            <a:schemeClr val="lt1"/>
-          </a:fontRef>
-        </p:style>
-        <p:txBody>
-          <a:bodyPr rtlCol="0" anchor="ctr" wrap="square"/>
-          <a:lstStyle/>
-          <a:p>
-            <a:pPr algn="ctr">
-              <a:defRPr sz="900">
-                <a:solidFill>
-                  <a:srgbClr val="6C8279"/>
-                </a:solidFill>
-                <a:latin typeface="IBM Plex Mono"/>
-              </a:defRPr>
-            </a:pPr>
-            <a:r>
-              <a:t>05 AUTHORIZE</a:t>
-            </a:r>
-          </a:p>
-          <a:p>
-            <a:pPr>
-              <a:defRPr sz="1300" b="1">
-                <a:solidFill>
-                  <a:srgbClr val="F5F3EF"/>
-                </a:solidFill>
-                <a:latin typeface="Inter"/>
-              </a:defRPr>
-            </a:pPr>
-            <a:r>
-              <a:t>Authorize</a:t>
-            </a:r>
-          </a:p>
-          <a:p>
-            <a:pPr>
-              <a:defRPr sz="900">
-                <a:solidFill>
-                  <a:srgbClr val="A3B8B0"/>
-                </a:solidFill>
-                <a:latin typeface="Inter"/>
-              </a:defRPr>
-            </a:pPr>
-            <a:r>
-              <a:t>Fail-closed gate</a:t>
-            </a:r>
-          </a:p>
-        </p:txBody>
-      </p:sp>
-      <p:sp>
-        <p:nvSpPr>
-          <p:cNvPr id="23" name="Rectangle 22"/>
-          <p:cNvSpPr/>
-          <p:nvPr/>
-        </p:nvSpPr>
-        <p:spPr>
-          <a:xfrm>
-            <a:off x="8010144" y="2057400"/>
-            <a:ext cx="1600200" cy="36576"/>
+            <a:off x="8302752" y="1965960"/>
+            <a:ext cx="3157423" cy="36576"/>
           </a:xfrm>
           <a:prstGeom prst="rect">
             <a:avLst/>
@@ -7576,280 +6863,14 @@
       </p:sp>
       <p:sp>
         <p:nvSpPr>
-          <p:cNvPr id="24" name="Rectangle 23"/>
+          <p:cNvPr id="12" name="Rectangle 11"/>
           <p:cNvSpPr/>
           <p:nvPr/>
         </p:nvSpPr>
         <p:spPr>
           <a:xfrm>
-            <a:off x="8101584" y="2926080"/>
-            <a:ext cx="1417320" cy="237744"/>
-          </a:xfrm>
-          <a:prstGeom prst="rect">
-            <a:avLst/>
-          </a:prstGeom>
-          <a:solidFill>
-            <a:srgbClr val="45260A"/>
-          </a:solidFill>
-          <a:ln>
-            <a:noFill/>
-          </a:ln>
-        </p:spPr>
-        <p:style>
-          <a:lnRef idx="1">
-            <a:schemeClr val="accent1"/>
-          </a:lnRef>
-          <a:fillRef idx="3">
-            <a:schemeClr val="accent1"/>
-          </a:fillRef>
-          <a:effectRef idx="2">
-            <a:schemeClr val="accent1"/>
-          </a:effectRef>
-          <a:fontRef idx="minor">
-            <a:schemeClr val="lt1"/>
-          </a:fontRef>
-        </p:style>
-        <p:txBody>
-          <a:bodyPr rtlCol="0" anchor="ctr"/>
-          <a:lstStyle/>
-          <a:p>
-            <a:pPr algn="ctr">
-              <a:defRPr sz="850" b="1">
-                <a:solidFill>
-                  <a:srgbClr val="FBBF24"/>
-                </a:solidFill>
-                <a:latin typeface="IBM Plex Mono"/>
-              </a:defRPr>
-            </a:pPr>
-            <a:r>
-              <a:t>HUMAN</a:t>
-            </a:r>
-          </a:p>
-        </p:txBody>
-      </p:sp>
-      <p:sp>
-        <p:nvSpPr>
-          <p:cNvPr id="25" name="TextBox 24"/>
-          <p:cNvSpPr txBox="1"/>
-          <p:nvPr/>
-        </p:nvSpPr>
-        <p:spPr>
-          <a:xfrm>
-            <a:off x="9610344" y="2423160"/>
-            <a:ext cx="219456" cy="365760"/>
-          </a:xfrm>
-          <a:prstGeom prst="rect">
-            <a:avLst/>
-          </a:prstGeom>
-          <a:noFill/>
-        </p:spPr>
-        <p:txBody>
-          <a:bodyPr wrap="none">
-            <a:spAutoFit/>
-          </a:bodyPr>
-          <a:lstStyle/>
-          <a:p>
-            <a:pPr algn="ctr">
-              <a:defRPr sz="1400" b="1">
-                <a:solidFill>
-                  <a:srgbClr val="00D1A7"/>
-                </a:solidFill>
-                <a:latin typeface="IBM Plex Mono"/>
-              </a:defRPr>
-            </a:pPr>
-            <a:r>
-              <a:t>→</a:t>
-            </a:r>
-          </a:p>
-        </p:txBody>
-      </p:sp>
-      <p:sp>
-        <p:nvSpPr>
-          <p:cNvPr id="26" name="Rectangle 25"/>
-          <p:cNvSpPr/>
-          <p:nvPr/>
-        </p:nvSpPr>
-        <p:spPr>
-          <a:xfrm>
-            <a:off x="9829800" y="2057400"/>
-            <a:ext cx="1600200" cy="1234440"/>
-          </a:xfrm>
-          <a:prstGeom prst="rect">
-            <a:avLst/>
-          </a:prstGeom>
-          <a:solidFill>
-            <a:srgbClr val="172621"/>
-          </a:solidFill>
-          <a:ln w="12700">
-            <a:solidFill>
-              <a:srgbClr val="223830"/>
-            </a:solidFill>
-          </a:ln>
-        </p:spPr>
-        <p:style>
-          <a:lnRef idx="1">
-            <a:schemeClr val="accent1"/>
-          </a:lnRef>
-          <a:fillRef idx="3">
-            <a:schemeClr val="accent1"/>
-          </a:fillRef>
-          <a:effectRef idx="2">
-            <a:schemeClr val="accent1"/>
-          </a:effectRef>
-          <a:fontRef idx="minor">
-            <a:schemeClr val="lt1"/>
-          </a:fontRef>
-        </p:style>
-        <p:txBody>
-          <a:bodyPr rtlCol="0" anchor="ctr" wrap="square"/>
-          <a:lstStyle/>
-          <a:p>
-            <a:pPr algn="ctr">
-              <a:defRPr sz="900">
-                <a:solidFill>
-                  <a:srgbClr val="6C8279"/>
-                </a:solidFill>
-                <a:latin typeface="IBM Plex Mono"/>
-              </a:defRPr>
-            </a:pPr>
-            <a:r>
-              <a:t>06 RECORD</a:t>
-            </a:r>
-          </a:p>
-          <a:p>
-            <a:pPr>
-              <a:defRPr sz="1300" b="1">
-                <a:solidFill>
-                  <a:srgbClr val="F5F3EF"/>
-                </a:solidFill>
-                <a:latin typeface="Inter"/>
-              </a:defRPr>
-            </a:pPr>
-            <a:r>
-              <a:t>Record</a:t>
-            </a:r>
-          </a:p>
-          <a:p>
-            <a:pPr>
-              <a:defRPr sz="900">
-                <a:solidFill>
-                  <a:srgbClr val="A3B8B0"/>
-                </a:solidFill>
-                <a:latin typeface="Inter"/>
-              </a:defRPr>
-            </a:pPr>
-            <a:r>
-              <a:t>Audit trace log</a:t>
-            </a:r>
-          </a:p>
-        </p:txBody>
-      </p:sp>
-      <p:sp>
-        <p:nvSpPr>
-          <p:cNvPr id="27" name="Rectangle 26"/>
-          <p:cNvSpPr/>
-          <p:nvPr/>
-        </p:nvSpPr>
-        <p:spPr>
-          <a:xfrm>
-            <a:off x="9829800" y="2057400"/>
-            <a:ext cx="1600200" cy="36576"/>
-          </a:xfrm>
-          <a:prstGeom prst="rect">
-            <a:avLst/>
-          </a:prstGeom>
-          <a:solidFill>
-            <a:srgbClr val="F5F3EF"/>
-          </a:solidFill>
-          <a:ln>
-            <a:noFill/>
-          </a:ln>
-        </p:spPr>
-        <p:style>
-          <a:lnRef idx="1">
-            <a:schemeClr val="accent1"/>
-          </a:lnRef>
-          <a:fillRef idx="3">
-            <a:schemeClr val="accent1"/>
-          </a:fillRef>
-          <a:effectRef idx="2">
-            <a:schemeClr val="accent1"/>
-          </a:effectRef>
-          <a:fontRef idx="minor">
-            <a:schemeClr val="lt1"/>
-          </a:fontRef>
-        </p:style>
-        <p:txBody>
-          <a:bodyPr rtlCol="0" anchor="ctr"/>
-          <a:lstStyle/>
-          <a:p>
-            <a:pPr algn="ctr"/>
-          </a:p>
-        </p:txBody>
-      </p:sp>
-      <p:sp>
-        <p:nvSpPr>
-          <p:cNvPr id="28" name="Rectangle 27"/>
-          <p:cNvSpPr/>
-          <p:nvPr/>
-        </p:nvSpPr>
-        <p:spPr>
-          <a:xfrm>
-            <a:off x="9921240" y="2926080"/>
-            <a:ext cx="1417320" cy="237744"/>
-          </a:xfrm>
-          <a:prstGeom prst="rect">
-            <a:avLst/>
-          </a:prstGeom>
-          <a:solidFill>
-            <a:srgbClr val="263831"/>
-          </a:solidFill>
-          <a:ln>
-            <a:noFill/>
-          </a:ln>
-        </p:spPr>
-        <p:style>
-          <a:lnRef idx="1">
-            <a:schemeClr val="accent1"/>
-          </a:lnRef>
-          <a:fillRef idx="3">
-            <a:schemeClr val="accent1"/>
-          </a:fillRef>
-          <a:effectRef idx="2">
-            <a:schemeClr val="accent1"/>
-          </a:effectRef>
-          <a:fontRef idx="minor">
-            <a:schemeClr val="lt1"/>
-          </a:fontRef>
-        </p:style>
-        <p:txBody>
-          <a:bodyPr rtlCol="0" anchor="ctr"/>
-          <a:lstStyle/>
-          <a:p>
-            <a:pPr algn="ctr">
-              <a:defRPr sz="850" b="1">
-                <a:solidFill>
-                  <a:srgbClr val="F5F3EF"/>
-                </a:solidFill>
-                <a:latin typeface="IBM Plex Mono"/>
-              </a:defRPr>
-            </a:pPr>
-            <a:r>
-              <a:t>CODE</a:t>
-            </a:r>
-          </a:p>
-        </p:txBody>
-      </p:sp>
-      <p:sp>
-        <p:nvSpPr>
-          <p:cNvPr id="29" name="Rectangle 28"/>
-          <p:cNvSpPr/>
-          <p:nvPr/>
-        </p:nvSpPr>
-        <p:spPr>
-          <a:xfrm>
-            <a:off x="731520" y="3474720"/>
-            <a:ext cx="6492240" cy="1554480"/>
+            <a:off x="731520" y="3429000"/>
+            <a:ext cx="10728655" cy="1874519"/>
           </a:xfrm>
           <a:prstGeom prst="rect">
             <a:avLst/>
@@ -7882,7 +6903,7 @@
           <a:lstStyle/>
           <a:p>
             <a:pPr algn="ctr">
-              <a:defRPr sz="1000" b="1">
+              <a:defRPr sz="1100" b="1">
                 <a:solidFill>
                   <a:srgbClr val="93C5FD"/>
                 </a:solidFill>
@@ -7890,57 +6911,31 @@
               </a:defRPr>
             </a:pPr>
             <a:r>
-              <a:t>CASE C · DYNAMIC STATEFUL CLARIFICATION LOOP</a:t>
-            </a:r>
-          </a:p>
-          <a:p>
-            <a:pPr>
-              <a:defRPr sz="1100" b="1">
-                <a:solidFill>
-                  <a:srgbClr val="F5F3EF"/>
-                </a:solidFill>
-                <a:latin typeface="Inter"/>
-              </a:defRPr>
-            </a:pPr>
-            <a:r>
-              <a:t>Dark Frames → ask_for_evidence() → WAITING_FOR_EVIDENCE → Customer Uploads → Resume Case</a:t>
-            </a:r>
-          </a:p>
-          <a:p>
-            <a:pPr>
-              <a:defRPr sz="950">
-                <a:solidFill>
-                  <a:srgbClr val="A3B8B0"/>
-                </a:solidFill>
-                <a:latin typeface="Inter"/>
-              </a:defRPr>
-            </a:pPr>
-            <a:r>
-              <a:t>Agentic State Machine: When lighting is insufficient, the agent halts standard execution, prompts a targeted checklist, pauses state in WAITING_FOR_EVIDENCE, and seamlessly resumes context upon media receipt (1 retry limit protects customer experience).</a:t>
-            </a:r>
-          </a:p>
-        </p:txBody>
-      </p:sp>
-      <p:sp>
-        <p:nvSpPr>
-          <p:cNvPr id="30" name="Rectangle 29"/>
+              <a:t>HERO AGENTIC INTERACTION: DYNAMIC STATEFUL CLARIFICATION LOOP (CASE C)</a:t>
+            </a:r>
+          </a:p>
+        </p:txBody>
+      </p:sp>
+      <p:sp>
+        <p:nvSpPr>
+          <p:cNvPr id="13" name="Rectangle 12"/>
           <p:cNvSpPr/>
           <p:nvPr/>
         </p:nvSpPr>
         <p:spPr>
           <a:xfrm>
-            <a:off x="7436815" y="3474720"/>
-            <a:ext cx="4023360" cy="1554480"/>
+            <a:off x="914400" y="3904488"/>
+            <a:ext cx="1536192" cy="502920"/>
           </a:xfrm>
           <a:prstGeom prst="rect">
             <a:avLst/>
           </a:prstGeom>
           <a:solidFill>
-            <a:srgbClr val="14221D"/>
+            <a:srgbClr val="1F302A"/>
           </a:solidFill>
-          <a:ln w="19050">
+          <a:ln w="12700">
             <a:solidFill>
-              <a:srgbClr val="059669"/>
+              <a:srgbClr val="223830"/>
             </a:solidFill>
           </a:ln>
         </p:spPr>
@@ -7963,59 +6958,520 @@
           <a:lstStyle/>
           <a:p>
             <a:pPr algn="ctr">
-              <a:defRPr sz="1000" b="1">
-                <a:solidFill>
-                  <a:srgbClr val="00D1A7"/>
+              <a:defRPr sz="850" b="1">
+                <a:solidFill>
+                  <a:srgbClr val="F5F3EF"/>
                 </a:solidFill>
                 <a:latin typeface="IBM Plex Mono"/>
               </a:defRPr>
             </a:pPr>
             <a:r>
-              <a:t>SECONDARY PS-04 ROUTE · ORDER STATUS FAST PATH</a:t>
-            </a:r>
-          </a:p>
+              <a:t>Dark Frames (brightness 28)</a:t>
+            </a:r>
+          </a:p>
+        </p:txBody>
+      </p:sp>
+      <p:sp>
+        <p:nvSpPr>
+          <p:cNvPr id="14" name="TextBox 13"/>
+          <p:cNvSpPr txBox="1"/>
+          <p:nvPr/>
+        </p:nvSpPr>
+        <p:spPr>
+          <a:xfrm>
+            <a:off x="2450592" y="3977640"/>
+            <a:ext cx="256032" cy="365760"/>
+          </a:xfrm>
+          <a:prstGeom prst="rect">
+            <a:avLst/>
+          </a:prstGeom>
+          <a:noFill/>
+        </p:spPr>
+        <p:txBody>
+          <a:bodyPr wrap="none">
+            <a:spAutoFit/>
+          </a:bodyPr>
+          <a:lstStyle/>
+          <a:p>
+            <a:pPr algn="ctr">
+              <a:defRPr sz="1300" b="1">
+                <a:solidFill>
+                  <a:srgbClr val="93C5FD"/>
+                </a:solidFill>
+                <a:latin typeface="IBM Plex Mono"/>
+              </a:defRPr>
+            </a:pPr>
+            <a:r>
+              <a:t>→</a:t>
+            </a:r>
+          </a:p>
+        </p:txBody>
+      </p:sp>
+      <p:sp>
+        <p:nvSpPr>
+          <p:cNvPr id="15" name="Rectangle 14"/>
+          <p:cNvSpPr/>
+          <p:nvPr/>
+        </p:nvSpPr>
+        <p:spPr>
+          <a:xfrm>
+            <a:off x="2706624" y="3904488"/>
+            <a:ext cx="1536192" cy="502920"/>
+          </a:xfrm>
+          <a:prstGeom prst="rect">
+            <a:avLst/>
+          </a:prstGeom>
+          <a:solidFill>
+            <a:srgbClr val="1F302A"/>
+          </a:solidFill>
+          <a:ln w="12700">
+            <a:solidFill>
+              <a:srgbClr val="223830"/>
+            </a:solidFill>
+          </a:ln>
+        </p:spPr>
+        <p:style>
+          <a:lnRef idx="1">
+            <a:schemeClr val="accent1"/>
+          </a:lnRef>
+          <a:fillRef idx="3">
+            <a:schemeClr val="accent1"/>
+          </a:fillRef>
+          <a:effectRef idx="2">
+            <a:schemeClr val="accent1"/>
+          </a:effectRef>
+          <a:fontRef idx="minor">
+            <a:schemeClr val="lt1"/>
+          </a:fontRef>
+        </p:style>
+        <p:txBody>
+          <a:bodyPr rtlCol="0" anchor="ctr" wrap="square"/>
+          <a:lstStyle/>
+          <a:p>
+            <a:pPr algn="ctr">
+              <a:defRPr sz="850" b="1">
+                <a:solidFill>
+                  <a:srgbClr val="F5F3EF"/>
+                </a:solidFill>
+                <a:latin typeface="IBM Plex Mono"/>
+              </a:defRPr>
+            </a:pPr>
+            <a:r>
+              <a:t>ask_for_evidence()</a:t>
+            </a:r>
+          </a:p>
+        </p:txBody>
+      </p:sp>
+      <p:sp>
+        <p:nvSpPr>
+          <p:cNvPr id="16" name="TextBox 15"/>
+          <p:cNvSpPr txBox="1"/>
+          <p:nvPr/>
+        </p:nvSpPr>
+        <p:spPr>
+          <a:xfrm>
+            <a:off x="4242816" y="3977640"/>
+            <a:ext cx="256032" cy="365760"/>
+          </a:xfrm>
+          <a:prstGeom prst="rect">
+            <a:avLst/>
+          </a:prstGeom>
+          <a:noFill/>
+        </p:spPr>
+        <p:txBody>
+          <a:bodyPr wrap="none">
+            <a:spAutoFit/>
+          </a:bodyPr>
+          <a:lstStyle/>
+          <a:p>
+            <a:pPr algn="ctr">
+              <a:defRPr sz="1300" b="1">
+                <a:solidFill>
+                  <a:srgbClr val="93C5FD"/>
+                </a:solidFill>
+                <a:latin typeface="IBM Plex Mono"/>
+              </a:defRPr>
+            </a:pPr>
+            <a:r>
+              <a:t>→</a:t>
+            </a:r>
+          </a:p>
+        </p:txBody>
+      </p:sp>
+      <p:sp>
+        <p:nvSpPr>
+          <p:cNvPr id="17" name="Rectangle 16"/>
+          <p:cNvSpPr/>
+          <p:nvPr/>
+        </p:nvSpPr>
+        <p:spPr>
+          <a:xfrm>
+            <a:off x="4498848" y="3904488"/>
+            <a:ext cx="1536192" cy="502920"/>
+          </a:xfrm>
+          <a:prstGeom prst="rect">
+            <a:avLst/>
+          </a:prstGeom>
+          <a:solidFill>
+            <a:srgbClr val="1E3A8A"/>
+          </a:solidFill>
+          <a:ln w="15240">
+            <a:solidFill>
+              <a:srgbClr val="60A5FA"/>
+            </a:solidFill>
+          </a:ln>
+        </p:spPr>
+        <p:style>
+          <a:lnRef idx="1">
+            <a:schemeClr val="accent1"/>
+          </a:lnRef>
+          <a:fillRef idx="3">
+            <a:schemeClr val="accent1"/>
+          </a:fillRef>
+          <a:effectRef idx="2">
+            <a:schemeClr val="accent1"/>
+          </a:effectRef>
+          <a:fontRef idx="minor">
+            <a:schemeClr val="lt1"/>
+          </a:fontRef>
+        </p:style>
+        <p:txBody>
+          <a:bodyPr rtlCol="0" anchor="ctr" wrap="square"/>
+          <a:lstStyle/>
+          <a:p>
+            <a:pPr algn="ctr">
+              <a:defRPr sz="850" b="1">
+                <a:solidFill>
+                  <a:srgbClr val="DBEAFE"/>
+                </a:solidFill>
+                <a:latin typeface="IBM Plex Mono"/>
+              </a:defRPr>
+            </a:pPr>
+            <a:r>
+              <a:t>WAITING_FOR_EVIDENCE</a:t>
+            </a:r>
+          </a:p>
+        </p:txBody>
+      </p:sp>
+      <p:sp>
+        <p:nvSpPr>
+          <p:cNvPr id="18" name="TextBox 17"/>
+          <p:cNvSpPr txBox="1"/>
+          <p:nvPr/>
+        </p:nvSpPr>
+        <p:spPr>
+          <a:xfrm>
+            <a:off x="6035040" y="3977640"/>
+            <a:ext cx="256032" cy="365760"/>
+          </a:xfrm>
+          <a:prstGeom prst="rect">
+            <a:avLst/>
+          </a:prstGeom>
+          <a:noFill/>
+        </p:spPr>
+        <p:txBody>
+          <a:bodyPr wrap="none">
+            <a:spAutoFit/>
+          </a:bodyPr>
+          <a:lstStyle/>
+          <a:p>
+            <a:pPr algn="ctr">
+              <a:defRPr sz="1300" b="1">
+                <a:solidFill>
+                  <a:srgbClr val="93C5FD"/>
+                </a:solidFill>
+                <a:latin typeface="IBM Plex Mono"/>
+              </a:defRPr>
+            </a:pPr>
+            <a:r>
+              <a:t>→</a:t>
+            </a:r>
+          </a:p>
+        </p:txBody>
+      </p:sp>
+      <p:sp>
+        <p:nvSpPr>
+          <p:cNvPr id="19" name="Rectangle 18"/>
+          <p:cNvSpPr/>
+          <p:nvPr/>
+        </p:nvSpPr>
+        <p:spPr>
+          <a:xfrm>
+            <a:off x="6291072" y="3904488"/>
+            <a:ext cx="1536192" cy="502920"/>
+          </a:xfrm>
+          <a:prstGeom prst="rect">
+            <a:avLst/>
+          </a:prstGeom>
+          <a:solidFill>
+            <a:srgbClr val="1F302A"/>
+          </a:solidFill>
+          <a:ln w="12700">
+            <a:solidFill>
+              <a:srgbClr val="223830"/>
+            </a:solidFill>
+          </a:ln>
+        </p:spPr>
+        <p:style>
+          <a:lnRef idx="1">
+            <a:schemeClr val="accent1"/>
+          </a:lnRef>
+          <a:fillRef idx="3">
+            <a:schemeClr val="accent1"/>
+          </a:fillRef>
+          <a:effectRef idx="2">
+            <a:schemeClr val="accent1"/>
+          </a:effectRef>
+          <a:fontRef idx="minor">
+            <a:schemeClr val="lt1"/>
+          </a:fontRef>
+        </p:style>
+        <p:txBody>
+          <a:bodyPr rtlCol="0" anchor="ctr" wrap="square"/>
+          <a:lstStyle/>
+          <a:p>
+            <a:pPr algn="ctr">
+              <a:defRPr sz="850" b="1">
+                <a:solidFill>
+                  <a:srgbClr val="F5F3EF"/>
+                </a:solidFill>
+                <a:latin typeface="IBM Plex Mono"/>
+              </a:defRPr>
+            </a:pPr>
+            <a:r>
+              <a:t>Customer Uploads</a:t>
+            </a:r>
+          </a:p>
+        </p:txBody>
+      </p:sp>
+      <p:sp>
+        <p:nvSpPr>
+          <p:cNvPr id="20" name="TextBox 19"/>
+          <p:cNvSpPr txBox="1"/>
+          <p:nvPr/>
+        </p:nvSpPr>
+        <p:spPr>
+          <a:xfrm>
+            <a:off x="7827264" y="3977640"/>
+            <a:ext cx="256032" cy="365760"/>
+          </a:xfrm>
+          <a:prstGeom prst="rect">
+            <a:avLst/>
+          </a:prstGeom>
+          <a:noFill/>
+        </p:spPr>
+        <p:txBody>
+          <a:bodyPr wrap="none">
+            <a:spAutoFit/>
+          </a:bodyPr>
+          <a:lstStyle/>
+          <a:p>
+            <a:pPr algn="ctr">
+              <a:defRPr sz="1300" b="1">
+                <a:solidFill>
+                  <a:srgbClr val="93C5FD"/>
+                </a:solidFill>
+                <a:latin typeface="IBM Plex Mono"/>
+              </a:defRPr>
+            </a:pPr>
+            <a:r>
+              <a:t>→</a:t>
+            </a:r>
+          </a:p>
+        </p:txBody>
+      </p:sp>
+      <p:sp>
+        <p:nvSpPr>
+          <p:cNvPr id="21" name="Rectangle 20"/>
+          <p:cNvSpPr/>
+          <p:nvPr/>
+        </p:nvSpPr>
+        <p:spPr>
+          <a:xfrm>
+            <a:off x="8083296" y="3904488"/>
+            <a:ext cx="1536192" cy="502920"/>
+          </a:xfrm>
+          <a:prstGeom prst="rect">
+            <a:avLst/>
+          </a:prstGeom>
+          <a:solidFill>
+            <a:srgbClr val="1E3A8A"/>
+          </a:solidFill>
+          <a:ln w="15240">
+            <a:solidFill>
+              <a:srgbClr val="60A5FA"/>
+            </a:solidFill>
+          </a:ln>
+        </p:spPr>
+        <p:style>
+          <a:lnRef idx="1">
+            <a:schemeClr val="accent1"/>
+          </a:lnRef>
+          <a:fillRef idx="3">
+            <a:schemeClr val="accent1"/>
+          </a:fillRef>
+          <a:effectRef idx="2">
+            <a:schemeClr val="accent1"/>
+          </a:effectRef>
+          <a:fontRef idx="minor">
+            <a:schemeClr val="lt1"/>
+          </a:fontRef>
+        </p:style>
+        <p:txBody>
+          <a:bodyPr rtlCol="0" anchor="ctr" wrap="square"/>
+          <a:lstStyle/>
+          <a:p>
+            <a:pPr algn="ctr">
+              <a:defRPr sz="850" b="1">
+                <a:solidFill>
+                  <a:srgbClr val="DBEAFE"/>
+                </a:solidFill>
+                <a:latin typeface="IBM Plex Mono"/>
+              </a:defRPr>
+            </a:pPr>
+            <a:r>
+              <a:t>RESUME CASE</a:t>
+            </a:r>
+          </a:p>
+        </p:txBody>
+      </p:sp>
+      <p:sp>
+        <p:nvSpPr>
+          <p:cNvPr id="22" name="TextBox 21"/>
+          <p:cNvSpPr txBox="1"/>
+          <p:nvPr/>
+        </p:nvSpPr>
+        <p:spPr>
+          <a:xfrm>
+            <a:off x="9619488" y="3977640"/>
+            <a:ext cx="256032" cy="365760"/>
+          </a:xfrm>
+          <a:prstGeom prst="rect">
+            <a:avLst/>
+          </a:prstGeom>
+          <a:noFill/>
+        </p:spPr>
+        <p:txBody>
+          <a:bodyPr wrap="none">
+            <a:spAutoFit/>
+          </a:bodyPr>
+          <a:lstStyle/>
+          <a:p>
+            <a:pPr algn="ctr">
+              <a:defRPr sz="1300" b="1">
+                <a:solidFill>
+                  <a:srgbClr val="93C5FD"/>
+                </a:solidFill>
+                <a:latin typeface="IBM Plex Mono"/>
+              </a:defRPr>
+            </a:pPr>
+            <a:r>
+              <a:t>→</a:t>
+            </a:r>
+          </a:p>
+        </p:txBody>
+      </p:sp>
+      <p:sp>
+        <p:nvSpPr>
+          <p:cNvPr id="23" name="Rectangle 22"/>
+          <p:cNvSpPr/>
+          <p:nvPr/>
+        </p:nvSpPr>
+        <p:spPr>
+          <a:xfrm>
+            <a:off x="9875520" y="3904488"/>
+            <a:ext cx="1536192" cy="502920"/>
+          </a:xfrm>
+          <a:prstGeom prst="rect">
+            <a:avLst/>
+          </a:prstGeom>
+          <a:solidFill>
+            <a:srgbClr val="1F302A"/>
+          </a:solidFill>
+          <a:ln w="12700">
+            <a:solidFill>
+              <a:srgbClr val="223830"/>
+            </a:solidFill>
+          </a:ln>
+        </p:spPr>
+        <p:style>
+          <a:lnRef idx="1">
+            <a:schemeClr val="accent1"/>
+          </a:lnRef>
+          <a:fillRef idx="3">
+            <a:schemeClr val="accent1"/>
+          </a:fillRef>
+          <a:effectRef idx="2">
+            <a:schemeClr val="accent1"/>
+          </a:effectRef>
+          <a:fontRef idx="minor">
+            <a:schemeClr val="lt1"/>
+          </a:fontRef>
+        </p:style>
+        <p:txBody>
+          <a:bodyPr rtlCol="0" anchor="ctr" wrap="square"/>
+          <a:lstStyle/>
+          <a:p>
+            <a:pPr algn="ctr">
+              <a:defRPr sz="850" b="1">
+                <a:solidFill>
+                  <a:srgbClr val="F5F3EF"/>
+                </a:solidFill>
+                <a:latin typeface="IBM Plex Mono"/>
+              </a:defRPr>
+            </a:pPr>
+            <a:r>
+              <a:t>Seller Review</a:t>
+            </a:r>
+          </a:p>
+        </p:txBody>
+      </p:sp>
+      <p:sp>
+        <p:nvSpPr>
+          <p:cNvPr id="24" name="TextBox 23"/>
+          <p:cNvSpPr txBox="1"/>
+          <p:nvPr/>
+        </p:nvSpPr>
+        <p:spPr>
+          <a:xfrm>
+            <a:off x="914400" y="4572000"/>
+            <a:ext cx="10362895" cy="640080"/>
+          </a:xfrm>
+          <a:prstGeom prst="rect">
+            <a:avLst/>
+          </a:prstGeom>
+          <a:noFill/>
+        </p:spPr>
+        <p:txBody>
+          <a:bodyPr wrap="square">
+            <a:spAutoFit/>
+          </a:bodyPr>
+          <a:lstStyle/>
           <a:p>
             <a:pPr>
-              <a:defRPr sz="1100" b="1">
-                <a:solidFill>
-                  <a:srgbClr val="F5F3EF"/>
+              <a:defRPr sz="1050">
+                <a:solidFill>
+                  <a:srgbClr val="A3B8B0"/>
                 </a:solidFill>
                 <a:latin typeface="Inter"/>
               </a:defRPr>
             </a:pPr>
             <a:r>
-              <a:t>“Where is my order?” → Direct Mock Store &amp; Courier Scan</a:t>
-            </a:r>
-          </a:p>
-          <a:p>
-            <a:pPr>
-              <a:defRPr sz="950">
-                <a:solidFill>
-                  <a:srgbClr val="A3B8B0"/>
-                </a:solidFill>
-                <a:latin typeface="Inter"/>
-              </a:defRPr>
-            </a:pPr>
-            <a:r>
-              <a:t>Instant delivery timestamp &amp; scan (Zero-vision overhead)</a:t>
-            </a:r>
-            <a:br/>
-            <a:r>
-              <a:t>Routine order queries take a direct tool route without calling heavy multimodal models. Escalates to human seller only if courier scan shows abnormal transit delay.</a:t>
-            </a:r>
-          </a:p>
-        </p:txBody>
-      </p:sp>
-      <p:sp>
-        <p:nvSpPr>
-          <p:cNvPr id="31" name="Rectangle 30"/>
+              <a:t>Why an agent? When video quality is insufficient, ReturnLens halts execution, issues a targeted re-film checklist, serializes case state into WAITING_FOR_EVIDENCE, and automatically resumes the exact case upon upload (1 retry limit prevents customer lock-out).</a:t>
+            </a:r>
+          </a:p>
+        </p:txBody>
+      </p:sp>
+      <p:sp>
+        <p:nvSpPr>
+          <p:cNvPr id="25" name="Rectangle 24"/>
           <p:cNvSpPr/>
           <p:nvPr/>
         </p:nvSpPr>
         <p:spPr>
           <a:xfrm>
-            <a:off x="731520" y="5212080"/>
-            <a:ext cx="10728655" cy="960120"/>
+            <a:off x="731520" y="5486400"/>
+            <a:ext cx="10728655" cy="658368"/>
           </a:xfrm>
           <a:prstGeom prst="rect">
             <a:avLst/>
@@ -8048,15 +7504,15 @@
           <a:lstStyle/>
           <a:p>
             <a:pPr algn="ctr">
-              <a:defRPr sz="900">
-                <a:solidFill>
-                  <a:srgbClr val="A3B8B0"/>
+              <a:defRPr sz="900" b="1">
+                <a:solidFill>
+                  <a:srgbClr val="34D399"/>
                 </a:solidFill>
                 <a:latin typeface="IBM Plex Mono"/>
               </a:defRPr>
             </a:pPr>
             <a:r>
-              <a:t>■ Model Calls: 3 base LLM calls per triage case (Planner, Vision, Critic) plus retries.   |   ■ Deterministic Policy: Rules P-01 to P-08 executed in pure Python code, never prompts.</a:t>
+              <a:t>SECONDARY PS-04 ROUTE: Query store &amp; courier tracking for "Where is my order?" without calling multimodal vision models.</a:t>
             </a:r>
           </a:p>
           <a:p>
@@ -8069,14 +7525,14 @@
               </a:defRPr>
             </a:pPr>
             <a:r>
-              <a:t>■ Critic Duty: Independent prompt audits cited frames; notes correlated vision limits.   |   ■ Safety Ceiling: Backend checks block payment tools; 1-click human authorization strictly enforced.</a:t>
-            </a:r>
-          </a:p>
-        </p:txBody>
-      </p:sp>
-      <p:sp>
-        <p:nvSpPr>
-          <p:cNvPr id="32" name="Rectangle 31"/>
+              <a:t>SYSTEM OUTPUT: Immutable JSON Audit Trail recorded at every state transition</a:t>
+            </a:r>
+          </a:p>
+        </p:txBody>
+      </p:sp>
+      <p:sp>
+        <p:nvSpPr>
+          <p:cNvPr id="26" name="Rectangle 25"/>
           <p:cNvSpPr/>
           <p:nvPr/>
         </p:nvSpPr>
@@ -8119,7 +7575,7 @@
       </p:sp>
       <p:sp>
         <p:nvSpPr>
-          <p:cNvPr id="33" name="TextBox 32"/>
+          <p:cNvPr id="27" name="TextBox 26"/>
           <p:cNvSpPr txBox="1"/>
           <p:nvPr/>
         </p:nvSpPr>
@@ -8155,7 +7611,7 @@
       </p:sp>
       <p:sp>
         <p:nvSpPr>
-          <p:cNvPr id="34" name="TextBox 33"/>
+          <p:cNvPr id="28" name="TextBox 27"/>
           <p:cNvSpPr txBox="1"/>
           <p:nvPr/>
         </p:nvSpPr>
@@ -8259,7 +7715,7 @@
         <p:spPr>
           <a:xfrm>
             <a:off x="731520" y="502920"/>
-            <a:ext cx="7315200" cy="365760"/>
+            <a:ext cx="7315200" cy="320040"/>
           </a:xfrm>
           <a:prstGeom prst="rect">
             <a:avLst/>
@@ -8281,7 +7737,7 @@
               </a:defRPr>
             </a:pPr>
             <a:r>
-              <a:t>DEMO SCENARIOS · CONTROLLED PROTOTYPE BEHAVIORS</a:t>
+              <a:t>DEMO SCENARIOS · BEHAVIORAL MATRIX</a:t>
             </a:r>
           </a:p>
         </p:txBody>
@@ -8294,8 +7750,8 @@
         </p:nvSpPr>
         <p:spPr>
           <a:xfrm>
-            <a:off x="731520" y="868680"/>
-            <a:ext cx="10698480" cy="685800"/>
+            <a:off x="731520" y="822960"/>
+            <a:ext cx="10728655" cy="594360"/>
           </a:xfrm>
           <a:prstGeom prst="rect">
             <a:avLst/>
@@ -8317,7 +7773,7 @@
               </a:defRPr>
             </a:pPr>
             <a:r>
-              <a:t>Four evidence conditions. Four controlled actions.</a:t>
+              <a:t>Different evidence. Different action.</a:t>
             </a:r>
           </a:p>
         </p:txBody>
@@ -8330,8 +7786,8 @@
         </p:nvSpPr>
         <p:spPr>
           <a:xfrm>
-            <a:off x="731520" y="1508760"/>
-            <a:ext cx="10698480" cy="411480"/>
+            <a:off x="731520" y="1417320"/>
+            <a:ext cx="10728655" cy="411480"/>
           </a:xfrm>
           <a:prstGeom prst="rect">
             <a:avLst/>
@@ -8345,7 +7801,7 @@
           <a:lstStyle/>
           <a:p>
             <a:pPr>
-              <a:defRPr sz="1800">
+              <a:defRPr sz="1900">
                 <a:solidFill>
                   <a:srgbClr val="596E64"/>
                 </a:solidFill>
@@ -8353,7 +7809,7 @@
               </a:defRPr>
             </a:pPr>
             <a:r>
-              <a:t>Expected prototype behaviors across staged benchmark cases. Not measured production metrics.</a:t>
+              <a:t>Predictable, controlled prototype responses across four distinct evidence conditions.</a:t>
             </a:r>
           </a:p>
         </p:txBody>
@@ -8367,7 +7823,7 @@
         <p:spPr>
           <a:xfrm>
             <a:off x="731520" y="2057400"/>
-            <a:ext cx="10728655" cy="932688"/>
+            <a:ext cx="10728655" cy="868680"/>
           </a:xfrm>
           <a:prstGeom prst="rect">
             <a:avLst/>
@@ -8411,8 +7867,8 @@
         </p:nvSpPr>
         <p:spPr>
           <a:xfrm>
-            <a:off x="914400" y="2258568"/>
-            <a:ext cx="2011680" cy="502920"/>
+            <a:off x="914400" y="2276856"/>
+            <a:ext cx="1920240" cy="429768"/>
           </a:xfrm>
           <a:prstGeom prst="rect">
             <a:avLst/>
@@ -8443,7 +7899,7 @@
           <a:lstStyle/>
           <a:p>
             <a:pPr algn="ctr">
-              <a:defRPr sz="1000" b="1">
+              <a:defRPr sz="1050" b="1">
                 <a:solidFill>
                   <a:srgbClr val="006B55"/>
                 </a:solidFill>
@@ -8451,20 +7907,7 @@
               </a:defRPr>
             </a:pPr>
             <a:r>
-              <a:t>CASE 01 · CONSISTENT</a:t>
-            </a:r>
-          </a:p>
-          <a:p>
-            <a:pPr algn="ctr">
-              <a:defRPr sz="900">
-                <a:solidFill>
-                  <a:srgbClr val="006B55"/>
-                </a:solidFill>
-                <a:latin typeface="Inter"/>
-              </a:defRPr>
-            </a:pPr>
-            <a:r>
-              <a:t>Clear Defect</a:t>
+              <a:t>01 · CONSISTENT</a:t>
             </a:r>
           </a:p>
         </p:txBody>
@@ -8477,8 +7920,8 @@
         </p:nvSpPr>
         <p:spPr>
           <a:xfrm>
-            <a:off x="3063240" y="2167128"/>
-            <a:ext cx="3566160" cy="731520"/>
+            <a:off x="2971800" y="2167128"/>
+            <a:ext cx="3749039" cy="640080"/>
           </a:xfrm>
           <a:prstGeom prst="rect">
             <a:avLst/>
@@ -8500,7 +7943,7 @@
               </a:defRPr>
             </a:pPr>
             <a:r>
-              <a:t>Staged casing crack verified in unboxing frame 00:04 · Manifest &amp; return window match.</a:t>
+              <a:t>Evidence Supported · Manifest matches, packaging tag present, cosmetic defect observed</a:t>
             </a:r>
           </a:p>
         </p:txBody>
@@ -8513,7 +7956,7 @@
         </p:nvSpPr>
         <p:spPr>
           <a:xfrm>
-            <a:off x="6720840" y="2276856"/>
+            <a:off x="6812280" y="2258568"/>
             <a:ext cx="274320" cy="457200"/>
           </a:xfrm>
           <a:prstGeom prst="rect">
@@ -8549,8 +7992,8 @@
         </p:nvSpPr>
         <p:spPr>
           <a:xfrm>
-            <a:off x="7086600" y="2167128"/>
-            <a:ext cx="4206240" cy="731520"/>
+            <a:off x="7178040" y="2167128"/>
+            <a:ext cx="4114800" cy="640080"/>
           </a:xfrm>
           <a:prstGeom prst="rect">
             <a:avLst/>
@@ -8564,7 +8007,7 @@
           <a:lstStyle/>
           <a:p>
             <a:pPr>
-              <a:defRPr sz="1050" b="1">
+              <a:defRPr sz="1100" b="1">
                 <a:solidFill>
                   <a:srgbClr val="006B55"/>
                 </a:solidFill>
@@ -8585,7 +8028,7 @@
               </a:defRPr>
             </a:pPr>
             <a:r>
-              <a:t>Agent prepares mock shipping label &amp; drafts refund in pending_return_receipt. Money releases only upon warehouse receipt.</a:t>
+              <a:t>Drafts mock shipping label and refund draft in pending_return_receipt. Money releases only on physical receipt.</a:t>
             </a:r>
           </a:p>
         </p:txBody>
@@ -8598,8 +8041,8 @@
         </p:nvSpPr>
         <p:spPr>
           <a:xfrm>
-            <a:off x="731520" y="3099816"/>
-            <a:ext cx="10728655" cy="932688"/>
+            <a:off x="731520" y="3035808"/>
+            <a:ext cx="10728655" cy="868680"/>
           </a:xfrm>
           <a:prstGeom prst="rect">
             <a:avLst/>
@@ -8643,8 +8086,8 @@
         </p:nvSpPr>
         <p:spPr>
           <a:xfrm>
-            <a:off x="914400" y="3300984"/>
-            <a:ext cx="2011680" cy="502920"/>
+            <a:off x="914400" y="3255264"/>
+            <a:ext cx="1920240" cy="429768"/>
           </a:xfrm>
           <a:prstGeom prst="rect">
             <a:avLst/>
@@ -8675,7 +8118,7 @@
           <a:lstStyle/>
           <a:p>
             <a:pPr algn="ctr">
-              <a:defRPr sz="1000" b="1">
+              <a:defRPr sz="1050" b="1">
                 <a:solidFill>
                   <a:srgbClr val="991B1B"/>
                 </a:solidFill>
@@ -8683,20 +8126,7 @@
               </a:defRPr>
             </a:pPr>
             <a:r>
-              <a:t>CASE 02 · CONTRADICTION</a:t>
-            </a:r>
-          </a:p>
-          <a:p>
-            <a:pPr algn="ctr">
-              <a:defRPr sz="900">
-                <a:solidFill>
-                  <a:srgbClr val="991B1B"/>
-                </a:solidFill>
-                <a:latin typeface="Inter"/>
-              </a:defRPr>
-            </a:pPr>
-            <a:r>
-              <a:t>Color Mismatch</a:t>
+              <a:t>02 · CONTRADICTION</a:t>
             </a:r>
           </a:p>
         </p:txBody>
@@ -8709,8 +8139,8 @@
         </p:nvSpPr>
         <p:spPr>
           <a:xfrm>
-            <a:off x="3063240" y="3209544"/>
-            <a:ext cx="3566160" cy="731520"/>
+            <a:off x="2971800" y="3145536"/>
+            <a:ext cx="3749039" cy="640080"/>
           </a:xfrm>
           <a:prstGeom prst="rect">
             <a:avLst/>
@@ -8732,7 +8162,7 @@
               </a:defRPr>
             </a:pPr>
             <a:r>
-              <a:t>White ordered (HEAD-WHT-02) vs Black unboxed in Frame 00:07 · Exact SKU unverified.</a:t>
+              <a:t>Ordered White, Observed Black · HEAD-WHT-02 ordered vs Frame 00:07 Black item</a:t>
             </a:r>
           </a:p>
         </p:txBody>
@@ -8745,7 +8175,7 @@
         </p:nvSpPr>
         <p:spPr>
           <a:xfrm>
-            <a:off x="6720840" y="3319272"/>
+            <a:off x="6812280" y="3236976"/>
             <a:ext cx="274320" cy="457200"/>
           </a:xfrm>
           <a:prstGeom prst="rect">
@@ -8781,8 +8211,8 @@
         </p:nvSpPr>
         <p:spPr>
           <a:xfrm>
-            <a:off x="7086600" y="3209544"/>
-            <a:ext cx="4206240" cy="731520"/>
+            <a:off x="7178040" y="3145536"/>
+            <a:ext cx="4114800" cy="640080"/>
           </a:xfrm>
           <a:prstGeom prst="rect">
             <a:avLst/>
@@ -8796,7 +8226,7 @@
           <a:lstStyle/>
           <a:p>
             <a:pPr>
-              <a:defRPr sz="1050" b="1">
+              <a:defRPr sz="1100" b="1">
                 <a:solidFill>
                   <a:srgbClr val="991B1B"/>
                 </a:solidFill>
@@ -8817,7 +8247,7 @@
               </a:defRPr>
             </a:pPr>
             <a:r>
-              <a:t>Policy P-03 blocks automation. Inhibits label and refund. Seller selects 1 of 3 concrete resolution options.</a:t>
+              <a:t>Policy P-03 blocks automation. Inhibits label and refund. Seller selects: mis-shipment / box label / warehouse inspection.</a:t>
             </a:r>
           </a:p>
         </p:txBody>
@@ -8830,8 +8260,8 @@
         </p:nvSpPr>
         <p:spPr>
           <a:xfrm>
-            <a:off x="731520" y="4142232"/>
-            <a:ext cx="10728655" cy="932688"/>
+            <a:off x="731520" y="4014216"/>
+            <a:ext cx="10728655" cy="868680"/>
           </a:xfrm>
           <a:prstGeom prst="rect">
             <a:avLst/>
@@ -8875,8 +8305,8 @@
         </p:nvSpPr>
         <p:spPr>
           <a:xfrm>
-            <a:off x="914400" y="4343400"/>
-            <a:ext cx="2011680" cy="502920"/>
+            <a:off x="914400" y="4233672"/>
+            <a:ext cx="1920240" cy="429768"/>
           </a:xfrm>
           <a:prstGeom prst="rect">
             <a:avLst/>
@@ -8907,7 +8337,7 @@
           <a:lstStyle/>
           <a:p>
             <a:pPr algn="ctr">
-              <a:defRPr sz="1000" b="1">
+              <a:defRPr sz="1050" b="1">
                 <a:solidFill>
                   <a:srgbClr val="1E40AF"/>
                 </a:solidFill>
@@ -8915,20 +8345,7 @@
               </a:defRPr>
             </a:pPr>
             <a:r>
-              <a:t>CASE 03 · UNCLEAR</a:t>
-            </a:r>
-          </a:p>
-          <a:p>
-            <a:pPr algn="ctr">
-              <a:defRPr sz="900">
-                <a:solidFill>
-                  <a:srgbClr val="1E40AF"/>
-                </a:solidFill>
-                <a:latin typeface="Inter"/>
-              </a:defRPr>
-            </a:pPr>
-            <a:r>
-              <a:t>Low Lighting</a:t>
+              <a:t>03 · UNCLEAR</a:t>
             </a:r>
           </a:p>
         </p:txBody>
@@ -8941,8 +8358,8 @@
         </p:nvSpPr>
         <p:spPr>
           <a:xfrm>
-            <a:off x="3063240" y="4251960"/>
-            <a:ext cx="3566160" cy="731520"/>
+            <a:off x="2971800" y="4123944"/>
+            <a:ext cx="3749039" cy="640080"/>
           </a:xfrm>
           <a:prstGeom prst="rect">
             <a:avLst/>
@@ -8964,7 +8381,7 @@
               </a:defRPr>
             </a:pPr>
             <a:r>
-              <a:t>4-second dark video, brightness 28/255, barcode obscured · Insufficient visual evidence.</a:t>
+              <a:t>Dark or Unreadable Evidence · 4s low-light video (brightness 28/255), barcode obscured</a:t>
             </a:r>
           </a:p>
         </p:txBody>
@@ -8977,7 +8394,7 @@
         </p:nvSpPr>
         <p:spPr>
           <a:xfrm>
-            <a:off x="6720840" y="4361688"/>
+            <a:off x="6812280" y="4215384"/>
             <a:ext cx="274320" cy="457200"/>
           </a:xfrm>
           <a:prstGeom prst="rect">
@@ -9013,8 +8430,8 @@
         </p:nvSpPr>
         <p:spPr>
           <a:xfrm>
-            <a:off x="7086600" y="4251960"/>
-            <a:ext cx="4206240" cy="731520"/>
+            <a:off x="7178040" y="4123944"/>
+            <a:ext cx="4114800" cy="640080"/>
           </a:xfrm>
           <a:prstGeom prst="rect">
             <a:avLst/>
@@ -9028,7 +8445,7 @@
           <a:lstStyle/>
           <a:p>
             <a:pPr>
-              <a:defRPr sz="1050" b="1">
+              <a:defRPr sz="1100" b="1">
                 <a:solidFill>
                   <a:srgbClr val="1E40AF"/>
                 </a:solidFill>
@@ -9049,7 +8466,7 @@
               </a:defRPr>
             </a:pPr>
             <a:r>
-              <a:t>Agent calls ask_for_evidence(); transitions ticket to WAITING_FOR_EVIDENCE; resumes context on upload (1 retry limit).</a:t>
+              <a:t>Calls ask_for_evidence(); transitions to WAITING_FOR_EVIDENCE; resumes context on upload (1 retry limit).</a:t>
             </a:r>
           </a:p>
         </p:txBody>
@@ -9062,8 +8479,8 @@
         </p:nvSpPr>
         <p:spPr>
           <a:xfrm>
-            <a:off x="731520" y="5184648"/>
-            <a:ext cx="10728655" cy="932688"/>
+            <a:off x="731520" y="4992624"/>
+            <a:ext cx="10728655" cy="868680"/>
           </a:xfrm>
           <a:prstGeom prst="rect">
             <a:avLst/>
@@ -9107,8 +8524,8 @@
         </p:nvSpPr>
         <p:spPr>
           <a:xfrm>
-            <a:off x="914400" y="5385816"/>
-            <a:ext cx="2011680" cy="502920"/>
+            <a:off x="914400" y="5212080"/>
+            <a:ext cx="1920240" cy="429768"/>
           </a:xfrm>
           <a:prstGeom prst="rect">
             <a:avLst/>
@@ -9139,7 +8556,7 @@
           <a:lstStyle/>
           <a:p>
             <a:pPr algn="ctr">
-              <a:defRPr sz="1000" b="1">
+              <a:defRPr sz="1050" b="1">
                 <a:solidFill>
                   <a:srgbClr val="065F46"/>
                 </a:solidFill>
@@ -9147,20 +8564,7 @@
               </a:defRPr>
             </a:pPr>
             <a:r>
-              <a:t>CASE 04 · SEQUENCE</a:t>
-            </a:r>
-          </a:p>
-          <a:p>
-            <a:pPr algn="ctr">
-              <a:defRPr sz="900">
-                <a:solidFill>
-                  <a:srgbClr val="065F46"/>
-                </a:solidFill>
-                <a:latin typeface="Inter"/>
-              </a:defRPr>
-            </a:pPr>
-            <a:r>
-              <a:t>Continuity Check</a:t>
+              <a:t>04 · SEQUENCE</a:t>
             </a:r>
           </a:p>
         </p:txBody>
@@ -9173,8 +8577,8 @@
         </p:nvSpPr>
         <p:spPr>
           <a:xfrm>
-            <a:off x="3063240" y="5294376"/>
-            <a:ext cx="3566160" cy="731520"/>
+            <a:off x="2971800" y="5102352"/>
+            <a:ext cx="3749039" cy="640080"/>
           </a:xfrm>
           <a:prstGeom prst="rect">
             <a:avLst/>
@@ -9196,7 +8600,7 @@
               </a:defRPr>
             </a:pPr>
             <a:r>
-              <a:t>Staged continuous take from sealed parcel opening to product reveal · Sequence inspected.</a:t>
+              <a:t>Continuity Uncertain · Staged take from sealed parcel opening to product reveal</a:t>
             </a:r>
           </a:p>
         </p:txBody>
@@ -9209,7 +8613,7 @@
         </p:nvSpPr>
         <p:spPr>
           <a:xfrm>
-            <a:off x="6720840" y="5404104"/>
+            <a:off x="6812280" y="5193792"/>
             <a:ext cx="274320" cy="457200"/>
           </a:xfrm>
           <a:prstGeom prst="rect">
@@ -9245,8 +8649,8 @@
         </p:nvSpPr>
         <p:spPr>
           <a:xfrm>
-            <a:off x="7086600" y="5294376"/>
-            <a:ext cx="4206240" cy="731520"/>
+            <a:off x="7178040" y="5102352"/>
+            <a:ext cx="4114800" cy="640080"/>
           </a:xfrm>
           <a:prstGeom prst="rect">
             <a:avLst/>
@@ -9260,7 +8664,7 @@
           <a:lstStyle/>
           <a:p>
             <a:pPr>
-              <a:defRPr sz="1050" b="1">
+              <a:defRPr sz="1100" b="1">
                 <a:solidFill>
                   <a:srgbClr val="065F46"/>
                 </a:solidFill>
@@ -9268,7 +8672,7 @@
               </a:defRPr>
             </a:pPr>
             <a:r>
-              <a:t>INSPECT CONTINUITY</a:t>
+              <a:t>INSPECT SEQUENCE CONTINUITY</a:t>
             </a:r>
           </a:p>
           <a:p>
@@ -9281,7 +8685,7 @@
               </a:defRPr>
             </a:pPr>
             <a:r>
-              <a:t>Expected prototype behavior: inspect sequence continuity and flag missing transitions for seller review.</a:t>
+              <a:t>Expected prototype behavior: inspects sequence continuity and flags cutaways for seller review.</a:t>
             </a:r>
           </a:p>
         </p:txBody>
@@ -9360,7 +8764,7 @@
               </a:defRPr>
             </a:pPr>
             <a:r>
-              <a:t>Staged prototype scenarios · Expected agent behaviors, not measured production metrics · Cap: min(₹4,999, remaining, paid)</a:t>
+              <a:t>Staged prototype scenarios · Expected agent behaviors, not measured production metrics</a:t>
             </a:r>
           </a:p>
         </p:txBody>
@@ -9471,7 +8875,7 @@
         <p:spPr>
           <a:xfrm>
             <a:off x="731520" y="502920"/>
-            <a:ext cx="7315200" cy="365760"/>
+            <a:ext cx="7315200" cy="320040"/>
           </a:xfrm>
           <a:prstGeom prst="rect">
             <a:avLst/>
@@ -9506,8 +8910,8 @@
         </p:nvSpPr>
         <p:spPr>
           <a:xfrm>
-            <a:off x="731520" y="868680"/>
-            <a:ext cx="10698480" cy="685800"/>
+            <a:off x="731520" y="822960"/>
+            <a:ext cx="10728655" cy="594360"/>
           </a:xfrm>
           <a:prstGeom prst="rect">
             <a:avLst/>
@@ -9542,8 +8946,8 @@
         </p:nvSpPr>
         <p:spPr>
           <a:xfrm>
-            <a:off x="731520" y="1508760"/>
-            <a:ext cx="10698480" cy="411480"/>
+            <a:off x="731520" y="1417320"/>
+            <a:ext cx="10728655" cy="411480"/>
           </a:xfrm>
           <a:prstGeom prst="rect">
             <a:avLst/>
@@ -9557,7 +8961,7 @@
           <a:lstStyle/>
           <a:p>
             <a:pPr>
-              <a:defRPr sz="1800">
+              <a:defRPr sz="1900">
                 <a:solidFill>
                   <a:srgbClr val="596E64"/>
                 </a:solidFill>
@@ -9565,7 +8969,7 @@
               </a:defRPr>
             </a:pPr>
             <a:r>
-              <a:t>Strict scope boundaries and single-threaded ownership make the prototype fully buildable in one day.</a:t>
+              <a:t>Strict scope boundaries and single-threaded ownership make the prototype buildable in one day.</a:t>
             </a:r>
           </a:p>
         </p:txBody>
@@ -9578,8 +8982,51 @@
         </p:nvSpPr>
         <p:spPr>
           <a:xfrm>
-            <a:off x="731520" y="2057400"/>
-            <a:ext cx="2560320" cy="1645920"/>
+            <a:off x="731520" y="2011680"/>
+            <a:ext cx="10728655" cy="36576"/>
+          </a:xfrm>
+          <a:prstGeom prst="rect">
+            <a:avLst/>
+          </a:prstGeom>
+          <a:solidFill>
+            <a:srgbClr val="006B55"/>
+          </a:solidFill>
+          <a:ln>
+            <a:noFill/>
+          </a:ln>
+        </p:spPr>
+        <p:style>
+          <a:lnRef idx="1">
+            <a:schemeClr val="accent1"/>
+          </a:lnRef>
+          <a:fillRef idx="3">
+            <a:schemeClr val="accent1"/>
+          </a:fillRef>
+          <a:effectRef idx="2">
+            <a:schemeClr val="accent1"/>
+          </a:effectRef>
+          <a:fontRef idx="minor">
+            <a:schemeClr val="lt1"/>
+          </a:fontRef>
+        </p:style>
+        <p:txBody>
+          <a:bodyPr rtlCol="0" anchor="ctr"/>
+          <a:lstStyle/>
+          <a:p>
+            <a:pPr algn="ctr"/>
+          </a:p>
+        </p:txBody>
+      </p:sp>
+      <p:sp>
+        <p:nvSpPr>
+          <p:cNvPr id="7" name="Rectangle 6"/>
+          <p:cNvSpPr/>
+          <p:nvPr/>
+        </p:nvSpPr>
+        <p:spPr>
+          <a:xfrm>
+            <a:off x="731520" y="2048256"/>
+            <a:ext cx="2560320" cy="1700784"/>
           </a:xfrm>
           <a:prstGeom prst="rect">
             <a:avLst/>
@@ -9620,7 +9067,7 @@
               </a:defRPr>
             </a:pPr>
             <a:r>
-              <a:t>00h – 06h · FOUNDATION</a:t>
+              <a:t>00–06h · FOUNDATION</a:t>
             </a:r>
           </a:p>
           <a:p>
@@ -9659,51 +9106,8 @@
               </a:defRPr>
             </a:pPr>
             <a:r>
-              <a:t>LangGraph state machine, mock Shopify/Shippo fixtures, order status route, state serialization.</a:t>
-            </a:r>
-          </a:p>
-        </p:txBody>
-      </p:sp>
-      <p:sp>
-        <p:nvSpPr>
-          <p:cNvPr id="7" name="Rectangle 6"/>
-          <p:cNvSpPr/>
-          <p:nvPr/>
-        </p:nvSpPr>
-        <p:spPr>
-          <a:xfrm>
-            <a:off x="731520" y="2057400"/>
-            <a:ext cx="2560320" cy="36576"/>
-          </a:xfrm>
-          <a:prstGeom prst="rect">
-            <a:avLst/>
-          </a:prstGeom>
-          <a:solidFill>
-            <a:srgbClr val="006B55"/>
-          </a:solidFill>
-          <a:ln>
-            <a:noFill/>
-          </a:ln>
-        </p:spPr>
-        <p:style>
-          <a:lnRef idx="1">
-            <a:schemeClr val="accent1"/>
-          </a:lnRef>
-          <a:fillRef idx="3">
-            <a:schemeClr val="accent1"/>
-          </a:fillRef>
-          <a:effectRef idx="2">
-            <a:schemeClr val="accent1"/>
-          </a:effectRef>
-          <a:fontRef idx="minor">
-            <a:schemeClr val="lt1"/>
-          </a:fontRef>
-        </p:style>
-        <p:txBody>
-          <a:bodyPr rtlCol="0" anchor="ctr"/>
-          <a:lstStyle/>
-          <a:p>
-            <a:pPr algn="ctr"/>
+              <a:t>LangGraph state machine, mock store &amp; courier fixtures, order status route.</a:t>
+            </a:r>
           </a:p>
         </p:txBody>
       </p:sp>
@@ -9715,8 +9119,8 @@
         </p:nvSpPr>
         <p:spPr>
           <a:xfrm>
-            <a:off x="3447288" y="2057400"/>
-            <a:ext cx="2560320" cy="1645920"/>
+            <a:off x="3447288" y="2048256"/>
+            <a:ext cx="2560320" cy="1700784"/>
           </a:xfrm>
           <a:prstGeom prst="rect">
             <a:avLst/>
@@ -9757,7 +9161,7 @@
               </a:defRPr>
             </a:pPr>
             <a:r>
-              <a:t>06h – 12h · EVIDENCE</a:t>
+              <a:t>06–12h · EVIDENCE</a:t>
             </a:r>
           </a:p>
           <a:p>
@@ -9796,7 +9200,7 @@
               </a:defRPr>
             </a:pPr>
             <a:r>
-              <a:t>FFmpeg keyframe extraction, vision schema, deterministic rules P-01 to P-08, critic prompt.</a:t>
+              <a:t>FFmpeg keyframe indexer, vision prompt schema, rules P-01 to P-08, critic prompt.</a:t>
             </a:r>
           </a:p>
         </p:txBody>
@@ -9809,51 +9213,8 @@
         </p:nvSpPr>
         <p:spPr>
           <a:xfrm>
-            <a:off x="3447288" y="2057400"/>
-            <a:ext cx="2560320" cy="36576"/>
-          </a:xfrm>
-          <a:prstGeom prst="rect">
-            <a:avLst/>
-          </a:prstGeom>
-          <a:solidFill>
-            <a:srgbClr val="006B55"/>
-          </a:solidFill>
-          <a:ln>
-            <a:noFill/>
-          </a:ln>
-        </p:spPr>
-        <p:style>
-          <a:lnRef idx="1">
-            <a:schemeClr val="accent1"/>
-          </a:lnRef>
-          <a:fillRef idx="3">
-            <a:schemeClr val="accent1"/>
-          </a:fillRef>
-          <a:effectRef idx="2">
-            <a:schemeClr val="accent1"/>
-          </a:effectRef>
-          <a:fontRef idx="minor">
-            <a:schemeClr val="lt1"/>
-          </a:fontRef>
-        </p:style>
-        <p:txBody>
-          <a:bodyPr rtlCol="0" anchor="ctr"/>
-          <a:lstStyle/>
-          <a:p>
-            <a:pPr algn="ctr"/>
-          </a:p>
-        </p:txBody>
-      </p:sp>
-      <p:sp>
-        <p:nvSpPr>
-          <p:cNvPr id="10" name="Rectangle 9"/>
-          <p:cNvSpPr/>
-          <p:nvPr/>
-        </p:nvSpPr>
-        <p:spPr>
-          <a:xfrm>
-            <a:off x="6163056" y="2057400"/>
-            <a:ext cx="2560320" cy="1645920"/>
+            <a:off x="6163056" y="2048256"/>
+            <a:ext cx="2560320" cy="1700784"/>
           </a:xfrm>
           <a:prstGeom prst="rect">
             <a:avLst/>
@@ -9894,7 +9255,7 @@
               </a:defRPr>
             </a:pPr>
             <a:r>
-              <a:t>12h – 18h · INTEGRATION</a:t>
+              <a:t>12–18h · INTEGRATION</a:t>
             </a:r>
           </a:p>
           <a:p>
@@ -9920,7 +9281,7 @@
               </a:defRPr>
             </a:pPr>
             <a:r>
-              <a:t>Person C (Integration) with A/B</a:t>
+              <a:t>Person C (Integration with A/B)</a:t>
             </a:r>
           </a:p>
           <a:p>
@@ -9933,64 +9294,21 @@
               </a:defRPr>
             </a:pPr>
             <a:r>
-              <a:t>Clarification/resume loop, seller console UI, wiring 4 staged demo cases (A–D).</a:t>
-            </a:r>
-          </a:p>
-        </p:txBody>
-      </p:sp>
-      <p:sp>
-        <p:nvSpPr>
-          <p:cNvPr id="11" name="Rectangle 10"/>
+              <a:t>Clarification/resume loop, seller review console UI, wiring 4 staged demo cases.</a:t>
+            </a:r>
+          </a:p>
+        </p:txBody>
+      </p:sp>
+      <p:sp>
+        <p:nvSpPr>
+          <p:cNvPr id="10" name="Rectangle 9"/>
           <p:cNvSpPr/>
           <p:nvPr/>
         </p:nvSpPr>
         <p:spPr>
           <a:xfrm>
-            <a:off x="6163056" y="2057400"/>
-            <a:ext cx="2560320" cy="36576"/>
-          </a:xfrm>
-          <a:prstGeom prst="rect">
-            <a:avLst/>
-          </a:prstGeom>
-          <a:solidFill>
-            <a:srgbClr val="006B55"/>
-          </a:solidFill>
-          <a:ln>
-            <a:noFill/>
-          </a:ln>
-        </p:spPr>
-        <p:style>
-          <a:lnRef idx="1">
-            <a:schemeClr val="accent1"/>
-          </a:lnRef>
-          <a:fillRef idx="3">
-            <a:schemeClr val="accent1"/>
-          </a:fillRef>
-          <a:effectRef idx="2">
-            <a:schemeClr val="accent1"/>
-          </a:effectRef>
-          <a:fontRef idx="minor">
-            <a:schemeClr val="lt1"/>
-          </a:fontRef>
-        </p:style>
-        <p:txBody>
-          <a:bodyPr rtlCol="0" anchor="ctr"/>
-          <a:lstStyle/>
-          <a:p>
-            <a:pPr algn="ctr"/>
-          </a:p>
-        </p:txBody>
-      </p:sp>
-      <p:sp>
-        <p:nvSpPr>
-          <p:cNvPr id="12" name="Rectangle 11"/>
-          <p:cNvSpPr/>
-          <p:nvPr/>
-        </p:nvSpPr>
-        <p:spPr>
-          <a:xfrm>
-            <a:off x="8878824" y="2057400"/>
-            <a:ext cx="2560320" cy="1645920"/>
+            <a:off x="8878824" y="2048256"/>
+            <a:ext cx="2560320" cy="1700784"/>
           </a:xfrm>
           <a:prstGeom prst="rect">
             <a:avLst/>
@@ -10031,7 +9349,7 @@
               </a:defRPr>
             </a:pPr>
             <a:r>
-              <a:t>18h – 24h · VALIDATION</a:t>
+              <a:t>18–24h · VALIDATION</a:t>
             </a:r>
           </a:p>
           <a:p>
@@ -10070,64 +9388,21 @@
               </a:defRPr>
             </a:pPr>
             <a:r>
-              <a:t>Authorization boundary tests, edge cases, fallback validation, demo recording, README.</a:t>
-            </a:r>
-          </a:p>
-        </p:txBody>
-      </p:sp>
-      <p:sp>
-        <p:nvSpPr>
-          <p:cNvPr id="13" name="Rectangle 12"/>
+              <a:t>Authorization safety tests, edge cases, fallback validation, demo video recording.</a:t>
+            </a:r>
+          </a:p>
+        </p:txBody>
+      </p:sp>
+      <p:sp>
+        <p:nvSpPr>
+          <p:cNvPr id="11" name="Rectangle 10"/>
           <p:cNvSpPr/>
           <p:nvPr/>
         </p:nvSpPr>
         <p:spPr>
           <a:xfrm>
-            <a:off x="8878824" y="2057400"/>
-            <a:ext cx="2560320" cy="36576"/>
-          </a:xfrm>
-          <a:prstGeom prst="rect">
-            <a:avLst/>
-          </a:prstGeom>
-          <a:solidFill>
-            <a:srgbClr val="006B55"/>
-          </a:solidFill>
-          <a:ln>
-            <a:noFill/>
-          </a:ln>
-        </p:spPr>
-        <p:style>
-          <a:lnRef idx="1">
-            <a:schemeClr val="accent1"/>
-          </a:lnRef>
-          <a:fillRef idx="3">
-            <a:schemeClr val="accent1"/>
-          </a:fillRef>
-          <a:effectRef idx="2">
-            <a:schemeClr val="accent1"/>
-          </a:effectRef>
-          <a:fontRef idx="minor">
-            <a:schemeClr val="lt1"/>
-          </a:fontRef>
-        </p:style>
-        <p:txBody>
-          <a:bodyPr rtlCol="0" anchor="ctr"/>
-          <a:lstStyle/>
-          <a:p>
-            <a:pPr algn="ctr"/>
-          </a:p>
-        </p:txBody>
-      </p:sp>
-      <p:sp>
-        <p:nvSpPr>
-          <p:cNvPr id="14" name="Rectangle 13"/>
-          <p:cNvSpPr/>
-          <p:nvPr/>
-        </p:nvSpPr>
-        <p:spPr>
-          <a:xfrm>
-            <a:off x="731520" y="3886200"/>
-            <a:ext cx="5257800" cy="2240280"/>
+            <a:off x="731520" y="3977639"/>
+            <a:ext cx="5257800" cy="2103120"/>
           </a:xfrm>
           <a:prstGeom prst="rect">
             <a:avLst/>
@@ -10165,14 +9440,14 @@
       </p:sp>
       <p:sp>
         <p:nvSpPr>
-          <p:cNvPr id="15" name="Rectangle 14"/>
+          <p:cNvPr id="12" name="Rectangle 11"/>
           <p:cNvSpPr/>
           <p:nvPr/>
         </p:nvSpPr>
         <p:spPr>
           <a:xfrm>
-            <a:off x="731520" y="3886200"/>
-            <a:ext cx="73152" cy="2240280"/>
+            <a:off x="731520" y="3977639"/>
+            <a:ext cx="73152" cy="2103120"/>
           </a:xfrm>
           <a:prstGeom prst="rect">
             <a:avLst/>
@@ -10208,14 +9483,14 @@
       </p:sp>
       <p:sp>
         <p:nvSpPr>
-          <p:cNvPr id="16" name="TextBox 15"/>
+          <p:cNvPr id="13" name="TextBox 12"/>
           <p:cNvSpPr txBox="1"/>
           <p:nvPr/>
         </p:nvSpPr>
         <p:spPr>
           <a:xfrm>
-            <a:off x="960120" y="4023360"/>
-            <a:ext cx="4937760" cy="1965960"/>
+            <a:off x="960120" y="4087367"/>
+            <a:ext cx="4937760" cy="1883664"/>
           </a:xfrm>
           <a:prstGeom prst="rect">
             <a:avLst/>
@@ -10322,14 +9597,14 @@
       </p:sp>
       <p:sp>
         <p:nvSpPr>
-          <p:cNvPr id="17" name="Rectangle 16"/>
+          <p:cNvPr id="14" name="Rectangle 13"/>
           <p:cNvSpPr/>
           <p:nvPr/>
         </p:nvSpPr>
         <p:spPr>
           <a:xfrm>
-            <a:off x="6202375" y="3886200"/>
-            <a:ext cx="5257800" cy="2240280"/>
+            <a:off x="6202375" y="3977639"/>
+            <a:ext cx="5257800" cy="2103120"/>
           </a:xfrm>
           <a:prstGeom prst="rect">
             <a:avLst/>
@@ -10367,14 +9642,14 @@
       </p:sp>
       <p:sp>
         <p:nvSpPr>
-          <p:cNvPr id="18" name="Rectangle 17"/>
+          <p:cNvPr id="15" name="Rectangle 14"/>
           <p:cNvSpPr/>
           <p:nvPr/>
         </p:nvSpPr>
         <p:spPr>
           <a:xfrm>
-            <a:off x="6202375" y="3886200"/>
-            <a:ext cx="73152" cy="2240280"/>
+            <a:off x="6202375" y="3977639"/>
+            <a:ext cx="73152" cy="2103120"/>
           </a:xfrm>
           <a:prstGeom prst="rect">
             <a:avLst/>
@@ -10410,14 +9685,14 @@
       </p:sp>
       <p:sp>
         <p:nvSpPr>
-          <p:cNvPr id="19" name="TextBox 18"/>
+          <p:cNvPr id="16" name="TextBox 15"/>
           <p:cNvSpPr txBox="1"/>
           <p:nvPr/>
         </p:nvSpPr>
         <p:spPr>
           <a:xfrm>
-            <a:off x="6430975" y="4023360"/>
-            <a:ext cx="4937760" cy="1965960"/>
+            <a:off x="6430975" y="4087367"/>
+            <a:ext cx="4937760" cy="1883664"/>
           </a:xfrm>
           <a:prstGeom prst="rect">
             <a:avLst/>
@@ -10511,7 +9786,7 @@
       </p:sp>
       <p:sp>
         <p:nvSpPr>
-          <p:cNvPr id="20" name="Rectangle 19"/>
+          <p:cNvPr id="17" name="Rectangle 16"/>
           <p:cNvSpPr/>
           <p:nvPr/>
         </p:nvSpPr>
@@ -10554,7 +9829,7 @@
       </p:sp>
       <p:sp>
         <p:nvSpPr>
-          <p:cNvPr id="21" name="TextBox 20"/>
+          <p:cNvPr id="18" name="TextBox 17"/>
           <p:cNvSpPr txBox="1"/>
           <p:nvPr/>
         </p:nvSpPr>
@@ -10590,7 +9865,7 @@
       </p:sp>
       <p:sp>
         <p:nvSpPr>
-          <p:cNvPr id="22" name="TextBox 21"/>
+          <p:cNvPr id="19" name="TextBox 18"/>
           <p:cNvSpPr txBox="1"/>
           <p:nvPr/>
         </p:nvSpPr>

</xml_diff>

<commit_message>
feat(rescue): complete visual redesign, eliminate layout overflows, and recover presentation quality (#4)
</commit_message>
<xml_diff>
--- a/ReturnLens_v4.pptx
+++ b/ReturnLens_v4.pptx
@@ -512,22 +512,17 @@
           </a:p>
           <a:p>
             <a:r>
-              <a:t>- Track &amp; Fit: AgentX Hackathon 2026, Problem Statement PS-04 (Autonomous Support Agent for Online Sellers).</a:t>
-            </a:r>
-          </a:p>
-          <a:p>
-            <a:r>
-              <a:t>- Team: Team Rookie (3 members).</a:t>
-            </a:r>
-          </a:p>
-          <a:p>
-            <a:r>
-              <a:t>- Target User: Solo direct-to-consumer (D2C) online merchant managing customer support, shipping, and returns alone.</a:t>
-            </a:r>
-          </a:p>
-          <a:p>
-            <a:r>
-              <a:t>- Core Insight: Solo sellers lose 15–20 minutes per return navigating fragmented tabs (chat, Shopify, Shippo, return policy), making memory-based decisions without traceable proof.</a:t>
+              <a:t>- Problem Statement Fit: PS-04 (Autonomous Support Agent for Online Sellers).</a:t>
+            </a:r>
+          </a:p>
+          <a:p>
+            <a:r>
+              <a:t>- Target User: Solo direct-to-consumer (D2C) online merchants managing customer support, shipping, and returns alone.</a:t>
+            </a:r>
+          </a:p>
+          <a:p>
+            <a:r>
+              <a:t>- Core Friction: Solo sellers spend 15–20 minutes per return opening fragmented tabs (buyer chat, Shopify, Shippo tracking, store return policy). Return decisions are currently made from memory without unified evidence.</a:t>
             </a:r>
           </a:p>
           <a:p>
@@ -4159,8 +4154,8 @@
         </p:nvSpPr>
         <p:spPr>
           <a:xfrm>
-            <a:off x="731520" y="594360"/>
-            <a:ext cx="4114800" cy="365760"/>
+            <a:off x="731520" y="731520"/>
+            <a:ext cx="4023360" cy="365760"/>
           </a:xfrm>
           <a:prstGeom prst="rect">
             <a:avLst/>
@@ -4195,8 +4190,8 @@
         </p:nvSpPr>
         <p:spPr>
           <a:xfrm>
-            <a:off x="731520" y="1051560"/>
-            <a:ext cx="4114800" cy="1005840"/>
+            <a:off x="731520" y="1188720"/>
+            <a:ext cx="4023360" cy="914400"/>
           </a:xfrm>
           <a:prstGeom prst="rect">
             <a:avLst/>
@@ -4210,7 +4205,7 @@
           <a:lstStyle/>
           <a:p>
             <a:pPr>
-              <a:defRPr sz="5600" b="1">
+              <a:defRPr sz="5400" b="1">
                 <a:solidFill>
                   <a:srgbClr val="172621"/>
                 </a:solidFill>
@@ -4231,8 +4226,94 @@
         </p:nvSpPr>
         <p:spPr>
           <a:xfrm>
-            <a:off x="731520" y="2148840"/>
-            <a:ext cx="4114800" cy="777240"/>
+            <a:off x="731520" y="2194560"/>
+            <a:ext cx="4023360" cy="1005840"/>
+          </a:xfrm>
+          <a:prstGeom prst="rect">
+            <a:avLst/>
+          </a:prstGeom>
+          <a:noFill/>
+        </p:spPr>
+        <p:txBody>
+          <a:bodyPr wrap="square">
+            <a:spAutoFit/>
+          </a:bodyPr>
+          <a:lstStyle/>
+          <a:p>
+            <a:pPr>
+              <a:defRPr sz="2400" b="1">
+                <a:solidFill>
+                  <a:srgbClr val="172621"/>
+                </a:solidFill>
+                <a:latin typeface="Inter"/>
+              </a:defRPr>
+            </a:pPr>
+            <a:r>
+              <a:t>Every return decision, backed by evidence.</a:t>
+            </a:r>
+          </a:p>
+        </p:txBody>
+      </p:sp>
+      <p:sp>
+        <p:nvSpPr>
+          <p:cNvPr id="6" name="TextBox 5"/>
+          <p:cNvSpPr txBox="1"/>
+          <p:nvPr/>
+        </p:nvSpPr>
+        <p:spPr>
+          <a:xfrm>
+            <a:off x="731520" y="3291840"/>
+            <a:ext cx="4023360" cy="1645920"/>
+          </a:xfrm>
+          <a:prstGeom prst="rect">
+            <a:avLst/>
+          </a:prstGeom>
+          <a:noFill/>
+        </p:spPr>
+        <p:txBody>
+          <a:bodyPr wrap="square">
+            <a:spAutoFit/>
+          </a:bodyPr>
+          <a:lstStyle/>
+          <a:p>
+            <a:pPr>
+              <a:defRPr sz="1400">
+                <a:solidFill>
+                  <a:srgbClr val="596E64"/>
+                </a:solidFill>
+                <a:latin typeface="Inter"/>
+              </a:defRPr>
+            </a:pPr>
+            <a:r>
+              <a:t>Evidence-backed returns triage for independent online sellers.</a:t>
+            </a:r>
+          </a:p>
+          <a:p>
+            <a:br/>
+            <a:pPr>
+              <a:defRPr sz="1300">
+                <a:solidFill>
+                  <a:srgbClr val="596E64"/>
+                </a:solidFill>
+                <a:latin typeface="Inter"/>
+              </a:defRPr>
+            </a:pPr>
+            <a:r>
+              <a:t>When a customer submits an unboxing video, ReturnLens cross-references store truth, verifies deterministic code policies, and gives the solo seller a 1-click decision console.</a:t>
+            </a:r>
+          </a:p>
+        </p:txBody>
+      </p:sp>
+      <p:sp>
+        <p:nvSpPr>
+          <p:cNvPr id="7" name="TextBox 6"/>
+          <p:cNvSpPr txBox="1"/>
+          <p:nvPr/>
+        </p:nvSpPr>
+        <p:spPr>
+          <a:xfrm>
+            <a:off x="731520" y="5303520"/>
+            <a:ext cx="4023360" cy="457200"/>
           </a:xfrm>
           <a:prstGeom prst="rect">
             <a:avLst/>
@@ -4246,70 +4327,29 @@
           <a:lstStyle/>
           <a:p>
             <a:pPr>
-              <a:defRPr sz="2400" b="1">
-                <a:solidFill>
-                  <a:srgbClr val="172621"/>
-                </a:solidFill>
-                <a:latin typeface="Inter"/>
-              </a:defRPr>
-            </a:pPr>
-            <a:r>
-              <a:t>Every return decision, backed by evidence.</a:t>
-            </a:r>
-          </a:p>
-        </p:txBody>
-      </p:sp>
-      <p:sp>
-        <p:nvSpPr>
-          <p:cNvPr id="6" name="TextBox 5"/>
-          <p:cNvSpPr txBox="1"/>
-          <p:nvPr/>
-        </p:nvSpPr>
-        <p:spPr>
-          <a:xfrm>
-            <a:off x="731520" y="3017520"/>
-            <a:ext cx="4114800" cy="1097280"/>
-          </a:xfrm>
-          <a:prstGeom prst="rect">
-            <a:avLst/>
-          </a:prstGeom>
-          <a:noFill/>
-        </p:spPr>
-        <p:txBody>
-          <a:bodyPr wrap="none">
-            <a:spAutoFit/>
-          </a:bodyPr>
-          <a:lstStyle/>
-          <a:p>
-            <a:pPr>
-              <a:defRPr sz="1300">
-                <a:solidFill>
-                  <a:srgbClr val="596E64"/>
-                </a:solidFill>
-                <a:latin typeface="Inter"/>
-              </a:defRPr>
-            </a:pPr>
-            <a:r>
-              <a:t>Evidence-backed returns triage for independent online sellers.</a:t>
-            </a:r>
-            <a:br/>
-            <a:br/>
-            <a:r>
-              <a:t>When a buyer submits an unboxing video, ReturnLens links video keyframes to store truth and courier scans, evaluates deterministic policy rules, and presents a 1-click decision console to the solo merchant.</a:t>
-            </a:r>
-          </a:p>
-        </p:txBody>
-      </p:sp>
-      <p:sp>
-        <p:nvSpPr>
-          <p:cNvPr id="7" name="Rectangle 6"/>
+              <a:defRPr sz="1000" b="1">
+                <a:solidFill>
+                  <a:srgbClr val="7A8E85"/>
+                </a:solidFill>
+                <a:latin typeface="IBM Plex Mono"/>
+              </a:defRPr>
+            </a:pPr>
+            <a:r>
+              <a:t>Team Rookie (3 Members) · 24-Hour Prototype Feasibility</a:t>
+            </a:r>
+          </a:p>
+        </p:txBody>
+      </p:sp>
+      <p:sp>
+        <p:nvSpPr>
+          <p:cNvPr id="8" name="Rectangle 7"/>
           <p:cNvSpPr/>
           <p:nvPr/>
         </p:nvSpPr>
         <p:spPr>
           <a:xfrm>
-            <a:off x="731520" y="4663440"/>
-            <a:ext cx="1280160" cy="1280160"/>
+            <a:off x="5166360" y="685800"/>
+            <a:ext cx="6293815" cy="5349240"/>
           </a:xfrm>
           <a:prstGeom prst="rect">
             <a:avLst/>
@@ -4338,101 +4378,10 @@
           </a:fontRef>
         </p:style>
         <p:txBody>
-          <a:bodyPr rtlCol="0" anchor="ctr" wrap="square"/>
-          <a:lstStyle/>
-          <a:p>
-            <a:pPr algn="ctr">
-              <a:defRPr sz="2000" b="1">
-                <a:solidFill>
-                  <a:srgbClr val="D95D39"/>
-                </a:solidFill>
-                <a:latin typeface="Inter"/>
-              </a:defRPr>
-            </a:pPr>
-            <a:r>
-              <a:t>15–20m</a:t>
-            </a:r>
-          </a:p>
-          <a:p>
-            <a:pPr>
-              <a:defRPr sz="950">
-                <a:solidFill>
-                  <a:srgbClr val="596E64"/>
-                </a:solidFill>
-                <a:latin typeface="Inter"/>
-              </a:defRPr>
-            </a:pPr>
-            <a:r>
-              <a:t>Manual triage eliminated</a:t>
-            </a:r>
-          </a:p>
-        </p:txBody>
-      </p:sp>
-      <p:sp>
-        <p:nvSpPr>
-          <p:cNvPr id="8" name="Rectangle 7"/>
-          <p:cNvSpPr/>
-          <p:nvPr/>
-        </p:nvSpPr>
-        <p:spPr>
-          <a:xfrm>
-            <a:off x="2103120" y="4663440"/>
-            <a:ext cx="1280160" cy="1280160"/>
-          </a:xfrm>
-          <a:prstGeom prst="rect">
-            <a:avLst/>
-          </a:prstGeom>
-          <a:solidFill>
-            <a:srgbClr val="FFFFFF"/>
-          </a:solidFill>
-          <a:ln w="12700">
-            <a:solidFill>
-              <a:srgbClr val="E2DED4"/>
-            </a:solidFill>
-          </a:ln>
-        </p:spPr>
-        <p:style>
-          <a:lnRef idx="1">
-            <a:schemeClr val="accent1"/>
-          </a:lnRef>
-          <a:fillRef idx="3">
-            <a:schemeClr val="accent1"/>
-          </a:fillRef>
-          <a:effectRef idx="2">
-            <a:schemeClr val="accent1"/>
-          </a:effectRef>
-          <a:fontRef idx="minor">
-            <a:schemeClr val="lt1"/>
-          </a:fontRef>
-        </p:style>
-        <p:txBody>
-          <a:bodyPr rtlCol="0" anchor="ctr" wrap="square"/>
-          <a:lstStyle/>
-          <a:p>
-            <a:pPr algn="ctr">
-              <a:defRPr sz="2000" b="1">
-                <a:solidFill>
-                  <a:srgbClr val="006B55"/>
-                </a:solidFill>
-                <a:latin typeface="Inter"/>
-              </a:defRPr>
-            </a:pPr>
-            <a:r>
-              <a:t>1-Click</a:t>
-            </a:r>
-          </a:p>
-          <a:p>
-            <a:pPr>
-              <a:defRPr sz="950">
-                <a:solidFill>
-                  <a:srgbClr val="596E64"/>
-                </a:solidFill>
-                <a:latin typeface="Inter"/>
-              </a:defRPr>
-            </a:pPr>
-            <a:r>
-              <a:t>Merchant verification</a:t>
-            </a:r>
+          <a:bodyPr rtlCol="0" anchor="ctr"/>
+          <a:lstStyle/>
+          <a:p>
+            <a:pPr algn="ctr"/>
           </a:p>
         </p:txBody>
       </p:sp>
@@ -4444,121 +4393,8 @@
         </p:nvSpPr>
         <p:spPr>
           <a:xfrm>
-            <a:off x="3474720" y="4663440"/>
-            <a:ext cx="1280160" cy="1280160"/>
-          </a:xfrm>
-          <a:prstGeom prst="rect">
-            <a:avLst/>
-          </a:prstGeom>
-          <a:solidFill>
-            <a:srgbClr val="FFFFFF"/>
-          </a:solidFill>
-          <a:ln w="12700">
-            <a:solidFill>
-              <a:srgbClr val="E2DED4"/>
-            </a:solidFill>
-          </a:ln>
-        </p:spPr>
-        <p:style>
-          <a:lnRef idx="1">
-            <a:schemeClr val="accent1"/>
-          </a:lnRef>
-          <a:fillRef idx="3">
-            <a:schemeClr val="accent1"/>
-          </a:fillRef>
-          <a:effectRef idx="2">
-            <a:schemeClr val="accent1"/>
-          </a:effectRef>
-          <a:fontRef idx="minor">
-            <a:schemeClr val="lt1"/>
-          </a:fontRef>
-        </p:style>
-        <p:txBody>
-          <a:bodyPr rtlCol="0" anchor="ctr" wrap="square"/>
-          <a:lstStyle/>
-          <a:p>
-            <a:pPr algn="ctr">
-              <a:defRPr sz="2000" b="1">
-                <a:solidFill>
-                  <a:srgbClr val="172621"/>
-                </a:solidFill>
-                <a:latin typeface="Inter"/>
-              </a:defRPr>
-            </a:pPr>
-            <a:r>
-              <a:t>24h</a:t>
-            </a:r>
-          </a:p>
-          <a:p>
-            <a:pPr>
-              <a:defRPr sz="950">
-                <a:solidFill>
-                  <a:srgbClr val="596E64"/>
-                </a:solidFill>
-                <a:latin typeface="Inter"/>
-              </a:defRPr>
-            </a:pPr>
-            <a:r>
-              <a:t>Prototype feasibility</a:t>
-            </a:r>
-          </a:p>
-        </p:txBody>
-      </p:sp>
-      <p:sp>
-        <p:nvSpPr>
-          <p:cNvPr id="10" name="Rectangle 9"/>
-          <p:cNvSpPr/>
-          <p:nvPr/>
-        </p:nvSpPr>
-        <p:spPr>
-          <a:xfrm>
-            <a:off x="5120640" y="685800"/>
-            <a:ext cx="6339535" cy="5394960"/>
-          </a:xfrm>
-          <a:prstGeom prst="rect">
-            <a:avLst/>
-          </a:prstGeom>
-          <a:solidFill>
-            <a:srgbClr val="FFFFFF"/>
-          </a:solidFill>
-          <a:ln w="12700">
-            <a:solidFill>
-              <a:srgbClr val="E2DED4"/>
-            </a:solidFill>
-          </a:ln>
-        </p:spPr>
-        <p:style>
-          <a:lnRef idx="1">
-            <a:schemeClr val="accent1"/>
-          </a:lnRef>
-          <a:fillRef idx="3">
-            <a:schemeClr val="accent1"/>
-          </a:fillRef>
-          <a:effectRef idx="2">
-            <a:schemeClr val="accent1"/>
-          </a:effectRef>
-          <a:fontRef idx="minor">
-            <a:schemeClr val="lt1"/>
-          </a:fontRef>
-        </p:style>
-        <p:txBody>
-          <a:bodyPr rtlCol="0" anchor="ctr"/>
-          <a:lstStyle/>
-          <a:p>
-            <a:pPr algn="ctr"/>
-          </a:p>
-        </p:txBody>
-      </p:sp>
-      <p:sp>
-        <p:nvSpPr>
-          <p:cNvPr id="11" name="Rectangle 10"/>
-          <p:cNvSpPr/>
-          <p:nvPr/>
-        </p:nvSpPr>
-        <p:spPr>
-          <a:xfrm>
-            <a:off x="5120640" y="685800"/>
-            <a:ext cx="6339535" cy="502920"/>
+            <a:off x="5166360" y="685800"/>
+            <a:ext cx="6293815" cy="457200"/>
           </a:xfrm>
           <a:prstGeom prst="rect">
             <a:avLst/>
@@ -4604,7 +4440,7 @@
       </p:sp>
       <p:pic>
         <p:nvPicPr>
-          <p:cNvPr id="12" name="Picture 11" descr="studio_white_headphones.jpg"/>
+          <p:cNvPr id="10" name="Picture 9" descr="studio_white_headphones.jpg"/>
           <p:cNvPicPr>
             <a:picLocks noChangeAspect="1"/>
           </p:cNvPicPr>
@@ -4618,8 +4454,8 @@
         </p:blipFill>
         <p:spPr>
           <a:xfrm>
-            <a:off x="5394960" y="1417320"/>
-            <a:ext cx="2468880" cy="2103120"/>
+            <a:off x="5349240" y="1280160"/>
+            <a:ext cx="2880360" cy="1920240"/>
           </a:xfrm>
           <a:prstGeom prst="rect">
             <a:avLst/>
@@ -4628,88 +4464,130 @@
       </p:pic>
       <p:sp>
         <p:nvSpPr>
-          <p:cNvPr id="13" name="TextBox 12"/>
-          <p:cNvSpPr txBox="1"/>
-          <p:nvPr/>
-        </p:nvSpPr>
-        <p:spPr>
-          <a:xfrm>
-            <a:off x="8046720" y="1371600"/>
-            <a:ext cx="3139135" cy="2194560"/>
-          </a:xfrm>
-          <a:prstGeom prst="rect">
-            <a:avLst/>
-          </a:prstGeom>
-          <a:noFill/>
-        </p:spPr>
-        <p:txBody>
-          <a:bodyPr wrap="square">
-            <a:spAutoFit/>
-          </a:bodyPr>
-          <a:lstStyle/>
-          <a:p>
-            <a:pPr>
-              <a:defRPr sz="950" b="1">
-                <a:solidFill>
-                  <a:srgbClr val="7A8E85"/>
+          <p:cNvPr id="11" name="Rectangle 10"/>
+          <p:cNvSpPr/>
+          <p:nvPr/>
+        </p:nvSpPr>
+        <p:spPr>
+          <a:xfrm>
+            <a:off x="5349240" y="3246120"/>
+            <a:ext cx="2880360" cy="292608"/>
+          </a:xfrm>
+          <a:prstGeom prst="rect">
+            <a:avLst/>
+          </a:prstGeom>
+          <a:solidFill>
+            <a:srgbClr val="E1F2EC"/>
+          </a:solidFill>
+          <a:ln>
+            <a:noFill/>
+          </a:ln>
+        </p:spPr>
+        <p:style>
+          <a:lnRef idx="1">
+            <a:schemeClr val="accent1"/>
+          </a:lnRef>
+          <a:fillRef idx="3">
+            <a:schemeClr val="accent1"/>
+          </a:fillRef>
+          <a:effectRef idx="2">
+            <a:schemeClr val="accent1"/>
+          </a:effectRef>
+          <a:fontRef idx="minor">
+            <a:schemeClr val="lt1"/>
+          </a:fontRef>
+        </p:style>
+        <p:txBody>
+          <a:bodyPr rtlCol="0" anchor="ctr"/>
+          <a:lstStyle/>
+          <a:p>
+            <a:pPr algn="ctr">
+              <a:defRPr sz="850" b="1">
+                <a:solidFill>
+                  <a:srgbClr val="006B55"/>
                 </a:solidFill>
                 <a:latin typeface="IBM Plex Mono"/>
               </a:defRPr>
             </a:pPr>
             <a:r>
-              <a:t>ORDER INFORMATION</a:t>
-            </a:r>
-          </a:p>
-          <a:p>
-            <a:pPr>
-              <a:defRPr sz="1100" b="1">
-                <a:solidFill>
-                  <a:srgbClr val="172621"/>
-                </a:solidFill>
-                <a:latin typeface="Inter"/>
-              </a:defRPr>
-            </a:pPr>
-            <a:r>
-              <a:t>Order #ORD-7729  ·  HEAD-WHT-02</a:t>
-            </a:r>
-            <a:br/>
-            <a:r>
-              <a:t>Matte White  ·  Price: ₹1,499</a:t>
-            </a:r>
-            <a:br/>
-            <a:r>
-              <a:t>Delivered 4 days ago</a:t>
-            </a:r>
-          </a:p>
-          <a:p>
-            <a:br/>
-            <a:pPr>
-              <a:defRPr sz="950" b="1">
-                <a:solidFill>
-                  <a:srgbClr val="7A8E85"/>
+              <a:t>ORDERED: HEAD-WHT-02 (WHITE)</a:t>
+            </a:r>
+          </a:p>
+        </p:txBody>
+      </p:sp>
+      <p:pic>
+        <p:nvPicPr>
+          <p:cNvPr id="12" name="Picture 11" descr="unboxing_black_headphones.jpg"/>
+          <p:cNvPicPr>
+            <a:picLocks noChangeAspect="1"/>
+          </p:cNvPicPr>
+          <p:nvPr/>
+        </p:nvPicPr>
+        <p:blipFill>
+          <a:blip r:embed="rId3"/>
+          <a:stretch>
+            <a:fillRect/>
+          </a:stretch>
+        </p:blipFill>
+        <p:spPr>
+          <a:xfrm>
+            <a:off x="8396935" y="1280160"/>
+            <a:ext cx="2880360" cy="1920240"/>
+          </a:xfrm>
+          <a:prstGeom prst="rect">
+            <a:avLst/>
+          </a:prstGeom>
+        </p:spPr>
+      </p:pic>
+      <p:sp>
+        <p:nvSpPr>
+          <p:cNvPr id="13" name="Rectangle 12"/>
+          <p:cNvSpPr/>
+          <p:nvPr/>
+        </p:nvSpPr>
+        <p:spPr>
+          <a:xfrm>
+            <a:off x="8396935" y="3246120"/>
+            <a:ext cx="2880360" cy="292608"/>
+          </a:xfrm>
+          <a:prstGeom prst="rect">
+            <a:avLst/>
+          </a:prstGeom>
+          <a:solidFill>
+            <a:srgbClr val="FCECE8"/>
+          </a:solidFill>
+          <a:ln>
+            <a:noFill/>
+          </a:ln>
+        </p:spPr>
+        <p:style>
+          <a:lnRef idx="1">
+            <a:schemeClr val="accent1"/>
+          </a:lnRef>
+          <a:fillRef idx="3">
+            <a:schemeClr val="accent1"/>
+          </a:fillRef>
+          <a:effectRef idx="2">
+            <a:schemeClr val="accent1"/>
+          </a:effectRef>
+          <a:fontRef idx="minor">
+            <a:schemeClr val="lt1"/>
+          </a:fontRef>
+        </p:style>
+        <p:txBody>
+          <a:bodyPr rtlCol="0" anchor="ctr"/>
+          <a:lstStyle/>
+          <a:p>
+            <a:pPr algn="ctr">
+              <a:defRPr sz="850" b="1">
+                <a:solidFill>
+                  <a:srgbClr val="991B1B"/>
                 </a:solidFill>
                 <a:latin typeface="IBM Plex Mono"/>
               </a:defRPr>
             </a:pPr>
             <a:r>
-              <a:t>EVIDENCE CITATION (STAGED)</a:t>
-            </a:r>
-          </a:p>
-          <a:p>
-            <a:pPr>
-              <a:defRPr sz="1050">
-                <a:solidFill>
-                  <a:srgbClr val="596E64"/>
-                </a:solidFill>
-                <a:latin typeface="Inter"/>
-              </a:defRPr>
-            </a:pPr>
-            <a:r>
-              <a:t>Frame 00:07 (Staged)</a:t>
-            </a:r>
-            <a:br/>
-            <a:r>
-              <a:t>Observed item casing is Midnight Black. Exact barcode unverified.</a:t>
+              <a:t>OBSERVED: BLACK ITEM · FRAME 00:07</a:t>
             </a:r>
           </a:p>
         </p:txBody>
@@ -4722,8 +4600,8 @@
         </p:nvSpPr>
         <p:spPr>
           <a:xfrm>
-            <a:off x="5394960" y="3703320"/>
-            <a:ext cx="5790895" cy="777240"/>
+            <a:off x="5349240" y="3639312"/>
+            <a:ext cx="5928055" cy="658368"/>
           </a:xfrm>
           <a:prstGeom prst="rect">
             <a:avLst/>
@@ -4756,7 +4634,7 @@
           <a:lstStyle/>
           <a:p>
             <a:pPr algn="ctr">
-              <a:defRPr sz="1000" b="1">
+              <a:defRPr sz="950" b="1">
                 <a:solidFill>
                   <a:srgbClr val="991B1B"/>
                 </a:solidFill>
@@ -4764,12 +4642,12 @@
               </a:defRPr>
             </a:pPr>
             <a:r>
-              <a:t>POLICY GATE: COLOR CONTRADICTION DETECTED</a:t>
+              <a:t>P-03: COLOR CONTRADICTION DETECTED</a:t>
             </a:r>
           </a:p>
           <a:p>
             <a:pPr>
-              <a:defRPr sz="1050">
+              <a:defRPr sz="950">
                 <a:solidFill>
                   <a:srgbClr val="991B1B"/>
                 </a:solidFill>
@@ -4790,8 +4668,8 @@
         </p:nvSpPr>
         <p:spPr>
           <a:xfrm>
-            <a:off x="5394960" y="4663439"/>
-            <a:ext cx="5790895" cy="411480"/>
+            <a:off x="5349240" y="4370832"/>
+            <a:ext cx="5928055" cy="365760"/>
           </a:xfrm>
           <a:prstGeom prst="rect">
             <a:avLst/>
@@ -4822,7 +4700,7 @@
           <a:lstStyle/>
           <a:p>
             <a:pPr algn="ctr">
-              <a:defRPr sz="1000" b="1">
+              <a:defRPr sz="950" b="1">
                 <a:solidFill>
                   <a:srgbClr val="92400E"/>
                 </a:solidFill>
@@ -4830,7 +4708,7 @@
               </a:defRPr>
             </a:pPr>
             <a:r>
-              <a:t>STATUS: ESCALATED FOR SELLER DECISION</a:t>
+              <a:t>STATUS: ESCALATED FOR SELLER DECISION (HUMAN GATE)</a:t>
             </a:r>
           </a:p>
         </p:txBody>
@@ -4843,8 +4721,8 @@
         </p:nvSpPr>
         <p:spPr>
           <a:xfrm>
-            <a:off x="5394960" y="5212080"/>
-            <a:ext cx="5790895" cy="594360"/>
+            <a:off x="5349240" y="4809744"/>
+            <a:ext cx="5928055" cy="502920"/>
           </a:xfrm>
           <a:prstGeom prst="rect">
             <a:avLst/>
@@ -4875,7 +4753,7 @@
           <a:lstStyle/>
           <a:p>
             <a:pPr algn="ctr">
-              <a:defRPr sz="1400" b="1">
+              <a:defRPr sz="1300" b="1">
                 <a:solidFill>
                   <a:srgbClr val="FFFFFF"/>
                 </a:solidFill>
@@ -4883,7 +4761,7 @@
               </a:defRPr>
             </a:pPr>
             <a:r>
-              <a:t>Review Evidence &amp; Authorize</a:t>
+              <a:t>Review Evidence &amp; Authorize Draft</a:t>
             </a:r>
           </a:p>
         </p:txBody>
@@ -5073,7 +4951,7 @@
         <p:spPr>
           <a:xfrm>
             <a:off x="731520" y="548640"/>
-            <a:ext cx="7315200" cy="365760"/>
+            <a:ext cx="7315200" cy="320040"/>
           </a:xfrm>
           <a:prstGeom prst="rect">
             <a:avLst/>
@@ -5108,8 +4986,8 @@
         </p:nvSpPr>
         <p:spPr>
           <a:xfrm>
-            <a:off x="731520" y="914400"/>
-            <a:ext cx="10698480" cy="685800"/>
+            <a:off x="731520" y="868680"/>
+            <a:ext cx="10728655" cy="594360"/>
           </a:xfrm>
           <a:prstGeom prst="rect">
             <a:avLst/>
@@ -5144,8 +5022,8 @@
         </p:nvSpPr>
         <p:spPr>
           <a:xfrm>
-            <a:off x="731520" y="1600200"/>
-            <a:ext cx="10698480" cy="457200"/>
+            <a:off x="731520" y="1463040"/>
+            <a:ext cx="10728655" cy="411480"/>
           </a:xfrm>
           <a:prstGeom prst="rect">
             <a:avLst/>
@@ -5153,7 +5031,7 @@
           <a:noFill/>
         </p:spPr>
         <p:txBody>
-          <a:bodyPr wrap="none">
+          <a:bodyPr wrap="square">
             <a:spAutoFit/>
           </a:bodyPr>
           <a:lstStyle/>
@@ -5167,7 +5045,7 @@
               </a:defRPr>
             </a:pPr>
             <a:r>
-              <a:t>Four systems. No traceable decision.  ·  Without a shared record, the seller connects order facts, video, and policy manually from memory.</a:t>
+              <a:t>Four systems. No traceable decision.  Without a shared record, the seller connects order facts, video, and policy manually from memory.</a:t>
             </a:r>
           </a:p>
         </p:txBody>
@@ -5180,8 +5058,8 @@
         </p:nvSpPr>
         <p:spPr>
           <a:xfrm>
-            <a:off x="731520" y="2240280"/>
-            <a:ext cx="3200400" cy="1783080"/>
+            <a:off x="731520" y="2057400"/>
+            <a:ext cx="4846320" cy="868680"/>
           </a:xfrm>
           <a:prstGeom prst="rect">
             <a:avLst/>
@@ -5214,7 +5092,7 @@
           <a:lstStyle/>
           <a:p>
             <a:pPr algn="ctr">
-              <a:defRPr sz="1000" b="1">
+              <a:defRPr sz="950" b="1">
                 <a:solidFill>
                   <a:srgbClr val="006B55"/>
                 </a:solidFill>
@@ -5222,33 +5100,20 @@
               </a:defRPr>
             </a:pPr>
             <a:r>
-              <a:t>01 BUYER VIDEO &amp; CLAIM</a:t>
-            </a:r>
-          </a:p>
-          <a:p>
-            <a:pPr>
-              <a:defRPr sz="1400" b="1">
-                <a:solidFill>
-                  <a:srgbClr val="172621"/>
-                </a:solidFill>
-                <a:latin typeface="Inter"/>
-              </a:defRPr>
-            </a:pPr>
-            <a:r>
-              <a:t>Buyer Video &amp; Claim</a:t>
+              <a:t>01  BUYER MESSAGE</a:t>
             </a:r>
           </a:p>
           <a:p>
             <a:pPr>
               <a:defRPr sz="1100">
                 <a:solidFill>
-                  <a:srgbClr val="596E64"/>
+                  <a:srgbClr val="172621"/>
                 </a:solidFill>
                 <a:latin typeface="Inter"/>
               </a:defRPr>
             </a:pPr>
             <a:r>
-              <a:t>Customer submits short unboxing clip and subjective text via chat.</a:t>
+              <a:t>Subjective text &amp; unindexed video claim in chat</a:t>
             </a:r>
           </a:p>
         </p:txBody>
@@ -5261,8 +5126,8 @@
         </p:nvSpPr>
         <p:spPr>
           <a:xfrm>
-            <a:off x="731520" y="4206240"/>
-            <a:ext cx="3200400" cy="1783080"/>
+            <a:off x="731520" y="3035808"/>
+            <a:ext cx="4846320" cy="868680"/>
           </a:xfrm>
           <a:prstGeom prst="rect">
             <a:avLst/>
@@ -5295,7 +5160,7 @@
           <a:lstStyle/>
           <a:p>
             <a:pPr algn="ctr">
-              <a:defRPr sz="1000" b="1">
+              <a:defRPr sz="950" b="1">
                 <a:solidFill>
                   <a:srgbClr val="006B55"/>
                 </a:solidFill>
@@ -5303,33 +5168,20 @@
               </a:defRPr>
             </a:pPr>
             <a:r>
-              <a:t>03 COURIER TRACKING SCAN</a:t>
-            </a:r>
-          </a:p>
-          <a:p>
-            <a:pPr>
-              <a:defRPr sz="1400" b="1">
-                <a:solidFill>
-                  <a:srgbClr val="172621"/>
-                </a:solidFill>
-                <a:latin typeface="Inter"/>
-              </a:defRPr>
-            </a:pPr>
-            <a:r>
-              <a:t>Courier Tracking Scan</a:t>
+              <a:t>02  ORDER RECORD</a:t>
             </a:r>
           </a:p>
           <a:p>
             <a:pPr>
               <a:defRPr sz="1100">
                 <a:solidFill>
-                  <a:srgbClr val="596E64"/>
+                  <a:srgbClr val="172621"/>
                 </a:solidFill>
                 <a:latin typeface="Inter"/>
               </a:defRPr>
             </a:pPr>
             <a:r>
-              <a:t>Shippo courier API records delivery scan 4 days ago.</a:t>
+              <a:t>Shopify manifest: HEAD-WHT-02, Matte White, ₹1,499</a:t>
             </a:r>
           </a:p>
         </p:txBody>
@@ -5342,8 +5194,180 @@
         </p:nvSpPr>
         <p:spPr>
           <a:xfrm>
-            <a:off x="4114800" y="2240280"/>
-            <a:ext cx="3962095" cy="3749039"/>
+            <a:off x="731520" y="4014216"/>
+            <a:ext cx="4846320" cy="868680"/>
+          </a:xfrm>
+          <a:prstGeom prst="rect">
+            <a:avLst/>
+          </a:prstGeom>
+          <a:solidFill>
+            <a:srgbClr val="FFFFFF"/>
+          </a:solidFill>
+          <a:ln w="12700">
+            <a:solidFill>
+              <a:srgbClr val="E2DED4"/>
+            </a:solidFill>
+          </a:ln>
+        </p:spPr>
+        <p:style>
+          <a:lnRef idx="1">
+            <a:schemeClr val="accent1"/>
+          </a:lnRef>
+          <a:fillRef idx="3">
+            <a:schemeClr val="accent1"/>
+          </a:fillRef>
+          <a:effectRef idx="2">
+            <a:schemeClr val="accent1"/>
+          </a:effectRef>
+          <a:fontRef idx="minor">
+            <a:schemeClr val="lt1"/>
+          </a:fontRef>
+        </p:style>
+        <p:txBody>
+          <a:bodyPr rtlCol="0" anchor="ctr" wrap="square"/>
+          <a:lstStyle/>
+          <a:p>
+            <a:pPr algn="ctr">
+              <a:defRPr sz="950" b="1">
+                <a:solidFill>
+                  <a:srgbClr val="006B55"/>
+                </a:solidFill>
+                <a:latin typeface="IBM Plex Mono"/>
+              </a:defRPr>
+            </a:pPr>
+            <a:r>
+              <a:t>03  COURIER STATUS</a:t>
+            </a:r>
+          </a:p>
+          <a:p>
+            <a:pPr>
+              <a:defRPr sz="1100">
+                <a:solidFill>
+                  <a:srgbClr val="172621"/>
+                </a:solidFill>
+                <a:latin typeface="Inter"/>
+              </a:defRPr>
+            </a:pPr>
+            <a:r>
+              <a:t>Shippo scan: delivered 4 days ago (Day 4 of 7)</a:t>
+            </a:r>
+          </a:p>
+        </p:txBody>
+      </p:sp>
+      <p:sp>
+        <p:nvSpPr>
+          <p:cNvPr id="9" name="Rectangle 8"/>
+          <p:cNvSpPr/>
+          <p:nvPr/>
+        </p:nvSpPr>
+        <p:spPr>
+          <a:xfrm>
+            <a:off x="731520" y="4992624"/>
+            <a:ext cx="4846320" cy="868680"/>
+          </a:xfrm>
+          <a:prstGeom prst="rect">
+            <a:avLst/>
+          </a:prstGeom>
+          <a:solidFill>
+            <a:srgbClr val="FFFFFF"/>
+          </a:solidFill>
+          <a:ln w="12700">
+            <a:solidFill>
+              <a:srgbClr val="E2DED4"/>
+            </a:solidFill>
+          </a:ln>
+        </p:spPr>
+        <p:style>
+          <a:lnRef idx="1">
+            <a:schemeClr val="accent1"/>
+          </a:lnRef>
+          <a:fillRef idx="3">
+            <a:schemeClr val="accent1"/>
+          </a:fillRef>
+          <a:effectRef idx="2">
+            <a:schemeClr val="accent1"/>
+          </a:effectRef>
+          <a:fontRef idx="minor">
+            <a:schemeClr val="lt1"/>
+          </a:fontRef>
+        </p:style>
+        <p:txBody>
+          <a:bodyPr rtlCol="0" anchor="ctr" wrap="square"/>
+          <a:lstStyle/>
+          <a:p>
+            <a:pPr algn="ctr">
+              <a:defRPr sz="950" b="1">
+                <a:solidFill>
+                  <a:srgbClr val="006B55"/>
+                </a:solidFill>
+                <a:latin typeface="IBM Plex Mono"/>
+              </a:defRPr>
+            </a:pPr>
+            <a:r>
+              <a:t>04  RETURN POLICY</a:t>
+            </a:r>
+          </a:p>
+          <a:p>
+            <a:pPr>
+              <a:defRPr sz="1100">
+                <a:solidFill>
+                  <a:srgbClr val="172621"/>
+                </a:solidFill>
+                <a:latin typeface="Inter"/>
+              </a:defRPr>
+            </a:pPr>
+            <a:r>
+              <a:t>7-day defect window; security packaging tag rule</a:t>
+            </a:r>
+          </a:p>
+        </p:txBody>
+      </p:sp>
+      <p:sp>
+        <p:nvSpPr>
+          <p:cNvPr id="10" name="TextBox 9"/>
+          <p:cNvSpPr txBox="1"/>
+          <p:nvPr/>
+        </p:nvSpPr>
+        <p:spPr>
+          <a:xfrm>
+            <a:off x="5715000" y="3474720"/>
+            <a:ext cx="365760" cy="548640"/>
+          </a:xfrm>
+          <a:prstGeom prst="rect">
+            <a:avLst/>
+          </a:prstGeom>
+          <a:noFill/>
+        </p:spPr>
+        <p:txBody>
+          <a:bodyPr wrap="none">
+            <a:spAutoFit/>
+          </a:bodyPr>
+          <a:lstStyle/>
+          <a:p>
+            <a:pPr>
+              <a:defRPr sz="2800" b="1">
+                <a:solidFill>
+                  <a:srgbClr val="D95D39"/>
+                </a:solidFill>
+                <a:latin typeface="IBM Plex Mono"/>
+              </a:defRPr>
+            </a:pPr>
+            <a:r>
+              <a:t>→</a:t>
+            </a:r>
+          </a:p>
+        </p:txBody>
+      </p:sp>
+      <p:sp>
+        <p:nvSpPr>
+          <p:cNvPr id="11" name="Rectangle 10"/>
+          <p:cNvSpPr/>
+          <p:nvPr/>
+        </p:nvSpPr>
+        <p:spPr>
+          <a:xfrm>
+            <a:off x="6217920" y="2057400"/>
+            <a:ext cx="5242255" cy="3803904"/>
           </a:xfrm>
           <a:prstGeom prst="rect">
             <a:avLst/>
@@ -5376,7 +5400,7 @@
           <a:lstStyle/>
           <a:p>
             <a:pPr algn="ctr">
-              <a:defRPr sz="1000" b="1">
+              <a:defRPr sz="1100" b="1">
                 <a:solidFill>
                   <a:srgbClr val="D95D39"/>
                 </a:solidFill>
@@ -5384,12 +5408,12 @@
               </a:defRPr>
             </a:pPr>
             <a:r>
-              <a:t>CRITICAL INFORMATION GAP</a:t>
+              <a:t>THE MISSING LINK</a:t>
             </a:r>
           </a:p>
           <a:p>
             <a:pPr algn="ctr">
-              <a:defRPr sz="1800" b="1">
+              <a:defRPr sz="2200" b="1">
                 <a:solidFill>
                   <a:srgbClr val="F5F3EF"/>
                 </a:solidFill>
@@ -5398,6 +5422,20 @@
             </a:pPr>
             <a:r>
               <a:t>NO SHARED EVIDENCE RECORD</a:t>
+            </a:r>
+          </a:p>
+          <a:p>
+            <a:br/>
+            <a:pPr algn="ctr">
+              <a:defRPr sz="1500" b="1" i="1">
+                <a:solidFill>
+                  <a:srgbClr val="FBBF24"/>
+                </a:solidFill>
+                <a:latin typeface="Inter"/>
+              </a:defRPr>
+            </a:pPr>
+            <a:r>
+              <a:t>“What evidence supports this return decision?”</a:t>
             </a:r>
           </a:p>
           <a:p>
@@ -5411,207 +5449,19 @@
               </a:defRPr>
             </a:pPr>
             <a:r>
-              <a:t>Today the seller opens 4 browser tabs and guesses. An erroneous refund burns inventory margin; an unfair denial destroys repeat customer trust. The gap is the absence of an auditable artifact tying order truth, video keyframes, and policy clauses together before money moves.</a:t>
-            </a:r>
-          </a:p>
-          <a:p>
+              <a:t>Today the seller opens 4 tabs and guesses. An erroneous refund burns inventory margin; an unfair denial destroys repeat customer trust.</a:t>
+            </a:r>
             <a:br/>
-            <a:pPr algn="ctr">
-              <a:defRPr sz="1600" b="1">
-                <a:solidFill>
-                  <a:srgbClr val="D95D39"/>
-                </a:solidFill>
-                <a:latin typeface="Inter"/>
-              </a:defRPr>
-            </a:pPr>
-            <a:r>
-              <a:t>9.0% vs 15.14%</a:t>
-            </a:r>
-          </a:p>
-          <a:p>
-            <a:pPr algn="ctr">
-              <a:defRPr sz="900">
-                <a:solidFill>
-                  <a:srgbClr val="9CA3AF"/>
-                </a:solidFill>
-                <a:latin typeface="Inter"/>
-              </a:defRPr>
-            </a:pPr>
-            <a:r>
-              <a:t>9.0% Return Fraud (NRF 2025, fraud only)  |  15.14% Fraud + Policy Abuse (Appriss/Deloitte 2024)</a:t>
-            </a:r>
             <a:br/>
             <a:r>
-              <a:t>Definitions differ: strict criminal fraud vs fraud combined with policy abuse.</a:t>
-            </a:r>
-          </a:p>
-        </p:txBody>
-      </p:sp>
-      <p:sp>
-        <p:nvSpPr>
-          <p:cNvPr id="9" name="Rectangle 8"/>
-          <p:cNvSpPr/>
-          <p:nvPr/>
-        </p:nvSpPr>
-        <p:spPr>
-          <a:xfrm>
-            <a:off x="8259775" y="2240280"/>
-            <a:ext cx="3200400" cy="1783080"/>
-          </a:xfrm>
-          <a:prstGeom prst="rect">
-            <a:avLst/>
-          </a:prstGeom>
-          <a:solidFill>
-            <a:srgbClr val="FFFFFF"/>
-          </a:solidFill>
-          <a:ln w="12700">
-            <a:solidFill>
-              <a:srgbClr val="E2DED4"/>
-            </a:solidFill>
-          </a:ln>
-        </p:spPr>
-        <p:style>
-          <a:lnRef idx="1">
-            <a:schemeClr val="accent1"/>
-          </a:lnRef>
-          <a:fillRef idx="3">
-            <a:schemeClr val="accent1"/>
-          </a:fillRef>
-          <a:effectRef idx="2">
-            <a:schemeClr val="accent1"/>
-          </a:effectRef>
-          <a:fontRef idx="minor">
-            <a:schemeClr val="lt1"/>
-          </a:fontRef>
-        </p:style>
-        <p:txBody>
-          <a:bodyPr rtlCol="0" anchor="ctr" wrap="square"/>
-          <a:lstStyle/>
-          <a:p>
-            <a:pPr algn="ctr">
-              <a:defRPr sz="1000" b="1">
-                <a:solidFill>
-                  <a:srgbClr val="006B55"/>
-                </a:solidFill>
-                <a:latin typeface="IBM Plex Mono"/>
-              </a:defRPr>
-            </a:pPr>
-            <a:r>
-              <a:t>02 STORE ORDER TRUTH</a:t>
-            </a:r>
-          </a:p>
-          <a:p>
-            <a:pPr>
-              <a:defRPr sz="1400" b="1">
-                <a:solidFill>
-                  <a:srgbClr val="172621"/>
-                </a:solidFill>
-                <a:latin typeface="Inter"/>
-              </a:defRPr>
-            </a:pPr>
-            <a:r>
-              <a:t>Store Order Truth</a:t>
-            </a:r>
-          </a:p>
-          <a:p>
-            <a:pPr>
-              <a:defRPr sz="1100">
-                <a:solidFill>
-                  <a:srgbClr val="596E64"/>
-                </a:solidFill>
-                <a:latin typeface="Inter"/>
-              </a:defRPr>
-            </a:pPr>
-            <a:r>
-              <a:t>Shopify store catalog specifies SKU HEAD-WHT-02 (White, ₹1,499).</a:t>
-            </a:r>
-          </a:p>
-        </p:txBody>
-      </p:sp>
-      <p:sp>
-        <p:nvSpPr>
-          <p:cNvPr id="10" name="Rectangle 9"/>
-          <p:cNvSpPr/>
-          <p:nvPr/>
-        </p:nvSpPr>
-        <p:spPr>
-          <a:xfrm>
-            <a:off x="8259775" y="4206240"/>
-            <a:ext cx="3200400" cy="1783080"/>
-          </a:xfrm>
-          <a:prstGeom prst="rect">
-            <a:avLst/>
-          </a:prstGeom>
-          <a:solidFill>
-            <a:srgbClr val="FFFFFF"/>
-          </a:solidFill>
-          <a:ln w="12700">
-            <a:solidFill>
-              <a:srgbClr val="E2DED4"/>
-            </a:solidFill>
-          </a:ln>
-        </p:spPr>
-        <p:style>
-          <a:lnRef idx="1">
-            <a:schemeClr val="accent1"/>
-          </a:lnRef>
-          <a:fillRef idx="3">
-            <a:schemeClr val="accent1"/>
-          </a:fillRef>
-          <a:effectRef idx="2">
-            <a:schemeClr val="accent1"/>
-          </a:effectRef>
-          <a:fontRef idx="minor">
-            <a:schemeClr val="lt1"/>
-          </a:fontRef>
-        </p:style>
-        <p:txBody>
-          <a:bodyPr rtlCol="0" anchor="ctr" wrap="square"/>
-          <a:lstStyle/>
-          <a:p>
-            <a:pPr algn="ctr">
-              <a:defRPr sz="1000" b="1">
-                <a:solidFill>
-                  <a:srgbClr val="006B55"/>
-                </a:solidFill>
-                <a:latin typeface="IBM Plex Mono"/>
-              </a:defRPr>
-            </a:pPr>
-            <a:r>
-              <a:t>04 STORE RETURN POLICY</a:t>
-            </a:r>
-          </a:p>
-          <a:p>
-            <a:pPr>
-              <a:defRPr sz="1400" b="1">
-                <a:solidFill>
-                  <a:srgbClr val="172621"/>
-                </a:solidFill>
-                <a:latin typeface="Inter"/>
-              </a:defRPr>
-            </a:pPr>
-            <a:r>
-              <a:t>Store Return Policy</a:t>
-            </a:r>
-          </a:p>
-          <a:p>
-            <a:pPr>
-              <a:defRPr sz="1100">
-                <a:solidFill>
-                  <a:srgbClr val="596E64"/>
-                </a:solidFill>
-                <a:latin typeface="Inter"/>
-              </a:defRPr>
-            </a:pPr>
-            <a:r>
-              <a:t>7-day defect window and tag condition in store terms.</a:t>
-            </a:r>
-          </a:p>
-        </p:txBody>
-      </p:sp>
-      <p:sp>
-        <p:nvSpPr>
-          <p:cNvPr id="11" name="Rectangle 10"/>
+              <a:t>The gap is not a missing return portal — it is the lack of an immutable trace linking order truth, video keyframes, and policy terms before money moves.</a:t>
+            </a:r>
+          </a:p>
+        </p:txBody>
+      </p:sp>
+      <p:sp>
+        <p:nvSpPr>
+          <p:cNvPr id="12" name="Rectangle 11"/>
           <p:cNvSpPr/>
           <p:nvPr/>
         </p:nvSpPr>
@@ -5654,7 +5504,7 @@
       </p:sp>
       <p:sp>
         <p:nvSpPr>
-          <p:cNvPr id="12" name="TextBox 11"/>
+          <p:cNvPr id="13" name="TextBox 12"/>
           <p:cNvSpPr txBox="1"/>
           <p:nvPr/>
         </p:nvSpPr>
@@ -5683,14 +5533,14 @@
               </a:defRPr>
             </a:pPr>
             <a:r>
-              <a:t>Fraud statistics note: 9.0% (NRF 2025, fraud only) vs 15.14% (Appriss/Deloitte 2024, fraud + abuse)</a:t>
-            </a:r>
-          </a:p>
-        </p:txBody>
-      </p:sp>
-      <p:sp>
-        <p:nvSpPr>
-          <p:cNvPr id="13" name="TextBox 12"/>
+              <a:t>Fraud research: 9% strict fraud (NRF 2025) vs 15.14% fraud + abuse (Appriss/Deloitte 2024). Details in notes.</a:t>
+            </a:r>
+          </a:p>
+        </p:txBody>
+      </p:sp>
+      <p:sp>
+        <p:nvSpPr>
+          <p:cNvPr id="14" name="TextBox 13"/>
           <p:cNvSpPr txBox="1"/>
           <p:nvPr/>
         </p:nvSpPr>
@@ -5794,7 +5644,7 @@
         <p:spPr>
           <a:xfrm>
             <a:off x="731520" y="502920"/>
-            <a:ext cx="7315200" cy="365760"/>
+            <a:ext cx="7315200" cy="320040"/>
           </a:xfrm>
           <a:prstGeom prst="rect">
             <a:avLst/>
@@ -5816,7 +5666,7 @@
               </a:defRPr>
             </a:pPr>
             <a:r>
-              <a:t>VISUAL EVIDENCE BENCHMARK · STAR DEMO</a:t>
+              <a:t>STAR DEMO · CORE BENCHMARK SCENARIO</a:t>
             </a:r>
           </a:p>
         </p:txBody>
@@ -5829,8 +5679,8 @@
         </p:nvSpPr>
         <p:spPr>
           <a:xfrm>
-            <a:off x="731520" y="868680"/>
-            <a:ext cx="10698480" cy="685800"/>
+            <a:off x="731520" y="822960"/>
+            <a:ext cx="10728655" cy="594360"/>
           </a:xfrm>
           <a:prstGeom prst="rect">
             <a:avLst/>
@@ -5865,8 +5715,8 @@
         </p:nvSpPr>
         <p:spPr>
           <a:xfrm>
-            <a:off x="731520" y="1554480"/>
-            <a:ext cx="10698480" cy="411480"/>
+            <a:off x="731520" y="1417320"/>
+            <a:ext cx="10728655" cy="411480"/>
           </a:xfrm>
           <a:prstGeom prst="rect">
             <a:avLst/>
@@ -5880,7 +5730,7 @@
           <a:lstStyle/>
           <a:p>
             <a:pPr>
-              <a:defRPr sz="1900">
+              <a:defRPr sz="2000" b="1">
                 <a:solidFill>
                   <a:srgbClr val="596E64"/>
                 </a:solidFill>
@@ -5901,8 +5751,8 @@
         </p:nvSpPr>
         <p:spPr>
           <a:xfrm>
-            <a:off x="731520" y="2057400"/>
-            <a:ext cx="7040880" cy="4069080"/>
+            <a:off x="731520" y="1965960"/>
+            <a:ext cx="7132320" cy="4069080"/>
           </a:xfrm>
           <a:prstGeom prst="rect">
             <a:avLst/>
@@ -5954,8 +5804,8 @@
         </p:blipFill>
         <p:spPr>
           <a:xfrm>
-            <a:off x="914400" y="2240280"/>
-            <a:ext cx="3246120" cy="2560320"/>
+            <a:off x="914400" y="2148840"/>
+            <a:ext cx="3291840" cy="2651760"/>
           </a:xfrm>
           <a:prstGeom prst="rect">
             <a:avLst/>
@@ -5978,8 +5828,8 @@
         </p:blipFill>
         <p:spPr>
           <a:xfrm>
-            <a:off x="4343400" y="2240280"/>
-            <a:ext cx="3246120" cy="2560320"/>
+            <a:off x="4389120" y="2148840"/>
+            <a:ext cx="3291840" cy="2651760"/>
           </a:xfrm>
           <a:prstGeom prst="rect">
             <a:avLst/>
@@ -5994,8 +5844,8 @@
         </p:nvSpPr>
         <p:spPr>
           <a:xfrm>
-            <a:off x="914400" y="4892040"/>
-            <a:ext cx="3246120" cy="320040"/>
+            <a:off x="914400" y="4873752"/>
+            <a:ext cx="3291840" cy="320040"/>
           </a:xfrm>
           <a:prstGeom prst="rect">
             <a:avLst/>
@@ -6047,8 +5897,8 @@
         </p:nvSpPr>
         <p:spPr>
           <a:xfrm>
-            <a:off x="4343400" y="4892040"/>
-            <a:ext cx="3246120" cy="320040"/>
+            <a:off x="4389120" y="4873752"/>
+            <a:ext cx="3291840" cy="320040"/>
           </a:xfrm>
           <a:prstGeom prst="rect">
             <a:avLst/>
@@ -6100,8 +5950,8 @@
         </p:nvSpPr>
         <p:spPr>
           <a:xfrm>
-            <a:off x="914400" y="5303520"/>
-            <a:ext cx="6675120" cy="731520"/>
+            <a:off x="914400" y="5257800"/>
+            <a:ext cx="6766560" cy="685800"/>
           </a:xfrm>
           <a:prstGeom prst="rect">
             <a:avLst/>
@@ -6123,7 +5973,7 @@
               </a:defRPr>
             </a:pPr>
             <a:r>
-              <a:t>Visual Grounding Honesty: Keyframe resolution reveals black casing. Exact SKU barcode is unreadable in this frame; ReturnLens factually records 'Observed Color: Midnight Black · Exact SKU: Not verified' and cites frame 00:07.</a:t>
+              <a:t>Visual Grounding Honesty: Keyframe resolution proves black casing. Exact SKU barcode is unreadable in this frame; ReturnLens factually records 'Observed Color: Black · Exact SKU: Not verified' and cites frame 00:07.</a:t>
             </a:r>
           </a:p>
         </p:txBody>
@@ -6136,8 +5986,8 @@
         </p:nvSpPr>
         <p:spPr>
           <a:xfrm>
-            <a:off x="8001000" y="2057400"/>
-            <a:ext cx="3459175" cy="4069080"/>
+            <a:off x="8119872" y="1965960"/>
+            <a:ext cx="3340303" cy="4069080"/>
           </a:xfrm>
           <a:prstGeom prst="rect">
             <a:avLst/>
@@ -6181,8 +6031,8 @@
         </p:nvSpPr>
         <p:spPr>
           <a:xfrm>
-            <a:off x="8183880" y="2194560"/>
-            <a:ext cx="3093415" cy="3794760"/>
+            <a:off x="8302752" y="2103120"/>
+            <a:ext cx="2974543" cy="3794760"/>
           </a:xfrm>
           <a:prstGeom prst="rect">
             <a:avLst/>
@@ -6204,7 +6054,7 @@
               </a:defRPr>
             </a:pPr>
             <a:r>
-              <a:t>DETERMINISTIC POLICY GATE</a:t>
+              <a:t>POLICY GATE EVALUATION</a:t>
             </a:r>
           </a:p>
           <a:p>
@@ -6222,7 +6072,7 @@
           </a:p>
           <a:p>
             <a:pPr>
-              <a:defRPr sz="900" b="1">
+              <a:defRPr sz="950" b="1">
                 <a:solidFill>
                   <a:srgbClr val="991B1B"/>
                 </a:solidFill>
@@ -6230,11 +6080,7 @@
               </a:defRPr>
             </a:pPr>
             <a:r>
-              <a:t>SELLER REVIEW REQUIRED</a:t>
-            </a:r>
-            <a:br/>
-            <a:r>
-              <a:t>Observed: Midnight Black · Exact SKU: Not verified in frame</a:t>
+              <a:t>STATUS: SELLER REVIEW REQUIRED</a:t>
             </a:r>
           </a:p>
           <a:p>
@@ -6248,6 +6094,59 @@
               </a:defRPr>
             </a:pPr>
             <a:r>
+              <a:t>Key Findings:</a:t>
+            </a:r>
+          </a:p>
+          <a:p>
+            <a:pPr>
+              <a:defRPr sz="1000">
+                <a:solidFill>
+                  <a:srgbClr val="596E64"/>
+                </a:solidFill>
+                <a:latin typeface="Inter"/>
+              </a:defRPr>
+            </a:pPr>
+            <a:r>
+              <a:t>• OBSERVED: Midnight Black</a:t>
+            </a:r>
+          </a:p>
+          <a:p>
+            <a:pPr>
+              <a:defRPr sz="1000">
+                <a:solidFill>
+                  <a:srgbClr val="596E64"/>
+                </a:solidFill>
+                <a:latin typeface="Inter"/>
+              </a:defRPr>
+            </a:pPr>
+            <a:r>
+              <a:t>• UNVERIFIED: Exact SKU barcode</a:t>
+            </a:r>
+          </a:p>
+          <a:p>
+            <a:pPr>
+              <a:defRPr sz="1000">
+                <a:solidFill>
+                  <a:srgbClr val="596E64"/>
+                </a:solidFill>
+                <a:latin typeface="Inter"/>
+              </a:defRPr>
+            </a:pPr>
+            <a:r>
+              <a:t>• NEXT ACTION: Seller review</a:t>
+            </a:r>
+          </a:p>
+          <a:p>
+            <a:br/>
+            <a:pPr>
+              <a:defRPr sz="1100" b="1">
+                <a:solidFill>
+                  <a:srgbClr val="172621"/>
+                </a:solidFill>
+                <a:latin typeface="Inter"/>
+              </a:defRPr>
+            </a:pPr>
+            <a:r>
               <a:t>Seller Resolution Options:</a:t>
             </a:r>
           </a:p>
@@ -6261,7 +6160,7 @@
               </a:defRPr>
             </a:pPr>
             <a:r>
-              <a:t>1. Request unboxing video with packaging label / serial visible</a:t>
+              <a:t>1. Request unboxing box label photo</a:t>
             </a:r>
           </a:p>
           <a:p>
@@ -6274,7 +6173,7 @@
               </a:defRPr>
             </a:pPr>
             <a:r>
-              <a:t>2. Reject return under policy (item does not match order record)</a:t>
+              <a:t>2. Reject return (item does not match order)</a:t>
             </a:r>
           </a:p>
           <a:p>
@@ -6287,13 +6186,13 @@
               </a:defRPr>
             </a:pPr>
             <a:r>
-              <a:t>3. Override &amp; approve if seller acknowledges known warehouse mis-shipment</a:t>
+              <a:t>3. Override &amp; approve (warehouse error)</a:t>
             </a:r>
           </a:p>
           <a:p>
             <a:br/>
             <a:pPr>
-              <a:defRPr sz="850">
+              <a:defRPr sz="900" b="1">
                 <a:solidFill>
                   <a:srgbClr val="596E64"/>
                 </a:solidFill>
@@ -6301,15 +6200,7 @@
               </a:defRPr>
             </a:pPr>
             <a:r>
-              <a:t>Financial Safety Ceiling:</a:t>
-            </a:r>
-            <a:br/>
-            <a:r>
-              <a:t>0 &lt; amount &lt;= min(₹4,999, remaining_refundable, order_paid)</a:t>
-            </a:r>
-            <a:br/>
-            <a:r>
-              <a:t>No auto-denial · No refund released without seller click</a:t>
+              <a:t>No auto-denial · No refund without seller click</a:t>
             </a:r>
           </a:p>
         </p:txBody>
@@ -6499,7 +6390,7 @@
         <p:spPr>
           <a:xfrm>
             <a:off x="731520" y="502920"/>
-            <a:ext cx="7315200" cy="365760"/>
+            <a:ext cx="7315200" cy="320040"/>
           </a:xfrm>
           <a:prstGeom prst="rect">
             <a:avLst/>
@@ -6534,8 +6425,8 @@
         </p:nvSpPr>
         <p:spPr>
           <a:xfrm>
-            <a:off x="731520" y="868680"/>
-            <a:ext cx="10698480" cy="685800"/>
+            <a:off x="731520" y="822960"/>
+            <a:ext cx="10728655" cy="594360"/>
           </a:xfrm>
           <a:prstGeom prst="rect">
             <a:avLst/>
@@ -6570,8 +6461,8 @@
         </p:nvSpPr>
         <p:spPr>
           <a:xfrm>
-            <a:off x="731520" y="1508760"/>
-            <a:ext cx="10698480" cy="411480"/>
+            <a:off x="731520" y="1417320"/>
+            <a:ext cx="10728655" cy="411480"/>
           </a:xfrm>
           <a:prstGeom prst="rect">
             <a:avLst/>
@@ -6585,7 +6476,7 @@
           <a:lstStyle/>
           <a:p>
             <a:pPr>
-              <a:defRPr sz="1800">
+              <a:defRPr sz="1900">
                 <a:solidFill>
                   <a:srgbClr val="A3B8B0"/>
                 </a:solidFill>
@@ -6606,8 +6497,8 @@
         </p:nvSpPr>
         <p:spPr>
           <a:xfrm>
-            <a:off x="731520" y="2057400"/>
-            <a:ext cx="1600200" cy="1234440"/>
+            <a:off x="731520" y="1965960"/>
+            <a:ext cx="3291840" cy="1234440"/>
           </a:xfrm>
           <a:prstGeom prst="rect">
             <a:avLst/>
@@ -6640,15 +6531,15 @@
           <a:lstStyle/>
           <a:p>
             <a:pPr algn="ctr">
-              <a:defRPr sz="900">
-                <a:solidFill>
-                  <a:srgbClr val="6C8279"/>
+              <a:defRPr sz="950" b="1">
+                <a:solidFill>
+                  <a:srgbClr val="00D1A7"/>
                 </a:solidFill>
                 <a:latin typeface="IBM Plex Mono"/>
               </a:defRPr>
             </a:pPr>
             <a:r>
-              <a:t>01 PLAN</a:t>
+              <a:t>01 MODEL ZONE</a:t>
             </a:r>
           </a:p>
           <a:p>
@@ -6661,12 +6552,12 @@
               </a:defRPr>
             </a:pPr>
             <a:r>
-              <a:t>Plan</a:t>
+              <a:t>Plan &amp; Observe</a:t>
             </a:r>
           </a:p>
           <a:p>
             <a:pPr>
-              <a:defRPr sz="900">
+              <a:defRPr sz="950">
                 <a:solidFill>
                   <a:srgbClr val="A3B8B0"/>
                 </a:solidFill>
@@ -6674,7 +6565,7 @@
               </a:defRPr>
             </a:pPr>
             <a:r>
-              <a:t>Typed plan schema</a:t>
+              <a:t>Planner validates JSON schema · Vision extracts keyframes &amp; non-binding visual metadata.</a:t>
             </a:r>
           </a:p>
         </p:txBody>
@@ -6687,8 +6578,8 @@
         </p:nvSpPr>
         <p:spPr>
           <a:xfrm>
-            <a:off x="731520" y="2057400"/>
-            <a:ext cx="1600200" cy="36576"/>
+            <a:off x="731520" y="1965960"/>
+            <a:ext cx="3291840" cy="36576"/>
           </a:xfrm>
           <a:prstGeom prst="rect">
             <a:avLst/>
@@ -6730,97 +6621,8 @@
         </p:nvSpPr>
         <p:spPr>
           <a:xfrm>
-            <a:off x="822960" y="2926080"/>
-            <a:ext cx="1417320" cy="237744"/>
-          </a:xfrm>
-          <a:prstGeom prst="rect">
-            <a:avLst/>
-          </a:prstGeom>
-          <a:solidFill>
-            <a:srgbClr val="00382B"/>
-          </a:solidFill>
-          <a:ln>
-            <a:noFill/>
-          </a:ln>
-        </p:spPr>
-        <p:style>
-          <a:lnRef idx="1">
-            <a:schemeClr val="accent1"/>
-          </a:lnRef>
-          <a:fillRef idx="3">
-            <a:schemeClr val="accent1"/>
-          </a:fillRef>
-          <a:effectRef idx="2">
-            <a:schemeClr val="accent1"/>
-          </a:effectRef>
-          <a:fontRef idx="minor">
-            <a:schemeClr val="lt1"/>
-          </a:fontRef>
-        </p:style>
-        <p:txBody>
-          <a:bodyPr rtlCol="0" anchor="ctr"/>
-          <a:lstStyle/>
-          <a:p>
-            <a:pPr algn="ctr">
-              <a:defRPr sz="850" b="1">
-                <a:solidFill>
-                  <a:srgbClr val="00D1A7"/>
-                </a:solidFill>
-                <a:latin typeface="IBM Plex Mono"/>
-              </a:defRPr>
-            </a:pPr>
-            <a:r>
-              <a:t>MODEL</a:t>
-            </a:r>
-          </a:p>
-        </p:txBody>
-      </p:sp>
-      <p:sp>
-        <p:nvSpPr>
-          <p:cNvPr id="9" name="TextBox 8"/>
-          <p:cNvSpPr txBox="1"/>
-          <p:nvPr/>
-        </p:nvSpPr>
-        <p:spPr>
-          <a:xfrm>
-            <a:off x="2331720" y="2423160"/>
-            <a:ext cx="219456" cy="365760"/>
-          </a:xfrm>
-          <a:prstGeom prst="rect">
-            <a:avLst/>
-          </a:prstGeom>
-          <a:noFill/>
-        </p:spPr>
-        <p:txBody>
-          <a:bodyPr wrap="none">
-            <a:spAutoFit/>
-          </a:bodyPr>
-          <a:lstStyle/>
-          <a:p>
-            <a:pPr algn="ctr">
-              <a:defRPr sz="1400" b="1">
-                <a:solidFill>
-                  <a:srgbClr val="00D1A7"/>
-                </a:solidFill>
-                <a:latin typeface="IBM Plex Mono"/>
-              </a:defRPr>
-            </a:pPr>
-            <a:r>
-              <a:t>→</a:t>
-            </a:r>
-          </a:p>
-        </p:txBody>
-      </p:sp>
-      <p:sp>
-        <p:nvSpPr>
-          <p:cNvPr id="10" name="Rectangle 9"/>
-          <p:cNvSpPr/>
-          <p:nvPr/>
-        </p:nvSpPr>
-        <p:spPr>
-          <a:xfrm>
-            <a:off x="2551176" y="2057400"/>
-            <a:ext cx="1600200" cy="1234440"/>
+            <a:off x="4242816" y="1965960"/>
+            <a:ext cx="3840480" cy="1234440"/>
           </a:xfrm>
           <a:prstGeom prst="rect">
             <a:avLst/>
@@ -6853,15 +6655,15 @@
           <a:lstStyle/>
           <a:p>
             <a:pPr algn="ctr">
-              <a:defRPr sz="900">
-                <a:solidFill>
-                  <a:srgbClr val="6C8279"/>
+              <a:defRPr sz="950" b="1">
+                <a:solidFill>
+                  <a:srgbClr val="F5F3EF"/>
                 </a:solidFill>
                 <a:latin typeface="IBM Plex Mono"/>
               </a:defRPr>
             </a:pPr>
             <a:r>
-              <a:t>02 RETRIEVE</a:t>
+              <a:t>02 CODE ZONE</a:t>
             </a:r>
           </a:p>
           <a:p>
@@ -6874,12 +6676,12 @@
               </a:defRPr>
             </a:pPr>
             <a:r>
-              <a:t>Retrieve</a:t>
+              <a:t>Retrieve &amp; Enforce Policy</a:t>
             </a:r>
           </a:p>
           <a:p>
             <a:pPr>
-              <a:defRPr sz="900">
+              <a:defRPr sz="950">
                 <a:solidFill>
                   <a:srgbClr val="A3B8B0"/>
                 </a:solidFill>
@@ -6887,21 +6689,21 @@
               </a:defRPr>
             </a:pPr>
             <a:r>
-              <a:t>FFmpeg &amp; mock APIs</a:t>
-            </a:r>
-          </a:p>
-        </p:txBody>
-      </p:sp>
-      <p:sp>
-        <p:nvSpPr>
-          <p:cNvPr id="11" name="Rectangle 10"/>
+              <a:t>Deterministic Python rules P-01 to P-08 · Shippo &amp; Shopify mock APIs enforce hard rules.</a:t>
+            </a:r>
+          </a:p>
+        </p:txBody>
+      </p:sp>
+      <p:sp>
+        <p:nvSpPr>
+          <p:cNvPr id="9" name="Rectangle 8"/>
           <p:cNvSpPr/>
           <p:nvPr/>
         </p:nvSpPr>
         <p:spPr>
           <a:xfrm>
-            <a:off x="2551176" y="2057400"/>
-            <a:ext cx="1600200" cy="36576"/>
+            <a:off x="4242816" y="1965960"/>
+            <a:ext cx="3840480" cy="36576"/>
           </a:xfrm>
           <a:prstGeom prst="rect">
             <a:avLst/>
@@ -6937,103 +6739,14 @@
       </p:sp>
       <p:sp>
         <p:nvSpPr>
-          <p:cNvPr id="12" name="Rectangle 11"/>
+          <p:cNvPr id="10" name="Rectangle 9"/>
           <p:cNvSpPr/>
           <p:nvPr/>
         </p:nvSpPr>
         <p:spPr>
           <a:xfrm>
-            <a:off x="2642616" y="2926080"/>
-            <a:ext cx="1417320" cy="237744"/>
-          </a:xfrm>
-          <a:prstGeom prst="rect">
-            <a:avLst/>
-          </a:prstGeom>
-          <a:solidFill>
-            <a:srgbClr val="263831"/>
-          </a:solidFill>
-          <a:ln>
-            <a:noFill/>
-          </a:ln>
-        </p:spPr>
-        <p:style>
-          <a:lnRef idx="1">
-            <a:schemeClr val="accent1"/>
-          </a:lnRef>
-          <a:fillRef idx="3">
-            <a:schemeClr val="accent1"/>
-          </a:fillRef>
-          <a:effectRef idx="2">
-            <a:schemeClr val="accent1"/>
-          </a:effectRef>
-          <a:fontRef idx="minor">
-            <a:schemeClr val="lt1"/>
-          </a:fontRef>
-        </p:style>
-        <p:txBody>
-          <a:bodyPr rtlCol="0" anchor="ctr"/>
-          <a:lstStyle/>
-          <a:p>
-            <a:pPr algn="ctr">
-              <a:defRPr sz="850" b="1">
-                <a:solidFill>
-                  <a:srgbClr val="F5F3EF"/>
-                </a:solidFill>
-                <a:latin typeface="IBM Plex Mono"/>
-              </a:defRPr>
-            </a:pPr>
-            <a:r>
-              <a:t>CODE</a:t>
-            </a:r>
-          </a:p>
-        </p:txBody>
-      </p:sp>
-      <p:sp>
-        <p:nvSpPr>
-          <p:cNvPr id="13" name="TextBox 12"/>
-          <p:cNvSpPr txBox="1"/>
-          <p:nvPr/>
-        </p:nvSpPr>
-        <p:spPr>
-          <a:xfrm>
-            <a:off x="4151376" y="2423160"/>
-            <a:ext cx="219456" cy="365760"/>
-          </a:xfrm>
-          <a:prstGeom prst="rect">
-            <a:avLst/>
-          </a:prstGeom>
-          <a:noFill/>
-        </p:spPr>
-        <p:txBody>
-          <a:bodyPr wrap="none">
-            <a:spAutoFit/>
-          </a:bodyPr>
-          <a:lstStyle/>
-          <a:p>
-            <a:pPr algn="ctr">
-              <a:defRPr sz="1400" b="1">
-                <a:solidFill>
-                  <a:srgbClr val="00D1A7"/>
-                </a:solidFill>
-                <a:latin typeface="IBM Plex Mono"/>
-              </a:defRPr>
-            </a:pPr>
-            <a:r>
-              <a:t>→</a:t>
-            </a:r>
-          </a:p>
-        </p:txBody>
-      </p:sp>
-      <p:sp>
-        <p:nvSpPr>
-          <p:cNvPr id="14" name="Rectangle 13"/>
-          <p:cNvSpPr/>
-          <p:nvPr/>
-        </p:nvSpPr>
-        <p:spPr>
-          <a:xfrm>
-            <a:off x="4370832" y="2057400"/>
-            <a:ext cx="1600200" cy="1234440"/>
+            <a:off x="8302752" y="1965960"/>
+            <a:ext cx="3157423" cy="1234440"/>
           </a:xfrm>
           <a:prstGeom prst="rect">
             <a:avLst/>
@@ -7066,15 +6779,15 @@
           <a:lstStyle/>
           <a:p>
             <a:pPr algn="ctr">
-              <a:defRPr sz="900">
-                <a:solidFill>
-                  <a:srgbClr val="6C8279"/>
+              <a:defRPr sz="950" b="1">
+                <a:solidFill>
+                  <a:srgbClr val="FBBF24"/>
                 </a:solidFill>
                 <a:latin typeface="IBM Plex Mono"/>
               </a:defRPr>
             </a:pPr>
             <a:r>
-              <a:t>03 EVALUATE</a:t>
+              <a:t>03 HUMAN SELLER GATE</a:t>
             </a:r>
           </a:p>
           <a:p>
@@ -7087,12 +6800,12 @@
               </a:defRPr>
             </a:pPr>
             <a:r>
-              <a:t>Evaluate</a:t>
+              <a:t>Authorize Consequential Action</a:t>
             </a:r>
           </a:p>
           <a:p>
             <a:pPr>
-              <a:defRPr sz="900">
+              <a:defRPr sz="950">
                 <a:solidFill>
                   <a:srgbClr val="A3B8B0"/>
                 </a:solidFill>
@@ -7100,447 +6813,21 @@
               </a:defRPr>
             </a:pPr>
             <a:r>
-              <a:t>Rules P-01 to P-08</a:t>
-            </a:r>
-          </a:p>
-        </p:txBody>
-      </p:sp>
-      <p:sp>
-        <p:nvSpPr>
-          <p:cNvPr id="15" name="Rectangle 14"/>
+              <a:t>Fail-closed authorization gate · 1-click human merchant confirmation for refund release.</a:t>
+            </a:r>
+          </a:p>
+        </p:txBody>
+      </p:sp>
+      <p:sp>
+        <p:nvSpPr>
+          <p:cNvPr id="11" name="Rectangle 10"/>
           <p:cNvSpPr/>
           <p:nvPr/>
         </p:nvSpPr>
         <p:spPr>
           <a:xfrm>
-            <a:off x="4370832" y="2057400"/>
-            <a:ext cx="1600200" cy="36576"/>
-          </a:xfrm>
-          <a:prstGeom prst="rect">
-            <a:avLst/>
-          </a:prstGeom>
-          <a:solidFill>
-            <a:srgbClr val="F5F3EF"/>
-          </a:solidFill>
-          <a:ln>
-            <a:noFill/>
-          </a:ln>
-        </p:spPr>
-        <p:style>
-          <a:lnRef idx="1">
-            <a:schemeClr val="accent1"/>
-          </a:lnRef>
-          <a:fillRef idx="3">
-            <a:schemeClr val="accent1"/>
-          </a:fillRef>
-          <a:effectRef idx="2">
-            <a:schemeClr val="accent1"/>
-          </a:effectRef>
-          <a:fontRef idx="minor">
-            <a:schemeClr val="lt1"/>
-          </a:fontRef>
-        </p:style>
-        <p:txBody>
-          <a:bodyPr rtlCol="0" anchor="ctr"/>
-          <a:lstStyle/>
-          <a:p>
-            <a:pPr algn="ctr"/>
-          </a:p>
-        </p:txBody>
-      </p:sp>
-      <p:sp>
-        <p:nvSpPr>
-          <p:cNvPr id="16" name="Rectangle 15"/>
-          <p:cNvSpPr/>
-          <p:nvPr/>
-        </p:nvSpPr>
-        <p:spPr>
-          <a:xfrm>
-            <a:off x="4462272" y="2926080"/>
-            <a:ext cx="1417320" cy="237744"/>
-          </a:xfrm>
-          <a:prstGeom prst="rect">
-            <a:avLst/>
-          </a:prstGeom>
-          <a:solidFill>
-            <a:srgbClr val="263831"/>
-          </a:solidFill>
-          <a:ln>
-            <a:noFill/>
-          </a:ln>
-        </p:spPr>
-        <p:style>
-          <a:lnRef idx="1">
-            <a:schemeClr val="accent1"/>
-          </a:lnRef>
-          <a:fillRef idx="3">
-            <a:schemeClr val="accent1"/>
-          </a:fillRef>
-          <a:effectRef idx="2">
-            <a:schemeClr val="accent1"/>
-          </a:effectRef>
-          <a:fontRef idx="minor">
-            <a:schemeClr val="lt1"/>
-          </a:fontRef>
-        </p:style>
-        <p:txBody>
-          <a:bodyPr rtlCol="0" anchor="ctr"/>
-          <a:lstStyle/>
-          <a:p>
-            <a:pPr algn="ctr">
-              <a:defRPr sz="850" b="1">
-                <a:solidFill>
-                  <a:srgbClr val="F5F3EF"/>
-                </a:solidFill>
-                <a:latin typeface="IBM Plex Mono"/>
-              </a:defRPr>
-            </a:pPr>
-            <a:r>
-              <a:t>CODE</a:t>
-            </a:r>
-          </a:p>
-        </p:txBody>
-      </p:sp>
-      <p:sp>
-        <p:nvSpPr>
-          <p:cNvPr id="17" name="TextBox 16"/>
-          <p:cNvSpPr txBox="1"/>
-          <p:nvPr/>
-        </p:nvSpPr>
-        <p:spPr>
-          <a:xfrm>
-            <a:off x="5971032" y="2423160"/>
-            <a:ext cx="219456" cy="365760"/>
-          </a:xfrm>
-          <a:prstGeom prst="rect">
-            <a:avLst/>
-          </a:prstGeom>
-          <a:noFill/>
-        </p:spPr>
-        <p:txBody>
-          <a:bodyPr wrap="none">
-            <a:spAutoFit/>
-          </a:bodyPr>
-          <a:lstStyle/>
-          <a:p>
-            <a:pPr algn="ctr">
-              <a:defRPr sz="1400" b="1">
-                <a:solidFill>
-                  <a:srgbClr val="00D1A7"/>
-                </a:solidFill>
-                <a:latin typeface="IBM Plex Mono"/>
-              </a:defRPr>
-            </a:pPr>
-            <a:r>
-              <a:t>→</a:t>
-            </a:r>
-          </a:p>
-        </p:txBody>
-      </p:sp>
-      <p:sp>
-        <p:nvSpPr>
-          <p:cNvPr id="18" name="Rectangle 17"/>
-          <p:cNvSpPr/>
-          <p:nvPr/>
-        </p:nvSpPr>
-        <p:spPr>
-          <a:xfrm>
-            <a:off x="6190488" y="2057400"/>
-            <a:ext cx="1600200" cy="1234440"/>
-          </a:xfrm>
-          <a:prstGeom prst="rect">
-            <a:avLst/>
-          </a:prstGeom>
-          <a:solidFill>
-            <a:srgbClr val="172621"/>
-          </a:solidFill>
-          <a:ln w="12700">
-            <a:solidFill>
-              <a:srgbClr val="223830"/>
-            </a:solidFill>
-          </a:ln>
-        </p:spPr>
-        <p:style>
-          <a:lnRef idx="1">
-            <a:schemeClr val="accent1"/>
-          </a:lnRef>
-          <a:fillRef idx="3">
-            <a:schemeClr val="accent1"/>
-          </a:fillRef>
-          <a:effectRef idx="2">
-            <a:schemeClr val="accent1"/>
-          </a:effectRef>
-          <a:fontRef idx="minor">
-            <a:schemeClr val="lt1"/>
-          </a:fontRef>
-        </p:style>
-        <p:txBody>
-          <a:bodyPr rtlCol="0" anchor="ctr" wrap="square"/>
-          <a:lstStyle/>
-          <a:p>
-            <a:pPr algn="ctr">
-              <a:defRPr sz="900">
-                <a:solidFill>
-                  <a:srgbClr val="6C8279"/>
-                </a:solidFill>
-                <a:latin typeface="IBM Plex Mono"/>
-              </a:defRPr>
-            </a:pPr>
-            <a:r>
-              <a:t>04 AUDIT</a:t>
-            </a:r>
-          </a:p>
-          <a:p>
-            <a:pPr>
-              <a:defRPr sz="1300" b="1">
-                <a:solidFill>
-                  <a:srgbClr val="F5F3EF"/>
-                </a:solidFill>
-                <a:latin typeface="Inter"/>
-              </a:defRPr>
-            </a:pPr>
-            <a:r>
-              <a:t>Audit</a:t>
-            </a:r>
-          </a:p>
-          <a:p>
-            <a:pPr>
-              <a:defRPr sz="900">
-                <a:solidFill>
-                  <a:srgbClr val="A3B8B0"/>
-                </a:solidFill>
-                <a:latin typeface="Inter"/>
-              </a:defRPr>
-            </a:pPr>
-            <a:r>
-              <a:t>Adversarial critic</a:t>
-            </a:r>
-          </a:p>
-        </p:txBody>
-      </p:sp>
-      <p:sp>
-        <p:nvSpPr>
-          <p:cNvPr id="19" name="Rectangle 18"/>
-          <p:cNvSpPr/>
-          <p:nvPr/>
-        </p:nvSpPr>
-        <p:spPr>
-          <a:xfrm>
-            <a:off x="6190488" y="2057400"/>
-            <a:ext cx="1600200" cy="36576"/>
-          </a:xfrm>
-          <a:prstGeom prst="rect">
-            <a:avLst/>
-          </a:prstGeom>
-          <a:solidFill>
-            <a:srgbClr val="00D1A7"/>
-          </a:solidFill>
-          <a:ln>
-            <a:noFill/>
-          </a:ln>
-        </p:spPr>
-        <p:style>
-          <a:lnRef idx="1">
-            <a:schemeClr val="accent1"/>
-          </a:lnRef>
-          <a:fillRef idx="3">
-            <a:schemeClr val="accent1"/>
-          </a:fillRef>
-          <a:effectRef idx="2">
-            <a:schemeClr val="accent1"/>
-          </a:effectRef>
-          <a:fontRef idx="minor">
-            <a:schemeClr val="lt1"/>
-          </a:fontRef>
-        </p:style>
-        <p:txBody>
-          <a:bodyPr rtlCol="0" anchor="ctr"/>
-          <a:lstStyle/>
-          <a:p>
-            <a:pPr algn="ctr"/>
-          </a:p>
-        </p:txBody>
-      </p:sp>
-      <p:sp>
-        <p:nvSpPr>
-          <p:cNvPr id="20" name="Rectangle 19"/>
-          <p:cNvSpPr/>
-          <p:nvPr/>
-        </p:nvSpPr>
-        <p:spPr>
-          <a:xfrm>
-            <a:off x="6281928" y="2926080"/>
-            <a:ext cx="1417320" cy="237744"/>
-          </a:xfrm>
-          <a:prstGeom prst="rect">
-            <a:avLst/>
-          </a:prstGeom>
-          <a:solidFill>
-            <a:srgbClr val="00382B"/>
-          </a:solidFill>
-          <a:ln>
-            <a:noFill/>
-          </a:ln>
-        </p:spPr>
-        <p:style>
-          <a:lnRef idx="1">
-            <a:schemeClr val="accent1"/>
-          </a:lnRef>
-          <a:fillRef idx="3">
-            <a:schemeClr val="accent1"/>
-          </a:fillRef>
-          <a:effectRef idx="2">
-            <a:schemeClr val="accent1"/>
-          </a:effectRef>
-          <a:fontRef idx="minor">
-            <a:schemeClr val="lt1"/>
-          </a:fontRef>
-        </p:style>
-        <p:txBody>
-          <a:bodyPr rtlCol="0" anchor="ctr"/>
-          <a:lstStyle/>
-          <a:p>
-            <a:pPr algn="ctr">
-              <a:defRPr sz="850" b="1">
-                <a:solidFill>
-                  <a:srgbClr val="00D1A7"/>
-                </a:solidFill>
-                <a:latin typeface="IBM Plex Mono"/>
-              </a:defRPr>
-            </a:pPr>
-            <a:r>
-              <a:t>MODEL</a:t>
-            </a:r>
-          </a:p>
-        </p:txBody>
-      </p:sp>
-      <p:sp>
-        <p:nvSpPr>
-          <p:cNvPr id="21" name="TextBox 20"/>
-          <p:cNvSpPr txBox="1"/>
-          <p:nvPr/>
-        </p:nvSpPr>
-        <p:spPr>
-          <a:xfrm>
-            <a:off x="7790688" y="2423160"/>
-            <a:ext cx="219456" cy="365760"/>
-          </a:xfrm>
-          <a:prstGeom prst="rect">
-            <a:avLst/>
-          </a:prstGeom>
-          <a:noFill/>
-        </p:spPr>
-        <p:txBody>
-          <a:bodyPr wrap="none">
-            <a:spAutoFit/>
-          </a:bodyPr>
-          <a:lstStyle/>
-          <a:p>
-            <a:pPr algn="ctr">
-              <a:defRPr sz="1400" b="1">
-                <a:solidFill>
-                  <a:srgbClr val="00D1A7"/>
-                </a:solidFill>
-                <a:latin typeface="IBM Plex Mono"/>
-              </a:defRPr>
-            </a:pPr>
-            <a:r>
-              <a:t>→</a:t>
-            </a:r>
-          </a:p>
-        </p:txBody>
-      </p:sp>
-      <p:sp>
-        <p:nvSpPr>
-          <p:cNvPr id="22" name="Rectangle 21"/>
-          <p:cNvSpPr/>
-          <p:nvPr/>
-        </p:nvSpPr>
-        <p:spPr>
-          <a:xfrm>
-            <a:off x="8010144" y="2057400"/>
-            <a:ext cx="1600200" cy="1234440"/>
-          </a:xfrm>
-          <a:prstGeom prst="rect">
-            <a:avLst/>
-          </a:prstGeom>
-          <a:solidFill>
-            <a:srgbClr val="172621"/>
-          </a:solidFill>
-          <a:ln w="12700">
-            <a:solidFill>
-              <a:srgbClr val="223830"/>
-            </a:solidFill>
-          </a:ln>
-        </p:spPr>
-        <p:style>
-          <a:lnRef idx="1">
-            <a:schemeClr val="accent1"/>
-          </a:lnRef>
-          <a:fillRef idx="3">
-            <a:schemeClr val="accent1"/>
-          </a:fillRef>
-          <a:effectRef idx="2">
-            <a:schemeClr val="accent1"/>
-          </a:effectRef>
-          <a:fontRef idx="minor">
-            <a:schemeClr val="lt1"/>
-          </a:fontRef>
-        </p:style>
-        <p:txBody>
-          <a:bodyPr rtlCol="0" anchor="ctr" wrap="square"/>
-          <a:lstStyle/>
-          <a:p>
-            <a:pPr algn="ctr">
-              <a:defRPr sz="900">
-                <a:solidFill>
-                  <a:srgbClr val="6C8279"/>
-                </a:solidFill>
-                <a:latin typeface="IBM Plex Mono"/>
-              </a:defRPr>
-            </a:pPr>
-            <a:r>
-              <a:t>05 AUTHORIZE</a:t>
-            </a:r>
-          </a:p>
-          <a:p>
-            <a:pPr>
-              <a:defRPr sz="1300" b="1">
-                <a:solidFill>
-                  <a:srgbClr val="F5F3EF"/>
-                </a:solidFill>
-                <a:latin typeface="Inter"/>
-              </a:defRPr>
-            </a:pPr>
-            <a:r>
-              <a:t>Authorize</a:t>
-            </a:r>
-          </a:p>
-          <a:p>
-            <a:pPr>
-              <a:defRPr sz="900">
-                <a:solidFill>
-                  <a:srgbClr val="A3B8B0"/>
-                </a:solidFill>
-                <a:latin typeface="Inter"/>
-              </a:defRPr>
-            </a:pPr>
-            <a:r>
-              <a:t>Fail-closed gate</a:t>
-            </a:r>
-          </a:p>
-        </p:txBody>
-      </p:sp>
-      <p:sp>
-        <p:nvSpPr>
-          <p:cNvPr id="23" name="Rectangle 22"/>
-          <p:cNvSpPr/>
-          <p:nvPr/>
-        </p:nvSpPr>
-        <p:spPr>
-          <a:xfrm>
-            <a:off x="8010144" y="2057400"/>
-            <a:ext cx="1600200" cy="36576"/>
+            <a:off x="8302752" y="1965960"/>
+            <a:ext cx="3157423" cy="36576"/>
           </a:xfrm>
           <a:prstGeom prst="rect">
             <a:avLst/>
@@ -7576,280 +6863,14 @@
       </p:sp>
       <p:sp>
         <p:nvSpPr>
-          <p:cNvPr id="24" name="Rectangle 23"/>
+          <p:cNvPr id="12" name="Rectangle 11"/>
           <p:cNvSpPr/>
           <p:nvPr/>
         </p:nvSpPr>
         <p:spPr>
           <a:xfrm>
-            <a:off x="8101584" y="2926080"/>
-            <a:ext cx="1417320" cy="237744"/>
-          </a:xfrm>
-          <a:prstGeom prst="rect">
-            <a:avLst/>
-          </a:prstGeom>
-          <a:solidFill>
-            <a:srgbClr val="45260A"/>
-          </a:solidFill>
-          <a:ln>
-            <a:noFill/>
-          </a:ln>
-        </p:spPr>
-        <p:style>
-          <a:lnRef idx="1">
-            <a:schemeClr val="accent1"/>
-          </a:lnRef>
-          <a:fillRef idx="3">
-            <a:schemeClr val="accent1"/>
-          </a:fillRef>
-          <a:effectRef idx="2">
-            <a:schemeClr val="accent1"/>
-          </a:effectRef>
-          <a:fontRef idx="minor">
-            <a:schemeClr val="lt1"/>
-          </a:fontRef>
-        </p:style>
-        <p:txBody>
-          <a:bodyPr rtlCol="0" anchor="ctr"/>
-          <a:lstStyle/>
-          <a:p>
-            <a:pPr algn="ctr">
-              <a:defRPr sz="850" b="1">
-                <a:solidFill>
-                  <a:srgbClr val="FBBF24"/>
-                </a:solidFill>
-                <a:latin typeface="IBM Plex Mono"/>
-              </a:defRPr>
-            </a:pPr>
-            <a:r>
-              <a:t>HUMAN</a:t>
-            </a:r>
-          </a:p>
-        </p:txBody>
-      </p:sp>
-      <p:sp>
-        <p:nvSpPr>
-          <p:cNvPr id="25" name="TextBox 24"/>
-          <p:cNvSpPr txBox="1"/>
-          <p:nvPr/>
-        </p:nvSpPr>
-        <p:spPr>
-          <a:xfrm>
-            <a:off x="9610344" y="2423160"/>
-            <a:ext cx="219456" cy="365760"/>
-          </a:xfrm>
-          <a:prstGeom prst="rect">
-            <a:avLst/>
-          </a:prstGeom>
-          <a:noFill/>
-        </p:spPr>
-        <p:txBody>
-          <a:bodyPr wrap="none">
-            <a:spAutoFit/>
-          </a:bodyPr>
-          <a:lstStyle/>
-          <a:p>
-            <a:pPr algn="ctr">
-              <a:defRPr sz="1400" b="1">
-                <a:solidFill>
-                  <a:srgbClr val="00D1A7"/>
-                </a:solidFill>
-                <a:latin typeface="IBM Plex Mono"/>
-              </a:defRPr>
-            </a:pPr>
-            <a:r>
-              <a:t>→</a:t>
-            </a:r>
-          </a:p>
-        </p:txBody>
-      </p:sp>
-      <p:sp>
-        <p:nvSpPr>
-          <p:cNvPr id="26" name="Rectangle 25"/>
-          <p:cNvSpPr/>
-          <p:nvPr/>
-        </p:nvSpPr>
-        <p:spPr>
-          <a:xfrm>
-            <a:off x="9829800" y="2057400"/>
-            <a:ext cx="1600200" cy="1234440"/>
-          </a:xfrm>
-          <a:prstGeom prst="rect">
-            <a:avLst/>
-          </a:prstGeom>
-          <a:solidFill>
-            <a:srgbClr val="172621"/>
-          </a:solidFill>
-          <a:ln w="12700">
-            <a:solidFill>
-              <a:srgbClr val="223830"/>
-            </a:solidFill>
-          </a:ln>
-        </p:spPr>
-        <p:style>
-          <a:lnRef idx="1">
-            <a:schemeClr val="accent1"/>
-          </a:lnRef>
-          <a:fillRef idx="3">
-            <a:schemeClr val="accent1"/>
-          </a:fillRef>
-          <a:effectRef idx="2">
-            <a:schemeClr val="accent1"/>
-          </a:effectRef>
-          <a:fontRef idx="minor">
-            <a:schemeClr val="lt1"/>
-          </a:fontRef>
-        </p:style>
-        <p:txBody>
-          <a:bodyPr rtlCol="0" anchor="ctr" wrap="square"/>
-          <a:lstStyle/>
-          <a:p>
-            <a:pPr algn="ctr">
-              <a:defRPr sz="900">
-                <a:solidFill>
-                  <a:srgbClr val="6C8279"/>
-                </a:solidFill>
-                <a:latin typeface="IBM Plex Mono"/>
-              </a:defRPr>
-            </a:pPr>
-            <a:r>
-              <a:t>06 RECORD</a:t>
-            </a:r>
-          </a:p>
-          <a:p>
-            <a:pPr>
-              <a:defRPr sz="1300" b="1">
-                <a:solidFill>
-                  <a:srgbClr val="F5F3EF"/>
-                </a:solidFill>
-                <a:latin typeface="Inter"/>
-              </a:defRPr>
-            </a:pPr>
-            <a:r>
-              <a:t>Record</a:t>
-            </a:r>
-          </a:p>
-          <a:p>
-            <a:pPr>
-              <a:defRPr sz="900">
-                <a:solidFill>
-                  <a:srgbClr val="A3B8B0"/>
-                </a:solidFill>
-                <a:latin typeface="Inter"/>
-              </a:defRPr>
-            </a:pPr>
-            <a:r>
-              <a:t>Audit trace log</a:t>
-            </a:r>
-          </a:p>
-        </p:txBody>
-      </p:sp>
-      <p:sp>
-        <p:nvSpPr>
-          <p:cNvPr id="27" name="Rectangle 26"/>
-          <p:cNvSpPr/>
-          <p:nvPr/>
-        </p:nvSpPr>
-        <p:spPr>
-          <a:xfrm>
-            <a:off x="9829800" y="2057400"/>
-            <a:ext cx="1600200" cy="36576"/>
-          </a:xfrm>
-          <a:prstGeom prst="rect">
-            <a:avLst/>
-          </a:prstGeom>
-          <a:solidFill>
-            <a:srgbClr val="F5F3EF"/>
-          </a:solidFill>
-          <a:ln>
-            <a:noFill/>
-          </a:ln>
-        </p:spPr>
-        <p:style>
-          <a:lnRef idx="1">
-            <a:schemeClr val="accent1"/>
-          </a:lnRef>
-          <a:fillRef idx="3">
-            <a:schemeClr val="accent1"/>
-          </a:fillRef>
-          <a:effectRef idx="2">
-            <a:schemeClr val="accent1"/>
-          </a:effectRef>
-          <a:fontRef idx="minor">
-            <a:schemeClr val="lt1"/>
-          </a:fontRef>
-        </p:style>
-        <p:txBody>
-          <a:bodyPr rtlCol="0" anchor="ctr"/>
-          <a:lstStyle/>
-          <a:p>
-            <a:pPr algn="ctr"/>
-          </a:p>
-        </p:txBody>
-      </p:sp>
-      <p:sp>
-        <p:nvSpPr>
-          <p:cNvPr id="28" name="Rectangle 27"/>
-          <p:cNvSpPr/>
-          <p:nvPr/>
-        </p:nvSpPr>
-        <p:spPr>
-          <a:xfrm>
-            <a:off x="9921240" y="2926080"/>
-            <a:ext cx="1417320" cy="237744"/>
-          </a:xfrm>
-          <a:prstGeom prst="rect">
-            <a:avLst/>
-          </a:prstGeom>
-          <a:solidFill>
-            <a:srgbClr val="263831"/>
-          </a:solidFill>
-          <a:ln>
-            <a:noFill/>
-          </a:ln>
-        </p:spPr>
-        <p:style>
-          <a:lnRef idx="1">
-            <a:schemeClr val="accent1"/>
-          </a:lnRef>
-          <a:fillRef idx="3">
-            <a:schemeClr val="accent1"/>
-          </a:fillRef>
-          <a:effectRef idx="2">
-            <a:schemeClr val="accent1"/>
-          </a:effectRef>
-          <a:fontRef idx="minor">
-            <a:schemeClr val="lt1"/>
-          </a:fontRef>
-        </p:style>
-        <p:txBody>
-          <a:bodyPr rtlCol="0" anchor="ctr"/>
-          <a:lstStyle/>
-          <a:p>
-            <a:pPr algn="ctr">
-              <a:defRPr sz="850" b="1">
-                <a:solidFill>
-                  <a:srgbClr val="F5F3EF"/>
-                </a:solidFill>
-                <a:latin typeface="IBM Plex Mono"/>
-              </a:defRPr>
-            </a:pPr>
-            <a:r>
-              <a:t>CODE</a:t>
-            </a:r>
-          </a:p>
-        </p:txBody>
-      </p:sp>
-      <p:sp>
-        <p:nvSpPr>
-          <p:cNvPr id="29" name="Rectangle 28"/>
-          <p:cNvSpPr/>
-          <p:nvPr/>
-        </p:nvSpPr>
-        <p:spPr>
-          <a:xfrm>
-            <a:off x="731520" y="3474720"/>
-            <a:ext cx="6492240" cy="1554480"/>
+            <a:off x="731520" y="3429000"/>
+            <a:ext cx="10728655" cy="1874519"/>
           </a:xfrm>
           <a:prstGeom prst="rect">
             <a:avLst/>
@@ -7882,7 +6903,7 @@
           <a:lstStyle/>
           <a:p>
             <a:pPr algn="ctr">
-              <a:defRPr sz="1000" b="1">
+              <a:defRPr sz="1100" b="1">
                 <a:solidFill>
                   <a:srgbClr val="93C5FD"/>
                 </a:solidFill>
@@ -7890,57 +6911,31 @@
               </a:defRPr>
             </a:pPr>
             <a:r>
-              <a:t>CASE C · DYNAMIC STATEFUL CLARIFICATION LOOP</a:t>
-            </a:r>
-          </a:p>
-          <a:p>
-            <a:pPr>
-              <a:defRPr sz="1100" b="1">
-                <a:solidFill>
-                  <a:srgbClr val="F5F3EF"/>
-                </a:solidFill>
-                <a:latin typeface="Inter"/>
-              </a:defRPr>
-            </a:pPr>
-            <a:r>
-              <a:t>Dark Frames → ask_for_evidence() → WAITING_FOR_EVIDENCE → Customer Uploads → Resume Case</a:t>
-            </a:r>
-          </a:p>
-          <a:p>
-            <a:pPr>
-              <a:defRPr sz="950">
-                <a:solidFill>
-                  <a:srgbClr val="A3B8B0"/>
-                </a:solidFill>
-                <a:latin typeface="Inter"/>
-              </a:defRPr>
-            </a:pPr>
-            <a:r>
-              <a:t>Agentic State Machine: When lighting is insufficient, the agent halts standard execution, prompts a targeted checklist, pauses state in WAITING_FOR_EVIDENCE, and seamlessly resumes context upon media receipt (1 retry limit protects customer experience).</a:t>
-            </a:r>
-          </a:p>
-        </p:txBody>
-      </p:sp>
-      <p:sp>
-        <p:nvSpPr>
-          <p:cNvPr id="30" name="Rectangle 29"/>
+              <a:t>HERO AGENTIC INTERACTION: DYNAMIC STATEFUL CLARIFICATION LOOP (CASE C)</a:t>
+            </a:r>
+          </a:p>
+        </p:txBody>
+      </p:sp>
+      <p:sp>
+        <p:nvSpPr>
+          <p:cNvPr id="13" name="Rectangle 12"/>
           <p:cNvSpPr/>
           <p:nvPr/>
         </p:nvSpPr>
         <p:spPr>
           <a:xfrm>
-            <a:off x="7436815" y="3474720"/>
-            <a:ext cx="4023360" cy="1554480"/>
+            <a:off x="914400" y="3904488"/>
+            <a:ext cx="1536192" cy="502920"/>
           </a:xfrm>
           <a:prstGeom prst="rect">
             <a:avLst/>
           </a:prstGeom>
           <a:solidFill>
-            <a:srgbClr val="14221D"/>
+            <a:srgbClr val="1F302A"/>
           </a:solidFill>
-          <a:ln w="19050">
+          <a:ln w="12700">
             <a:solidFill>
-              <a:srgbClr val="059669"/>
+              <a:srgbClr val="223830"/>
             </a:solidFill>
           </a:ln>
         </p:spPr>
@@ -7963,59 +6958,520 @@
           <a:lstStyle/>
           <a:p>
             <a:pPr algn="ctr">
-              <a:defRPr sz="1000" b="1">
-                <a:solidFill>
-                  <a:srgbClr val="00D1A7"/>
+              <a:defRPr sz="850" b="1">
+                <a:solidFill>
+                  <a:srgbClr val="F5F3EF"/>
                 </a:solidFill>
                 <a:latin typeface="IBM Plex Mono"/>
               </a:defRPr>
             </a:pPr>
             <a:r>
-              <a:t>SECONDARY PS-04 ROUTE · ORDER STATUS FAST PATH</a:t>
-            </a:r>
-          </a:p>
+              <a:t>Dark Frames (brightness 28)</a:t>
+            </a:r>
+          </a:p>
+        </p:txBody>
+      </p:sp>
+      <p:sp>
+        <p:nvSpPr>
+          <p:cNvPr id="14" name="TextBox 13"/>
+          <p:cNvSpPr txBox="1"/>
+          <p:nvPr/>
+        </p:nvSpPr>
+        <p:spPr>
+          <a:xfrm>
+            <a:off x="2450592" y="3977640"/>
+            <a:ext cx="256032" cy="365760"/>
+          </a:xfrm>
+          <a:prstGeom prst="rect">
+            <a:avLst/>
+          </a:prstGeom>
+          <a:noFill/>
+        </p:spPr>
+        <p:txBody>
+          <a:bodyPr wrap="none">
+            <a:spAutoFit/>
+          </a:bodyPr>
+          <a:lstStyle/>
+          <a:p>
+            <a:pPr algn="ctr">
+              <a:defRPr sz="1300" b="1">
+                <a:solidFill>
+                  <a:srgbClr val="93C5FD"/>
+                </a:solidFill>
+                <a:latin typeface="IBM Plex Mono"/>
+              </a:defRPr>
+            </a:pPr>
+            <a:r>
+              <a:t>→</a:t>
+            </a:r>
+          </a:p>
+        </p:txBody>
+      </p:sp>
+      <p:sp>
+        <p:nvSpPr>
+          <p:cNvPr id="15" name="Rectangle 14"/>
+          <p:cNvSpPr/>
+          <p:nvPr/>
+        </p:nvSpPr>
+        <p:spPr>
+          <a:xfrm>
+            <a:off x="2706624" y="3904488"/>
+            <a:ext cx="1536192" cy="502920"/>
+          </a:xfrm>
+          <a:prstGeom prst="rect">
+            <a:avLst/>
+          </a:prstGeom>
+          <a:solidFill>
+            <a:srgbClr val="1F302A"/>
+          </a:solidFill>
+          <a:ln w="12700">
+            <a:solidFill>
+              <a:srgbClr val="223830"/>
+            </a:solidFill>
+          </a:ln>
+        </p:spPr>
+        <p:style>
+          <a:lnRef idx="1">
+            <a:schemeClr val="accent1"/>
+          </a:lnRef>
+          <a:fillRef idx="3">
+            <a:schemeClr val="accent1"/>
+          </a:fillRef>
+          <a:effectRef idx="2">
+            <a:schemeClr val="accent1"/>
+          </a:effectRef>
+          <a:fontRef idx="minor">
+            <a:schemeClr val="lt1"/>
+          </a:fontRef>
+        </p:style>
+        <p:txBody>
+          <a:bodyPr rtlCol="0" anchor="ctr" wrap="square"/>
+          <a:lstStyle/>
+          <a:p>
+            <a:pPr algn="ctr">
+              <a:defRPr sz="850" b="1">
+                <a:solidFill>
+                  <a:srgbClr val="F5F3EF"/>
+                </a:solidFill>
+                <a:latin typeface="IBM Plex Mono"/>
+              </a:defRPr>
+            </a:pPr>
+            <a:r>
+              <a:t>ask_for_evidence()</a:t>
+            </a:r>
+          </a:p>
+        </p:txBody>
+      </p:sp>
+      <p:sp>
+        <p:nvSpPr>
+          <p:cNvPr id="16" name="TextBox 15"/>
+          <p:cNvSpPr txBox="1"/>
+          <p:nvPr/>
+        </p:nvSpPr>
+        <p:spPr>
+          <a:xfrm>
+            <a:off x="4242816" y="3977640"/>
+            <a:ext cx="256032" cy="365760"/>
+          </a:xfrm>
+          <a:prstGeom prst="rect">
+            <a:avLst/>
+          </a:prstGeom>
+          <a:noFill/>
+        </p:spPr>
+        <p:txBody>
+          <a:bodyPr wrap="none">
+            <a:spAutoFit/>
+          </a:bodyPr>
+          <a:lstStyle/>
+          <a:p>
+            <a:pPr algn="ctr">
+              <a:defRPr sz="1300" b="1">
+                <a:solidFill>
+                  <a:srgbClr val="93C5FD"/>
+                </a:solidFill>
+                <a:latin typeface="IBM Plex Mono"/>
+              </a:defRPr>
+            </a:pPr>
+            <a:r>
+              <a:t>→</a:t>
+            </a:r>
+          </a:p>
+        </p:txBody>
+      </p:sp>
+      <p:sp>
+        <p:nvSpPr>
+          <p:cNvPr id="17" name="Rectangle 16"/>
+          <p:cNvSpPr/>
+          <p:nvPr/>
+        </p:nvSpPr>
+        <p:spPr>
+          <a:xfrm>
+            <a:off x="4498848" y="3904488"/>
+            <a:ext cx="1536192" cy="502920"/>
+          </a:xfrm>
+          <a:prstGeom prst="rect">
+            <a:avLst/>
+          </a:prstGeom>
+          <a:solidFill>
+            <a:srgbClr val="1E3A8A"/>
+          </a:solidFill>
+          <a:ln w="15240">
+            <a:solidFill>
+              <a:srgbClr val="60A5FA"/>
+            </a:solidFill>
+          </a:ln>
+        </p:spPr>
+        <p:style>
+          <a:lnRef idx="1">
+            <a:schemeClr val="accent1"/>
+          </a:lnRef>
+          <a:fillRef idx="3">
+            <a:schemeClr val="accent1"/>
+          </a:fillRef>
+          <a:effectRef idx="2">
+            <a:schemeClr val="accent1"/>
+          </a:effectRef>
+          <a:fontRef idx="minor">
+            <a:schemeClr val="lt1"/>
+          </a:fontRef>
+        </p:style>
+        <p:txBody>
+          <a:bodyPr rtlCol="0" anchor="ctr" wrap="square"/>
+          <a:lstStyle/>
+          <a:p>
+            <a:pPr algn="ctr">
+              <a:defRPr sz="850" b="1">
+                <a:solidFill>
+                  <a:srgbClr val="DBEAFE"/>
+                </a:solidFill>
+                <a:latin typeface="IBM Plex Mono"/>
+              </a:defRPr>
+            </a:pPr>
+            <a:r>
+              <a:t>WAITING_FOR_EVIDENCE</a:t>
+            </a:r>
+          </a:p>
+        </p:txBody>
+      </p:sp>
+      <p:sp>
+        <p:nvSpPr>
+          <p:cNvPr id="18" name="TextBox 17"/>
+          <p:cNvSpPr txBox="1"/>
+          <p:nvPr/>
+        </p:nvSpPr>
+        <p:spPr>
+          <a:xfrm>
+            <a:off x="6035040" y="3977640"/>
+            <a:ext cx="256032" cy="365760"/>
+          </a:xfrm>
+          <a:prstGeom prst="rect">
+            <a:avLst/>
+          </a:prstGeom>
+          <a:noFill/>
+        </p:spPr>
+        <p:txBody>
+          <a:bodyPr wrap="none">
+            <a:spAutoFit/>
+          </a:bodyPr>
+          <a:lstStyle/>
+          <a:p>
+            <a:pPr algn="ctr">
+              <a:defRPr sz="1300" b="1">
+                <a:solidFill>
+                  <a:srgbClr val="93C5FD"/>
+                </a:solidFill>
+                <a:latin typeface="IBM Plex Mono"/>
+              </a:defRPr>
+            </a:pPr>
+            <a:r>
+              <a:t>→</a:t>
+            </a:r>
+          </a:p>
+        </p:txBody>
+      </p:sp>
+      <p:sp>
+        <p:nvSpPr>
+          <p:cNvPr id="19" name="Rectangle 18"/>
+          <p:cNvSpPr/>
+          <p:nvPr/>
+        </p:nvSpPr>
+        <p:spPr>
+          <a:xfrm>
+            <a:off x="6291072" y="3904488"/>
+            <a:ext cx="1536192" cy="502920"/>
+          </a:xfrm>
+          <a:prstGeom prst="rect">
+            <a:avLst/>
+          </a:prstGeom>
+          <a:solidFill>
+            <a:srgbClr val="1F302A"/>
+          </a:solidFill>
+          <a:ln w="12700">
+            <a:solidFill>
+              <a:srgbClr val="223830"/>
+            </a:solidFill>
+          </a:ln>
+        </p:spPr>
+        <p:style>
+          <a:lnRef idx="1">
+            <a:schemeClr val="accent1"/>
+          </a:lnRef>
+          <a:fillRef idx="3">
+            <a:schemeClr val="accent1"/>
+          </a:fillRef>
+          <a:effectRef idx="2">
+            <a:schemeClr val="accent1"/>
+          </a:effectRef>
+          <a:fontRef idx="minor">
+            <a:schemeClr val="lt1"/>
+          </a:fontRef>
+        </p:style>
+        <p:txBody>
+          <a:bodyPr rtlCol="0" anchor="ctr" wrap="square"/>
+          <a:lstStyle/>
+          <a:p>
+            <a:pPr algn="ctr">
+              <a:defRPr sz="850" b="1">
+                <a:solidFill>
+                  <a:srgbClr val="F5F3EF"/>
+                </a:solidFill>
+                <a:latin typeface="IBM Plex Mono"/>
+              </a:defRPr>
+            </a:pPr>
+            <a:r>
+              <a:t>Customer Uploads</a:t>
+            </a:r>
+          </a:p>
+        </p:txBody>
+      </p:sp>
+      <p:sp>
+        <p:nvSpPr>
+          <p:cNvPr id="20" name="TextBox 19"/>
+          <p:cNvSpPr txBox="1"/>
+          <p:nvPr/>
+        </p:nvSpPr>
+        <p:spPr>
+          <a:xfrm>
+            <a:off x="7827264" y="3977640"/>
+            <a:ext cx="256032" cy="365760"/>
+          </a:xfrm>
+          <a:prstGeom prst="rect">
+            <a:avLst/>
+          </a:prstGeom>
+          <a:noFill/>
+        </p:spPr>
+        <p:txBody>
+          <a:bodyPr wrap="none">
+            <a:spAutoFit/>
+          </a:bodyPr>
+          <a:lstStyle/>
+          <a:p>
+            <a:pPr algn="ctr">
+              <a:defRPr sz="1300" b="1">
+                <a:solidFill>
+                  <a:srgbClr val="93C5FD"/>
+                </a:solidFill>
+                <a:latin typeface="IBM Plex Mono"/>
+              </a:defRPr>
+            </a:pPr>
+            <a:r>
+              <a:t>→</a:t>
+            </a:r>
+          </a:p>
+        </p:txBody>
+      </p:sp>
+      <p:sp>
+        <p:nvSpPr>
+          <p:cNvPr id="21" name="Rectangle 20"/>
+          <p:cNvSpPr/>
+          <p:nvPr/>
+        </p:nvSpPr>
+        <p:spPr>
+          <a:xfrm>
+            <a:off x="8083296" y="3904488"/>
+            <a:ext cx="1536192" cy="502920"/>
+          </a:xfrm>
+          <a:prstGeom prst="rect">
+            <a:avLst/>
+          </a:prstGeom>
+          <a:solidFill>
+            <a:srgbClr val="1E3A8A"/>
+          </a:solidFill>
+          <a:ln w="15240">
+            <a:solidFill>
+              <a:srgbClr val="60A5FA"/>
+            </a:solidFill>
+          </a:ln>
+        </p:spPr>
+        <p:style>
+          <a:lnRef idx="1">
+            <a:schemeClr val="accent1"/>
+          </a:lnRef>
+          <a:fillRef idx="3">
+            <a:schemeClr val="accent1"/>
+          </a:fillRef>
+          <a:effectRef idx="2">
+            <a:schemeClr val="accent1"/>
+          </a:effectRef>
+          <a:fontRef idx="minor">
+            <a:schemeClr val="lt1"/>
+          </a:fontRef>
+        </p:style>
+        <p:txBody>
+          <a:bodyPr rtlCol="0" anchor="ctr" wrap="square"/>
+          <a:lstStyle/>
+          <a:p>
+            <a:pPr algn="ctr">
+              <a:defRPr sz="850" b="1">
+                <a:solidFill>
+                  <a:srgbClr val="DBEAFE"/>
+                </a:solidFill>
+                <a:latin typeface="IBM Plex Mono"/>
+              </a:defRPr>
+            </a:pPr>
+            <a:r>
+              <a:t>RESUME CASE</a:t>
+            </a:r>
+          </a:p>
+        </p:txBody>
+      </p:sp>
+      <p:sp>
+        <p:nvSpPr>
+          <p:cNvPr id="22" name="TextBox 21"/>
+          <p:cNvSpPr txBox="1"/>
+          <p:nvPr/>
+        </p:nvSpPr>
+        <p:spPr>
+          <a:xfrm>
+            <a:off x="9619488" y="3977640"/>
+            <a:ext cx="256032" cy="365760"/>
+          </a:xfrm>
+          <a:prstGeom prst="rect">
+            <a:avLst/>
+          </a:prstGeom>
+          <a:noFill/>
+        </p:spPr>
+        <p:txBody>
+          <a:bodyPr wrap="none">
+            <a:spAutoFit/>
+          </a:bodyPr>
+          <a:lstStyle/>
+          <a:p>
+            <a:pPr algn="ctr">
+              <a:defRPr sz="1300" b="1">
+                <a:solidFill>
+                  <a:srgbClr val="93C5FD"/>
+                </a:solidFill>
+                <a:latin typeface="IBM Plex Mono"/>
+              </a:defRPr>
+            </a:pPr>
+            <a:r>
+              <a:t>→</a:t>
+            </a:r>
+          </a:p>
+        </p:txBody>
+      </p:sp>
+      <p:sp>
+        <p:nvSpPr>
+          <p:cNvPr id="23" name="Rectangle 22"/>
+          <p:cNvSpPr/>
+          <p:nvPr/>
+        </p:nvSpPr>
+        <p:spPr>
+          <a:xfrm>
+            <a:off x="9875520" y="3904488"/>
+            <a:ext cx="1536192" cy="502920"/>
+          </a:xfrm>
+          <a:prstGeom prst="rect">
+            <a:avLst/>
+          </a:prstGeom>
+          <a:solidFill>
+            <a:srgbClr val="1F302A"/>
+          </a:solidFill>
+          <a:ln w="12700">
+            <a:solidFill>
+              <a:srgbClr val="223830"/>
+            </a:solidFill>
+          </a:ln>
+        </p:spPr>
+        <p:style>
+          <a:lnRef idx="1">
+            <a:schemeClr val="accent1"/>
+          </a:lnRef>
+          <a:fillRef idx="3">
+            <a:schemeClr val="accent1"/>
+          </a:fillRef>
+          <a:effectRef idx="2">
+            <a:schemeClr val="accent1"/>
+          </a:effectRef>
+          <a:fontRef idx="minor">
+            <a:schemeClr val="lt1"/>
+          </a:fontRef>
+        </p:style>
+        <p:txBody>
+          <a:bodyPr rtlCol="0" anchor="ctr" wrap="square"/>
+          <a:lstStyle/>
+          <a:p>
+            <a:pPr algn="ctr">
+              <a:defRPr sz="850" b="1">
+                <a:solidFill>
+                  <a:srgbClr val="F5F3EF"/>
+                </a:solidFill>
+                <a:latin typeface="IBM Plex Mono"/>
+              </a:defRPr>
+            </a:pPr>
+            <a:r>
+              <a:t>Seller Review</a:t>
+            </a:r>
+          </a:p>
+        </p:txBody>
+      </p:sp>
+      <p:sp>
+        <p:nvSpPr>
+          <p:cNvPr id="24" name="TextBox 23"/>
+          <p:cNvSpPr txBox="1"/>
+          <p:nvPr/>
+        </p:nvSpPr>
+        <p:spPr>
+          <a:xfrm>
+            <a:off x="914400" y="4572000"/>
+            <a:ext cx="10362895" cy="640080"/>
+          </a:xfrm>
+          <a:prstGeom prst="rect">
+            <a:avLst/>
+          </a:prstGeom>
+          <a:noFill/>
+        </p:spPr>
+        <p:txBody>
+          <a:bodyPr wrap="square">
+            <a:spAutoFit/>
+          </a:bodyPr>
+          <a:lstStyle/>
           <a:p>
             <a:pPr>
-              <a:defRPr sz="1100" b="1">
-                <a:solidFill>
-                  <a:srgbClr val="F5F3EF"/>
+              <a:defRPr sz="1050">
+                <a:solidFill>
+                  <a:srgbClr val="A3B8B0"/>
                 </a:solidFill>
                 <a:latin typeface="Inter"/>
               </a:defRPr>
             </a:pPr>
             <a:r>
-              <a:t>“Where is my order?” → Direct Mock Store &amp; Courier Scan</a:t>
-            </a:r>
-          </a:p>
-          <a:p>
-            <a:pPr>
-              <a:defRPr sz="950">
-                <a:solidFill>
-                  <a:srgbClr val="A3B8B0"/>
-                </a:solidFill>
-                <a:latin typeface="Inter"/>
-              </a:defRPr>
-            </a:pPr>
-            <a:r>
-              <a:t>Instant delivery timestamp &amp; scan (Zero-vision overhead)</a:t>
-            </a:r>
-            <a:br/>
-            <a:r>
-              <a:t>Routine order queries take a direct tool route without calling heavy multimodal models. Escalates to human seller only if courier scan shows abnormal transit delay.</a:t>
-            </a:r>
-          </a:p>
-        </p:txBody>
-      </p:sp>
-      <p:sp>
-        <p:nvSpPr>
-          <p:cNvPr id="31" name="Rectangle 30"/>
+              <a:t>Why an agent? When video quality is insufficient, ReturnLens halts execution, issues a targeted re-film checklist, serializes case state into WAITING_FOR_EVIDENCE, and automatically resumes the exact case upon upload (1 retry limit prevents customer lock-out).</a:t>
+            </a:r>
+          </a:p>
+        </p:txBody>
+      </p:sp>
+      <p:sp>
+        <p:nvSpPr>
+          <p:cNvPr id="25" name="Rectangle 24"/>
           <p:cNvSpPr/>
           <p:nvPr/>
         </p:nvSpPr>
         <p:spPr>
           <a:xfrm>
-            <a:off x="731520" y="5212080"/>
-            <a:ext cx="10728655" cy="960120"/>
+            <a:off x="731520" y="5486400"/>
+            <a:ext cx="10728655" cy="658368"/>
           </a:xfrm>
           <a:prstGeom prst="rect">
             <a:avLst/>
@@ -8048,15 +7504,15 @@
           <a:lstStyle/>
           <a:p>
             <a:pPr algn="ctr">
-              <a:defRPr sz="900">
-                <a:solidFill>
-                  <a:srgbClr val="A3B8B0"/>
+              <a:defRPr sz="900" b="1">
+                <a:solidFill>
+                  <a:srgbClr val="34D399"/>
                 </a:solidFill>
                 <a:latin typeface="IBM Plex Mono"/>
               </a:defRPr>
             </a:pPr>
             <a:r>
-              <a:t>■ Model Calls: 3 base LLM calls per triage case (Planner, Vision, Critic) plus retries.   |   ■ Deterministic Policy: Rules P-01 to P-08 executed in pure Python code, never prompts.</a:t>
+              <a:t>SECONDARY PS-04 ROUTE: Query store &amp; courier tracking for "Where is my order?" without calling multimodal vision models.</a:t>
             </a:r>
           </a:p>
           <a:p>
@@ -8069,14 +7525,14 @@
               </a:defRPr>
             </a:pPr>
             <a:r>
-              <a:t>■ Critic Duty: Independent prompt audits cited frames; notes correlated vision limits.   |   ■ Safety Ceiling: Backend checks block payment tools; 1-click human authorization strictly enforced.</a:t>
-            </a:r>
-          </a:p>
-        </p:txBody>
-      </p:sp>
-      <p:sp>
-        <p:nvSpPr>
-          <p:cNvPr id="32" name="Rectangle 31"/>
+              <a:t>SYSTEM OUTPUT: Immutable JSON Audit Trail recorded at every state transition</a:t>
+            </a:r>
+          </a:p>
+        </p:txBody>
+      </p:sp>
+      <p:sp>
+        <p:nvSpPr>
+          <p:cNvPr id="26" name="Rectangle 25"/>
           <p:cNvSpPr/>
           <p:nvPr/>
         </p:nvSpPr>
@@ -8119,7 +7575,7 @@
       </p:sp>
       <p:sp>
         <p:nvSpPr>
-          <p:cNvPr id="33" name="TextBox 32"/>
+          <p:cNvPr id="27" name="TextBox 26"/>
           <p:cNvSpPr txBox="1"/>
           <p:nvPr/>
         </p:nvSpPr>
@@ -8155,7 +7611,7 @@
       </p:sp>
       <p:sp>
         <p:nvSpPr>
-          <p:cNvPr id="34" name="TextBox 33"/>
+          <p:cNvPr id="28" name="TextBox 27"/>
           <p:cNvSpPr txBox="1"/>
           <p:nvPr/>
         </p:nvSpPr>
@@ -8259,7 +7715,7 @@
         <p:spPr>
           <a:xfrm>
             <a:off x="731520" y="502920"/>
-            <a:ext cx="7315200" cy="365760"/>
+            <a:ext cx="7315200" cy="320040"/>
           </a:xfrm>
           <a:prstGeom prst="rect">
             <a:avLst/>
@@ -8281,7 +7737,7 @@
               </a:defRPr>
             </a:pPr>
             <a:r>
-              <a:t>DEMO SCENARIOS · CONTROLLED PROTOTYPE BEHAVIORS</a:t>
+              <a:t>DEMO SCENARIOS · BEHAVIORAL MATRIX</a:t>
             </a:r>
           </a:p>
         </p:txBody>
@@ -8294,8 +7750,8 @@
         </p:nvSpPr>
         <p:spPr>
           <a:xfrm>
-            <a:off x="731520" y="868680"/>
-            <a:ext cx="10698480" cy="685800"/>
+            <a:off x="731520" y="822960"/>
+            <a:ext cx="10728655" cy="594360"/>
           </a:xfrm>
           <a:prstGeom prst="rect">
             <a:avLst/>
@@ -8317,7 +7773,7 @@
               </a:defRPr>
             </a:pPr>
             <a:r>
-              <a:t>Four evidence conditions. Four controlled actions.</a:t>
+              <a:t>Different evidence. Different action.</a:t>
             </a:r>
           </a:p>
         </p:txBody>
@@ -8330,8 +7786,8 @@
         </p:nvSpPr>
         <p:spPr>
           <a:xfrm>
-            <a:off x="731520" y="1508760"/>
-            <a:ext cx="10698480" cy="411480"/>
+            <a:off x="731520" y="1417320"/>
+            <a:ext cx="10728655" cy="411480"/>
           </a:xfrm>
           <a:prstGeom prst="rect">
             <a:avLst/>
@@ -8345,7 +7801,7 @@
           <a:lstStyle/>
           <a:p>
             <a:pPr>
-              <a:defRPr sz="1800">
+              <a:defRPr sz="1900">
                 <a:solidFill>
                   <a:srgbClr val="596E64"/>
                 </a:solidFill>
@@ -8353,7 +7809,7 @@
               </a:defRPr>
             </a:pPr>
             <a:r>
-              <a:t>Expected prototype behaviors across staged benchmark cases. Not measured production metrics.</a:t>
+              <a:t>Predictable, controlled prototype responses across four distinct evidence conditions.</a:t>
             </a:r>
           </a:p>
         </p:txBody>
@@ -8367,7 +7823,7 @@
         <p:spPr>
           <a:xfrm>
             <a:off x="731520" y="2057400"/>
-            <a:ext cx="10728655" cy="932688"/>
+            <a:ext cx="10728655" cy="868680"/>
           </a:xfrm>
           <a:prstGeom prst="rect">
             <a:avLst/>
@@ -8411,8 +7867,8 @@
         </p:nvSpPr>
         <p:spPr>
           <a:xfrm>
-            <a:off x="914400" y="2258568"/>
-            <a:ext cx="2011680" cy="502920"/>
+            <a:off x="914400" y="2276856"/>
+            <a:ext cx="1920240" cy="429768"/>
           </a:xfrm>
           <a:prstGeom prst="rect">
             <a:avLst/>
@@ -8443,7 +7899,7 @@
           <a:lstStyle/>
           <a:p>
             <a:pPr algn="ctr">
-              <a:defRPr sz="1000" b="1">
+              <a:defRPr sz="1050" b="1">
                 <a:solidFill>
                   <a:srgbClr val="006B55"/>
                 </a:solidFill>
@@ -8451,20 +7907,7 @@
               </a:defRPr>
             </a:pPr>
             <a:r>
-              <a:t>CASE 01 · CONSISTENT</a:t>
-            </a:r>
-          </a:p>
-          <a:p>
-            <a:pPr algn="ctr">
-              <a:defRPr sz="900">
-                <a:solidFill>
-                  <a:srgbClr val="006B55"/>
-                </a:solidFill>
-                <a:latin typeface="Inter"/>
-              </a:defRPr>
-            </a:pPr>
-            <a:r>
-              <a:t>Clear Defect</a:t>
+              <a:t>01 · CONSISTENT</a:t>
             </a:r>
           </a:p>
         </p:txBody>
@@ -8477,8 +7920,8 @@
         </p:nvSpPr>
         <p:spPr>
           <a:xfrm>
-            <a:off x="3063240" y="2167128"/>
-            <a:ext cx="3566160" cy="731520"/>
+            <a:off x="2971800" y="2167128"/>
+            <a:ext cx="3749039" cy="640080"/>
           </a:xfrm>
           <a:prstGeom prst="rect">
             <a:avLst/>
@@ -8500,7 +7943,7 @@
               </a:defRPr>
             </a:pPr>
             <a:r>
-              <a:t>Staged casing crack verified in unboxing frame 00:04 · Manifest &amp; return window match.</a:t>
+              <a:t>Evidence Supported · Manifest matches, packaging tag present, cosmetic defect observed</a:t>
             </a:r>
           </a:p>
         </p:txBody>
@@ -8513,7 +7956,7 @@
         </p:nvSpPr>
         <p:spPr>
           <a:xfrm>
-            <a:off x="6720840" y="2276856"/>
+            <a:off x="6812280" y="2258568"/>
             <a:ext cx="274320" cy="457200"/>
           </a:xfrm>
           <a:prstGeom prst="rect">
@@ -8549,8 +7992,8 @@
         </p:nvSpPr>
         <p:spPr>
           <a:xfrm>
-            <a:off x="7086600" y="2167128"/>
-            <a:ext cx="4206240" cy="731520"/>
+            <a:off x="7178040" y="2167128"/>
+            <a:ext cx="4114800" cy="640080"/>
           </a:xfrm>
           <a:prstGeom prst="rect">
             <a:avLst/>
@@ -8564,7 +8007,7 @@
           <a:lstStyle/>
           <a:p>
             <a:pPr>
-              <a:defRPr sz="1050" b="1">
+              <a:defRPr sz="1100" b="1">
                 <a:solidFill>
                   <a:srgbClr val="006B55"/>
                 </a:solidFill>
@@ -8585,7 +8028,7 @@
               </a:defRPr>
             </a:pPr>
             <a:r>
-              <a:t>Agent prepares mock shipping label &amp; drafts refund in pending_return_receipt. Money releases only upon warehouse receipt.</a:t>
+              <a:t>Drafts mock shipping label and refund draft in pending_return_receipt. Money releases only on physical receipt.</a:t>
             </a:r>
           </a:p>
         </p:txBody>
@@ -8598,8 +8041,8 @@
         </p:nvSpPr>
         <p:spPr>
           <a:xfrm>
-            <a:off x="731520" y="3099816"/>
-            <a:ext cx="10728655" cy="932688"/>
+            <a:off x="731520" y="3035808"/>
+            <a:ext cx="10728655" cy="868680"/>
           </a:xfrm>
           <a:prstGeom prst="rect">
             <a:avLst/>
@@ -8643,8 +8086,8 @@
         </p:nvSpPr>
         <p:spPr>
           <a:xfrm>
-            <a:off x="914400" y="3300984"/>
-            <a:ext cx="2011680" cy="502920"/>
+            <a:off x="914400" y="3255264"/>
+            <a:ext cx="1920240" cy="429768"/>
           </a:xfrm>
           <a:prstGeom prst="rect">
             <a:avLst/>
@@ -8675,7 +8118,7 @@
           <a:lstStyle/>
           <a:p>
             <a:pPr algn="ctr">
-              <a:defRPr sz="1000" b="1">
+              <a:defRPr sz="1050" b="1">
                 <a:solidFill>
                   <a:srgbClr val="991B1B"/>
                 </a:solidFill>
@@ -8683,20 +8126,7 @@
               </a:defRPr>
             </a:pPr>
             <a:r>
-              <a:t>CASE 02 · CONTRADICTION</a:t>
-            </a:r>
-          </a:p>
-          <a:p>
-            <a:pPr algn="ctr">
-              <a:defRPr sz="900">
-                <a:solidFill>
-                  <a:srgbClr val="991B1B"/>
-                </a:solidFill>
-                <a:latin typeface="Inter"/>
-              </a:defRPr>
-            </a:pPr>
-            <a:r>
-              <a:t>Color Mismatch</a:t>
+              <a:t>02 · CONTRADICTION</a:t>
             </a:r>
           </a:p>
         </p:txBody>
@@ -8709,8 +8139,8 @@
         </p:nvSpPr>
         <p:spPr>
           <a:xfrm>
-            <a:off x="3063240" y="3209544"/>
-            <a:ext cx="3566160" cy="731520"/>
+            <a:off x="2971800" y="3145536"/>
+            <a:ext cx="3749039" cy="640080"/>
           </a:xfrm>
           <a:prstGeom prst="rect">
             <a:avLst/>
@@ -8732,7 +8162,7 @@
               </a:defRPr>
             </a:pPr>
             <a:r>
-              <a:t>White ordered (HEAD-WHT-02) vs Black unboxed in Frame 00:07 · Exact SKU unverified.</a:t>
+              <a:t>Ordered White, Observed Black · HEAD-WHT-02 ordered vs Frame 00:07 Black item</a:t>
             </a:r>
           </a:p>
         </p:txBody>
@@ -8745,7 +8175,7 @@
         </p:nvSpPr>
         <p:spPr>
           <a:xfrm>
-            <a:off x="6720840" y="3319272"/>
+            <a:off x="6812280" y="3236976"/>
             <a:ext cx="274320" cy="457200"/>
           </a:xfrm>
           <a:prstGeom prst="rect">
@@ -8781,8 +8211,8 @@
         </p:nvSpPr>
         <p:spPr>
           <a:xfrm>
-            <a:off x="7086600" y="3209544"/>
-            <a:ext cx="4206240" cy="731520"/>
+            <a:off x="7178040" y="3145536"/>
+            <a:ext cx="4114800" cy="640080"/>
           </a:xfrm>
           <a:prstGeom prst="rect">
             <a:avLst/>
@@ -8796,7 +8226,7 @@
           <a:lstStyle/>
           <a:p>
             <a:pPr>
-              <a:defRPr sz="1050" b="1">
+              <a:defRPr sz="1100" b="1">
                 <a:solidFill>
                   <a:srgbClr val="991B1B"/>
                 </a:solidFill>
@@ -8817,7 +8247,7 @@
               </a:defRPr>
             </a:pPr>
             <a:r>
-              <a:t>Policy P-03 blocks automation. Inhibits label and refund. Seller selects 1 of 3 concrete resolution options.</a:t>
+              <a:t>Policy P-03 blocks automation. Inhibits label and refund. Seller selects: mis-shipment / box label / warehouse inspection.</a:t>
             </a:r>
           </a:p>
         </p:txBody>
@@ -8830,8 +8260,8 @@
         </p:nvSpPr>
         <p:spPr>
           <a:xfrm>
-            <a:off x="731520" y="4142232"/>
-            <a:ext cx="10728655" cy="932688"/>
+            <a:off x="731520" y="4014216"/>
+            <a:ext cx="10728655" cy="868680"/>
           </a:xfrm>
           <a:prstGeom prst="rect">
             <a:avLst/>
@@ -8875,8 +8305,8 @@
         </p:nvSpPr>
         <p:spPr>
           <a:xfrm>
-            <a:off x="914400" y="4343400"/>
-            <a:ext cx="2011680" cy="502920"/>
+            <a:off x="914400" y="4233672"/>
+            <a:ext cx="1920240" cy="429768"/>
           </a:xfrm>
           <a:prstGeom prst="rect">
             <a:avLst/>
@@ -8907,7 +8337,7 @@
           <a:lstStyle/>
           <a:p>
             <a:pPr algn="ctr">
-              <a:defRPr sz="1000" b="1">
+              <a:defRPr sz="1050" b="1">
                 <a:solidFill>
                   <a:srgbClr val="1E40AF"/>
                 </a:solidFill>
@@ -8915,20 +8345,7 @@
               </a:defRPr>
             </a:pPr>
             <a:r>
-              <a:t>CASE 03 · UNCLEAR</a:t>
-            </a:r>
-          </a:p>
-          <a:p>
-            <a:pPr algn="ctr">
-              <a:defRPr sz="900">
-                <a:solidFill>
-                  <a:srgbClr val="1E40AF"/>
-                </a:solidFill>
-                <a:latin typeface="Inter"/>
-              </a:defRPr>
-            </a:pPr>
-            <a:r>
-              <a:t>Low Lighting</a:t>
+              <a:t>03 · UNCLEAR</a:t>
             </a:r>
           </a:p>
         </p:txBody>
@@ -8941,8 +8358,8 @@
         </p:nvSpPr>
         <p:spPr>
           <a:xfrm>
-            <a:off x="3063240" y="4251960"/>
-            <a:ext cx="3566160" cy="731520"/>
+            <a:off x="2971800" y="4123944"/>
+            <a:ext cx="3749039" cy="640080"/>
           </a:xfrm>
           <a:prstGeom prst="rect">
             <a:avLst/>
@@ -8964,7 +8381,7 @@
               </a:defRPr>
             </a:pPr>
             <a:r>
-              <a:t>4-second dark video, brightness 28/255, barcode obscured · Insufficient visual evidence.</a:t>
+              <a:t>Dark or Unreadable Evidence · 4s low-light video (brightness 28/255), barcode obscured</a:t>
             </a:r>
           </a:p>
         </p:txBody>
@@ -8977,7 +8394,7 @@
         </p:nvSpPr>
         <p:spPr>
           <a:xfrm>
-            <a:off x="6720840" y="4361688"/>
+            <a:off x="6812280" y="4215384"/>
             <a:ext cx="274320" cy="457200"/>
           </a:xfrm>
           <a:prstGeom prst="rect">
@@ -9013,8 +8430,8 @@
         </p:nvSpPr>
         <p:spPr>
           <a:xfrm>
-            <a:off x="7086600" y="4251960"/>
-            <a:ext cx="4206240" cy="731520"/>
+            <a:off x="7178040" y="4123944"/>
+            <a:ext cx="4114800" cy="640080"/>
           </a:xfrm>
           <a:prstGeom prst="rect">
             <a:avLst/>
@@ -9028,7 +8445,7 @@
           <a:lstStyle/>
           <a:p>
             <a:pPr>
-              <a:defRPr sz="1050" b="1">
+              <a:defRPr sz="1100" b="1">
                 <a:solidFill>
                   <a:srgbClr val="1E40AF"/>
                 </a:solidFill>
@@ -9049,7 +8466,7 @@
               </a:defRPr>
             </a:pPr>
             <a:r>
-              <a:t>Agent calls ask_for_evidence(); transitions ticket to WAITING_FOR_EVIDENCE; resumes context on upload (1 retry limit).</a:t>
+              <a:t>Calls ask_for_evidence(); transitions to WAITING_FOR_EVIDENCE; resumes context on upload (1 retry limit).</a:t>
             </a:r>
           </a:p>
         </p:txBody>
@@ -9062,8 +8479,8 @@
         </p:nvSpPr>
         <p:spPr>
           <a:xfrm>
-            <a:off x="731520" y="5184648"/>
-            <a:ext cx="10728655" cy="932688"/>
+            <a:off x="731520" y="4992624"/>
+            <a:ext cx="10728655" cy="868680"/>
           </a:xfrm>
           <a:prstGeom prst="rect">
             <a:avLst/>
@@ -9107,8 +8524,8 @@
         </p:nvSpPr>
         <p:spPr>
           <a:xfrm>
-            <a:off x="914400" y="5385816"/>
-            <a:ext cx="2011680" cy="502920"/>
+            <a:off x="914400" y="5212080"/>
+            <a:ext cx="1920240" cy="429768"/>
           </a:xfrm>
           <a:prstGeom prst="rect">
             <a:avLst/>
@@ -9139,7 +8556,7 @@
           <a:lstStyle/>
           <a:p>
             <a:pPr algn="ctr">
-              <a:defRPr sz="1000" b="1">
+              <a:defRPr sz="1050" b="1">
                 <a:solidFill>
                   <a:srgbClr val="065F46"/>
                 </a:solidFill>
@@ -9147,20 +8564,7 @@
               </a:defRPr>
             </a:pPr>
             <a:r>
-              <a:t>CASE 04 · SEQUENCE</a:t>
-            </a:r>
-          </a:p>
-          <a:p>
-            <a:pPr algn="ctr">
-              <a:defRPr sz="900">
-                <a:solidFill>
-                  <a:srgbClr val="065F46"/>
-                </a:solidFill>
-                <a:latin typeface="Inter"/>
-              </a:defRPr>
-            </a:pPr>
-            <a:r>
-              <a:t>Continuity Check</a:t>
+              <a:t>04 · SEQUENCE</a:t>
             </a:r>
           </a:p>
         </p:txBody>
@@ -9173,8 +8577,8 @@
         </p:nvSpPr>
         <p:spPr>
           <a:xfrm>
-            <a:off x="3063240" y="5294376"/>
-            <a:ext cx="3566160" cy="731520"/>
+            <a:off x="2971800" y="5102352"/>
+            <a:ext cx="3749039" cy="640080"/>
           </a:xfrm>
           <a:prstGeom prst="rect">
             <a:avLst/>
@@ -9196,7 +8600,7 @@
               </a:defRPr>
             </a:pPr>
             <a:r>
-              <a:t>Staged continuous take from sealed parcel opening to product reveal · Sequence inspected.</a:t>
+              <a:t>Continuity Uncertain · Staged take from sealed parcel opening to product reveal</a:t>
             </a:r>
           </a:p>
         </p:txBody>
@@ -9209,7 +8613,7 @@
         </p:nvSpPr>
         <p:spPr>
           <a:xfrm>
-            <a:off x="6720840" y="5404104"/>
+            <a:off x="6812280" y="5193792"/>
             <a:ext cx="274320" cy="457200"/>
           </a:xfrm>
           <a:prstGeom prst="rect">
@@ -9245,8 +8649,8 @@
         </p:nvSpPr>
         <p:spPr>
           <a:xfrm>
-            <a:off x="7086600" y="5294376"/>
-            <a:ext cx="4206240" cy="731520"/>
+            <a:off x="7178040" y="5102352"/>
+            <a:ext cx="4114800" cy="640080"/>
           </a:xfrm>
           <a:prstGeom prst="rect">
             <a:avLst/>
@@ -9260,7 +8664,7 @@
           <a:lstStyle/>
           <a:p>
             <a:pPr>
-              <a:defRPr sz="1050" b="1">
+              <a:defRPr sz="1100" b="1">
                 <a:solidFill>
                   <a:srgbClr val="065F46"/>
                 </a:solidFill>
@@ -9268,7 +8672,7 @@
               </a:defRPr>
             </a:pPr>
             <a:r>
-              <a:t>INSPECT CONTINUITY</a:t>
+              <a:t>INSPECT SEQUENCE CONTINUITY</a:t>
             </a:r>
           </a:p>
           <a:p>
@@ -9281,7 +8685,7 @@
               </a:defRPr>
             </a:pPr>
             <a:r>
-              <a:t>Expected prototype behavior: inspect sequence continuity and flag missing transitions for seller review.</a:t>
+              <a:t>Expected prototype behavior: inspects sequence continuity and flags cutaways for seller review.</a:t>
             </a:r>
           </a:p>
         </p:txBody>
@@ -9360,7 +8764,7 @@
               </a:defRPr>
             </a:pPr>
             <a:r>
-              <a:t>Staged prototype scenarios · Expected agent behaviors, not measured production metrics · Cap: min(₹4,999, remaining, paid)</a:t>
+              <a:t>Staged prototype scenarios · Expected agent behaviors, not measured production metrics</a:t>
             </a:r>
           </a:p>
         </p:txBody>
@@ -9471,7 +8875,7 @@
         <p:spPr>
           <a:xfrm>
             <a:off x="731520" y="502920"/>
-            <a:ext cx="7315200" cy="365760"/>
+            <a:ext cx="7315200" cy="320040"/>
           </a:xfrm>
           <a:prstGeom prst="rect">
             <a:avLst/>
@@ -9506,8 +8910,8 @@
         </p:nvSpPr>
         <p:spPr>
           <a:xfrm>
-            <a:off x="731520" y="868680"/>
-            <a:ext cx="10698480" cy="685800"/>
+            <a:off x="731520" y="822960"/>
+            <a:ext cx="10728655" cy="594360"/>
           </a:xfrm>
           <a:prstGeom prst="rect">
             <a:avLst/>
@@ -9542,8 +8946,8 @@
         </p:nvSpPr>
         <p:spPr>
           <a:xfrm>
-            <a:off x="731520" y="1508760"/>
-            <a:ext cx="10698480" cy="411480"/>
+            <a:off x="731520" y="1417320"/>
+            <a:ext cx="10728655" cy="411480"/>
           </a:xfrm>
           <a:prstGeom prst="rect">
             <a:avLst/>
@@ -9557,7 +8961,7 @@
           <a:lstStyle/>
           <a:p>
             <a:pPr>
-              <a:defRPr sz="1800">
+              <a:defRPr sz="1900">
                 <a:solidFill>
                   <a:srgbClr val="596E64"/>
                 </a:solidFill>
@@ -9565,7 +8969,7 @@
               </a:defRPr>
             </a:pPr>
             <a:r>
-              <a:t>Strict scope boundaries and single-threaded ownership make the prototype fully buildable in one day.</a:t>
+              <a:t>Strict scope boundaries and single-threaded ownership make the prototype buildable in one day.</a:t>
             </a:r>
           </a:p>
         </p:txBody>
@@ -9578,8 +8982,51 @@
         </p:nvSpPr>
         <p:spPr>
           <a:xfrm>
-            <a:off x="731520" y="2057400"/>
-            <a:ext cx="2560320" cy="1645920"/>
+            <a:off x="731520" y="2011680"/>
+            <a:ext cx="10728655" cy="36576"/>
+          </a:xfrm>
+          <a:prstGeom prst="rect">
+            <a:avLst/>
+          </a:prstGeom>
+          <a:solidFill>
+            <a:srgbClr val="006B55"/>
+          </a:solidFill>
+          <a:ln>
+            <a:noFill/>
+          </a:ln>
+        </p:spPr>
+        <p:style>
+          <a:lnRef idx="1">
+            <a:schemeClr val="accent1"/>
+          </a:lnRef>
+          <a:fillRef idx="3">
+            <a:schemeClr val="accent1"/>
+          </a:fillRef>
+          <a:effectRef idx="2">
+            <a:schemeClr val="accent1"/>
+          </a:effectRef>
+          <a:fontRef idx="minor">
+            <a:schemeClr val="lt1"/>
+          </a:fontRef>
+        </p:style>
+        <p:txBody>
+          <a:bodyPr rtlCol="0" anchor="ctr"/>
+          <a:lstStyle/>
+          <a:p>
+            <a:pPr algn="ctr"/>
+          </a:p>
+        </p:txBody>
+      </p:sp>
+      <p:sp>
+        <p:nvSpPr>
+          <p:cNvPr id="7" name="Rectangle 6"/>
+          <p:cNvSpPr/>
+          <p:nvPr/>
+        </p:nvSpPr>
+        <p:spPr>
+          <a:xfrm>
+            <a:off x="731520" y="2048256"/>
+            <a:ext cx="2560320" cy="1700784"/>
           </a:xfrm>
           <a:prstGeom prst="rect">
             <a:avLst/>
@@ -9620,7 +9067,7 @@
               </a:defRPr>
             </a:pPr>
             <a:r>
-              <a:t>00h – 06h · FOUNDATION</a:t>
+              <a:t>00–06h · FOUNDATION</a:t>
             </a:r>
           </a:p>
           <a:p>
@@ -9659,51 +9106,8 @@
               </a:defRPr>
             </a:pPr>
             <a:r>
-              <a:t>LangGraph state machine, mock Shopify/Shippo fixtures, order status route, state serialization.</a:t>
-            </a:r>
-          </a:p>
-        </p:txBody>
-      </p:sp>
-      <p:sp>
-        <p:nvSpPr>
-          <p:cNvPr id="7" name="Rectangle 6"/>
-          <p:cNvSpPr/>
-          <p:nvPr/>
-        </p:nvSpPr>
-        <p:spPr>
-          <a:xfrm>
-            <a:off x="731520" y="2057400"/>
-            <a:ext cx="2560320" cy="36576"/>
-          </a:xfrm>
-          <a:prstGeom prst="rect">
-            <a:avLst/>
-          </a:prstGeom>
-          <a:solidFill>
-            <a:srgbClr val="006B55"/>
-          </a:solidFill>
-          <a:ln>
-            <a:noFill/>
-          </a:ln>
-        </p:spPr>
-        <p:style>
-          <a:lnRef idx="1">
-            <a:schemeClr val="accent1"/>
-          </a:lnRef>
-          <a:fillRef idx="3">
-            <a:schemeClr val="accent1"/>
-          </a:fillRef>
-          <a:effectRef idx="2">
-            <a:schemeClr val="accent1"/>
-          </a:effectRef>
-          <a:fontRef idx="minor">
-            <a:schemeClr val="lt1"/>
-          </a:fontRef>
-        </p:style>
-        <p:txBody>
-          <a:bodyPr rtlCol="0" anchor="ctr"/>
-          <a:lstStyle/>
-          <a:p>
-            <a:pPr algn="ctr"/>
+              <a:t>LangGraph state machine, mock store &amp; courier fixtures, order status route.</a:t>
+            </a:r>
           </a:p>
         </p:txBody>
       </p:sp>
@@ -9715,8 +9119,8 @@
         </p:nvSpPr>
         <p:spPr>
           <a:xfrm>
-            <a:off x="3447288" y="2057400"/>
-            <a:ext cx="2560320" cy="1645920"/>
+            <a:off x="3447288" y="2048256"/>
+            <a:ext cx="2560320" cy="1700784"/>
           </a:xfrm>
           <a:prstGeom prst="rect">
             <a:avLst/>
@@ -9757,7 +9161,7 @@
               </a:defRPr>
             </a:pPr>
             <a:r>
-              <a:t>06h – 12h · EVIDENCE</a:t>
+              <a:t>06–12h · EVIDENCE</a:t>
             </a:r>
           </a:p>
           <a:p>
@@ -9796,7 +9200,7 @@
               </a:defRPr>
             </a:pPr>
             <a:r>
-              <a:t>FFmpeg keyframe extraction, vision schema, deterministic rules P-01 to P-08, critic prompt.</a:t>
+              <a:t>FFmpeg keyframe indexer, vision prompt schema, rules P-01 to P-08, critic prompt.</a:t>
             </a:r>
           </a:p>
         </p:txBody>
@@ -9809,51 +9213,8 @@
         </p:nvSpPr>
         <p:spPr>
           <a:xfrm>
-            <a:off x="3447288" y="2057400"/>
-            <a:ext cx="2560320" cy="36576"/>
-          </a:xfrm>
-          <a:prstGeom prst="rect">
-            <a:avLst/>
-          </a:prstGeom>
-          <a:solidFill>
-            <a:srgbClr val="006B55"/>
-          </a:solidFill>
-          <a:ln>
-            <a:noFill/>
-          </a:ln>
-        </p:spPr>
-        <p:style>
-          <a:lnRef idx="1">
-            <a:schemeClr val="accent1"/>
-          </a:lnRef>
-          <a:fillRef idx="3">
-            <a:schemeClr val="accent1"/>
-          </a:fillRef>
-          <a:effectRef idx="2">
-            <a:schemeClr val="accent1"/>
-          </a:effectRef>
-          <a:fontRef idx="minor">
-            <a:schemeClr val="lt1"/>
-          </a:fontRef>
-        </p:style>
-        <p:txBody>
-          <a:bodyPr rtlCol="0" anchor="ctr"/>
-          <a:lstStyle/>
-          <a:p>
-            <a:pPr algn="ctr"/>
-          </a:p>
-        </p:txBody>
-      </p:sp>
-      <p:sp>
-        <p:nvSpPr>
-          <p:cNvPr id="10" name="Rectangle 9"/>
-          <p:cNvSpPr/>
-          <p:nvPr/>
-        </p:nvSpPr>
-        <p:spPr>
-          <a:xfrm>
-            <a:off x="6163056" y="2057400"/>
-            <a:ext cx="2560320" cy="1645920"/>
+            <a:off x="6163056" y="2048256"/>
+            <a:ext cx="2560320" cy="1700784"/>
           </a:xfrm>
           <a:prstGeom prst="rect">
             <a:avLst/>
@@ -9894,7 +9255,7 @@
               </a:defRPr>
             </a:pPr>
             <a:r>
-              <a:t>12h – 18h · INTEGRATION</a:t>
+              <a:t>12–18h · INTEGRATION</a:t>
             </a:r>
           </a:p>
           <a:p>
@@ -9920,7 +9281,7 @@
               </a:defRPr>
             </a:pPr>
             <a:r>
-              <a:t>Person C (Integration) with A/B</a:t>
+              <a:t>Person C (Integration with A/B)</a:t>
             </a:r>
           </a:p>
           <a:p>
@@ -9933,64 +9294,21 @@
               </a:defRPr>
             </a:pPr>
             <a:r>
-              <a:t>Clarification/resume loop, seller console UI, wiring 4 staged demo cases (A–D).</a:t>
-            </a:r>
-          </a:p>
-        </p:txBody>
-      </p:sp>
-      <p:sp>
-        <p:nvSpPr>
-          <p:cNvPr id="11" name="Rectangle 10"/>
+              <a:t>Clarification/resume loop, seller review console UI, wiring 4 staged demo cases.</a:t>
+            </a:r>
+          </a:p>
+        </p:txBody>
+      </p:sp>
+      <p:sp>
+        <p:nvSpPr>
+          <p:cNvPr id="10" name="Rectangle 9"/>
           <p:cNvSpPr/>
           <p:nvPr/>
         </p:nvSpPr>
         <p:spPr>
           <a:xfrm>
-            <a:off x="6163056" y="2057400"/>
-            <a:ext cx="2560320" cy="36576"/>
-          </a:xfrm>
-          <a:prstGeom prst="rect">
-            <a:avLst/>
-          </a:prstGeom>
-          <a:solidFill>
-            <a:srgbClr val="006B55"/>
-          </a:solidFill>
-          <a:ln>
-            <a:noFill/>
-          </a:ln>
-        </p:spPr>
-        <p:style>
-          <a:lnRef idx="1">
-            <a:schemeClr val="accent1"/>
-          </a:lnRef>
-          <a:fillRef idx="3">
-            <a:schemeClr val="accent1"/>
-          </a:fillRef>
-          <a:effectRef idx="2">
-            <a:schemeClr val="accent1"/>
-          </a:effectRef>
-          <a:fontRef idx="minor">
-            <a:schemeClr val="lt1"/>
-          </a:fontRef>
-        </p:style>
-        <p:txBody>
-          <a:bodyPr rtlCol="0" anchor="ctr"/>
-          <a:lstStyle/>
-          <a:p>
-            <a:pPr algn="ctr"/>
-          </a:p>
-        </p:txBody>
-      </p:sp>
-      <p:sp>
-        <p:nvSpPr>
-          <p:cNvPr id="12" name="Rectangle 11"/>
-          <p:cNvSpPr/>
-          <p:nvPr/>
-        </p:nvSpPr>
-        <p:spPr>
-          <a:xfrm>
-            <a:off x="8878824" y="2057400"/>
-            <a:ext cx="2560320" cy="1645920"/>
+            <a:off x="8878824" y="2048256"/>
+            <a:ext cx="2560320" cy="1700784"/>
           </a:xfrm>
           <a:prstGeom prst="rect">
             <a:avLst/>
@@ -10031,7 +9349,7 @@
               </a:defRPr>
             </a:pPr>
             <a:r>
-              <a:t>18h – 24h · VALIDATION</a:t>
+              <a:t>18–24h · VALIDATION</a:t>
             </a:r>
           </a:p>
           <a:p>
@@ -10070,64 +9388,21 @@
               </a:defRPr>
             </a:pPr>
             <a:r>
-              <a:t>Authorization boundary tests, edge cases, fallback validation, demo recording, README.</a:t>
-            </a:r>
-          </a:p>
-        </p:txBody>
-      </p:sp>
-      <p:sp>
-        <p:nvSpPr>
-          <p:cNvPr id="13" name="Rectangle 12"/>
+              <a:t>Authorization safety tests, edge cases, fallback validation, demo video recording.</a:t>
+            </a:r>
+          </a:p>
+        </p:txBody>
+      </p:sp>
+      <p:sp>
+        <p:nvSpPr>
+          <p:cNvPr id="11" name="Rectangle 10"/>
           <p:cNvSpPr/>
           <p:nvPr/>
         </p:nvSpPr>
         <p:spPr>
           <a:xfrm>
-            <a:off x="8878824" y="2057400"/>
-            <a:ext cx="2560320" cy="36576"/>
-          </a:xfrm>
-          <a:prstGeom prst="rect">
-            <a:avLst/>
-          </a:prstGeom>
-          <a:solidFill>
-            <a:srgbClr val="006B55"/>
-          </a:solidFill>
-          <a:ln>
-            <a:noFill/>
-          </a:ln>
-        </p:spPr>
-        <p:style>
-          <a:lnRef idx="1">
-            <a:schemeClr val="accent1"/>
-          </a:lnRef>
-          <a:fillRef idx="3">
-            <a:schemeClr val="accent1"/>
-          </a:fillRef>
-          <a:effectRef idx="2">
-            <a:schemeClr val="accent1"/>
-          </a:effectRef>
-          <a:fontRef idx="minor">
-            <a:schemeClr val="lt1"/>
-          </a:fontRef>
-        </p:style>
-        <p:txBody>
-          <a:bodyPr rtlCol="0" anchor="ctr"/>
-          <a:lstStyle/>
-          <a:p>
-            <a:pPr algn="ctr"/>
-          </a:p>
-        </p:txBody>
-      </p:sp>
-      <p:sp>
-        <p:nvSpPr>
-          <p:cNvPr id="14" name="Rectangle 13"/>
-          <p:cNvSpPr/>
-          <p:nvPr/>
-        </p:nvSpPr>
-        <p:spPr>
-          <a:xfrm>
-            <a:off x="731520" y="3886200"/>
-            <a:ext cx="5257800" cy="2240280"/>
+            <a:off x="731520" y="3977639"/>
+            <a:ext cx="5257800" cy="2103120"/>
           </a:xfrm>
           <a:prstGeom prst="rect">
             <a:avLst/>
@@ -10165,14 +9440,14 @@
       </p:sp>
       <p:sp>
         <p:nvSpPr>
-          <p:cNvPr id="15" name="Rectangle 14"/>
+          <p:cNvPr id="12" name="Rectangle 11"/>
           <p:cNvSpPr/>
           <p:nvPr/>
         </p:nvSpPr>
         <p:spPr>
           <a:xfrm>
-            <a:off x="731520" y="3886200"/>
-            <a:ext cx="73152" cy="2240280"/>
+            <a:off x="731520" y="3977639"/>
+            <a:ext cx="73152" cy="2103120"/>
           </a:xfrm>
           <a:prstGeom prst="rect">
             <a:avLst/>
@@ -10208,14 +9483,14 @@
       </p:sp>
       <p:sp>
         <p:nvSpPr>
-          <p:cNvPr id="16" name="TextBox 15"/>
+          <p:cNvPr id="13" name="TextBox 12"/>
           <p:cNvSpPr txBox="1"/>
           <p:nvPr/>
         </p:nvSpPr>
         <p:spPr>
           <a:xfrm>
-            <a:off x="960120" y="4023360"/>
-            <a:ext cx="4937760" cy="1965960"/>
+            <a:off x="960120" y="4087367"/>
+            <a:ext cx="4937760" cy="1883664"/>
           </a:xfrm>
           <a:prstGeom prst="rect">
             <a:avLst/>
@@ -10322,14 +9597,14 @@
       </p:sp>
       <p:sp>
         <p:nvSpPr>
-          <p:cNvPr id="17" name="Rectangle 16"/>
+          <p:cNvPr id="14" name="Rectangle 13"/>
           <p:cNvSpPr/>
           <p:nvPr/>
         </p:nvSpPr>
         <p:spPr>
           <a:xfrm>
-            <a:off x="6202375" y="3886200"/>
-            <a:ext cx="5257800" cy="2240280"/>
+            <a:off x="6202375" y="3977639"/>
+            <a:ext cx="5257800" cy="2103120"/>
           </a:xfrm>
           <a:prstGeom prst="rect">
             <a:avLst/>
@@ -10367,14 +9642,14 @@
       </p:sp>
       <p:sp>
         <p:nvSpPr>
-          <p:cNvPr id="18" name="Rectangle 17"/>
+          <p:cNvPr id="15" name="Rectangle 14"/>
           <p:cNvSpPr/>
           <p:nvPr/>
         </p:nvSpPr>
         <p:spPr>
           <a:xfrm>
-            <a:off x="6202375" y="3886200"/>
-            <a:ext cx="73152" cy="2240280"/>
+            <a:off x="6202375" y="3977639"/>
+            <a:ext cx="73152" cy="2103120"/>
           </a:xfrm>
           <a:prstGeom prst="rect">
             <a:avLst/>
@@ -10410,14 +9685,14 @@
       </p:sp>
       <p:sp>
         <p:nvSpPr>
-          <p:cNvPr id="19" name="TextBox 18"/>
+          <p:cNvPr id="16" name="TextBox 15"/>
           <p:cNvSpPr txBox="1"/>
           <p:nvPr/>
         </p:nvSpPr>
         <p:spPr>
           <a:xfrm>
-            <a:off x="6430975" y="4023360"/>
-            <a:ext cx="4937760" cy="1965960"/>
+            <a:off x="6430975" y="4087367"/>
+            <a:ext cx="4937760" cy="1883664"/>
           </a:xfrm>
           <a:prstGeom prst="rect">
             <a:avLst/>
@@ -10511,7 +9786,7 @@
       </p:sp>
       <p:sp>
         <p:nvSpPr>
-          <p:cNvPr id="20" name="Rectangle 19"/>
+          <p:cNvPr id="17" name="Rectangle 16"/>
           <p:cNvSpPr/>
           <p:nvPr/>
         </p:nvSpPr>
@@ -10554,7 +9829,7 @@
       </p:sp>
       <p:sp>
         <p:nvSpPr>
-          <p:cNvPr id="21" name="TextBox 20"/>
+          <p:cNvPr id="18" name="TextBox 17"/>
           <p:cNvSpPr txBox="1"/>
           <p:nvPr/>
         </p:nvSpPr>
@@ -10590,7 +9865,7 @@
       </p:sp>
       <p:sp>
         <p:nvSpPr>
-          <p:cNvPr id="22" name="TextBox 21"/>
+          <p:cNvPr id="19" name="TextBox 18"/>
           <p:cNvSpPr txBox="1"/>
           <p:nvPr/>
         </p:nvSpPr>

</xml_diff>

<commit_message>
feat(polish): final judge-ready polish, collision elimination, and typography QA
</commit_message>
<xml_diff>
--- a/ReturnLens_v4.pptx
+++ b/ReturnLens_v4.pptx
@@ -522,7 +522,7 @@
           </a:p>
           <a:p>
             <a:r>
-              <a:t>- Core Friction: Solo sellers spend 15–20 minutes per return opening fragmented tabs (buyer chat, Shopify, Shippo tracking, store return policy). Return decisions are currently made from memory without unified evidence.</a:t>
+              <a:t>- Core Friction: Solo sellers lose valuable hours navigating fragmented tabs (buyer chat, Shopify, Shippo tracking, store return policy). Return decisions are currently made from memory without unified evidence.</a:t>
             </a:r>
           </a:p>
           <a:p>
@@ -532,7 +532,7 @@
           </a:p>
           <a:p>
             <a:r>
-              <a:t>- The Console Mockup showcases our core benchmark (Case B): Buyer ordered White Headphones (HEAD-WHT-02, ₹1,499), but unboxing frame 00:07 reveals a Black item. The agent flags the contradiction and presents actionable choices to the seller.</a:t>
+              <a:t>- Console Focus: Side-by-side comparison between ordered White Headphones (HEAD-WHT-02, ₹1,499) and unboxed Black Headphones (Frame 00:07). The agent flags the contradiction, leaves exact SKU unverified, and surfaces actionable resolution choices to the seller.</a:t>
             </a:r>
           </a:p>
           <a:p>
@@ -612,12 +612,7 @@
           </a:p>
           <a:p>
             <a:r>
-              <a:t>- The returns bottleneck for solo sellers is not an absent returns portal; it is fragmented, unverified context.</a:t>
-            </a:r>
-          </a:p>
-          <a:p>
-            <a:r>
-              <a:t>- The four disconnected sources:</a:t>
+              <a:t>- The returns bottleneck for solo sellers is not an absent returns portal; it is fragmented, unverified context across four disconnected systems:</a:t>
             </a:r>
           </a:p>
           <a:p>
@@ -647,7 +642,7 @@
           </a:p>
           <a:p>
             <a:r>
-              <a:t>- Fraud Context (Sourced definitions): NRF 2025 reports 9% for strictly criminal return fraud, whereas Appriss/Deloitte 2024 reports 15.14% when combining fraud and policy abuse (wardrobing, unboxing swaps). These measure distinct scopes and must never be merged.</a:t>
+              <a:t>- Sourced Fraud Context: NRF 2025 reports 9% for strictly criminal return fraud, whereas Appriss/Deloitte 2024 reports 15.14% when combining fraud and policy abuse (wardrobing, unboxing swaps). These measure distinct scopes and must never be merged.</a:t>
             </a:r>
           </a:p>
           <a:p>
@@ -732,12 +727,12 @@
           </a:p>
           <a:p>
             <a:r>
-              <a:t>- Visual Grounding Honesty: The agent does NOT claim to read an unreadable SKU barcode from frame 00:07. It factually observes: 'Observed Color: Midnight Black · Exact SKU: Not verified · Tag: Not visible in cited frame'.</a:t>
-            </a:r>
-          </a:p>
-          <a:p>
-            <a:r>
-              <a:t>- Decision Logic: Seeing a black item when white was ordered is an undeniable visual contradiction against the manifest. Instead of auto-denying the customer (which might alienate an honest buyer if the warehouse mis-shipped), the policy engine triggers ESCALATE.</a:t>
+              <a:t>- Visual Grounding Honesty: The agent does NOT claim to read an unreadable SKU barcode from frame 00:07. It factually observes: 'Observed Color: Midnight Black · Exact SKU: Not verified · Tag: Not visible in cited frame'. Frame citations provide a traceable reference, not proof of footage authenticity.</a:t>
+            </a:r>
+          </a:p>
+          <a:p>
+            <a:r>
+              <a:t>- Decision Logic: Seeing a black item when white was ordered is an undeniable visual contradiction against the manifest. Instead of auto-denying the customer, the policy engine triggers ESCALATE.</a:t>
             </a:r>
           </a:p>
           <a:p>
@@ -842,12 +837,17 @@
           </a:p>
           <a:p>
             <a:r>
+              <a:t>- Responsibilities: Planner model proposes tool actions; backend code validates JSON schemas; FFmpeg extracts keyframes; vision model generates cited observations; deterministic Python rules evaluate policy P-01 to P-08; seller gate authorizes consequential actions.</a:t>
+            </a:r>
+          </a:p>
+          <a:p>
+            <a:r>
               <a:t>- DEFENSE QUESTION 1: Why is this an agent rather than a hardcoded workflow?</a:t>
             </a:r>
           </a:p>
           <a:p>
             <a:r>
-              <a:t>  ReturnLens is an autonomous state machine with dynamic action selection, multi-modal observation, and stateful lifecycle management. In Case C, when a customer submits a dark/blurry video (average brightness 28), the agent does NOT simply fail or run a static linear chain. It inspects the frames, determines evidence is insufficient under Policy P-05, dynamically decides to invoke ask_for_evidence() with specific re-filming guidance, transitions the ticket to WAITING_FOR_EVIDENCE, pauses execution while retaining state and order context, and resumes the exact triage session when new media arrives. Conversely, for routine order status requests, the agent selects the zero-vision fast path directly querying mock APIs.</a:t>
+              <a:t>  ReturnLens is an autonomous state machine with dynamic action selection, multimodal observation, and stateful lifecycle management. In Case C, when a customer submits a dark or blurry video (average brightness 28), the agent does NOT simply fail or run a static linear chain. It inspects the frames, determines evidence is insufficient under Policy P-05, dynamically decides to invoke ask_for_evidence() with specific re-filming guidance, transitions the ticket to WAITING_FOR_EVIDENCE, pauses execution while retaining state and order context, and resumes the exact triage session when new media arrives. Conversely, for routine order status requests, the agent selects the zero-vision fast path directly querying mock APIs.</a:t>
             </a:r>
           </a:p>
           <a:p>
@@ -867,17 +867,17 @@
           </a:p>
           <a:p>
             <a:r>
-              <a:t>  1. Idempotency keys (hash(order_id, return_id, transaction_type)) prevent double-execution.</a:t>
-            </a:r>
-          </a:p>
-          <a:p>
-            <a:r>
-              <a:t>  2. Ledgers track cumulative refunded amounts against total order value: 0 &lt; amount &lt;= min(₹4,999, remaining_refundable_amount, order_paid_amount).</a:t>
-            </a:r>
-          </a:p>
-          <a:p>
-            <a:r>
-              <a:t>  3. LLMs possess zero capability to call payment gateways directly; all actions produce draft state objects awaiting merchant authorization.</a:t>
+              <a:t>  1. Idempotency keys (hash(order_id, return_id, transaction_type)) with backend uniqueness checks prevent duplicate execution.</a:t>
+            </a:r>
+          </a:p>
+          <a:p>
+            <a:r>
+              <a:t>  2. Ledgers enforce: 0 &lt; amount &lt;= min(₹4,999, remaining_refundable_amount, order_paid_amount).</a:t>
+            </a:r>
+          </a:p>
+          <a:p>
+            <a:r>
+              <a:t>  3. Sequence: Refund proposal -&gt; Code validation -&gt; Seller approval -&gt; Revalidation -&gt; Draft creation -&gt; Receipt -&gt; Release. LLMs possess zero capability to call payment gateways directly.</a:t>
             </a:r>
           </a:p>
         </p:txBody>
@@ -972,7 +972,7 @@
           </a:p>
           <a:p>
             <a:r>
-              <a:t>- Case 04 (Continuity): Expected prototype behavior: inspect parcel-to-product sequence to flag suspicious cut-aways or missing transitions.</a:t>
+              <a:t>- Case 04 (Continuity): Expected prototype behavior: inspect parcel-to-product sequence to flag suspicious cut-aways or missing transitions. Does not claim proven prevention of video manipulation.</a:t>
             </a:r>
           </a:p>
           <a:p>
@@ -1062,22 +1062,22 @@
           </a:p>
           <a:p>
             <a:r>
-              <a:t>  2. Clear division of labor with single-threaded ownership across 3 teammates:</a:t>
-            </a:r>
-          </a:p>
-          <a:p>
-            <a:r>
-              <a:t>     - Person A (Backend &amp; State Machine): LangGraph orchestrator, mock store/courier APIs, order status fast path, state serialization.</a:t>
-            </a:r>
-          </a:p>
-          <a:p>
-            <a:r>
-              <a:t>     - Person B (Video Pipeline &amp; UI): FFmpeg keyframe extraction, deterministic rules P-01 to P-08, critic prompt, seller console.</a:t>
-            </a:r>
-          </a:p>
-          <a:p>
-            <a:r>
-              <a:t>     - Person C (Integration &amp; Validation): Clarification/resume loop, 4 staged demo cases (A-D), authorization boundary tests, demo video recording, README.</a:t>
+              <a:t>  2. Clear division of labor with single-threaded component ownership across 3 teammates:</a:t>
+            </a:r>
+          </a:p>
+          <a:p>
+            <a:r>
+              <a:t>     - Person A (Agent / Backend / Policy / Authorization): LangGraph orchestrator, mock store/courier APIs, order status fast path, deterministic rules P-01 to P-08, fail-closed authorization gate.</a:t>
+            </a:r>
+          </a:p>
+          <a:p>
+            <a:r>
+              <a:t>     - Person B (Vision / Evidence / UI): FFmpeg keyframe extraction, vision schema, critic prompt, seller console UI.</a:t>
+            </a:r>
+          </a:p>
+          <a:p>
+            <a:r>
+              <a:t>     - Person C (Mock Fixtures / Integration / QA): Test fixtures, clarification/resume loop, 4 staged demo cases (A-D), authorization tests, demo video recording, README.</a:t>
             </a:r>
           </a:p>
           <a:p>
@@ -1087,12 +1087,12 @@
           </a:p>
           <a:p>
             <a:r>
-              <a:t>     - NEVER CUT: Core policy engine, frame citations, seller authorization gate, structured audit log, clarification/resume loop, 4 demo cases.</a:t>
-            </a:r>
-          </a:p>
-          <a:p>
-            <a:r>
-              <a:t>     - CUT FIRST IF BEHIND: Real carrier webhooks, multi-product order parsing, video OCR barcode scanning, production payment gateways, seller analytics dashboards.</a:t>
+              <a:t>     - MUST DELIVER: Mock store/courier APIs, deterministic policy engine, frame citations, seller authorization gate, structured audit log, clarification/resume loop, 4 demo cases.</a:t>
+            </a:r>
+          </a:p>
+          <a:p>
+            <a:r>
+              <a:t>     - CUT FIRST IF BEHIND: Case D advanced continuity checks (stretch), real carrier webhooks, multi-product order parsing, video OCR barcode scanning, production payment gateways, seller analytics dashboards.</a:t>
             </a:r>
           </a:p>
           <a:p>
@@ -4154,8 +4154,8 @@
         </p:nvSpPr>
         <p:spPr>
           <a:xfrm>
-            <a:off x="731520" y="731520"/>
-            <a:ext cx="4023360" cy="365760"/>
+            <a:off x="731520" y="685800"/>
+            <a:ext cx="4297680" cy="320040"/>
           </a:xfrm>
           <a:prstGeom prst="rect">
             <a:avLst/>
@@ -4190,8 +4190,8 @@
         </p:nvSpPr>
         <p:spPr>
           <a:xfrm>
-            <a:off x="731520" y="1188720"/>
-            <a:ext cx="4023360" cy="914400"/>
+            <a:off x="731520" y="1051560"/>
+            <a:ext cx="4297680" cy="914400"/>
           </a:xfrm>
           <a:prstGeom prst="rect">
             <a:avLst/>
@@ -4226,8 +4226,8 @@
         </p:nvSpPr>
         <p:spPr>
           <a:xfrm>
-            <a:off x="731520" y="2194560"/>
-            <a:ext cx="4023360" cy="1005840"/>
+            <a:off x="731520" y="2057400"/>
+            <a:ext cx="4297680" cy="914400"/>
           </a:xfrm>
           <a:prstGeom prst="rect">
             <a:avLst/>
@@ -4241,7 +4241,7 @@
           <a:lstStyle/>
           <a:p>
             <a:pPr>
-              <a:defRPr sz="2400" b="1">
+              <a:defRPr sz="2200" b="1">
                 <a:solidFill>
                   <a:srgbClr val="172621"/>
                 </a:solidFill>
@@ -4249,7 +4249,7 @@
               </a:defRPr>
             </a:pPr>
             <a:r>
-              <a:t>Every return decision, backed by evidence.</a:t>
+              <a:t>“Every return decision, backed by evidence.”</a:t>
             </a:r>
           </a:p>
         </p:txBody>
@@ -4262,8 +4262,8 @@
         </p:nvSpPr>
         <p:spPr>
           <a:xfrm>
-            <a:off x="731520" y="3291840"/>
-            <a:ext cx="4023360" cy="1645920"/>
+            <a:off x="731520" y="3063240"/>
+            <a:ext cx="4297680" cy="2011680"/>
           </a:xfrm>
           <a:prstGeom prst="rect">
             <a:avLst/>
@@ -4277,21 +4277,21 @@
           <a:lstStyle/>
           <a:p>
             <a:pPr>
-              <a:defRPr sz="1400">
-                <a:solidFill>
-                  <a:srgbClr val="596E64"/>
+              <a:defRPr sz="1600" b="1">
+                <a:solidFill>
+                  <a:srgbClr val="172621"/>
                 </a:solidFill>
                 <a:latin typeface="Inter"/>
               </a:defRPr>
             </a:pPr>
             <a:r>
-              <a:t>Evidence-backed returns triage for independent online sellers.</a:t>
+              <a:t>Connect customer evidence, order facts and policy — then let the seller decide.</a:t>
             </a:r>
           </a:p>
           <a:p>
             <a:br/>
             <a:pPr>
-              <a:defRPr sz="1300">
+              <a:defRPr sz="1400">
                 <a:solidFill>
                   <a:srgbClr val="596E64"/>
                 </a:solidFill>
@@ -4299,7 +4299,7 @@
               </a:defRPr>
             </a:pPr>
             <a:r>
-              <a:t>When a customer submits an unboxing video, ReturnLens cross-references store truth, verifies deterministic code policies, and gives the solo seller a 1-click decision console.</a:t>
+              <a:t>ReturnLens unifies unboxing video evidence, store truth, and policy checks into a 1-click decision console for solo merchants.</a:t>
             </a:r>
           </a:p>
         </p:txBody>
@@ -4312,8 +4312,8 @@
         </p:nvSpPr>
         <p:spPr>
           <a:xfrm>
-            <a:off x="731520" y="5303520"/>
-            <a:ext cx="4023360" cy="457200"/>
+            <a:off x="731520" y="5532120"/>
+            <a:ext cx="4297680" cy="365760"/>
           </a:xfrm>
           <a:prstGeom prst="rect">
             <a:avLst/>
@@ -4327,15 +4327,15 @@
           <a:lstStyle/>
           <a:p>
             <a:pPr>
-              <a:defRPr sz="1000" b="1">
-                <a:solidFill>
-                  <a:srgbClr val="7A8E85"/>
+              <a:defRPr sz="1100" b="1">
+                <a:solidFill>
+                  <a:srgbClr val="006B55"/>
                 </a:solidFill>
                 <a:latin typeface="IBM Plex Mono"/>
               </a:defRPr>
             </a:pPr>
             <a:r>
-              <a:t>Team Rookie (3 Members) · 24-Hour Prototype Feasibility</a:t>
+              <a:t>Team Rookie · AgentX PS-04 · 24h Prototype</a:t>
             </a:r>
           </a:p>
         </p:txBody>
@@ -4348,8 +4348,8 @@
         </p:nvSpPr>
         <p:spPr>
           <a:xfrm>
-            <a:off x="5166360" y="685800"/>
-            <a:ext cx="6293815" cy="5349240"/>
+            <a:off x="5349240" y="685800"/>
+            <a:ext cx="6110935" cy="5349240"/>
           </a:xfrm>
           <a:prstGeom prst="rect">
             <a:avLst/>
@@ -4393,8 +4393,8 @@
         </p:nvSpPr>
         <p:spPr>
           <a:xfrm>
-            <a:off x="5166360" y="685800"/>
-            <a:ext cx="6293815" cy="457200"/>
+            <a:off x="5349240" y="685800"/>
+            <a:ext cx="6110935" cy="457200"/>
           </a:xfrm>
           <a:prstGeom prst="rect">
             <a:avLst/>
@@ -4425,7 +4425,7 @@
           <a:lstStyle/>
           <a:p>
             <a:pPr algn="ctr">
-              <a:defRPr sz="1000" b="1">
+              <a:defRPr sz="1100" b="1">
                 <a:solidFill>
                   <a:srgbClr val="00D1A7"/>
                 </a:solidFill>
@@ -4454,8 +4454,8 @@
         </p:blipFill>
         <p:spPr>
           <a:xfrm>
-            <a:off x="5349240" y="1280160"/>
-            <a:ext cx="2880360" cy="1920240"/>
+            <a:off x="5532120" y="1280160"/>
+            <a:ext cx="2788920" cy="1965960"/>
           </a:xfrm>
           <a:prstGeom prst="rect">
             <a:avLst/>
@@ -4470,8 +4470,8 @@
         </p:nvSpPr>
         <p:spPr>
           <a:xfrm>
-            <a:off x="5349240" y="3246120"/>
-            <a:ext cx="2880360" cy="292608"/>
+            <a:off x="5532120" y="3291840"/>
+            <a:ext cx="2788920" cy="320040"/>
           </a:xfrm>
           <a:prstGeom prst="rect">
             <a:avLst/>
@@ -4498,11 +4498,11 @@
           </a:fontRef>
         </p:style>
         <p:txBody>
-          <a:bodyPr rtlCol="0" anchor="ctr"/>
+          <a:bodyPr rtlCol="0" anchor="ctr" lIns="18288" rIns="18288"/>
           <a:lstStyle/>
           <a:p>
             <a:pPr algn="ctr">
-              <a:defRPr sz="850" b="1">
+              <a:defRPr sz="1050" b="1">
                 <a:solidFill>
                   <a:srgbClr val="006B55"/>
                 </a:solidFill>
@@ -4531,8 +4531,8 @@
         </p:blipFill>
         <p:spPr>
           <a:xfrm>
-            <a:off x="8396935" y="1280160"/>
-            <a:ext cx="2880360" cy="1920240"/>
+            <a:off x="8488375" y="1280160"/>
+            <a:ext cx="2788920" cy="1965960"/>
           </a:xfrm>
           <a:prstGeom prst="rect">
             <a:avLst/>
@@ -4547,8 +4547,8 @@
         </p:nvSpPr>
         <p:spPr>
           <a:xfrm>
-            <a:off x="8396935" y="3246120"/>
-            <a:ext cx="2880360" cy="292608"/>
+            <a:off x="8488375" y="3291840"/>
+            <a:ext cx="2788920" cy="320040"/>
           </a:xfrm>
           <a:prstGeom prst="rect">
             <a:avLst/>
@@ -4575,11 +4575,11 @@
           </a:fontRef>
         </p:style>
         <p:txBody>
-          <a:bodyPr rtlCol="0" anchor="ctr"/>
+          <a:bodyPr rtlCol="0" anchor="ctr" lIns="18288" rIns="18288"/>
           <a:lstStyle/>
           <a:p>
             <a:pPr algn="ctr">
-              <a:defRPr sz="850" b="1">
+              <a:defRPr sz="1000" b="1">
                 <a:solidFill>
                   <a:srgbClr val="991B1B"/>
                 </a:solidFill>
@@ -4600,8 +4600,8 @@
         </p:nvSpPr>
         <p:spPr>
           <a:xfrm>
-            <a:off x="5349240" y="3639312"/>
-            <a:ext cx="5928055" cy="658368"/>
+            <a:off x="5532120" y="3721608"/>
+            <a:ext cx="5745175" cy="658368"/>
           </a:xfrm>
           <a:prstGeom prst="rect">
             <a:avLst/>
@@ -4634,7 +4634,7 @@
           <a:lstStyle/>
           <a:p>
             <a:pPr algn="ctr">
-              <a:defRPr sz="950" b="1">
+              <a:defRPr sz="1150" b="1">
                 <a:solidFill>
                   <a:srgbClr val="991B1B"/>
                 </a:solidFill>
@@ -4647,7 +4647,7 @@
           </a:p>
           <a:p>
             <a:pPr>
-              <a:defRPr sz="950">
+              <a:defRPr sz="1150">
                 <a:solidFill>
                   <a:srgbClr val="991B1B"/>
                 </a:solidFill>
@@ -4655,7 +4655,7 @@
               </a:defRPr>
             </a:pPr>
             <a:r>
-              <a:t>P-04 Return Window: PASS (Day 4 of 7)  |  P-03 Manifest Match: CONTRADICTION FLAGGED</a:t>
+              <a:t>P-04 Return Window: PASS (Day 4 of 7)  |  P-03 Manifest: CONTRADICTION FLAGGED</a:t>
             </a:r>
           </a:p>
         </p:txBody>
@@ -4668,8 +4668,8 @@
         </p:nvSpPr>
         <p:spPr>
           <a:xfrm>
-            <a:off x="5349240" y="4370832"/>
-            <a:ext cx="5928055" cy="365760"/>
+            <a:off x="5532120" y="4453128"/>
+            <a:ext cx="5745175" cy="384048"/>
           </a:xfrm>
           <a:prstGeom prst="rect">
             <a:avLst/>
@@ -4700,7 +4700,7 @@
           <a:lstStyle/>
           <a:p>
             <a:pPr algn="ctr">
-              <a:defRPr sz="950" b="1">
+              <a:defRPr sz="1200" b="1">
                 <a:solidFill>
                   <a:srgbClr val="92400E"/>
                 </a:solidFill>
@@ -4708,7 +4708,7 @@
               </a:defRPr>
             </a:pPr>
             <a:r>
-              <a:t>STATUS: ESCALATED FOR SELLER DECISION (HUMAN GATE)</a:t>
+              <a:t>SELLER REVIEW REQUIRED (HUMAN GATE)</a:t>
             </a:r>
           </a:p>
         </p:txBody>
@@ -4721,8 +4721,8 @@
         </p:nvSpPr>
         <p:spPr>
           <a:xfrm>
-            <a:off x="5349240" y="4809744"/>
-            <a:ext cx="5928055" cy="502920"/>
+            <a:off x="5532120" y="4910328"/>
+            <a:ext cx="5745175" cy="502920"/>
           </a:xfrm>
           <a:prstGeom prst="rect">
             <a:avLst/>
@@ -4753,7 +4753,7 @@
           <a:lstStyle/>
           <a:p>
             <a:pPr algn="ctr">
-              <a:defRPr sz="1300" b="1">
+              <a:defRPr sz="1400" b="1">
                 <a:solidFill>
                   <a:srgbClr val="FFFFFF"/>
                 </a:solidFill>
@@ -5092,7 +5092,7 @@
           <a:lstStyle/>
           <a:p>
             <a:pPr algn="ctr">
-              <a:defRPr sz="950" b="1">
+              <a:defRPr sz="1100" b="1">
                 <a:solidFill>
                   <a:srgbClr val="006B55"/>
                 </a:solidFill>
@@ -5105,7 +5105,7 @@
           </a:p>
           <a:p>
             <a:pPr>
-              <a:defRPr sz="1100">
+              <a:defRPr sz="1300">
                 <a:solidFill>
                   <a:srgbClr val="172621"/>
                 </a:solidFill>
@@ -5160,7 +5160,7 @@
           <a:lstStyle/>
           <a:p>
             <a:pPr algn="ctr">
-              <a:defRPr sz="950" b="1">
+              <a:defRPr sz="1100" b="1">
                 <a:solidFill>
                   <a:srgbClr val="006B55"/>
                 </a:solidFill>
@@ -5173,7 +5173,7 @@
           </a:p>
           <a:p>
             <a:pPr>
-              <a:defRPr sz="1100">
+              <a:defRPr sz="1300">
                 <a:solidFill>
                   <a:srgbClr val="172621"/>
                 </a:solidFill>
@@ -5228,7 +5228,7 @@
           <a:lstStyle/>
           <a:p>
             <a:pPr algn="ctr">
-              <a:defRPr sz="950" b="1">
+              <a:defRPr sz="1100" b="1">
                 <a:solidFill>
                   <a:srgbClr val="006B55"/>
                 </a:solidFill>
@@ -5241,7 +5241,7 @@
           </a:p>
           <a:p>
             <a:pPr>
-              <a:defRPr sz="1100">
+              <a:defRPr sz="1300">
                 <a:solidFill>
                   <a:srgbClr val="172621"/>
                 </a:solidFill>
@@ -5296,7 +5296,7 @@
           <a:lstStyle/>
           <a:p>
             <a:pPr algn="ctr">
-              <a:defRPr sz="950" b="1">
+              <a:defRPr sz="1100" b="1">
                 <a:solidFill>
                   <a:srgbClr val="006B55"/>
                 </a:solidFill>
@@ -5309,7 +5309,7 @@
           </a:p>
           <a:p>
             <a:pPr>
-              <a:defRPr sz="1100">
+              <a:defRPr sz="1300">
                 <a:solidFill>
                   <a:srgbClr val="172621"/>
                 </a:solidFill>
@@ -5345,7 +5345,7 @@
           <a:lstStyle/>
           <a:p>
             <a:pPr>
-              <a:defRPr sz="2800" b="1">
+              <a:defRPr sz="3200" b="1">
                 <a:solidFill>
                   <a:srgbClr val="D95D39"/>
                 </a:solidFill>
@@ -5400,7 +5400,7 @@
           <a:lstStyle/>
           <a:p>
             <a:pPr algn="ctr">
-              <a:defRPr sz="1100" b="1">
+              <a:defRPr sz="1200" b="1">
                 <a:solidFill>
                   <a:srgbClr val="D95D39"/>
                 </a:solidFill>
@@ -5413,7 +5413,7 @@
           </a:p>
           <a:p>
             <a:pPr algn="ctr">
-              <a:defRPr sz="2200" b="1">
+              <a:defRPr sz="2600" b="1">
                 <a:solidFill>
                   <a:srgbClr val="F5F3EF"/>
                 </a:solidFill>
@@ -5427,7 +5427,7 @@
           <a:p>
             <a:br/>
             <a:pPr algn="ctr">
-              <a:defRPr sz="1500" b="1" i="1">
+              <a:defRPr sz="1800" b="1" i="1">
                 <a:solidFill>
                   <a:srgbClr val="FBBF24"/>
                 </a:solidFill>
@@ -5441,7 +5441,21 @@
           <a:p>
             <a:br/>
             <a:pPr algn="ctr">
-              <a:defRPr sz="1150">
+              <a:defRPr sz="1500" b="1">
+                <a:solidFill>
+                  <a:srgbClr val="F5F3EF"/>
+                </a:solidFill>
+                <a:latin typeface="Inter"/>
+              </a:defRPr>
+            </a:pPr>
+            <a:r>
+              <a:t>Four disconnected sources. One seller making the call.</a:t>
+            </a:r>
+          </a:p>
+          <a:p>
+            <a:br/>
+            <a:pPr algn="ctr">
+              <a:defRPr sz="1300">
                 <a:solidFill>
                   <a:srgbClr val="D1D5DB"/>
                 </a:solidFill>
@@ -5449,12 +5463,7 @@
               </a:defRPr>
             </a:pPr>
             <a:r>
-              <a:t>Today the seller opens 4 tabs and guesses. An erroneous refund burns inventory margin; an unfair denial destroys repeat customer trust.</a:t>
-            </a:r>
-            <a:br/>
-            <a:br/>
-            <a:r>
-              <a:t>The gap is not a missing return portal — it is the lack of an immutable trace linking order truth, video keyframes, and policy terms before money moves.</a:t>
+              <a:t>The gap is the absence of an auditable artifact linking order truth, video keyframes, and policy before money moves.</a:t>
             </a:r>
           </a:p>
         </p:txBody>
@@ -5752,7 +5761,7 @@
         <p:spPr>
           <a:xfrm>
             <a:off x="731520" y="1965960"/>
-            <a:ext cx="7132320" cy="4069080"/>
+            <a:ext cx="6949440" cy="4069080"/>
           </a:xfrm>
           <a:prstGeom prst="rect">
             <a:avLst/>
@@ -5805,7 +5814,7 @@
         <p:spPr>
           <a:xfrm>
             <a:off x="914400" y="2148840"/>
-            <a:ext cx="3291840" cy="2651760"/>
+            <a:ext cx="3200400" cy="2606040"/>
           </a:xfrm>
           <a:prstGeom prst="rect">
             <a:avLst/>
@@ -5828,8 +5837,8 @@
         </p:blipFill>
         <p:spPr>
           <a:xfrm>
-            <a:off x="4389120" y="2148840"/>
-            <a:ext cx="3291840" cy="2651760"/>
+            <a:off x="4297680" y="2148840"/>
+            <a:ext cx="3200400" cy="2606040"/>
           </a:xfrm>
           <a:prstGeom prst="rect">
             <a:avLst/>
@@ -5844,8 +5853,8 @@
         </p:nvSpPr>
         <p:spPr>
           <a:xfrm>
-            <a:off x="914400" y="4873752"/>
-            <a:ext cx="3291840" cy="320040"/>
+            <a:off x="914400" y="4846320"/>
+            <a:ext cx="3200400" cy="347472"/>
           </a:xfrm>
           <a:prstGeom prst="rect">
             <a:avLst/>
@@ -5876,7 +5885,7 @@
           <a:lstStyle/>
           <a:p>
             <a:pPr algn="ctr">
-              <a:defRPr sz="900" b="1">
+              <a:defRPr sz="1100" b="1">
                 <a:solidFill>
                   <a:srgbClr val="006B55"/>
                 </a:solidFill>
@@ -5897,8 +5906,8 @@
         </p:nvSpPr>
         <p:spPr>
           <a:xfrm>
-            <a:off x="4389120" y="4873752"/>
-            <a:ext cx="3291840" cy="320040"/>
+            <a:off x="4297680" y="4846320"/>
+            <a:ext cx="3200400" cy="347472"/>
           </a:xfrm>
           <a:prstGeom prst="rect">
             <a:avLst/>
@@ -5929,7 +5938,7 @@
           <a:lstStyle/>
           <a:p>
             <a:pPr algn="ctr">
-              <a:defRPr sz="900" b="1">
+              <a:defRPr sz="1100" b="1">
                 <a:solidFill>
                   <a:srgbClr val="991B1B"/>
                 </a:solidFill>
@@ -5950,8 +5959,8 @@
         </p:nvSpPr>
         <p:spPr>
           <a:xfrm>
-            <a:off x="914400" y="5257800"/>
-            <a:ext cx="6766560" cy="685800"/>
+            <a:off x="914400" y="5303520"/>
+            <a:ext cx="6583680" cy="594360"/>
           </a:xfrm>
           <a:prstGeom prst="rect">
             <a:avLst/>
@@ -5965,7 +5974,7 @@
           <a:lstStyle/>
           <a:p>
             <a:pPr>
-              <a:defRPr sz="1000">
+              <a:defRPr sz="1300" b="1">
                 <a:solidFill>
                   <a:srgbClr val="596E64"/>
                 </a:solidFill>
@@ -5973,7 +5982,20 @@
               </a:defRPr>
             </a:pPr>
             <a:r>
-              <a:t>Visual Grounding Honesty: Keyframe resolution proves black casing. Exact SKU barcode is unreadable in this frame; ReturnLens factually records 'Observed Color: Black · Exact SKU: Not verified' and cites frame 00:07.</a:t>
+              <a:t>Visual Grounding: Keyframe 00:07 confirms black casing. Exact SKU barcode is unverified in this frame.</a:t>
+            </a:r>
+          </a:p>
+          <a:p>
+            <a:pPr>
+              <a:defRPr sz="1150">
+                <a:solidFill>
+                  <a:srgbClr val="7A8E85"/>
+                </a:solidFill>
+                <a:latin typeface="Inter"/>
+              </a:defRPr>
+            </a:pPr>
+            <a:r>
+              <a:t>Frame citation provides a traceable timestamped reference, not absolute proof of video authenticity.</a:t>
             </a:r>
           </a:p>
         </p:txBody>
@@ -5986,8 +6008,8 @@
         </p:nvSpPr>
         <p:spPr>
           <a:xfrm>
-            <a:off x="8119872" y="1965960"/>
-            <a:ext cx="3340303" cy="4069080"/>
+            <a:off x="7955279" y="1965960"/>
+            <a:ext cx="3504895" cy="4069080"/>
           </a:xfrm>
           <a:prstGeom prst="rect">
             <a:avLst/>
@@ -6031,8 +6053,8 @@
         </p:nvSpPr>
         <p:spPr>
           <a:xfrm>
-            <a:off x="8302752" y="2103120"/>
-            <a:ext cx="2974543" cy="3794760"/>
+            <a:off x="8183879" y="2148840"/>
+            <a:ext cx="3047695" cy="3703320"/>
           </a:xfrm>
           <a:prstGeom prst="rect">
             <a:avLst/>
@@ -6046,7 +6068,7 @@
           <a:lstStyle/>
           <a:p>
             <a:pPr>
-              <a:defRPr sz="950" b="1">
+              <a:defRPr sz="1100" b="1">
                 <a:solidFill>
                   <a:srgbClr val="D95D39"/>
                 </a:solidFill>
@@ -6059,7 +6081,7 @@
           </a:p>
           <a:p>
             <a:pPr>
-              <a:defRPr sz="1600" b="1">
+              <a:defRPr sz="2200" b="1">
                 <a:solidFill>
                   <a:srgbClr val="991B1B"/>
                 </a:solidFill>
@@ -6067,26 +6089,13 @@
               </a:defRPr>
             </a:pPr>
             <a:r>
-              <a:t>P-03: COLOR CONTRADICTION</a:t>
-            </a:r>
-          </a:p>
-          <a:p>
-            <a:pPr>
-              <a:defRPr sz="950" b="1">
-                <a:solidFill>
-                  <a:srgbClr val="991B1B"/>
-                </a:solidFill>
-                <a:latin typeface="IBM Plex Mono"/>
-              </a:defRPr>
-            </a:pPr>
-            <a:r>
-              <a:t>STATUS: SELLER REVIEW REQUIRED</a:t>
+              <a:t>COLOR CONTRADICTION</a:t>
             </a:r>
           </a:p>
           <a:p>
             <a:br/>
             <a:pPr>
-              <a:defRPr sz="1100" b="1">
+              <a:defRPr sz="1500" b="1">
                 <a:solidFill>
                   <a:srgbClr val="172621"/>
                 </a:solidFill>
@@ -6094,120 +6103,149 @@
               </a:defRPr>
             </a:pPr>
             <a:r>
-              <a:t>Key Findings:</a:t>
-            </a:r>
-          </a:p>
-          <a:p>
+              <a:t>• ORDERED — Matte White</a:t>
+            </a:r>
+          </a:p>
+          <a:p>
+            <a:pPr>
+              <a:defRPr sz="1500" b="1">
+                <a:solidFill>
+                  <a:srgbClr val="991B1B"/>
+                </a:solidFill>
+                <a:latin typeface="Inter"/>
+              </a:defRPr>
+            </a:pPr>
+            <a:r>
+              <a:t>• OBSERVED — Midnight Black</a:t>
+            </a:r>
+          </a:p>
+          <a:p>
+            <a:pPr>
+              <a:defRPr sz="1400" b="1">
+                <a:solidFill>
+                  <a:srgbClr val="596E64"/>
+                </a:solidFill>
+                <a:latin typeface="Inter"/>
+              </a:defRPr>
+            </a:pPr>
+            <a:r>
+              <a:t>• EXACT SKU — Not verified</a:t>
+            </a:r>
+          </a:p>
+        </p:txBody>
+      </p:sp>
+      <p:sp>
+        <p:nvSpPr>
+          <p:cNvPr id="14" name="Rectangle 13"/>
+          <p:cNvSpPr/>
+          <p:nvPr/>
+        </p:nvSpPr>
+        <p:spPr>
+          <a:xfrm>
+            <a:off x="8183879" y="4434840"/>
+            <a:ext cx="3047695" cy="548640"/>
+          </a:xfrm>
+          <a:prstGeom prst="rect">
+            <a:avLst/>
+          </a:prstGeom>
+          <a:solidFill>
+            <a:srgbClr val="FCECE8"/>
+          </a:solidFill>
+          <a:ln w="19050">
+            <a:solidFill>
+              <a:srgbClr val="D95D39"/>
+            </a:solidFill>
+          </a:ln>
+        </p:spPr>
+        <p:style>
+          <a:lnRef idx="1">
+            <a:schemeClr val="accent1"/>
+          </a:lnRef>
+          <a:fillRef idx="3">
+            <a:schemeClr val="accent1"/>
+          </a:fillRef>
+          <a:effectRef idx="2">
+            <a:schemeClr val="accent1"/>
+          </a:effectRef>
+          <a:fontRef idx="minor">
+            <a:schemeClr val="lt1"/>
+          </a:fontRef>
+        </p:style>
+        <p:txBody>
+          <a:bodyPr rtlCol="0" anchor="ctr"/>
+          <a:lstStyle/>
+          <a:p>
+            <a:pPr algn="ctr">
+              <a:defRPr sz="1400" b="1">
+                <a:solidFill>
+                  <a:srgbClr val="991B1B"/>
+                </a:solidFill>
+                <a:latin typeface="IBM Plex Mono"/>
+              </a:defRPr>
+            </a:pPr>
+            <a:r>
+              <a:t>SELLER REVIEW REQUIRED</a:t>
+            </a:r>
+          </a:p>
+        </p:txBody>
+      </p:sp>
+      <p:sp>
+        <p:nvSpPr>
+          <p:cNvPr id="15" name="TextBox 14"/>
+          <p:cNvSpPr txBox="1"/>
+          <p:nvPr/>
+        </p:nvSpPr>
+        <p:spPr>
+          <a:xfrm>
+            <a:off x="8183879" y="5120640"/>
+            <a:ext cx="3047695" cy="731520"/>
+          </a:xfrm>
+          <a:prstGeom prst="rect">
+            <a:avLst/>
+          </a:prstGeom>
+          <a:noFill/>
+        </p:spPr>
+        <p:txBody>
+          <a:bodyPr wrap="square">
+            <a:spAutoFit/>
+          </a:bodyPr>
+          <a:lstStyle/>
+          <a:p>
+            <a:pPr>
+              <a:defRPr sz="1300" b="1">
+                <a:solidFill>
+                  <a:srgbClr val="172621"/>
+                </a:solidFill>
+                <a:latin typeface="Inter"/>
+              </a:defRPr>
+            </a:pPr>
+            <a:r>
+              <a:t>No automatic denial or refund without seller authorization.</a:t>
+            </a:r>
+          </a:p>
+          <a:p>
+            <a:br/>
             <a:pPr>
               <a:defRPr sz="1000">
                 <a:solidFill>
                   <a:srgbClr val="596E64"/>
                 </a:solidFill>
-                <a:latin typeface="Inter"/>
-              </a:defRPr>
-            </a:pPr>
-            <a:r>
-              <a:t>• OBSERVED: Midnight Black</a:t>
-            </a:r>
-          </a:p>
-          <a:p>
-            <a:pPr>
-              <a:defRPr sz="1000">
-                <a:solidFill>
-                  <a:srgbClr val="596E64"/>
-                </a:solidFill>
-                <a:latin typeface="Inter"/>
-              </a:defRPr>
-            </a:pPr>
-            <a:r>
-              <a:t>• UNVERIFIED: Exact SKU barcode</a:t>
-            </a:r>
-          </a:p>
-          <a:p>
-            <a:pPr>
-              <a:defRPr sz="1000">
-                <a:solidFill>
-                  <a:srgbClr val="596E64"/>
-                </a:solidFill>
-                <a:latin typeface="Inter"/>
-              </a:defRPr>
-            </a:pPr>
-            <a:r>
-              <a:t>• NEXT ACTION: Seller review</a:t>
-            </a:r>
-          </a:p>
-          <a:p>
+                <a:latin typeface="IBM Plex Mono"/>
+              </a:defRPr>
+            </a:pPr>
+            <a:r>
+              <a:t>Financial safety ceiling:</a:t>
+            </a:r>
             <a:br/>
-            <a:pPr>
-              <a:defRPr sz="1100" b="1">
-                <a:solidFill>
-                  <a:srgbClr val="172621"/>
-                </a:solidFill>
-                <a:latin typeface="Inter"/>
-              </a:defRPr>
-            </a:pPr>
-            <a:r>
-              <a:t>Seller Resolution Options:</a:t>
-            </a:r>
-          </a:p>
-          <a:p>
-            <a:pPr>
-              <a:defRPr sz="950">
-                <a:solidFill>
-                  <a:srgbClr val="596E64"/>
-                </a:solidFill>
-                <a:latin typeface="Inter"/>
-              </a:defRPr>
-            </a:pPr>
-            <a:r>
-              <a:t>1. Request unboxing box label photo</a:t>
-            </a:r>
-          </a:p>
-          <a:p>
-            <a:pPr>
-              <a:defRPr sz="950">
-                <a:solidFill>
-                  <a:srgbClr val="596E64"/>
-                </a:solidFill>
-                <a:latin typeface="Inter"/>
-              </a:defRPr>
-            </a:pPr>
-            <a:r>
-              <a:t>2. Reject return (item does not match order)</a:t>
-            </a:r>
-          </a:p>
-          <a:p>
-            <a:pPr>
-              <a:defRPr sz="950">
-                <a:solidFill>
-                  <a:srgbClr val="596E64"/>
-                </a:solidFill>
-                <a:latin typeface="Inter"/>
-              </a:defRPr>
-            </a:pPr>
-            <a:r>
-              <a:t>3. Override &amp; approve (warehouse error)</a:t>
-            </a:r>
-          </a:p>
-          <a:p>
-            <a:br/>
-            <a:pPr>
-              <a:defRPr sz="900" b="1">
-                <a:solidFill>
-                  <a:srgbClr val="596E64"/>
-                </a:solidFill>
-                <a:latin typeface="IBM Plex Mono"/>
-              </a:defRPr>
-            </a:pPr>
-            <a:r>
-              <a:t>No auto-denial · No refund without seller click</a:t>
-            </a:r>
-          </a:p>
-        </p:txBody>
-      </p:sp>
-      <p:sp>
-        <p:nvSpPr>
-          <p:cNvPr id="14" name="Rectangle 13"/>
+            <a:r>
+              <a:t>0 &lt; amount &lt;= min(₹4,999, remaining, paid)</a:t>
+            </a:r>
+          </a:p>
+        </p:txBody>
+      </p:sp>
+      <p:sp>
+        <p:nvSpPr>
+          <p:cNvPr id="16" name="Rectangle 15"/>
           <p:cNvSpPr/>
           <p:nvPr/>
         </p:nvSpPr>
@@ -6250,7 +6288,7 @@
       </p:sp>
       <p:sp>
         <p:nvSpPr>
-          <p:cNvPr id="15" name="TextBox 14"/>
+          <p:cNvPr id="17" name="TextBox 16"/>
           <p:cNvSpPr txBox="1"/>
           <p:nvPr/>
         </p:nvSpPr>
@@ -6279,14 +6317,14 @@
               </a:defRPr>
             </a:pPr>
             <a:r>
-              <a:t>Illustrative staged evidence · Mock Shopify &amp; Shippo APIs</a:t>
-            </a:r>
-          </a:p>
-        </p:txBody>
-      </p:sp>
-      <p:sp>
-        <p:nvSpPr>
-          <p:cNvPr id="16" name="TextBox 15"/>
+              <a:t>Illustrative staged evidence · Exact SKU: Not verified · Mock Shopify &amp; Shippo APIs</a:t>
+            </a:r>
+          </a:p>
+        </p:txBody>
+      </p:sp>
+      <p:sp>
+        <p:nvSpPr>
+          <p:cNvPr id="18" name="TextBox 17"/>
           <p:cNvSpPr txBox="1"/>
           <p:nvPr/>
         </p:nvSpPr>
@@ -6476,7 +6514,7 @@
           <a:lstStyle/>
           <a:p>
             <a:pPr>
-              <a:defRPr sz="1900">
+              <a:defRPr sz="1800">
                 <a:solidFill>
                   <a:srgbClr val="A3B8B0"/>
                 </a:solidFill>
@@ -6531,7 +6569,7 @@
           <a:lstStyle/>
           <a:p>
             <a:pPr algn="ctr">
-              <a:defRPr sz="950" b="1">
+              <a:defRPr sz="1200" b="1">
                 <a:solidFill>
                   <a:srgbClr val="00D1A7"/>
                 </a:solidFill>
@@ -6539,12 +6577,12 @@
               </a:defRPr>
             </a:pPr>
             <a:r>
-              <a:t>01 MODEL ZONE</a:t>
+              <a:t>MODEL</a:t>
             </a:r>
           </a:p>
           <a:p>
             <a:pPr>
-              <a:defRPr sz="1300" b="1">
+              <a:defRPr sz="1550" b="1">
                 <a:solidFill>
                   <a:srgbClr val="F5F3EF"/>
                 </a:solidFill>
@@ -6552,12 +6590,12 @@
               </a:defRPr>
             </a:pPr>
             <a:r>
-              <a:t>Plan &amp; Observe</a:t>
+              <a:t>Plan and observe</a:t>
             </a:r>
           </a:p>
           <a:p>
             <a:pPr>
-              <a:defRPr sz="950">
+              <a:defRPr sz="1200">
                 <a:solidFill>
                   <a:srgbClr val="A3B8B0"/>
                 </a:solidFill>
@@ -6565,7 +6603,7 @@
               </a:defRPr>
             </a:pPr>
             <a:r>
-              <a:t>Planner validates JSON schema · Vision extracts keyframes &amp; non-binding visual metadata.</a:t>
+              <a:t>Planner proposes typed actions · Vision model generates cited observations.</a:t>
             </a:r>
           </a:p>
         </p:txBody>
@@ -6622,7 +6660,7 @@
         <p:spPr>
           <a:xfrm>
             <a:off x="4242816" y="1965960"/>
-            <a:ext cx="3840480" cy="1234440"/>
+            <a:ext cx="3931920" cy="1234440"/>
           </a:xfrm>
           <a:prstGeom prst="rect">
             <a:avLst/>
@@ -6655,7 +6693,7 @@
           <a:lstStyle/>
           <a:p>
             <a:pPr algn="ctr">
-              <a:defRPr sz="950" b="1">
+              <a:defRPr sz="1200" b="1">
                 <a:solidFill>
                   <a:srgbClr val="F5F3EF"/>
                 </a:solidFill>
@@ -6663,12 +6701,12 @@
               </a:defRPr>
             </a:pPr>
             <a:r>
-              <a:t>02 CODE ZONE</a:t>
+              <a:t>CODE</a:t>
             </a:r>
           </a:p>
           <a:p>
             <a:pPr>
-              <a:defRPr sz="1300" b="1">
+              <a:defRPr sz="1550" b="1">
                 <a:solidFill>
                   <a:srgbClr val="F5F3EF"/>
                 </a:solidFill>
@@ -6676,12 +6714,12 @@
               </a:defRPr>
             </a:pPr>
             <a:r>
-              <a:t>Retrieve &amp; Enforce Policy</a:t>
+              <a:t>Retrieve, validate and enforce rules</a:t>
             </a:r>
           </a:p>
           <a:p>
             <a:pPr>
-              <a:defRPr sz="950">
+              <a:defRPr sz="1200">
                 <a:solidFill>
                   <a:srgbClr val="A3B8B0"/>
                 </a:solidFill>
@@ -6689,7 +6727,7 @@
               </a:defRPr>
             </a:pPr>
             <a:r>
-              <a:t>Deterministic Python rules P-01 to P-08 · Shippo &amp; Shopify mock APIs enforce hard rules.</a:t>
+              <a:t>Backend code validates schemas · FFmpeg extracts frames · Python code evaluates rules P-01 to P-08.</a:t>
             </a:r>
           </a:p>
         </p:txBody>
@@ -6703,7 +6741,7 @@
         <p:spPr>
           <a:xfrm>
             <a:off x="4242816" y="1965960"/>
-            <a:ext cx="3840480" cy="36576"/>
+            <a:ext cx="3931920" cy="36576"/>
           </a:xfrm>
           <a:prstGeom prst="rect">
             <a:avLst/>
@@ -6745,8 +6783,8 @@
         </p:nvSpPr>
         <p:spPr>
           <a:xfrm>
-            <a:off x="8302752" y="1965960"/>
-            <a:ext cx="3157423" cy="1234440"/>
+            <a:off x="8394192" y="1965960"/>
+            <a:ext cx="3065983" cy="1234440"/>
           </a:xfrm>
           <a:prstGeom prst="rect">
             <a:avLst/>
@@ -6779,7 +6817,7 @@
           <a:lstStyle/>
           <a:p>
             <a:pPr algn="ctr">
-              <a:defRPr sz="950" b="1">
+              <a:defRPr sz="1200" b="1">
                 <a:solidFill>
                   <a:srgbClr val="FBBF24"/>
                 </a:solidFill>
@@ -6787,12 +6825,12 @@
               </a:defRPr>
             </a:pPr>
             <a:r>
-              <a:t>03 HUMAN SELLER GATE</a:t>
+              <a:t>SELLER</a:t>
             </a:r>
           </a:p>
           <a:p>
             <a:pPr>
-              <a:defRPr sz="1300" b="1">
+              <a:defRPr sz="1550" b="1">
                 <a:solidFill>
                   <a:srgbClr val="F5F3EF"/>
                 </a:solidFill>
@@ -6800,12 +6838,12 @@
               </a:defRPr>
             </a:pPr>
             <a:r>
-              <a:t>Authorize Consequential Action</a:t>
+              <a:t>Approve consequential actions</a:t>
             </a:r>
           </a:p>
           <a:p>
             <a:pPr>
-              <a:defRPr sz="950">
+              <a:defRPr sz="1200">
                 <a:solidFill>
                   <a:srgbClr val="A3B8B0"/>
                 </a:solidFill>
@@ -6813,7 +6851,7 @@
               </a:defRPr>
             </a:pPr>
             <a:r>
-              <a:t>Fail-closed authorization gate · 1-click human merchant confirmation for refund release.</a:t>
+              <a:t>Fail-closed authorization gate · 1-click human merchant confirmation before refund release.</a:t>
             </a:r>
           </a:p>
         </p:txBody>
@@ -6826,8 +6864,8 @@
         </p:nvSpPr>
         <p:spPr>
           <a:xfrm>
-            <a:off x="8302752" y="1965960"/>
-            <a:ext cx="3157423" cy="36576"/>
+            <a:off x="8394192" y="1965960"/>
+            <a:ext cx="3065983" cy="36576"/>
           </a:xfrm>
           <a:prstGeom prst="rect">
             <a:avLst/>
@@ -6869,7 +6907,7 @@
         </p:nvSpPr>
         <p:spPr>
           <a:xfrm>
-            <a:off x="731520" y="3429000"/>
+            <a:off x="731520" y="3401568"/>
             <a:ext cx="10728655" cy="1874519"/>
           </a:xfrm>
           <a:prstGeom prst="rect">
@@ -6899,11 +6937,37 @@
           </a:fontRef>
         </p:style>
         <p:txBody>
-          <a:bodyPr rtlCol="0" anchor="ctr" wrap="square"/>
-          <a:lstStyle/>
-          <a:p>
-            <a:pPr algn="ctr">
-              <a:defRPr sz="1100" b="1">
+          <a:bodyPr rtlCol="0" anchor="ctr"/>
+          <a:lstStyle/>
+          <a:p>
+            <a:pPr algn="ctr"/>
+          </a:p>
+        </p:txBody>
+      </p:sp>
+      <p:sp>
+        <p:nvSpPr>
+          <p:cNvPr id="13" name="TextBox 12"/>
+          <p:cNvSpPr txBox="1"/>
+          <p:nvPr/>
+        </p:nvSpPr>
+        <p:spPr>
+          <a:xfrm>
+            <a:off x="914400" y="3511296"/>
+            <a:ext cx="10362895" cy="320040"/>
+          </a:xfrm>
+          <a:prstGeom prst="rect">
+            <a:avLst/>
+          </a:prstGeom>
+          <a:noFill/>
+        </p:spPr>
+        <p:txBody>
+          <a:bodyPr wrap="none">
+            <a:spAutoFit/>
+          </a:bodyPr>
+          <a:lstStyle/>
+          <a:p>
+            <a:pPr>
+              <a:defRPr sz="1300" b="1">
                 <a:solidFill>
                   <a:srgbClr val="93C5FD"/>
                 </a:solidFill>
@@ -6911,21 +6975,21 @@
               </a:defRPr>
             </a:pPr>
             <a:r>
-              <a:t>HERO AGENTIC INTERACTION: DYNAMIC STATEFUL CLARIFICATION LOOP (CASE C)</a:t>
-            </a:r>
-          </a:p>
-        </p:txBody>
-      </p:sp>
-      <p:sp>
-        <p:nvSpPr>
-          <p:cNvPr id="13" name="Rectangle 12"/>
+              <a:t>DYNAMIC STATEFUL CLARIFICATION LOOP (CASE C)</a:t>
+            </a:r>
+          </a:p>
+        </p:txBody>
+      </p:sp>
+      <p:sp>
+        <p:nvSpPr>
+          <p:cNvPr id="14" name="Rectangle 13"/>
           <p:cNvSpPr/>
           <p:nvPr/>
         </p:nvSpPr>
         <p:spPr>
           <a:xfrm>
-            <a:off x="914400" y="3904488"/>
-            <a:ext cx="1536192" cy="502920"/>
+            <a:off x="868680" y="3904488"/>
+            <a:ext cx="1627632" cy="594360"/>
           </a:xfrm>
           <a:prstGeom prst="rect">
             <a:avLst/>
@@ -6954,11 +7018,11 @@
           </a:fontRef>
         </p:style>
         <p:txBody>
-          <a:bodyPr rtlCol="0" anchor="ctr" wrap="square"/>
+          <a:bodyPr rtlCol="0" anchor="ctr" wrap="square" lIns="27432" rIns="27432"/>
           <a:lstStyle/>
           <a:p>
             <a:pPr algn="ctr">
-              <a:defRPr sz="850" b="1">
+              <a:defRPr sz="1000" b="1">
                 <a:solidFill>
                   <a:srgbClr val="F5F3EF"/>
                 </a:solidFill>
@@ -6966,21 +7030,21 @@
               </a:defRPr>
             </a:pPr>
             <a:r>
-              <a:t>Dark Frames (brightness 28)</a:t>
-            </a:r>
-          </a:p>
-        </p:txBody>
-      </p:sp>
-      <p:sp>
-        <p:nvSpPr>
-          <p:cNvPr id="14" name="TextBox 13"/>
+              <a:t>DARK EVIDENCE</a:t>
+            </a:r>
+          </a:p>
+        </p:txBody>
+      </p:sp>
+      <p:sp>
+        <p:nvSpPr>
+          <p:cNvPr id="15" name="TextBox 14"/>
           <p:cNvSpPr txBox="1"/>
           <p:nvPr/>
         </p:nvSpPr>
         <p:spPr>
           <a:xfrm>
-            <a:off x="2450592" y="3977640"/>
-            <a:ext cx="256032" cy="365760"/>
+            <a:off x="2478024" y="4014216"/>
+            <a:ext cx="201168" cy="365760"/>
           </a:xfrm>
           <a:prstGeom prst="rect">
             <a:avLst/>
@@ -6994,7 +7058,7 @@
           <a:lstStyle/>
           <a:p>
             <a:pPr algn="ctr">
-              <a:defRPr sz="1300" b="1">
+              <a:defRPr sz="1400" b="1">
                 <a:solidFill>
                   <a:srgbClr val="93C5FD"/>
                 </a:solidFill>
@@ -7009,14 +7073,14 @@
       </p:sp>
       <p:sp>
         <p:nvSpPr>
-          <p:cNvPr id="15" name="Rectangle 14"/>
+          <p:cNvPr id="16" name="Rectangle 15"/>
           <p:cNvSpPr/>
           <p:nvPr/>
         </p:nvSpPr>
         <p:spPr>
           <a:xfrm>
-            <a:off x="2706624" y="3904488"/>
-            <a:ext cx="1536192" cy="502920"/>
+            <a:off x="2660904" y="3904488"/>
+            <a:ext cx="1627632" cy="594360"/>
           </a:xfrm>
           <a:prstGeom prst="rect">
             <a:avLst/>
@@ -7045,11 +7109,11 @@
           </a:fontRef>
         </p:style>
         <p:txBody>
-          <a:bodyPr rtlCol="0" anchor="ctr" wrap="square"/>
+          <a:bodyPr rtlCol="0" anchor="ctr" wrap="square" lIns="27432" rIns="27432"/>
           <a:lstStyle/>
           <a:p>
             <a:pPr algn="ctr">
-              <a:defRPr sz="850" b="1">
+              <a:defRPr sz="1000" b="1">
                 <a:solidFill>
                   <a:srgbClr val="F5F3EF"/>
                 </a:solidFill>
@@ -7057,21 +7121,21 @@
               </a:defRPr>
             </a:pPr>
             <a:r>
-              <a:t>ask_for_evidence()</a:t>
-            </a:r>
-          </a:p>
-        </p:txBody>
-      </p:sp>
-      <p:sp>
-        <p:nvSpPr>
-          <p:cNvPr id="16" name="TextBox 15"/>
+              <a:t>ASK FOR PHOTO</a:t>
+            </a:r>
+          </a:p>
+        </p:txBody>
+      </p:sp>
+      <p:sp>
+        <p:nvSpPr>
+          <p:cNvPr id="17" name="TextBox 16"/>
           <p:cNvSpPr txBox="1"/>
           <p:nvPr/>
         </p:nvSpPr>
         <p:spPr>
           <a:xfrm>
-            <a:off x="4242816" y="3977640"/>
-            <a:ext cx="256032" cy="365760"/>
+            <a:off x="4270248" y="4014216"/>
+            <a:ext cx="201168" cy="365760"/>
           </a:xfrm>
           <a:prstGeom prst="rect">
             <a:avLst/>
@@ -7085,7 +7149,7 @@
           <a:lstStyle/>
           <a:p>
             <a:pPr algn="ctr">
-              <a:defRPr sz="1300" b="1">
+              <a:defRPr sz="1400" b="1">
                 <a:solidFill>
                   <a:srgbClr val="93C5FD"/>
                 </a:solidFill>
@@ -7100,14 +7164,14 @@
       </p:sp>
       <p:sp>
         <p:nvSpPr>
-          <p:cNvPr id="17" name="Rectangle 16"/>
+          <p:cNvPr id="18" name="Rectangle 17"/>
           <p:cNvSpPr/>
           <p:nvPr/>
         </p:nvSpPr>
         <p:spPr>
           <a:xfrm>
-            <a:off x="4498848" y="3904488"/>
-            <a:ext cx="1536192" cy="502920"/>
+            <a:off x="4453128" y="3904488"/>
+            <a:ext cx="1627632" cy="594360"/>
           </a:xfrm>
           <a:prstGeom prst="rect">
             <a:avLst/>
@@ -7115,7 +7179,7 @@
           <a:solidFill>
             <a:srgbClr val="1E3A8A"/>
           </a:solidFill>
-          <a:ln w="15240">
+          <a:ln w="19050">
             <a:solidFill>
               <a:srgbClr val="60A5FA"/>
             </a:solidFill>
@@ -7136,11 +7200,11 @@
           </a:fontRef>
         </p:style>
         <p:txBody>
-          <a:bodyPr rtlCol="0" anchor="ctr" wrap="square"/>
+          <a:bodyPr rtlCol="0" anchor="ctr" wrap="square" lIns="27432" rIns="27432"/>
           <a:lstStyle/>
           <a:p>
             <a:pPr algn="ctr">
-              <a:defRPr sz="850" b="1">
+              <a:defRPr sz="1000" b="1">
                 <a:solidFill>
                   <a:srgbClr val="DBEAFE"/>
                 </a:solidFill>
@@ -7155,14 +7219,14 @@
       </p:sp>
       <p:sp>
         <p:nvSpPr>
-          <p:cNvPr id="18" name="TextBox 17"/>
+          <p:cNvPr id="19" name="TextBox 18"/>
           <p:cNvSpPr txBox="1"/>
           <p:nvPr/>
         </p:nvSpPr>
         <p:spPr>
           <a:xfrm>
-            <a:off x="6035040" y="3977640"/>
-            <a:ext cx="256032" cy="365760"/>
+            <a:off x="6062472" y="4014216"/>
+            <a:ext cx="201168" cy="365760"/>
           </a:xfrm>
           <a:prstGeom prst="rect">
             <a:avLst/>
@@ -7176,7 +7240,7 @@
           <a:lstStyle/>
           <a:p>
             <a:pPr algn="ctr">
-              <a:defRPr sz="1300" b="1">
+              <a:defRPr sz="1400" b="1">
                 <a:solidFill>
                   <a:srgbClr val="93C5FD"/>
                 </a:solidFill>
@@ -7191,14 +7255,14 @@
       </p:sp>
       <p:sp>
         <p:nvSpPr>
-          <p:cNvPr id="19" name="Rectangle 18"/>
+          <p:cNvPr id="20" name="Rectangle 19"/>
           <p:cNvSpPr/>
           <p:nvPr/>
         </p:nvSpPr>
         <p:spPr>
           <a:xfrm>
-            <a:off x="6291072" y="3904488"/>
-            <a:ext cx="1536192" cy="502920"/>
+            <a:off x="6245352" y="3904488"/>
+            <a:ext cx="1627632" cy="594360"/>
           </a:xfrm>
           <a:prstGeom prst="rect">
             <a:avLst/>
@@ -7227,11 +7291,11 @@
           </a:fontRef>
         </p:style>
         <p:txBody>
-          <a:bodyPr rtlCol="0" anchor="ctr" wrap="square"/>
+          <a:bodyPr rtlCol="0" anchor="ctr" wrap="square" lIns="27432" rIns="27432"/>
           <a:lstStyle/>
           <a:p>
             <a:pPr algn="ctr">
-              <a:defRPr sz="850" b="1">
+              <a:defRPr sz="1000" b="1">
                 <a:solidFill>
                   <a:srgbClr val="F5F3EF"/>
                 </a:solidFill>
@@ -7239,21 +7303,21 @@
               </a:defRPr>
             </a:pPr>
             <a:r>
-              <a:t>Customer Uploads</a:t>
-            </a:r>
-          </a:p>
-        </p:txBody>
-      </p:sp>
-      <p:sp>
-        <p:nvSpPr>
-          <p:cNvPr id="20" name="TextBox 19"/>
+              <a:t>CUSTOMER UPLOAD</a:t>
+            </a:r>
+          </a:p>
+        </p:txBody>
+      </p:sp>
+      <p:sp>
+        <p:nvSpPr>
+          <p:cNvPr id="21" name="TextBox 20"/>
           <p:cNvSpPr txBox="1"/>
           <p:nvPr/>
         </p:nvSpPr>
         <p:spPr>
           <a:xfrm>
-            <a:off x="7827264" y="3977640"/>
-            <a:ext cx="256032" cy="365760"/>
+            <a:off x="7854696" y="4014216"/>
+            <a:ext cx="201168" cy="365760"/>
           </a:xfrm>
           <a:prstGeom prst="rect">
             <a:avLst/>
@@ -7267,7 +7331,7 @@
           <a:lstStyle/>
           <a:p>
             <a:pPr algn="ctr">
-              <a:defRPr sz="1300" b="1">
+              <a:defRPr sz="1400" b="1">
                 <a:solidFill>
                   <a:srgbClr val="93C5FD"/>
                 </a:solidFill>
@@ -7282,14 +7346,14 @@
       </p:sp>
       <p:sp>
         <p:nvSpPr>
-          <p:cNvPr id="21" name="Rectangle 20"/>
+          <p:cNvPr id="22" name="Rectangle 21"/>
           <p:cNvSpPr/>
           <p:nvPr/>
         </p:nvSpPr>
         <p:spPr>
           <a:xfrm>
-            <a:off x="8083296" y="3904488"/>
-            <a:ext cx="1536192" cy="502920"/>
+            <a:off x="8037576" y="3904488"/>
+            <a:ext cx="1627632" cy="594360"/>
           </a:xfrm>
           <a:prstGeom prst="rect">
             <a:avLst/>
@@ -7297,7 +7361,7 @@
           <a:solidFill>
             <a:srgbClr val="1E3A8A"/>
           </a:solidFill>
-          <a:ln w="15240">
+          <a:ln w="19050">
             <a:solidFill>
               <a:srgbClr val="60A5FA"/>
             </a:solidFill>
@@ -7318,11 +7382,11 @@
           </a:fontRef>
         </p:style>
         <p:txBody>
-          <a:bodyPr rtlCol="0" anchor="ctr" wrap="square"/>
+          <a:bodyPr rtlCol="0" anchor="ctr" wrap="square" lIns="27432" rIns="27432"/>
           <a:lstStyle/>
           <a:p>
             <a:pPr algn="ctr">
-              <a:defRPr sz="850" b="1">
+              <a:defRPr sz="1000" b="1">
                 <a:solidFill>
                   <a:srgbClr val="DBEAFE"/>
                 </a:solidFill>
@@ -7337,14 +7401,14 @@
       </p:sp>
       <p:sp>
         <p:nvSpPr>
-          <p:cNvPr id="22" name="TextBox 21"/>
+          <p:cNvPr id="23" name="TextBox 22"/>
           <p:cNvSpPr txBox="1"/>
           <p:nvPr/>
         </p:nvSpPr>
         <p:spPr>
           <a:xfrm>
-            <a:off x="9619488" y="3977640"/>
-            <a:ext cx="256032" cy="365760"/>
+            <a:off x="9646920" y="4014216"/>
+            <a:ext cx="201168" cy="365760"/>
           </a:xfrm>
           <a:prstGeom prst="rect">
             <a:avLst/>
@@ -7358,7 +7422,7 @@
           <a:lstStyle/>
           <a:p>
             <a:pPr algn="ctr">
-              <a:defRPr sz="1300" b="1">
+              <a:defRPr sz="1400" b="1">
                 <a:solidFill>
                   <a:srgbClr val="93C5FD"/>
                 </a:solidFill>
@@ -7373,14 +7437,14 @@
       </p:sp>
       <p:sp>
         <p:nvSpPr>
-          <p:cNvPr id="23" name="Rectangle 22"/>
+          <p:cNvPr id="24" name="Rectangle 23"/>
           <p:cNvSpPr/>
           <p:nvPr/>
         </p:nvSpPr>
         <p:spPr>
           <a:xfrm>
-            <a:off x="9875520" y="3904488"/>
-            <a:ext cx="1536192" cy="502920"/>
+            <a:off x="9829800" y="3904488"/>
+            <a:ext cx="1627632" cy="594360"/>
           </a:xfrm>
           <a:prstGeom prst="rect">
             <a:avLst/>
@@ -7409,11 +7473,11 @@
           </a:fontRef>
         </p:style>
         <p:txBody>
-          <a:bodyPr rtlCol="0" anchor="ctr" wrap="square"/>
+          <a:bodyPr rtlCol="0" anchor="ctr" wrap="square" lIns="27432" rIns="27432"/>
           <a:lstStyle/>
           <a:p>
             <a:pPr algn="ctr">
-              <a:defRPr sz="850" b="1">
+              <a:defRPr sz="1000" b="1">
                 <a:solidFill>
                   <a:srgbClr val="F5F3EF"/>
                 </a:solidFill>
@@ -7421,21 +7485,21 @@
               </a:defRPr>
             </a:pPr>
             <a:r>
-              <a:t>Seller Review</a:t>
-            </a:r>
-          </a:p>
-        </p:txBody>
-      </p:sp>
-      <p:sp>
-        <p:nvSpPr>
-          <p:cNvPr id="24" name="TextBox 23"/>
+              <a:t>SELLER REVIEW</a:t>
+            </a:r>
+          </a:p>
+        </p:txBody>
+      </p:sp>
+      <p:sp>
+        <p:nvSpPr>
+          <p:cNvPr id="25" name="TextBox 24"/>
           <p:cNvSpPr txBox="1"/>
           <p:nvPr/>
         </p:nvSpPr>
         <p:spPr>
           <a:xfrm>
-            <a:off x="914400" y="4572000"/>
-            <a:ext cx="10362895" cy="640080"/>
+            <a:off x="914400" y="4636008"/>
+            <a:ext cx="10362895" cy="502920"/>
           </a:xfrm>
           <a:prstGeom prst="rect">
             <a:avLst/>
@@ -7449,7 +7513,7 @@
           <a:lstStyle/>
           <a:p>
             <a:pPr>
-              <a:defRPr sz="1050">
+              <a:defRPr sz="1250">
                 <a:solidFill>
                   <a:srgbClr val="A3B8B0"/>
                 </a:solidFill>
@@ -7457,21 +7521,21 @@
               </a:defRPr>
             </a:pPr>
             <a:r>
-              <a:t>Why an agent? When video quality is insufficient, ReturnLens halts execution, issues a targeted re-film checklist, serializes case state into WAITING_FOR_EVIDENCE, and automatically resumes the exact case upon upload (1 retry limit prevents customer lock-out).</a:t>
-            </a:r>
-          </a:p>
-        </p:txBody>
-      </p:sp>
-      <p:sp>
-        <p:nvSpPr>
-          <p:cNvPr id="25" name="Rectangle 24"/>
+              <a:t>Agent calls ask_for_evidence() on low-light frames, serializes context, and resumes execution upon customer upload.</a:t>
+            </a:r>
+          </a:p>
+        </p:txBody>
+      </p:sp>
+      <p:sp>
+        <p:nvSpPr>
+          <p:cNvPr id="26" name="Rectangle 25"/>
           <p:cNvSpPr/>
           <p:nvPr/>
         </p:nvSpPr>
         <p:spPr>
           <a:xfrm>
-            <a:off x="731520" y="5486400"/>
-            <a:ext cx="10728655" cy="658368"/>
+            <a:off x="731520" y="5440680"/>
+            <a:ext cx="10728655" cy="713232"/>
           </a:xfrm>
           <a:prstGeom prst="rect">
             <a:avLst/>
@@ -7504,7 +7568,7 @@
           <a:lstStyle/>
           <a:p>
             <a:pPr algn="ctr">
-              <a:defRPr sz="900" b="1">
+              <a:defRPr sz="1100" b="1">
                 <a:solidFill>
                   <a:srgbClr val="34D399"/>
                 </a:solidFill>
@@ -7512,12 +7576,12 @@
               </a:defRPr>
             </a:pPr>
             <a:r>
-              <a:t>SECONDARY PS-04 ROUTE: Query store &amp; courier tracking for "Where is my order?" without calling multimodal vision models.</a:t>
+              <a:t>SECONDARY PS-04 ROUTE ("Where is my order?"): Store API → Courier API → Customer Reply (Zero vision overhead)</a:t>
             </a:r>
           </a:p>
           <a:p>
             <a:pPr>
-              <a:defRPr sz="900">
+              <a:defRPr sz="1050">
                 <a:solidFill>
                   <a:srgbClr val="A3B8B0"/>
                 </a:solidFill>
@@ -7525,14 +7589,14 @@
               </a:defRPr>
             </a:pPr>
             <a:r>
-              <a:t>SYSTEM OUTPUT: Immutable JSON Audit Trail recorded at every state transition</a:t>
-            </a:r>
-          </a:p>
-        </p:txBody>
-      </p:sp>
-      <p:sp>
-        <p:nvSpPr>
-          <p:cNvPr id="26" name="Rectangle 25"/>
+              <a:t>Structured JSON Audit Log recorded at every state transition.</a:t>
+            </a:r>
+          </a:p>
+        </p:txBody>
+      </p:sp>
+      <p:sp>
+        <p:nvSpPr>
+          <p:cNvPr id="27" name="Rectangle 26"/>
           <p:cNvSpPr/>
           <p:nvPr/>
         </p:nvSpPr>
@@ -7575,7 +7639,7 @@
       </p:sp>
       <p:sp>
         <p:nvSpPr>
-          <p:cNvPr id="27" name="TextBox 26"/>
+          <p:cNvPr id="28" name="TextBox 27"/>
           <p:cNvSpPr txBox="1"/>
           <p:nvPr/>
         </p:nvSpPr>
@@ -7604,14 +7668,14 @@
               </a:defRPr>
             </a:pPr>
             <a:r>
-              <a:t>Structured audit log recorded at every state transition · Decision priority: Contradiction &gt; Hard fail &gt; Unclear only &gt; All pass</a:t>
-            </a:r>
-          </a:p>
-        </p:txBody>
-      </p:sp>
-      <p:sp>
-        <p:nvSpPr>
-          <p:cNvPr id="28" name="TextBox 27"/>
+              <a:t>Structured JSON Audit Log recorded at every state transition · Decision priority: Contradiction &gt; Hard fail &gt; Unclear only &gt; All pass</a:t>
+            </a:r>
+          </a:p>
+        </p:txBody>
+      </p:sp>
+      <p:sp>
+        <p:nvSpPr>
+          <p:cNvPr id="29" name="TextBox 28"/>
           <p:cNvSpPr txBox="1"/>
           <p:nvPr/>
         </p:nvSpPr>
@@ -7801,7 +7865,7 @@
           <a:lstStyle/>
           <a:p>
             <a:pPr>
-              <a:defRPr sz="1900">
+              <a:defRPr sz="1800">
                 <a:solidFill>
                   <a:srgbClr val="596E64"/>
                 </a:solidFill>
@@ -7867,8 +7931,8 @@
         </p:nvSpPr>
         <p:spPr>
           <a:xfrm>
-            <a:off x="914400" y="2276856"/>
-            <a:ext cx="1920240" cy="429768"/>
+            <a:off x="914400" y="2258568"/>
+            <a:ext cx="2011680" cy="457200"/>
           </a:xfrm>
           <a:prstGeom prst="rect">
             <a:avLst/>
@@ -7899,7 +7963,7 @@
           <a:lstStyle/>
           <a:p>
             <a:pPr algn="ctr">
-              <a:defRPr sz="1050" b="1">
+              <a:defRPr sz="1200" b="1">
                 <a:solidFill>
                   <a:srgbClr val="006B55"/>
                 </a:solidFill>
@@ -7920,8 +7984,8 @@
         </p:nvSpPr>
         <p:spPr>
           <a:xfrm>
-            <a:off x="2971800" y="2167128"/>
-            <a:ext cx="3749039" cy="640080"/>
+            <a:off x="3063240" y="2167128"/>
+            <a:ext cx="3657600" cy="640080"/>
           </a:xfrm>
           <a:prstGeom prst="rect">
             <a:avLst/>
@@ -7935,7 +7999,7 @@
           <a:lstStyle/>
           <a:p>
             <a:pPr>
-              <a:defRPr sz="1100" b="1">
+              <a:defRPr sz="1300" b="1">
                 <a:solidFill>
                   <a:srgbClr val="172621"/>
                 </a:solidFill>
@@ -7956,7 +8020,7 @@
         </p:nvSpPr>
         <p:spPr>
           <a:xfrm>
-            <a:off x="6812280" y="2258568"/>
+            <a:off x="6812280" y="2240280"/>
             <a:ext cx="274320" cy="457200"/>
           </a:xfrm>
           <a:prstGeom prst="rect">
@@ -7971,7 +8035,7 @@
           <a:lstStyle/>
           <a:p>
             <a:pPr>
-              <a:defRPr sz="1600" b="1">
+              <a:defRPr sz="1800" b="1">
                 <a:solidFill>
                   <a:srgbClr val="006B55"/>
                 </a:solidFill>
@@ -7992,8 +8056,8 @@
         </p:nvSpPr>
         <p:spPr>
           <a:xfrm>
-            <a:off x="7178040" y="2167128"/>
-            <a:ext cx="4114800" cy="640080"/>
+            <a:off x="7178040" y="2148840"/>
+            <a:ext cx="4114800" cy="685800"/>
           </a:xfrm>
           <a:prstGeom prst="rect">
             <a:avLst/>
@@ -8007,7 +8071,7 @@
           <a:lstStyle/>
           <a:p>
             <a:pPr>
-              <a:defRPr sz="1100" b="1">
+              <a:defRPr sz="1400" b="1">
                 <a:solidFill>
                   <a:srgbClr val="006B55"/>
                 </a:solidFill>
@@ -8020,7 +8084,7 @@
           </a:p>
           <a:p>
             <a:pPr>
-              <a:defRPr sz="1000">
+              <a:defRPr sz="1200">
                 <a:solidFill>
                   <a:srgbClr val="596E64"/>
                 </a:solidFill>
@@ -8028,7 +8092,7 @@
               </a:defRPr>
             </a:pPr>
             <a:r>
-              <a:t>Drafts mock shipping label and refund draft in pending_return_receipt. Money releases only on physical receipt.</a:t>
+              <a:t>Drafts mock return label and refund draft in pending_return_receipt. Money releases only on physical receipt.</a:t>
             </a:r>
           </a:p>
         </p:txBody>
@@ -8086,8 +8150,8 @@
         </p:nvSpPr>
         <p:spPr>
           <a:xfrm>
-            <a:off x="914400" y="3255264"/>
-            <a:ext cx="1920240" cy="429768"/>
+            <a:off x="914400" y="3236976"/>
+            <a:ext cx="2011680" cy="457200"/>
           </a:xfrm>
           <a:prstGeom prst="rect">
             <a:avLst/>
@@ -8118,7 +8182,7 @@
           <a:lstStyle/>
           <a:p>
             <a:pPr algn="ctr">
-              <a:defRPr sz="1050" b="1">
+              <a:defRPr sz="1200" b="1">
                 <a:solidFill>
                   <a:srgbClr val="991B1B"/>
                 </a:solidFill>
@@ -8139,8 +8203,8 @@
         </p:nvSpPr>
         <p:spPr>
           <a:xfrm>
-            <a:off x="2971800" y="3145536"/>
-            <a:ext cx="3749039" cy="640080"/>
+            <a:off x="3063240" y="3145536"/>
+            <a:ext cx="3657600" cy="640080"/>
           </a:xfrm>
           <a:prstGeom prst="rect">
             <a:avLst/>
@@ -8154,7 +8218,7 @@
           <a:lstStyle/>
           <a:p>
             <a:pPr>
-              <a:defRPr sz="1100" b="1">
+              <a:defRPr sz="1300" b="1">
                 <a:solidFill>
                   <a:srgbClr val="172621"/>
                 </a:solidFill>
@@ -8175,7 +8239,7 @@
         </p:nvSpPr>
         <p:spPr>
           <a:xfrm>
-            <a:off x="6812280" y="3236976"/>
+            <a:off x="6812280" y="3218688"/>
             <a:ext cx="274320" cy="457200"/>
           </a:xfrm>
           <a:prstGeom prst="rect">
@@ -8190,7 +8254,7 @@
           <a:lstStyle/>
           <a:p>
             <a:pPr>
-              <a:defRPr sz="1600" b="1">
+              <a:defRPr sz="1800" b="1">
                 <a:solidFill>
                   <a:srgbClr val="006B55"/>
                 </a:solidFill>
@@ -8211,8 +8275,8 @@
         </p:nvSpPr>
         <p:spPr>
           <a:xfrm>
-            <a:off x="7178040" y="3145536"/>
-            <a:ext cx="4114800" cy="640080"/>
+            <a:off x="7178040" y="3127248"/>
+            <a:ext cx="4114800" cy="685800"/>
           </a:xfrm>
           <a:prstGeom prst="rect">
             <a:avLst/>
@@ -8226,7 +8290,7 @@
           <a:lstStyle/>
           <a:p>
             <a:pPr>
-              <a:defRPr sz="1100" b="1">
+              <a:defRPr sz="1400" b="1">
                 <a:solidFill>
                   <a:srgbClr val="991B1B"/>
                 </a:solidFill>
@@ -8239,7 +8303,7 @@
           </a:p>
           <a:p>
             <a:pPr>
-              <a:defRPr sz="1000">
+              <a:defRPr sz="1200">
                 <a:solidFill>
                   <a:srgbClr val="596E64"/>
                 </a:solidFill>
@@ -8305,8 +8369,8 @@
         </p:nvSpPr>
         <p:spPr>
           <a:xfrm>
-            <a:off x="914400" y="4233672"/>
-            <a:ext cx="1920240" cy="429768"/>
+            <a:off x="914400" y="4215384"/>
+            <a:ext cx="2011680" cy="457200"/>
           </a:xfrm>
           <a:prstGeom prst="rect">
             <a:avLst/>
@@ -8337,7 +8401,7 @@
           <a:lstStyle/>
           <a:p>
             <a:pPr algn="ctr">
-              <a:defRPr sz="1050" b="1">
+              <a:defRPr sz="1200" b="1">
                 <a:solidFill>
                   <a:srgbClr val="1E40AF"/>
                 </a:solidFill>
@@ -8358,8 +8422,8 @@
         </p:nvSpPr>
         <p:spPr>
           <a:xfrm>
-            <a:off x="2971800" y="4123944"/>
-            <a:ext cx="3749039" cy="640080"/>
+            <a:off x="3063240" y="4123944"/>
+            <a:ext cx="3657600" cy="640080"/>
           </a:xfrm>
           <a:prstGeom prst="rect">
             <a:avLst/>
@@ -8373,7 +8437,7 @@
           <a:lstStyle/>
           <a:p>
             <a:pPr>
-              <a:defRPr sz="1100" b="1">
+              <a:defRPr sz="1300" b="1">
                 <a:solidFill>
                   <a:srgbClr val="172621"/>
                 </a:solidFill>
@@ -8381,7 +8445,7 @@
               </a:defRPr>
             </a:pPr>
             <a:r>
-              <a:t>Dark or Unreadable Evidence · 4s low-light video (brightness 28/255), barcode obscured</a:t>
+              <a:t>Insufficient Visual Evidence · 4s low-light video (brightness 28/255), barcode obscured</a:t>
             </a:r>
           </a:p>
         </p:txBody>
@@ -8394,7 +8458,7 @@
         </p:nvSpPr>
         <p:spPr>
           <a:xfrm>
-            <a:off x="6812280" y="4215384"/>
+            <a:off x="6812280" y="4197096"/>
             <a:ext cx="274320" cy="457200"/>
           </a:xfrm>
           <a:prstGeom prst="rect">
@@ -8409,7 +8473,7 @@
           <a:lstStyle/>
           <a:p>
             <a:pPr>
-              <a:defRPr sz="1600" b="1">
+              <a:defRPr sz="1800" b="1">
                 <a:solidFill>
                   <a:srgbClr val="006B55"/>
                 </a:solidFill>
@@ -8430,8 +8494,8 @@
         </p:nvSpPr>
         <p:spPr>
           <a:xfrm>
-            <a:off x="7178040" y="4123944"/>
-            <a:ext cx="4114800" cy="640080"/>
+            <a:off x="7178040" y="4105656"/>
+            <a:ext cx="4114800" cy="685800"/>
           </a:xfrm>
           <a:prstGeom prst="rect">
             <a:avLst/>
@@ -8445,7 +8509,7 @@
           <a:lstStyle/>
           <a:p>
             <a:pPr>
-              <a:defRPr sz="1100" b="1">
+              <a:defRPr sz="1400" b="1">
                 <a:solidFill>
                   <a:srgbClr val="1E40AF"/>
                 </a:solidFill>
@@ -8458,7 +8522,7 @@
           </a:p>
           <a:p>
             <a:pPr>
-              <a:defRPr sz="1000">
+              <a:defRPr sz="1200">
                 <a:solidFill>
                   <a:srgbClr val="596E64"/>
                 </a:solidFill>
@@ -8524,8 +8588,8 @@
         </p:nvSpPr>
         <p:spPr>
           <a:xfrm>
-            <a:off x="914400" y="5212080"/>
-            <a:ext cx="1920240" cy="429768"/>
+            <a:off x="914400" y="5193792"/>
+            <a:ext cx="2011680" cy="457200"/>
           </a:xfrm>
           <a:prstGeom prst="rect">
             <a:avLst/>
@@ -8556,7 +8620,7 @@
           <a:lstStyle/>
           <a:p>
             <a:pPr algn="ctr">
-              <a:defRPr sz="1050" b="1">
+              <a:defRPr sz="1200" b="1">
                 <a:solidFill>
                   <a:srgbClr val="065F46"/>
                 </a:solidFill>
@@ -8577,8 +8641,8 @@
         </p:nvSpPr>
         <p:spPr>
           <a:xfrm>
-            <a:off x="2971800" y="5102352"/>
-            <a:ext cx="3749039" cy="640080"/>
+            <a:off x="3063240" y="5102352"/>
+            <a:ext cx="3657600" cy="640080"/>
           </a:xfrm>
           <a:prstGeom prst="rect">
             <a:avLst/>
@@ -8592,7 +8656,7 @@
           <a:lstStyle/>
           <a:p>
             <a:pPr>
-              <a:defRPr sz="1100" b="1">
+              <a:defRPr sz="1300" b="1">
                 <a:solidFill>
                   <a:srgbClr val="172621"/>
                 </a:solidFill>
@@ -8613,7 +8677,7 @@
         </p:nvSpPr>
         <p:spPr>
           <a:xfrm>
-            <a:off x="6812280" y="5193792"/>
+            <a:off x="6812280" y="5175504"/>
             <a:ext cx="274320" cy="457200"/>
           </a:xfrm>
           <a:prstGeom prst="rect">
@@ -8628,7 +8692,7 @@
           <a:lstStyle/>
           <a:p>
             <a:pPr>
-              <a:defRPr sz="1600" b="1">
+              <a:defRPr sz="1800" b="1">
                 <a:solidFill>
                   <a:srgbClr val="006B55"/>
                 </a:solidFill>
@@ -8649,8 +8713,8 @@
         </p:nvSpPr>
         <p:spPr>
           <a:xfrm>
-            <a:off x="7178040" y="5102352"/>
-            <a:ext cx="4114800" cy="640080"/>
+            <a:off x="7178040" y="5084064"/>
+            <a:ext cx="4114800" cy="685800"/>
           </a:xfrm>
           <a:prstGeom prst="rect">
             <a:avLst/>
@@ -8664,7 +8728,7 @@
           <a:lstStyle/>
           <a:p>
             <a:pPr>
-              <a:defRPr sz="1100" b="1">
+              <a:defRPr sz="1400" b="1">
                 <a:solidFill>
                   <a:srgbClr val="065F46"/>
                 </a:solidFill>
@@ -8677,7 +8741,7 @@
           </a:p>
           <a:p>
             <a:pPr>
-              <a:defRPr sz="1000">
+              <a:defRPr sz="1200">
                 <a:solidFill>
                   <a:srgbClr val="596E64"/>
                 </a:solidFill>
@@ -8685,7 +8749,7 @@
               </a:defRPr>
             </a:pPr>
             <a:r>
-              <a:t>Expected prototype behavior: inspects sequence continuity and flags cutaways for seller review.</a:t>
+              <a:t>Expected prototype behavior: inspect sequence continuity and flag cutaways for seller review.</a:t>
             </a:r>
           </a:p>
         </p:txBody>
@@ -8961,7 +9025,7 @@
           <a:lstStyle/>
           <a:p>
             <a:pPr>
-              <a:defRPr sz="1900">
+              <a:defRPr sz="1800">
                 <a:solidFill>
                   <a:srgbClr val="596E64"/>
                 </a:solidFill>
@@ -9059,7 +9123,7 @@
           <a:lstStyle/>
           <a:p>
             <a:pPr algn="ctr">
-              <a:defRPr sz="1000" b="1">
+              <a:defRPr sz="1200" b="1">
                 <a:solidFill>
                   <a:srgbClr val="006B55"/>
                 </a:solidFill>
@@ -9067,12 +9131,12 @@
               </a:defRPr>
             </a:pPr>
             <a:r>
-              <a:t>00–06h · FOUNDATION</a:t>
+              <a:t>00–06h</a:t>
             </a:r>
           </a:p>
           <a:p>
             <a:pPr>
-              <a:defRPr sz="1300" b="1">
+              <a:defRPr sz="1500" b="1">
                 <a:solidFill>
                   <a:srgbClr val="172621"/>
                 </a:solidFill>
@@ -9085,7 +9149,7 @@
           </a:p>
           <a:p>
             <a:pPr>
-              <a:defRPr sz="1000" b="1">
+              <a:defRPr sz="1150" b="1">
                 <a:solidFill>
                   <a:srgbClr val="006B55"/>
                 </a:solidFill>
@@ -9093,12 +9157,12 @@
               </a:defRPr>
             </a:pPr>
             <a:r>
-              <a:t>Person A (Backend)</a:t>
+              <a:t>Person A (Agent / Backend / Policy)</a:t>
             </a:r>
           </a:p>
           <a:p>
             <a:pPr>
-              <a:defRPr sz="950">
+              <a:defRPr sz="1100">
                 <a:solidFill>
                   <a:srgbClr val="596E64"/>
                 </a:solidFill>
@@ -9106,7 +9170,7 @@
               </a:defRPr>
             </a:pPr>
             <a:r>
-              <a:t>LangGraph state machine, mock store &amp; courier fixtures, order status route.</a:t>
+              <a:t>LangGraph state machine, mock store &amp; courier fixtures, order status fast path.</a:t>
             </a:r>
           </a:p>
         </p:txBody>
@@ -9153,7 +9217,7 @@
           <a:lstStyle/>
           <a:p>
             <a:pPr algn="ctr">
-              <a:defRPr sz="1000" b="1">
+              <a:defRPr sz="1200" b="1">
                 <a:solidFill>
                   <a:srgbClr val="006B55"/>
                 </a:solidFill>
@@ -9161,12 +9225,12 @@
               </a:defRPr>
             </a:pPr>
             <a:r>
-              <a:t>06–12h · EVIDENCE</a:t>
+              <a:t>06–12h</a:t>
             </a:r>
           </a:p>
           <a:p>
             <a:pPr>
-              <a:defRPr sz="1300" b="1">
+              <a:defRPr sz="1500" b="1">
                 <a:solidFill>
                   <a:srgbClr val="172621"/>
                 </a:solidFill>
@@ -9179,7 +9243,7 @@
           </a:p>
           <a:p>
             <a:pPr>
-              <a:defRPr sz="1000" b="1">
+              <a:defRPr sz="1150" b="1">
                 <a:solidFill>
                   <a:srgbClr val="006B55"/>
                 </a:solidFill>
@@ -9187,12 +9251,12 @@
               </a:defRPr>
             </a:pPr>
             <a:r>
-              <a:t>Person B (Vision &amp; UI)</a:t>
+              <a:t>Person B (Vision / Evidence / UI)</a:t>
             </a:r>
           </a:p>
           <a:p>
             <a:pPr>
-              <a:defRPr sz="950">
+              <a:defRPr sz="1100">
                 <a:solidFill>
                   <a:srgbClr val="596E64"/>
                 </a:solidFill>
@@ -9200,7 +9264,7 @@
               </a:defRPr>
             </a:pPr>
             <a:r>
-              <a:t>FFmpeg keyframe indexer, vision prompt schema, rules P-01 to P-08, critic prompt.</a:t>
+              <a:t>FFmpeg keyframe indexer, vision prompt schema, critic prompt, seller console UI.</a:t>
             </a:r>
           </a:p>
         </p:txBody>
@@ -9247,7 +9311,7 @@
           <a:lstStyle/>
           <a:p>
             <a:pPr algn="ctr">
-              <a:defRPr sz="1000" b="1">
+              <a:defRPr sz="1200" b="1">
                 <a:solidFill>
                   <a:srgbClr val="006B55"/>
                 </a:solidFill>
@@ -9255,12 +9319,12 @@
               </a:defRPr>
             </a:pPr>
             <a:r>
-              <a:t>12–18h · INTEGRATION</a:t>
+              <a:t>12–18h</a:t>
             </a:r>
           </a:p>
           <a:p>
             <a:pPr>
-              <a:defRPr sz="1300" b="1">
+              <a:defRPr sz="1500" b="1">
                 <a:solidFill>
                   <a:srgbClr val="172621"/>
                 </a:solidFill>
@@ -9273,7 +9337,7 @@
           </a:p>
           <a:p>
             <a:pPr>
-              <a:defRPr sz="1000" b="1">
+              <a:defRPr sz="1150" b="1">
                 <a:solidFill>
                   <a:srgbClr val="006B55"/>
                 </a:solidFill>
@@ -9281,12 +9345,12 @@
               </a:defRPr>
             </a:pPr>
             <a:r>
-              <a:t>Person C (Integration with A/B)</a:t>
+              <a:t>Person C (Fixtures / Integration / QA)</a:t>
             </a:r>
           </a:p>
           <a:p>
             <a:pPr>
-              <a:defRPr sz="950">
+              <a:defRPr sz="1100">
                 <a:solidFill>
                   <a:srgbClr val="596E64"/>
                 </a:solidFill>
@@ -9294,7 +9358,7 @@
               </a:defRPr>
             </a:pPr>
             <a:r>
-              <a:t>Clarification/resume loop, seller review console UI, wiring 4 staged demo cases.</a:t>
+              <a:t>Clarification/resume loop, wiring 4 staged demo cases, end-to-end event bus.</a:t>
             </a:r>
           </a:p>
         </p:txBody>
@@ -9341,7 +9405,7 @@
           <a:lstStyle/>
           <a:p>
             <a:pPr algn="ctr">
-              <a:defRPr sz="1000" b="1">
+              <a:defRPr sz="1200" b="1">
                 <a:solidFill>
                   <a:srgbClr val="006B55"/>
                 </a:solidFill>
@@ -9349,12 +9413,12 @@
               </a:defRPr>
             </a:pPr>
             <a:r>
-              <a:t>18–24h · VALIDATION</a:t>
+              <a:t>18–24h</a:t>
             </a:r>
           </a:p>
           <a:p>
             <a:pPr>
-              <a:defRPr sz="1300" b="1">
+              <a:defRPr sz="1500" b="1">
                 <a:solidFill>
                   <a:srgbClr val="172621"/>
                 </a:solidFill>
@@ -9367,7 +9431,7 @@
           </a:p>
           <a:p>
             <a:pPr>
-              <a:defRPr sz="1000" b="1">
+              <a:defRPr sz="1150" b="1">
                 <a:solidFill>
                   <a:srgbClr val="006B55"/>
                 </a:solidFill>
@@ -9380,7 +9444,7 @@
           </a:p>
           <a:p>
             <a:pPr>
-              <a:defRPr sz="950">
+              <a:defRPr sz="1100">
                 <a:solidFill>
                   <a:srgbClr val="596E64"/>
                 </a:solidFill>
@@ -9504,7 +9568,7 @@
           <a:lstStyle/>
           <a:p>
             <a:pPr>
-              <a:defRPr sz="1100" b="1">
+              <a:defRPr sz="1300" b="1">
                 <a:solidFill>
                   <a:srgbClr val="006B55"/>
                 </a:solidFill>
@@ -9517,7 +9581,7 @@
           </a:p>
           <a:p>
             <a:pPr>
-              <a:defRPr sz="1050">
+              <a:defRPr sz="1200">
                 <a:solidFill>
                   <a:srgbClr val="172621"/>
                 </a:solidFill>
@@ -9525,12 +9589,12 @@
               </a:defRPr>
             </a:pPr>
             <a:r>
-              <a:t>• Deterministic policy engine (P-01 to P-08)</a:t>
+              <a:t>• Mock store &amp; courier APIs</a:t>
             </a:r>
           </a:p>
           <a:p>
             <a:pPr>
-              <a:defRPr sz="1050">
+              <a:defRPr sz="1200">
                 <a:solidFill>
                   <a:srgbClr val="172621"/>
                 </a:solidFill>
@@ -9538,12 +9602,12 @@
               </a:defRPr>
             </a:pPr>
             <a:r>
-              <a:t>• Evidence-pack keyframe citations</a:t>
+              <a:t>• Deterministic policy &amp; seller gate</a:t>
             </a:r>
           </a:p>
           <a:p>
             <a:pPr>
-              <a:defRPr sz="1050">
+              <a:defRPr sz="1200">
                 <a:solidFill>
                   <a:srgbClr val="172621"/>
                 </a:solidFill>
@@ -9551,12 +9615,12 @@
               </a:defRPr>
             </a:pPr>
             <a:r>
-              <a:t>• Fail-closed seller authorization gate</a:t>
+              <a:t>• Color-mismatch contradiction scenario</a:t>
             </a:r>
           </a:p>
           <a:p>
             <a:pPr>
-              <a:defRPr sz="1050">
+              <a:defRPr sz="1200">
                 <a:solidFill>
                   <a:srgbClr val="172621"/>
                 </a:solidFill>
@@ -9564,12 +9628,25 @@
               </a:defRPr>
             </a:pPr>
             <a:r>
+              <a:t>• Clarification / resume scenario (Case C)</a:t>
+            </a:r>
+          </a:p>
+          <a:p>
+            <a:pPr>
+              <a:defRPr sz="1200">
+                <a:solidFill>
+                  <a:srgbClr val="172621"/>
+                </a:solidFill>
+                <a:latin typeface="Inter"/>
+              </a:defRPr>
+            </a:pPr>
+            <a:r>
               <a:t>• Structured JSON audit trail log</a:t>
             </a:r>
           </a:p>
           <a:p>
             <a:pPr>
-              <a:defRPr sz="1050">
+              <a:defRPr sz="1200">
                 <a:solidFill>
                   <a:srgbClr val="172621"/>
                 </a:solidFill>
@@ -9577,20 +9654,7 @@
               </a:defRPr>
             </a:pPr>
             <a:r>
-              <a:t>• Stateful clarification/resume loop</a:t>
-            </a:r>
-          </a:p>
-          <a:p>
-            <a:pPr>
-              <a:defRPr sz="1050">
-                <a:solidFill>
-                  <a:srgbClr val="172621"/>
-                </a:solidFill>
-                <a:latin typeface="Inter"/>
-              </a:defRPr>
-            </a:pPr>
-            <a:r>
-              <a:t>• 4 reproducible demo scenarios</a:t>
+              <a:t>• Order-status fast path lookup</a:t>
             </a:r>
           </a:p>
         </p:txBody>
@@ -9706,7 +9770,7 @@
           <a:lstStyle/>
           <a:p>
             <a:pPr>
-              <a:defRPr sz="1100" b="1">
+              <a:defRPr sz="1300" b="1">
                 <a:solidFill>
                   <a:srgbClr val="D95D39"/>
                 </a:solidFill>
@@ -9719,7 +9783,7 @@
           </a:p>
           <a:p>
             <a:pPr>
-              <a:defRPr sz="1050">
+              <a:defRPr sz="1200">
                 <a:solidFill>
                   <a:srgbClr val="172621"/>
                 </a:solidFill>
@@ -9727,12 +9791,12 @@
               </a:defRPr>
             </a:pPr>
             <a:r>
-              <a:t>• Live carrier webhooks (keep mock courier)</a:t>
+              <a:t>• Advanced continuity checks (Case D stretch)</a:t>
             </a:r>
           </a:p>
           <a:p>
             <a:pPr>
-              <a:defRPr sz="1050">
+              <a:defRPr sz="1200">
                 <a:solidFill>
                   <a:srgbClr val="172621"/>
                 </a:solidFill>
@@ -9740,12 +9804,12 @@
               </a:defRPr>
             </a:pPr>
             <a:r>
-              <a:t>• Multi-item return parsing (keep 1 item/return)</a:t>
+              <a:t>• Live external carrier &amp; store integrations</a:t>
             </a:r>
           </a:p>
           <a:p>
             <a:pPr>
-              <a:defRPr sz="1050">
+              <a:defRPr sz="1200">
                 <a:solidFill>
                   <a:srgbClr val="172621"/>
                 </a:solidFill>
@@ -9753,25 +9817,12 @@
               </a:defRPr>
             </a:pPr>
             <a:r>
-              <a:t>• Video OCR barcode scanner (keep visual color)</a:t>
+              <a:t>• Video OCR barcode scanner</a:t>
             </a:r>
           </a:p>
           <a:p>
             <a:pPr>
-              <a:defRPr sz="1050">
-                <a:solidFill>
-                  <a:srgbClr val="172621"/>
-                </a:solidFill>
-                <a:latin typeface="Inter"/>
-              </a:defRPr>
-            </a:pPr>
-            <a:r>
-              <a:t>• Live payment gateways (keep draft refunds)</a:t>
-            </a:r>
-          </a:p>
-          <a:p>
-            <a:pPr>
-              <a:defRPr sz="1050">
+              <a:defRPr sz="1200">
                 <a:solidFill>
                   <a:srgbClr val="172621"/>
                 </a:solidFill>

</xml_diff>

<commit_message>
feat(polish): final judge-ready polish, collision elimination, and typography QA (#5)
</commit_message>
<xml_diff>
--- a/ReturnLens_v4.pptx
+++ b/ReturnLens_v4.pptx
@@ -522,7 +522,7 @@
           </a:p>
           <a:p>
             <a:r>
-              <a:t>- Core Friction: Solo sellers spend 15–20 minutes per return opening fragmented tabs (buyer chat, Shopify, Shippo tracking, store return policy). Return decisions are currently made from memory without unified evidence.</a:t>
+              <a:t>- Core Friction: Solo sellers lose valuable hours navigating fragmented tabs (buyer chat, Shopify, Shippo tracking, store return policy). Return decisions are currently made from memory without unified evidence.</a:t>
             </a:r>
           </a:p>
           <a:p>
@@ -532,7 +532,7 @@
           </a:p>
           <a:p>
             <a:r>
-              <a:t>- The Console Mockup showcases our core benchmark (Case B): Buyer ordered White Headphones (HEAD-WHT-02, ₹1,499), but unboxing frame 00:07 reveals a Black item. The agent flags the contradiction and presents actionable choices to the seller.</a:t>
+              <a:t>- Console Focus: Side-by-side comparison between ordered White Headphones (HEAD-WHT-02, ₹1,499) and unboxed Black Headphones (Frame 00:07). The agent flags the contradiction, leaves exact SKU unverified, and surfaces actionable resolution choices to the seller.</a:t>
             </a:r>
           </a:p>
           <a:p>
@@ -612,12 +612,7 @@
           </a:p>
           <a:p>
             <a:r>
-              <a:t>- The returns bottleneck for solo sellers is not an absent returns portal; it is fragmented, unverified context.</a:t>
-            </a:r>
-          </a:p>
-          <a:p>
-            <a:r>
-              <a:t>- The four disconnected sources:</a:t>
+              <a:t>- The returns bottleneck for solo sellers is not an absent returns portal; it is fragmented, unverified context across four disconnected systems:</a:t>
             </a:r>
           </a:p>
           <a:p>
@@ -647,7 +642,7 @@
           </a:p>
           <a:p>
             <a:r>
-              <a:t>- Fraud Context (Sourced definitions): NRF 2025 reports 9% for strictly criminal return fraud, whereas Appriss/Deloitte 2024 reports 15.14% when combining fraud and policy abuse (wardrobing, unboxing swaps). These measure distinct scopes and must never be merged.</a:t>
+              <a:t>- Sourced Fraud Context: NRF 2025 reports 9% for strictly criminal return fraud, whereas Appriss/Deloitte 2024 reports 15.14% when combining fraud and policy abuse (wardrobing, unboxing swaps). These measure distinct scopes and must never be merged.</a:t>
             </a:r>
           </a:p>
           <a:p>
@@ -732,12 +727,12 @@
           </a:p>
           <a:p>
             <a:r>
-              <a:t>- Visual Grounding Honesty: The agent does NOT claim to read an unreadable SKU barcode from frame 00:07. It factually observes: 'Observed Color: Midnight Black · Exact SKU: Not verified · Tag: Not visible in cited frame'.</a:t>
-            </a:r>
-          </a:p>
-          <a:p>
-            <a:r>
-              <a:t>- Decision Logic: Seeing a black item when white was ordered is an undeniable visual contradiction against the manifest. Instead of auto-denying the customer (which might alienate an honest buyer if the warehouse mis-shipped), the policy engine triggers ESCALATE.</a:t>
+              <a:t>- Visual Grounding Honesty: The agent does NOT claim to read an unreadable SKU barcode from frame 00:07. It factually observes: 'Observed Color: Midnight Black · Exact SKU: Not verified · Tag: Not visible in cited frame'. Frame citations provide a traceable reference, not proof of footage authenticity.</a:t>
+            </a:r>
+          </a:p>
+          <a:p>
+            <a:r>
+              <a:t>- Decision Logic: Seeing a black item when white was ordered is an undeniable visual contradiction against the manifest. Instead of auto-denying the customer, the policy engine triggers ESCALATE.</a:t>
             </a:r>
           </a:p>
           <a:p>
@@ -842,12 +837,17 @@
           </a:p>
           <a:p>
             <a:r>
+              <a:t>- Responsibilities: Planner model proposes tool actions; backend code validates JSON schemas; FFmpeg extracts keyframes; vision model generates cited observations; deterministic Python rules evaluate policy P-01 to P-08; seller gate authorizes consequential actions.</a:t>
+            </a:r>
+          </a:p>
+          <a:p>
+            <a:r>
               <a:t>- DEFENSE QUESTION 1: Why is this an agent rather than a hardcoded workflow?</a:t>
             </a:r>
           </a:p>
           <a:p>
             <a:r>
-              <a:t>  ReturnLens is an autonomous state machine with dynamic action selection, multi-modal observation, and stateful lifecycle management. In Case C, when a customer submits a dark/blurry video (average brightness 28), the agent does NOT simply fail or run a static linear chain. It inspects the frames, determines evidence is insufficient under Policy P-05, dynamically decides to invoke ask_for_evidence() with specific re-filming guidance, transitions the ticket to WAITING_FOR_EVIDENCE, pauses execution while retaining state and order context, and resumes the exact triage session when new media arrives. Conversely, for routine order status requests, the agent selects the zero-vision fast path directly querying mock APIs.</a:t>
+              <a:t>  ReturnLens is an autonomous state machine with dynamic action selection, multimodal observation, and stateful lifecycle management. In Case C, when a customer submits a dark or blurry video (average brightness 28), the agent does NOT simply fail or run a static linear chain. It inspects the frames, determines evidence is insufficient under Policy P-05, dynamically decides to invoke ask_for_evidence() with specific re-filming guidance, transitions the ticket to WAITING_FOR_EVIDENCE, pauses execution while retaining state and order context, and resumes the exact triage session when new media arrives. Conversely, for routine order status requests, the agent selects the zero-vision fast path directly querying mock APIs.</a:t>
             </a:r>
           </a:p>
           <a:p>
@@ -867,17 +867,17 @@
           </a:p>
           <a:p>
             <a:r>
-              <a:t>  1. Idempotency keys (hash(order_id, return_id, transaction_type)) prevent double-execution.</a:t>
-            </a:r>
-          </a:p>
-          <a:p>
-            <a:r>
-              <a:t>  2. Ledgers track cumulative refunded amounts against total order value: 0 &lt; amount &lt;= min(₹4,999, remaining_refundable_amount, order_paid_amount).</a:t>
-            </a:r>
-          </a:p>
-          <a:p>
-            <a:r>
-              <a:t>  3. LLMs possess zero capability to call payment gateways directly; all actions produce draft state objects awaiting merchant authorization.</a:t>
+              <a:t>  1. Idempotency keys (hash(order_id, return_id, transaction_type)) with backend uniqueness checks prevent duplicate execution.</a:t>
+            </a:r>
+          </a:p>
+          <a:p>
+            <a:r>
+              <a:t>  2. Ledgers enforce: 0 &lt; amount &lt;= min(₹4,999, remaining_refundable_amount, order_paid_amount).</a:t>
+            </a:r>
+          </a:p>
+          <a:p>
+            <a:r>
+              <a:t>  3. Sequence: Refund proposal -&gt; Code validation -&gt; Seller approval -&gt; Revalidation -&gt; Draft creation -&gt; Receipt -&gt; Release. LLMs possess zero capability to call payment gateways directly.</a:t>
             </a:r>
           </a:p>
         </p:txBody>
@@ -972,7 +972,7 @@
           </a:p>
           <a:p>
             <a:r>
-              <a:t>- Case 04 (Continuity): Expected prototype behavior: inspect parcel-to-product sequence to flag suspicious cut-aways or missing transitions.</a:t>
+              <a:t>- Case 04 (Continuity): Expected prototype behavior: inspect parcel-to-product sequence to flag suspicious cut-aways or missing transitions. Does not claim proven prevention of video manipulation.</a:t>
             </a:r>
           </a:p>
           <a:p>
@@ -1062,22 +1062,22 @@
           </a:p>
           <a:p>
             <a:r>
-              <a:t>  2. Clear division of labor with single-threaded ownership across 3 teammates:</a:t>
-            </a:r>
-          </a:p>
-          <a:p>
-            <a:r>
-              <a:t>     - Person A (Backend &amp; State Machine): LangGraph orchestrator, mock store/courier APIs, order status fast path, state serialization.</a:t>
-            </a:r>
-          </a:p>
-          <a:p>
-            <a:r>
-              <a:t>     - Person B (Video Pipeline &amp; UI): FFmpeg keyframe extraction, deterministic rules P-01 to P-08, critic prompt, seller console.</a:t>
-            </a:r>
-          </a:p>
-          <a:p>
-            <a:r>
-              <a:t>     - Person C (Integration &amp; Validation): Clarification/resume loop, 4 staged demo cases (A-D), authorization boundary tests, demo video recording, README.</a:t>
+              <a:t>  2. Clear division of labor with single-threaded component ownership across 3 teammates:</a:t>
+            </a:r>
+          </a:p>
+          <a:p>
+            <a:r>
+              <a:t>     - Person A (Agent / Backend / Policy / Authorization): LangGraph orchestrator, mock store/courier APIs, order status fast path, deterministic rules P-01 to P-08, fail-closed authorization gate.</a:t>
+            </a:r>
+          </a:p>
+          <a:p>
+            <a:r>
+              <a:t>     - Person B (Vision / Evidence / UI): FFmpeg keyframe extraction, vision schema, critic prompt, seller console UI.</a:t>
+            </a:r>
+          </a:p>
+          <a:p>
+            <a:r>
+              <a:t>     - Person C (Mock Fixtures / Integration / QA): Test fixtures, clarification/resume loop, 4 staged demo cases (A-D), authorization tests, demo video recording, README.</a:t>
             </a:r>
           </a:p>
           <a:p>
@@ -1087,12 +1087,12 @@
           </a:p>
           <a:p>
             <a:r>
-              <a:t>     - NEVER CUT: Core policy engine, frame citations, seller authorization gate, structured audit log, clarification/resume loop, 4 demo cases.</a:t>
-            </a:r>
-          </a:p>
-          <a:p>
-            <a:r>
-              <a:t>     - CUT FIRST IF BEHIND: Real carrier webhooks, multi-product order parsing, video OCR barcode scanning, production payment gateways, seller analytics dashboards.</a:t>
+              <a:t>     - MUST DELIVER: Mock store/courier APIs, deterministic policy engine, frame citations, seller authorization gate, structured audit log, clarification/resume loop, 4 demo cases.</a:t>
+            </a:r>
+          </a:p>
+          <a:p>
+            <a:r>
+              <a:t>     - CUT FIRST IF BEHIND: Case D advanced continuity checks (stretch), real carrier webhooks, multi-product order parsing, video OCR barcode scanning, production payment gateways, seller analytics dashboards.</a:t>
             </a:r>
           </a:p>
           <a:p>
@@ -4154,8 +4154,8 @@
         </p:nvSpPr>
         <p:spPr>
           <a:xfrm>
-            <a:off x="731520" y="731520"/>
-            <a:ext cx="4023360" cy="365760"/>
+            <a:off x="731520" y="685800"/>
+            <a:ext cx="4297680" cy="320040"/>
           </a:xfrm>
           <a:prstGeom prst="rect">
             <a:avLst/>
@@ -4190,8 +4190,8 @@
         </p:nvSpPr>
         <p:spPr>
           <a:xfrm>
-            <a:off x="731520" y="1188720"/>
-            <a:ext cx="4023360" cy="914400"/>
+            <a:off x="731520" y="1051560"/>
+            <a:ext cx="4297680" cy="914400"/>
           </a:xfrm>
           <a:prstGeom prst="rect">
             <a:avLst/>
@@ -4226,8 +4226,8 @@
         </p:nvSpPr>
         <p:spPr>
           <a:xfrm>
-            <a:off x="731520" y="2194560"/>
-            <a:ext cx="4023360" cy="1005840"/>
+            <a:off x="731520" y="2057400"/>
+            <a:ext cx="4297680" cy="914400"/>
           </a:xfrm>
           <a:prstGeom prst="rect">
             <a:avLst/>
@@ -4241,7 +4241,7 @@
           <a:lstStyle/>
           <a:p>
             <a:pPr>
-              <a:defRPr sz="2400" b="1">
+              <a:defRPr sz="2200" b="1">
                 <a:solidFill>
                   <a:srgbClr val="172621"/>
                 </a:solidFill>
@@ -4249,7 +4249,7 @@
               </a:defRPr>
             </a:pPr>
             <a:r>
-              <a:t>Every return decision, backed by evidence.</a:t>
+              <a:t>“Every return decision, backed by evidence.”</a:t>
             </a:r>
           </a:p>
         </p:txBody>
@@ -4262,8 +4262,8 @@
         </p:nvSpPr>
         <p:spPr>
           <a:xfrm>
-            <a:off x="731520" y="3291840"/>
-            <a:ext cx="4023360" cy="1645920"/>
+            <a:off x="731520" y="3063240"/>
+            <a:ext cx="4297680" cy="2011680"/>
           </a:xfrm>
           <a:prstGeom prst="rect">
             <a:avLst/>
@@ -4277,21 +4277,21 @@
           <a:lstStyle/>
           <a:p>
             <a:pPr>
-              <a:defRPr sz="1400">
-                <a:solidFill>
-                  <a:srgbClr val="596E64"/>
+              <a:defRPr sz="1600" b="1">
+                <a:solidFill>
+                  <a:srgbClr val="172621"/>
                 </a:solidFill>
                 <a:latin typeface="Inter"/>
               </a:defRPr>
             </a:pPr>
             <a:r>
-              <a:t>Evidence-backed returns triage for independent online sellers.</a:t>
+              <a:t>Connect customer evidence, order facts and policy — then let the seller decide.</a:t>
             </a:r>
           </a:p>
           <a:p>
             <a:br/>
             <a:pPr>
-              <a:defRPr sz="1300">
+              <a:defRPr sz="1400">
                 <a:solidFill>
                   <a:srgbClr val="596E64"/>
                 </a:solidFill>
@@ -4299,7 +4299,7 @@
               </a:defRPr>
             </a:pPr>
             <a:r>
-              <a:t>When a customer submits an unboxing video, ReturnLens cross-references store truth, verifies deterministic code policies, and gives the solo seller a 1-click decision console.</a:t>
+              <a:t>ReturnLens unifies unboxing video evidence, store truth, and policy checks into a 1-click decision console for solo merchants.</a:t>
             </a:r>
           </a:p>
         </p:txBody>
@@ -4312,8 +4312,8 @@
         </p:nvSpPr>
         <p:spPr>
           <a:xfrm>
-            <a:off x="731520" y="5303520"/>
-            <a:ext cx="4023360" cy="457200"/>
+            <a:off x="731520" y="5532120"/>
+            <a:ext cx="4297680" cy="365760"/>
           </a:xfrm>
           <a:prstGeom prst="rect">
             <a:avLst/>
@@ -4327,15 +4327,15 @@
           <a:lstStyle/>
           <a:p>
             <a:pPr>
-              <a:defRPr sz="1000" b="1">
-                <a:solidFill>
-                  <a:srgbClr val="7A8E85"/>
+              <a:defRPr sz="1100" b="1">
+                <a:solidFill>
+                  <a:srgbClr val="006B55"/>
                 </a:solidFill>
                 <a:latin typeface="IBM Plex Mono"/>
               </a:defRPr>
             </a:pPr>
             <a:r>
-              <a:t>Team Rookie (3 Members) · 24-Hour Prototype Feasibility</a:t>
+              <a:t>Team Rookie · AgentX PS-04 · 24h Prototype</a:t>
             </a:r>
           </a:p>
         </p:txBody>
@@ -4348,8 +4348,8 @@
         </p:nvSpPr>
         <p:spPr>
           <a:xfrm>
-            <a:off x="5166360" y="685800"/>
-            <a:ext cx="6293815" cy="5349240"/>
+            <a:off x="5349240" y="685800"/>
+            <a:ext cx="6110935" cy="5349240"/>
           </a:xfrm>
           <a:prstGeom prst="rect">
             <a:avLst/>
@@ -4393,8 +4393,8 @@
         </p:nvSpPr>
         <p:spPr>
           <a:xfrm>
-            <a:off x="5166360" y="685800"/>
-            <a:ext cx="6293815" cy="457200"/>
+            <a:off x="5349240" y="685800"/>
+            <a:ext cx="6110935" cy="457200"/>
           </a:xfrm>
           <a:prstGeom prst="rect">
             <a:avLst/>
@@ -4425,7 +4425,7 @@
           <a:lstStyle/>
           <a:p>
             <a:pPr algn="ctr">
-              <a:defRPr sz="1000" b="1">
+              <a:defRPr sz="1100" b="1">
                 <a:solidFill>
                   <a:srgbClr val="00D1A7"/>
                 </a:solidFill>
@@ -4454,8 +4454,8 @@
         </p:blipFill>
         <p:spPr>
           <a:xfrm>
-            <a:off x="5349240" y="1280160"/>
-            <a:ext cx="2880360" cy="1920240"/>
+            <a:off x="5532120" y="1280160"/>
+            <a:ext cx="2788920" cy="1965960"/>
           </a:xfrm>
           <a:prstGeom prst="rect">
             <a:avLst/>
@@ -4470,8 +4470,8 @@
         </p:nvSpPr>
         <p:spPr>
           <a:xfrm>
-            <a:off x="5349240" y="3246120"/>
-            <a:ext cx="2880360" cy="292608"/>
+            <a:off x="5532120" y="3291840"/>
+            <a:ext cx="2788920" cy="320040"/>
           </a:xfrm>
           <a:prstGeom prst="rect">
             <a:avLst/>
@@ -4498,11 +4498,11 @@
           </a:fontRef>
         </p:style>
         <p:txBody>
-          <a:bodyPr rtlCol="0" anchor="ctr"/>
+          <a:bodyPr rtlCol="0" anchor="ctr" lIns="18288" rIns="18288"/>
           <a:lstStyle/>
           <a:p>
             <a:pPr algn="ctr">
-              <a:defRPr sz="850" b="1">
+              <a:defRPr sz="1050" b="1">
                 <a:solidFill>
                   <a:srgbClr val="006B55"/>
                 </a:solidFill>
@@ -4531,8 +4531,8 @@
         </p:blipFill>
         <p:spPr>
           <a:xfrm>
-            <a:off x="8396935" y="1280160"/>
-            <a:ext cx="2880360" cy="1920240"/>
+            <a:off x="8488375" y="1280160"/>
+            <a:ext cx="2788920" cy="1965960"/>
           </a:xfrm>
           <a:prstGeom prst="rect">
             <a:avLst/>
@@ -4547,8 +4547,8 @@
         </p:nvSpPr>
         <p:spPr>
           <a:xfrm>
-            <a:off x="8396935" y="3246120"/>
-            <a:ext cx="2880360" cy="292608"/>
+            <a:off x="8488375" y="3291840"/>
+            <a:ext cx="2788920" cy="320040"/>
           </a:xfrm>
           <a:prstGeom prst="rect">
             <a:avLst/>
@@ -4575,11 +4575,11 @@
           </a:fontRef>
         </p:style>
         <p:txBody>
-          <a:bodyPr rtlCol="0" anchor="ctr"/>
+          <a:bodyPr rtlCol="0" anchor="ctr" lIns="18288" rIns="18288"/>
           <a:lstStyle/>
           <a:p>
             <a:pPr algn="ctr">
-              <a:defRPr sz="850" b="1">
+              <a:defRPr sz="1000" b="1">
                 <a:solidFill>
                   <a:srgbClr val="991B1B"/>
                 </a:solidFill>
@@ -4600,8 +4600,8 @@
         </p:nvSpPr>
         <p:spPr>
           <a:xfrm>
-            <a:off x="5349240" y="3639312"/>
-            <a:ext cx="5928055" cy="658368"/>
+            <a:off x="5532120" y="3721608"/>
+            <a:ext cx="5745175" cy="658368"/>
           </a:xfrm>
           <a:prstGeom prst="rect">
             <a:avLst/>
@@ -4634,7 +4634,7 @@
           <a:lstStyle/>
           <a:p>
             <a:pPr algn="ctr">
-              <a:defRPr sz="950" b="1">
+              <a:defRPr sz="1150" b="1">
                 <a:solidFill>
                   <a:srgbClr val="991B1B"/>
                 </a:solidFill>
@@ -4647,7 +4647,7 @@
           </a:p>
           <a:p>
             <a:pPr>
-              <a:defRPr sz="950">
+              <a:defRPr sz="1150">
                 <a:solidFill>
                   <a:srgbClr val="991B1B"/>
                 </a:solidFill>
@@ -4655,7 +4655,7 @@
               </a:defRPr>
             </a:pPr>
             <a:r>
-              <a:t>P-04 Return Window: PASS (Day 4 of 7)  |  P-03 Manifest Match: CONTRADICTION FLAGGED</a:t>
+              <a:t>P-04 Return Window: PASS (Day 4 of 7)  |  P-03 Manifest: CONTRADICTION FLAGGED</a:t>
             </a:r>
           </a:p>
         </p:txBody>
@@ -4668,8 +4668,8 @@
         </p:nvSpPr>
         <p:spPr>
           <a:xfrm>
-            <a:off x="5349240" y="4370832"/>
-            <a:ext cx="5928055" cy="365760"/>
+            <a:off x="5532120" y="4453128"/>
+            <a:ext cx="5745175" cy="384048"/>
           </a:xfrm>
           <a:prstGeom prst="rect">
             <a:avLst/>
@@ -4700,7 +4700,7 @@
           <a:lstStyle/>
           <a:p>
             <a:pPr algn="ctr">
-              <a:defRPr sz="950" b="1">
+              <a:defRPr sz="1200" b="1">
                 <a:solidFill>
                   <a:srgbClr val="92400E"/>
                 </a:solidFill>
@@ -4708,7 +4708,7 @@
               </a:defRPr>
             </a:pPr>
             <a:r>
-              <a:t>STATUS: ESCALATED FOR SELLER DECISION (HUMAN GATE)</a:t>
+              <a:t>SELLER REVIEW REQUIRED (HUMAN GATE)</a:t>
             </a:r>
           </a:p>
         </p:txBody>
@@ -4721,8 +4721,8 @@
         </p:nvSpPr>
         <p:spPr>
           <a:xfrm>
-            <a:off x="5349240" y="4809744"/>
-            <a:ext cx="5928055" cy="502920"/>
+            <a:off x="5532120" y="4910328"/>
+            <a:ext cx="5745175" cy="502920"/>
           </a:xfrm>
           <a:prstGeom prst="rect">
             <a:avLst/>
@@ -4753,7 +4753,7 @@
           <a:lstStyle/>
           <a:p>
             <a:pPr algn="ctr">
-              <a:defRPr sz="1300" b="1">
+              <a:defRPr sz="1400" b="1">
                 <a:solidFill>
                   <a:srgbClr val="FFFFFF"/>
                 </a:solidFill>
@@ -5092,7 +5092,7 @@
           <a:lstStyle/>
           <a:p>
             <a:pPr algn="ctr">
-              <a:defRPr sz="950" b="1">
+              <a:defRPr sz="1100" b="1">
                 <a:solidFill>
                   <a:srgbClr val="006B55"/>
                 </a:solidFill>
@@ -5105,7 +5105,7 @@
           </a:p>
           <a:p>
             <a:pPr>
-              <a:defRPr sz="1100">
+              <a:defRPr sz="1300">
                 <a:solidFill>
                   <a:srgbClr val="172621"/>
                 </a:solidFill>
@@ -5160,7 +5160,7 @@
           <a:lstStyle/>
           <a:p>
             <a:pPr algn="ctr">
-              <a:defRPr sz="950" b="1">
+              <a:defRPr sz="1100" b="1">
                 <a:solidFill>
                   <a:srgbClr val="006B55"/>
                 </a:solidFill>
@@ -5173,7 +5173,7 @@
           </a:p>
           <a:p>
             <a:pPr>
-              <a:defRPr sz="1100">
+              <a:defRPr sz="1300">
                 <a:solidFill>
                   <a:srgbClr val="172621"/>
                 </a:solidFill>
@@ -5228,7 +5228,7 @@
           <a:lstStyle/>
           <a:p>
             <a:pPr algn="ctr">
-              <a:defRPr sz="950" b="1">
+              <a:defRPr sz="1100" b="1">
                 <a:solidFill>
                   <a:srgbClr val="006B55"/>
                 </a:solidFill>
@@ -5241,7 +5241,7 @@
           </a:p>
           <a:p>
             <a:pPr>
-              <a:defRPr sz="1100">
+              <a:defRPr sz="1300">
                 <a:solidFill>
                   <a:srgbClr val="172621"/>
                 </a:solidFill>
@@ -5296,7 +5296,7 @@
           <a:lstStyle/>
           <a:p>
             <a:pPr algn="ctr">
-              <a:defRPr sz="950" b="1">
+              <a:defRPr sz="1100" b="1">
                 <a:solidFill>
                   <a:srgbClr val="006B55"/>
                 </a:solidFill>
@@ -5309,7 +5309,7 @@
           </a:p>
           <a:p>
             <a:pPr>
-              <a:defRPr sz="1100">
+              <a:defRPr sz="1300">
                 <a:solidFill>
                   <a:srgbClr val="172621"/>
                 </a:solidFill>
@@ -5345,7 +5345,7 @@
           <a:lstStyle/>
           <a:p>
             <a:pPr>
-              <a:defRPr sz="2800" b="1">
+              <a:defRPr sz="3200" b="1">
                 <a:solidFill>
                   <a:srgbClr val="D95D39"/>
                 </a:solidFill>
@@ -5400,7 +5400,7 @@
           <a:lstStyle/>
           <a:p>
             <a:pPr algn="ctr">
-              <a:defRPr sz="1100" b="1">
+              <a:defRPr sz="1200" b="1">
                 <a:solidFill>
                   <a:srgbClr val="D95D39"/>
                 </a:solidFill>
@@ -5413,7 +5413,7 @@
           </a:p>
           <a:p>
             <a:pPr algn="ctr">
-              <a:defRPr sz="2200" b="1">
+              <a:defRPr sz="2600" b="1">
                 <a:solidFill>
                   <a:srgbClr val="F5F3EF"/>
                 </a:solidFill>
@@ -5427,7 +5427,7 @@
           <a:p>
             <a:br/>
             <a:pPr algn="ctr">
-              <a:defRPr sz="1500" b="1" i="1">
+              <a:defRPr sz="1800" b="1" i="1">
                 <a:solidFill>
                   <a:srgbClr val="FBBF24"/>
                 </a:solidFill>
@@ -5441,7 +5441,21 @@
           <a:p>
             <a:br/>
             <a:pPr algn="ctr">
-              <a:defRPr sz="1150">
+              <a:defRPr sz="1500" b="1">
+                <a:solidFill>
+                  <a:srgbClr val="F5F3EF"/>
+                </a:solidFill>
+                <a:latin typeface="Inter"/>
+              </a:defRPr>
+            </a:pPr>
+            <a:r>
+              <a:t>Four disconnected sources. One seller making the call.</a:t>
+            </a:r>
+          </a:p>
+          <a:p>
+            <a:br/>
+            <a:pPr algn="ctr">
+              <a:defRPr sz="1300">
                 <a:solidFill>
                   <a:srgbClr val="D1D5DB"/>
                 </a:solidFill>
@@ -5449,12 +5463,7 @@
               </a:defRPr>
             </a:pPr>
             <a:r>
-              <a:t>Today the seller opens 4 tabs and guesses. An erroneous refund burns inventory margin; an unfair denial destroys repeat customer trust.</a:t>
-            </a:r>
-            <a:br/>
-            <a:br/>
-            <a:r>
-              <a:t>The gap is not a missing return portal — it is the lack of an immutable trace linking order truth, video keyframes, and policy terms before money moves.</a:t>
+              <a:t>The gap is the absence of an auditable artifact linking order truth, video keyframes, and policy before money moves.</a:t>
             </a:r>
           </a:p>
         </p:txBody>
@@ -5752,7 +5761,7 @@
         <p:spPr>
           <a:xfrm>
             <a:off x="731520" y="1965960"/>
-            <a:ext cx="7132320" cy="4069080"/>
+            <a:ext cx="6949440" cy="4069080"/>
           </a:xfrm>
           <a:prstGeom prst="rect">
             <a:avLst/>
@@ -5805,7 +5814,7 @@
         <p:spPr>
           <a:xfrm>
             <a:off x="914400" y="2148840"/>
-            <a:ext cx="3291840" cy="2651760"/>
+            <a:ext cx="3200400" cy="2606040"/>
           </a:xfrm>
           <a:prstGeom prst="rect">
             <a:avLst/>
@@ -5828,8 +5837,8 @@
         </p:blipFill>
         <p:spPr>
           <a:xfrm>
-            <a:off x="4389120" y="2148840"/>
-            <a:ext cx="3291840" cy="2651760"/>
+            <a:off x="4297680" y="2148840"/>
+            <a:ext cx="3200400" cy="2606040"/>
           </a:xfrm>
           <a:prstGeom prst="rect">
             <a:avLst/>
@@ -5844,8 +5853,8 @@
         </p:nvSpPr>
         <p:spPr>
           <a:xfrm>
-            <a:off x="914400" y="4873752"/>
-            <a:ext cx="3291840" cy="320040"/>
+            <a:off x="914400" y="4846320"/>
+            <a:ext cx="3200400" cy="347472"/>
           </a:xfrm>
           <a:prstGeom prst="rect">
             <a:avLst/>
@@ -5876,7 +5885,7 @@
           <a:lstStyle/>
           <a:p>
             <a:pPr algn="ctr">
-              <a:defRPr sz="900" b="1">
+              <a:defRPr sz="1100" b="1">
                 <a:solidFill>
                   <a:srgbClr val="006B55"/>
                 </a:solidFill>
@@ -5897,8 +5906,8 @@
         </p:nvSpPr>
         <p:spPr>
           <a:xfrm>
-            <a:off x="4389120" y="4873752"/>
-            <a:ext cx="3291840" cy="320040"/>
+            <a:off x="4297680" y="4846320"/>
+            <a:ext cx="3200400" cy="347472"/>
           </a:xfrm>
           <a:prstGeom prst="rect">
             <a:avLst/>
@@ -5929,7 +5938,7 @@
           <a:lstStyle/>
           <a:p>
             <a:pPr algn="ctr">
-              <a:defRPr sz="900" b="1">
+              <a:defRPr sz="1100" b="1">
                 <a:solidFill>
                   <a:srgbClr val="991B1B"/>
                 </a:solidFill>
@@ -5950,8 +5959,8 @@
         </p:nvSpPr>
         <p:spPr>
           <a:xfrm>
-            <a:off x="914400" y="5257800"/>
-            <a:ext cx="6766560" cy="685800"/>
+            <a:off x="914400" y="5303520"/>
+            <a:ext cx="6583680" cy="594360"/>
           </a:xfrm>
           <a:prstGeom prst="rect">
             <a:avLst/>
@@ -5965,7 +5974,7 @@
           <a:lstStyle/>
           <a:p>
             <a:pPr>
-              <a:defRPr sz="1000">
+              <a:defRPr sz="1300" b="1">
                 <a:solidFill>
                   <a:srgbClr val="596E64"/>
                 </a:solidFill>
@@ -5973,7 +5982,20 @@
               </a:defRPr>
             </a:pPr>
             <a:r>
-              <a:t>Visual Grounding Honesty: Keyframe resolution proves black casing. Exact SKU barcode is unreadable in this frame; ReturnLens factually records 'Observed Color: Black · Exact SKU: Not verified' and cites frame 00:07.</a:t>
+              <a:t>Visual Grounding: Keyframe 00:07 confirms black casing. Exact SKU barcode is unverified in this frame.</a:t>
+            </a:r>
+          </a:p>
+          <a:p>
+            <a:pPr>
+              <a:defRPr sz="1150">
+                <a:solidFill>
+                  <a:srgbClr val="7A8E85"/>
+                </a:solidFill>
+                <a:latin typeface="Inter"/>
+              </a:defRPr>
+            </a:pPr>
+            <a:r>
+              <a:t>Frame citation provides a traceable timestamped reference, not absolute proof of video authenticity.</a:t>
             </a:r>
           </a:p>
         </p:txBody>
@@ -5986,8 +6008,8 @@
         </p:nvSpPr>
         <p:spPr>
           <a:xfrm>
-            <a:off x="8119872" y="1965960"/>
-            <a:ext cx="3340303" cy="4069080"/>
+            <a:off x="7955279" y="1965960"/>
+            <a:ext cx="3504895" cy="4069080"/>
           </a:xfrm>
           <a:prstGeom prst="rect">
             <a:avLst/>
@@ -6031,8 +6053,8 @@
         </p:nvSpPr>
         <p:spPr>
           <a:xfrm>
-            <a:off x="8302752" y="2103120"/>
-            <a:ext cx="2974543" cy="3794760"/>
+            <a:off x="8183879" y="2148840"/>
+            <a:ext cx="3047695" cy="3703320"/>
           </a:xfrm>
           <a:prstGeom prst="rect">
             <a:avLst/>
@@ -6046,7 +6068,7 @@
           <a:lstStyle/>
           <a:p>
             <a:pPr>
-              <a:defRPr sz="950" b="1">
+              <a:defRPr sz="1100" b="1">
                 <a:solidFill>
                   <a:srgbClr val="D95D39"/>
                 </a:solidFill>
@@ -6059,7 +6081,7 @@
           </a:p>
           <a:p>
             <a:pPr>
-              <a:defRPr sz="1600" b="1">
+              <a:defRPr sz="2200" b="1">
                 <a:solidFill>
                   <a:srgbClr val="991B1B"/>
                 </a:solidFill>
@@ -6067,26 +6089,13 @@
               </a:defRPr>
             </a:pPr>
             <a:r>
-              <a:t>P-03: COLOR CONTRADICTION</a:t>
-            </a:r>
-          </a:p>
-          <a:p>
-            <a:pPr>
-              <a:defRPr sz="950" b="1">
-                <a:solidFill>
-                  <a:srgbClr val="991B1B"/>
-                </a:solidFill>
-                <a:latin typeface="IBM Plex Mono"/>
-              </a:defRPr>
-            </a:pPr>
-            <a:r>
-              <a:t>STATUS: SELLER REVIEW REQUIRED</a:t>
+              <a:t>COLOR CONTRADICTION</a:t>
             </a:r>
           </a:p>
           <a:p>
             <a:br/>
             <a:pPr>
-              <a:defRPr sz="1100" b="1">
+              <a:defRPr sz="1500" b="1">
                 <a:solidFill>
                   <a:srgbClr val="172621"/>
                 </a:solidFill>
@@ -6094,120 +6103,149 @@
               </a:defRPr>
             </a:pPr>
             <a:r>
-              <a:t>Key Findings:</a:t>
-            </a:r>
-          </a:p>
-          <a:p>
+              <a:t>• ORDERED — Matte White</a:t>
+            </a:r>
+          </a:p>
+          <a:p>
+            <a:pPr>
+              <a:defRPr sz="1500" b="1">
+                <a:solidFill>
+                  <a:srgbClr val="991B1B"/>
+                </a:solidFill>
+                <a:latin typeface="Inter"/>
+              </a:defRPr>
+            </a:pPr>
+            <a:r>
+              <a:t>• OBSERVED — Midnight Black</a:t>
+            </a:r>
+          </a:p>
+          <a:p>
+            <a:pPr>
+              <a:defRPr sz="1400" b="1">
+                <a:solidFill>
+                  <a:srgbClr val="596E64"/>
+                </a:solidFill>
+                <a:latin typeface="Inter"/>
+              </a:defRPr>
+            </a:pPr>
+            <a:r>
+              <a:t>• EXACT SKU — Not verified</a:t>
+            </a:r>
+          </a:p>
+        </p:txBody>
+      </p:sp>
+      <p:sp>
+        <p:nvSpPr>
+          <p:cNvPr id="14" name="Rectangle 13"/>
+          <p:cNvSpPr/>
+          <p:nvPr/>
+        </p:nvSpPr>
+        <p:spPr>
+          <a:xfrm>
+            <a:off x="8183879" y="4434840"/>
+            <a:ext cx="3047695" cy="548640"/>
+          </a:xfrm>
+          <a:prstGeom prst="rect">
+            <a:avLst/>
+          </a:prstGeom>
+          <a:solidFill>
+            <a:srgbClr val="FCECE8"/>
+          </a:solidFill>
+          <a:ln w="19050">
+            <a:solidFill>
+              <a:srgbClr val="D95D39"/>
+            </a:solidFill>
+          </a:ln>
+        </p:spPr>
+        <p:style>
+          <a:lnRef idx="1">
+            <a:schemeClr val="accent1"/>
+          </a:lnRef>
+          <a:fillRef idx="3">
+            <a:schemeClr val="accent1"/>
+          </a:fillRef>
+          <a:effectRef idx="2">
+            <a:schemeClr val="accent1"/>
+          </a:effectRef>
+          <a:fontRef idx="minor">
+            <a:schemeClr val="lt1"/>
+          </a:fontRef>
+        </p:style>
+        <p:txBody>
+          <a:bodyPr rtlCol="0" anchor="ctr"/>
+          <a:lstStyle/>
+          <a:p>
+            <a:pPr algn="ctr">
+              <a:defRPr sz="1400" b="1">
+                <a:solidFill>
+                  <a:srgbClr val="991B1B"/>
+                </a:solidFill>
+                <a:latin typeface="IBM Plex Mono"/>
+              </a:defRPr>
+            </a:pPr>
+            <a:r>
+              <a:t>SELLER REVIEW REQUIRED</a:t>
+            </a:r>
+          </a:p>
+        </p:txBody>
+      </p:sp>
+      <p:sp>
+        <p:nvSpPr>
+          <p:cNvPr id="15" name="TextBox 14"/>
+          <p:cNvSpPr txBox="1"/>
+          <p:nvPr/>
+        </p:nvSpPr>
+        <p:spPr>
+          <a:xfrm>
+            <a:off x="8183879" y="5120640"/>
+            <a:ext cx="3047695" cy="731520"/>
+          </a:xfrm>
+          <a:prstGeom prst="rect">
+            <a:avLst/>
+          </a:prstGeom>
+          <a:noFill/>
+        </p:spPr>
+        <p:txBody>
+          <a:bodyPr wrap="square">
+            <a:spAutoFit/>
+          </a:bodyPr>
+          <a:lstStyle/>
+          <a:p>
+            <a:pPr>
+              <a:defRPr sz="1300" b="1">
+                <a:solidFill>
+                  <a:srgbClr val="172621"/>
+                </a:solidFill>
+                <a:latin typeface="Inter"/>
+              </a:defRPr>
+            </a:pPr>
+            <a:r>
+              <a:t>No automatic denial or refund without seller authorization.</a:t>
+            </a:r>
+          </a:p>
+          <a:p>
+            <a:br/>
             <a:pPr>
               <a:defRPr sz="1000">
                 <a:solidFill>
                   <a:srgbClr val="596E64"/>
                 </a:solidFill>
-                <a:latin typeface="Inter"/>
-              </a:defRPr>
-            </a:pPr>
-            <a:r>
-              <a:t>• OBSERVED: Midnight Black</a:t>
-            </a:r>
-          </a:p>
-          <a:p>
-            <a:pPr>
-              <a:defRPr sz="1000">
-                <a:solidFill>
-                  <a:srgbClr val="596E64"/>
-                </a:solidFill>
-                <a:latin typeface="Inter"/>
-              </a:defRPr>
-            </a:pPr>
-            <a:r>
-              <a:t>• UNVERIFIED: Exact SKU barcode</a:t>
-            </a:r>
-          </a:p>
-          <a:p>
-            <a:pPr>
-              <a:defRPr sz="1000">
-                <a:solidFill>
-                  <a:srgbClr val="596E64"/>
-                </a:solidFill>
-                <a:latin typeface="Inter"/>
-              </a:defRPr>
-            </a:pPr>
-            <a:r>
-              <a:t>• NEXT ACTION: Seller review</a:t>
-            </a:r>
-          </a:p>
-          <a:p>
+                <a:latin typeface="IBM Plex Mono"/>
+              </a:defRPr>
+            </a:pPr>
+            <a:r>
+              <a:t>Financial safety ceiling:</a:t>
+            </a:r>
             <a:br/>
-            <a:pPr>
-              <a:defRPr sz="1100" b="1">
-                <a:solidFill>
-                  <a:srgbClr val="172621"/>
-                </a:solidFill>
-                <a:latin typeface="Inter"/>
-              </a:defRPr>
-            </a:pPr>
-            <a:r>
-              <a:t>Seller Resolution Options:</a:t>
-            </a:r>
-          </a:p>
-          <a:p>
-            <a:pPr>
-              <a:defRPr sz="950">
-                <a:solidFill>
-                  <a:srgbClr val="596E64"/>
-                </a:solidFill>
-                <a:latin typeface="Inter"/>
-              </a:defRPr>
-            </a:pPr>
-            <a:r>
-              <a:t>1. Request unboxing box label photo</a:t>
-            </a:r>
-          </a:p>
-          <a:p>
-            <a:pPr>
-              <a:defRPr sz="950">
-                <a:solidFill>
-                  <a:srgbClr val="596E64"/>
-                </a:solidFill>
-                <a:latin typeface="Inter"/>
-              </a:defRPr>
-            </a:pPr>
-            <a:r>
-              <a:t>2. Reject return (item does not match order)</a:t>
-            </a:r>
-          </a:p>
-          <a:p>
-            <a:pPr>
-              <a:defRPr sz="950">
-                <a:solidFill>
-                  <a:srgbClr val="596E64"/>
-                </a:solidFill>
-                <a:latin typeface="Inter"/>
-              </a:defRPr>
-            </a:pPr>
-            <a:r>
-              <a:t>3. Override &amp; approve (warehouse error)</a:t>
-            </a:r>
-          </a:p>
-          <a:p>
-            <a:br/>
-            <a:pPr>
-              <a:defRPr sz="900" b="1">
-                <a:solidFill>
-                  <a:srgbClr val="596E64"/>
-                </a:solidFill>
-                <a:latin typeface="IBM Plex Mono"/>
-              </a:defRPr>
-            </a:pPr>
-            <a:r>
-              <a:t>No auto-denial · No refund without seller click</a:t>
-            </a:r>
-          </a:p>
-        </p:txBody>
-      </p:sp>
-      <p:sp>
-        <p:nvSpPr>
-          <p:cNvPr id="14" name="Rectangle 13"/>
+            <a:r>
+              <a:t>0 &lt; amount &lt;= min(₹4,999, remaining, paid)</a:t>
+            </a:r>
+          </a:p>
+        </p:txBody>
+      </p:sp>
+      <p:sp>
+        <p:nvSpPr>
+          <p:cNvPr id="16" name="Rectangle 15"/>
           <p:cNvSpPr/>
           <p:nvPr/>
         </p:nvSpPr>
@@ -6250,7 +6288,7 @@
       </p:sp>
       <p:sp>
         <p:nvSpPr>
-          <p:cNvPr id="15" name="TextBox 14"/>
+          <p:cNvPr id="17" name="TextBox 16"/>
           <p:cNvSpPr txBox="1"/>
           <p:nvPr/>
         </p:nvSpPr>
@@ -6279,14 +6317,14 @@
               </a:defRPr>
             </a:pPr>
             <a:r>
-              <a:t>Illustrative staged evidence · Mock Shopify &amp; Shippo APIs</a:t>
-            </a:r>
-          </a:p>
-        </p:txBody>
-      </p:sp>
-      <p:sp>
-        <p:nvSpPr>
-          <p:cNvPr id="16" name="TextBox 15"/>
+              <a:t>Illustrative staged evidence · Exact SKU: Not verified · Mock Shopify &amp; Shippo APIs</a:t>
+            </a:r>
+          </a:p>
+        </p:txBody>
+      </p:sp>
+      <p:sp>
+        <p:nvSpPr>
+          <p:cNvPr id="18" name="TextBox 17"/>
           <p:cNvSpPr txBox="1"/>
           <p:nvPr/>
         </p:nvSpPr>
@@ -6476,7 +6514,7 @@
           <a:lstStyle/>
           <a:p>
             <a:pPr>
-              <a:defRPr sz="1900">
+              <a:defRPr sz="1800">
                 <a:solidFill>
                   <a:srgbClr val="A3B8B0"/>
                 </a:solidFill>
@@ -6531,7 +6569,7 @@
           <a:lstStyle/>
           <a:p>
             <a:pPr algn="ctr">
-              <a:defRPr sz="950" b="1">
+              <a:defRPr sz="1200" b="1">
                 <a:solidFill>
                   <a:srgbClr val="00D1A7"/>
                 </a:solidFill>
@@ -6539,12 +6577,12 @@
               </a:defRPr>
             </a:pPr>
             <a:r>
-              <a:t>01 MODEL ZONE</a:t>
+              <a:t>MODEL</a:t>
             </a:r>
           </a:p>
           <a:p>
             <a:pPr>
-              <a:defRPr sz="1300" b="1">
+              <a:defRPr sz="1550" b="1">
                 <a:solidFill>
                   <a:srgbClr val="F5F3EF"/>
                 </a:solidFill>
@@ -6552,12 +6590,12 @@
               </a:defRPr>
             </a:pPr>
             <a:r>
-              <a:t>Plan &amp; Observe</a:t>
+              <a:t>Plan and observe</a:t>
             </a:r>
           </a:p>
           <a:p>
             <a:pPr>
-              <a:defRPr sz="950">
+              <a:defRPr sz="1200">
                 <a:solidFill>
                   <a:srgbClr val="A3B8B0"/>
                 </a:solidFill>
@@ -6565,7 +6603,7 @@
               </a:defRPr>
             </a:pPr>
             <a:r>
-              <a:t>Planner validates JSON schema · Vision extracts keyframes &amp; non-binding visual metadata.</a:t>
+              <a:t>Planner proposes typed actions · Vision model generates cited observations.</a:t>
             </a:r>
           </a:p>
         </p:txBody>
@@ -6622,7 +6660,7 @@
         <p:spPr>
           <a:xfrm>
             <a:off x="4242816" y="1965960"/>
-            <a:ext cx="3840480" cy="1234440"/>
+            <a:ext cx="3931920" cy="1234440"/>
           </a:xfrm>
           <a:prstGeom prst="rect">
             <a:avLst/>
@@ -6655,7 +6693,7 @@
           <a:lstStyle/>
           <a:p>
             <a:pPr algn="ctr">
-              <a:defRPr sz="950" b="1">
+              <a:defRPr sz="1200" b="1">
                 <a:solidFill>
                   <a:srgbClr val="F5F3EF"/>
                 </a:solidFill>
@@ -6663,12 +6701,12 @@
               </a:defRPr>
             </a:pPr>
             <a:r>
-              <a:t>02 CODE ZONE</a:t>
+              <a:t>CODE</a:t>
             </a:r>
           </a:p>
           <a:p>
             <a:pPr>
-              <a:defRPr sz="1300" b="1">
+              <a:defRPr sz="1550" b="1">
                 <a:solidFill>
                   <a:srgbClr val="F5F3EF"/>
                 </a:solidFill>
@@ -6676,12 +6714,12 @@
               </a:defRPr>
             </a:pPr>
             <a:r>
-              <a:t>Retrieve &amp; Enforce Policy</a:t>
+              <a:t>Retrieve, validate and enforce rules</a:t>
             </a:r>
           </a:p>
           <a:p>
             <a:pPr>
-              <a:defRPr sz="950">
+              <a:defRPr sz="1200">
                 <a:solidFill>
                   <a:srgbClr val="A3B8B0"/>
                 </a:solidFill>
@@ -6689,7 +6727,7 @@
               </a:defRPr>
             </a:pPr>
             <a:r>
-              <a:t>Deterministic Python rules P-01 to P-08 · Shippo &amp; Shopify mock APIs enforce hard rules.</a:t>
+              <a:t>Backend code validates schemas · FFmpeg extracts frames · Python code evaluates rules P-01 to P-08.</a:t>
             </a:r>
           </a:p>
         </p:txBody>
@@ -6703,7 +6741,7 @@
         <p:spPr>
           <a:xfrm>
             <a:off x="4242816" y="1965960"/>
-            <a:ext cx="3840480" cy="36576"/>
+            <a:ext cx="3931920" cy="36576"/>
           </a:xfrm>
           <a:prstGeom prst="rect">
             <a:avLst/>
@@ -6745,8 +6783,8 @@
         </p:nvSpPr>
         <p:spPr>
           <a:xfrm>
-            <a:off x="8302752" y="1965960"/>
-            <a:ext cx="3157423" cy="1234440"/>
+            <a:off x="8394192" y="1965960"/>
+            <a:ext cx="3065983" cy="1234440"/>
           </a:xfrm>
           <a:prstGeom prst="rect">
             <a:avLst/>
@@ -6779,7 +6817,7 @@
           <a:lstStyle/>
           <a:p>
             <a:pPr algn="ctr">
-              <a:defRPr sz="950" b="1">
+              <a:defRPr sz="1200" b="1">
                 <a:solidFill>
                   <a:srgbClr val="FBBF24"/>
                 </a:solidFill>
@@ -6787,12 +6825,12 @@
               </a:defRPr>
             </a:pPr>
             <a:r>
-              <a:t>03 HUMAN SELLER GATE</a:t>
+              <a:t>SELLER</a:t>
             </a:r>
           </a:p>
           <a:p>
             <a:pPr>
-              <a:defRPr sz="1300" b="1">
+              <a:defRPr sz="1550" b="1">
                 <a:solidFill>
                   <a:srgbClr val="F5F3EF"/>
                 </a:solidFill>
@@ -6800,12 +6838,12 @@
               </a:defRPr>
             </a:pPr>
             <a:r>
-              <a:t>Authorize Consequential Action</a:t>
+              <a:t>Approve consequential actions</a:t>
             </a:r>
           </a:p>
           <a:p>
             <a:pPr>
-              <a:defRPr sz="950">
+              <a:defRPr sz="1200">
                 <a:solidFill>
                   <a:srgbClr val="A3B8B0"/>
                 </a:solidFill>
@@ -6813,7 +6851,7 @@
               </a:defRPr>
             </a:pPr>
             <a:r>
-              <a:t>Fail-closed authorization gate · 1-click human merchant confirmation for refund release.</a:t>
+              <a:t>Fail-closed authorization gate · 1-click human merchant confirmation before refund release.</a:t>
             </a:r>
           </a:p>
         </p:txBody>
@@ -6826,8 +6864,8 @@
         </p:nvSpPr>
         <p:spPr>
           <a:xfrm>
-            <a:off x="8302752" y="1965960"/>
-            <a:ext cx="3157423" cy="36576"/>
+            <a:off x="8394192" y="1965960"/>
+            <a:ext cx="3065983" cy="36576"/>
           </a:xfrm>
           <a:prstGeom prst="rect">
             <a:avLst/>
@@ -6869,7 +6907,7 @@
         </p:nvSpPr>
         <p:spPr>
           <a:xfrm>
-            <a:off x="731520" y="3429000"/>
+            <a:off x="731520" y="3401568"/>
             <a:ext cx="10728655" cy="1874519"/>
           </a:xfrm>
           <a:prstGeom prst="rect">
@@ -6899,11 +6937,37 @@
           </a:fontRef>
         </p:style>
         <p:txBody>
-          <a:bodyPr rtlCol="0" anchor="ctr" wrap="square"/>
-          <a:lstStyle/>
-          <a:p>
-            <a:pPr algn="ctr">
-              <a:defRPr sz="1100" b="1">
+          <a:bodyPr rtlCol="0" anchor="ctr"/>
+          <a:lstStyle/>
+          <a:p>
+            <a:pPr algn="ctr"/>
+          </a:p>
+        </p:txBody>
+      </p:sp>
+      <p:sp>
+        <p:nvSpPr>
+          <p:cNvPr id="13" name="TextBox 12"/>
+          <p:cNvSpPr txBox="1"/>
+          <p:nvPr/>
+        </p:nvSpPr>
+        <p:spPr>
+          <a:xfrm>
+            <a:off x="914400" y="3511296"/>
+            <a:ext cx="10362895" cy="320040"/>
+          </a:xfrm>
+          <a:prstGeom prst="rect">
+            <a:avLst/>
+          </a:prstGeom>
+          <a:noFill/>
+        </p:spPr>
+        <p:txBody>
+          <a:bodyPr wrap="none">
+            <a:spAutoFit/>
+          </a:bodyPr>
+          <a:lstStyle/>
+          <a:p>
+            <a:pPr>
+              <a:defRPr sz="1300" b="1">
                 <a:solidFill>
                   <a:srgbClr val="93C5FD"/>
                 </a:solidFill>
@@ -6911,21 +6975,21 @@
               </a:defRPr>
             </a:pPr>
             <a:r>
-              <a:t>HERO AGENTIC INTERACTION: DYNAMIC STATEFUL CLARIFICATION LOOP (CASE C)</a:t>
-            </a:r>
-          </a:p>
-        </p:txBody>
-      </p:sp>
-      <p:sp>
-        <p:nvSpPr>
-          <p:cNvPr id="13" name="Rectangle 12"/>
+              <a:t>DYNAMIC STATEFUL CLARIFICATION LOOP (CASE C)</a:t>
+            </a:r>
+          </a:p>
+        </p:txBody>
+      </p:sp>
+      <p:sp>
+        <p:nvSpPr>
+          <p:cNvPr id="14" name="Rectangle 13"/>
           <p:cNvSpPr/>
           <p:nvPr/>
         </p:nvSpPr>
         <p:spPr>
           <a:xfrm>
-            <a:off x="914400" y="3904488"/>
-            <a:ext cx="1536192" cy="502920"/>
+            <a:off x="868680" y="3904488"/>
+            <a:ext cx="1627632" cy="594360"/>
           </a:xfrm>
           <a:prstGeom prst="rect">
             <a:avLst/>
@@ -6954,11 +7018,11 @@
           </a:fontRef>
         </p:style>
         <p:txBody>
-          <a:bodyPr rtlCol="0" anchor="ctr" wrap="square"/>
+          <a:bodyPr rtlCol="0" anchor="ctr" wrap="square" lIns="27432" rIns="27432"/>
           <a:lstStyle/>
           <a:p>
             <a:pPr algn="ctr">
-              <a:defRPr sz="850" b="1">
+              <a:defRPr sz="1000" b="1">
                 <a:solidFill>
                   <a:srgbClr val="F5F3EF"/>
                 </a:solidFill>
@@ -6966,21 +7030,21 @@
               </a:defRPr>
             </a:pPr>
             <a:r>
-              <a:t>Dark Frames (brightness 28)</a:t>
-            </a:r>
-          </a:p>
-        </p:txBody>
-      </p:sp>
-      <p:sp>
-        <p:nvSpPr>
-          <p:cNvPr id="14" name="TextBox 13"/>
+              <a:t>DARK EVIDENCE</a:t>
+            </a:r>
+          </a:p>
+        </p:txBody>
+      </p:sp>
+      <p:sp>
+        <p:nvSpPr>
+          <p:cNvPr id="15" name="TextBox 14"/>
           <p:cNvSpPr txBox="1"/>
           <p:nvPr/>
         </p:nvSpPr>
         <p:spPr>
           <a:xfrm>
-            <a:off x="2450592" y="3977640"/>
-            <a:ext cx="256032" cy="365760"/>
+            <a:off x="2478024" y="4014216"/>
+            <a:ext cx="201168" cy="365760"/>
           </a:xfrm>
           <a:prstGeom prst="rect">
             <a:avLst/>
@@ -6994,7 +7058,7 @@
           <a:lstStyle/>
           <a:p>
             <a:pPr algn="ctr">
-              <a:defRPr sz="1300" b="1">
+              <a:defRPr sz="1400" b="1">
                 <a:solidFill>
                   <a:srgbClr val="93C5FD"/>
                 </a:solidFill>
@@ -7009,14 +7073,14 @@
       </p:sp>
       <p:sp>
         <p:nvSpPr>
-          <p:cNvPr id="15" name="Rectangle 14"/>
+          <p:cNvPr id="16" name="Rectangle 15"/>
           <p:cNvSpPr/>
           <p:nvPr/>
         </p:nvSpPr>
         <p:spPr>
           <a:xfrm>
-            <a:off x="2706624" y="3904488"/>
-            <a:ext cx="1536192" cy="502920"/>
+            <a:off x="2660904" y="3904488"/>
+            <a:ext cx="1627632" cy="594360"/>
           </a:xfrm>
           <a:prstGeom prst="rect">
             <a:avLst/>
@@ -7045,11 +7109,11 @@
           </a:fontRef>
         </p:style>
         <p:txBody>
-          <a:bodyPr rtlCol="0" anchor="ctr" wrap="square"/>
+          <a:bodyPr rtlCol="0" anchor="ctr" wrap="square" lIns="27432" rIns="27432"/>
           <a:lstStyle/>
           <a:p>
             <a:pPr algn="ctr">
-              <a:defRPr sz="850" b="1">
+              <a:defRPr sz="1000" b="1">
                 <a:solidFill>
                   <a:srgbClr val="F5F3EF"/>
                 </a:solidFill>
@@ -7057,21 +7121,21 @@
               </a:defRPr>
             </a:pPr>
             <a:r>
-              <a:t>ask_for_evidence()</a:t>
-            </a:r>
-          </a:p>
-        </p:txBody>
-      </p:sp>
-      <p:sp>
-        <p:nvSpPr>
-          <p:cNvPr id="16" name="TextBox 15"/>
+              <a:t>ASK FOR PHOTO</a:t>
+            </a:r>
+          </a:p>
+        </p:txBody>
+      </p:sp>
+      <p:sp>
+        <p:nvSpPr>
+          <p:cNvPr id="17" name="TextBox 16"/>
           <p:cNvSpPr txBox="1"/>
           <p:nvPr/>
         </p:nvSpPr>
         <p:spPr>
           <a:xfrm>
-            <a:off x="4242816" y="3977640"/>
-            <a:ext cx="256032" cy="365760"/>
+            <a:off x="4270248" y="4014216"/>
+            <a:ext cx="201168" cy="365760"/>
           </a:xfrm>
           <a:prstGeom prst="rect">
             <a:avLst/>
@@ -7085,7 +7149,7 @@
           <a:lstStyle/>
           <a:p>
             <a:pPr algn="ctr">
-              <a:defRPr sz="1300" b="1">
+              <a:defRPr sz="1400" b="1">
                 <a:solidFill>
                   <a:srgbClr val="93C5FD"/>
                 </a:solidFill>
@@ -7100,14 +7164,14 @@
       </p:sp>
       <p:sp>
         <p:nvSpPr>
-          <p:cNvPr id="17" name="Rectangle 16"/>
+          <p:cNvPr id="18" name="Rectangle 17"/>
           <p:cNvSpPr/>
           <p:nvPr/>
         </p:nvSpPr>
         <p:spPr>
           <a:xfrm>
-            <a:off x="4498848" y="3904488"/>
-            <a:ext cx="1536192" cy="502920"/>
+            <a:off x="4453128" y="3904488"/>
+            <a:ext cx="1627632" cy="594360"/>
           </a:xfrm>
           <a:prstGeom prst="rect">
             <a:avLst/>
@@ -7115,7 +7179,7 @@
           <a:solidFill>
             <a:srgbClr val="1E3A8A"/>
           </a:solidFill>
-          <a:ln w="15240">
+          <a:ln w="19050">
             <a:solidFill>
               <a:srgbClr val="60A5FA"/>
             </a:solidFill>
@@ -7136,11 +7200,11 @@
           </a:fontRef>
         </p:style>
         <p:txBody>
-          <a:bodyPr rtlCol="0" anchor="ctr" wrap="square"/>
+          <a:bodyPr rtlCol="0" anchor="ctr" wrap="square" lIns="27432" rIns="27432"/>
           <a:lstStyle/>
           <a:p>
             <a:pPr algn="ctr">
-              <a:defRPr sz="850" b="1">
+              <a:defRPr sz="1000" b="1">
                 <a:solidFill>
                   <a:srgbClr val="DBEAFE"/>
                 </a:solidFill>
@@ -7155,14 +7219,14 @@
       </p:sp>
       <p:sp>
         <p:nvSpPr>
-          <p:cNvPr id="18" name="TextBox 17"/>
+          <p:cNvPr id="19" name="TextBox 18"/>
           <p:cNvSpPr txBox="1"/>
           <p:nvPr/>
         </p:nvSpPr>
         <p:spPr>
           <a:xfrm>
-            <a:off x="6035040" y="3977640"/>
-            <a:ext cx="256032" cy="365760"/>
+            <a:off x="6062472" y="4014216"/>
+            <a:ext cx="201168" cy="365760"/>
           </a:xfrm>
           <a:prstGeom prst="rect">
             <a:avLst/>
@@ -7176,7 +7240,7 @@
           <a:lstStyle/>
           <a:p>
             <a:pPr algn="ctr">
-              <a:defRPr sz="1300" b="1">
+              <a:defRPr sz="1400" b="1">
                 <a:solidFill>
                   <a:srgbClr val="93C5FD"/>
                 </a:solidFill>
@@ -7191,14 +7255,14 @@
       </p:sp>
       <p:sp>
         <p:nvSpPr>
-          <p:cNvPr id="19" name="Rectangle 18"/>
+          <p:cNvPr id="20" name="Rectangle 19"/>
           <p:cNvSpPr/>
           <p:nvPr/>
         </p:nvSpPr>
         <p:spPr>
           <a:xfrm>
-            <a:off x="6291072" y="3904488"/>
-            <a:ext cx="1536192" cy="502920"/>
+            <a:off x="6245352" y="3904488"/>
+            <a:ext cx="1627632" cy="594360"/>
           </a:xfrm>
           <a:prstGeom prst="rect">
             <a:avLst/>
@@ -7227,11 +7291,11 @@
           </a:fontRef>
         </p:style>
         <p:txBody>
-          <a:bodyPr rtlCol="0" anchor="ctr" wrap="square"/>
+          <a:bodyPr rtlCol="0" anchor="ctr" wrap="square" lIns="27432" rIns="27432"/>
           <a:lstStyle/>
           <a:p>
             <a:pPr algn="ctr">
-              <a:defRPr sz="850" b="1">
+              <a:defRPr sz="1000" b="1">
                 <a:solidFill>
                   <a:srgbClr val="F5F3EF"/>
                 </a:solidFill>
@@ -7239,21 +7303,21 @@
               </a:defRPr>
             </a:pPr>
             <a:r>
-              <a:t>Customer Uploads</a:t>
-            </a:r>
-          </a:p>
-        </p:txBody>
-      </p:sp>
-      <p:sp>
-        <p:nvSpPr>
-          <p:cNvPr id="20" name="TextBox 19"/>
+              <a:t>CUSTOMER UPLOAD</a:t>
+            </a:r>
+          </a:p>
+        </p:txBody>
+      </p:sp>
+      <p:sp>
+        <p:nvSpPr>
+          <p:cNvPr id="21" name="TextBox 20"/>
           <p:cNvSpPr txBox="1"/>
           <p:nvPr/>
         </p:nvSpPr>
         <p:spPr>
           <a:xfrm>
-            <a:off x="7827264" y="3977640"/>
-            <a:ext cx="256032" cy="365760"/>
+            <a:off x="7854696" y="4014216"/>
+            <a:ext cx="201168" cy="365760"/>
           </a:xfrm>
           <a:prstGeom prst="rect">
             <a:avLst/>
@@ -7267,7 +7331,7 @@
           <a:lstStyle/>
           <a:p>
             <a:pPr algn="ctr">
-              <a:defRPr sz="1300" b="1">
+              <a:defRPr sz="1400" b="1">
                 <a:solidFill>
                   <a:srgbClr val="93C5FD"/>
                 </a:solidFill>
@@ -7282,14 +7346,14 @@
       </p:sp>
       <p:sp>
         <p:nvSpPr>
-          <p:cNvPr id="21" name="Rectangle 20"/>
+          <p:cNvPr id="22" name="Rectangle 21"/>
           <p:cNvSpPr/>
           <p:nvPr/>
         </p:nvSpPr>
         <p:spPr>
           <a:xfrm>
-            <a:off x="8083296" y="3904488"/>
-            <a:ext cx="1536192" cy="502920"/>
+            <a:off x="8037576" y="3904488"/>
+            <a:ext cx="1627632" cy="594360"/>
           </a:xfrm>
           <a:prstGeom prst="rect">
             <a:avLst/>
@@ -7297,7 +7361,7 @@
           <a:solidFill>
             <a:srgbClr val="1E3A8A"/>
           </a:solidFill>
-          <a:ln w="15240">
+          <a:ln w="19050">
             <a:solidFill>
               <a:srgbClr val="60A5FA"/>
             </a:solidFill>
@@ -7318,11 +7382,11 @@
           </a:fontRef>
         </p:style>
         <p:txBody>
-          <a:bodyPr rtlCol="0" anchor="ctr" wrap="square"/>
+          <a:bodyPr rtlCol="0" anchor="ctr" wrap="square" lIns="27432" rIns="27432"/>
           <a:lstStyle/>
           <a:p>
             <a:pPr algn="ctr">
-              <a:defRPr sz="850" b="1">
+              <a:defRPr sz="1000" b="1">
                 <a:solidFill>
                   <a:srgbClr val="DBEAFE"/>
                 </a:solidFill>
@@ -7337,14 +7401,14 @@
       </p:sp>
       <p:sp>
         <p:nvSpPr>
-          <p:cNvPr id="22" name="TextBox 21"/>
+          <p:cNvPr id="23" name="TextBox 22"/>
           <p:cNvSpPr txBox="1"/>
           <p:nvPr/>
         </p:nvSpPr>
         <p:spPr>
           <a:xfrm>
-            <a:off x="9619488" y="3977640"/>
-            <a:ext cx="256032" cy="365760"/>
+            <a:off x="9646920" y="4014216"/>
+            <a:ext cx="201168" cy="365760"/>
           </a:xfrm>
           <a:prstGeom prst="rect">
             <a:avLst/>
@@ -7358,7 +7422,7 @@
           <a:lstStyle/>
           <a:p>
             <a:pPr algn="ctr">
-              <a:defRPr sz="1300" b="1">
+              <a:defRPr sz="1400" b="1">
                 <a:solidFill>
                   <a:srgbClr val="93C5FD"/>
                 </a:solidFill>
@@ -7373,14 +7437,14 @@
       </p:sp>
       <p:sp>
         <p:nvSpPr>
-          <p:cNvPr id="23" name="Rectangle 22"/>
+          <p:cNvPr id="24" name="Rectangle 23"/>
           <p:cNvSpPr/>
           <p:nvPr/>
         </p:nvSpPr>
         <p:spPr>
           <a:xfrm>
-            <a:off x="9875520" y="3904488"/>
-            <a:ext cx="1536192" cy="502920"/>
+            <a:off x="9829800" y="3904488"/>
+            <a:ext cx="1627632" cy="594360"/>
           </a:xfrm>
           <a:prstGeom prst="rect">
             <a:avLst/>
@@ -7409,11 +7473,11 @@
           </a:fontRef>
         </p:style>
         <p:txBody>
-          <a:bodyPr rtlCol="0" anchor="ctr" wrap="square"/>
+          <a:bodyPr rtlCol="0" anchor="ctr" wrap="square" lIns="27432" rIns="27432"/>
           <a:lstStyle/>
           <a:p>
             <a:pPr algn="ctr">
-              <a:defRPr sz="850" b="1">
+              <a:defRPr sz="1000" b="1">
                 <a:solidFill>
                   <a:srgbClr val="F5F3EF"/>
                 </a:solidFill>
@@ -7421,21 +7485,21 @@
               </a:defRPr>
             </a:pPr>
             <a:r>
-              <a:t>Seller Review</a:t>
-            </a:r>
-          </a:p>
-        </p:txBody>
-      </p:sp>
-      <p:sp>
-        <p:nvSpPr>
-          <p:cNvPr id="24" name="TextBox 23"/>
+              <a:t>SELLER REVIEW</a:t>
+            </a:r>
+          </a:p>
+        </p:txBody>
+      </p:sp>
+      <p:sp>
+        <p:nvSpPr>
+          <p:cNvPr id="25" name="TextBox 24"/>
           <p:cNvSpPr txBox="1"/>
           <p:nvPr/>
         </p:nvSpPr>
         <p:spPr>
           <a:xfrm>
-            <a:off x="914400" y="4572000"/>
-            <a:ext cx="10362895" cy="640080"/>
+            <a:off x="914400" y="4636008"/>
+            <a:ext cx="10362895" cy="502920"/>
           </a:xfrm>
           <a:prstGeom prst="rect">
             <a:avLst/>
@@ -7449,7 +7513,7 @@
           <a:lstStyle/>
           <a:p>
             <a:pPr>
-              <a:defRPr sz="1050">
+              <a:defRPr sz="1250">
                 <a:solidFill>
                   <a:srgbClr val="A3B8B0"/>
                 </a:solidFill>
@@ -7457,21 +7521,21 @@
               </a:defRPr>
             </a:pPr>
             <a:r>
-              <a:t>Why an agent? When video quality is insufficient, ReturnLens halts execution, issues a targeted re-film checklist, serializes case state into WAITING_FOR_EVIDENCE, and automatically resumes the exact case upon upload (1 retry limit prevents customer lock-out).</a:t>
-            </a:r>
-          </a:p>
-        </p:txBody>
-      </p:sp>
-      <p:sp>
-        <p:nvSpPr>
-          <p:cNvPr id="25" name="Rectangle 24"/>
+              <a:t>Agent calls ask_for_evidence() on low-light frames, serializes context, and resumes execution upon customer upload.</a:t>
+            </a:r>
+          </a:p>
+        </p:txBody>
+      </p:sp>
+      <p:sp>
+        <p:nvSpPr>
+          <p:cNvPr id="26" name="Rectangle 25"/>
           <p:cNvSpPr/>
           <p:nvPr/>
         </p:nvSpPr>
         <p:spPr>
           <a:xfrm>
-            <a:off x="731520" y="5486400"/>
-            <a:ext cx="10728655" cy="658368"/>
+            <a:off x="731520" y="5440680"/>
+            <a:ext cx="10728655" cy="713232"/>
           </a:xfrm>
           <a:prstGeom prst="rect">
             <a:avLst/>
@@ -7504,7 +7568,7 @@
           <a:lstStyle/>
           <a:p>
             <a:pPr algn="ctr">
-              <a:defRPr sz="900" b="1">
+              <a:defRPr sz="1100" b="1">
                 <a:solidFill>
                   <a:srgbClr val="34D399"/>
                 </a:solidFill>
@@ -7512,12 +7576,12 @@
               </a:defRPr>
             </a:pPr>
             <a:r>
-              <a:t>SECONDARY PS-04 ROUTE: Query store &amp; courier tracking for "Where is my order?" without calling multimodal vision models.</a:t>
+              <a:t>SECONDARY PS-04 ROUTE ("Where is my order?"): Store API → Courier API → Customer Reply (Zero vision overhead)</a:t>
             </a:r>
           </a:p>
           <a:p>
             <a:pPr>
-              <a:defRPr sz="900">
+              <a:defRPr sz="1050">
                 <a:solidFill>
                   <a:srgbClr val="A3B8B0"/>
                 </a:solidFill>
@@ -7525,14 +7589,14 @@
               </a:defRPr>
             </a:pPr>
             <a:r>
-              <a:t>SYSTEM OUTPUT: Immutable JSON Audit Trail recorded at every state transition</a:t>
-            </a:r>
-          </a:p>
-        </p:txBody>
-      </p:sp>
-      <p:sp>
-        <p:nvSpPr>
-          <p:cNvPr id="26" name="Rectangle 25"/>
+              <a:t>Structured JSON Audit Log recorded at every state transition.</a:t>
+            </a:r>
+          </a:p>
+        </p:txBody>
+      </p:sp>
+      <p:sp>
+        <p:nvSpPr>
+          <p:cNvPr id="27" name="Rectangle 26"/>
           <p:cNvSpPr/>
           <p:nvPr/>
         </p:nvSpPr>
@@ -7575,7 +7639,7 @@
       </p:sp>
       <p:sp>
         <p:nvSpPr>
-          <p:cNvPr id="27" name="TextBox 26"/>
+          <p:cNvPr id="28" name="TextBox 27"/>
           <p:cNvSpPr txBox="1"/>
           <p:nvPr/>
         </p:nvSpPr>
@@ -7604,14 +7668,14 @@
               </a:defRPr>
             </a:pPr>
             <a:r>
-              <a:t>Structured audit log recorded at every state transition · Decision priority: Contradiction &gt; Hard fail &gt; Unclear only &gt; All pass</a:t>
-            </a:r>
-          </a:p>
-        </p:txBody>
-      </p:sp>
-      <p:sp>
-        <p:nvSpPr>
-          <p:cNvPr id="28" name="TextBox 27"/>
+              <a:t>Structured JSON Audit Log recorded at every state transition · Decision priority: Contradiction &gt; Hard fail &gt; Unclear only &gt; All pass</a:t>
+            </a:r>
+          </a:p>
+        </p:txBody>
+      </p:sp>
+      <p:sp>
+        <p:nvSpPr>
+          <p:cNvPr id="29" name="TextBox 28"/>
           <p:cNvSpPr txBox="1"/>
           <p:nvPr/>
         </p:nvSpPr>
@@ -7801,7 +7865,7 @@
           <a:lstStyle/>
           <a:p>
             <a:pPr>
-              <a:defRPr sz="1900">
+              <a:defRPr sz="1800">
                 <a:solidFill>
                   <a:srgbClr val="596E64"/>
                 </a:solidFill>
@@ -7867,8 +7931,8 @@
         </p:nvSpPr>
         <p:spPr>
           <a:xfrm>
-            <a:off x="914400" y="2276856"/>
-            <a:ext cx="1920240" cy="429768"/>
+            <a:off x="914400" y="2258568"/>
+            <a:ext cx="2011680" cy="457200"/>
           </a:xfrm>
           <a:prstGeom prst="rect">
             <a:avLst/>
@@ -7899,7 +7963,7 @@
           <a:lstStyle/>
           <a:p>
             <a:pPr algn="ctr">
-              <a:defRPr sz="1050" b="1">
+              <a:defRPr sz="1200" b="1">
                 <a:solidFill>
                   <a:srgbClr val="006B55"/>
                 </a:solidFill>
@@ -7920,8 +7984,8 @@
         </p:nvSpPr>
         <p:spPr>
           <a:xfrm>
-            <a:off x="2971800" y="2167128"/>
-            <a:ext cx="3749039" cy="640080"/>
+            <a:off x="3063240" y="2167128"/>
+            <a:ext cx="3657600" cy="640080"/>
           </a:xfrm>
           <a:prstGeom prst="rect">
             <a:avLst/>
@@ -7935,7 +7999,7 @@
           <a:lstStyle/>
           <a:p>
             <a:pPr>
-              <a:defRPr sz="1100" b="1">
+              <a:defRPr sz="1300" b="1">
                 <a:solidFill>
                   <a:srgbClr val="172621"/>
                 </a:solidFill>
@@ -7956,7 +8020,7 @@
         </p:nvSpPr>
         <p:spPr>
           <a:xfrm>
-            <a:off x="6812280" y="2258568"/>
+            <a:off x="6812280" y="2240280"/>
             <a:ext cx="274320" cy="457200"/>
           </a:xfrm>
           <a:prstGeom prst="rect">
@@ -7971,7 +8035,7 @@
           <a:lstStyle/>
           <a:p>
             <a:pPr>
-              <a:defRPr sz="1600" b="1">
+              <a:defRPr sz="1800" b="1">
                 <a:solidFill>
                   <a:srgbClr val="006B55"/>
                 </a:solidFill>
@@ -7992,8 +8056,8 @@
         </p:nvSpPr>
         <p:spPr>
           <a:xfrm>
-            <a:off x="7178040" y="2167128"/>
-            <a:ext cx="4114800" cy="640080"/>
+            <a:off x="7178040" y="2148840"/>
+            <a:ext cx="4114800" cy="685800"/>
           </a:xfrm>
           <a:prstGeom prst="rect">
             <a:avLst/>
@@ -8007,7 +8071,7 @@
           <a:lstStyle/>
           <a:p>
             <a:pPr>
-              <a:defRPr sz="1100" b="1">
+              <a:defRPr sz="1400" b="1">
                 <a:solidFill>
                   <a:srgbClr val="006B55"/>
                 </a:solidFill>
@@ -8020,7 +8084,7 @@
           </a:p>
           <a:p>
             <a:pPr>
-              <a:defRPr sz="1000">
+              <a:defRPr sz="1200">
                 <a:solidFill>
                   <a:srgbClr val="596E64"/>
                 </a:solidFill>
@@ -8028,7 +8092,7 @@
               </a:defRPr>
             </a:pPr>
             <a:r>
-              <a:t>Drafts mock shipping label and refund draft in pending_return_receipt. Money releases only on physical receipt.</a:t>
+              <a:t>Drafts mock return label and refund draft in pending_return_receipt. Money releases only on physical receipt.</a:t>
             </a:r>
           </a:p>
         </p:txBody>
@@ -8086,8 +8150,8 @@
         </p:nvSpPr>
         <p:spPr>
           <a:xfrm>
-            <a:off x="914400" y="3255264"/>
-            <a:ext cx="1920240" cy="429768"/>
+            <a:off x="914400" y="3236976"/>
+            <a:ext cx="2011680" cy="457200"/>
           </a:xfrm>
           <a:prstGeom prst="rect">
             <a:avLst/>
@@ -8118,7 +8182,7 @@
           <a:lstStyle/>
           <a:p>
             <a:pPr algn="ctr">
-              <a:defRPr sz="1050" b="1">
+              <a:defRPr sz="1200" b="1">
                 <a:solidFill>
                   <a:srgbClr val="991B1B"/>
                 </a:solidFill>
@@ -8139,8 +8203,8 @@
         </p:nvSpPr>
         <p:spPr>
           <a:xfrm>
-            <a:off x="2971800" y="3145536"/>
-            <a:ext cx="3749039" cy="640080"/>
+            <a:off x="3063240" y="3145536"/>
+            <a:ext cx="3657600" cy="640080"/>
           </a:xfrm>
           <a:prstGeom prst="rect">
             <a:avLst/>
@@ -8154,7 +8218,7 @@
           <a:lstStyle/>
           <a:p>
             <a:pPr>
-              <a:defRPr sz="1100" b="1">
+              <a:defRPr sz="1300" b="1">
                 <a:solidFill>
                   <a:srgbClr val="172621"/>
                 </a:solidFill>
@@ -8175,7 +8239,7 @@
         </p:nvSpPr>
         <p:spPr>
           <a:xfrm>
-            <a:off x="6812280" y="3236976"/>
+            <a:off x="6812280" y="3218688"/>
             <a:ext cx="274320" cy="457200"/>
           </a:xfrm>
           <a:prstGeom prst="rect">
@@ -8190,7 +8254,7 @@
           <a:lstStyle/>
           <a:p>
             <a:pPr>
-              <a:defRPr sz="1600" b="1">
+              <a:defRPr sz="1800" b="1">
                 <a:solidFill>
                   <a:srgbClr val="006B55"/>
                 </a:solidFill>
@@ -8211,8 +8275,8 @@
         </p:nvSpPr>
         <p:spPr>
           <a:xfrm>
-            <a:off x="7178040" y="3145536"/>
-            <a:ext cx="4114800" cy="640080"/>
+            <a:off x="7178040" y="3127248"/>
+            <a:ext cx="4114800" cy="685800"/>
           </a:xfrm>
           <a:prstGeom prst="rect">
             <a:avLst/>
@@ -8226,7 +8290,7 @@
           <a:lstStyle/>
           <a:p>
             <a:pPr>
-              <a:defRPr sz="1100" b="1">
+              <a:defRPr sz="1400" b="1">
                 <a:solidFill>
                   <a:srgbClr val="991B1B"/>
                 </a:solidFill>
@@ -8239,7 +8303,7 @@
           </a:p>
           <a:p>
             <a:pPr>
-              <a:defRPr sz="1000">
+              <a:defRPr sz="1200">
                 <a:solidFill>
                   <a:srgbClr val="596E64"/>
                 </a:solidFill>
@@ -8305,8 +8369,8 @@
         </p:nvSpPr>
         <p:spPr>
           <a:xfrm>
-            <a:off x="914400" y="4233672"/>
-            <a:ext cx="1920240" cy="429768"/>
+            <a:off x="914400" y="4215384"/>
+            <a:ext cx="2011680" cy="457200"/>
           </a:xfrm>
           <a:prstGeom prst="rect">
             <a:avLst/>
@@ -8337,7 +8401,7 @@
           <a:lstStyle/>
           <a:p>
             <a:pPr algn="ctr">
-              <a:defRPr sz="1050" b="1">
+              <a:defRPr sz="1200" b="1">
                 <a:solidFill>
                   <a:srgbClr val="1E40AF"/>
                 </a:solidFill>
@@ -8358,8 +8422,8 @@
         </p:nvSpPr>
         <p:spPr>
           <a:xfrm>
-            <a:off x="2971800" y="4123944"/>
-            <a:ext cx="3749039" cy="640080"/>
+            <a:off x="3063240" y="4123944"/>
+            <a:ext cx="3657600" cy="640080"/>
           </a:xfrm>
           <a:prstGeom prst="rect">
             <a:avLst/>
@@ -8373,7 +8437,7 @@
           <a:lstStyle/>
           <a:p>
             <a:pPr>
-              <a:defRPr sz="1100" b="1">
+              <a:defRPr sz="1300" b="1">
                 <a:solidFill>
                   <a:srgbClr val="172621"/>
                 </a:solidFill>
@@ -8381,7 +8445,7 @@
               </a:defRPr>
             </a:pPr>
             <a:r>
-              <a:t>Dark or Unreadable Evidence · 4s low-light video (brightness 28/255), barcode obscured</a:t>
+              <a:t>Insufficient Visual Evidence · 4s low-light video (brightness 28/255), barcode obscured</a:t>
             </a:r>
           </a:p>
         </p:txBody>
@@ -8394,7 +8458,7 @@
         </p:nvSpPr>
         <p:spPr>
           <a:xfrm>
-            <a:off x="6812280" y="4215384"/>
+            <a:off x="6812280" y="4197096"/>
             <a:ext cx="274320" cy="457200"/>
           </a:xfrm>
           <a:prstGeom prst="rect">
@@ -8409,7 +8473,7 @@
           <a:lstStyle/>
           <a:p>
             <a:pPr>
-              <a:defRPr sz="1600" b="1">
+              <a:defRPr sz="1800" b="1">
                 <a:solidFill>
                   <a:srgbClr val="006B55"/>
                 </a:solidFill>
@@ -8430,8 +8494,8 @@
         </p:nvSpPr>
         <p:spPr>
           <a:xfrm>
-            <a:off x="7178040" y="4123944"/>
-            <a:ext cx="4114800" cy="640080"/>
+            <a:off x="7178040" y="4105656"/>
+            <a:ext cx="4114800" cy="685800"/>
           </a:xfrm>
           <a:prstGeom prst="rect">
             <a:avLst/>
@@ -8445,7 +8509,7 @@
           <a:lstStyle/>
           <a:p>
             <a:pPr>
-              <a:defRPr sz="1100" b="1">
+              <a:defRPr sz="1400" b="1">
                 <a:solidFill>
                   <a:srgbClr val="1E40AF"/>
                 </a:solidFill>
@@ -8458,7 +8522,7 @@
           </a:p>
           <a:p>
             <a:pPr>
-              <a:defRPr sz="1000">
+              <a:defRPr sz="1200">
                 <a:solidFill>
                   <a:srgbClr val="596E64"/>
                 </a:solidFill>
@@ -8524,8 +8588,8 @@
         </p:nvSpPr>
         <p:spPr>
           <a:xfrm>
-            <a:off x="914400" y="5212080"/>
-            <a:ext cx="1920240" cy="429768"/>
+            <a:off x="914400" y="5193792"/>
+            <a:ext cx="2011680" cy="457200"/>
           </a:xfrm>
           <a:prstGeom prst="rect">
             <a:avLst/>
@@ -8556,7 +8620,7 @@
           <a:lstStyle/>
           <a:p>
             <a:pPr algn="ctr">
-              <a:defRPr sz="1050" b="1">
+              <a:defRPr sz="1200" b="1">
                 <a:solidFill>
                   <a:srgbClr val="065F46"/>
                 </a:solidFill>
@@ -8577,8 +8641,8 @@
         </p:nvSpPr>
         <p:spPr>
           <a:xfrm>
-            <a:off x="2971800" y="5102352"/>
-            <a:ext cx="3749039" cy="640080"/>
+            <a:off x="3063240" y="5102352"/>
+            <a:ext cx="3657600" cy="640080"/>
           </a:xfrm>
           <a:prstGeom prst="rect">
             <a:avLst/>
@@ -8592,7 +8656,7 @@
           <a:lstStyle/>
           <a:p>
             <a:pPr>
-              <a:defRPr sz="1100" b="1">
+              <a:defRPr sz="1300" b="1">
                 <a:solidFill>
                   <a:srgbClr val="172621"/>
                 </a:solidFill>
@@ -8613,7 +8677,7 @@
         </p:nvSpPr>
         <p:spPr>
           <a:xfrm>
-            <a:off x="6812280" y="5193792"/>
+            <a:off x="6812280" y="5175504"/>
             <a:ext cx="274320" cy="457200"/>
           </a:xfrm>
           <a:prstGeom prst="rect">
@@ -8628,7 +8692,7 @@
           <a:lstStyle/>
           <a:p>
             <a:pPr>
-              <a:defRPr sz="1600" b="1">
+              <a:defRPr sz="1800" b="1">
                 <a:solidFill>
                   <a:srgbClr val="006B55"/>
                 </a:solidFill>
@@ -8649,8 +8713,8 @@
         </p:nvSpPr>
         <p:spPr>
           <a:xfrm>
-            <a:off x="7178040" y="5102352"/>
-            <a:ext cx="4114800" cy="640080"/>
+            <a:off x="7178040" y="5084064"/>
+            <a:ext cx="4114800" cy="685800"/>
           </a:xfrm>
           <a:prstGeom prst="rect">
             <a:avLst/>
@@ -8664,7 +8728,7 @@
           <a:lstStyle/>
           <a:p>
             <a:pPr>
-              <a:defRPr sz="1100" b="1">
+              <a:defRPr sz="1400" b="1">
                 <a:solidFill>
                   <a:srgbClr val="065F46"/>
                 </a:solidFill>
@@ -8677,7 +8741,7 @@
           </a:p>
           <a:p>
             <a:pPr>
-              <a:defRPr sz="1000">
+              <a:defRPr sz="1200">
                 <a:solidFill>
                   <a:srgbClr val="596E64"/>
                 </a:solidFill>
@@ -8685,7 +8749,7 @@
               </a:defRPr>
             </a:pPr>
             <a:r>
-              <a:t>Expected prototype behavior: inspects sequence continuity and flags cutaways for seller review.</a:t>
+              <a:t>Expected prototype behavior: inspect sequence continuity and flag cutaways for seller review.</a:t>
             </a:r>
           </a:p>
         </p:txBody>
@@ -8961,7 +9025,7 @@
           <a:lstStyle/>
           <a:p>
             <a:pPr>
-              <a:defRPr sz="1900">
+              <a:defRPr sz="1800">
                 <a:solidFill>
                   <a:srgbClr val="596E64"/>
                 </a:solidFill>
@@ -9059,7 +9123,7 @@
           <a:lstStyle/>
           <a:p>
             <a:pPr algn="ctr">
-              <a:defRPr sz="1000" b="1">
+              <a:defRPr sz="1200" b="1">
                 <a:solidFill>
                   <a:srgbClr val="006B55"/>
                 </a:solidFill>
@@ -9067,12 +9131,12 @@
               </a:defRPr>
             </a:pPr>
             <a:r>
-              <a:t>00–06h · FOUNDATION</a:t>
+              <a:t>00–06h</a:t>
             </a:r>
           </a:p>
           <a:p>
             <a:pPr>
-              <a:defRPr sz="1300" b="1">
+              <a:defRPr sz="1500" b="1">
                 <a:solidFill>
                   <a:srgbClr val="172621"/>
                 </a:solidFill>
@@ -9085,7 +9149,7 @@
           </a:p>
           <a:p>
             <a:pPr>
-              <a:defRPr sz="1000" b="1">
+              <a:defRPr sz="1150" b="1">
                 <a:solidFill>
                   <a:srgbClr val="006B55"/>
                 </a:solidFill>
@@ -9093,12 +9157,12 @@
               </a:defRPr>
             </a:pPr>
             <a:r>
-              <a:t>Person A (Backend)</a:t>
+              <a:t>Person A (Agent / Backend / Policy)</a:t>
             </a:r>
           </a:p>
           <a:p>
             <a:pPr>
-              <a:defRPr sz="950">
+              <a:defRPr sz="1100">
                 <a:solidFill>
                   <a:srgbClr val="596E64"/>
                 </a:solidFill>
@@ -9106,7 +9170,7 @@
               </a:defRPr>
             </a:pPr>
             <a:r>
-              <a:t>LangGraph state machine, mock store &amp; courier fixtures, order status route.</a:t>
+              <a:t>LangGraph state machine, mock store &amp; courier fixtures, order status fast path.</a:t>
             </a:r>
           </a:p>
         </p:txBody>
@@ -9153,7 +9217,7 @@
           <a:lstStyle/>
           <a:p>
             <a:pPr algn="ctr">
-              <a:defRPr sz="1000" b="1">
+              <a:defRPr sz="1200" b="1">
                 <a:solidFill>
                   <a:srgbClr val="006B55"/>
                 </a:solidFill>
@@ -9161,12 +9225,12 @@
               </a:defRPr>
             </a:pPr>
             <a:r>
-              <a:t>06–12h · EVIDENCE</a:t>
+              <a:t>06–12h</a:t>
             </a:r>
           </a:p>
           <a:p>
             <a:pPr>
-              <a:defRPr sz="1300" b="1">
+              <a:defRPr sz="1500" b="1">
                 <a:solidFill>
                   <a:srgbClr val="172621"/>
                 </a:solidFill>
@@ -9179,7 +9243,7 @@
           </a:p>
           <a:p>
             <a:pPr>
-              <a:defRPr sz="1000" b="1">
+              <a:defRPr sz="1150" b="1">
                 <a:solidFill>
                   <a:srgbClr val="006B55"/>
                 </a:solidFill>
@@ -9187,12 +9251,12 @@
               </a:defRPr>
             </a:pPr>
             <a:r>
-              <a:t>Person B (Vision &amp; UI)</a:t>
+              <a:t>Person B (Vision / Evidence / UI)</a:t>
             </a:r>
           </a:p>
           <a:p>
             <a:pPr>
-              <a:defRPr sz="950">
+              <a:defRPr sz="1100">
                 <a:solidFill>
                   <a:srgbClr val="596E64"/>
                 </a:solidFill>
@@ -9200,7 +9264,7 @@
               </a:defRPr>
             </a:pPr>
             <a:r>
-              <a:t>FFmpeg keyframe indexer, vision prompt schema, rules P-01 to P-08, critic prompt.</a:t>
+              <a:t>FFmpeg keyframe indexer, vision prompt schema, critic prompt, seller console UI.</a:t>
             </a:r>
           </a:p>
         </p:txBody>
@@ -9247,7 +9311,7 @@
           <a:lstStyle/>
           <a:p>
             <a:pPr algn="ctr">
-              <a:defRPr sz="1000" b="1">
+              <a:defRPr sz="1200" b="1">
                 <a:solidFill>
                   <a:srgbClr val="006B55"/>
                 </a:solidFill>
@@ -9255,12 +9319,12 @@
               </a:defRPr>
             </a:pPr>
             <a:r>
-              <a:t>12–18h · INTEGRATION</a:t>
+              <a:t>12–18h</a:t>
             </a:r>
           </a:p>
           <a:p>
             <a:pPr>
-              <a:defRPr sz="1300" b="1">
+              <a:defRPr sz="1500" b="1">
                 <a:solidFill>
                   <a:srgbClr val="172621"/>
                 </a:solidFill>
@@ -9273,7 +9337,7 @@
           </a:p>
           <a:p>
             <a:pPr>
-              <a:defRPr sz="1000" b="1">
+              <a:defRPr sz="1150" b="1">
                 <a:solidFill>
                   <a:srgbClr val="006B55"/>
                 </a:solidFill>
@@ -9281,12 +9345,12 @@
               </a:defRPr>
             </a:pPr>
             <a:r>
-              <a:t>Person C (Integration with A/B)</a:t>
+              <a:t>Person C (Fixtures / Integration / QA)</a:t>
             </a:r>
           </a:p>
           <a:p>
             <a:pPr>
-              <a:defRPr sz="950">
+              <a:defRPr sz="1100">
                 <a:solidFill>
                   <a:srgbClr val="596E64"/>
                 </a:solidFill>
@@ -9294,7 +9358,7 @@
               </a:defRPr>
             </a:pPr>
             <a:r>
-              <a:t>Clarification/resume loop, seller review console UI, wiring 4 staged demo cases.</a:t>
+              <a:t>Clarification/resume loop, wiring 4 staged demo cases, end-to-end event bus.</a:t>
             </a:r>
           </a:p>
         </p:txBody>
@@ -9341,7 +9405,7 @@
           <a:lstStyle/>
           <a:p>
             <a:pPr algn="ctr">
-              <a:defRPr sz="1000" b="1">
+              <a:defRPr sz="1200" b="1">
                 <a:solidFill>
                   <a:srgbClr val="006B55"/>
                 </a:solidFill>
@@ -9349,12 +9413,12 @@
               </a:defRPr>
             </a:pPr>
             <a:r>
-              <a:t>18–24h · VALIDATION</a:t>
+              <a:t>18–24h</a:t>
             </a:r>
           </a:p>
           <a:p>
             <a:pPr>
-              <a:defRPr sz="1300" b="1">
+              <a:defRPr sz="1500" b="1">
                 <a:solidFill>
                   <a:srgbClr val="172621"/>
                 </a:solidFill>
@@ -9367,7 +9431,7 @@
           </a:p>
           <a:p>
             <a:pPr>
-              <a:defRPr sz="1000" b="1">
+              <a:defRPr sz="1150" b="1">
                 <a:solidFill>
                   <a:srgbClr val="006B55"/>
                 </a:solidFill>
@@ -9380,7 +9444,7 @@
           </a:p>
           <a:p>
             <a:pPr>
-              <a:defRPr sz="950">
+              <a:defRPr sz="1100">
                 <a:solidFill>
                   <a:srgbClr val="596E64"/>
                 </a:solidFill>
@@ -9504,7 +9568,7 @@
           <a:lstStyle/>
           <a:p>
             <a:pPr>
-              <a:defRPr sz="1100" b="1">
+              <a:defRPr sz="1300" b="1">
                 <a:solidFill>
                   <a:srgbClr val="006B55"/>
                 </a:solidFill>
@@ -9517,7 +9581,7 @@
           </a:p>
           <a:p>
             <a:pPr>
-              <a:defRPr sz="1050">
+              <a:defRPr sz="1200">
                 <a:solidFill>
                   <a:srgbClr val="172621"/>
                 </a:solidFill>
@@ -9525,12 +9589,12 @@
               </a:defRPr>
             </a:pPr>
             <a:r>
-              <a:t>• Deterministic policy engine (P-01 to P-08)</a:t>
+              <a:t>• Mock store &amp; courier APIs</a:t>
             </a:r>
           </a:p>
           <a:p>
             <a:pPr>
-              <a:defRPr sz="1050">
+              <a:defRPr sz="1200">
                 <a:solidFill>
                   <a:srgbClr val="172621"/>
                 </a:solidFill>
@@ -9538,12 +9602,12 @@
               </a:defRPr>
             </a:pPr>
             <a:r>
-              <a:t>• Evidence-pack keyframe citations</a:t>
+              <a:t>• Deterministic policy &amp; seller gate</a:t>
             </a:r>
           </a:p>
           <a:p>
             <a:pPr>
-              <a:defRPr sz="1050">
+              <a:defRPr sz="1200">
                 <a:solidFill>
                   <a:srgbClr val="172621"/>
                 </a:solidFill>
@@ -9551,12 +9615,12 @@
               </a:defRPr>
             </a:pPr>
             <a:r>
-              <a:t>• Fail-closed seller authorization gate</a:t>
+              <a:t>• Color-mismatch contradiction scenario</a:t>
             </a:r>
           </a:p>
           <a:p>
             <a:pPr>
-              <a:defRPr sz="1050">
+              <a:defRPr sz="1200">
                 <a:solidFill>
                   <a:srgbClr val="172621"/>
                 </a:solidFill>
@@ -9564,12 +9628,25 @@
               </a:defRPr>
             </a:pPr>
             <a:r>
+              <a:t>• Clarification / resume scenario (Case C)</a:t>
+            </a:r>
+          </a:p>
+          <a:p>
+            <a:pPr>
+              <a:defRPr sz="1200">
+                <a:solidFill>
+                  <a:srgbClr val="172621"/>
+                </a:solidFill>
+                <a:latin typeface="Inter"/>
+              </a:defRPr>
+            </a:pPr>
+            <a:r>
               <a:t>• Structured JSON audit trail log</a:t>
             </a:r>
           </a:p>
           <a:p>
             <a:pPr>
-              <a:defRPr sz="1050">
+              <a:defRPr sz="1200">
                 <a:solidFill>
                   <a:srgbClr val="172621"/>
                 </a:solidFill>
@@ -9577,20 +9654,7 @@
               </a:defRPr>
             </a:pPr>
             <a:r>
-              <a:t>• Stateful clarification/resume loop</a:t>
-            </a:r>
-          </a:p>
-          <a:p>
-            <a:pPr>
-              <a:defRPr sz="1050">
-                <a:solidFill>
-                  <a:srgbClr val="172621"/>
-                </a:solidFill>
-                <a:latin typeface="Inter"/>
-              </a:defRPr>
-            </a:pPr>
-            <a:r>
-              <a:t>• 4 reproducible demo scenarios</a:t>
+              <a:t>• Order-status fast path lookup</a:t>
             </a:r>
           </a:p>
         </p:txBody>
@@ -9706,7 +9770,7 @@
           <a:lstStyle/>
           <a:p>
             <a:pPr>
-              <a:defRPr sz="1100" b="1">
+              <a:defRPr sz="1300" b="1">
                 <a:solidFill>
                   <a:srgbClr val="D95D39"/>
                 </a:solidFill>
@@ -9719,7 +9783,7 @@
           </a:p>
           <a:p>
             <a:pPr>
-              <a:defRPr sz="1050">
+              <a:defRPr sz="1200">
                 <a:solidFill>
                   <a:srgbClr val="172621"/>
                 </a:solidFill>
@@ -9727,12 +9791,12 @@
               </a:defRPr>
             </a:pPr>
             <a:r>
-              <a:t>• Live carrier webhooks (keep mock courier)</a:t>
+              <a:t>• Advanced continuity checks (Case D stretch)</a:t>
             </a:r>
           </a:p>
           <a:p>
             <a:pPr>
-              <a:defRPr sz="1050">
+              <a:defRPr sz="1200">
                 <a:solidFill>
                   <a:srgbClr val="172621"/>
                 </a:solidFill>
@@ -9740,12 +9804,12 @@
               </a:defRPr>
             </a:pPr>
             <a:r>
-              <a:t>• Multi-item return parsing (keep 1 item/return)</a:t>
+              <a:t>• Live external carrier &amp; store integrations</a:t>
             </a:r>
           </a:p>
           <a:p>
             <a:pPr>
-              <a:defRPr sz="1050">
+              <a:defRPr sz="1200">
                 <a:solidFill>
                   <a:srgbClr val="172621"/>
                 </a:solidFill>
@@ -9753,25 +9817,12 @@
               </a:defRPr>
             </a:pPr>
             <a:r>
-              <a:t>• Video OCR barcode scanner (keep visual color)</a:t>
+              <a:t>• Video OCR barcode scanner</a:t>
             </a:r>
           </a:p>
           <a:p>
             <a:pPr>
-              <a:defRPr sz="1050">
-                <a:solidFill>
-                  <a:srgbClr val="172621"/>
-                </a:solidFill>
-                <a:latin typeface="Inter"/>
-              </a:defRPr>
-            </a:pPr>
-            <a:r>
-              <a:t>• Live payment gateways (keep draft refunds)</a:t>
-            </a:r>
-          </a:p>
-          <a:p>
-            <a:pPr>
-              <a:defRPr sz="1050">
+              <a:defRPr sz="1200">
                 <a:solidFill>
                   <a:srgbClr val="172621"/>
                 </a:solidFill>

</xml_diff>